<commit_message>
docs: use the full paper title on the deck's title slide
Co-Authored-By: Claude Opus 5.5 (1M context) <noreply@anthropic.com>
Claude-Session: https://claude.ai/code/session_01JZtuYERhuCe7nB9VYHwcfv
</commit_message>
<xml_diff>
--- a/presentation/bed-rest-to-mars-talk.pptx
+++ b/presentation/bed-rest-to-mars-talk.pptx
@@ -126,13 +126,13 @@
   <p:extLst>
     <p:ext uri="{521415D9-36F7-43E2-AB2F-B90AF26B5E84}">
       <p14:sectionLst xmlns:p14="http://schemas.microsoft.com/office/powerpoint/2010/main">
-        <p14:section name="Opening" id="{ad0841e5-3fab-0860-2eca-e27087ff7d1a}">
+        <p14:section name="Opening" id="{cc07f759-abaf-dca1-bdfb-68918a592c3c}">
           <p14:sldIdLst>
             <p14:sldId id="256"/>
             <p14:sldId id="257"/>
           </p14:sldIdLst>
         </p14:section>
-        <p14:section name="Part 1" id="{e52363c4-ae97-bd7d-9b3f-534dc9bf0b2e}">
+        <p14:section name="Part 1" id="{3d46d190-1dfd-0146-7917-14fd4af74c2f}">
           <p14:sldIdLst>
             <p14:sldId id="258"/>
             <p14:sldId id="259"/>
@@ -143,7 +143,7 @@
             <p14:sldId id="264"/>
           </p14:sldIdLst>
         </p14:section>
-        <p14:section name="Part 2" id="{59ca29a9-e4ae-f324-92c6-452453aa92c6}">
+        <p14:section name="Part 2" id="{225974b8-bb81-45af-0c23-7d1c3e397fd5}">
           <p14:sldIdLst>
             <p14:sldId id="265"/>
             <p14:sldId id="266"/>
@@ -154,7 +154,7 @@
             <p14:sldId id="271"/>
           </p14:sldIdLst>
         </p14:section>
-        <p14:section name="Backup" id="{4437c8ef-bd8a-1585-fae8-d77fb4670869}">
+        <p14:section name="Backup" id="{54ceb4b6-55ac-a84a-9253-2173ad50f932}">
           <p14:sldIdLst>
             <p14:sldId id="272"/>
             <p14:sldId id="273"/>
@@ -162,13 +162,13 @@
             <p14:sldId id="275"/>
           </p14:sldIdLst>
         </p14:section>
-        <p14:section name="Backup" id="{8eba0c1a-eeab-9252-eda9-3aecba7abf71}">
+        <p14:section name="Backup" id="{893790a9-df3d-a883-0b68-c4a7a09eb378}">
           <p14:sldIdLst/>
         </p14:section>
-        <p14:section name="Backup" id="{ea074bdf-8fb6-a27e-0088-d55549b01248}">
+        <p14:section name="Backup" id="{4f64aac0-3f62-e72d-30cf-90e19c3409b0}">
           <p14:sldIdLst/>
         </p14:section>
-        <p14:section name="Backup" id="{2e965657-e482-5f77-a0ac-6739f81528be}">
+        <p14:section name="Backup" id="{e7d7322b-41f6-3316-4aba-d4c61e29cab9}">
           <p14:sldIdLst/>
         </p14:section>
       </p14:sectionLst>
@@ -4835,8 +4835,8 @@
         </p:nvSpPr>
         <p:spPr>
           <a:xfrm>
-            <a:off x="822960" y="2011680"/>
-            <a:ext cx="10515600" cy="914400"/>
+            <a:off x="822960" y="1371600"/>
+            <a:ext cx="10515600" cy="2651760"/>
           </a:xfrm>
           <a:prstGeom prst="rect">
             <a:avLst/>
@@ -4845,10 +4845,13 @@
           <a:ln/>
         </p:spPr>
         <p:txBody>
-          <a:bodyPr wrap="square" lIns="0" tIns="0" rIns="0" bIns="0" rtlCol="0" anchor="t"/>
+          <a:bodyPr wrap="square" lIns="0" tIns="0" rIns="0" bIns="0" rtlCol="0" anchor="b"/>
           <a:lstStyle/>
           <a:p>
             <a:pPr indent="0" marL="0">
+              <a:spcAft>
+                <a:spcPts val="800"/>
+              </a:spcAft>
               <a:buNone/>
             </a:pPr>
             <a:r>
@@ -4860,7 +4863,27 @@
                 <a:ea typeface="Cambria" pitchFamily="34" charset="-122"/>
                 <a:cs typeface="Cambria" pitchFamily="34" charset="-120"/>
               </a:rPr>
-              <a:t>From Bed Rest to Mars</a:t>
+              <a:t>From Bed Rest to Mars:</a:t>
+            </a:r>
+            <a:endParaRPr lang="en-US" sz="4400" dirty="0"/>
+          </a:p>
+          <a:p>
+            <a:pPr indent="0" marL="0">
+              <a:spcAft>
+                <a:spcPts val="800"/>
+              </a:spcAft>
+              <a:buNone/>
+            </a:pPr>
+            <a:r>
+              <a:rPr lang="en-US" sz="2800" b="1" dirty="0">
+                <a:solidFill>
+                  <a:schemeClr val="tx2"/>
+                </a:solidFill>
+                <a:latin typeface="Cambria" pitchFamily="34" charset="0"/>
+                <a:ea typeface="Cambria" pitchFamily="34" charset="-122"/>
+                <a:cs typeface="Cambria" pitchFamily="34" charset="-120"/>
+              </a:rPr>
+              <a:t>Development of a Literature-Derived Machine Learning Framework for Predicting Lower-Limb Muscle Atrophy in Spaceflight Analogues</a:t>
             </a:r>
             <a:endParaRPr lang="en-US" sz="4400" dirty="0"/>
           </a:p>
@@ -4874,8 +4897,8 @@
         </p:nvSpPr>
         <p:spPr>
           <a:xfrm>
-            <a:off x="822960" y="2926080"/>
-            <a:ext cx="10515600" cy="548640"/>
+            <a:off x="822960" y="4343400"/>
+            <a:ext cx="10515600" cy="365760"/>
           </a:xfrm>
           <a:prstGeom prst="rect">
             <a:avLst/>
@@ -4891,14 +4914,14 @@
               <a:buNone/>
             </a:pPr>
             <a:r>
-              <a:rPr lang="en-US" sz="2400" dirty="0">
-                <a:solidFill>
-                  <a:schemeClr val="tx1"/>
-                </a:solidFill>
-              </a:rPr>
-              <a:t>Forecasting lower-limb muscle loss during unloading</a:t>
-            </a:r>
-            <a:endParaRPr lang="en-US" sz="2400" dirty="0"/>
+              <a:rPr lang="en-US" sz="1600" dirty="0">
+                <a:solidFill>
+                  <a:schemeClr val="accent3"/>
+                </a:solidFill>
+              </a:rPr>
+              <a:t>[Authors]  |  [Affiliation]</a:t>
+            </a:r>
+            <a:endParaRPr lang="en-US" sz="1600" dirty="0"/>
           </a:p>
         </p:txBody>
       </p:sp>
@@ -4910,43 +4933,7 @@
         </p:nvSpPr>
         <p:spPr>
           <a:xfrm>
-            <a:off x="822960" y="3931920"/>
-            <a:ext cx="10515600" cy="365760"/>
-          </a:xfrm>
-          <a:prstGeom prst="rect">
-            <a:avLst/>
-          </a:prstGeom>
-          <a:noFill/>
-          <a:ln/>
-        </p:spPr>
-        <p:txBody>
-          <a:bodyPr wrap="square" lIns="0" tIns="0" rIns="0" bIns="0" rtlCol="0" anchor="t"/>
-          <a:lstStyle/>
-          <a:p>
-            <a:pPr indent="0" marL="0">
-              <a:buNone/>
-            </a:pPr>
-            <a:r>
-              <a:rPr lang="en-US" sz="1600" dirty="0">
-                <a:solidFill>
-                  <a:schemeClr val="accent3"/>
-                </a:solidFill>
-              </a:rPr>
-              <a:t>[Authors]  |  [Affiliation]</a:t>
-            </a:r>
-            <a:endParaRPr lang="en-US" sz="1600" dirty="0"/>
-          </a:p>
-        </p:txBody>
-      </p:sp>
-      <p:sp>
-        <p:nvSpPr>
-          <p:cNvPr id="5" name="Text 3"/>
-          <p:cNvSpPr txBox="1"/>
-          <p:nvPr/>
-        </p:nvSpPr>
-        <p:spPr>
-          <a:xfrm>
-            <a:off x="822960" y="4343400"/>
+            <a:off x="822960" y="4754880"/>
             <a:ext cx="10515600" cy="365760"/>
           </a:xfrm>
           <a:prstGeom prst="rect">

</xml_diff>

<commit_message>
docs: add authors and affiliations to the deck
Co-Authored-By: Claude Opus 5.5 (1M context) <noreply@anthropic.com>
Claude-Session: https://claude.ai/code/session_01JZtuYERhuCe7nB9VYHwcfv
</commit_message>
<xml_diff>
--- a/presentation/bed-rest-to-mars-talk.pptx
+++ b/presentation/bed-rest-to-mars-talk.pptx
@@ -126,13 +126,13 @@
   <p:extLst>
     <p:ext uri="{521415D9-36F7-43E2-AB2F-B90AF26B5E84}">
       <p14:sectionLst xmlns:p14="http://schemas.microsoft.com/office/powerpoint/2010/main">
-        <p14:section name="Opening" id="{cc07f759-abaf-dca1-bdfb-68918a592c3c}">
+        <p14:section name="Opening" id="{553f19e8-233d-ac0a-f81f-f45064007b27}">
           <p14:sldIdLst>
             <p14:sldId id="256"/>
             <p14:sldId id="257"/>
           </p14:sldIdLst>
         </p14:section>
-        <p14:section name="Part 1" id="{3d46d190-1dfd-0146-7917-14fd4af74c2f}">
+        <p14:section name="Part 1" id="{d36f6662-859a-5a74-00a1-7967bd5bdf87}">
           <p14:sldIdLst>
             <p14:sldId id="258"/>
             <p14:sldId id="259"/>
@@ -143,7 +143,7 @@
             <p14:sldId id="264"/>
           </p14:sldIdLst>
         </p14:section>
-        <p14:section name="Part 2" id="{225974b8-bb81-45af-0c23-7d1c3e397fd5}">
+        <p14:section name="Part 2" id="{065d1f1c-712c-594d-8b5c-4deb215b4375}">
           <p14:sldIdLst>
             <p14:sldId id="265"/>
             <p14:sldId id="266"/>
@@ -154,7 +154,7 @@
             <p14:sldId id="271"/>
           </p14:sldIdLst>
         </p14:section>
-        <p14:section name="Backup" id="{54ceb4b6-55ac-a84a-9253-2173ad50f932}">
+        <p14:section name="Backup" id="{19eb8296-13a5-95b7-42b4-9a69f575c3b6}">
           <p14:sldIdLst>
             <p14:sldId id="272"/>
             <p14:sldId id="273"/>
@@ -162,13 +162,13 @@
             <p14:sldId id="275"/>
           </p14:sldIdLst>
         </p14:section>
-        <p14:section name="Backup" id="{893790a9-df3d-a883-0b68-c4a7a09eb378}">
+        <p14:section name="Backup" id="{0d7cd1b5-551f-694f-80a6-d4bdd7fbead0}">
           <p14:sldIdLst/>
         </p14:section>
-        <p14:section name="Backup" id="{4f64aac0-3f62-e72d-30cf-90e19c3409b0}">
+        <p14:section name="Backup" id="{d6c38d3a-3b9e-701e-763e-af796516014e}">
           <p14:sldIdLst/>
         </p14:section>
-        <p14:section name="Backup" id="{e7d7322b-41f6-3316-4aba-d4c61e29cab9}">
+        <p14:section name="Backup" id="{4ae08df2-d6f4-64d1-94b1-6275c6d21fe5}">
           <p14:sldIdLst/>
         </p14:section>
       </p14:sectionLst>
@@ -2535,7 +2535,7 @@
           <a:p>
             <a:r>
               <a:rPr lang="en-US" dirty="0"/>
-              <a:t>Intro (co-author). Placeholder: fill in authors, affiliation and the opening sentence.</a:t>
+              <a:t>Intro (Niloufar). Placeholder: add the opening sentence.</a:t>
             </a:r>
             <a:endParaRPr lang="en-US" dirty="0"/>
           </a:p>
@@ -4897,7 +4897,7 @@
         </p:nvSpPr>
         <p:spPr>
           <a:xfrm>
-            <a:off x="822960" y="4343400"/>
+            <a:off x="822960" y="4297680"/>
             <a:ext cx="10515600" cy="365760"/>
           </a:xfrm>
           <a:prstGeom prst="rect">
@@ -4914,14 +4914,47 @@
               <a:buNone/>
             </a:pPr>
             <a:r>
-              <a:rPr lang="en-US" sz="1600" dirty="0">
-                <a:solidFill>
-                  <a:schemeClr val="accent3"/>
-                </a:solidFill>
-              </a:rPr>
-              <a:t>[Authors]  |  [Affiliation]</a:t>
-            </a:r>
-            <a:endParaRPr lang="en-US" sz="1600" dirty="0"/>
+              <a:rPr lang="en-US" sz="1800" dirty="0">
+                <a:solidFill>
+                  <a:schemeClr val="tx1"/>
+                </a:solidFill>
+              </a:rPr>
+              <a:t>Niloufar Ahmadymarzdashty</a:t>
+            </a:r>
+            <a:pPr indent="0" marL="0">
+              <a:buNone/>
+            </a:pPr>
+            <a:r>
+              <a:rPr lang="en-US" sz="1800" baseline="30000" dirty="0">
+                <a:solidFill>
+                  <a:schemeClr val="tx1"/>
+                </a:solidFill>
+              </a:rPr>
+              <a:t>1</a:t>
+            </a:r>
+            <a:pPr indent="0" marL="0">
+              <a:buNone/>
+            </a:pPr>
+            <a:r>
+              <a:rPr lang="en-US" sz="1800" dirty="0">
+                <a:solidFill>
+                  <a:schemeClr val="tx1"/>
+                </a:solidFill>
+              </a:rPr>
+              <a:t>,  Milad Bahari Qaragoz</a:t>
+            </a:r>
+            <a:pPr indent="0" marL="0">
+              <a:buNone/>
+            </a:pPr>
+            <a:r>
+              <a:rPr lang="en-US" sz="1800" baseline="30000" dirty="0">
+                <a:solidFill>
+                  <a:schemeClr val="tx1"/>
+                </a:solidFill>
+              </a:rPr>
+              <a:t>2</a:t>
+            </a:r>
+            <a:endParaRPr lang="en-US" sz="1800" dirty="0"/>
           </a:p>
         </p:txBody>
       </p:sp>
@@ -4933,8 +4966,8 @@
         </p:nvSpPr>
         <p:spPr>
           <a:xfrm>
-            <a:off x="822960" y="4754880"/>
-            <a:ext cx="10515600" cy="365760"/>
+            <a:off x="822960" y="4709160"/>
+            <a:ext cx="10515600" cy="548640"/>
           </a:xfrm>
           <a:prstGeom prst="rect">
             <a:avLst/>
@@ -4950,14 +4983,86 @@
               <a:buNone/>
             </a:pPr>
             <a:r>
-              <a:rPr lang="en-US" sz="1600" dirty="0">
+              <a:rPr lang="en-US" sz="1400" baseline="30000" dirty="0">
                 <a:solidFill>
                   <a:schemeClr val="accent3"/>
                 </a:solidFill>
               </a:rPr>
+              <a:t>1</a:t>
+            </a:r>
+            <a:pPr indent="0" marL="0">
+              <a:buNone/>
+            </a:pPr>
+            <a:r>
+              <a:rPr lang="en-US" sz="1400" dirty="0">
+                <a:solidFill>
+                  <a:schemeClr val="accent3"/>
+                </a:solidFill>
+              </a:rPr>
+              <a:t> Independent researcher</a:t>
+            </a:r>
+            <a:endParaRPr lang="en-US" sz="1400" dirty="0"/>
+          </a:p>
+          <a:p>
+            <a:pPr indent="0" marL="0">
+              <a:buNone/>
+            </a:pPr>
+            <a:r>
+              <a:rPr lang="en-US" sz="1400" baseline="30000" dirty="0">
+                <a:solidFill>
+                  <a:schemeClr val="accent3"/>
+                </a:solidFill>
+              </a:rPr>
+              <a:t>2</a:t>
+            </a:r>
+            <a:pPr indent="0" marL="0">
+              <a:buNone/>
+            </a:pPr>
+            <a:r>
+              <a:rPr lang="en-US" sz="1400" dirty="0">
+                <a:solidFill>
+                  <a:schemeClr val="accent3"/>
+                </a:solidFill>
+              </a:rPr>
+              <a:t> Master's candidate, Friedrich-Alexander-Universität Erlangen-Nürnberg (FAU)</a:t>
+            </a:r>
+            <a:endParaRPr lang="en-US" sz="1400" dirty="0"/>
+          </a:p>
+        </p:txBody>
+      </p:sp>
+      <p:sp>
+        <p:nvSpPr>
+          <p:cNvPr id="5" name="Text 3"/>
+          <p:cNvSpPr txBox="1"/>
+          <p:nvPr/>
+        </p:nvSpPr>
+        <p:spPr>
+          <a:xfrm>
+            <a:off x="822960" y="5394960"/>
+            <a:ext cx="10515600" cy="365760"/>
+          </a:xfrm>
+          <a:prstGeom prst="rect">
+            <a:avLst/>
+          </a:prstGeom>
+          <a:noFill/>
+          <a:ln/>
+        </p:spPr>
+        <p:txBody>
+          <a:bodyPr wrap="square" lIns="0" tIns="0" rIns="0" bIns="0" rtlCol="0" anchor="t"/>
+          <a:lstStyle/>
+          <a:p>
+            <a:pPr indent="0" marL="0">
+              <a:buNone/>
+            </a:pPr>
+            <a:r>
+              <a:rPr lang="en-US" sz="1400" dirty="0">
+                <a:solidFill>
+                  <a:schemeClr val="accent3"/>
+                </a:solidFill>
+              </a:rPr>
               <a:t>DGLRM 2026</a:t>
             </a:r>
-            <a:endParaRPr lang="en-US" sz="1600" dirty="0"/>
+            <a:endParaRPr lang="en-US" sz="1400" dirty="0"/>
           </a:p>
         </p:txBody>
       </p:sp>
@@ -5291,7 +5396,7 @@
                   <a:schemeClr val="accent3"/>
                 </a:solidFill>
               </a:rPr>
-              <a:t>PLACEHOLDER: content by co-author</a:t>
+              <a:t>PLACEHOLDER: content by Niloufar</a:t>
             </a:r>
             <a:endParaRPr lang="en-US" sz="1400" dirty="0"/>
           </a:p>
@@ -11721,7 +11826,7 @@
                   <a:schemeClr val="accent3"/>
                 </a:solidFill>
               </a:rPr>
-              <a:t>[Co-author]</a:t>
+              <a:t>Niloufar Ahmadymarzdashty</a:t>
             </a:r>
             <a:endParaRPr lang="en-US" sz="1600" dirty="0"/>
           </a:p>
@@ -11840,7 +11945,7 @@
                   <a:schemeClr val="accent3"/>
                 </a:solidFill>
               </a:rPr>
-              <a:t>[Presenter]</a:t>
+              <a:t>Milad Bahari Qaragoz</a:t>
             </a:r>
             <a:endParaRPr lang="en-US" sz="1600" dirty="0"/>
           </a:p>
@@ -13322,7 +13427,7 @@
                   <a:schemeClr val="accent3"/>
                 </a:solidFill>
               </a:rPr>
-              <a:t>PLACEHOLDER: content by co-author</a:t>
+              <a:t>PLACEHOLDER: content by Niloufar</a:t>
             </a:r>
             <a:endParaRPr lang="en-US" sz="1400" dirty="0"/>
           </a:p>
@@ -13774,7 +13879,7 @@
                   <a:schemeClr val="accent3"/>
                 </a:solidFill>
               </a:rPr>
-              <a:t>PLACEHOLDER: content by co-author</a:t>
+              <a:t>PLACEHOLDER: content by Niloufar</a:t>
             </a:r>
             <a:endParaRPr lang="en-US" sz="1400" dirty="0"/>
           </a:p>
@@ -14244,7 +14349,7 @@
                   <a:schemeClr val="accent3"/>
                 </a:solidFill>
               </a:rPr>
-              <a:t>PLACEHOLDER: content by co-author</a:t>
+              <a:t>PLACEHOLDER: content by Niloufar</a:t>
             </a:r>
             <a:endParaRPr lang="en-US" sz="1400" dirty="0"/>
           </a:p>
@@ -14696,7 +14801,7 @@
                   <a:schemeClr val="accent3"/>
                 </a:solidFill>
               </a:rPr>
-              <a:t>PLACEHOLDER: content by co-author</a:t>
+              <a:t>PLACEHOLDER: content by Niloufar</a:t>
             </a:r>
             <a:endParaRPr lang="en-US" sz="1400" dirty="0"/>
           </a:p>
@@ -15180,7 +15285,7 @@
                   <a:schemeClr val="accent3"/>
                 </a:solidFill>
               </a:rPr>
-              <a:t>PLACEHOLDER: content by co-author</a:t>
+              <a:t>PLACEHOLDER: content by Niloufar</a:t>
             </a:r>
             <a:endParaRPr lang="en-US" sz="1400" dirty="0"/>
           </a:p>
@@ -15664,7 +15769,7 @@
                   <a:schemeClr val="accent3"/>
                 </a:solidFill>
               </a:rPr>
-              <a:t>PLACEHOLDER: content by co-author</a:t>
+              <a:t>PLACEHOLDER: content by Niloufar</a:t>
             </a:r>
             <a:endParaRPr lang="en-US" sz="1400" dirty="0"/>
           </a:p>
@@ -16134,7 +16239,7 @@
                   <a:schemeClr val="accent3"/>
                 </a:solidFill>
               </a:rPr>
-              <a:t>PLACEHOLDER: content by co-author</a:t>
+              <a:t>PLACEHOLDER: content by Niloufar</a:t>
             </a:r>
             <a:endParaRPr lang="en-US" sz="1400" dirty="0"/>
           </a:p>

</xml_diff>

<commit_message>
docs: add the DGLRM logo to the deck
Co-Authored-By: Claude Opus 5.5 (1M context) <noreply@anthropic.com>
Claude-Session: https://claude.ai/code/session_01JZtuYERhuCe7nB9VYHwcfv
</commit_message>
<xml_diff>
--- a/presentation/bed-rest-to-mars-talk.pptx
+++ b/presentation/bed-rest-to-mars-talk.pptx
@@ -126,13 +126,13 @@
   <p:extLst>
     <p:ext uri="{521415D9-36F7-43E2-AB2F-B90AF26B5E84}">
       <p14:sectionLst xmlns:p14="http://schemas.microsoft.com/office/powerpoint/2010/main">
-        <p14:section name="Opening" id="{553f19e8-233d-ac0a-f81f-f45064007b27}">
+        <p14:section name="Opening" id="{f9acf58c-9b27-e31a-01c8-98f4c46ca5b5}">
           <p14:sldIdLst>
             <p14:sldId id="256"/>
             <p14:sldId id="257"/>
           </p14:sldIdLst>
         </p14:section>
-        <p14:section name="Part 1" id="{d36f6662-859a-5a74-00a1-7967bd5bdf87}">
+        <p14:section name="Part 1" id="{3a44ccd7-3a1d-693e-5d82-7c182db4f5e4}">
           <p14:sldIdLst>
             <p14:sldId id="258"/>
             <p14:sldId id="259"/>
@@ -143,7 +143,7 @@
             <p14:sldId id="264"/>
           </p14:sldIdLst>
         </p14:section>
-        <p14:section name="Part 2" id="{065d1f1c-712c-594d-8b5c-4deb215b4375}">
+        <p14:section name="Part 2" id="{0e7b0658-30fe-a06a-b041-1f16925b5311}">
           <p14:sldIdLst>
             <p14:sldId id="265"/>
             <p14:sldId id="266"/>
@@ -154,7 +154,7 @@
             <p14:sldId id="271"/>
           </p14:sldIdLst>
         </p14:section>
-        <p14:section name="Backup" id="{19eb8296-13a5-95b7-42b4-9a69f575c3b6}">
+        <p14:section name="Backup" id="{b90dcf77-daaa-ad06-29c8-186bba575a92}">
           <p14:sldIdLst>
             <p14:sldId id="272"/>
             <p14:sldId id="273"/>
@@ -162,13 +162,13 @@
             <p14:sldId id="275"/>
           </p14:sldIdLst>
         </p14:section>
-        <p14:section name="Backup" id="{0d7cd1b5-551f-694f-80a6-d4bdd7fbead0}">
+        <p14:section name="Backup" id="{944e4554-33fc-b4fa-86d2-909c1a6f3709}">
           <p14:sldIdLst/>
         </p14:section>
-        <p14:section name="Backup" id="{d6c38d3a-3b9e-701e-763e-af796516014e}">
+        <p14:section name="Backup" id="{e5a44368-8d70-d467-619e-59d60b092ada}">
           <p14:sldIdLst/>
         </p14:section>
-        <p14:section name="Backup" id="{4ae08df2-d6f4-64d1-94b1-6275c6d21fe5}">
+        <p14:section name="Backup" id="{046db176-ae5d-d6c9-056d-d37fba20186e}">
           <p14:sldIdLst/>
         </p14:section>
       </p14:sectionLst>
@@ -4365,16 +4365,40 @@
           </a:p>
         </p:txBody>
       </p:sp>
-      <p:sp>
-        <p:nvSpPr>
-          <p:cNvPr id="3" name="Text 0"/>
-          <p:cNvSpPr/>
-          <p:nvPr/>
-        </p:nvSpPr>
-        <p:spPr>
-          <a:xfrm>
-            <a:off x="548640" y="6355080"/>
-            <a:ext cx="7315200" cy="274320"/>
+      <p:pic>
+        <p:nvPicPr>
+          <p:cNvPr id="3" name="Image 0" descr="DGLRM logo">    </p:cNvPr>
+          <p:cNvPicPr>
+            <a:picLocks noChangeAspect="1"/>
+          </p:cNvPicPr>
+          <p:nvPr/>
+        </p:nvPicPr>
+        <p:blipFill>
+          <a:blip r:embed="rId1"/>
+          <a:stretch>
+            <a:fillRect/>
+          </a:stretch>
+        </p:blipFill>
+        <p:spPr>
+          <a:xfrm>
+            <a:off x="548640" y="6336792"/>
+            <a:ext cx="1143000" cy="307258"/>
+          </a:xfrm>
+          <a:prstGeom prst="rect">
+            <a:avLst/>
+          </a:prstGeom>
+        </p:spPr>
+      </p:pic>
+      <p:sp>
+        <p:nvSpPr>
+          <p:cNvPr id="4" name="Text 0"/>
+          <p:cNvSpPr/>
+          <p:nvPr/>
+        </p:nvSpPr>
+        <p:spPr>
+          <a:xfrm>
+            <a:off x="1828800" y="6355080"/>
+            <a:ext cx="4572000" cy="274320"/>
           </a:xfrm>
           <a:prstGeom prst="rect">
             <a:avLst/>
@@ -4827,9 +4851,33 @@
           <a:chExt cx="0" cy="0"/>
         </a:xfrm>
       </p:grpSpPr>
-      <p:sp>
-        <p:nvSpPr>
-          <p:cNvPr id="2" name="Text 0"/>
+      <p:pic>
+        <p:nvPicPr>
+          <p:cNvPr id="2" name="Image 0" descr="DGLRM logo">    </p:cNvPr>
+          <p:cNvPicPr>
+            <a:picLocks noChangeAspect="1"/>
+          </p:cNvPicPr>
+          <p:nvPr/>
+        </p:nvPicPr>
+        <p:blipFill>
+          <a:blip r:embed="rId1"/>
+          <a:stretch>
+            <a:fillRect/>
+          </a:stretch>
+        </p:blipFill>
+        <p:spPr>
+          <a:xfrm>
+            <a:off x="822960" y="548640"/>
+            <a:ext cx="2926080" cy="786581"/>
+          </a:xfrm>
+          <a:prstGeom prst="rect">
+            <a:avLst/>
+          </a:prstGeom>
+        </p:spPr>
+      </p:pic>
+      <p:sp>
+        <p:nvSpPr>
+          <p:cNvPr id="3" name="Text 0"/>
           <p:cNvSpPr txBox="1"/>
           <p:nvPr/>
         </p:nvSpPr>
@@ -4891,7 +4939,7 @@
       </p:sp>
       <p:sp>
         <p:nvSpPr>
-          <p:cNvPr id="3" name="Text 1"/>
+          <p:cNvPr id="4" name="Text 1"/>
           <p:cNvSpPr txBox="1"/>
           <p:nvPr/>
         </p:nvSpPr>
@@ -4960,7 +5008,7 @@
       </p:sp>
       <p:sp>
         <p:nvSpPr>
-          <p:cNvPr id="4" name="Text 2"/>
+          <p:cNvPr id="5" name="Text 2"/>
           <p:cNvSpPr txBox="1"/>
           <p:nvPr/>
         </p:nvSpPr>
@@ -5032,7 +5080,7 @@
       </p:sp>
       <p:sp>
         <p:nvSpPr>
-          <p:cNvPr id="5" name="Text 3"/>
+          <p:cNvPr id="6" name="Text 3"/>
           <p:cNvSpPr txBox="1"/>
           <p:nvPr/>
         </p:nvSpPr>

</xml_diff>

<commit_message>
docs: name the 64. Jahrestagung der DGLRM on the deck
Co-Authored-By: Claude Opus 5.5 (1M context) <noreply@anthropic.com>
Claude-Session: https://claude.ai/code/session_01JZtuYERhuCe7nB9VYHwcfv
</commit_message>
<xml_diff>
--- a/presentation/bed-rest-to-mars-talk.pptx
+++ b/presentation/bed-rest-to-mars-talk.pptx
@@ -126,13 +126,13 @@
   <p:extLst>
     <p:ext uri="{521415D9-36F7-43E2-AB2F-B90AF26B5E84}">
       <p14:sectionLst xmlns:p14="http://schemas.microsoft.com/office/powerpoint/2010/main">
-        <p14:section name="Opening" id="{f9acf58c-9b27-e31a-01c8-98f4c46ca5b5}">
+        <p14:section name="Opening" id="{3fcbb1e7-e5c6-e7fd-2a70-1c706b1e655b}">
           <p14:sldIdLst>
             <p14:sldId id="256"/>
             <p14:sldId id="257"/>
           </p14:sldIdLst>
         </p14:section>
-        <p14:section name="Part 1" id="{3a44ccd7-3a1d-693e-5d82-7c182db4f5e4}">
+        <p14:section name="Part 1" id="{4ae86094-96fc-62a9-07d1-d8bdd868351f}">
           <p14:sldIdLst>
             <p14:sldId id="258"/>
             <p14:sldId id="259"/>
@@ -143,7 +143,7 @@
             <p14:sldId id="264"/>
           </p14:sldIdLst>
         </p14:section>
-        <p14:section name="Part 2" id="{0e7b0658-30fe-a06a-b041-1f16925b5311}">
+        <p14:section name="Part 2" id="{a572456b-cb02-daa0-749b-2b849eebda8a}">
           <p14:sldIdLst>
             <p14:sldId id="265"/>
             <p14:sldId id="266"/>
@@ -154,7 +154,7 @@
             <p14:sldId id="271"/>
           </p14:sldIdLst>
         </p14:section>
-        <p14:section name="Backup" id="{b90dcf77-daaa-ad06-29c8-186bba575a92}">
+        <p14:section name="Backup" id="{2699b8c5-0066-4ae2-465a-812f8c6852f4}">
           <p14:sldIdLst>
             <p14:sldId id="272"/>
             <p14:sldId id="273"/>
@@ -162,13 +162,13 @@
             <p14:sldId id="275"/>
           </p14:sldIdLst>
         </p14:section>
-        <p14:section name="Backup" id="{944e4554-33fc-b4fa-86d2-909c1a6f3709}">
+        <p14:section name="Backup" id="{0953650d-2d3d-beba-d504-2f8ed087bb29}">
           <p14:sldIdLst/>
         </p14:section>
-        <p14:section name="Backup" id="{e5a44368-8d70-d467-619e-59d60b092ada}">
+        <p14:section name="Backup" id="{098aaca0-ca26-cc45-5fac-858f6bbb4734}">
           <p14:sldIdLst/>
         </p14:section>
-        <p14:section name="Backup" id="{046db176-ae5d-d6c9-056d-d37fba20186e}">
+        <p14:section name="Backup" id="{6eff4745-285d-efbc-866f-788fc74159bf}">
           <p14:sldIdLst/>
         </p14:section>
       </p14:sectionLst>
@@ -4419,7 +4419,7 @@
                   <a:schemeClr val="accent3"/>
                 </a:solidFill>
               </a:rPr>
-              <a:t>From Bed Rest to Mars  |  DGLRM 2026</a:t>
+              <a:t>From Bed Rest to Mars  |  64. Jahrestagung der DGLRM</a:t>
             </a:r>
             <a:endParaRPr lang="en-US" sz="1000" dirty="0"/>
           </a:p>
@@ -5103,14 +5103,14 @@
               <a:buNone/>
             </a:pPr>
             <a:r>
-              <a:rPr lang="en-US" sz="1400" dirty="0">
-                <a:solidFill>
-                  <a:schemeClr val="accent3"/>
-                </a:solidFill>
-              </a:rPr>
-              <a:t>DGLRM 2026</a:t>
-            </a:r>
-            <a:endParaRPr lang="en-US" sz="1400" dirty="0"/>
+              <a:rPr lang="en-US" sz="1600" b="1" dirty="0">
+                <a:solidFill>
+                  <a:schemeClr val="tx2"/>
+                </a:solidFill>
+              </a:rPr>
+              <a:t>64. Jahrestagung der DGLRM</a:t>
+            </a:r>
+            <a:endParaRPr lang="en-US" sz="1600" dirty="0"/>
           </a:p>
         </p:txBody>
       </p:sp>

</xml_diff>

<commit_message>
Slide 3: two-column motivation slide with bed-rest and muscle cross-section graphic
Co-Authored-By: Claude Opus 5.5 (1M context) <noreply@anthropic.com>
Claude-Session: https://claude.ai/code/session_01JZtuYERhuCe7nB9VYHwcfv
</commit_message>
<xml_diff>
--- a/presentation/bed-rest-to-mars-talk.pptx
+++ b/presentation/bed-rest-to-mars-talk.pptx
@@ -126,13 +126,13 @@
   <p:extLst>
     <p:ext uri="{521415D9-36F7-43E2-AB2F-B90AF26B5E84}">
       <p14:sectionLst xmlns:p14="http://schemas.microsoft.com/office/powerpoint/2010/main">
-        <p14:section name="Opening" id="{3fcbb1e7-e5c6-e7fd-2a70-1c706b1e655b}">
+        <p14:section name="Opening" id="{9f1ec760-602a-276d-f790-e9f28eb2ed1f}">
           <p14:sldIdLst>
             <p14:sldId id="256"/>
             <p14:sldId id="257"/>
           </p14:sldIdLst>
         </p14:section>
-        <p14:section name="Part 1" id="{4ae86094-96fc-62a9-07d1-d8bdd868351f}">
+        <p14:section name="Part 1" id="{1eb59899-980d-9128-28fc-ce6dfdfba2e0}">
           <p14:sldIdLst>
             <p14:sldId id="258"/>
             <p14:sldId id="259"/>
@@ -143,7 +143,7 @@
             <p14:sldId id="264"/>
           </p14:sldIdLst>
         </p14:section>
-        <p14:section name="Part 2" id="{a572456b-cb02-daa0-749b-2b849eebda8a}">
+        <p14:section name="Part 2" id="{3acac844-80bc-fc0b-98e1-03fbfdad200c}">
           <p14:sldIdLst>
             <p14:sldId id="265"/>
             <p14:sldId id="266"/>
@@ -154,7 +154,7 @@
             <p14:sldId id="271"/>
           </p14:sldIdLst>
         </p14:section>
-        <p14:section name="Backup" id="{2699b8c5-0066-4ae2-465a-812f8c6852f4}">
+        <p14:section name="Backup" id="{5098d96c-1c66-428a-6e9f-e7969e334cd4}">
           <p14:sldIdLst>
             <p14:sldId id="272"/>
             <p14:sldId id="273"/>
@@ -162,13 +162,13 @@
             <p14:sldId id="275"/>
           </p14:sldIdLst>
         </p14:section>
-        <p14:section name="Backup" id="{0953650d-2d3d-beba-d504-2f8ed087bb29}">
+        <p14:section name="Backup" id="{3ae905a1-b6b8-b568-bdc9-29155b697c90}">
           <p14:sldIdLst/>
         </p14:section>
-        <p14:section name="Backup" id="{098aaca0-ca26-cc45-5fac-858f6bbb4734}">
+        <p14:section name="Backup" id="{f591bcc6-d0b4-5bd8-9894-e2cff3088413}">
           <p14:sldIdLst/>
         </p14:section>
-        <p14:section name="Backup" id="{6eff4745-285d-efbc-866f-788fc74159bf}">
+        <p14:section name="Backup" id="{09ae3420-12f8-08e1-6ce7-c9455634195e}">
           <p14:sldIdLst/>
         </p14:section>
       </p14:sectionLst>
@@ -3699,7 +3699,10 @@
           <a:p>
             <a:r>
               <a:rPr lang="en-US" dirty="0"/>
-              <a:t>Placeholder for the co-author's slide. The suggested points are from the final report on branch feat/report; replace them with the final content.</a:t>
+              <a:t>Opening of part 1 (Niloufar), about forty-five seconds.
+Muscle atrophy, especially in the legs, is one of the main problems of long-duration spaceflight. Our question was whether the amount of atrophy can be predicted. To answer it, we built a dataset from the published literature and a machine-learning framework on top of it.
+Why it matters: a prediction lets crews and planners act early, match exercise and nutrition to the expected loss, focus monitoring on the muscles that lose most, protect strength and function, and plan long missions where exercise equipment is limited.
+On the right is the ground model we rely on: volunteers lie in bed tilted six degrees head-down for weeks to months. The circles show a calf cross-section drawn to scale: after 60 days of bed rest, control groups lose about 16 percent of calf muscle in our model.</a:t>
             </a:r>
             <a:endParaRPr lang="en-US" dirty="0"/>
           </a:p>
@@ -13414,7 +13417,7 @@
                 <a:ea typeface="Cambria" pitchFamily="34" charset="-122"/>
                 <a:cs typeface="Cambria" pitchFamily="34" charset="-120"/>
               </a:rPr>
-              <a:t>Why forecast muscle loss?</a:t>
+              <a:t>Motivation: can we predict muscle atrophy?</a:t>
             </a:r>
             <a:endParaRPr lang="en-US" sz="2800" dirty="0"/>
           </a:p>
@@ -13422,16 +13425,400 @@
       </p:sp>
       <p:sp>
         <p:nvSpPr>
-          <p:cNvPr id="11" name="Placeholder frame"/>
-          <p:cNvSpPr/>
+          <p:cNvPr id="11" name="Text 9"/>
+          <p:cNvSpPr txBox="1"/>
           <p:nvPr/>
         </p:nvSpPr>
         <p:spPr>
           <a:xfrm>
             <a:off x="548640" y="1234440"/>
-            <a:ext cx="11064240" cy="4846320"/>
-          </a:xfrm>
-          <a:prstGeom prst="rect">
+            <a:ext cx="6035040" cy="4892040"/>
+          </a:xfrm>
+          <a:prstGeom prst="rect">
+            <a:avLst/>
+          </a:prstGeom>
+          <a:noFill/>
+          <a:ln/>
+        </p:spPr>
+        <p:txBody>
+          <a:bodyPr wrap="square" lIns="0" tIns="0" rIns="0" bIns="0" rtlCol="0" anchor="t"/>
+          <a:lstStyle/>
+          <a:p>
+            <a:pPr indent="0" marL="0">
+              <a:spcAft>
+                <a:spcPts val="400"/>
+              </a:spcAft>
+              <a:buNone/>
+            </a:pPr>
+            <a:r>
+              <a:rPr lang="en-US" sz="1800" b="1" dirty="0">
+                <a:solidFill>
+                  <a:schemeClr val="tx2"/>
+                </a:solidFill>
+              </a:rPr>
+              <a:t>What are we doing?</a:t>
+            </a:r>
+            <a:endParaRPr lang="en-US" sz="1800" dirty="0"/>
+          </a:p>
+          <a:p>
+            <a:pPr marL="342900" indent="-342900">
+              <a:spcAft>
+                <a:spcPts val="400"/>
+              </a:spcAft>
+              <a:buSzPct val="100000"/>
+              <a:buChar char="•"/>
+            </a:pPr>
+            <a:r>
+              <a:rPr lang="en-US" sz="1500" dirty="0">
+                <a:solidFill>
+                  <a:schemeClr val="tx1"/>
+                </a:solidFill>
+              </a:rPr>
+              <a:t>Lower-limb muscle atrophy is a major challenge in long-duration spaceflight</a:t>
+            </a:r>
+            <a:endParaRPr lang="en-US" sz="1800" dirty="0"/>
+          </a:p>
+          <a:p>
+            <a:pPr marL="342900" indent="-342900">
+              <a:spcAft>
+                <a:spcPts val="400"/>
+              </a:spcAft>
+              <a:buSzPct val="100000"/>
+              <a:buChar char="•"/>
+            </a:pPr>
+            <a:r>
+              <a:rPr lang="en-US" sz="1500" dirty="0">
+                <a:solidFill>
+                  <a:schemeClr val="tx1"/>
+                </a:solidFill>
+              </a:rPr>
+              <a:t>Research question: can the extent of muscle atrophy be predicted?</a:t>
+            </a:r>
+            <a:endParaRPr lang="en-US" sz="1800" dirty="0"/>
+          </a:p>
+          <a:p>
+            <a:pPr marL="342900" indent="-342900">
+              <a:spcAft>
+                <a:spcPts val="400"/>
+              </a:spcAft>
+              <a:buSzPct val="100000"/>
+              <a:buChar char="•"/>
+            </a:pPr>
+            <a:r>
+              <a:rPr lang="en-US" sz="1500" dirty="0">
+                <a:solidFill>
+                  <a:schemeClr val="tx1"/>
+                </a:solidFill>
+              </a:rPr>
+              <a:t>Aim: a literature-derived dataset and a machine-learning framework for this prediction</a:t>
+            </a:r>
+            <a:endParaRPr lang="en-US" sz="1800" dirty="0"/>
+          </a:p>
+          <a:p>
+            <a:pPr indent="0" marL="0">
+              <a:spcBef>
+                <a:spcPts val="1400"/>
+              </a:spcBef>
+              <a:spcAft>
+                <a:spcPts val="400"/>
+              </a:spcAft>
+              <a:buNone/>
+            </a:pPr>
+            <a:r>
+              <a:rPr lang="en-US" sz="1800" b="1" dirty="0">
+                <a:solidFill>
+                  <a:schemeClr val="tx2"/>
+                </a:solidFill>
+              </a:rPr>
+              <a:t>Why is this important?</a:t>
+            </a:r>
+            <a:endParaRPr lang="en-US" sz="1800" dirty="0"/>
+          </a:p>
+          <a:p>
+            <a:pPr marL="342900" indent="-342900">
+              <a:spcAft>
+                <a:spcPts val="400"/>
+              </a:spcAft>
+              <a:buSzPct val="100000"/>
+              <a:buChar char="•"/>
+            </a:pPr>
+            <a:r>
+              <a:rPr lang="en-US" sz="1500" dirty="0">
+                <a:solidFill>
+                  <a:schemeClr val="tx1"/>
+                </a:solidFill>
+              </a:rPr>
+              <a:t>Prevention: identify risk early and leave time to intervene</a:t>
+            </a:r>
+            <a:endParaRPr lang="en-US" sz="1800" dirty="0"/>
+          </a:p>
+          <a:p>
+            <a:pPr marL="342900" indent="-342900">
+              <a:spcAft>
+                <a:spcPts val="400"/>
+              </a:spcAft>
+              <a:buSzPct val="100000"/>
+              <a:buChar char="•"/>
+            </a:pPr>
+            <a:r>
+              <a:rPr lang="en-US" sz="1500" dirty="0">
+                <a:solidFill>
+                  <a:schemeClr val="tx1"/>
+                </a:solidFill>
+              </a:rPr>
+              <a:t>Countermeasures: match exercise and nutrition to the predicted risk</a:t>
+            </a:r>
+            <a:endParaRPr lang="en-US" sz="1800" dirty="0"/>
+          </a:p>
+          <a:p>
+            <a:pPr marL="342900" indent="-342900">
+              <a:spcAft>
+                <a:spcPts val="400"/>
+              </a:spcAft>
+              <a:buSzPct val="100000"/>
+              <a:buChar char="•"/>
+            </a:pPr>
+            <a:r>
+              <a:rPr lang="en-US" sz="1500" dirty="0">
+                <a:solidFill>
+                  <a:schemeClr val="tx1"/>
+                </a:solidFill>
+              </a:rPr>
+              <a:t>Vulnerable muscles: show which muscles need closer monitoring</a:t>
+            </a:r>
+            <a:endParaRPr lang="en-US" sz="1800" dirty="0"/>
+          </a:p>
+          <a:p>
+            <a:pPr marL="342900" indent="-342900">
+              <a:spcAft>
+                <a:spcPts val="400"/>
+              </a:spcAft>
+              <a:buSzPct val="100000"/>
+              <a:buChar char="•"/>
+            </a:pPr>
+            <a:r>
+              <a:rPr lang="en-US" sz="1500" dirty="0">
+                <a:solidFill>
+                  <a:schemeClr val="tx1"/>
+                </a:solidFill>
+              </a:rPr>
+              <a:t>Function: less muscle loss helps preserve strength and power</a:t>
+            </a:r>
+            <a:endParaRPr lang="en-US" sz="1800" dirty="0"/>
+          </a:p>
+          <a:p>
+            <a:pPr marL="342900" indent="-342900">
+              <a:spcAft>
+                <a:spcPts val="400"/>
+              </a:spcAft>
+              <a:buSzPct val="100000"/>
+              <a:buChar char="•"/>
+            </a:pPr>
+            <a:r>
+              <a:rPr lang="en-US" sz="1500" dirty="0">
+                <a:solidFill>
+                  <a:schemeClr val="tx1"/>
+                </a:solidFill>
+              </a:rPr>
+              <a:t>Mission planning: estimate muscle loss on long missions with limited exercise equipment</a:t>
+            </a:r>
+            <a:endParaRPr lang="en-US" sz="1800" dirty="0"/>
+          </a:p>
+        </p:txBody>
+      </p:sp>
+      <p:sp>
+        <p:nvSpPr>
+          <p:cNvPr id="12" name="Illustration panel"/>
+          <p:cNvSpPr/>
+          <p:nvPr/>
+        </p:nvSpPr>
+        <p:spPr>
+          <a:xfrm>
+            <a:off x="6903720" y="1234440"/>
+            <a:ext cx="4736592" cy="4892040"/>
+          </a:xfrm>
+          <a:prstGeom prst="rect">
+            <a:avLst/>
+          </a:prstGeom>
+          <a:solidFill>
+            <a:schemeClr val="bg2"/>
+          </a:solidFill>
+          <a:ln/>
+        </p:spPr>
+      </p:sp>
+      <p:sp>
+        <p:nvSpPr>
+          <p:cNvPr id="13" name="Text 11"/>
+          <p:cNvSpPr txBox="1"/>
+          <p:nvPr/>
+        </p:nvSpPr>
+        <p:spPr>
+          <a:xfrm>
+            <a:off x="7132320" y="1371600"/>
+            <a:ext cx="4279392" cy="320040"/>
+          </a:xfrm>
+          <a:prstGeom prst="rect">
+            <a:avLst/>
+          </a:prstGeom>
+          <a:noFill/>
+          <a:ln/>
+        </p:spPr>
+        <p:txBody>
+          <a:bodyPr wrap="square" lIns="0" tIns="0" rIns="0" bIns="0" rtlCol="0" anchor="t"/>
+          <a:lstStyle/>
+          <a:p>
+            <a:pPr indent="0" marL="0">
+              <a:buNone/>
+            </a:pPr>
+            <a:r>
+              <a:rPr lang="en-US" sz="1400" b="1" dirty="0">
+                <a:solidFill>
+                  <a:schemeClr val="tx2"/>
+                </a:solidFill>
+              </a:rPr>
+              <a:t>Ground analogue: 6° head-down bed rest</a:t>
+            </a:r>
+            <a:endParaRPr lang="en-US" sz="1400" dirty="0"/>
+          </a:p>
+        </p:txBody>
+      </p:sp>
+      <p:sp>
+        <p:nvSpPr>
+          <p:cNvPr id="14" name="Bed"/>
+          <p:cNvSpPr/>
+          <p:nvPr/>
+        </p:nvSpPr>
+        <p:spPr>
+          <a:xfrm rot="360000">
+            <a:off x="7315200" y="2377440"/>
+            <a:ext cx="3931920" cy="128016"/>
+          </a:xfrm>
+          <a:prstGeom prst="rect">
+            <a:avLst/>
+          </a:prstGeom>
+          <a:solidFill>
+            <a:schemeClr val="accent3"/>
+          </a:solidFill>
+          <a:ln/>
+        </p:spPr>
+      </p:sp>
+      <p:sp>
+        <p:nvSpPr>
+          <p:cNvPr id="15" name="Body"/>
+          <p:cNvSpPr/>
+          <p:nvPr/>
+        </p:nvSpPr>
+        <p:spPr>
+          <a:xfrm rot="360000">
+            <a:off x="7863840" y="2093976"/>
+            <a:ext cx="2606040" cy="329184"/>
+          </a:xfrm>
+          <a:prstGeom prst="roundRect">
+            <a:avLst>
+              <a:gd name="adj" fmla="val 41667"/>
+            </a:avLst>
+          </a:prstGeom>
+          <a:solidFill>
+            <a:schemeClr val="tx2"/>
+          </a:solidFill>
+          <a:ln/>
+        </p:spPr>
+      </p:sp>
+      <p:sp>
+        <p:nvSpPr>
+          <p:cNvPr id="16" name="Head"/>
+          <p:cNvSpPr/>
+          <p:nvPr/>
+        </p:nvSpPr>
+        <p:spPr>
+          <a:xfrm>
+            <a:off x="10469880" y="2167128"/>
+            <a:ext cx="384048" cy="384048"/>
+          </a:xfrm>
+          <a:prstGeom prst="ellipse">
+            <a:avLst/>
+          </a:prstGeom>
+          <a:solidFill>
+            <a:schemeClr val="tx2"/>
+          </a:solidFill>
+          <a:ln/>
+        </p:spPr>
+      </p:sp>
+      <p:sp>
+        <p:nvSpPr>
+          <p:cNvPr id="17" name="Text 15"/>
+          <p:cNvSpPr txBox="1"/>
+          <p:nvPr/>
+        </p:nvSpPr>
+        <p:spPr>
+          <a:xfrm>
+            <a:off x="7132320" y="2788920"/>
+            <a:ext cx="4279392" cy="274320"/>
+          </a:xfrm>
+          <a:prstGeom prst="rect">
+            <a:avLst/>
+          </a:prstGeom>
+          <a:noFill/>
+          <a:ln/>
+        </p:spPr>
+        <p:txBody>
+          <a:bodyPr wrap="square" lIns="0" tIns="0" rIns="0" bIns="0" rtlCol="0" anchor="t"/>
+          <a:lstStyle/>
+          <a:p>
+            <a:pPr indent="0" marL="0">
+              <a:buNone/>
+            </a:pPr>
+            <a:r>
+              <a:rPr lang="en-US" sz="1200" i="1" dirty="0">
+                <a:solidFill>
+                  <a:schemeClr val="accent3"/>
+                </a:solidFill>
+              </a:rPr>
+              <a:t>Weeks to months in bed; legs carry no body weight</a:t>
+            </a:r>
+            <a:endParaRPr lang="en-US" sz="1200" dirty="0"/>
+          </a:p>
+        </p:txBody>
+      </p:sp>
+      <p:sp>
+        <p:nvSpPr>
+          <p:cNvPr id="18" name="Muscle before"/>
+          <p:cNvSpPr/>
+          <p:nvPr/>
+        </p:nvSpPr>
+        <p:spPr>
+          <a:xfrm>
+            <a:off x="7223760" y="3337560"/>
+            <a:ext cx="1737360" cy="1737360"/>
+          </a:xfrm>
+          <a:prstGeom prst="ellipse">
+            <a:avLst/>
+          </a:prstGeom>
+          <a:solidFill>
+            <a:schemeClr val="accent1">
+              <a:alpha val="75000"/>
+            </a:schemeClr>
+          </a:solidFill>
+          <a:ln w="12700">
+            <a:solidFill>
+              <a:srgbClr val="A23B2A"/>
+            </a:solidFill>
+            <a:prstDash val="solid"/>
+          </a:ln>
+        </p:spPr>
+      </p:sp>
+      <p:sp>
+        <p:nvSpPr>
+          <p:cNvPr id="19" name="Muscle before bone"/>
+          <p:cNvSpPr/>
+          <p:nvPr/>
+        </p:nvSpPr>
+        <p:spPr>
+          <a:xfrm>
+            <a:off x="7717536" y="4151376"/>
+            <a:ext cx="384048" cy="384048"/>
+          </a:xfrm>
+          <a:prstGeom prst="ellipse">
             <a:avLst/>
           </a:prstGeom>
           <a:solidFill>
@@ -13441,20 +13828,118 @@
             <a:solidFill>
               <a:srgbClr val="9AA3AE"/>
             </a:solidFill>
+            <a:prstDash val="solid"/>
+          </a:ln>
+        </p:spPr>
+      </p:sp>
+      <p:sp>
+        <p:nvSpPr>
+          <p:cNvPr id="20" name="Arrow"/>
+          <p:cNvSpPr/>
+          <p:nvPr/>
+        </p:nvSpPr>
+        <p:spPr>
+          <a:xfrm>
+            <a:off x="9098280" y="4206240"/>
+            <a:ext cx="548640" cy="0"/>
+          </a:xfrm>
+          <a:prstGeom prst="line">
+            <a:avLst/>
+          </a:prstGeom>
+          <a:noFill/>
+          <a:ln w="15875">
+            <a:solidFill>
+              <a:srgbClr val="1A1A1A"/>
+            </a:solidFill>
+            <a:prstDash val="solid"/>
+            <a:tailEnd type="triangle"/>
+          </a:ln>
+        </p:spPr>
+      </p:sp>
+      <p:sp>
+        <p:nvSpPr>
+          <p:cNvPr id="21" name="Muscle after"/>
+          <p:cNvSpPr/>
+          <p:nvPr/>
+        </p:nvSpPr>
+        <p:spPr>
+          <a:xfrm>
+            <a:off x="9764214" y="3409134"/>
+            <a:ext cx="1594211" cy="1594211"/>
+          </a:xfrm>
+          <a:prstGeom prst="ellipse">
+            <a:avLst/>
+          </a:prstGeom>
+          <a:solidFill>
+            <a:schemeClr val="accent1">
+              <a:alpha val="75000"/>
+            </a:schemeClr>
+          </a:solidFill>
+          <a:ln w="12700">
+            <a:solidFill>
+              <a:srgbClr val="A23B2A"/>
+            </a:solidFill>
+            <a:prstDash val="solid"/>
+          </a:ln>
+        </p:spPr>
+      </p:sp>
+      <p:sp>
+        <p:nvSpPr>
+          <p:cNvPr id="22" name="Muscle after bone"/>
+          <p:cNvSpPr/>
+          <p:nvPr/>
+        </p:nvSpPr>
+        <p:spPr>
+          <a:xfrm>
+            <a:off x="10186416" y="4151376"/>
+            <a:ext cx="384048" cy="384048"/>
+          </a:xfrm>
+          <a:prstGeom prst="ellipse">
+            <a:avLst/>
+          </a:prstGeom>
+          <a:solidFill>
+            <a:schemeClr val="bg1"/>
+          </a:solidFill>
+          <a:ln w="12700">
+            <a:solidFill>
+              <a:srgbClr val="9AA3AE"/>
+            </a:solidFill>
+            <a:prstDash val="solid"/>
+          </a:ln>
+        </p:spPr>
+      </p:sp>
+      <p:sp>
+        <p:nvSpPr>
+          <p:cNvPr id="23" name="Original outline"/>
+          <p:cNvSpPr/>
+          <p:nvPr/>
+        </p:nvSpPr>
+        <p:spPr>
+          <a:xfrm>
+            <a:off x="9692640" y="3337560"/>
+            <a:ext cx="1737360" cy="1737360"/>
+          </a:xfrm>
+          <a:prstGeom prst="ellipse">
+            <a:avLst/>
+          </a:prstGeom>
+          <a:ln w="12700">
+            <a:solidFill>
+              <a:srgbClr val="1A1A1A"/>
+            </a:solidFill>
             <a:prstDash val="dash"/>
           </a:ln>
         </p:spPr>
       </p:sp>
       <p:sp>
         <p:nvSpPr>
-          <p:cNvPr id="12" name="Text 10"/>
+          <p:cNvPr id="24" name="Text 22"/>
           <p:cNvSpPr txBox="1"/>
           <p:nvPr/>
         </p:nvSpPr>
         <p:spPr>
           <a:xfrm>
-            <a:off x="822960" y="1463040"/>
-            <a:ext cx="10515600" cy="4480560"/>
+            <a:off x="7178040" y="5166360"/>
+            <a:ext cx="1828800" cy="274320"/>
           </a:xfrm>
           <a:prstGeom prst="rect">
             <a:avLst/>
@@ -13466,89 +13951,90 @@
           <a:bodyPr wrap="square" lIns="0" tIns="0" rIns="0" bIns="0" rtlCol="0" anchor="t"/>
           <a:lstStyle/>
           <a:p>
+            <a:pPr algn="ctr" indent="0" marL="0">
+              <a:buNone/>
+            </a:pPr>
+            <a:r>
+              <a:rPr lang="en-US" sz="1300" b="1" dirty="0">
+                <a:solidFill>
+                  <a:schemeClr val="tx1"/>
+                </a:solidFill>
+              </a:rPr>
+              <a:t>Before bed rest</a:t>
+            </a:r>
+            <a:endParaRPr lang="en-US" sz="1300" dirty="0"/>
+          </a:p>
+        </p:txBody>
+      </p:sp>
+      <p:sp>
+        <p:nvSpPr>
+          <p:cNvPr id="25" name="Text 23"/>
+          <p:cNvSpPr txBox="1"/>
+          <p:nvPr/>
+        </p:nvSpPr>
+        <p:spPr>
+          <a:xfrm>
+            <a:off x="9646920" y="5166360"/>
+            <a:ext cx="1828800" cy="274320"/>
+          </a:xfrm>
+          <a:prstGeom prst="rect">
+            <a:avLst/>
+          </a:prstGeom>
+          <a:noFill/>
+          <a:ln/>
+        </p:spPr>
+        <p:txBody>
+          <a:bodyPr wrap="square" lIns="0" tIns="0" rIns="0" bIns="0" rtlCol="0" anchor="t"/>
+          <a:lstStyle/>
+          <a:p>
+            <a:pPr algn="ctr" indent="0" marL="0">
+              <a:buNone/>
+            </a:pPr>
+            <a:r>
+              <a:rPr lang="en-US" sz="1300" b="1" dirty="0">
+                <a:solidFill>
+                  <a:schemeClr val="accent1"/>
+                </a:solidFill>
+              </a:rPr>
+              <a:t>Day 60: −16%</a:t>
+            </a:r>
+            <a:endParaRPr lang="en-US" sz="1300" dirty="0"/>
+          </a:p>
+        </p:txBody>
+      </p:sp>
+      <p:sp>
+        <p:nvSpPr>
+          <p:cNvPr id="26" name="Text 24"/>
+          <p:cNvSpPr txBox="1"/>
+          <p:nvPr/>
+        </p:nvSpPr>
+        <p:spPr>
+          <a:xfrm>
+            <a:off x="7132320" y="5532120"/>
+            <a:ext cx="4279392" cy="457200"/>
+          </a:xfrm>
+          <a:prstGeom prst="rect">
+            <a:avLst/>
+          </a:prstGeom>
+          <a:noFill/>
+          <a:ln/>
+        </p:spPr>
+        <p:txBody>
+          <a:bodyPr wrap="square" lIns="0" tIns="0" rIns="0" bIns="0" rtlCol="0" anchor="t"/>
+          <a:lstStyle/>
+          <a:p>
             <a:pPr indent="0" marL="0">
               <a:buNone/>
             </a:pPr>
             <a:r>
-              <a:rPr lang="en-US" sz="1400" b="1" dirty="0">
+              <a:rPr lang="en-US" sz="1100" i="1" dirty="0">
                 <a:solidFill>
                   <a:schemeClr val="accent3"/>
                 </a:solidFill>
               </a:rPr>
-              <a:t>PLACEHOLDER: content by Niloufar</a:t>
-            </a:r>
-            <a:endParaRPr lang="en-US" sz="1400" dirty="0"/>
-          </a:p>
-          <a:p>
-            <a:pPr indent="0" marL="0">
-              <a:spcAft>
-                <a:spcPts val="600"/>
-              </a:spcAft>
-              <a:buNone/>
-            </a:pPr>
-            <a:r>
-              <a:rPr lang="en-US" sz="1400" i="1" dirty="0">
-                <a:solidFill>
-                  <a:schemeClr val="accent3"/>
-                </a:solidFill>
-              </a:rPr>
-              <a:t>Suggested points from the final report:</a:t>
-            </a:r>
-            <a:endParaRPr lang="en-US" sz="1400" dirty="0"/>
-          </a:p>
-          <a:p>
-            <a:pPr marL="342900" indent="-342900">
-              <a:spcAft>
-                <a:spcPts val="400"/>
-              </a:spcAft>
-              <a:buSzPct val="100000"/>
-              <a:buChar char="•"/>
-            </a:pPr>
-            <a:r>
-              <a:rPr lang="en-US" sz="1600" dirty="0">
-                <a:solidFill>
-                  <a:schemeClr val="tx1"/>
-                </a:solidFill>
-              </a:rPr>
-              <a:t>Unloaded muscles that hold the body up against gravity lose mass and strength</a:t>
-            </a:r>
-            <a:endParaRPr lang="en-US" sz="1400" dirty="0"/>
-          </a:p>
-          <a:p>
-            <a:pPr marL="342900" indent="-342900">
-              <a:spcAft>
-                <a:spcPts val="400"/>
-              </a:spcAft>
-              <a:buSzPct val="100000"/>
-              <a:buChar char="•"/>
-            </a:pPr>
-            <a:r>
-              <a:rPr lang="en-US" sz="1600" dirty="0">
-                <a:solidFill>
-                  <a:schemeClr val="tx1"/>
-                </a:solidFill>
-              </a:rPr>
-              <a:t>A transit to Mars takes about six months; the crew must stand, move and work on arrival</a:t>
-            </a:r>
-            <a:endParaRPr lang="en-US" sz="1400" dirty="0"/>
-          </a:p>
-          <a:p>
-            <a:pPr marL="342900" indent="-342900">
-              <a:spcAft>
-                <a:spcPts val="400"/>
-              </a:spcAft>
-              <a:buSzPct val="100000"/>
-              <a:buChar char="•"/>
-            </a:pPr>
-            <a:r>
-              <a:rPr lang="en-US" sz="1600" dirty="0">
-                <a:solidFill>
-                  <a:schemeClr val="tx1"/>
-                </a:solidFill>
-              </a:rPr>
-              <a:t>Countermeasures are planned before departure, so planners need to know how much of a given muscle is lost after a given number of days</a:t>
-            </a:r>
-            <a:endParaRPr lang="en-US" sz="1400" dirty="0"/>
+              <a:t>Calf cross-section to scale; dashed line = size before. Model estimate for control groups (plantar flexors, −15.8% at day 60).</a:t>
+            </a:r>
+            <a:endParaRPr lang="en-US" sz="1100" dirty="0"/>
           </a:p>
         </p:txBody>
       </p:sp>

</xml_diff>

<commit_message>
Slide 4: why from bed rest to Mars, with mission-duration chart and readiness workflow
Co-Authored-By: Claude Opus 5.5 (1M context) <noreply@anthropic.com>
Claude-Session: https://claude.ai/code/session_01JZtuYERhuCe7nB9VYHwcfv
</commit_message>
<xml_diff>
--- a/presentation/bed-rest-to-mars-talk.pptx
+++ b/presentation/bed-rest-to-mars-talk.pptx
@@ -126,13 +126,13 @@
   <p:extLst>
     <p:ext uri="{521415D9-36F7-43E2-AB2F-B90AF26B5E84}">
       <p14:sectionLst xmlns:p14="http://schemas.microsoft.com/office/powerpoint/2010/main">
-        <p14:section name="Opening" id="{9f1ec760-602a-276d-f790-e9f28eb2ed1f}">
+        <p14:section name="Opening" id="{f197ad8b-59a4-2d74-0164-f68eb5d5641f}">
           <p14:sldIdLst>
             <p14:sldId id="256"/>
             <p14:sldId id="257"/>
           </p14:sldIdLst>
         </p14:section>
-        <p14:section name="Part 1" id="{1eb59899-980d-9128-28fc-ce6dfdfba2e0}">
+        <p14:section name="Part 1" id="{9852aba5-79ce-0ab4-09cf-7375582b52e2}">
           <p14:sldIdLst>
             <p14:sldId id="258"/>
             <p14:sldId id="259"/>
@@ -143,7 +143,7 @@
             <p14:sldId id="264"/>
           </p14:sldIdLst>
         </p14:section>
-        <p14:section name="Part 2" id="{3acac844-80bc-fc0b-98e1-03fbfdad200c}">
+        <p14:section name="Part 2" id="{a5c562b9-2ff9-9437-11bc-e3b4d8bf5c2f}">
           <p14:sldIdLst>
             <p14:sldId id="265"/>
             <p14:sldId id="266"/>
@@ -154,7 +154,7 @@
             <p14:sldId id="271"/>
           </p14:sldIdLst>
         </p14:section>
-        <p14:section name="Backup" id="{5098d96c-1c66-428a-6e9f-e7969e334cd4}">
+        <p14:section name="Backup" id="{18098c89-f719-549a-3c04-25d183574bce}">
           <p14:sldIdLst>
             <p14:sldId id="272"/>
             <p14:sldId id="273"/>
@@ -162,13 +162,13 @@
             <p14:sldId id="275"/>
           </p14:sldIdLst>
         </p14:section>
-        <p14:section name="Backup" id="{3ae905a1-b6b8-b568-bdc9-29155b697c90}">
+        <p14:section name="Backup" id="{44cd8629-4e03-fca8-c161-284732192d26}">
           <p14:sldIdLst/>
         </p14:section>
-        <p14:section name="Backup" id="{f591bcc6-d0b4-5bd8-9894-e2cff3088413}">
+        <p14:section name="Backup" id="{d9ba4ffa-8801-04db-50cb-f37c52e6c1bf}">
           <p14:sldIdLst/>
         </p14:section>
-        <p14:section name="Backup" id="{09ae3420-12f8-08e1-6ce7-c9455634195e}">
+        <p14:section name="Backup" id="{283d6083-0dfe-a83a-d9f4-c050a09919ff}">
           <p14:sldIdLst/>
         </p14:section>
       </p14:sectionLst>
@@ -3790,7 +3790,10 @@
           <a:p>
             <a:r>
               <a:rPr lang="en-US" dirty="0"/>
-              <a:t>Placeholder for the co-author's slide. The suggested points are from the final report on branch feat/report; replace them with the final content.</a:t>
+              <a:t>Part 1 (Niloufar), about forty-five seconds.
+Direct spaceflight data on muscle are scarce: in our dataset only 14 of 742 rows come from spaceflight. So we use head-down bed rest, the standard ground analogue: volunteers lie tilted six degrees head-down, and their legs carry no weight, under controlled conditions and for set durations. Bed rest is not the same as spaceflight, but it is a sound starting point to build and test prediction models.
+Mars in our title stands for the long-term application. The chart puts the durations side by side. Our bed-rest data reach day 119. A Moon mission lasted up to 12 days. An ISS stay and a Mars transit both last about six months, but from the ISS a crew can return within hours, and on landing they go straight into medical care. A Mars crew cannot come back early in an emergency, and after months in weightlessness they must leave the spacecraft and work on the surface.
+The bottom row is the idea: atrophy prediction, together with strength and power testing, could one day help keep the crew ready for work on arrival. The dashed steps are future use, and applying the model on a real mission needs validation with spaceflight data first.</a:t>
             </a:r>
             <a:endParaRPr lang="en-US" dirty="0"/>
           </a:p>
@@ -14352,7 +14355,7 @@
                 <a:ea typeface="Cambria" pitchFamily="34" charset="-122"/>
                 <a:cs typeface="Cambria" pitchFamily="34" charset="-120"/>
               </a:rPr>
-              <a:t>From bed rest to Mars: why use bed-rest data?</a:t>
+              <a:t>Why from bed rest to Mars?</a:t>
             </a:r>
             <a:endParaRPr lang="en-US" sz="2800" dirty="0"/>
           </a:p>
@@ -14360,20 +14363,990 @@
       </p:sp>
       <p:sp>
         <p:nvSpPr>
-          <p:cNvPr id="11" name="Placeholder frame"/>
-          <p:cNvSpPr/>
-          <p:nvPr/>
-        </p:nvSpPr>
-        <p:spPr>
-          <a:xfrm>
-            <a:off x="548640" y="1234440"/>
-            <a:ext cx="11064240" cy="4846320"/>
+          <p:cNvPr id="11" name="Text 9"/>
+          <p:cNvSpPr txBox="1"/>
+          <p:nvPr/>
+        </p:nvSpPr>
+        <p:spPr>
+          <a:xfrm>
+            <a:off x="548640" y="1188720"/>
+            <a:ext cx="5577840" cy="3520440"/>
+          </a:xfrm>
+          <a:prstGeom prst="rect">
+            <a:avLst/>
+          </a:prstGeom>
+          <a:noFill/>
+          <a:ln/>
+        </p:spPr>
+        <p:txBody>
+          <a:bodyPr wrap="square" lIns="0" tIns="0" rIns="0" bIns="0" rtlCol="0" anchor="t"/>
+          <a:lstStyle/>
+          <a:p>
+            <a:pPr indent="0" marL="0">
+              <a:spcAft>
+                <a:spcPts val="300"/>
+              </a:spcAft>
+              <a:buNone/>
+            </a:pPr>
+            <a:r>
+              <a:rPr lang="en-US" sz="1700" b="1" dirty="0">
+                <a:solidFill>
+                  <a:schemeClr val="tx2"/>
+                </a:solidFill>
+              </a:rPr>
+              <a:t>Bed rest: the ground analogue</a:t>
+            </a:r>
+            <a:endParaRPr lang="en-US" sz="1700" dirty="0"/>
+          </a:p>
+          <a:p>
+            <a:pPr marL="342900" indent="-342900">
+              <a:spcAft>
+                <a:spcPts val="400"/>
+              </a:spcAft>
+              <a:buSzPct val="100000"/>
+              <a:buChar char="•"/>
+            </a:pPr>
+            <a:r>
+              <a:rPr lang="en-US" sz="1400" dirty="0">
+                <a:solidFill>
+                  <a:schemeClr val="tx1"/>
+                </a:solidFill>
+              </a:rPr>
+              <a:t>Spaceflight data on muscle are scarce: 14 of 742 rows in our dataset</a:t>
+            </a:r>
+            <a:endParaRPr lang="en-US" sz="1700" dirty="0"/>
+          </a:p>
+          <a:p>
+            <a:pPr marL="342900" indent="-342900">
+              <a:spcAft>
+                <a:spcPts val="400"/>
+              </a:spcAft>
+              <a:buSzPct val="100000"/>
+              <a:buChar char="•"/>
+            </a:pPr>
+            <a:r>
+              <a:rPr lang="en-US" sz="1400" dirty="0">
+                <a:solidFill>
+                  <a:schemeClr val="tx1"/>
+                </a:solidFill>
+              </a:rPr>
+              <a:t>Head-down bed rest unloads the legs under controlled conditions, for set durations</a:t>
+            </a:r>
+            <a:endParaRPr lang="en-US" sz="1700" dirty="0"/>
+          </a:p>
+          <a:p>
+            <a:pPr marL="342900" indent="-342900">
+              <a:spcAft>
+                <a:spcPts val="400"/>
+              </a:spcAft>
+              <a:buSzPct val="100000"/>
+              <a:buChar char="•"/>
+            </a:pPr>
+            <a:r>
+              <a:rPr lang="en-US" sz="1400" dirty="0">
+                <a:solidFill>
+                  <a:schemeClr val="tx1"/>
+                </a:solidFill>
+              </a:rPr>
+              <a:t>Not equivalent to spaceflight, but a sound basis to build and test prediction models</a:t>
+            </a:r>
+            <a:endParaRPr lang="en-US" sz="1700" dirty="0"/>
+          </a:p>
+          <a:p>
+            <a:pPr indent="0" marL="0">
+              <a:spcBef>
+                <a:spcPts val="1000"/>
+              </a:spcBef>
+              <a:spcAft>
+                <a:spcPts val="300"/>
+              </a:spcAft>
+              <a:buNone/>
+            </a:pPr>
+            <a:r>
+              <a:rPr lang="en-US" sz="1700" b="1" dirty="0">
+                <a:solidFill>
+                  <a:schemeClr val="tx2"/>
+                </a:solidFill>
+              </a:rPr>
+              <a:t>Mars: the long-term application</a:t>
+            </a:r>
+            <a:endParaRPr lang="en-US" sz="1700" dirty="0"/>
+          </a:p>
+          <a:p>
+            <a:pPr marL="342900" indent="-342900">
+              <a:spcAft>
+                <a:spcPts val="400"/>
+              </a:spcAft>
+              <a:buSzPct val="100000"/>
+              <a:buChar char="•"/>
+            </a:pPr>
+            <a:r>
+              <a:rPr lang="en-US" sz="1400" dirty="0">
+                <a:solidFill>
+                  <a:schemeClr val="tx1"/>
+                </a:solidFill>
+              </a:rPr>
+              <a:t>Transit of about 6 months, far longer than a Moon mission</a:t>
+            </a:r>
+            <a:endParaRPr lang="en-US" sz="1700" dirty="0"/>
+          </a:p>
+          <a:p>
+            <a:pPr marL="342900" indent="-342900">
+              <a:spcAft>
+                <a:spcPts val="400"/>
+              </a:spcAft>
+              <a:buSzPct val="100000"/>
+              <a:buChar char="•"/>
+            </a:pPr>
+            <a:r>
+              <a:rPr lang="en-US" sz="1400" dirty="0">
+                <a:solidFill>
+                  <a:schemeClr val="tx1"/>
+                </a:solidFill>
+              </a:rPr>
+              <a:t>No early return in an emergency: after months in weightlessness, the crew must leave the spacecraft and work on the surface</a:t>
+            </a:r>
+            <a:endParaRPr lang="en-US" sz="1700" dirty="0"/>
+          </a:p>
+          <a:p>
+            <a:pPr marL="342900" indent="-342900">
+              <a:spcAft>
+                <a:spcPts val="400"/>
+              </a:spcAft>
+              <a:buSzPct val="100000"/>
+              <a:buChar char="•"/>
+            </a:pPr>
+            <a:r>
+              <a:rPr lang="en-US" sz="1400" dirty="0">
+                <a:solidFill>
+                  <a:schemeClr val="tx1"/>
+                </a:solidFill>
+              </a:rPr>
+              <a:t>Use on such a mission requires validation with spaceflight data</a:t>
+            </a:r>
+            <a:endParaRPr lang="en-US" sz="1700" dirty="0"/>
+          </a:p>
+        </p:txBody>
+      </p:sp>
+      <p:sp>
+        <p:nvSpPr>
+          <p:cNvPr id="12" name="Duration panel"/>
+          <p:cNvSpPr/>
+          <p:nvPr/>
+        </p:nvSpPr>
+        <p:spPr>
+          <a:xfrm>
+            <a:off x="6492240" y="1188720"/>
+            <a:ext cx="5148072" cy="3520440"/>
           </a:xfrm>
           <a:prstGeom prst="rect">
             <a:avLst/>
           </a:prstGeom>
           <a:solidFill>
-            <a:schemeClr val="bg1"/>
+            <a:schemeClr val="bg2"/>
+          </a:solidFill>
+          <a:ln/>
+        </p:spPr>
+      </p:sp>
+      <p:sp>
+        <p:nvSpPr>
+          <p:cNvPr id="13" name="Text 11"/>
+          <p:cNvSpPr txBox="1"/>
+          <p:nvPr/>
+        </p:nvSpPr>
+        <p:spPr>
+          <a:xfrm>
+            <a:off x="6675120" y="1280160"/>
+            <a:ext cx="4782312" cy="274320"/>
+          </a:xfrm>
+          <a:prstGeom prst="rect">
+            <a:avLst/>
+          </a:prstGeom>
+          <a:noFill/>
+          <a:ln/>
+        </p:spPr>
+        <p:txBody>
+          <a:bodyPr wrap="square" lIns="0" tIns="0" rIns="0" bIns="0" rtlCol="0" anchor="t"/>
+          <a:lstStyle/>
+          <a:p>
+            <a:pPr indent="0" marL="0">
+              <a:buNone/>
+            </a:pPr>
+            <a:r>
+              <a:rPr lang="en-US" sz="1400" b="1" dirty="0">
+                <a:solidFill>
+                  <a:schemeClr val="tx2"/>
+                </a:solidFill>
+              </a:rPr>
+              <a:t>Time without Earth's gravity (days)</a:t>
+            </a:r>
+            <a:endParaRPr lang="en-US" sz="1400" dirty="0"/>
+          </a:p>
+        </p:txBody>
+      </p:sp>
+      <p:sp>
+        <p:nvSpPr>
+          <p:cNvPr id="14" name="Text 12"/>
+          <p:cNvSpPr txBox="1"/>
+          <p:nvPr/>
+        </p:nvSpPr>
+        <p:spPr>
+          <a:xfrm>
+            <a:off x="6675120" y="1737360"/>
+            <a:ext cx="1691640" cy="502920"/>
+          </a:xfrm>
+          <a:prstGeom prst="rect">
+            <a:avLst/>
+          </a:prstGeom>
+          <a:noFill/>
+          <a:ln/>
+        </p:spPr>
+        <p:txBody>
+          <a:bodyPr wrap="square" lIns="0" tIns="0" rIns="0" bIns="0" rtlCol="0" anchor="t"/>
+          <a:lstStyle/>
+          <a:p>
+            <a:pPr indent="0" marL="0">
+              <a:buNone/>
+            </a:pPr>
+            <a:r>
+              <a:rPr lang="en-US" sz="1300" b="1" dirty="0">
+                <a:solidFill>
+                  <a:schemeClr val="tx1"/>
+                </a:solidFill>
+              </a:rPr>
+              <a:t>Bed-rest data</a:t>
+            </a:r>
+            <a:endParaRPr lang="en-US" sz="1300" dirty="0"/>
+          </a:p>
+          <a:p>
+            <a:pPr indent="0" marL="0">
+              <a:buNone/>
+            </a:pPr>
+            <a:r>
+              <a:rPr lang="en-US" sz="1050" i="1" dirty="0">
+                <a:solidFill>
+                  <a:schemeClr val="accent3"/>
+                </a:solidFill>
+              </a:rPr>
+              <a:t>our data: day 5 to 119</a:t>
+            </a:r>
+            <a:endParaRPr lang="en-US" sz="1300" dirty="0"/>
+          </a:p>
+        </p:txBody>
+      </p:sp>
+      <p:sp>
+        <p:nvSpPr>
+          <p:cNvPr id="15" name="Bed-rest data bar"/>
+          <p:cNvSpPr/>
+          <p:nvPr/>
+        </p:nvSpPr>
+        <p:spPr>
+          <a:xfrm>
+            <a:off x="8665083" y="1847088"/>
+            <a:ext cx="1589684" cy="274320"/>
+          </a:xfrm>
+          <a:prstGeom prst="rect">
+            <a:avLst/>
+          </a:prstGeom>
+          <a:solidFill>
+            <a:srgbClr val="1F3A5F"/>
+          </a:solidFill>
+          <a:ln/>
+        </p:spPr>
+      </p:sp>
+      <p:sp>
+        <p:nvSpPr>
+          <p:cNvPr id="16" name="Gap to 180 days"/>
+          <p:cNvSpPr/>
+          <p:nvPr/>
+        </p:nvSpPr>
+        <p:spPr>
+          <a:xfrm>
+            <a:off x="10254767" y="1847088"/>
+            <a:ext cx="850621" cy="274320"/>
+          </a:xfrm>
+          <a:prstGeom prst="rect">
+            <a:avLst/>
+          </a:prstGeom>
+          <a:ln w="12700">
+            <a:solidFill>
+              <a:srgbClr val="1F3A5F"/>
+            </a:solidFill>
+            <a:prstDash val="dash"/>
+          </a:ln>
+        </p:spPr>
+      </p:sp>
+      <p:sp>
+        <p:nvSpPr>
+          <p:cNvPr id="17" name="Text 15"/>
+          <p:cNvSpPr txBox="1"/>
+          <p:nvPr/>
+        </p:nvSpPr>
+        <p:spPr>
+          <a:xfrm>
+            <a:off x="10254767" y="1847088"/>
+            <a:ext cx="850621" cy="274320"/>
+          </a:xfrm>
+          <a:prstGeom prst="rect">
+            <a:avLst/>
+          </a:prstGeom>
+          <a:noFill/>
+          <a:ln/>
+        </p:spPr>
+        <p:txBody>
+          <a:bodyPr wrap="square" lIns="0" tIns="0" rIns="0" bIns="0" rtlCol="0" anchor="ctr"/>
+          <a:lstStyle/>
+          <a:p>
+            <a:pPr algn="ctr" indent="0" marL="0">
+              <a:buNone/>
+            </a:pPr>
+            <a:r>
+              <a:rPr lang="en-US" sz="1000" i="1" dirty="0">
+                <a:solidFill>
+                  <a:schemeClr val="tx2"/>
+                </a:solidFill>
+              </a:rPr>
+              <a:t>not covered</a:t>
+            </a:r>
+            <a:endParaRPr lang="en-US" sz="1000" dirty="0"/>
+          </a:p>
+        </p:txBody>
+      </p:sp>
+      <p:sp>
+        <p:nvSpPr>
+          <p:cNvPr id="18" name="Text 16"/>
+          <p:cNvSpPr txBox="1"/>
+          <p:nvPr/>
+        </p:nvSpPr>
+        <p:spPr>
+          <a:xfrm>
+            <a:off x="6675120" y="2359152"/>
+            <a:ext cx="1691640" cy="502920"/>
+          </a:xfrm>
+          <a:prstGeom prst="rect">
+            <a:avLst/>
+          </a:prstGeom>
+          <a:noFill/>
+          <a:ln/>
+        </p:spPr>
+        <p:txBody>
+          <a:bodyPr wrap="square" lIns="0" tIns="0" rIns="0" bIns="0" rtlCol="0" anchor="t"/>
+          <a:lstStyle/>
+          <a:p>
+            <a:pPr indent="0" marL="0">
+              <a:buNone/>
+            </a:pPr>
+            <a:r>
+              <a:rPr lang="en-US" sz="1300" b="1" dirty="0">
+                <a:solidFill>
+                  <a:schemeClr val="tx1"/>
+                </a:solidFill>
+              </a:rPr>
+              <a:t>Moon mission</a:t>
+            </a:r>
+            <a:endParaRPr lang="en-US" sz="1300" dirty="0"/>
+          </a:p>
+          <a:p>
+            <a:pPr indent="0" marL="0">
+              <a:buNone/>
+            </a:pPr>
+            <a:r>
+              <a:rPr lang="en-US" sz="1050" i="1" dirty="0">
+                <a:solidFill>
+                  <a:schemeClr val="accent3"/>
+                </a:solidFill>
+              </a:rPr>
+              <a:t>Apollo: up to 12 days</a:t>
+            </a:r>
+            <a:endParaRPr lang="en-US" sz="1300" dirty="0"/>
+          </a:p>
+        </p:txBody>
+      </p:sp>
+      <p:sp>
+        <p:nvSpPr>
+          <p:cNvPr id="19" name="Moon mission bar"/>
+          <p:cNvSpPr/>
+          <p:nvPr/>
+        </p:nvSpPr>
+        <p:spPr>
+          <a:xfrm>
+            <a:off x="8595360" y="2468880"/>
+            <a:ext cx="167335" cy="274320"/>
+          </a:xfrm>
+          <a:prstGeom prst="rect">
+            <a:avLst/>
+          </a:prstGeom>
+          <a:solidFill>
+            <a:srgbClr val="A7AEB8"/>
+          </a:solidFill>
+          <a:ln/>
+        </p:spPr>
+      </p:sp>
+      <p:sp>
+        <p:nvSpPr>
+          <p:cNvPr id="20" name="Text 18"/>
+          <p:cNvSpPr txBox="1"/>
+          <p:nvPr/>
+        </p:nvSpPr>
+        <p:spPr>
+          <a:xfrm>
+            <a:off x="6675120" y="2980944"/>
+            <a:ext cx="1691640" cy="502920"/>
+          </a:xfrm>
+          <a:prstGeom prst="rect">
+            <a:avLst/>
+          </a:prstGeom>
+          <a:noFill/>
+          <a:ln/>
+        </p:spPr>
+        <p:txBody>
+          <a:bodyPr wrap="square" lIns="0" tIns="0" rIns="0" bIns="0" rtlCol="0" anchor="t"/>
+          <a:lstStyle/>
+          <a:p>
+            <a:pPr indent="0" marL="0">
+              <a:buNone/>
+            </a:pPr>
+            <a:r>
+              <a:rPr lang="en-US" sz="1300" b="1" dirty="0">
+                <a:solidFill>
+                  <a:schemeClr val="tx1"/>
+                </a:solidFill>
+              </a:rPr>
+              <a:t>ISS stay</a:t>
+            </a:r>
+            <a:endParaRPr lang="en-US" sz="1300" dirty="0"/>
+          </a:p>
+          <a:p>
+            <a:pPr indent="0" marL="0">
+              <a:buNone/>
+            </a:pPr>
+            <a:r>
+              <a:rPr lang="en-US" sz="1050" i="1" dirty="0">
+                <a:solidFill>
+                  <a:schemeClr val="accent3"/>
+                </a:solidFill>
+              </a:rPr>
+              <a:t>return within hours</a:t>
+            </a:r>
+            <a:endParaRPr lang="en-US" sz="1300" dirty="0"/>
+          </a:p>
+        </p:txBody>
+      </p:sp>
+      <p:sp>
+        <p:nvSpPr>
+          <p:cNvPr id="21" name="ISS stay bar"/>
+          <p:cNvSpPr/>
+          <p:nvPr/>
+        </p:nvSpPr>
+        <p:spPr>
+          <a:xfrm>
+            <a:off x="8595360" y="3090672"/>
+            <a:ext cx="2510028" cy="274320"/>
+          </a:xfrm>
+          <a:prstGeom prst="rect">
+            <a:avLst/>
+          </a:prstGeom>
+          <a:solidFill>
+            <a:srgbClr val="A7AEB8"/>
+          </a:solidFill>
+          <a:ln/>
+        </p:spPr>
+      </p:sp>
+      <p:sp>
+        <p:nvSpPr>
+          <p:cNvPr id="22" name="Text 20"/>
+          <p:cNvSpPr txBox="1"/>
+          <p:nvPr/>
+        </p:nvSpPr>
+        <p:spPr>
+          <a:xfrm>
+            <a:off x="6675120" y="3602736"/>
+            <a:ext cx="1691640" cy="502920"/>
+          </a:xfrm>
+          <a:prstGeom prst="rect">
+            <a:avLst/>
+          </a:prstGeom>
+          <a:noFill/>
+          <a:ln/>
+        </p:spPr>
+        <p:txBody>
+          <a:bodyPr wrap="square" lIns="0" tIns="0" rIns="0" bIns="0" rtlCol="0" anchor="t"/>
+          <a:lstStyle/>
+          <a:p>
+            <a:pPr indent="0" marL="0">
+              <a:buNone/>
+            </a:pPr>
+            <a:r>
+              <a:rPr lang="en-US" sz="1300" b="1" dirty="0">
+                <a:solidFill>
+                  <a:schemeClr val="tx1"/>
+                </a:solidFill>
+              </a:rPr>
+              <a:t>Mars transit</a:t>
+            </a:r>
+            <a:endParaRPr lang="en-US" sz="1300" dirty="0"/>
+          </a:p>
+          <a:p>
+            <a:pPr indent="0" marL="0">
+              <a:buNone/>
+            </a:pPr>
+            <a:r>
+              <a:rPr lang="en-US" sz="1050" i="1" dirty="0">
+                <a:solidFill>
+                  <a:schemeClr val="accent3"/>
+                </a:solidFill>
+              </a:rPr>
+              <a:t>no early return</a:t>
+            </a:r>
+            <a:endParaRPr lang="en-US" sz="1300" dirty="0"/>
+          </a:p>
+        </p:txBody>
+      </p:sp>
+      <p:sp>
+        <p:nvSpPr>
+          <p:cNvPr id="23" name="Mars transit bar"/>
+          <p:cNvSpPr/>
+          <p:nvPr/>
+        </p:nvSpPr>
+        <p:spPr>
+          <a:xfrm>
+            <a:off x="8595360" y="3712464"/>
+            <a:ext cx="2510028" cy="274320"/>
+          </a:xfrm>
+          <a:prstGeom prst="rect">
+            <a:avLst/>
+          </a:prstGeom>
+          <a:solidFill>
+            <a:srgbClr val="A23B2A"/>
+          </a:solidFill>
+          <a:ln/>
+        </p:spPr>
+      </p:sp>
+      <p:sp>
+        <p:nvSpPr>
+          <p:cNvPr id="24" name="Day axis"/>
+          <p:cNvSpPr/>
+          <p:nvPr/>
+        </p:nvSpPr>
+        <p:spPr>
+          <a:xfrm>
+            <a:off x="8595360" y="4242816"/>
+            <a:ext cx="2788920" cy="0"/>
+          </a:xfrm>
+          <a:prstGeom prst="line">
+            <a:avLst/>
+          </a:prstGeom>
+          <a:noFill/>
+          <a:ln w="9525">
+            <a:solidFill>
+              <a:srgbClr val="6B7280"/>
+            </a:solidFill>
+            <a:prstDash val="solid"/>
+          </a:ln>
+        </p:spPr>
+      </p:sp>
+      <p:sp>
+        <p:nvSpPr>
+          <p:cNvPr id="25" name="Tick 0"/>
+          <p:cNvSpPr/>
+          <p:nvPr/>
+        </p:nvSpPr>
+        <p:spPr>
+          <a:xfrm>
+            <a:off x="8595360" y="4242816"/>
+            <a:ext cx="0" cy="54864"/>
+          </a:xfrm>
+          <a:prstGeom prst="line">
+            <a:avLst/>
+          </a:prstGeom>
+          <a:noFill/>
+          <a:ln w="9525">
+            <a:solidFill>
+              <a:srgbClr val="6B7280"/>
+            </a:solidFill>
+            <a:prstDash val="solid"/>
+          </a:ln>
+        </p:spPr>
+      </p:sp>
+      <p:sp>
+        <p:nvSpPr>
+          <p:cNvPr id="26" name="Text 24"/>
+          <p:cNvSpPr txBox="1"/>
+          <p:nvPr/>
+        </p:nvSpPr>
+        <p:spPr>
+          <a:xfrm>
+            <a:off x="8321040" y="4306824"/>
+            <a:ext cx="548640" cy="201168"/>
+          </a:xfrm>
+          <a:prstGeom prst="rect">
+            <a:avLst/>
+          </a:prstGeom>
+          <a:noFill/>
+          <a:ln/>
+        </p:spPr>
+        <p:txBody>
+          <a:bodyPr wrap="square" lIns="0" tIns="0" rIns="0" bIns="0" rtlCol="0" anchor="t"/>
+          <a:lstStyle/>
+          <a:p>
+            <a:pPr algn="ctr" indent="0" marL="0">
+              <a:buNone/>
+            </a:pPr>
+            <a:r>
+              <a:rPr lang="en-US" sz="1000" dirty="0">
+                <a:solidFill>
+                  <a:schemeClr val="accent3"/>
+                </a:solidFill>
+              </a:rPr>
+              <a:t>0</a:t>
+            </a:r>
+            <a:endParaRPr lang="en-US" sz="1000" dirty="0"/>
+          </a:p>
+        </p:txBody>
+      </p:sp>
+      <p:sp>
+        <p:nvSpPr>
+          <p:cNvPr id="27" name="Tick 60"/>
+          <p:cNvSpPr/>
+          <p:nvPr/>
+        </p:nvSpPr>
+        <p:spPr>
+          <a:xfrm>
+            <a:off x="9432036" y="4242816"/>
+            <a:ext cx="0" cy="54864"/>
+          </a:xfrm>
+          <a:prstGeom prst="line">
+            <a:avLst/>
+          </a:prstGeom>
+          <a:noFill/>
+          <a:ln w="9525">
+            <a:solidFill>
+              <a:srgbClr val="6B7280"/>
+            </a:solidFill>
+            <a:prstDash val="solid"/>
+          </a:ln>
+        </p:spPr>
+      </p:sp>
+      <p:sp>
+        <p:nvSpPr>
+          <p:cNvPr id="28" name="Text 26"/>
+          <p:cNvSpPr txBox="1"/>
+          <p:nvPr/>
+        </p:nvSpPr>
+        <p:spPr>
+          <a:xfrm>
+            <a:off x="9157716" y="4306824"/>
+            <a:ext cx="548640" cy="201168"/>
+          </a:xfrm>
+          <a:prstGeom prst="rect">
+            <a:avLst/>
+          </a:prstGeom>
+          <a:noFill/>
+          <a:ln/>
+        </p:spPr>
+        <p:txBody>
+          <a:bodyPr wrap="square" lIns="0" tIns="0" rIns="0" bIns="0" rtlCol="0" anchor="t"/>
+          <a:lstStyle/>
+          <a:p>
+            <a:pPr algn="ctr" indent="0" marL="0">
+              <a:buNone/>
+            </a:pPr>
+            <a:r>
+              <a:rPr lang="en-US" sz="1000" dirty="0">
+                <a:solidFill>
+                  <a:schemeClr val="accent3"/>
+                </a:solidFill>
+              </a:rPr>
+              <a:t>60</a:t>
+            </a:r>
+            <a:endParaRPr lang="en-US" sz="1000" dirty="0"/>
+          </a:p>
+        </p:txBody>
+      </p:sp>
+      <p:sp>
+        <p:nvSpPr>
+          <p:cNvPr id="29" name="Tick 120"/>
+          <p:cNvSpPr/>
+          <p:nvPr/>
+        </p:nvSpPr>
+        <p:spPr>
+          <a:xfrm>
+            <a:off x="10268712" y="4242816"/>
+            <a:ext cx="0" cy="54864"/>
+          </a:xfrm>
+          <a:prstGeom prst="line">
+            <a:avLst/>
+          </a:prstGeom>
+          <a:noFill/>
+          <a:ln w="9525">
+            <a:solidFill>
+              <a:srgbClr val="6B7280"/>
+            </a:solidFill>
+            <a:prstDash val="solid"/>
+          </a:ln>
+        </p:spPr>
+      </p:sp>
+      <p:sp>
+        <p:nvSpPr>
+          <p:cNvPr id="30" name="Text 28"/>
+          <p:cNvSpPr txBox="1"/>
+          <p:nvPr/>
+        </p:nvSpPr>
+        <p:spPr>
+          <a:xfrm>
+            <a:off x="9994392" y="4306824"/>
+            <a:ext cx="548640" cy="201168"/>
+          </a:xfrm>
+          <a:prstGeom prst="rect">
+            <a:avLst/>
+          </a:prstGeom>
+          <a:noFill/>
+          <a:ln/>
+        </p:spPr>
+        <p:txBody>
+          <a:bodyPr wrap="square" lIns="0" tIns="0" rIns="0" bIns="0" rtlCol="0" anchor="t"/>
+          <a:lstStyle/>
+          <a:p>
+            <a:pPr algn="ctr" indent="0" marL="0">
+              <a:buNone/>
+            </a:pPr>
+            <a:r>
+              <a:rPr lang="en-US" sz="1000" dirty="0">
+                <a:solidFill>
+                  <a:schemeClr val="accent3"/>
+                </a:solidFill>
+              </a:rPr>
+              <a:t>120</a:t>
+            </a:r>
+            <a:endParaRPr lang="en-US" sz="1000" dirty="0"/>
+          </a:p>
+        </p:txBody>
+      </p:sp>
+      <p:sp>
+        <p:nvSpPr>
+          <p:cNvPr id="31" name="Tick 180"/>
+          <p:cNvSpPr/>
+          <p:nvPr/>
+        </p:nvSpPr>
+        <p:spPr>
+          <a:xfrm>
+            <a:off x="11105388" y="4242816"/>
+            <a:ext cx="0" cy="54864"/>
+          </a:xfrm>
+          <a:prstGeom prst="line">
+            <a:avLst/>
+          </a:prstGeom>
+          <a:noFill/>
+          <a:ln w="9525">
+            <a:solidFill>
+              <a:srgbClr val="6B7280"/>
+            </a:solidFill>
+            <a:prstDash val="solid"/>
+          </a:ln>
+        </p:spPr>
+      </p:sp>
+      <p:sp>
+        <p:nvSpPr>
+          <p:cNvPr id="32" name="Text 30"/>
+          <p:cNvSpPr txBox="1"/>
+          <p:nvPr/>
+        </p:nvSpPr>
+        <p:spPr>
+          <a:xfrm>
+            <a:off x="10831068" y="4306824"/>
+            <a:ext cx="548640" cy="201168"/>
+          </a:xfrm>
+          <a:prstGeom prst="rect">
+            <a:avLst/>
+          </a:prstGeom>
+          <a:noFill/>
+          <a:ln/>
+        </p:spPr>
+        <p:txBody>
+          <a:bodyPr wrap="square" lIns="0" tIns="0" rIns="0" bIns="0" rtlCol="0" anchor="t"/>
+          <a:lstStyle/>
+          <a:p>
+            <a:pPr algn="ctr" indent="0" marL="0">
+              <a:buNone/>
+            </a:pPr>
+            <a:r>
+              <a:rPr lang="en-US" sz="1000" dirty="0">
+                <a:solidFill>
+                  <a:schemeClr val="accent3"/>
+                </a:solidFill>
+              </a:rPr>
+              <a:t>180</a:t>
+            </a:r>
+            <a:endParaRPr lang="en-US" sz="1000" dirty="0"/>
+          </a:p>
+        </p:txBody>
+      </p:sp>
+      <p:sp>
+        <p:nvSpPr>
+          <p:cNvPr id="33" name="Step 1"/>
+          <p:cNvSpPr/>
+          <p:nvPr/>
+        </p:nvSpPr>
+        <p:spPr>
+          <a:xfrm>
+            <a:off x="548640" y="4983480"/>
+            <a:ext cx="2423160" cy="685800"/>
+          </a:xfrm>
+          <a:prstGeom prst="rect">
+            <a:avLst/>
+          </a:prstGeom>
+          <a:solidFill>
+            <a:srgbClr val="FFFFFF"/>
+          </a:solidFill>
+          <a:ln w="12700">
+            <a:solidFill>
+              <a:srgbClr val="9AA3AE"/>
+            </a:solidFill>
+            <a:prstDash val="solid"/>
+          </a:ln>
+        </p:spPr>
+      </p:sp>
+      <p:sp>
+        <p:nvSpPr>
+          <p:cNvPr id="34" name="Text 32"/>
+          <p:cNvSpPr txBox="1"/>
+          <p:nvPr/>
+        </p:nvSpPr>
+        <p:spPr>
+          <a:xfrm>
+            <a:off x="640080" y="4983480"/>
+            <a:ext cx="2240280" cy="685800"/>
+          </a:xfrm>
+          <a:prstGeom prst="rect">
+            <a:avLst/>
+          </a:prstGeom>
+          <a:noFill/>
+          <a:ln/>
+        </p:spPr>
+        <p:txBody>
+          <a:bodyPr wrap="square" lIns="0" tIns="0" rIns="0" bIns="0" rtlCol="0" anchor="ctr"/>
+          <a:lstStyle/>
+          <a:p>
+            <a:pPr algn="ctr" indent="0" marL="0">
+              <a:buNone/>
+            </a:pPr>
+            <a:r>
+              <a:rPr lang="en-US" sz="1400" b="1" dirty="0">
+                <a:solidFill>
+                  <a:schemeClr val="tx1"/>
+                </a:solidFill>
+              </a:rPr>
+              <a:t>Bed-rest studies</a:t>
+            </a:r>
+            <a:endParaRPr lang="en-US" sz="1400" dirty="0"/>
+          </a:p>
+          <a:p>
+            <a:pPr algn="ctr" indent="0" marL="0">
+              <a:buNone/>
+            </a:pPr>
+            <a:r>
+              <a:rPr lang="en-US" sz="1100" i="1" dirty="0">
+                <a:solidFill>
+                  <a:schemeClr val="tx1"/>
+                </a:solidFill>
+              </a:rPr>
+              <a:t>ground analogue</a:t>
+            </a:r>
+            <a:endParaRPr lang="en-US" sz="1400" dirty="0"/>
+          </a:p>
+        </p:txBody>
+      </p:sp>
+      <p:sp>
+        <p:nvSpPr>
+          <p:cNvPr id="35" name="Step 2"/>
+          <p:cNvSpPr/>
+          <p:nvPr/>
+        </p:nvSpPr>
+        <p:spPr>
+          <a:xfrm>
+            <a:off x="3429000" y="4983480"/>
+            <a:ext cx="2423160" cy="685800"/>
+          </a:xfrm>
+          <a:prstGeom prst="rect">
+            <a:avLst/>
+          </a:prstGeom>
+          <a:solidFill>
+            <a:srgbClr val="1F3A5F"/>
+          </a:solidFill>
+          <a:ln w="12700">
+            <a:solidFill>
+              <a:srgbClr val="1F3A5F"/>
+            </a:solidFill>
+            <a:prstDash val="solid"/>
+          </a:ln>
+        </p:spPr>
+      </p:sp>
+      <p:sp>
+        <p:nvSpPr>
+          <p:cNvPr id="36" name="Text 34"/>
+          <p:cNvSpPr txBox="1"/>
+          <p:nvPr/>
+        </p:nvSpPr>
+        <p:spPr>
+          <a:xfrm>
+            <a:off x="3520440" y="4983480"/>
+            <a:ext cx="2240280" cy="685800"/>
+          </a:xfrm>
+          <a:prstGeom prst="rect">
+            <a:avLst/>
+          </a:prstGeom>
+          <a:noFill/>
+          <a:ln/>
+        </p:spPr>
+        <p:txBody>
+          <a:bodyPr wrap="square" lIns="0" tIns="0" rIns="0" bIns="0" rtlCol="0" anchor="ctr"/>
+          <a:lstStyle/>
+          <a:p>
+            <a:pPr algn="ctr" indent="0" marL="0">
+              <a:buNone/>
+            </a:pPr>
+            <a:r>
+              <a:rPr lang="en-US" sz="1400" b="1" dirty="0">
+                <a:solidFill>
+                  <a:schemeClr val="bg1"/>
+                </a:solidFill>
+              </a:rPr>
+              <a:t>Atrophy prediction</a:t>
+            </a:r>
+            <a:endParaRPr lang="en-US" sz="1400" dirty="0"/>
+          </a:p>
+          <a:p>
+            <a:pPr algn="ctr" indent="0" marL="0">
+              <a:buNone/>
+            </a:pPr>
+            <a:r>
+              <a:rPr lang="en-US" sz="1100" i="1" dirty="0">
+                <a:solidFill>
+                  <a:schemeClr val="bg1"/>
+                </a:solidFill>
+              </a:rPr>
+              <a:t>this work</a:t>
+            </a:r>
+            <a:endParaRPr lang="en-US" sz="1400" dirty="0"/>
+          </a:p>
+        </p:txBody>
+      </p:sp>
+      <p:sp>
+        <p:nvSpPr>
+          <p:cNvPr id="37" name="Step 3"/>
+          <p:cNvSpPr/>
+          <p:nvPr/>
+        </p:nvSpPr>
+        <p:spPr>
+          <a:xfrm>
+            <a:off x="6309360" y="4983480"/>
+            <a:ext cx="2423160" cy="685800"/>
+          </a:xfrm>
+          <a:prstGeom prst="rect">
+            <a:avLst/>
+          </a:prstGeom>
+          <a:solidFill>
+            <a:srgbClr val="FFFFFF"/>
           </a:solidFill>
           <a:ln w="12700">
             <a:solidFill>
@@ -14385,14 +15358,14 @@
       </p:sp>
       <p:sp>
         <p:nvSpPr>
-          <p:cNvPr id="12" name="Text 10"/>
+          <p:cNvPr id="38" name="Text 36"/>
           <p:cNvSpPr txBox="1"/>
           <p:nvPr/>
         </p:nvSpPr>
         <p:spPr>
           <a:xfrm>
-            <a:off x="822960" y="1463040"/>
-            <a:ext cx="10515600" cy="4480560"/>
+            <a:off x="6400800" y="4983480"/>
+            <a:ext cx="2240280" cy="685800"/>
           </a:xfrm>
           <a:prstGeom prst="rect">
             <a:avLst/>
@@ -14401,6 +15374,187 @@
           <a:ln/>
         </p:spPr>
         <p:txBody>
+          <a:bodyPr wrap="square" lIns="0" tIns="0" rIns="0" bIns="0" rtlCol="0" anchor="ctr"/>
+          <a:lstStyle/>
+          <a:p>
+            <a:pPr algn="ctr" indent="0" marL="0">
+              <a:buNone/>
+            </a:pPr>
+            <a:r>
+              <a:rPr lang="en-US" sz="1400" b="1" dirty="0">
+                <a:solidFill>
+                  <a:schemeClr val="tx1"/>
+                </a:solidFill>
+              </a:rPr>
+              <a:t>Strength and power assessment</a:t>
+            </a:r>
+            <a:endParaRPr lang="en-US" sz="1400" dirty="0"/>
+          </a:p>
+        </p:txBody>
+      </p:sp>
+      <p:sp>
+        <p:nvSpPr>
+          <p:cNvPr id="39" name="Step 4"/>
+          <p:cNvSpPr/>
+          <p:nvPr/>
+        </p:nvSpPr>
+        <p:spPr>
+          <a:xfrm>
+            <a:off x="9189720" y="4983480"/>
+            <a:ext cx="2423160" cy="685800"/>
+          </a:xfrm>
+          <a:prstGeom prst="rect">
+            <a:avLst/>
+          </a:prstGeom>
+          <a:solidFill>
+            <a:srgbClr val="FFFFFF"/>
+          </a:solidFill>
+          <a:ln w="12700">
+            <a:solidFill>
+              <a:srgbClr val="9AA3AE"/>
+            </a:solidFill>
+            <a:prstDash val="dash"/>
+          </a:ln>
+        </p:spPr>
+      </p:sp>
+      <p:sp>
+        <p:nvSpPr>
+          <p:cNvPr id="40" name="Text 38"/>
+          <p:cNvSpPr txBox="1"/>
+          <p:nvPr/>
+        </p:nvSpPr>
+        <p:spPr>
+          <a:xfrm>
+            <a:off x="9281160" y="4983480"/>
+            <a:ext cx="2240280" cy="685800"/>
+          </a:xfrm>
+          <a:prstGeom prst="rect">
+            <a:avLst/>
+          </a:prstGeom>
+          <a:noFill/>
+          <a:ln/>
+        </p:spPr>
+        <p:txBody>
+          <a:bodyPr wrap="square" lIns="0" tIns="0" rIns="0" bIns="0" rtlCol="0" anchor="ctr"/>
+          <a:lstStyle/>
+          <a:p>
+            <a:pPr algn="ctr" indent="0" marL="0">
+              <a:buNone/>
+            </a:pPr>
+            <a:r>
+              <a:rPr lang="en-US" sz="1400" b="1" dirty="0">
+                <a:solidFill>
+                  <a:schemeClr val="tx1"/>
+                </a:solidFill>
+              </a:rPr>
+              <a:t>Operational readiness on arrival</a:t>
+            </a:r>
+            <a:endParaRPr lang="en-US" sz="1400" dirty="0"/>
+          </a:p>
+        </p:txBody>
+      </p:sp>
+      <p:sp>
+        <p:nvSpPr>
+          <p:cNvPr id="41" name="Arrow 1"/>
+          <p:cNvSpPr/>
+          <p:nvPr/>
+        </p:nvSpPr>
+        <p:spPr>
+          <a:xfrm>
+            <a:off x="3017520" y="5326380"/>
+            <a:ext cx="365760" cy="0"/>
+          </a:xfrm>
+          <a:prstGeom prst="line">
+            <a:avLst/>
+          </a:prstGeom>
+          <a:noFill/>
+          <a:ln w="15875">
+            <a:solidFill>
+              <a:srgbClr val="1A1A1A"/>
+            </a:solidFill>
+            <a:prstDash val="solid"/>
+            <a:tailEnd type="triangle"/>
+          </a:ln>
+        </p:spPr>
+      </p:sp>
+      <p:sp>
+        <p:nvSpPr>
+          <p:cNvPr id="42" name="Text 40"/>
+          <p:cNvSpPr txBox="1"/>
+          <p:nvPr/>
+        </p:nvSpPr>
+        <p:spPr>
+          <a:xfrm>
+            <a:off x="5852160" y="4983480"/>
+            <a:ext cx="457200" cy="685800"/>
+          </a:xfrm>
+          <a:prstGeom prst="rect">
+            <a:avLst/>
+          </a:prstGeom>
+          <a:noFill/>
+          <a:ln/>
+        </p:spPr>
+        <p:txBody>
+          <a:bodyPr wrap="square" lIns="0" tIns="0" rIns="0" bIns="0" rtlCol="0" anchor="ctr"/>
+          <a:lstStyle/>
+          <a:p>
+            <a:pPr algn="ctr" indent="0" marL="0">
+              <a:buNone/>
+            </a:pPr>
+            <a:r>
+              <a:rPr lang="en-US" sz="2400" b="1" dirty="0">
+                <a:solidFill>
+                  <a:schemeClr val="tx2"/>
+                </a:solidFill>
+              </a:rPr>
+              <a:t>+</a:t>
+            </a:r>
+            <a:endParaRPr lang="en-US" sz="2400" dirty="0"/>
+          </a:p>
+        </p:txBody>
+      </p:sp>
+      <p:sp>
+        <p:nvSpPr>
+          <p:cNvPr id="43" name="Arrow 3"/>
+          <p:cNvSpPr/>
+          <p:nvPr/>
+        </p:nvSpPr>
+        <p:spPr>
+          <a:xfrm>
+            <a:off x="8778240" y="5326380"/>
+            <a:ext cx="365760" cy="0"/>
+          </a:xfrm>
+          <a:prstGeom prst="line">
+            <a:avLst/>
+          </a:prstGeom>
+          <a:noFill/>
+          <a:ln w="15875">
+            <a:solidFill>
+              <a:srgbClr val="1A1A1A"/>
+            </a:solidFill>
+            <a:prstDash val="solid"/>
+            <a:tailEnd type="triangle"/>
+          </a:ln>
+        </p:spPr>
+      </p:sp>
+      <p:sp>
+        <p:nvSpPr>
+          <p:cNvPr id="44" name="Text 42"/>
+          <p:cNvSpPr txBox="1"/>
+          <p:nvPr/>
+        </p:nvSpPr>
+        <p:spPr>
+          <a:xfrm>
+            <a:off x="6309360" y="5733288"/>
+            <a:ext cx="5303520" cy="228600"/>
+          </a:xfrm>
+          <a:prstGeom prst="rect">
+            <a:avLst/>
+          </a:prstGeom>
+          <a:noFill/>
+          <a:ln/>
+        </p:spPr>
+        <p:txBody>
           <a:bodyPr wrap="square" lIns="0" tIns="0" rIns="0" bIns="0" rtlCol="0" anchor="t"/>
           <a:lstStyle/>
           <a:p>
@@ -14408,103 +15562,14 @@
               <a:buNone/>
             </a:pPr>
             <a:r>
-              <a:rPr lang="en-US" sz="1400" b="1" dirty="0">
+              <a:rPr lang="en-US" sz="1100" i="1" dirty="0">
                 <a:solidFill>
                   <a:schemeClr val="accent3"/>
                 </a:solidFill>
               </a:rPr>
-              <a:t>PLACEHOLDER: content by Niloufar</a:t>
-            </a:r>
-            <a:endParaRPr lang="en-US" sz="1400" dirty="0"/>
-          </a:p>
-          <a:p>
-            <a:pPr indent="0" marL="0">
-              <a:spcAft>
-                <a:spcPts val="600"/>
-              </a:spcAft>
-              <a:buNone/>
-            </a:pPr>
-            <a:r>
-              <a:rPr lang="en-US" sz="1400" i="1" dirty="0">
-                <a:solidFill>
-                  <a:schemeClr val="accent3"/>
-                </a:solidFill>
-              </a:rPr>
-              <a:t>Suggested points from the final report:</a:t>
-            </a:r>
-            <a:endParaRPr lang="en-US" sz="1400" dirty="0"/>
-          </a:p>
-          <a:p>
-            <a:pPr marL="342900" indent="-342900">
-              <a:spcAft>
-                <a:spcPts val="400"/>
-              </a:spcAft>
-              <a:buSzPct val="100000"/>
-              <a:buChar char="•"/>
-            </a:pPr>
-            <a:r>
-              <a:rPr lang="en-US" sz="1600" dirty="0">
-                <a:solidFill>
-                  <a:schemeClr val="tx1"/>
-                </a:solidFill>
-              </a:rPr>
-              <a:t>Spaceflight data on leg muscle size are scarce, and the groups measured are small</a:t>
-            </a:r>
-            <a:endParaRPr lang="en-US" sz="1400" dirty="0"/>
-          </a:p>
-          <a:p>
-            <a:pPr marL="342900" indent="-342900">
-              <a:spcAft>
-                <a:spcPts val="400"/>
-              </a:spcAft>
-              <a:buSzPct val="100000"/>
-              <a:buChar char="•"/>
-            </a:pPr>
-            <a:r>
-              <a:rPr lang="en-US" sz="1600" dirty="0">
-                <a:solidFill>
-                  <a:schemeClr val="tx1"/>
-                </a:solidFill>
-              </a:rPr>
-              <a:t>Bed rest is the established ground model: healthy volunteers lie in bed, usually tilted 6° head-down so that body fluids shift towards the head as in orbit</a:t>
-            </a:r>
-            <a:endParaRPr lang="en-US" sz="1400" dirty="0"/>
-          </a:p>
-          <a:p>
-            <a:pPr marL="342900" indent="-342900">
-              <a:spcAft>
-                <a:spcPts val="400"/>
-              </a:spcAft>
-              <a:buSzPct val="100000"/>
-              <a:buChar char="•"/>
-            </a:pPr>
-            <a:r>
-              <a:rPr lang="en-US" sz="1600" dirty="0">
-                <a:solidFill>
-                  <a:schemeClr val="tx1"/>
-                </a:solidFill>
-              </a:rPr>
-              <a:t>Three decades of campaigns at NASA, MEDES (Toulouse), Charité (Berlin), DLR (Cologne) and elsewhere</a:t>
-            </a:r>
-            <a:endParaRPr lang="en-US" sz="1400" dirty="0"/>
-          </a:p>
-          <a:p>
-            <a:pPr marL="342900" indent="-342900">
-              <a:spcAft>
-                <a:spcPts val="400"/>
-              </a:spcAft>
-              <a:buSzPct val="100000"/>
-              <a:buChar char="•"/>
-            </a:pPr>
-            <a:r>
-              <a:rPr lang="en-US" sz="1600" dirty="0">
-                <a:solidFill>
-                  <a:schemeClr val="tx1"/>
-                </a:solidFill>
-              </a:rPr>
-              <a:t>Bed rest imitates weightlessness but is not the same</a:t>
-            </a:r>
-            <a:endParaRPr lang="en-US" sz="1400" dirty="0"/>
+              <a:t>Dashed: future use, which needs validation with spaceflight data</a:t>
+            </a:r>
+            <a:endParaRPr lang="en-US" sz="1100" dirty="0"/>
           </a:p>
         </p:txBody>
       </p:sp>

</xml_diff>

<commit_message>
Slide 4: Moon vs Mars mission graphic, drop dataset figures
Co-Authored-By: Claude Opus 5.5 (1M context) <noreply@anthropic.com>
Claude-Session: https://claude.ai/code/session_01JZtuYERhuCe7nB9VYHwcfv
</commit_message>
<xml_diff>
--- a/presentation/bed-rest-to-mars-talk.pptx
+++ b/presentation/bed-rest-to-mars-talk.pptx
@@ -126,13 +126,13 @@
   <p:extLst>
     <p:ext uri="{521415D9-36F7-43E2-AB2F-B90AF26B5E84}">
       <p14:sectionLst xmlns:p14="http://schemas.microsoft.com/office/powerpoint/2010/main">
-        <p14:section name="Opening" id="{f197ad8b-59a4-2d74-0164-f68eb5d5641f}">
+        <p14:section name="Opening" id="{a13dd9fb-77dc-a407-e923-29c6c2779835}">
           <p14:sldIdLst>
             <p14:sldId id="256"/>
             <p14:sldId id="257"/>
           </p14:sldIdLst>
         </p14:section>
-        <p14:section name="Part 1" id="{9852aba5-79ce-0ab4-09cf-7375582b52e2}">
+        <p14:section name="Part 1" id="{05f7214c-cbb2-b196-082b-98bab2e6a788}">
           <p14:sldIdLst>
             <p14:sldId id="258"/>
             <p14:sldId id="259"/>
@@ -143,7 +143,7 @@
             <p14:sldId id="264"/>
           </p14:sldIdLst>
         </p14:section>
-        <p14:section name="Part 2" id="{a5c562b9-2ff9-9437-11bc-e3b4d8bf5c2f}">
+        <p14:section name="Part 2" id="{e1e4b4c3-a5f8-11d9-ae09-778c42cd3edf}">
           <p14:sldIdLst>
             <p14:sldId id="265"/>
             <p14:sldId id="266"/>
@@ -154,7 +154,7 @@
             <p14:sldId id="271"/>
           </p14:sldIdLst>
         </p14:section>
-        <p14:section name="Backup" id="{18098c89-f719-549a-3c04-25d183574bce}">
+        <p14:section name="Backup" id="{81441cba-5157-5af9-30a2-7f2bb27203fd}">
           <p14:sldIdLst>
             <p14:sldId id="272"/>
             <p14:sldId id="273"/>
@@ -162,13 +162,13 @@
             <p14:sldId id="275"/>
           </p14:sldIdLst>
         </p14:section>
-        <p14:section name="Backup" id="{44cd8629-4e03-fca8-c161-284732192d26}">
+        <p14:section name="Backup" id="{d8fb7918-f64b-454c-3d67-667e1e29d9fc}">
           <p14:sldIdLst/>
         </p14:section>
-        <p14:section name="Backup" id="{d9ba4ffa-8801-04db-50cb-f37c52e6c1bf}">
+        <p14:section name="Backup" id="{3c1afbc2-00b7-41ee-ede8-82840da9d498}">
           <p14:sldIdLst/>
         </p14:section>
-        <p14:section name="Backup" id="{283d6083-0dfe-a83a-d9f4-c050a09919ff}">
+        <p14:section name="Backup" id="{cc8adf65-e778-fbf8-ee07-6d987e08c947}">
           <p14:sldIdLst/>
         </p14:section>
       </p14:sectionLst>
@@ -3791,8 +3791,8 @@
             <a:r>
               <a:rPr lang="en-US" dirty="0"/>
               <a:t>Part 1 (Niloufar), about forty-five seconds.
-Direct spaceflight data on muscle are scarce: in our dataset only 14 of 742 rows come from spaceflight. So we use head-down bed rest, the standard ground analogue: volunteers lie tilted six degrees head-down, and their legs carry no weight, under controlled conditions and for set durations. Bed rest is not the same as spaceflight, but it is a sound starting point to build and test prediction models.
-Mars in our title stands for the long-term application. The chart puts the durations side by side. Our bed-rest data reach day 119. A Moon mission lasted up to 12 days. An ISS stay and a Mars transit both last about six months, but from the ISS a crew can return within hours, and on landing they go straight into medical care. A Mars crew cannot come back early in an emergency, and after months in weightlessness they must leave the spacecraft and work on the surface.
+Direct spaceflight data on muscle are scarce, so we use head-down bed rest, the standard ground analogue: volunteers lie tilted six degrees head-down and their legs carry no weight, under controlled conditions. Bed rest is not the same as spaceflight, but it is a sound starting point to build and test prediction models.
+Mars in our title stands for the long-term application. The panel compares the two missions on one time scale. A Moon mission lasted about twelve days, and the crew could be home in three. A Mars mission takes about two and a half years: six months to get there, about five hundred days on the surface, six months back. There is no early return in an emergency, and after six months in weightlessness the crew must leave the spacecraft and work on the surface. Mission figures: Apollo 17, and NASA's Mars Design Reference Architecture 5.0.
 The bottom row is the idea: atrophy prediction, together with strength and power testing, could one day help keep the crew ready for work on arrival. The dashed steps are future use, and applying the model on a real mission needs validation with spaceflight data first.</a:t>
             </a:r>
             <a:endParaRPr lang="en-US" dirty="0"/>
@@ -14412,7 +14412,7 @@
                   <a:schemeClr val="tx1"/>
                 </a:solidFill>
               </a:rPr>
-              <a:t>Spaceflight data on muscle are scarce: 14 of 742 rows in our dataset</a:t>
+              <a:t>Direct spaceflight data on muscle are scarce</a:t>
             </a:r>
             <a:endParaRPr lang="en-US" sz="1700" dirty="0"/>
           </a:p>
@@ -14430,7 +14430,7 @@
                   <a:schemeClr val="tx1"/>
                 </a:solidFill>
               </a:rPr>
-              <a:t>Head-down bed rest unloads the legs under controlled conditions, for set durations</a:t>
+              <a:t>Head-down bed rest is the established ground analogue: it unloads the legs under controlled conditions</a:t>
             </a:r>
             <a:endParaRPr lang="en-US" sz="1700" dirty="0"/>
           </a:p>
@@ -14486,7 +14486,7 @@
                   <a:schemeClr val="tx1"/>
                 </a:solidFill>
               </a:rPr>
-              <a:t>Transit of about 6 months, far longer than a Moon mission</a:t>
+              <a:t>A Mars mission lasts years, not days: about 6 months of transit each way</a:t>
             </a:r>
             <a:endParaRPr lang="en-US" sz="1700" dirty="0"/>
           </a:p>
@@ -14504,7 +14504,7 @@
                   <a:schemeClr val="tx1"/>
                 </a:solidFill>
               </a:rPr>
-              <a:t>No early return in an emergency: after months in weightlessness, the crew must leave the spacecraft and work on the surface</a:t>
+              <a:t>No early return in an emergency: the crew depends on its own fitness</a:t>
             </a:r>
             <a:endParaRPr lang="en-US" sz="1700" dirty="0"/>
           </a:p>
@@ -14522,7 +14522,7 @@
                   <a:schemeClr val="tx1"/>
                 </a:solidFill>
               </a:rPr>
-              <a:t>Use on such a mission requires validation with spaceflight data</a:t>
+              <a:t>After months in weightlessness, the crew must leave the spacecraft and work on the surface</a:t>
             </a:r>
             <a:endParaRPr lang="en-US" sz="1700" dirty="0"/>
           </a:p>
@@ -14530,7 +14530,7 @@
       </p:sp>
       <p:sp>
         <p:nvSpPr>
-          <p:cNvPr id="12" name="Duration panel"/>
+          <p:cNvPr id="12" name="Mission panel"/>
           <p:cNvSpPr/>
           <p:nvPr/>
         </p:nvSpPr>
@@ -14578,7 +14578,7 @@
                   <a:schemeClr val="tx2"/>
                 </a:solidFill>
               </a:rPr>
-              <a:t>Time without Earth's gravity (days)</a:t>
+              <a:t>Moon mission vs Mars mission</a:t>
             </a:r>
             <a:endParaRPr lang="en-US" sz="1400" dirty="0"/>
           </a:p>
@@ -14586,66 +14586,16 @@
       </p:sp>
       <p:sp>
         <p:nvSpPr>
-          <p:cNvPr id="14" name="Text 12"/>
-          <p:cNvSpPr txBox="1"/>
-          <p:nvPr/>
-        </p:nvSpPr>
-        <p:spPr>
-          <a:xfrm>
-            <a:off x="6675120" y="1737360"/>
-            <a:ext cx="1691640" cy="502920"/>
-          </a:xfrm>
-          <a:prstGeom prst="rect">
-            <a:avLst/>
-          </a:prstGeom>
-          <a:noFill/>
-          <a:ln/>
-        </p:spPr>
-        <p:txBody>
-          <a:bodyPr wrap="square" lIns="0" tIns="0" rIns="0" bIns="0" rtlCol="0" anchor="t"/>
-          <a:lstStyle/>
-          <a:p>
-            <a:pPr indent="0" marL="0">
-              <a:buNone/>
-            </a:pPr>
-            <a:r>
-              <a:rPr lang="en-US" sz="1300" b="1" dirty="0">
-                <a:solidFill>
-                  <a:schemeClr val="tx1"/>
-                </a:solidFill>
-              </a:rPr>
-              <a:t>Bed-rest data</a:t>
-            </a:r>
-            <a:endParaRPr lang="en-US" sz="1300" dirty="0"/>
-          </a:p>
-          <a:p>
-            <a:pPr indent="0" marL="0">
-              <a:buNone/>
-            </a:pPr>
-            <a:r>
-              <a:rPr lang="en-US" sz="1050" i="1" dirty="0">
-                <a:solidFill>
-                  <a:schemeClr val="accent3"/>
-                </a:solidFill>
-              </a:rPr>
-              <a:t>our data: day 5 to 119</a:t>
-            </a:r>
-            <a:endParaRPr lang="en-US" sz="1300" dirty="0"/>
-          </a:p>
-        </p:txBody>
-      </p:sp>
-      <p:sp>
-        <p:nvSpPr>
-          <p:cNvPr id="15" name="Bed-rest data bar"/>
-          <p:cNvSpPr/>
-          <p:nvPr/>
-        </p:nvSpPr>
-        <p:spPr>
-          <a:xfrm>
-            <a:off x="8665083" y="1847088"/>
-            <a:ext cx="1589684" cy="274320"/>
-          </a:xfrm>
-          <a:prstGeom prst="rect">
+          <p:cNvPr id="14" name="Earth"/>
+          <p:cNvSpPr/>
+          <p:nvPr/>
+        </p:nvSpPr>
+        <p:spPr>
+          <a:xfrm>
+            <a:off x="6720840" y="1874520"/>
+            <a:ext cx="457200" cy="457200"/>
+          </a:xfrm>
+          <a:prstGeom prst="ellipse">
             <a:avLst/>
           </a:prstGeom>
           <a:solidFill>
@@ -14656,36 +14606,14 @@
       </p:sp>
       <p:sp>
         <p:nvSpPr>
-          <p:cNvPr id="16" name="Gap to 180 days"/>
-          <p:cNvSpPr/>
-          <p:nvPr/>
-        </p:nvSpPr>
-        <p:spPr>
-          <a:xfrm>
-            <a:off x="10254767" y="1847088"/>
-            <a:ext cx="850621" cy="274320"/>
-          </a:xfrm>
-          <a:prstGeom prst="rect">
-            <a:avLst/>
-          </a:prstGeom>
-          <a:ln w="12700">
-            <a:solidFill>
-              <a:srgbClr val="1F3A5F"/>
-            </a:solidFill>
-            <a:prstDash val="dash"/>
-          </a:ln>
-        </p:spPr>
-      </p:sp>
-      <p:sp>
-        <p:nvSpPr>
-          <p:cNvPr id="17" name="Text 15"/>
+          <p:cNvPr id="15" name="Text 13"/>
           <p:cNvSpPr txBox="1"/>
           <p:nvPr/>
         </p:nvSpPr>
         <p:spPr>
           <a:xfrm>
-            <a:off x="10254767" y="1847088"/>
-            <a:ext cx="850621" cy="274320"/>
+            <a:off x="6400800" y="2404872"/>
+            <a:ext cx="1097280" cy="228600"/>
           </a:xfrm>
           <a:prstGeom prst="rect">
             <a:avLst/>
@@ -14694,86 +14622,36 @@
           <a:ln/>
         </p:spPr>
         <p:txBody>
-          <a:bodyPr wrap="square" lIns="0" tIns="0" rIns="0" bIns="0" rtlCol="0" anchor="ctr"/>
+          <a:bodyPr wrap="square" lIns="0" tIns="0" rIns="0" bIns="0" rtlCol="0" anchor="t"/>
           <a:lstStyle/>
           <a:p>
             <a:pPr algn="ctr" indent="0" marL="0">
               <a:buNone/>
             </a:pPr>
             <a:r>
-              <a:rPr lang="en-US" sz="1000" i="1" dirty="0">
-                <a:solidFill>
-                  <a:schemeClr val="tx2"/>
-                </a:solidFill>
-              </a:rPr>
-              <a:t>not covered</a:t>
-            </a:r>
-            <a:endParaRPr lang="en-US" sz="1000" dirty="0"/>
-          </a:p>
-        </p:txBody>
-      </p:sp>
-      <p:sp>
-        <p:nvSpPr>
-          <p:cNvPr id="18" name="Text 16"/>
-          <p:cNvSpPr txBox="1"/>
-          <p:nvPr/>
-        </p:nvSpPr>
-        <p:spPr>
-          <a:xfrm>
-            <a:off x="6675120" y="2359152"/>
-            <a:ext cx="1691640" cy="502920"/>
-          </a:xfrm>
-          <a:prstGeom prst="rect">
-            <a:avLst/>
-          </a:prstGeom>
-          <a:noFill/>
-          <a:ln/>
-        </p:spPr>
-        <p:txBody>
-          <a:bodyPr wrap="square" lIns="0" tIns="0" rIns="0" bIns="0" rtlCol="0" anchor="t"/>
-          <a:lstStyle/>
-          <a:p>
-            <a:pPr indent="0" marL="0">
-              <a:buNone/>
-            </a:pPr>
-            <a:r>
-              <a:rPr lang="en-US" sz="1300" b="1" dirty="0">
+              <a:rPr lang="en-US" sz="1100" b="1" dirty="0">
                 <a:solidFill>
                   <a:schemeClr val="tx1"/>
                 </a:solidFill>
               </a:rPr>
-              <a:t>Moon mission</a:t>
-            </a:r>
-            <a:endParaRPr lang="en-US" sz="1300" dirty="0"/>
-          </a:p>
-          <a:p>
-            <a:pPr indent="0" marL="0">
-              <a:buNone/>
-            </a:pPr>
-            <a:r>
-              <a:rPr lang="en-US" sz="1050" i="1" dirty="0">
-                <a:solidFill>
-                  <a:schemeClr val="accent3"/>
-                </a:solidFill>
-              </a:rPr>
-              <a:t>Apollo: up to 12 days</a:t>
-            </a:r>
-            <a:endParaRPr lang="en-US" sz="1300" dirty="0"/>
-          </a:p>
-        </p:txBody>
-      </p:sp>
-      <p:sp>
-        <p:nvSpPr>
-          <p:cNvPr id="19" name="Moon mission bar"/>
-          <p:cNvSpPr/>
-          <p:nvPr/>
-        </p:nvSpPr>
-        <p:spPr>
-          <a:xfrm>
-            <a:off x="8595360" y="2468880"/>
-            <a:ext cx="167335" cy="274320"/>
-          </a:xfrm>
-          <a:prstGeom prst="rect">
+              <a:t>Earth</a:t>
+            </a:r>
+            <a:endParaRPr lang="en-US" sz="1100" dirty="0"/>
+          </a:p>
+        </p:txBody>
+      </p:sp>
+      <p:sp>
+        <p:nvSpPr>
+          <p:cNvPr id="16" name="Moon"/>
+          <p:cNvSpPr/>
+          <p:nvPr/>
+        </p:nvSpPr>
+        <p:spPr>
+          <a:xfrm>
+            <a:off x="7900416" y="2002536"/>
+            <a:ext cx="201168" cy="201168"/>
+          </a:xfrm>
+          <a:prstGeom prst="ellipse">
             <a:avLst/>
           </a:prstGeom>
           <a:solidFill>
@@ -14784,14 +14662,14 @@
       </p:sp>
       <p:sp>
         <p:nvSpPr>
-          <p:cNvPr id="20" name="Text 18"/>
+          <p:cNvPr id="17" name="Text 15"/>
           <p:cNvSpPr txBox="1"/>
           <p:nvPr/>
         </p:nvSpPr>
         <p:spPr>
           <a:xfrm>
-            <a:off x="6675120" y="2980944"/>
-            <a:ext cx="1691640" cy="502920"/>
+            <a:off x="7452360" y="2404872"/>
+            <a:ext cx="1097280" cy="228600"/>
           </a:xfrm>
           <a:prstGeom prst="rect">
             <a:avLst/>
@@ -14803,117 +14681,33 @@
           <a:bodyPr wrap="square" lIns="0" tIns="0" rIns="0" bIns="0" rtlCol="0" anchor="t"/>
           <a:lstStyle/>
           <a:p>
-            <a:pPr indent="0" marL="0">
+            <a:pPr algn="ctr" indent="0" marL="0">
               <a:buNone/>
             </a:pPr>
             <a:r>
-              <a:rPr lang="en-US" sz="1300" b="1" dirty="0">
+              <a:rPr lang="en-US" sz="1100" b="1" dirty="0">
                 <a:solidFill>
                   <a:schemeClr val="tx1"/>
                 </a:solidFill>
               </a:rPr>
-              <a:t>ISS stay</a:t>
-            </a:r>
-            <a:endParaRPr lang="en-US" sz="1300" dirty="0"/>
-          </a:p>
-          <a:p>
-            <a:pPr indent="0" marL="0">
-              <a:buNone/>
-            </a:pPr>
-            <a:r>
-              <a:rPr lang="en-US" sz="1050" i="1" dirty="0">
-                <a:solidFill>
-                  <a:schemeClr val="accent3"/>
-                </a:solidFill>
-              </a:rPr>
-              <a:t>return within hours</a:t>
-            </a:r>
-            <a:endParaRPr lang="en-US" sz="1300" dirty="0"/>
-          </a:p>
-        </p:txBody>
-      </p:sp>
-      <p:sp>
-        <p:nvSpPr>
-          <p:cNvPr id="21" name="ISS stay bar"/>
-          <p:cNvSpPr/>
-          <p:nvPr/>
-        </p:nvSpPr>
-        <p:spPr>
-          <a:xfrm>
-            <a:off x="8595360" y="3090672"/>
-            <a:ext cx="2510028" cy="274320"/>
-          </a:xfrm>
-          <a:prstGeom prst="rect">
-            <a:avLst/>
-          </a:prstGeom>
-          <a:solidFill>
-            <a:srgbClr val="A7AEB8"/>
-          </a:solidFill>
-          <a:ln/>
-        </p:spPr>
-      </p:sp>
-      <p:sp>
-        <p:nvSpPr>
-          <p:cNvPr id="22" name="Text 20"/>
-          <p:cNvSpPr txBox="1"/>
-          <p:nvPr/>
-        </p:nvSpPr>
-        <p:spPr>
-          <a:xfrm>
-            <a:off x="6675120" y="3602736"/>
-            <a:ext cx="1691640" cy="502920"/>
-          </a:xfrm>
-          <a:prstGeom prst="rect">
-            <a:avLst/>
-          </a:prstGeom>
-          <a:noFill/>
-          <a:ln/>
-        </p:spPr>
-        <p:txBody>
-          <a:bodyPr wrap="square" lIns="0" tIns="0" rIns="0" bIns="0" rtlCol="0" anchor="t"/>
-          <a:lstStyle/>
-          <a:p>
-            <a:pPr indent="0" marL="0">
-              <a:buNone/>
-            </a:pPr>
-            <a:r>
-              <a:rPr lang="en-US" sz="1300" b="1" dirty="0">
-                <a:solidFill>
-                  <a:schemeClr val="tx1"/>
-                </a:solidFill>
-              </a:rPr>
-              <a:t>Mars transit</a:t>
-            </a:r>
-            <a:endParaRPr lang="en-US" sz="1300" dirty="0"/>
-          </a:p>
-          <a:p>
-            <a:pPr indent="0" marL="0">
-              <a:buNone/>
-            </a:pPr>
-            <a:r>
-              <a:rPr lang="en-US" sz="1050" i="1" dirty="0">
-                <a:solidFill>
-                  <a:schemeClr val="accent3"/>
-                </a:solidFill>
-              </a:rPr>
-              <a:t>no early return</a:t>
-            </a:r>
-            <a:endParaRPr lang="en-US" sz="1300" dirty="0"/>
-          </a:p>
-        </p:txBody>
-      </p:sp>
-      <p:sp>
-        <p:nvSpPr>
-          <p:cNvPr id="23" name="Mars transit bar"/>
-          <p:cNvSpPr/>
-          <p:nvPr/>
-        </p:nvSpPr>
-        <p:spPr>
-          <a:xfrm>
-            <a:off x="8595360" y="3712464"/>
-            <a:ext cx="2510028" cy="274320"/>
-          </a:xfrm>
-          <a:prstGeom prst="rect">
+              <a:t>Moon</a:t>
+            </a:r>
+            <a:endParaRPr lang="en-US" sz="1100" dirty="0"/>
+          </a:p>
+        </p:txBody>
+      </p:sp>
+      <p:sp>
+        <p:nvSpPr>
+          <p:cNvPr id="18" name="Mars"/>
+          <p:cNvSpPr/>
+          <p:nvPr/>
+        </p:nvSpPr>
+        <p:spPr>
+          <a:xfrm>
+            <a:off x="10972800" y="1920240"/>
+            <a:ext cx="365760" cy="365760"/>
+          </a:xfrm>
+          <a:prstGeom prst="ellipse">
             <a:avLst/>
           </a:prstGeom>
           <a:solidFill>
@@ -14924,14 +14718,571 @@
       </p:sp>
       <p:sp>
         <p:nvSpPr>
-          <p:cNvPr id="24" name="Day axis"/>
-          <p:cNvSpPr/>
-          <p:nvPr/>
-        </p:nvSpPr>
-        <p:spPr>
-          <a:xfrm>
-            <a:off x="8595360" y="4242816"/>
-            <a:ext cx="2788920" cy="0"/>
+          <p:cNvPr id="19" name="Text 17"/>
+          <p:cNvSpPr txBox="1"/>
+          <p:nvPr/>
+        </p:nvSpPr>
+        <p:spPr>
+          <a:xfrm>
+            <a:off x="10607040" y="2404872"/>
+            <a:ext cx="1097280" cy="228600"/>
+          </a:xfrm>
+          <a:prstGeom prst="rect">
+            <a:avLst/>
+          </a:prstGeom>
+          <a:noFill/>
+          <a:ln/>
+        </p:spPr>
+        <p:txBody>
+          <a:bodyPr wrap="square" lIns="0" tIns="0" rIns="0" bIns="0" rtlCol="0" anchor="t"/>
+          <a:lstStyle/>
+          <a:p>
+            <a:pPr algn="ctr" indent="0" marL="0">
+              <a:buNone/>
+            </a:pPr>
+            <a:r>
+              <a:rPr lang="en-US" sz="1100" b="1" dirty="0">
+                <a:solidFill>
+                  <a:schemeClr val="tx1"/>
+                </a:solidFill>
+              </a:rPr>
+              <a:t>Mars</a:t>
+            </a:r>
+            <a:endParaRPr lang="en-US" sz="1100" dirty="0"/>
+          </a:p>
+        </p:txBody>
+      </p:sp>
+      <p:sp>
+        <p:nvSpPr>
+          <p:cNvPr id="20" name="Route to Moon"/>
+          <p:cNvSpPr/>
+          <p:nvPr/>
+        </p:nvSpPr>
+        <p:spPr>
+          <a:xfrm>
+            <a:off x="7205472" y="2103120"/>
+            <a:ext cx="676656" cy="0"/>
+          </a:xfrm>
+          <a:prstGeom prst="line">
+            <a:avLst/>
+          </a:prstGeom>
+          <a:noFill/>
+          <a:ln w="12700">
+            <a:solidFill>
+              <a:srgbClr val="6B7280"/>
+            </a:solidFill>
+            <a:prstDash val="dash"/>
+            <a:tailEnd type="triangle"/>
+          </a:ln>
+        </p:spPr>
+      </p:sp>
+      <p:sp>
+        <p:nvSpPr>
+          <p:cNvPr id="21" name="Text 19"/>
+          <p:cNvSpPr txBox="1"/>
+          <p:nvPr/>
+        </p:nvSpPr>
+        <p:spPr>
+          <a:xfrm>
+            <a:off x="7205472" y="1810512"/>
+            <a:ext cx="676656" cy="228600"/>
+          </a:xfrm>
+          <a:prstGeom prst="rect">
+            <a:avLst/>
+          </a:prstGeom>
+          <a:noFill/>
+          <a:ln/>
+        </p:spPr>
+        <p:txBody>
+          <a:bodyPr wrap="square" lIns="0" tIns="0" rIns="0" bIns="0" rtlCol="0" anchor="t"/>
+          <a:lstStyle/>
+          <a:p>
+            <a:pPr algn="ctr" indent="0" marL="0">
+              <a:buNone/>
+            </a:pPr>
+            <a:r>
+              <a:rPr lang="en-US" sz="1100" i="1" dirty="0">
+                <a:solidFill>
+                  <a:schemeClr val="tx2"/>
+                </a:solidFill>
+              </a:rPr>
+              <a:t>3 days</a:t>
+            </a:r>
+            <a:endParaRPr lang="en-US" sz="1100" dirty="0"/>
+          </a:p>
+        </p:txBody>
+      </p:sp>
+      <p:sp>
+        <p:nvSpPr>
+          <p:cNvPr id="22" name="Route to Mars"/>
+          <p:cNvSpPr/>
+          <p:nvPr/>
+        </p:nvSpPr>
+        <p:spPr>
+          <a:xfrm>
+            <a:off x="8183880" y="2103120"/>
+            <a:ext cx="2770632" cy="0"/>
+          </a:xfrm>
+          <a:prstGeom prst="line">
+            <a:avLst/>
+          </a:prstGeom>
+          <a:noFill/>
+          <a:ln w="12700">
+            <a:solidFill>
+              <a:srgbClr val="6B7280"/>
+            </a:solidFill>
+            <a:prstDash val="dash"/>
+            <a:tailEnd type="triangle"/>
+          </a:ln>
+        </p:spPr>
+      </p:sp>
+      <p:sp>
+        <p:nvSpPr>
+          <p:cNvPr id="23" name="Text 21"/>
+          <p:cNvSpPr txBox="1"/>
+          <p:nvPr/>
+        </p:nvSpPr>
+        <p:spPr>
+          <a:xfrm>
+            <a:off x="8183880" y="1810512"/>
+            <a:ext cx="2770632" cy="228600"/>
+          </a:xfrm>
+          <a:prstGeom prst="rect">
+            <a:avLst/>
+          </a:prstGeom>
+          <a:noFill/>
+          <a:ln/>
+        </p:spPr>
+        <p:txBody>
+          <a:bodyPr wrap="square" lIns="0" tIns="0" rIns="0" bIns="0" rtlCol="0" anchor="t"/>
+          <a:lstStyle/>
+          <a:p>
+            <a:pPr algn="ctr" indent="0" marL="0">
+              <a:buNone/>
+            </a:pPr>
+            <a:r>
+              <a:rPr lang="en-US" sz="1100" i="1" dirty="0">
+                <a:solidFill>
+                  <a:schemeClr val="tx2"/>
+                </a:solidFill>
+              </a:rPr>
+              <a:t>about 6 months, one way</a:t>
+            </a:r>
+            <a:endParaRPr lang="en-US" sz="1100" dirty="0"/>
+          </a:p>
+        </p:txBody>
+      </p:sp>
+      <p:sp>
+        <p:nvSpPr>
+          <p:cNvPr id="24" name="Text 22"/>
+          <p:cNvSpPr txBox="1"/>
+          <p:nvPr/>
+        </p:nvSpPr>
+        <p:spPr>
+          <a:xfrm>
+            <a:off x="6675120" y="2788920"/>
+            <a:ext cx="1691640" cy="502920"/>
+          </a:xfrm>
+          <a:prstGeom prst="rect">
+            <a:avLst/>
+          </a:prstGeom>
+          <a:noFill/>
+          <a:ln/>
+        </p:spPr>
+        <p:txBody>
+          <a:bodyPr wrap="square" lIns="0" tIns="0" rIns="0" bIns="0" rtlCol="0" anchor="t"/>
+          <a:lstStyle/>
+          <a:p>
+            <a:pPr indent="0" marL="0">
+              <a:buNone/>
+            </a:pPr>
+            <a:r>
+              <a:rPr lang="en-US" sz="1300" b="1" dirty="0">
+                <a:solidFill>
+                  <a:schemeClr val="tx1"/>
+                </a:solidFill>
+              </a:rPr>
+              <a:t>Moon mission</a:t>
+            </a:r>
+            <a:endParaRPr lang="en-US" sz="1300" dirty="0"/>
+          </a:p>
+          <a:p>
+            <a:pPr indent="0" marL="0">
+              <a:buNone/>
+            </a:pPr>
+            <a:r>
+              <a:rPr lang="en-US" sz="1050" i="1" dirty="0">
+                <a:solidFill>
+                  <a:schemeClr val="accent3"/>
+                </a:solidFill>
+              </a:rPr>
+              <a:t>about 12 days</a:t>
+            </a:r>
+            <a:endParaRPr lang="en-US" sz="1300" dirty="0"/>
+          </a:p>
+        </p:txBody>
+      </p:sp>
+      <p:sp>
+        <p:nvSpPr>
+          <p:cNvPr id="25" name="Moon mission bar"/>
+          <p:cNvSpPr/>
+          <p:nvPr/>
+        </p:nvSpPr>
+        <p:spPr>
+          <a:xfrm>
+            <a:off x="8229600" y="2880360"/>
+            <a:ext cx="42672" cy="292608"/>
+          </a:xfrm>
+          <a:prstGeom prst="rect">
+            <a:avLst/>
+          </a:prstGeom>
+          <a:solidFill>
+            <a:srgbClr val="6B7280"/>
+          </a:solidFill>
+          <a:ln/>
+        </p:spPr>
+      </p:sp>
+      <p:sp>
+        <p:nvSpPr>
+          <p:cNvPr id="26" name="Text 24"/>
+          <p:cNvSpPr txBox="1"/>
+          <p:nvPr/>
+        </p:nvSpPr>
+        <p:spPr>
+          <a:xfrm>
+            <a:off x="8327136" y="2880360"/>
+            <a:ext cx="1828800" cy="292608"/>
+          </a:xfrm>
+          <a:prstGeom prst="rect">
+            <a:avLst/>
+          </a:prstGeom>
+          <a:noFill/>
+          <a:ln/>
+        </p:spPr>
+        <p:txBody>
+          <a:bodyPr wrap="square" lIns="0" tIns="0" rIns="0" bIns="0" rtlCol="0" anchor="ctr"/>
+          <a:lstStyle/>
+          <a:p>
+            <a:pPr indent="0" marL="0">
+              <a:buNone/>
+            </a:pPr>
+            <a:r>
+              <a:rPr lang="en-US" sz="1050" i="1" dirty="0">
+                <a:solidFill>
+                  <a:schemeClr val="accent3"/>
+                </a:solidFill>
+              </a:rPr>
+              <a:t>◄ the whole mission</a:t>
+            </a:r>
+            <a:endParaRPr lang="en-US" sz="1050" dirty="0"/>
+          </a:p>
+        </p:txBody>
+      </p:sp>
+      <p:sp>
+        <p:nvSpPr>
+          <p:cNvPr id="27" name="Text 25"/>
+          <p:cNvSpPr txBox="1"/>
+          <p:nvPr/>
+        </p:nvSpPr>
+        <p:spPr>
+          <a:xfrm>
+            <a:off x="6675120" y="3474720"/>
+            <a:ext cx="1691640" cy="502920"/>
+          </a:xfrm>
+          <a:prstGeom prst="rect">
+            <a:avLst/>
+          </a:prstGeom>
+          <a:noFill/>
+          <a:ln/>
+        </p:spPr>
+        <p:txBody>
+          <a:bodyPr wrap="square" lIns="0" tIns="0" rIns="0" bIns="0" rtlCol="0" anchor="t"/>
+          <a:lstStyle/>
+          <a:p>
+            <a:pPr indent="0" marL="0">
+              <a:buNone/>
+            </a:pPr>
+            <a:r>
+              <a:rPr lang="en-US" sz="1300" b="1" dirty="0">
+                <a:solidFill>
+                  <a:schemeClr val="tx1"/>
+                </a:solidFill>
+              </a:rPr>
+              <a:t>Mars mission</a:t>
+            </a:r>
+            <a:endParaRPr lang="en-US" sz="1300" dirty="0"/>
+          </a:p>
+          <a:p>
+            <a:pPr indent="0" marL="0">
+              <a:buNone/>
+            </a:pPr>
+            <a:r>
+              <a:rPr lang="en-US" sz="1050" i="1" dirty="0">
+                <a:solidFill>
+                  <a:schemeClr val="accent3"/>
+                </a:solidFill>
+              </a:rPr>
+              <a:t>about 2.5 years</a:t>
+            </a:r>
+            <a:endParaRPr lang="en-US" sz="1300" dirty="0"/>
+          </a:p>
+        </p:txBody>
+      </p:sp>
+      <p:sp>
+        <p:nvSpPr>
+          <p:cNvPr id="28" name="Mars to Mars"/>
+          <p:cNvSpPr/>
+          <p:nvPr/>
+        </p:nvSpPr>
+        <p:spPr>
+          <a:xfrm>
+            <a:off x="8229600" y="3566160"/>
+            <a:ext cx="640080" cy="292608"/>
+          </a:xfrm>
+          <a:prstGeom prst="rect">
+            <a:avLst/>
+          </a:prstGeom>
+          <a:solidFill>
+            <a:srgbClr val="A23B2A"/>
+          </a:solidFill>
+          <a:ln w="12700">
+            <a:solidFill>
+              <a:srgbClr val="FFFFFF"/>
+            </a:solidFill>
+            <a:prstDash val="solid"/>
+          </a:ln>
+        </p:spPr>
+      </p:sp>
+      <p:sp>
+        <p:nvSpPr>
+          <p:cNvPr id="29" name="Text 27"/>
+          <p:cNvSpPr txBox="1"/>
+          <p:nvPr/>
+        </p:nvSpPr>
+        <p:spPr>
+          <a:xfrm>
+            <a:off x="8229600" y="3566160"/>
+            <a:ext cx="640080" cy="292608"/>
+          </a:xfrm>
+          <a:prstGeom prst="rect">
+            <a:avLst/>
+          </a:prstGeom>
+          <a:noFill/>
+          <a:ln/>
+        </p:spPr>
+        <p:txBody>
+          <a:bodyPr wrap="square" lIns="0" tIns="0" rIns="0" bIns="0" rtlCol="0" anchor="ctr"/>
+          <a:lstStyle/>
+          <a:p>
+            <a:pPr algn="ctr" indent="0" marL="0">
+              <a:buNone/>
+            </a:pPr>
+            <a:r>
+              <a:rPr lang="en-US" sz="1000" b="1" dirty="0">
+                <a:solidFill>
+                  <a:schemeClr val="bg1"/>
+                </a:solidFill>
+              </a:rPr>
+              <a:t>to Mars</a:t>
+            </a:r>
+            <a:endParaRPr lang="en-US" sz="1000" dirty="0"/>
+          </a:p>
+        </p:txBody>
+      </p:sp>
+      <p:sp>
+        <p:nvSpPr>
+          <p:cNvPr id="30" name="Mars on Mars, about 500 days"/>
+          <p:cNvSpPr/>
+          <p:nvPr/>
+        </p:nvSpPr>
+        <p:spPr>
+          <a:xfrm>
+            <a:off x="8869680" y="3566160"/>
+            <a:ext cx="1778000" cy="292608"/>
+          </a:xfrm>
+          <a:prstGeom prst="rect">
+            <a:avLst/>
+          </a:prstGeom>
+          <a:solidFill>
+            <a:srgbClr val="A23B2A">
+              <a:alpha val="55000"/>
+            </a:srgbClr>
+          </a:solidFill>
+          <a:ln w="12700">
+            <a:solidFill>
+              <a:srgbClr val="FFFFFF"/>
+            </a:solidFill>
+            <a:prstDash val="solid"/>
+          </a:ln>
+        </p:spPr>
+      </p:sp>
+      <p:sp>
+        <p:nvSpPr>
+          <p:cNvPr id="31" name="Text 29"/>
+          <p:cNvSpPr txBox="1"/>
+          <p:nvPr/>
+        </p:nvSpPr>
+        <p:spPr>
+          <a:xfrm>
+            <a:off x="8869680" y="3566160"/>
+            <a:ext cx="1778000" cy="292608"/>
+          </a:xfrm>
+          <a:prstGeom prst="rect">
+            <a:avLst/>
+          </a:prstGeom>
+          <a:noFill/>
+          <a:ln/>
+        </p:spPr>
+        <p:txBody>
+          <a:bodyPr wrap="square" lIns="0" tIns="0" rIns="0" bIns="0" rtlCol="0" anchor="ctr"/>
+          <a:lstStyle/>
+          <a:p>
+            <a:pPr algn="ctr" indent="0" marL="0">
+              <a:buNone/>
+            </a:pPr>
+            <a:r>
+              <a:rPr lang="en-US" sz="1000" b="1" dirty="0">
+                <a:solidFill>
+                  <a:schemeClr val="tx1"/>
+                </a:solidFill>
+              </a:rPr>
+              <a:t>on Mars, about 500 days</a:t>
+            </a:r>
+            <a:endParaRPr lang="en-US" sz="1000" dirty="0"/>
+          </a:p>
+        </p:txBody>
+      </p:sp>
+      <p:sp>
+        <p:nvSpPr>
+          <p:cNvPr id="32" name="Mars home"/>
+          <p:cNvSpPr/>
+          <p:nvPr/>
+        </p:nvSpPr>
+        <p:spPr>
+          <a:xfrm>
+            <a:off x="10647680" y="3566160"/>
+            <a:ext cx="640080" cy="292608"/>
+          </a:xfrm>
+          <a:prstGeom prst="rect">
+            <a:avLst/>
+          </a:prstGeom>
+          <a:solidFill>
+            <a:srgbClr val="A23B2A"/>
+          </a:solidFill>
+          <a:ln w="12700">
+            <a:solidFill>
+              <a:srgbClr val="FFFFFF"/>
+            </a:solidFill>
+            <a:prstDash val="solid"/>
+          </a:ln>
+        </p:spPr>
+      </p:sp>
+      <p:sp>
+        <p:nvSpPr>
+          <p:cNvPr id="33" name="Text 31"/>
+          <p:cNvSpPr txBox="1"/>
+          <p:nvPr/>
+        </p:nvSpPr>
+        <p:spPr>
+          <a:xfrm>
+            <a:off x="10647680" y="3566160"/>
+            <a:ext cx="640080" cy="292608"/>
+          </a:xfrm>
+          <a:prstGeom prst="rect">
+            <a:avLst/>
+          </a:prstGeom>
+          <a:noFill/>
+          <a:ln/>
+        </p:spPr>
+        <p:txBody>
+          <a:bodyPr wrap="square" lIns="0" tIns="0" rIns="0" bIns="0" rtlCol="0" anchor="ctr"/>
+          <a:lstStyle/>
+          <a:p>
+            <a:pPr algn="ctr" indent="0" marL="0">
+              <a:buNone/>
+            </a:pPr>
+            <a:r>
+              <a:rPr lang="en-US" sz="1000" b="1" dirty="0">
+                <a:solidFill>
+                  <a:schemeClr val="bg1"/>
+                </a:solidFill>
+              </a:rPr>
+              <a:t>home</a:t>
+            </a:r>
+            <a:endParaRPr lang="en-US" sz="1000" dirty="0"/>
+          </a:p>
+        </p:txBody>
+      </p:sp>
+      <p:sp>
+        <p:nvSpPr>
+          <p:cNvPr id="34" name="Arrival marker"/>
+          <p:cNvSpPr/>
+          <p:nvPr/>
+        </p:nvSpPr>
+        <p:spPr>
+          <a:xfrm>
+            <a:off x="8869680" y="3886200"/>
+            <a:ext cx="0" cy="182880"/>
+          </a:xfrm>
+          <a:prstGeom prst="line">
+            <a:avLst/>
+          </a:prstGeom>
+          <a:noFill/>
+          <a:ln w="12700">
+            <a:solidFill>
+              <a:srgbClr val="1A1A1A"/>
+            </a:solidFill>
+            <a:prstDash val="solid"/>
+            <a:headEnd type="triangle"/>
+          </a:ln>
+        </p:spPr>
+      </p:sp>
+      <p:sp>
+        <p:nvSpPr>
+          <p:cNvPr id="35" name="Text 33"/>
+          <p:cNvSpPr txBox="1"/>
+          <p:nvPr/>
+        </p:nvSpPr>
+        <p:spPr>
+          <a:xfrm>
+            <a:off x="8321040" y="4087368"/>
+            <a:ext cx="3749040" cy="228600"/>
+          </a:xfrm>
+          <a:prstGeom prst="rect">
+            <a:avLst/>
+          </a:prstGeom>
+          <a:noFill/>
+          <a:ln/>
+        </p:spPr>
+        <p:txBody>
+          <a:bodyPr wrap="square" lIns="0" tIns="0" rIns="0" bIns="0" rtlCol="0" anchor="t"/>
+          <a:lstStyle/>
+          <a:p>
+            <a:pPr algn="l" indent="0" marL="0">
+              <a:buNone/>
+            </a:pPr>
+            <a:r>
+              <a:rPr lang="en-US" sz="1050" i="1" dirty="0">
+                <a:solidFill>
+                  <a:schemeClr val="tx2"/>
+                </a:solidFill>
+              </a:rPr>
+              <a:t>arrival: 6 months weightless, then surface work</a:t>
+            </a:r>
+            <a:endParaRPr lang="en-US" sz="1050" dirty="0"/>
+          </a:p>
+        </p:txBody>
+      </p:sp>
+      <p:sp>
+        <p:nvSpPr>
+          <p:cNvPr id="36" name="Time axis"/>
+          <p:cNvSpPr/>
+          <p:nvPr/>
+        </p:nvSpPr>
+        <p:spPr>
+          <a:xfrm>
+            <a:off x="8229600" y="4434840"/>
+            <a:ext cx="3200400" cy="0"/>
           </a:xfrm>
           <a:prstGeom prst="line">
             <a:avLst/>
@@ -14947,13 +15298,13 @@
       </p:sp>
       <p:sp>
         <p:nvSpPr>
-          <p:cNvPr id="25" name="Tick 0"/>
-          <p:cNvSpPr/>
-          <p:nvPr/>
-        </p:nvSpPr>
-        <p:spPr>
-          <a:xfrm>
-            <a:off x="8595360" y="4242816"/>
+          <p:cNvPr id="37" name="Tick 0"/>
+          <p:cNvSpPr/>
+          <p:nvPr/>
+        </p:nvSpPr>
+        <p:spPr>
+          <a:xfrm>
+            <a:off x="8229600" y="4434840"/>
             <a:ext cx="0" cy="54864"/>
           </a:xfrm>
           <a:prstGeom prst="line">
@@ -14970,14 +15321,14 @@
       </p:sp>
       <p:sp>
         <p:nvSpPr>
-          <p:cNvPr id="26" name="Text 24"/>
+          <p:cNvPr id="38" name="Text 36"/>
           <p:cNvSpPr txBox="1"/>
           <p:nvPr/>
         </p:nvSpPr>
         <p:spPr>
           <a:xfrm>
-            <a:off x="8321040" y="4306824"/>
-            <a:ext cx="548640" cy="201168"/>
+            <a:off x="7863840" y="4489704"/>
+            <a:ext cx="731520" cy="182880"/>
           </a:xfrm>
           <a:prstGeom prst="rect">
             <a:avLst/>
@@ -15006,13 +15357,13 @@
       </p:sp>
       <p:sp>
         <p:nvSpPr>
-          <p:cNvPr id="27" name="Tick 60"/>
-          <p:cNvSpPr/>
-          <p:nvPr/>
-        </p:nvSpPr>
-        <p:spPr>
-          <a:xfrm>
-            <a:off x="9432036" y="4242816"/>
+          <p:cNvPr id="39" name="Tick 1 year"/>
+          <p:cNvSpPr/>
+          <p:nvPr/>
+        </p:nvSpPr>
+        <p:spPr>
+          <a:xfrm>
+            <a:off x="9527540" y="4434840"/>
             <a:ext cx="0" cy="54864"/>
           </a:xfrm>
           <a:prstGeom prst="line">
@@ -15029,14 +15380,14 @@
       </p:sp>
       <p:sp>
         <p:nvSpPr>
-          <p:cNvPr id="28" name="Text 26"/>
+          <p:cNvPr id="40" name="Text 38"/>
           <p:cNvSpPr txBox="1"/>
           <p:nvPr/>
         </p:nvSpPr>
         <p:spPr>
           <a:xfrm>
-            <a:off x="9157716" y="4306824"/>
-            <a:ext cx="548640" cy="201168"/>
+            <a:off x="9161780" y="4489704"/>
+            <a:ext cx="731520" cy="182880"/>
           </a:xfrm>
           <a:prstGeom prst="rect">
             <a:avLst/>
@@ -15057,7 +15408,7 @@
                   <a:schemeClr val="accent3"/>
                 </a:solidFill>
               </a:rPr>
-              <a:t>60</a:t>
+              <a:t>1 year</a:t>
             </a:r>
             <a:endParaRPr lang="en-US" sz="1000" dirty="0"/>
           </a:p>
@@ -15065,13 +15416,13 @@
       </p:sp>
       <p:sp>
         <p:nvSpPr>
-          <p:cNvPr id="29" name="Tick 120"/>
-          <p:cNvSpPr/>
-          <p:nvPr/>
-        </p:nvSpPr>
-        <p:spPr>
-          <a:xfrm>
-            <a:off x="10268712" y="4242816"/>
+          <p:cNvPr id="41" name="Tick 2 years"/>
+          <p:cNvSpPr/>
+          <p:nvPr/>
+        </p:nvSpPr>
+        <p:spPr>
+          <a:xfrm>
+            <a:off x="10825480" y="4434840"/>
             <a:ext cx="0" cy="54864"/>
           </a:xfrm>
           <a:prstGeom prst="line">
@@ -15088,14 +15439,14 @@
       </p:sp>
       <p:sp>
         <p:nvSpPr>
-          <p:cNvPr id="30" name="Text 28"/>
+          <p:cNvPr id="42" name="Text 40"/>
           <p:cNvSpPr txBox="1"/>
           <p:nvPr/>
         </p:nvSpPr>
         <p:spPr>
           <a:xfrm>
-            <a:off x="9994392" y="4306824"/>
-            <a:ext cx="548640" cy="201168"/>
+            <a:off x="10459720" y="4489704"/>
+            <a:ext cx="731520" cy="182880"/>
           </a:xfrm>
           <a:prstGeom prst="rect">
             <a:avLst/>
@@ -15116,7 +15467,7 @@
                   <a:schemeClr val="accent3"/>
                 </a:solidFill>
               </a:rPr>
-              <a:t>120</a:t>
+              <a:t>2 years</a:t>
             </a:r>
             <a:endParaRPr lang="en-US" sz="1000" dirty="0"/>
           </a:p>
@@ -15124,66 +15475,7 @@
       </p:sp>
       <p:sp>
         <p:nvSpPr>
-          <p:cNvPr id="31" name="Tick 180"/>
-          <p:cNvSpPr/>
-          <p:nvPr/>
-        </p:nvSpPr>
-        <p:spPr>
-          <a:xfrm>
-            <a:off x="11105388" y="4242816"/>
-            <a:ext cx="0" cy="54864"/>
-          </a:xfrm>
-          <a:prstGeom prst="line">
-            <a:avLst/>
-          </a:prstGeom>
-          <a:noFill/>
-          <a:ln w="9525">
-            <a:solidFill>
-              <a:srgbClr val="6B7280"/>
-            </a:solidFill>
-            <a:prstDash val="solid"/>
-          </a:ln>
-        </p:spPr>
-      </p:sp>
-      <p:sp>
-        <p:nvSpPr>
-          <p:cNvPr id="32" name="Text 30"/>
-          <p:cNvSpPr txBox="1"/>
-          <p:nvPr/>
-        </p:nvSpPr>
-        <p:spPr>
-          <a:xfrm>
-            <a:off x="10831068" y="4306824"/>
-            <a:ext cx="548640" cy="201168"/>
-          </a:xfrm>
-          <a:prstGeom prst="rect">
-            <a:avLst/>
-          </a:prstGeom>
-          <a:noFill/>
-          <a:ln/>
-        </p:spPr>
-        <p:txBody>
-          <a:bodyPr wrap="square" lIns="0" tIns="0" rIns="0" bIns="0" rtlCol="0" anchor="t"/>
-          <a:lstStyle/>
-          <a:p>
-            <a:pPr algn="ctr" indent="0" marL="0">
-              <a:buNone/>
-            </a:pPr>
-            <a:r>
-              <a:rPr lang="en-US" sz="1000" dirty="0">
-                <a:solidFill>
-                  <a:schemeClr val="accent3"/>
-                </a:solidFill>
-              </a:rPr>
-              <a:t>180</a:t>
-            </a:r>
-            <a:endParaRPr lang="en-US" sz="1000" dirty="0"/>
-          </a:p>
-        </p:txBody>
-      </p:sp>
-      <p:sp>
-        <p:nvSpPr>
-          <p:cNvPr id="33" name="Step 1"/>
+          <p:cNvPr id="43" name="Step 1"/>
           <p:cNvSpPr/>
           <p:nvPr/>
         </p:nvSpPr>
@@ -15208,7 +15500,7 @@
       </p:sp>
       <p:sp>
         <p:nvSpPr>
-          <p:cNvPr id="34" name="Text 32"/>
+          <p:cNvPr id="44" name="Text 42"/>
           <p:cNvSpPr txBox="1"/>
           <p:nvPr/>
         </p:nvSpPr>
@@ -15258,7 +15550,7 @@
       </p:sp>
       <p:sp>
         <p:nvSpPr>
-          <p:cNvPr id="35" name="Step 2"/>
+          <p:cNvPr id="45" name="Step 2"/>
           <p:cNvSpPr/>
           <p:nvPr/>
         </p:nvSpPr>
@@ -15283,7 +15575,7 @@
       </p:sp>
       <p:sp>
         <p:nvSpPr>
-          <p:cNvPr id="36" name="Text 34"/>
+          <p:cNvPr id="46" name="Text 44"/>
           <p:cNvSpPr txBox="1"/>
           <p:nvPr/>
         </p:nvSpPr>
@@ -15333,7 +15625,7 @@
       </p:sp>
       <p:sp>
         <p:nvSpPr>
-          <p:cNvPr id="37" name="Step 3"/>
+          <p:cNvPr id="47" name="Step 3"/>
           <p:cNvSpPr/>
           <p:nvPr/>
         </p:nvSpPr>
@@ -15358,7 +15650,7 @@
       </p:sp>
       <p:sp>
         <p:nvSpPr>
-          <p:cNvPr id="38" name="Text 36"/>
+          <p:cNvPr id="48" name="Text 46"/>
           <p:cNvSpPr txBox="1"/>
           <p:nvPr/>
         </p:nvSpPr>
@@ -15394,7 +15686,7 @@
       </p:sp>
       <p:sp>
         <p:nvSpPr>
-          <p:cNvPr id="39" name="Step 4"/>
+          <p:cNvPr id="49" name="Step 4"/>
           <p:cNvSpPr/>
           <p:nvPr/>
         </p:nvSpPr>
@@ -15419,7 +15711,7 @@
       </p:sp>
       <p:sp>
         <p:nvSpPr>
-          <p:cNvPr id="40" name="Text 38"/>
+          <p:cNvPr id="50" name="Text 48"/>
           <p:cNvSpPr txBox="1"/>
           <p:nvPr/>
         </p:nvSpPr>
@@ -15455,7 +15747,7 @@
       </p:sp>
       <p:sp>
         <p:nvSpPr>
-          <p:cNvPr id="41" name="Arrow 1"/>
+          <p:cNvPr id="51" name="Arrow 1"/>
           <p:cNvSpPr/>
           <p:nvPr/>
         </p:nvSpPr>
@@ -15479,7 +15771,7 @@
       </p:sp>
       <p:sp>
         <p:nvSpPr>
-          <p:cNvPr id="42" name="Text 40"/>
+          <p:cNvPr id="52" name="Text 50"/>
           <p:cNvSpPr txBox="1"/>
           <p:nvPr/>
         </p:nvSpPr>
@@ -15515,7 +15807,7 @@
       </p:sp>
       <p:sp>
         <p:nvSpPr>
-          <p:cNvPr id="43" name="Arrow 3"/>
+          <p:cNvPr id="53" name="Arrow 3"/>
           <p:cNvSpPr/>
           <p:nvPr/>
         </p:nvSpPr>
@@ -15539,7 +15831,7 @@
       </p:sp>
       <p:sp>
         <p:nvSpPr>
-          <p:cNvPr id="44" name="Text 42"/>
+          <p:cNvPr id="54" name="Text 52"/>
           <p:cNvSpPr txBox="1"/>
           <p:nvPr/>
         </p:nvSpPr>

</xml_diff>

<commit_message>
Slide 4: planet photo overlays on Earth, Moon and Mars
Co-Authored-By: Claude Opus 5.5 (1M context) <noreply@anthropic.com>
Claude-Session: https://claude.ai/code/session_01JZtuYERhuCe7nB9VYHwcfv
</commit_message>
<xml_diff>
--- a/presentation/bed-rest-to-mars-talk.pptx
+++ b/presentation/bed-rest-to-mars-talk.pptx
@@ -126,13 +126,13 @@
   <p:extLst>
     <p:ext uri="{521415D9-36F7-43E2-AB2F-B90AF26B5E84}">
       <p14:sectionLst xmlns:p14="http://schemas.microsoft.com/office/powerpoint/2010/main">
-        <p14:section name="Opening" id="{a13dd9fb-77dc-a407-e923-29c6c2779835}">
+        <p14:section name="Opening" id="{6fa73704-5a31-3ad0-92da-bd5c63575813}">
           <p14:sldIdLst>
             <p14:sldId id="256"/>
             <p14:sldId id="257"/>
           </p14:sldIdLst>
         </p14:section>
-        <p14:section name="Part 1" id="{05f7214c-cbb2-b196-082b-98bab2e6a788}">
+        <p14:section name="Part 1" id="{9fbb8818-4e1f-57ca-0508-5e7dc4c4733f}">
           <p14:sldIdLst>
             <p14:sldId id="258"/>
             <p14:sldId id="259"/>
@@ -143,7 +143,7 @@
             <p14:sldId id="264"/>
           </p14:sldIdLst>
         </p14:section>
-        <p14:section name="Part 2" id="{e1e4b4c3-a5f8-11d9-ae09-778c42cd3edf}">
+        <p14:section name="Part 2" id="{968db5b1-769b-debb-9e99-2532e7e53dc0}">
           <p14:sldIdLst>
             <p14:sldId id="265"/>
             <p14:sldId id="266"/>
@@ -154,7 +154,7 @@
             <p14:sldId id="271"/>
           </p14:sldIdLst>
         </p14:section>
-        <p14:section name="Backup" id="{81441cba-5157-5af9-30a2-7f2bb27203fd}">
+        <p14:section name="Backup" id="{f19e346b-f869-41ea-cf5c-750c41d0ab0c}">
           <p14:sldIdLst>
             <p14:sldId id="272"/>
             <p14:sldId id="273"/>
@@ -162,13 +162,13 @@
             <p14:sldId id="275"/>
           </p14:sldIdLst>
         </p14:section>
-        <p14:section name="Backup" id="{d8fb7918-f64b-454c-3d67-667e1e29d9fc}">
+        <p14:section name="Backup" id="{2e9b795d-9649-8cca-de2b-e8a4ce180743}">
           <p14:sldIdLst/>
         </p14:section>
-        <p14:section name="Backup" id="{3c1afbc2-00b7-41ee-ede8-82840da9d498}">
+        <p14:section name="Backup" id="{5ce81784-33b0-7937-861b-a6ded380ddc6}">
           <p14:sldIdLst/>
         </p14:section>
-        <p14:section name="Backup" id="{cc8adf65-e778-fbf8-ee07-6d987e08c947}">
+        <p14:section name="Backup" id="{0fa2da9c-de04-995d-be3a-2846bf6ccde0}">
           <p14:sldIdLst/>
         </p14:section>
       </p14:sectionLst>
@@ -14592,8 +14592,8 @@
         </p:nvSpPr>
         <p:spPr>
           <a:xfrm>
-            <a:off x="6720840" y="1874520"/>
-            <a:ext cx="457200" cy="457200"/>
+            <a:off x="6675120" y="1828800"/>
+            <a:ext cx="548640" cy="548640"/>
           </a:xfrm>
           <a:prstGeom prst="ellipse">
             <a:avLst/>
@@ -14604,15 +14604,39 @@
           <a:ln/>
         </p:spPr>
       </p:sp>
-      <p:sp>
-        <p:nvSpPr>
-          <p:cNvPr id="15" name="Text 13"/>
+      <p:pic>
+        <p:nvPicPr>
+          <p:cNvPr id="15" name="Image 0" descr="Earth (photo map, semi-transparent)">    </p:cNvPr>
+          <p:cNvPicPr>
+            <a:picLocks noChangeAspect="1"/>
+          </p:cNvPicPr>
+          <p:nvPr/>
+        </p:nvPicPr>
+        <p:blipFill>
+          <a:blip r:embed="rId1"/>
+          <a:stretch>
+            <a:fillRect/>
+          </a:stretch>
+        </p:blipFill>
+        <p:spPr>
+          <a:xfrm>
+            <a:off x="6675120" y="1828800"/>
+            <a:ext cx="548640" cy="548640"/>
+          </a:xfrm>
+          <a:prstGeom prst="rect">
+            <a:avLst/>
+          </a:prstGeom>
+        </p:spPr>
+      </p:pic>
+      <p:sp>
+        <p:nvSpPr>
+          <p:cNvPr id="16" name="Text 13"/>
           <p:cNvSpPr txBox="1"/>
           <p:nvPr/>
         </p:nvSpPr>
         <p:spPr>
           <a:xfrm>
-            <a:off x="6400800" y="2404872"/>
+            <a:off x="6400800" y="2432304"/>
             <a:ext cx="1097280" cy="228600"/>
           </a:xfrm>
           <a:prstGeom prst="rect">
@@ -14642,14 +14666,14 @@
       </p:sp>
       <p:sp>
         <p:nvSpPr>
-          <p:cNvPr id="16" name="Moon"/>
-          <p:cNvSpPr/>
-          <p:nvPr/>
-        </p:nvSpPr>
-        <p:spPr>
-          <a:xfrm>
-            <a:off x="7900416" y="2002536"/>
-            <a:ext cx="201168" cy="201168"/>
+          <p:cNvPr id="17" name="Moon"/>
+          <p:cNvSpPr/>
+          <p:nvPr/>
+        </p:nvSpPr>
+        <p:spPr>
+          <a:xfrm>
+            <a:off x="7863840" y="1965960"/>
+            <a:ext cx="274320" cy="274320"/>
           </a:xfrm>
           <a:prstGeom prst="ellipse">
             <a:avLst/>
@@ -14660,15 +14684,39 @@
           <a:ln/>
         </p:spPr>
       </p:sp>
-      <p:sp>
-        <p:nvSpPr>
-          <p:cNvPr id="17" name="Text 15"/>
+      <p:pic>
+        <p:nvPicPr>
+          <p:cNvPr id="18" name="Image 1" descr="Moon (photo map, semi-transparent)">    </p:cNvPr>
+          <p:cNvPicPr>
+            <a:picLocks noChangeAspect="1"/>
+          </p:cNvPicPr>
+          <p:nvPr/>
+        </p:nvPicPr>
+        <p:blipFill>
+          <a:blip r:embed="rId2"/>
+          <a:stretch>
+            <a:fillRect/>
+          </a:stretch>
+        </p:blipFill>
+        <p:spPr>
+          <a:xfrm>
+            <a:off x="7863840" y="1965960"/>
+            <a:ext cx="274320" cy="274320"/>
+          </a:xfrm>
+          <a:prstGeom prst="rect">
+            <a:avLst/>
+          </a:prstGeom>
+        </p:spPr>
+      </p:pic>
+      <p:sp>
+        <p:nvSpPr>
+          <p:cNvPr id="19" name="Text 15"/>
           <p:cNvSpPr txBox="1"/>
           <p:nvPr/>
         </p:nvSpPr>
         <p:spPr>
           <a:xfrm>
-            <a:off x="7452360" y="2404872"/>
+            <a:off x="7452360" y="2432304"/>
             <a:ext cx="1097280" cy="228600"/>
           </a:xfrm>
           <a:prstGeom prst="rect">
@@ -14698,14 +14746,14 @@
       </p:sp>
       <p:sp>
         <p:nvSpPr>
-          <p:cNvPr id="18" name="Mars"/>
-          <p:cNvSpPr/>
-          <p:nvPr/>
-        </p:nvSpPr>
-        <p:spPr>
-          <a:xfrm>
-            <a:off x="10972800" y="1920240"/>
-            <a:ext cx="365760" cy="365760"/>
+          <p:cNvPr id="20" name="Mars"/>
+          <p:cNvSpPr/>
+          <p:nvPr/>
+        </p:nvSpPr>
+        <p:spPr>
+          <a:xfrm>
+            <a:off x="10927080" y="1874520"/>
+            <a:ext cx="457200" cy="457200"/>
           </a:xfrm>
           <a:prstGeom prst="ellipse">
             <a:avLst/>
@@ -14716,15 +14764,39 @@
           <a:ln/>
         </p:spPr>
       </p:sp>
-      <p:sp>
-        <p:nvSpPr>
-          <p:cNvPr id="19" name="Text 17"/>
+      <p:pic>
+        <p:nvPicPr>
+          <p:cNvPr id="21" name="Image 2" descr="Mars (photo map, semi-transparent)">    </p:cNvPr>
+          <p:cNvPicPr>
+            <a:picLocks noChangeAspect="1"/>
+          </p:cNvPicPr>
+          <p:nvPr/>
+        </p:nvPicPr>
+        <p:blipFill>
+          <a:blip r:embed="rId3"/>
+          <a:stretch>
+            <a:fillRect/>
+          </a:stretch>
+        </p:blipFill>
+        <p:spPr>
+          <a:xfrm>
+            <a:off x="10927080" y="1874520"/>
+            <a:ext cx="457200" cy="457200"/>
+          </a:xfrm>
+          <a:prstGeom prst="rect">
+            <a:avLst/>
+          </a:prstGeom>
+        </p:spPr>
+      </p:pic>
+      <p:sp>
+        <p:nvSpPr>
+          <p:cNvPr id="22" name="Text 17"/>
           <p:cNvSpPr txBox="1"/>
           <p:nvPr/>
         </p:nvSpPr>
         <p:spPr>
           <a:xfrm>
-            <a:off x="10607040" y="2404872"/>
+            <a:off x="10607040" y="2432304"/>
             <a:ext cx="1097280" cy="228600"/>
           </a:xfrm>
           <a:prstGeom prst="rect">
@@ -14754,14 +14826,14 @@
       </p:sp>
       <p:sp>
         <p:nvSpPr>
-          <p:cNvPr id="20" name="Route to Moon"/>
-          <p:cNvSpPr/>
-          <p:nvPr/>
-        </p:nvSpPr>
-        <p:spPr>
-          <a:xfrm>
-            <a:off x="7205472" y="2103120"/>
-            <a:ext cx="676656" cy="0"/>
+          <p:cNvPr id="23" name="Route to Moon"/>
+          <p:cNvSpPr/>
+          <p:nvPr/>
+        </p:nvSpPr>
+        <p:spPr>
+          <a:xfrm>
+            <a:off x="7251192" y="2103120"/>
+            <a:ext cx="594360" cy="0"/>
           </a:xfrm>
           <a:prstGeom prst="line">
             <a:avLst/>
@@ -14778,14 +14850,14 @@
       </p:sp>
       <p:sp>
         <p:nvSpPr>
-          <p:cNvPr id="21" name="Text 19"/>
+          <p:cNvPr id="24" name="Text 19"/>
           <p:cNvSpPr txBox="1"/>
           <p:nvPr/>
         </p:nvSpPr>
         <p:spPr>
           <a:xfrm>
-            <a:off x="7205472" y="1810512"/>
-            <a:ext cx="676656" cy="228600"/>
+            <a:off x="7251192" y="1810512"/>
+            <a:ext cx="594360" cy="228600"/>
           </a:xfrm>
           <a:prstGeom prst="rect">
             <a:avLst/>
@@ -14814,14 +14886,14 @@
       </p:sp>
       <p:sp>
         <p:nvSpPr>
-          <p:cNvPr id="22" name="Route to Mars"/>
+          <p:cNvPr id="25" name="Route to Mars"/>
           <p:cNvSpPr/>
           <p:nvPr/>
         </p:nvSpPr>
         <p:spPr>
           <a:xfrm>
             <a:off x="8183880" y="2103120"/>
-            <a:ext cx="2770632" cy="0"/>
+            <a:ext cx="2724912" cy="0"/>
           </a:xfrm>
           <a:prstGeom prst="line">
             <a:avLst/>
@@ -14838,14 +14910,14 @@
       </p:sp>
       <p:sp>
         <p:nvSpPr>
-          <p:cNvPr id="23" name="Text 21"/>
+          <p:cNvPr id="26" name="Text 21"/>
           <p:cNvSpPr txBox="1"/>
           <p:nvPr/>
         </p:nvSpPr>
         <p:spPr>
           <a:xfrm>
             <a:off x="8183880" y="1810512"/>
-            <a:ext cx="2770632" cy="228600"/>
+            <a:ext cx="2724912" cy="228600"/>
           </a:xfrm>
           <a:prstGeom prst="rect">
             <a:avLst/>
@@ -14874,7 +14946,7 @@
       </p:sp>
       <p:sp>
         <p:nvSpPr>
-          <p:cNvPr id="24" name="Text 22"/>
+          <p:cNvPr id="27" name="Text 22"/>
           <p:cNvSpPr txBox="1"/>
           <p:nvPr/>
         </p:nvSpPr>
@@ -14924,7 +14996,7 @@
       </p:sp>
       <p:sp>
         <p:nvSpPr>
-          <p:cNvPr id="25" name="Moon mission bar"/>
+          <p:cNvPr id="28" name="Moon mission bar"/>
           <p:cNvSpPr/>
           <p:nvPr/>
         </p:nvSpPr>
@@ -14944,7 +15016,7 @@
       </p:sp>
       <p:sp>
         <p:nvSpPr>
-          <p:cNvPr id="26" name="Text 24"/>
+          <p:cNvPr id="29" name="Text 24"/>
           <p:cNvSpPr txBox="1"/>
           <p:nvPr/>
         </p:nvSpPr>
@@ -14980,7 +15052,7 @@
       </p:sp>
       <p:sp>
         <p:nvSpPr>
-          <p:cNvPr id="27" name="Text 25"/>
+          <p:cNvPr id="30" name="Text 25"/>
           <p:cNvSpPr txBox="1"/>
           <p:nvPr/>
         </p:nvSpPr>
@@ -15030,7 +15102,7 @@
       </p:sp>
       <p:sp>
         <p:nvSpPr>
-          <p:cNvPr id="28" name="Mars to Mars"/>
+          <p:cNvPr id="31" name="Mars to Mars"/>
           <p:cNvSpPr/>
           <p:nvPr/>
         </p:nvSpPr>
@@ -15055,7 +15127,7 @@
       </p:sp>
       <p:sp>
         <p:nvSpPr>
-          <p:cNvPr id="29" name="Text 27"/>
+          <p:cNvPr id="32" name="Text 27"/>
           <p:cNvSpPr txBox="1"/>
           <p:nvPr/>
         </p:nvSpPr>
@@ -15091,7 +15163,7 @@
       </p:sp>
       <p:sp>
         <p:nvSpPr>
-          <p:cNvPr id="30" name="Mars on Mars, about 500 days"/>
+          <p:cNvPr id="33" name="Mars on Mars, about 500 days"/>
           <p:cNvSpPr/>
           <p:nvPr/>
         </p:nvSpPr>
@@ -15118,7 +15190,7 @@
       </p:sp>
       <p:sp>
         <p:nvSpPr>
-          <p:cNvPr id="31" name="Text 29"/>
+          <p:cNvPr id="34" name="Text 29"/>
           <p:cNvSpPr txBox="1"/>
           <p:nvPr/>
         </p:nvSpPr>
@@ -15154,7 +15226,7 @@
       </p:sp>
       <p:sp>
         <p:nvSpPr>
-          <p:cNvPr id="32" name="Mars home"/>
+          <p:cNvPr id="35" name="Mars home"/>
           <p:cNvSpPr/>
           <p:nvPr/>
         </p:nvSpPr>
@@ -15179,7 +15251,7 @@
       </p:sp>
       <p:sp>
         <p:nvSpPr>
-          <p:cNvPr id="33" name="Text 31"/>
+          <p:cNvPr id="36" name="Text 31"/>
           <p:cNvSpPr txBox="1"/>
           <p:nvPr/>
         </p:nvSpPr>
@@ -15215,7 +15287,7 @@
       </p:sp>
       <p:sp>
         <p:nvSpPr>
-          <p:cNvPr id="34" name="Arrival marker"/>
+          <p:cNvPr id="37" name="Arrival marker"/>
           <p:cNvSpPr/>
           <p:nvPr/>
         </p:nvSpPr>
@@ -15239,7 +15311,7 @@
       </p:sp>
       <p:sp>
         <p:nvSpPr>
-          <p:cNvPr id="35" name="Text 33"/>
+          <p:cNvPr id="38" name="Text 33"/>
           <p:cNvSpPr txBox="1"/>
           <p:nvPr/>
         </p:nvSpPr>
@@ -15275,7 +15347,7 @@
       </p:sp>
       <p:sp>
         <p:nvSpPr>
-          <p:cNvPr id="36" name="Time axis"/>
+          <p:cNvPr id="39" name="Time axis"/>
           <p:cNvSpPr/>
           <p:nvPr/>
         </p:nvSpPr>
@@ -15298,7 +15370,7 @@
       </p:sp>
       <p:sp>
         <p:nvSpPr>
-          <p:cNvPr id="37" name="Tick 0"/>
+          <p:cNvPr id="40" name="Tick 0"/>
           <p:cNvSpPr/>
           <p:nvPr/>
         </p:nvSpPr>
@@ -15321,7 +15393,7 @@
       </p:sp>
       <p:sp>
         <p:nvSpPr>
-          <p:cNvPr id="38" name="Text 36"/>
+          <p:cNvPr id="41" name="Text 36"/>
           <p:cNvSpPr txBox="1"/>
           <p:nvPr/>
         </p:nvSpPr>
@@ -15357,7 +15429,7 @@
       </p:sp>
       <p:sp>
         <p:nvSpPr>
-          <p:cNvPr id="39" name="Tick 1 year"/>
+          <p:cNvPr id="42" name="Tick 1 year"/>
           <p:cNvSpPr/>
           <p:nvPr/>
         </p:nvSpPr>
@@ -15380,7 +15452,7 @@
       </p:sp>
       <p:sp>
         <p:nvSpPr>
-          <p:cNvPr id="40" name="Text 38"/>
+          <p:cNvPr id="43" name="Text 38"/>
           <p:cNvSpPr txBox="1"/>
           <p:nvPr/>
         </p:nvSpPr>
@@ -15416,7 +15488,7 @@
       </p:sp>
       <p:sp>
         <p:nvSpPr>
-          <p:cNvPr id="41" name="Tick 2 years"/>
+          <p:cNvPr id="44" name="Tick 2 years"/>
           <p:cNvSpPr/>
           <p:nvPr/>
         </p:nvSpPr>
@@ -15439,7 +15511,7 @@
       </p:sp>
       <p:sp>
         <p:nvSpPr>
-          <p:cNvPr id="42" name="Text 40"/>
+          <p:cNvPr id="45" name="Text 40"/>
           <p:cNvSpPr txBox="1"/>
           <p:nvPr/>
         </p:nvSpPr>
@@ -15475,7 +15547,7 @@
       </p:sp>
       <p:sp>
         <p:nvSpPr>
-          <p:cNvPr id="43" name="Step 1"/>
+          <p:cNvPr id="46" name="Step 1"/>
           <p:cNvSpPr/>
           <p:nvPr/>
         </p:nvSpPr>
@@ -15500,7 +15572,7 @@
       </p:sp>
       <p:sp>
         <p:nvSpPr>
-          <p:cNvPr id="44" name="Text 42"/>
+          <p:cNvPr id="47" name="Text 42"/>
           <p:cNvSpPr txBox="1"/>
           <p:nvPr/>
         </p:nvSpPr>
@@ -15550,7 +15622,7 @@
       </p:sp>
       <p:sp>
         <p:nvSpPr>
-          <p:cNvPr id="45" name="Step 2"/>
+          <p:cNvPr id="48" name="Step 2"/>
           <p:cNvSpPr/>
           <p:nvPr/>
         </p:nvSpPr>
@@ -15575,7 +15647,7 @@
       </p:sp>
       <p:sp>
         <p:nvSpPr>
-          <p:cNvPr id="46" name="Text 44"/>
+          <p:cNvPr id="49" name="Text 44"/>
           <p:cNvSpPr txBox="1"/>
           <p:nvPr/>
         </p:nvSpPr>
@@ -15625,7 +15697,7 @@
       </p:sp>
       <p:sp>
         <p:nvSpPr>
-          <p:cNvPr id="47" name="Step 3"/>
+          <p:cNvPr id="50" name="Step 3"/>
           <p:cNvSpPr/>
           <p:nvPr/>
         </p:nvSpPr>
@@ -15650,7 +15722,7 @@
       </p:sp>
       <p:sp>
         <p:nvSpPr>
-          <p:cNvPr id="48" name="Text 46"/>
+          <p:cNvPr id="51" name="Text 46"/>
           <p:cNvSpPr txBox="1"/>
           <p:nvPr/>
         </p:nvSpPr>
@@ -15686,7 +15758,7 @@
       </p:sp>
       <p:sp>
         <p:nvSpPr>
-          <p:cNvPr id="49" name="Step 4"/>
+          <p:cNvPr id="52" name="Step 4"/>
           <p:cNvSpPr/>
           <p:nvPr/>
         </p:nvSpPr>
@@ -15711,7 +15783,7 @@
       </p:sp>
       <p:sp>
         <p:nvSpPr>
-          <p:cNvPr id="50" name="Text 48"/>
+          <p:cNvPr id="53" name="Text 48"/>
           <p:cNvSpPr txBox="1"/>
           <p:nvPr/>
         </p:nvSpPr>
@@ -15747,7 +15819,7 @@
       </p:sp>
       <p:sp>
         <p:nvSpPr>
-          <p:cNvPr id="51" name="Arrow 1"/>
+          <p:cNvPr id="54" name="Arrow 1"/>
           <p:cNvSpPr/>
           <p:nvPr/>
         </p:nvSpPr>
@@ -15771,7 +15843,7 @@
       </p:sp>
       <p:sp>
         <p:nvSpPr>
-          <p:cNvPr id="52" name="Text 50"/>
+          <p:cNvPr id="55" name="Text 50"/>
           <p:cNvSpPr txBox="1"/>
           <p:nvPr/>
         </p:nvSpPr>
@@ -15807,7 +15879,7 @@
       </p:sp>
       <p:sp>
         <p:nvSpPr>
-          <p:cNvPr id="53" name="Arrow 3"/>
+          <p:cNvPr id="56" name="Arrow 3"/>
           <p:cNvSpPr/>
           <p:nvPr/>
         </p:nvSpPr>
@@ -15831,7 +15903,7 @@
       </p:sp>
       <p:sp>
         <p:nvSpPr>
-          <p:cNvPr id="54" name="Text 52"/>
+          <p:cNvPr id="57" name="Text 52"/>
           <p:cNvSpPr txBox="1"/>
           <p:nvPr/>
         </p:nvSpPr>

</xml_diff>

<commit_message>
Slide 5: study range, dataset growth and one-dot-per-study chart
Co-Authored-By: Claude Opus 5.5 (1M context) <noreply@anthropic.com>
Claude-Session: https://claude.ai/code/session_01JZtuYERhuCe7nB9VYHwcfv
</commit_message>
<xml_diff>
--- a/presentation/bed-rest-to-mars-talk.pptx
+++ b/presentation/bed-rest-to-mars-talk.pptx
@@ -126,13 +126,13 @@
   <p:extLst>
     <p:ext uri="{521415D9-36F7-43E2-AB2F-B90AF26B5E84}">
       <p14:sectionLst xmlns:p14="http://schemas.microsoft.com/office/powerpoint/2010/main">
-        <p14:section name="Opening" id="{6fa73704-5a31-3ad0-92da-bd5c63575813}">
+        <p14:section name="Opening" id="{664270cf-b046-7e87-01f0-f79a78f90322}">
           <p14:sldIdLst>
             <p14:sldId id="256"/>
             <p14:sldId id="257"/>
           </p14:sldIdLst>
         </p14:section>
-        <p14:section name="Part 1" id="{9fbb8818-4e1f-57ca-0508-5e7dc4c4733f}">
+        <p14:section name="Part 1" id="{9030eaab-a23b-f567-8326-f43362db3fb2}">
           <p14:sldIdLst>
             <p14:sldId id="258"/>
             <p14:sldId id="259"/>
@@ -143,7 +143,7 @@
             <p14:sldId id="264"/>
           </p14:sldIdLst>
         </p14:section>
-        <p14:section name="Part 2" id="{968db5b1-769b-debb-9e99-2532e7e53dc0}">
+        <p14:section name="Part 2" id="{1402b37b-4606-0270-91d1-3d458d800aed}">
           <p14:sldIdLst>
             <p14:sldId id="265"/>
             <p14:sldId id="266"/>
@@ -154,7 +154,7 @@
             <p14:sldId id="271"/>
           </p14:sldIdLst>
         </p14:section>
-        <p14:section name="Backup" id="{f19e346b-f869-41ea-cf5c-750c41d0ab0c}">
+        <p14:section name="Backup" id="{d6c80283-cae9-0b78-5738-0f06981981eb}">
           <p14:sldIdLst>
             <p14:sldId id="272"/>
             <p14:sldId id="273"/>
@@ -162,13 +162,13 @@
             <p14:sldId id="275"/>
           </p14:sldIdLst>
         </p14:section>
-        <p14:section name="Backup" id="{2e9b795d-9649-8cca-de2b-e8a4ce180743}">
+        <p14:section name="Backup" id="{7d78bfde-eab1-e412-4406-868e32b5b458}">
           <p14:sldIdLst/>
         </p14:section>
-        <p14:section name="Backup" id="{5ce81784-33b0-7937-861b-a6ded380ddc6}">
+        <p14:section name="Backup" id="{3051625c-a487-34f6-6e27-ba74b2a90707}">
           <p14:sldIdLst/>
         </p14:section>
-        <p14:section name="Backup" id="{0fa2da9c-de04-995d-be3a-2846bf6ccde0}">
+        <p14:section name="Backup" id="{d3ea5abc-fa71-8959-de0a-926ac3e7920d}">
           <p14:sldIdLst/>
         </p14:section>
       </p14:sectionLst>
@@ -3881,7 +3881,10 @@
           <a:p>
             <a:r>
               <a:rPr lang="en-US" dirty="0"/>
-              <a:t>Placeholder for the co-author's slide. The suggested points are from the final report on branch feat/report; replace them with the final content.</a:t>
+              <a:t>Part 1 (Niloufar), about forty-five seconds.
+When we submitted the abstract, the dataset held 15 studies. After submission we kept extending it, and the final dataset has 52 studies. They were published between 1992 and 2026 and cover unloading from 5 days to 180 days: up to 119 days of bed rest on the ground, and 180 days in spaceflight.
+On the right, each dot is one study, placed by its year of publication and how long the unloading lasted. Most studies are head-down or horizontal bed rest; the three spaceflight studies sit at 180 days.
+The 52 studies come from 36 independent campaigns, because one bed-rest campaign often produces several papers. Together they give 742 measurements of leg muscle size, taken with MRI, CT, DXA or ultrasound.</a:t>
             </a:r>
             <a:endParaRPr lang="en-US" dirty="0"/>
           </a:p>
@@ -16251,7 +16254,7 @@
                 <a:ea typeface="Cambria" pitchFamily="34" charset="-122"/>
                 <a:cs typeface="Cambria" pitchFamily="34" charset="-120"/>
               </a:rPr>
-              <a:t>What range of unloading did we study?</a:t>
+              <a:t>What range did we study?</a:t>
             </a:r>
             <a:endParaRPr lang="en-US" sz="2800" dirty="0"/>
           </a:p>
@@ -16259,28 +16262,39 @@
       </p:sp>
       <p:sp>
         <p:nvSpPr>
-          <p:cNvPr id="11" name="Placeholder frame"/>
-          <p:cNvSpPr/>
-          <p:nvPr/>
-        </p:nvSpPr>
-        <p:spPr>
-          <a:xfrm>
-            <a:off x="548640" y="1234440"/>
-            <a:ext cx="11064240" cy="4846320"/>
-          </a:xfrm>
-          <a:prstGeom prst="rect">
-            <a:avLst/>
-          </a:prstGeom>
-          <a:solidFill>
-            <a:schemeClr val="bg1"/>
-          </a:solidFill>
-          <a:ln w="12700">
-            <a:solidFill>
-              <a:srgbClr val="9AA3AE"/>
-            </a:solidFill>
-            <a:prstDash val="dash"/>
-          </a:ln>
-        </p:spPr>
+          <p:cNvPr id="11" name="Text 9"/>
+          <p:cNvSpPr txBox="1"/>
+          <p:nvPr/>
+        </p:nvSpPr>
+        <p:spPr>
+          <a:xfrm>
+            <a:off x="548640" y="1188720"/>
+            <a:ext cx="5394960" cy="320040"/>
+          </a:xfrm>
+          <a:prstGeom prst="rect">
+            <a:avLst/>
+          </a:prstGeom>
+          <a:noFill/>
+          <a:ln/>
+        </p:spPr>
+        <p:txBody>
+          <a:bodyPr wrap="square" lIns="0" tIns="0" rIns="0" bIns="0" rtlCol="0" anchor="t"/>
+          <a:lstStyle/>
+          <a:p>
+            <a:pPr indent="0" marL="0">
+              <a:buNone/>
+            </a:pPr>
+            <a:r>
+              <a:rPr lang="en-US" sz="1700" b="1" dirty="0">
+                <a:solidFill>
+                  <a:schemeClr val="tx2"/>
+                </a:solidFill>
+              </a:rPr>
+              <a:t>The dataset grew after the abstract</a:t>
+            </a:r>
+            <a:endParaRPr lang="en-US" sz="1700" dirty="0"/>
+          </a:p>
+        </p:txBody>
       </p:sp>
       <p:sp>
         <p:nvSpPr>
@@ -16290,8 +16304,8 @@
         </p:nvSpPr>
         <p:spPr>
           <a:xfrm>
-            <a:off x="822960" y="1463040"/>
-            <a:ext cx="10515600" cy="4480560"/>
+            <a:off x="548640" y="1645920"/>
+            <a:ext cx="1874520" cy="365760"/>
           </a:xfrm>
           <a:prstGeom prst="rect">
             <a:avLst/>
@@ -16300,6 +16314,190 @@
           <a:ln/>
         </p:spPr>
         <p:txBody>
+          <a:bodyPr wrap="square" lIns="0" tIns="0" rIns="0" bIns="0" rtlCol="0" anchor="ctr"/>
+          <a:lstStyle/>
+          <a:p>
+            <a:pPr indent="0" marL="0">
+              <a:buNone/>
+            </a:pPr>
+            <a:r>
+              <a:rPr lang="en-US" sz="1400" dirty="0">
+                <a:solidFill>
+                  <a:schemeClr val="tx1"/>
+                </a:solidFill>
+              </a:rPr>
+              <a:t>Abstract submission</a:t>
+            </a:r>
+            <a:endParaRPr lang="en-US" sz="1400" dirty="0"/>
+          </a:p>
+        </p:txBody>
+      </p:sp>
+      <p:sp>
+        <p:nvSpPr>
+          <p:cNvPr id="13" name="Abstract submission bar"/>
+          <p:cNvSpPr/>
+          <p:nvPr/>
+        </p:nvSpPr>
+        <p:spPr>
+          <a:xfrm>
+            <a:off x="2514600" y="1682496"/>
+            <a:ext cx="633046" cy="292608"/>
+          </a:xfrm>
+          <a:prstGeom prst="rect">
+            <a:avLst/>
+          </a:prstGeom>
+          <a:solidFill>
+            <a:srgbClr val="A7AEB8"/>
+          </a:solidFill>
+          <a:ln/>
+        </p:spPr>
+      </p:sp>
+      <p:sp>
+        <p:nvSpPr>
+          <p:cNvPr id="14" name="Text 12"/>
+          <p:cNvSpPr txBox="1"/>
+          <p:nvPr/>
+        </p:nvSpPr>
+        <p:spPr>
+          <a:xfrm>
+            <a:off x="3239086" y="1645920"/>
+            <a:ext cx="1280160" cy="365760"/>
+          </a:xfrm>
+          <a:prstGeom prst="rect">
+            <a:avLst/>
+          </a:prstGeom>
+          <a:noFill/>
+          <a:ln/>
+        </p:spPr>
+        <p:txBody>
+          <a:bodyPr wrap="square" lIns="0" tIns="0" rIns="0" bIns="0" rtlCol="0" anchor="ctr"/>
+          <a:lstStyle/>
+          <a:p>
+            <a:pPr indent="0" marL="0">
+              <a:buNone/>
+            </a:pPr>
+            <a:r>
+              <a:rPr lang="en-US" sz="1400" b="1" dirty="0">
+                <a:solidFill>
+                  <a:schemeClr val="tx1"/>
+                </a:solidFill>
+              </a:rPr>
+              <a:t>15 studies</a:t>
+            </a:r>
+            <a:endParaRPr lang="en-US" sz="1400" dirty="0"/>
+          </a:p>
+        </p:txBody>
+      </p:sp>
+      <p:sp>
+        <p:nvSpPr>
+          <p:cNvPr id="15" name="Text 13"/>
+          <p:cNvSpPr txBox="1"/>
+          <p:nvPr/>
+        </p:nvSpPr>
+        <p:spPr>
+          <a:xfrm>
+            <a:off x="548640" y="2148840"/>
+            <a:ext cx="1874520" cy="365760"/>
+          </a:xfrm>
+          <a:prstGeom prst="rect">
+            <a:avLst/>
+          </a:prstGeom>
+          <a:noFill/>
+          <a:ln/>
+        </p:spPr>
+        <p:txBody>
+          <a:bodyPr wrap="square" lIns="0" tIns="0" rIns="0" bIns="0" rtlCol="0" anchor="ctr"/>
+          <a:lstStyle/>
+          <a:p>
+            <a:pPr indent="0" marL="0">
+              <a:buNone/>
+            </a:pPr>
+            <a:r>
+              <a:rPr lang="en-US" sz="1400" dirty="0">
+                <a:solidFill>
+                  <a:schemeClr val="tx1"/>
+                </a:solidFill>
+              </a:rPr>
+              <a:t>Final dataset</a:t>
+            </a:r>
+            <a:endParaRPr lang="en-US" sz="1400" dirty="0"/>
+          </a:p>
+        </p:txBody>
+      </p:sp>
+      <p:sp>
+        <p:nvSpPr>
+          <p:cNvPr id="16" name="Final dataset bar"/>
+          <p:cNvSpPr/>
+          <p:nvPr/>
+        </p:nvSpPr>
+        <p:spPr>
+          <a:xfrm>
+            <a:off x="2514600" y="2185416"/>
+            <a:ext cx="2194560" cy="292608"/>
+          </a:xfrm>
+          <a:prstGeom prst="rect">
+            <a:avLst/>
+          </a:prstGeom>
+          <a:solidFill>
+            <a:srgbClr val="1F3A5F"/>
+          </a:solidFill>
+          <a:ln/>
+        </p:spPr>
+      </p:sp>
+      <p:sp>
+        <p:nvSpPr>
+          <p:cNvPr id="17" name="Text 15"/>
+          <p:cNvSpPr txBox="1"/>
+          <p:nvPr/>
+        </p:nvSpPr>
+        <p:spPr>
+          <a:xfrm>
+            <a:off x="4800600" y="2148840"/>
+            <a:ext cx="1280160" cy="365760"/>
+          </a:xfrm>
+          <a:prstGeom prst="rect">
+            <a:avLst/>
+          </a:prstGeom>
+          <a:noFill/>
+          <a:ln/>
+        </p:spPr>
+        <p:txBody>
+          <a:bodyPr wrap="square" lIns="0" tIns="0" rIns="0" bIns="0" rtlCol="0" anchor="ctr"/>
+          <a:lstStyle/>
+          <a:p>
+            <a:pPr indent="0" marL="0">
+              <a:buNone/>
+            </a:pPr>
+            <a:r>
+              <a:rPr lang="en-US" sz="1400" b="1" dirty="0">
+                <a:solidFill>
+                  <a:schemeClr val="tx2"/>
+                </a:solidFill>
+              </a:rPr>
+              <a:t>52 studies</a:t>
+            </a:r>
+            <a:endParaRPr lang="en-US" sz="1400" dirty="0"/>
+          </a:p>
+        </p:txBody>
+      </p:sp>
+      <p:sp>
+        <p:nvSpPr>
+          <p:cNvPr id="18" name="Text 16"/>
+          <p:cNvSpPr txBox="1"/>
+          <p:nvPr/>
+        </p:nvSpPr>
+        <p:spPr>
+          <a:xfrm>
+            <a:off x="548640" y="2788920"/>
+            <a:ext cx="5394960" cy="320040"/>
+          </a:xfrm>
+          <a:prstGeom prst="rect">
+            <a:avLst/>
+          </a:prstGeom>
+          <a:noFill/>
+          <a:ln/>
+        </p:spPr>
+        <p:txBody>
           <a:bodyPr wrap="square" lIns="0" tIns="0" rIns="0" bIns="0" rtlCol="0" anchor="t"/>
           <a:lstStyle/>
           <a:p>
@@ -16307,85 +16505,3081 @@
               <a:buNone/>
             </a:pPr>
             <a:r>
+              <a:rPr lang="en-US" sz="1700" b="1" dirty="0">
+                <a:solidFill>
+                  <a:schemeClr val="tx2"/>
+                </a:solidFill>
+              </a:rPr>
+              <a:t>Final dataset</a:t>
+            </a:r>
+            <a:endParaRPr lang="en-US" sz="1700" dirty="0"/>
+          </a:p>
+        </p:txBody>
+      </p:sp>
+      <p:graphicFrame>
+        <p:nvGraphicFramePr>
+          <p:cNvPr id="6" name="Table 0"/>
+          <p:cNvGraphicFramePr>
+            <a:graphicFrameLocks noGrp="1"/>
+          </p:cNvGraphicFramePr>
+          <p:nvPr>
+            <p:extLst>
+              <p:ext uri="{D42A27DB-BD31-4B8C-83A1-F6EECF244321}">
+                <p14:modId xmlns:p14="http://schemas.microsoft.com/office/powerpoint/2010/main" val="1579011935"/>
+              </p:ext>
+            </p:extLst>
+          </p:nvPr>
+        </p:nvGraphicFramePr>
+        <p:xfrm>
+          <a:off x="548640" y="3154680"/>
+          <a:ext cx="5394960" cy="914400"/>
+        </p:xfrm>
+        <a:graphic>
+          <a:graphicData uri="http://schemas.openxmlformats.org/drawingml/2006/table">
+            <a:tbl>
+              <a:tblPr/>
+              <a:tblGrid>
+                <a:gridCol w="1600200"/>
+                <a:gridCol w="3794760"/>
+              </a:tblGrid>
+              <a:tr h="0">
+                <a:tc>
+                  <a:txBody>
+                    <a:bodyPr/>
+                    <a:lstStyle/>
+                    <a:p>
+                      <a:pPr indent="0" marL="0">
+                        <a:buNone/>
+                      </a:pPr>
+                      <a:r>
+                        <a:rPr lang="en-US" sz="1300" b="1" dirty="0">
+                          <a:solidFill>
+                            <a:srgbClr val="1F3A5F"/>
+                          </a:solidFill>
+                          <a:latin typeface="Calibri" pitchFamily="34" charset="0"/>
+                          <a:ea typeface="Calibri" pitchFamily="34" charset="-122"/>
+                          <a:cs typeface="Calibri" pitchFamily="34" charset="-120"/>
+                        </a:rPr>
+                        <a:t>Published</a:t>
+                      </a:r>
+                      <a:endParaRPr lang="en-US" sz="1300" dirty="0">
+                        <a:latin typeface="Calibri" charset="0"/>
+                        <a:ea typeface="Calibri" charset="0"/>
+                        <a:cs typeface="Calibri" charset="0"/>
+                      </a:endParaRPr>
+                    </a:p>
+                  </a:txBody>
+                  <a:tcPr marL="0" marR="45720" marT="36576" marB="36576" anchor="t">
+                    <a:lnL w="0" cap="flat" cmpd="sng" algn="ctr">
+                      <a:noFill/>
+                    </a:lnL>
+                    <a:lnR w="0" cap="flat" cmpd="sng" algn="ctr">
+                      <a:noFill/>
+                    </a:lnR>
+                    <a:lnT w="0" cap="flat" cmpd="sng" algn="ctr">
+                      <a:noFill/>
+                    </a:lnT>
+                    <a:lnB w="9525" cap="flat" cmpd="sng" algn="ctr">
+                      <a:solidFill>
+                        <a:srgbClr val="E5E7EB"/>
+                      </a:solidFill>
+                      <a:prstDash val="solid"/>
+                      <a:round/>
+                      <a:headEnd type="none" w="med" len="med"/>
+                      <a:tailEnd type="none" w="med" len="med"/>
+                    </a:lnB>
+                  </a:tcPr>
+                </a:tc>
+                <a:tc>
+                  <a:txBody>
+                    <a:bodyPr/>
+                    <a:lstStyle/>
+                    <a:p>
+                      <a:pPr indent="0" marL="0">
+                        <a:buNone/>
+                      </a:pPr>
+                      <a:r>
+                        <a:rPr lang="en-US" sz="1300" dirty="0">
+                          <a:solidFill>
+                            <a:srgbClr val="1A1A1A"/>
+                          </a:solidFill>
+                          <a:latin typeface="Calibri" pitchFamily="34" charset="0"/>
+                          <a:ea typeface="Calibri" pitchFamily="34" charset="-122"/>
+                          <a:cs typeface="Calibri" pitchFamily="34" charset="-120"/>
+                        </a:rPr>
+                        <a:t>1992 to 2026</a:t>
+                      </a:r>
+                      <a:endParaRPr lang="en-US" sz="1300" dirty="0">
+                        <a:latin typeface="Calibri" charset="0"/>
+                        <a:ea typeface="Calibri" charset="0"/>
+                        <a:cs typeface="Calibri" charset="0"/>
+                      </a:endParaRPr>
+                    </a:p>
+                  </a:txBody>
+                  <a:tcPr marL="0" marR="45720" marT="36576" marB="36576" anchor="t">
+                    <a:lnL w="0" cap="flat" cmpd="sng" algn="ctr">
+                      <a:noFill/>
+                    </a:lnL>
+                    <a:lnR w="0" cap="flat" cmpd="sng" algn="ctr">
+                      <a:noFill/>
+                    </a:lnR>
+                    <a:lnT w="0" cap="flat" cmpd="sng" algn="ctr">
+                      <a:noFill/>
+                    </a:lnT>
+                    <a:lnB w="9525" cap="flat" cmpd="sng" algn="ctr">
+                      <a:solidFill>
+                        <a:srgbClr val="E5E7EB"/>
+                      </a:solidFill>
+                      <a:prstDash val="solid"/>
+                      <a:round/>
+                      <a:headEnd type="none" w="med" len="med"/>
+                      <a:tailEnd type="none" w="med" len="med"/>
+                    </a:lnB>
+                  </a:tcPr>
+                </a:tc>
+              </a:tr>
+              <a:tr h="0">
+                <a:tc>
+                  <a:txBody>
+                    <a:bodyPr/>
+                    <a:lstStyle/>
+                    <a:p>
+                      <a:pPr indent="0" marL="0">
+                        <a:buNone/>
+                      </a:pPr>
+                      <a:r>
+                        <a:rPr lang="en-US" sz="1300" b="1" dirty="0">
+                          <a:solidFill>
+                            <a:srgbClr val="1F3A5F"/>
+                          </a:solidFill>
+                          <a:latin typeface="Calibri" pitchFamily="34" charset="0"/>
+                          <a:ea typeface="Calibri" pitchFamily="34" charset="-122"/>
+                          <a:cs typeface="Calibri" pitchFamily="34" charset="-120"/>
+                        </a:rPr>
+                        <a:t>Unloading</a:t>
+                      </a:r>
+                      <a:endParaRPr lang="en-US" sz="1300" dirty="0">
+                        <a:latin typeface="Calibri" charset="0"/>
+                        <a:ea typeface="Calibri" charset="0"/>
+                        <a:cs typeface="Calibri" charset="0"/>
+                      </a:endParaRPr>
+                    </a:p>
+                  </a:txBody>
+                  <a:tcPr marL="0" marR="45720" marT="36576" marB="36576" anchor="t">
+                    <a:lnL w="0" cap="flat" cmpd="sng" algn="ctr">
+                      <a:noFill/>
+                    </a:lnL>
+                    <a:lnR w="0" cap="flat" cmpd="sng" algn="ctr">
+                      <a:noFill/>
+                    </a:lnR>
+                    <a:lnT w="0" cap="flat" cmpd="sng" algn="ctr">
+                      <a:noFill/>
+                    </a:lnT>
+                    <a:lnB w="9525" cap="flat" cmpd="sng" algn="ctr">
+                      <a:solidFill>
+                        <a:srgbClr val="E5E7EB"/>
+                      </a:solidFill>
+                      <a:prstDash val="solid"/>
+                      <a:round/>
+                      <a:headEnd type="none" w="med" len="med"/>
+                      <a:tailEnd type="none" w="med" len="med"/>
+                    </a:lnB>
+                  </a:tcPr>
+                </a:tc>
+                <a:tc>
+                  <a:txBody>
+                    <a:bodyPr/>
+                    <a:lstStyle/>
+                    <a:p>
+                      <a:pPr indent="0" marL="0">
+                        <a:buNone/>
+                      </a:pPr>
+                      <a:r>
+                        <a:rPr lang="en-US" sz="1300" dirty="0">
+                          <a:solidFill>
+                            <a:srgbClr val="1A1A1A"/>
+                          </a:solidFill>
+                          <a:latin typeface="Calibri" pitchFamily="34" charset="0"/>
+                          <a:ea typeface="Calibri" pitchFamily="34" charset="-122"/>
+                          <a:cs typeface="Calibri" pitchFamily="34" charset="-120"/>
+                        </a:rPr>
+                        <a:t>5 to 119 days on the ground; 180 days in spaceflight</a:t>
+                      </a:r>
+                      <a:endParaRPr lang="en-US" sz="1300" dirty="0">
+                        <a:latin typeface="Calibri" charset="0"/>
+                        <a:ea typeface="Calibri" charset="0"/>
+                        <a:cs typeface="Calibri" charset="0"/>
+                      </a:endParaRPr>
+                    </a:p>
+                  </a:txBody>
+                  <a:tcPr marL="0" marR="45720" marT="36576" marB="36576" anchor="t">
+                    <a:lnL w="0" cap="flat" cmpd="sng" algn="ctr">
+                      <a:noFill/>
+                    </a:lnL>
+                    <a:lnR w="0" cap="flat" cmpd="sng" algn="ctr">
+                      <a:noFill/>
+                    </a:lnR>
+                    <a:lnT w="0" cap="flat" cmpd="sng" algn="ctr">
+                      <a:noFill/>
+                    </a:lnT>
+                    <a:lnB w="9525" cap="flat" cmpd="sng" algn="ctr">
+                      <a:solidFill>
+                        <a:srgbClr val="E5E7EB"/>
+                      </a:solidFill>
+                      <a:prstDash val="solid"/>
+                      <a:round/>
+                      <a:headEnd type="none" w="med" len="med"/>
+                      <a:tailEnd type="none" w="med" len="med"/>
+                    </a:lnB>
+                  </a:tcPr>
+                </a:tc>
+              </a:tr>
+              <a:tr h="0">
+                <a:tc>
+                  <a:txBody>
+                    <a:bodyPr/>
+                    <a:lstStyle/>
+                    <a:p>
+                      <a:pPr indent="0" marL="0">
+                        <a:buNone/>
+                      </a:pPr>
+                      <a:r>
+                        <a:rPr lang="en-US" sz="1300" b="1" dirty="0">
+                          <a:solidFill>
+                            <a:srgbClr val="1F3A5F"/>
+                          </a:solidFill>
+                          <a:latin typeface="Calibri" pitchFamily="34" charset="0"/>
+                          <a:ea typeface="Calibri" pitchFamily="34" charset="-122"/>
+                          <a:cs typeface="Calibri" pitchFamily="34" charset="-120"/>
+                        </a:rPr>
+                        <a:t>Campaigns</a:t>
+                      </a:r>
+                      <a:endParaRPr lang="en-US" sz="1300" dirty="0">
+                        <a:latin typeface="Calibri" charset="0"/>
+                        <a:ea typeface="Calibri" charset="0"/>
+                        <a:cs typeface="Calibri" charset="0"/>
+                      </a:endParaRPr>
+                    </a:p>
+                  </a:txBody>
+                  <a:tcPr marL="0" marR="45720" marT="36576" marB="36576" anchor="t">
+                    <a:lnL w="0" cap="flat" cmpd="sng" algn="ctr">
+                      <a:noFill/>
+                    </a:lnL>
+                    <a:lnR w="0" cap="flat" cmpd="sng" algn="ctr">
+                      <a:noFill/>
+                    </a:lnR>
+                    <a:lnT w="0" cap="flat" cmpd="sng" algn="ctr">
+                      <a:noFill/>
+                    </a:lnT>
+                    <a:lnB w="9525" cap="flat" cmpd="sng" algn="ctr">
+                      <a:solidFill>
+                        <a:srgbClr val="E5E7EB"/>
+                      </a:solidFill>
+                      <a:prstDash val="solid"/>
+                      <a:round/>
+                      <a:headEnd type="none" w="med" len="med"/>
+                      <a:tailEnd type="none" w="med" len="med"/>
+                    </a:lnB>
+                  </a:tcPr>
+                </a:tc>
+                <a:tc>
+                  <a:txBody>
+                    <a:bodyPr/>
+                    <a:lstStyle/>
+                    <a:p>
+                      <a:pPr indent="0" marL="0">
+                        <a:buNone/>
+                      </a:pPr>
+                      <a:r>
+                        <a:rPr lang="en-US" sz="1300" dirty="0">
+                          <a:solidFill>
+                            <a:srgbClr val="1A1A1A"/>
+                          </a:solidFill>
+                          <a:latin typeface="Calibri" pitchFamily="34" charset="0"/>
+                          <a:ea typeface="Calibri" pitchFamily="34" charset="-122"/>
+                          <a:cs typeface="Calibri" pitchFamily="34" charset="-120"/>
+                        </a:rPr>
+                        <a:t>36 independent campaigns (one campaign can yield several papers)</a:t>
+                      </a:r>
+                      <a:endParaRPr lang="en-US" sz="1300" dirty="0">
+                        <a:latin typeface="Calibri" charset="0"/>
+                        <a:ea typeface="Calibri" charset="0"/>
+                        <a:cs typeface="Calibri" charset="0"/>
+                      </a:endParaRPr>
+                    </a:p>
+                  </a:txBody>
+                  <a:tcPr marL="0" marR="45720" marT="36576" marB="36576" anchor="t">
+                    <a:lnL w="0" cap="flat" cmpd="sng" algn="ctr">
+                      <a:noFill/>
+                    </a:lnL>
+                    <a:lnR w="0" cap="flat" cmpd="sng" algn="ctr">
+                      <a:noFill/>
+                    </a:lnR>
+                    <a:lnT w="0" cap="flat" cmpd="sng" algn="ctr">
+                      <a:noFill/>
+                    </a:lnT>
+                    <a:lnB w="9525" cap="flat" cmpd="sng" algn="ctr">
+                      <a:solidFill>
+                        <a:srgbClr val="E5E7EB"/>
+                      </a:solidFill>
+                      <a:prstDash val="solid"/>
+                      <a:round/>
+                      <a:headEnd type="none" w="med" len="med"/>
+                      <a:tailEnd type="none" w="med" len="med"/>
+                    </a:lnB>
+                  </a:tcPr>
+                </a:tc>
+              </a:tr>
+              <a:tr h="0">
+                <a:tc>
+                  <a:txBody>
+                    <a:bodyPr/>
+                    <a:lstStyle/>
+                    <a:p>
+                      <a:pPr indent="0" marL="0">
+                        <a:buNone/>
+                      </a:pPr>
+                      <a:r>
+                        <a:rPr lang="en-US" sz="1300" b="1" dirty="0">
+                          <a:solidFill>
+                            <a:srgbClr val="1F3A5F"/>
+                          </a:solidFill>
+                          <a:latin typeface="Calibri" pitchFamily="34" charset="0"/>
+                          <a:ea typeface="Calibri" pitchFamily="34" charset="-122"/>
+                          <a:cs typeface="Calibri" pitchFamily="34" charset="-120"/>
+                        </a:rPr>
+                        <a:t>Measurements</a:t>
+                      </a:r>
+                      <a:endParaRPr lang="en-US" sz="1300" dirty="0">
+                        <a:latin typeface="Calibri" charset="0"/>
+                        <a:ea typeface="Calibri" charset="0"/>
+                        <a:cs typeface="Calibri" charset="0"/>
+                      </a:endParaRPr>
+                    </a:p>
+                  </a:txBody>
+                  <a:tcPr marL="0" marR="45720" marT="36576" marB="36576" anchor="t">
+                    <a:lnL w="0" cap="flat" cmpd="sng" algn="ctr">
+                      <a:noFill/>
+                    </a:lnL>
+                    <a:lnR w="0" cap="flat" cmpd="sng" algn="ctr">
+                      <a:noFill/>
+                    </a:lnR>
+                    <a:lnT w="0" cap="flat" cmpd="sng" algn="ctr">
+                      <a:noFill/>
+                    </a:lnT>
+                    <a:lnB w="9525" cap="flat" cmpd="sng" algn="ctr">
+                      <a:solidFill>
+                        <a:srgbClr val="E5E7EB"/>
+                      </a:solidFill>
+                      <a:prstDash val="solid"/>
+                      <a:round/>
+                      <a:headEnd type="none" w="med" len="med"/>
+                      <a:tailEnd type="none" w="med" len="med"/>
+                    </a:lnB>
+                  </a:tcPr>
+                </a:tc>
+                <a:tc>
+                  <a:txBody>
+                    <a:bodyPr/>
+                    <a:lstStyle/>
+                    <a:p>
+                      <a:pPr indent="0" marL="0">
+                        <a:buNone/>
+                      </a:pPr>
+                      <a:r>
+                        <a:rPr lang="en-US" sz="1300" dirty="0">
+                          <a:solidFill>
+                            <a:srgbClr val="1A1A1A"/>
+                          </a:solidFill>
+                          <a:latin typeface="Calibri" pitchFamily="34" charset="0"/>
+                          <a:ea typeface="Calibri" pitchFamily="34" charset="-122"/>
+                          <a:cs typeface="Calibri" pitchFamily="34" charset="-120"/>
+                        </a:rPr>
+                        <a:t>742 (one per study, group, muscle and scan day)</a:t>
+                      </a:r>
+                      <a:endParaRPr lang="en-US" sz="1300" dirty="0">
+                        <a:latin typeface="Calibri" charset="0"/>
+                        <a:ea typeface="Calibri" charset="0"/>
+                        <a:cs typeface="Calibri" charset="0"/>
+                      </a:endParaRPr>
+                    </a:p>
+                  </a:txBody>
+                  <a:tcPr marL="0" marR="45720" marT="36576" marB="36576" anchor="t">
+                    <a:lnL w="0" cap="flat" cmpd="sng" algn="ctr">
+                      <a:noFill/>
+                    </a:lnL>
+                    <a:lnR w="0" cap="flat" cmpd="sng" algn="ctr">
+                      <a:noFill/>
+                    </a:lnR>
+                    <a:lnT w="0" cap="flat" cmpd="sng" algn="ctr">
+                      <a:noFill/>
+                    </a:lnT>
+                    <a:lnB w="9525" cap="flat" cmpd="sng" algn="ctr">
+                      <a:solidFill>
+                        <a:srgbClr val="E5E7EB"/>
+                      </a:solidFill>
+                      <a:prstDash val="solid"/>
+                      <a:round/>
+                      <a:headEnd type="none" w="med" len="med"/>
+                      <a:tailEnd type="none" w="med" len="med"/>
+                    </a:lnB>
+                  </a:tcPr>
+                </a:tc>
+              </a:tr>
+              <a:tr h="0">
+                <a:tc>
+                  <a:txBody>
+                    <a:bodyPr/>
+                    <a:lstStyle/>
+                    <a:p>
+                      <a:pPr indent="0" marL="0">
+                        <a:buNone/>
+                      </a:pPr>
+                      <a:r>
+                        <a:rPr lang="en-US" sz="1300" b="1" dirty="0">
+                          <a:solidFill>
+                            <a:srgbClr val="1F3A5F"/>
+                          </a:solidFill>
+                          <a:latin typeface="Calibri" pitchFamily="34" charset="0"/>
+                          <a:ea typeface="Calibri" pitchFamily="34" charset="-122"/>
+                          <a:cs typeface="Calibri" pitchFamily="34" charset="-120"/>
+                        </a:rPr>
+                        <a:t>Designs</a:t>
+                      </a:r>
+                      <a:endParaRPr lang="en-US" sz="1300" dirty="0">
+                        <a:latin typeface="Calibri" charset="0"/>
+                        <a:ea typeface="Calibri" charset="0"/>
+                        <a:cs typeface="Calibri" charset="0"/>
+                      </a:endParaRPr>
+                    </a:p>
+                  </a:txBody>
+                  <a:tcPr marL="0" marR="45720" marT="36576" marB="36576" anchor="t">
+                    <a:lnL w="0" cap="flat" cmpd="sng" algn="ctr">
+                      <a:noFill/>
+                    </a:lnL>
+                    <a:lnR w="0" cap="flat" cmpd="sng" algn="ctr">
+                      <a:noFill/>
+                    </a:lnR>
+                    <a:lnT w="0" cap="flat" cmpd="sng" algn="ctr">
+                      <a:noFill/>
+                    </a:lnT>
+                    <a:lnB w="9525" cap="flat" cmpd="sng" algn="ctr">
+                      <a:solidFill>
+                        <a:srgbClr val="E5E7EB"/>
+                      </a:solidFill>
+                      <a:prstDash val="solid"/>
+                      <a:round/>
+                      <a:headEnd type="none" w="med" len="med"/>
+                      <a:tailEnd type="none" w="med" len="med"/>
+                    </a:lnB>
+                  </a:tcPr>
+                </a:tc>
+                <a:tc>
+                  <a:txBody>
+                    <a:bodyPr/>
+                    <a:lstStyle/>
+                    <a:p>
+                      <a:pPr indent="0" marL="0">
+                        <a:buNone/>
+                      </a:pPr>
+                      <a:r>
+                        <a:rPr lang="en-US" sz="1300" dirty="0">
+                          <a:solidFill>
+                            <a:srgbClr val="1A1A1A"/>
+                          </a:solidFill>
+                          <a:latin typeface="Calibri" pitchFamily="34" charset="0"/>
+                          <a:ea typeface="Calibri" pitchFamily="34" charset="-122"/>
+                          <a:cs typeface="Calibri" pitchFamily="34" charset="-120"/>
+                        </a:rPr>
+                        <a:t>bed rest 46 studies (head-down 27, horizontal 19), spaceflight 3, limb suspension 2, dry immersion 1</a:t>
+                      </a:r>
+                      <a:endParaRPr lang="en-US" sz="1300" dirty="0">
+                        <a:latin typeface="Calibri" charset="0"/>
+                        <a:ea typeface="Calibri" charset="0"/>
+                        <a:cs typeface="Calibri" charset="0"/>
+                      </a:endParaRPr>
+                    </a:p>
+                  </a:txBody>
+                  <a:tcPr marL="0" marR="45720" marT="36576" marB="36576" anchor="t">
+                    <a:lnL w="0" cap="flat" cmpd="sng" algn="ctr">
+                      <a:noFill/>
+                    </a:lnL>
+                    <a:lnR w="0" cap="flat" cmpd="sng" algn="ctr">
+                      <a:noFill/>
+                    </a:lnR>
+                    <a:lnT w="0" cap="flat" cmpd="sng" algn="ctr">
+                      <a:noFill/>
+                    </a:lnT>
+                    <a:lnB w="9525" cap="flat" cmpd="sng" algn="ctr">
+                      <a:solidFill>
+                        <a:srgbClr val="E5E7EB"/>
+                      </a:solidFill>
+                      <a:prstDash val="solid"/>
+                      <a:round/>
+                      <a:headEnd type="none" w="med" len="med"/>
+                      <a:tailEnd type="none" w="med" len="med"/>
+                    </a:lnB>
+                  </a:tcPr>
+                </a:tc>
+              </a:tr>
+              <a:tr h="0">
+                <a:tc>
+                  <a:txBody>
+                    <a:bodyPr/>
+                    <a:lstStyle/>
+                    <a:p>
+                      <a:pPr indent="0" marL="0">
+                        <a:buNone/>
+                      </a:pPr>
+                      <a:r>
+                        <a:rPr lang="en-US" sz="1300" b="1" dirty="0">
+                          <a:solidFill>
+                            <a:srgbClr val="1F3A5F"/>
+                          </a:solidFill>
+                          <a:latin typeface="Calibri" pitchFamily="34" charset="0"/>
+                          <a:ea typeface="Calibri" pitchFamily="34" charset="-122"/>
+                          <a:cs typeface="Calibri" pitchFamily="34" charset="-120"/>
+                        </a:rPr>
+                        <a:t>Imaging</a:t>
+                      </a:r>
+                      <a:endParaRPr lang="en-US" sz="1300" dirty="0">
+                        <a:latin typeface="Calibri" charset="0"/>
+                        <a:ea typeface="Calibri" charset="0"/>
+                        <a:cs typeface="Calibri" charset="0"/>
+                      </a:endParaRPr>
+                    </a:p>
+                  </a:txBody>
+                  <a:tcPr marL="0" marR="45720" marT="36576" marB="36576" anchor="t">
+                    <a:lnL w="0" cap="flat" cmpd="sng" algn="ctr">
+                      <a:noFill/>
+                    </a:lnL>
+                    <a:lnR w="0" cap="flat" cmpd="sng" algn="ctr">
+                      <a:noFill/>
+                    </a:lnR>
+                    <a:lnT w="0" cap="flat" cmpd="sng" algn="ctr">
+                      <a:noFill/>
+                    </a:lnT>
+                    <a:lnB w="9525" cap="flat" cmpd="sng" algn="ctr">
+                      <a:solidFill>
+                        <a:srgbClr val="E5E7EB"/>
+                      </a:solidFill>
+                      <a:prstDash val="solid"/>
+                      <a:round/>
+                      <a:headEnd type="none" w="med" len="med"/>
+                      <a:tailEnd type="none" w="med" len="med"/>
+                    </a:lnB>
+                  </a:tcPr>
+                </a:tc>
+                <a:tc>
+                  <a:txBody>
+                    <a:bodyPr/>
+                    <a:lstStyle/>
+                    <a:p>
+                      <a:pPr indent="0" marL="0">
+                        <a:buNone/>
+                      </a:pPr>
+                      <a:r>
+                        <a:rPr lang="en-US" sz="1300" dirty="0">
+                          <a:solidFill>
+                            <a:srgbClr val="1A1A1A"/>
+                          </a:solidFill>
+                          <a:latin typeface="Calibri" pitchFamily="34" charset="0"/>
+                          <a:ea typeface="Calibri" pitchFamily="34" charset="-122"/>
+                          <a:cs typeface="Calibri" pitchFamily="34" charset="-120"/>
+                        </a:rPr>
+                        <a:t>MRI, CT, DXA and ultrasound</a:t>
+                      </a:r>
+                      <a:endParaRPr lang="en-US" sz="1300" dirty="0">
+                        <a:latin typeface="Calibri" charset="0"/>
+                        <a:ea typeface="Calibri" charset="0"/>
+                        <a:cs typeface="Calibri" charset="0"/>
+                      </a:endParaRPr>
+                    </a:p>
+                  </a:txBody>
+                  <a:tcPr marL="0" marR="45720" marT="36576" marB="36576" anchor="t">
+                    <a:lnL w="0" cap="flat" cmpd="sng" algn="ctr">
+                      <a:noFill/>
+                    </a:lnL>
+                    <a:lnR w="0" cap="flat" cmpd="sng" algn="ctr">
+                      <a:noFill/>
+                    </a:lnR>
+                    <a:lnT w="0" cap="flat" cmpd="sng" algn="ctr">
+                      <a:noFill/>
+                    </a:lnT>
+                    <a:lnB w="9525" cap="flat" cmpd="sng" algn="ctr">
+                      <a:solidFill>
+                        <a:srgbClr val="E5E7EB"/>
+                      </a:solidFill>
+                      <a:prstDash val="solid"/>
+                      <a:round/>
+                      <a:headEnd type="none" w="med" len="med"/>
+                      <a:tailEnd type="none" w="med" len="med"/>
+                    </a:lnB>
+                  </a:tcPr>
+                </a:tc>
+              </a:tr>
+            </a:tbl>
+          </a:graphicData>
+        </a:graphic>
+      </p:graphicFrame>
+      <p:sp>
+        <p:nvSpPr>
+          <p:cNvPr id="20" name="Range panel"/>
+          <p:cNvSpPr/>
+          <p:nvPr/>
+        </p:nvSpPr>
+        <p:spPr>
+          <a:xfrm>
+            <a:off x="6355080" y="1188720"/>
+            <a:ext cx="5285232" cy="4937760"/>
+          </a:xfrm>
+          <a:prstGeom prst="rect">
+            <a:avLst/>
+          </a:prstGeom>
+          <a:solidFill>
+            <a:schemeClr val="bg2"/>
+          </a:solidFill>
+          <a:ln/>
+        </p:spPr>
+      </p:sp>
+      <p:sp>
+        <p:nvSpPr>
+          <p:cNvPr id="21" name="Text 18"/>
+          <p:cNvSpPr txBox="1"/>
+          <p:nvPr/>
+        </p:nvSpPr>
+        <p:spPr>
+          <a:xfrm>
+            <a:off x="6537960" y="1280160"/>
+            <a:ext cx="4919472" cy="292608"/>
+          </a:xfrm>
+          <a:prstGeom prst="rect">
+            <a:avLst/>
+          </a:prstGeom>
+          <a:noFill/>
+          <a:ln/>
+        </p:spPr>
+        <p:txBody>
+          <a:bodyPr wrap="square" lIns="0" tIns="0" rIns="0" bIns="0" rtlCol="0" anchor="t"/>
+          <a:lstStyle/>
+          <a:p>
+            <a:pPr indent="0" marL="0">
+              <a:buNone/>
+            </a:pPr>
+            <a:r>
               <a:rPr lang="en-US" sz="1400" b="1" dirty="0">
                 <a:solidFill>
+                  <a:schemeClr val="tx2"/>
+                </a:solidFill>
+              </a:rPr>
+              <a:t>Each dot is one study</a:t>
+            </a:r>
+            <a:endParaRPr lang="en-US" sz="1400" dirty="0"/>
+          </a:p>
+        </p:txBody>
+      </p:sp>
+      <p:sp>
+        <p:nvSpPr>
+          <p:cNvPr id="22" name="Grid 0"/>
+          <p:cNvSpPr/>
+          <p:nvPr/>
+        </p:nvSpPr>
+        <p:spPr>
+          <a:xfrm>
+            <a:off x="7086600" y="4983480"/>
+            <a:ext cx="4343400" cy="0"/>
+          </a:xfrm>
+          <a:prstGeom prst="line">
+            <a:avLst/>
+          </a:prstGeom>
+          <a:noFill/>
+          <a:ln w="9525">
+            <a:solidFill>
+              <a:srgbClr val="6B7280"/>
+            </a:solidFill>
+            <a:prstDash val="solid"/>
+          </a:ln>
+        </p:spPr>
+      </p:sp>
+      <p:sp>
+        <p:nvSpPr>
+          <p:cNvPr id="23" name="Text 20"/>
+          <p:cNvSpPr txBox="1"/>
+          <p:nvPr/>
+        </p:nvSpPr>
+        <p:spPr>
+          <a:xfrm>
+            <a:off x="6629400" y="4882896"/>
+            <a:ext cx="384048" cy="201168"/>
+          </a:xfrm>
+          <a:prstGeom prst="rect">
+            <a:avLst/>
+          </a:prstGeom>
+          <a:noFill/>
+          <a:ln/>
+        </p:spPr>
+        <p:txBody>
+          <a:bodyPr wrap="square" lIns="0" tIns="0" rIns="0" bIns="0" rtlCol="0" anchor="t"/>
+          <a:lstStyle/>
+          <a:p>
+            <a:pPr algn="r" indent="0" marL="0">
+              <a:buNone/>
+            </a:pPr>
+            <a:r>
+              <a:rPr lang="en-US" sz="1000" dirty="0">
+                <a:solidFill>
                   <a:schemeClr val="accent3"/>
                 </a:solidFill>
               </a:rPr>
-              <a:t>PLACEHOLDER: content by Niloufar</a:t>
-            </a:r>
-            <a:endParaRPr lang="en-US" sz="1400" dirty="0"/>
-          </a:p>
+              <a:t>0</a:t>
+            </a:r>
+            <a:endParaRPr lang="en-US" sz="1000" dirty="0"/>
+          </a:p>
+        </p:txBody>
+      </p:sp>
+      <p:sp>
+        <p:nvSpPr>
+          <p:cNvPr id="24" name="Grid 30"/>
+          <p:cNvSpPr/>
+          <p:nvPr/>
+        </p:nvSpPr>
+        <p:spPr>
+          <a:xfrm>
+            <a:off x="7086600" y="4514248"/>
+            <a:ext cx="4343400" cy="0"/>
+          </a:xfrm>
+          <a:prstGeom prst="line">
+            <a:avLst/>
+          </a:prstGeom>
+          <a:noFill/>
+          <a:ln w="9525">
+            <a:solidFill>
+              <a:srgbClr val="E5E7EB"/>
+            </a:solidFill>
+            <a:prstDash val="solid"/>
+          </a:ln>
+        </p:spPr>
+      </p:sp>
+      <p:sp>
+        <p:nvSpPr>
+          <p:cNvPr id="25" name="Text 22"/>
+          <p:cNvSpPr txBox="1"/>
+          <p:nvPr/>
+        </p:nvSpPr>
+        <p:spPr>
+          <a:xfrm>
+            <a:off x="6629400" y="4413664"/>
+            <a:ext cx="384048" cy="201168"/>
+          </a:xfrm>
+          <a:prstGeom prst="rect">
+            <a:avLst/>
+          </a:prstGeom>
+          <a:noFill/>
+          <a:ln/>
+        </p:spPr>
+        <p:txBody>
+          <a:bodyPr wrap="square" lIns="0" tIns="0" rIns="0" bIns="0" rtlCol="0" anchor="t"/>
+          <a:lstStyle/>
+          <a:p>
+            <a:pPr algn="r" indent="0" marL="0">
+              <a:buNone/>
+            </a:pPr>
+            <a:r>
+              <a:rPr lang="en-US" sz="1000" dirty="0">
+                <a:solidFill>
+                  <a:schemeClr val="accent3"/>
+                </a:solidFill>
+              </a:rPr>
+              <a:t>30</a:t>
+            </a:r>
+            <a:endParaRPr lang="en-US" sz="1000" dirty="0"/>
+          </a:p>
+        </p:txBody>
+      </p:sp>
+      <p:sp>
+        <p:nvSpPr>
+          <p:cNvPr id="26" name="Grid 60"/>
+          <p:cNvSpPr/>
+          <p:nvPr/>
+        </p:nvSpPr>
+        <p:spPr>
+          <a:xfrm>
+            <a:off x="7086600" y="4045017"/>
+            <a:ext cx="4343400" cy="0"/>
+          </a:xfrm>
+          <a:prstGeom prst="line">
+            <a:avLst/>
+          </a:prstGeom>
+          <a:noFill/>
+          <a:ln w="9525">
+            <a:solidFill>
+              <a:srgbClr val="E5E7EB"/>
+            </a:solidFill>
+            <a:prstDash val="solid"/>
+          </a:ln>
+        </p:spPr>
+      </p:sp>
+      <p:sp>
+        <p:nvSpPr>
+          <p:cNvPr id="27" name="Text 24"/>
+          <p:cNvSpPr txBox="1"/>
+          <p:nvPr/>
+        </p:nvSpPr>
+        <p:spPr>
+          <a:xfrm>
+            <a:off x="6629400" y="3944433"/>
+            <a:ext cx="384048" cy="201168"/>
+          </a:xfrm>
+          <a:prstGeom prst="rect">
+            <a:avLst/>
+          </a:prstGeom>
+          <a:noFill/>
+          <a:ln/>
+        </p:spPr>
+        <p:txBody>
+          <a:bodyPr wrap="square" lIns="0" tIns="0" rIns="0" bIns="0" rtlCol="0" anchor="t"/>
+          <a:lstStyle/>
+          <a:p>
+            <a:pPr algn="r" indent="0" marL="0">
+              <a:buNone/>
+            </a:pPr>
+            <a:r>
+              <a:rPr lang="en-US" sz="1000" dirty="0">
+                <a:solidFill>
+                  <a:schemeClr val="accent3"/>
+                </a:solidFill>
+              </a:rPr>
+              <a:t>60</a:t>
+            </a:r>
+            <a:endParaRPr lang="en-US" sz="1000" dirty="0"/>
+          </a:p>
+        </p:txBody>
+      </p:sp>
+      <p:sp>
+        <p:nvSpPr>
+          <p:cNvPr id="28" name="Grid 90"/>
+          <p:cNvSpPr/>
+          <p:nvPr/>
+        </p:nvSpPr>
+        <p:spPr>
+          <a:xfrm>
+            <a:off x="7086600" y="3575785"/>
+            <a:ext cx="4343400" cy="0"/>
+          </a:xfrm>
+          <a:prstGeom prst="line">
+            <a:avLst/>
+          </a:prstGeom>
+          <a:noFill/>
+          <a:ln w="9525">
+            <a:solidFill>
+              <a:srgbClr val="E5E7EB"/>
+            </a:solidFill>
+            <a:prstDash val="solid"/>
+          </a:ln>
+        </p:spPr>
+      </p:sp>
+      <p:sp>
+        <p:nvSpPr>
+          <p:cNvPr id="29" name="Text 26"/>
+          <p:cNvSpPr txBox="1"/>
+          <p:nvPr/>
+        </p:nvSpPr>
+        <p:spPr>
+          <a:xfrm>
+            <a:off x="6629400" y="3475201"/>
+            <a:ext cx="384048" cy="201168"/>
+          </a:xfrm>
+          <a:prstGeom prst="rect">
+            <a:avLst/>
+          </a:prstGeom>
+          <a:noFill/>
+          <a:ln/>
+        </p:spPr>
+        <p:txBody>
+          <a:bodyPr wrap="square" lIns="0" tIns="0" rIns="0" bIns="0" rtlCol="0" anchor="t"/>
+          <a:lstStyle/>
+          <a:p>
+            <a:pPr algn="r" indent="0" marL="0">
+              <a:buNone/>
+            </a:pPr>
+            <a:r>
+              <a:rPr lang="en-US" sz="1000" dirty="0">
+                <a:solidFill>
+                  <a:schemeClr val="accent3"/>
+                </a:solidFill>
+              </a:rPr>
+              <a:t>90</a:t>
+            </a:r>
+            <a:endParaRPr lang="en-US" sz="1000" dirty="0"/>
+          </a:p>
+        </p:txBody>
+      </p:sp>
+      <p:sp>
+        <p:nvSpPr>
+          <p:cNvPr id="30" name="Grid 120"/>
+          <p:cNvSpPr/>
+          <p:nvPr/>
+        </p:nvSpPr>
+        <p:spPr>
+          <a:xfrm>
+            <a:off x="7086600" y="3106554"/>
+            <a:ext cx="4343400" cy="0"/>
+          </a:xfrm>
+          <a:prstGeom prst="line">
+            <a:avLst/>
+          </a:prstGeom>
+          <a:noFill/>
+          <a:ln w="9525">
+            <a:solidFill>
+              <a:srgbClr val="E5E7EB"/>
+            </a:solidFill>
+            <a:prstDash val="solid"/>
+          </a:ln>
+        </p:spPr>
+      </p:sp>
+      <p:sp>
+        <p:nvSpPr>
+          <p:cNvPr id="31" name="Text 28"/>
+          <p:cNvSpPr txBox="1"/>
+          <p:nvPr/>
+        </p:nvSpPr>
+        <p:spPr>
+          <a:xfrm>
+            <a:off x="6629400" y="3005970"/>
+            <a:ext cx="384048" cy="201168"/>
+          </a:xfrm>
+          <a:prstGeom prst="rect">
+            <a:avLst/>
+          </a:prstGeom>
+          <a:noFill/>
+          <a:ln/>
+        </p:spPr>
+        <p:txBody>
+          <a:bodyPr wrap="square" lIns="0" tIns="0" rIns="0" bIns="0" rtlCol="0" anchor="t"/>
+          <a:lstStyle/>
+          <a:p>
+            <a:pPr algn="r" indent="0" marL="0">
+              <a:buNone/>
+            </a:pPr>
+            <a:r>
+              <a:rPr lang="en-US" sz="1000" dirty="0">
+                <a:solidFill>
+                  <a:schemeClr val="accent3"/>
+                </a:solidFill>
+              </a:rPr>
+              <a:t>120</a:t>
+            </a:r>
+            <a:endParaRPr lang="en-US" sz="1000" dirty="0"/>
+          </a:p>
+        </p:txBody>
+      </p:sp>
+      <p:sp>
+        <p:nvSpPr>
+          <p:cNvPr id="32" name="Grid 150"/>
+          <p:cNvSpPr/>
+          <p:nvPr/>
+        </p:nvSpPr>
+        <p:spPr>
+          <a:xfrm>
+            <a:off x="7086600" y="2637322"/>
+            <a:ext cx="4343400" cy="0"/>
+          </a:xfrm>
+          <a:prstGeom prst="line">
+            <a:avLst/>
+          </a:prstGeom>
+          <a:noFill/>
+          <a:ln w="9525">
+            <a:solidFill>
+              <a:srgbClr val="E5E7EB"/>
+            </a:solidFill>
+            <a:prstDash val="solid"/>
+          </a:ln>
+        </p:spPr>
+      </p:sp>
+      <p:sp>
+        <p:nvSpPr>
+          <p:cNvPr id="33" name="Text 30"/>
+          <p:cNvSpPr txBox="1"/>
+          <p:nvPr/>
+        </p:nvSpPr>
+        <p:spPr>
+          <a:xfrm>
+            <a:off x="6629400" y="2536738"/>
+            <a:ext cx="384048" cy="201168"/>
+          </a:xfrm>
+          <a:prstGeom prst="rect">
+            <a:avLst/>
+          </a:prstGeom>
+          <a:noFill/>
+          <a:ln/>
+        </p:spPr>
+        <p:txBody>
+          <a:bodyPr wrap="square" lIns="0" tIns="0" rIns="0" bIns="0" rtlCol="0" anchor="t"/>
+          <a:lstStyle/>
+          <a:p>
+            <a:pPr algn="r" indent="0" marL="0">
+              <a:buNone/>
+            </a:pPr>
+            <a:r>
+              <a:rPr lang="en-US" sz="1000" dirty="0">
+                <a:solidFill>
+                  <a:schemeClr val="accent3"/>
+                </a:solidFill>
+              </a:rPr>
+              <a:t>150</a:t>
+            </a:r>
+            <a:endParaRPr lang="en-US" sz="1000" dirty="0"/>
+          </a:p>
+        </p:txBody>
+      </p:sp>
+      <p:sp>
+        <p:nvSpPr>
+          <p:cNvPr id="34" name="Grid 180"/>
+          <p:cNvSpPr/>
+          <p:nvPr/>
+        </p:nvSpPr>
+        <p:spPr>
+          <a:xfrm>
+            <a:off x="7086600" y="2168091"/>
+            <a:ext cx="4343400" cy="0"/>
+          </a:xfrm>
+          <a:prstGeom prst="line">
+            <a:avLst/>
+          </a:prstGeom>
+          <a:noFill/>
+          <a:ln w="9525">
+            <a:solidFill>
+              <a:srgbClr val="E5E7EB"/>
+            </a:solidFill>
+            <a:prstDash val="solid"/>
+          </a:ln>
+        </p:spPr>
+      </p:sp>
+      <p:sp>
+        <p:nvSpPr>
+          <p:cNvPr id="35" name="Text 32"/>
+          <p:cNvSpPr txBox="1"/>
+          <p:nvPr/>
+        </p:nvSpPr>
+        <p:spPr>
+          <a:xfrm>
+            <a:off x="6629400" y="2067507"/>
+            <a:ext cx="384048" cy="201168"/>
+          </a:xfrm>
+          <a:prstGeom prst="rect">
+            <a:avLst/>
+          </a:prstGeom>
+          <a:noFill/>
+          <a:ln/>
+        </p:spPr>
+        <p:txBody>
+          <a:bodyPr wrap="square" lIns="0" tIns="0" rIns="0" bIns="0" rtlCol="0" anchor="t"/>
+          <a:lstStyle/>
+          <a:p>
+            <a:pPr algn="r" indent="0" marL="0">
+              <a:buNone/>
+            </a:pPr>
+            <a:r>
+              <a:rPr lang="en-US" sz="1000" dirty="0">
+                <a:solidFill>
+                  <a:schemeClr val="accent3"/>
+                </a:solidFill>
+              </a:rPr>
+              <a:t>180</a:t>
+            </a:r>
+            <a:endParaRPr lang="en-US" sz="1000" dirty="0"/>
+          </a:p>
+        </p:txBody>
+      </p:sp>
+      <p:sp>
+        <p:nvSpPr>
+          <p:cNvPr id="36" name="Tick 1990"/>
+          <p:cNvSpPr/>
+          <p:nvPr/>
+        </p:nvSpPr>
+        <p:spPr>
+          <a:xfrm>
+            <a:off x="7086600" y="4983480"/>
+            <a:ext cx="0" cy="54864"/>
+          </a:xfrm>
+          <a:prstGeom prst="line">
+            <a:avLst/>
+          </a:prstGeom>
+          <a:noFill/>
+          <a:ln w="9525">
+            <a:solidFill>
+              <a:srgbClr val="6B7280"/>
+            </a:solidFill>
+            <a:prstDash val="solid"/>
+          </a:ln>
+        </p:spPr>
+      </p:sp>
+      <p:sp>
+        <p:nvSpPr>
+          <p:cNvPr id="37" name="Text 34"/>
+          <p:cNvSpPr txBox="1"/>
+          <p:nvPr/>
+        </p:nvSpPr>
+        <p:spPr>
+          <a:xfrm>
+            <a:off x="6766560" y="5047488"/>
+            <a:ext cx="640080" cy="201168"/>
+          </a:xfrm>
+          <a:prstGeom prst="rect">
+            <a:avLst/>
+          </a:prstGeom>
+          <a:noFill/>
+          <a:ln/>
+        </p:spPr>
+        <p:txBody>
+          <a:bodyPr wrap="square" lIns="0" tIns="0" rIns="0" bIns="0" rtlCol="0" anchor="t"/>
+          <a:lstStyle/>
+          <a:p>
+            <a:pPr algn="ctr" indent="0" marL="0">
+              <a:buNone/>
+            </a:pPr>
+            <a:r>
+              <a:rPr lang="en-US" sz="1000" dirty="0">
+                <a:solidFill>
+                  <a:schemeClr val="accent3"/>
+                </a:solidFill>
+              </a:rPr>
+              <a:t>1990</a:t>
+            </a:r>
+            <a:endParaRPr lang="en-US" sz="1000" dirty="0"/>
+          </a:p>
+        </p:txBody>
+      </p:sp>
+      <p:sp>
+        <p:nvSpPr>
+          <p:cNvPr id="38" name="Tick 2000"/>
+          <p:cNvSpPr/>
+          <p:nvPr/>
+        </p:nvSpPr>
+        <p:spPr>
+          <a:xfrm>
+            <a:off x="8260492" y="4983480"/>
+            <a:ext cx="0" cy="54864"/>
+          </a:xfrm>
+          <a:prstGeom prst="line">
+            <a:avLst/>
+          </a:prstGeom>
+          <a:noFill/>
+          <a:ln w="9525">
+            <a:solidFill>
+              <a:srgbClr val="6B7280"/>
+            </a:solidFill>
+            <a:prstDash val="solid"/>
+          </a:ln>
+        </p:spPr>
+      </p:sp>
+      <p:sp>
+        <p:nvSpPr>
+          <p:cNvPr id="39" name="Text 36"/>
+          <p:cNvSpPr txBox="1"/>
+          <p:nvPr/>
+        </p:nvSpPr>
+        <p:spPr>
+          <a:xfrm>
+            <a:off x="7940452" y="5047488"/>
+            <a:ext cx="640080" cy="201168"/>
+          </a:xfrm>
+          <a:prstGeom prst="rect">
+            <a:avLst/>
+          </a:prstGeom>
+          <a:noFill/>
+          <a:ln/>
+        </p:spPr>
+        <p:txBody>
+          <a:bodyPr wrap="square" lIns="0" tIns="0" rIns="0" bIns="0" rtlCol="0" anchor="t"/>
+          <a:lstStyle/>
+          <a:p>
+            <a:pPr algn="ctr" indent="0" marL="0">
+              <a:buNone/>
+            </a:pPr>
+            <a:r>
+              <a:rPr lang="en-US" sz="1000" dirty="0">
+                <a:solidFill>
+                  <a:schemeClr val="accent3"/>
+                </a:solidFill>
+              </a:rPr>
+              <a:t>2000</a:t>
+            </a:r>
+            <a:endParaRPr lang="en-US" sz="1000" dirty="0"/>
+          </a:p>
+        </p:txBody>
+      </p:sp>
+      <p:sp>
+        <p:nvSpPr>
+          <p:cNvPr id="40" name="Tick 2010"/>
+          <p:cNvSpPr/>
+          <p:nvPr/>
+        </p:nvSpPr>
+        <p:spPr>
+          <a:xfrm>
+            <a:off x="9434384" y="4983480"/>
+            <a:ext cx="0" cy="54864"/>
+          </a:xfrm>
+          <a:prstGeom prst="line">
+            <a:avLst/>
+          </a:prstGeom>
+          <a:noFill/>
+          <a:ln w="9525">
+            <a:solidFill>
+              <a:srgbClr val="6B7280"/>
+            </a:solidFill>
+            <a:prstDash val="solid"/>
+          </a:ln>
+        </p:spPr>
+      </p:sp>
+      <p:sp>
+        <p:nvSpPr>
+          <p:cNvPr id="41" name="Text 38"/>
+          <p:cNvSpPr txBox="1"/>
+          <p:nvPr/>
+        </p:nvSpPr>
+        <p:spPr>
+          <a:xfrm>
+            <a:off x="9114344" y="5047488"/>
+            <a:ext cx="640080" cy="201168"/>
+          </a:xfrm>
+          <a:prstGeom prst="rect">
+            <a:avLst/>
+          </a:prstGeom>
+          <a:noFill/>
+          <a:ln/>
+        </p:spPr>
+        <p:txBody>
+          <a:bodyPr wrap="square" lIns="0" tIns="0" rIns="0" bIns="0" rtlCol="0" anchor="t"/>
+          <a:lstStyle/>
+          <a:p>
+            <a:pPr algn="ctr" indent="0" marL="0">
+              <a:buNone/>
+            </a:pPr>
+            <a:r>
+              <a:rPr lang="en-US" sz="1000" dirty="0">
+                <a:solidFill>
+                  <a:schemeClr val="accent3"/>
+                </a:solidFill>
+              </a:rPr>
+              <a:t>2010</a:t>
+            </a:r>
+            <a:endParaRPr lang="en-US" sz="1000" dirty="0"/>
+          </a:p>
+        </p:txBody>
+      </p:sp>
+      <p:sp>
+        <p:nvSpPr>
+          <p:cNvPr id="42" name="Tick 2020"/>
+          <p:cNvSpPr/>
+          <p:nvPr/>
+        </p:nvSpPr>
+        <p:spPr>
+          <a:xfrm>
+            <a:off x="10608276" y="4983480"/>
+            <a:ext cx="0" cy="54864"/>
+          </a:xfrm>
+          <a:prstGeom prst="line">
+            <a:avLst/>
+          </a:prstGeom>
+          <a:noFill/>
+          <a:ln w="9525">
+            <a:solidFill>
+              <a:srgbClr val="6B7280"/>
+            </a:solidFill>
+            <a:prstDash val="solid"/>
+          </a:ln>
+        </p:spPr>
+      </p:sp>
+      <p:sp>
+        <p:nvSpPr>
+          <p:cNvPr id="43" name="Text 40"/>
+          <p:cNvSpPr txBox="1"/>
+          <p:nvPr/>
+        </p:nvSpPr>
+        <p:spPr>
+          <a:xfrm>
+            <a:off x="10288236" y="5047488"/>
+            <a:ext cx="640080" cy="201168"/>
+          </a:xfrm>
+          <a:prstGeom prst="rect">
+            <a:avLst/>
+          </a:prstGeom>
+          <a:noFill/>
+          <a:ln/>
+        </p:spPr>
+        <p:txBody>
+          <a:bodyPr wrap="square" lIns="0" tIns="0" rIns="0" bIns="0" rtlCol="0" anchor="t"/>
+          <a:lstStyle/>
+          <a:p>
+            <a:pPr algn="ctr" indent="0" marL="0">
+              <a:buNone/>
+            </a:pPr>
+            <a:r>
+              <a:rPr lang="en-US" sz="1000" dirty="0">
+                <a:solidFill>
+                  <a:schemeClr val="accent3"/>
+                </a:solidFill>
+              </a:rPr>
+              <a:t>2020</a:t>
+            </a:r>
+            <a:endParaRPr lang="en-US" sz="1000" dirty="0"/>
+          </a:p>
+        </p:txBody>
+      </p:sp>
+      <p:sp>
+        <p:nvSpPr>
+          <p:cNvPr id="44" name="Text 41"/>
+          <p:cNvSpPr txBox="1"/>
+          <p:nvPr/>
+        </p:nvSpPr>
+        <p:spPr>
+          <a:xfrm>
+            <a:off x="7086600" y="5257800"/>
+            <a:ext cx="4343400" cy="228600"/>
+          </a:xfrm>
+          <a:prstGeom prst="rect">
+            <a:avLst/>
+          </a:prstGeom>
+          <a:noFill/>
+          <a:ln/>
+        </p:spPr>
+        <p:txBody>
+          <a:bodyPr wrap="square" lIns="0" tIns="0" rIns="0" bIns="0" rtlCol="0" anchor="t"/>
+          <a:lstStyle/>
+          <a:p>
+            <a:pPr algn="ctr" indent="0" marL="0">
+              <a:buNone/>
+            </a:pPr>
+            <a:r>
+              <a:rPr lang="en-US" sz="1100" dirty="0">
+                <a:solidFill>
+                  <a:schemeClr val="accent3"/>
+                </a:solidFill>
+              </a:rPr>
+              <a:t>Year of publication</a:t>
+            </a:r>
+            <a:endParaRPr lang="en-US" sz="1100" dirty="0"/>
+          </a:p>
+        </p:txBody>
+      </p:sp>
+      <p:sp>
+        <p:nvSpPr>
+          <p:cNvPr id="45" name="Text 42"/>
+          <p:cNvSpPr txBox="1"/>
+          <p:nvPr/>
+        </p:nvSpPr>
+        <p:spPr>
+          <a:xfrm>
+            <a:off x="6400800" y="1737360"/>
+            <a:ext cx="1463040" cy="228600"/>
+          </a:xfrm>
+          <a:prstGeom prst="rect">
+            <a:avLst/>
+          </a:prstGeom>
+          <a:noFill/>
+          <a:ln/>
+        </p:spPr>
+        <p:txBody>
+          <a:bodyPr wrap="square" lIns="0" tIns="0" rIns="0" bIns="0" rtlCol="0" anchor="t"/>
+          <a:lstStyle/>
           <a:p>
             <a:pPr indent="0" marL="0">
-              <a:spcAft>
-                <a:spcPts val="600"/>
-              </a:spcAft>
               <a:buNone/>
             </a:pPr>
             <a:r>
-              <a:rPr lang="en-US" sz="1400" i="1" dirty="0">
+              <a:rPr lang="en-US" sz="1100" dirty="0">
                 <a:solidFill>
                   <a:schemeClr val="accent3"/>
                 </a:solidFill>
               </a:rPr>
-              <a:t>Suggested points from the final report:</a:t>
-            </a:r>
-            <a:endParaRPr lang="en-US" sz="1400" dirty="0"/>
-          </a:p>
-          <a:p>
-            <a:pPr marL="342900" indent="-342900">
-              <a:spcAft>
-                <a:spcPts val="400"/>
-              </a:spcAft>
-              <a:buSzPct val="100000"/>
-              <a:buChar char="•"/>
-            </a:pPr>
-            <a:r>
-              <a:rPr lang="en-US" sz="1600" dirty="0">
+              <a:t>Unloading (days)</a:t>
+            </a:r>
+            <a:endParaRPr lang="en-US" sz="1100" dirty="0"/>
+          </a:p>
+        </p:txBody>
+      </p:sp>
+      <p:sp>
+        <p:nvSpPr>
+          <p:cNvPr id="46" name="Study 1992 119 d"/>
+          <p:cNvSpPr/>
+          <p:nvPr/>
+        </p:nvSpPr>
+        <p:spPr>
+          <a:xfrm>
+            <a:off x="7261942" y="3062759"/>
+            <a:ext cx="118872" cy="118872"/>
+          </a:xfrm>
+          <a:prstGeom prst="ellipse">
+            <a:avLst/>
+          </a:prstGeom>
+          <a:solidFill>
+            <a:srgbClr val="9AA3AE">
+              <a:alpha val="90000"/>
+            </a:srgbClr>
+          </a:solidFill>
+          <a:ln w="6350">
+            <a:solidFill>
+              <a:srgbClr val="FFFFFF"/>
+            </a:solidFill>
+            <a:prstDash val="solid"/>
+          </a:ln>
+        </p:spPr>
+      </p:sp>
+      <p:sp>
+        <p:nvSpPr>
+          <p:cNvPr id="47" name="Study 1994 30 d"/>
+          <p:cNvSpPr/>
+          <p:nvPr/>
+        </p:nvSpPr>
+        <p:spPr>
+          <a:xfrm>
+            <a:off x="7496721" y="4454812"/>
+            <a:ext cx="118872" cy="118872"/>
+          </a:xfrm>
+          <a:prstGeom prst="ellipse">
+            <a:avLst/>
+          </a:prstGeom>
+          <a:solidFill>
+            <a:srgbClr val="1F3A5F">
+              <a:alpha val="90000"/>
+            </a:srgbClr>
+          </a:solidFill>
+          <a:ln w="6350">
+            <a:solidFill>
+              <a:srgbClr val="FFFFFF"/>
+            </a:solidFill>
+            <a:prstDash val="solid"/>
+          </a:ln>
+        </p:spPr>
+      </p:sp>
+      <p:sp>
+        <p:nvSpPr>
+          <p:cNvPr id="48" name="Study 2004 90 d"/>
+          <p:cNvSpPr/>
+          <p:nvPr/>
+        </p:nvSpPr>
+        <p:spPr>
+          <a:xfrm>
+            <a:off x="8670613" y="3516349"/>
+            <a:ext cx="118872" cy="118872"/>
+          </a:xfrm>
+          <a:prstGeom prst="ellipse">
+            <a:avLst/>
+          </a:prstGeom>
+          <a:solidFill>
+            <a:srgbClr val="1F3A5F">
+              <a:alpha val="90000"/>
+            </a:srgbClr>
+          </a:solidFill>
+          <a:ln w="6350">
+            <a:solidFill>
+              <a:srgbClr val="FFFFFF"/>
+            </a:solidFill>
+            <a:prstDash val="solid"/>
+          </a:ln>
+        </p:spPr>
+      </p:sp>
+      <p:sp>
+        <p:nvSpPr>
+          <p:cNvPr id="49" name="Study 2007 35 d"/>
+          <p:cNvSpPr/>
+          <p:nvPr/>
+        </p:nvSpPr>
+        <p:spPr>
+          <a:xfrm>
+            <a:off x="9022780" y="4376607"/>
+            <a:ext cx="118872" cy="118872"/>
+          </a:xfrm>
+          <a:prstGeom prst="ellipse">
+            <a:avLst/>
+          </a:prstGeom>
+          <a:solidFill>
+            <a:srgbClr val="9AA3AE">
+              <a:alpha val="90000"/>
+            </a:srgbClr>
+          </a:solidFill>
+          <a:ln w="6350">
+            <a:solidFill>
+              <a:srgbClr val="FFFFFF"/>
+            </a:solidFill>
+            <a:prstDash val="solid"/>
+          </a:ln>
+        </p:spPr>
+      </p:sp>
+      <p:sp>
+        <p:nvSpPr>
+          <p:cNvPr id="50" name="Study 2007 60 d"/>
+          <p:cNvSpPr/>
+          <p:nvPr/>
+        </p:nvSpPr>
+        <p:spPr>
+          <a:xfrm>
+            <a:off x="9022780" y="3985581"/>
+            <a:ext cx="118872" cy="118872"/>
+          </a:xfrm>
+          <a:prstGeom prst="ellipse">
+            <a:avLst/>
+          </a:prstGeom>
+          <a:solidFill>
+            <a:srgbClr val="1F3A5F">
+              <a:alpha val="90000"/>
+            </a:srgbClr>
+          </a:solidFill>
+          <a:ln w="6350">
+            <a:solidFill>
+              <a:srgbClr val="FFFFFF"/>
+            </a:solidFill>
+            <a:prstDash val="solid"/>
+          </a:ln>
+        </p:spPr>
+      </p:sp>
+      <p:sp>
+        <p:nvSpPr>
+          <p:cNvPr id="51" name="Study 2009 14 d"/>
+          <p:cNvSpPr/>
+          <p:nvPr/>
+        </p:nvSpPr>
+        <p:spPr>
+          <a:xfrm>
+            <a:off x="9257559" y="4705069"/>
+            <a:ext cx="118872" cy="118872"/>
+          </a:xfrm>
+          <a:prstGeom prst="ellipse">
+            <a:avLst/>
+          </a:prstGeom>
+          <a:solidFill>
+            <a:srgbClr val="1F3A5F">
+              <a:alpha val="90000"/>
+            </a:srgbClr>
+          </a:solidFill>
+          <a:ln w="6350">
+            <a:solidFill>
+              <a:srgbClr val="FFFFFF"/>
+            </a:solidFill>
+            <a:prstDash val="solid"/>
+          </a:ln>
+        </p:spPr>
+      </p:sp>
+      <p:sp>
+        <p:nvSpPr>
+          <p:cNvPr id="52" name="Study 2009 56 d"/>
+          <p:cNvSpPr/>
+          <p:nvPr/>
+        </p:nvSpPr>
+        <p:spPr>
+          <a:xfrm>
+            <a:off x="9257559" y="4048145"/>
+            <a:ext cx="118872" cy="118872"/>
+          </a:xfrm>
+          <a:prstGeom prst="ellipse">
+            <a:avLst/>
+          </a:prstGeom>
+          <a:solidFill>
+            <a:srgbClr val="9AA3AE">
+              <a:alpha val="90000"/>
+            </a:srgbClr>
+          </a:solidFill>
+          <a:ln w="6350">
+            <a:solidFill>
+              <a:srgbClr val="FFFFFF"/>
+            </a:solidFill>
+            <a:prstDash val="solid"/>
+          </a:ln>
+        </p:spPr>
+      </p:sp>
+      <p:sp>
+        <p:nvSpPr>
+          <p:cNvPr id="53" name="Study 2012 60 d"/>
+          <p:cNvSpPr/>
+          <p:nvPr/>
+        </p:nvSpPr>
+        <p:spPr>
+          <a:xfrm>
+            <a:off x="9609726" y="3985581"/>
+            <a:ext cx="118872" cy="118872"/>
+          </a:xfrm>
+          <a:prstGeom prst="ellipse">
+            <a:avLst/>
+          </a:prstGeom>
+          <a:solidFill>
+            <a:srgbClr val="1F3A5F">
+              <a:alpha val="90000"/>
+            </a:srgbClr>
+          </a:solidFill>
+          <a:ln w="6350">
+            <a:solidFill>
+              <a:srgbClr val="FFFFFF"/>
+            </a:solidFill>
+            <a:prstDash val="solid"/>
+          </a:ln>
+        </p:spPr>
+      </p:sp>
+      <p:sp>
+        <p:nvSpPr>
+          <p:cNvPr id="54" name="Study 2013 7 d"/>
+          <p:cNvSpPr/>
+          <p:nvPr/>
+        </p:nvSpPr>
+        <p:spPr>
+          <a:xfrm>
+            <a:off x="9727115" y="4814557"/>
+            <a:ext cx="118872" cy="118872"/>
+          </a:xfrm>
+          <a:prstGeom prst="ellipse">
+            <a:avLst/>
+          </a:prstGeom>
+          <a:solidFill>
+            <a:srgbClr val="9AA3AE">
+              <a:alpha val="90000"/>
+            </a:srgbClr>
+          </a:solidFill>
+          <a:ln w="6350">
+            <a:solidFill>
+              <a:srgbClr val="FFFFFF"/>
+            </a:solidFill>
+            <a:prstDash val="solid"/>
+          </a:ln>
+        </p:spPr>
+      </p:sp>
+      <p:sp>
+        <p:nvSpPr>
+          <p:cNvPr id="55" name="Study 2013 90 d"/>
+          <p:cNvSpPr/>
+          <p:nvPr/>
+        </p:nvSpPr>
+        <p:spPr>
+          <a:xfrm>
+            <a:off x="9727115" y="3516349"/>
+            <a:ext cx="118872" cy="118872"/>
+          </a:xfrm>
+          <a:prstGeom prst="ellipse">
+            <a:avLst/>
+          </a:prstGeom>
+          <a:solidFill>
+            <a:srgbClr val="1F3A5F">
+              <a:alpha val="90000"/>
+            </a:srgbClr>
+          </a:solidFill>
+          <a:ln w="6350">
+            <a:solidFill>
+              <a:srgbClr val="FFFFFF"/>
+            </a:solidFill>
+            <a:prstDash val="solid"/>
+          </a:ln>
+        </p:spPr>
+      </p:sp>
+      <p:sp>
+        <p:nvSpPr>
+          <p:cNvPr id="56" name="Study 2014 30 d"/>
+          <p:cNvSpPr/>
+          <p:nvPr/>
+        </p:nvSpPr>
+        <p:spPr>
+          <a:xfrm>
+            <a:off x="9844505" y="4454812"/>
+            <a:ext cx="118872" cy="118872"/>
+          </a:xfrm>
+          <a:prstGeom prst="ellipse">
+            <a:avLst/>
+          </a:prstGeom>
+          <a:solidFill>
+            <a:srgbClr val="2E8B57">
+              <a:alpha val="90000"/>
+            </a:srgbClr>
+          </a:solidFill>
+          <a:ln w="6350">
+            <a:solidFill>
+              <a:srgbClr val="FFFFFF"/>
+            </a:solidFill>
+            <a:prstDash val="solid"/>
+          </a:ln>
+        </p:spPr>
+      </p:sp>
+      <p:sp>
+        <p:nvSpPr>
+          <p:cNvPr id="57" name="Study 2014 35 d"/>
+          <p:cNvSpPr/>
+          <p:nvPr/>
+        </p:nvSpPr>
+        <p:spPr>
+          <a:xfrm>
+            <a:off x="9844505" y="4376607"/>
+            <a:ext cx="118872" cy="118872"/>
+          </a:xfrm>
+          <a:prstGeom prst="ellipse">
+            <a:avLst/>
+          </a:prstGeom>
+          <a:solidFill>
+            <a:srgbClr val="1F3A5F">
+              <a:alpha val="90000"/>
+            </a:srgbClr>
+          </a:solidFill>
+          <a:ln w="6350">
+            <a:solidFill>
+              <a:srgbClr val="FFFFFF"/>
+            </a:solidFill>
+            <a:prstDash val="solid"/>
+          </a:ln>
+        </p:spPr>
+      </p:sp>
+      <p:sp>
+        <p:nvSpPr>
+          <p:cNvPr id="58" name="Study 2015 5 d"/>
+          <p:cNvSpPr/>
+          <p:nvPr/>
+        </p:nvSpPr>
+        <p:spPr>
+          <a:xfrm>
+            <a:off x="9961894" y="4845839"/>
+            <a:ext cx="118872" cy="118872"/>
+          </a:xfrm>
+          <a:prstGeom prst="ellipse">
+            <a:avLst/>
+          </a:prstGeom>
+          <a:solidFill>
+            <a:srgbClr val="1F3A5F">
+              <a:alpha val="90000"/>
+            </a:srgbClr>
+          </a:solidFill>
+          <a:ln w="6350">
+            <a:solidFill>
+              <a:srgbClr val="FFFFFF"/>
+            </a:solidFill>
+            <a:prstDash val="solid"/>
+          </a:ln>
+        </p:spPr>
+      </p:sp>
+      <p:sp>
+        <p:nvSpPr>
+          <p:cNvPr id="59" name="Study 2015 5 d"/>
+          <p:cNvSpPr/>
+          <p:nvPr/>
+        </p:nvSpPr>
+        <p:spPr>
+          <a:xfrm>
+            <a:off x="10053334" y="4845839"/>
+            <a:ext cx="118872" cy="118872"/>
+          </a:xfrm>
+          <a:prstGeom prst="ellipse">
+            <a:avLst/>
+          </a:prstGeom>
+          <a:solidFill>
+            <a:srgbClr val="9AA3AE">
+              <a:alpha val="90000"/>
+            </a:srgbClr>
+          </a:solidFill>
+          <a:ln w="6350">
+            <a:solidFill>
+              <a:srgbClr val="FFFFFF"/>
+            </a:solidFill>
+            <a:prstDash val="solid"/>
+          </a:ln>
+        </p:spPr>
+      </p:sp>
+      <p:sp>
+        <p:nvSpPr>
+          <p:cNvPr id="60" name="Study 2015 60 d"/>
+          <p:cNvSpPr/>
+          <p:nvPr/>
+        </p:nvSpPr>
+        <p:spPr>
+          <a:xfrm>
+            <a:off x="9961894" y="3985581"/>
+            <a:ext cx="118872" cy="118872"/>
+          </a:xfrm>
+          <a:prstGeom prst="ellipse">
+            <a:avLst/>
+          </a:prstGeom>
+          <a:solidFill>
+            <a:srgbClr val="1F3A5F">
+              <a:alpha val="90000"/>
+            </a:srgbClr>
+          </a:solidFill>
+          <a:ln w="6350">
+            <a:solidFill>
+              <a:srgbClr val="FFFFFF"/>
+            </a:solidFill>
+            <a:prstDash val="solid"/>
+          </a:ln>
+        </p:spPr>
+      </p:sp>
+      <p:sp>
+        <p:nvSpPr>
+          <p:cNvPr id="61" name="Study 2016 7 d"/>
+          <p:cNvSpPr/>
+          <p:nvPr/>
+        </p:nvSpPr>
+        <p:spPr>
+          <a:xfrm>
+            <a:off x="10079283" y="4814557"/>
+            <a:ext cx="118872" cy="118872"/>
+          </a:xfrm>
+          <a:prstGeom prst="ellipse">
+            <a:avLst/>
+          </a:prstGeom>
+          <a:solidFill>
+            <a:srgbClr val="9AA3AE">
+              <a:alpha val="90000"/>
+            </a:srgbClr>
+          </a:solidFill>
+          <a:ln w="6350">
+            <a:solidFill>
+              <a:srgbClr val="FFFFFF"/>
+            </a:solidFill>
+            <a:prstDash val="solid"/>
+          </a:ln>
+        </p:spPr>
+      </p:sp>
+      <p:sp>
+        <p:nvSpPr>
+          <p:cNvPr id="62" name="Study 2016 14 d"/>
+          <p:cNvSpPr/>
+          <p:nvPr/>
+        </p:nvSpPr>
+        <p:spPr>
+          <a:xfrm>
+            <a:off x="10079283" y="4705069"/>
+            <a:ext cx="118872" cy="118872"/>
+          </a:xfrm>
+          <a:prstGeom prst="ellipse">
+            <a:avLst/>
+          </a:prstGeom>
+          <a:solidFill>
+            <a:srgbClr val="9AA3AE">
+              <a:alpha val="90000"/>
+            </a:srgbClr>
+          </a:solidFill>
+          <a:ln w="6350">
+            <a:solidFill>
+              <a:srgbClr val="FFFFFF"/>
+            </a:solidFill>
+            <a:prstDash val="solid"/>
+          </a:ln>
+        </p:spPr>
+      </p:sp>
+      <p:sp>
+        <p:nvSpPr>
+          <p:cNvPr id="63" name="Study 2016 60 d"/>
+          <p:cNvSpPr/>
+          <p:nvPr/>
+        </p:nvSpPr>
+        <p:spPr>
+          <a:xfrm>
+            <a:off x="10079283" y="3985581"/>
+            <a:ext cx="118872" cy="118872"/>
+          </a:xfrm>
+          <a:prstGeom prst="ellipse">
+            <a:avLst/>
+          </a:prstGeom>
+          <a:solidFill>
+            <a:srgbClr val="1F3A5F">
+              <a:alpha val="90000"/>
+            </a:srgbClr>
+          </a:solidFill>
+          <a:ln w="6350">
+            <a:solidFill>
+              <a:srgbClr val="FFFFFF"/>
+            </a:solidFill>
+            <a:prstDash val="solid"/>
+          </a:ln>
+        </p:spPr>
+      </p:sp>
+      <p:sp>
+        <p:nvSpPr>
+          <p:cNvPr id="64" name="Study 2016 84 d"/>
+          <p:cNvSpPr/>
+          <p:nvPr/>
+        </p:nvSpPr>
+        <p:spPr>
+          <a:xfrm>
+            <a:off x="10079283" y="3610196"/>
+            <a:ext cx="118872" cy="118872"/>
+          </a:xfrm>
+          <a:prstGeom prst="ellipse">
+            <a:avLst/>
+          </a:prstGeom>
+          <a:solidFill>
+            <a:srgbClr val="1F3A5F">
+              <a:alpha val="90000"/>
+            </a:srgbClr>
+          </a:solidFill>
+          <a:ln w="6350">
+            <a:solidFill>
+              <a:srgbClr val="FFFFFF"/>
+            </a:solidFill>
+            <a:prstDash val="solid"/>
+          </a:ln>
+        </p:spPr>
+      </p:sp>
+      <p:sp>
+        <p:nvSpPr>
+          <p:cNvPr id="65" name="Study 2016 180 d"/>
+          <p:cNvSpPr/>
+          <p:nvPr/>
+        </p:nvSpPr>
+        <p:spPr>
+          <a:xfrm>
+            <a:off x="10079283" y="2108655"/>
+            <a:ext cx="118872" cy="118872"/>
+          </a:xfrm>
+          <a:prstGeom prst="ellipse">
+            <a:avLst/>
+          </a:prstGeom>
+          <a:solidFill>
+            <a:srgbClr val="A23B2A">
+              <a:alpha val="90000"/>
+            </a:srgbClr>
+          </a:solidFill>
+          <a:ln w="6350">
+            <a:solidFill>
+              <a:srgbClr val="FFFFFF"/>
+            </a:solidFill>
+            <a:prstDash val="solid"/>
+          </a:ln>
+        </p:spPr>
+      </p:sp>
+      <p:sp>
+        <p:nvSpPr>
+          <p:cNvPr id="66" name="Study 2017 60 d"/>
+          <p:cNvSpPr/>
+          <p:nvPr/>
+        </p:nvSpPr>
+        <p:spPr>
+          <a:xfrm>
+            <a:off x="10196672" y="3985581"/>
+            <a:ext cx="118872" cy="118872"/>
+          </a:xfrm>
+          <a:prstGeom prst="ellipse">
+            <a:avLst/>
+          </a:prstGeom>
+          <a:solidFill>
+            <a:srgbClr val="1F3A5F">
+              <a:alpha val="90000"/>
+            </a:srgbClr>
+          </a:solidFill>
+          <a:ln w="6350">
+            <a:solidFill>
+              <a:srgbClr val="FFFFFF"/>
+            </a:solidFill>
+            <a:prstDash val="solid"/>
+          </a:ln>
+        </p:spPr>
+      </p:sp>
+      <p:sp>
+        <p:nvSpPr>
+          <p:cNvPr id="67" name="Study 2017 90 d"/>
+          <p:cNvSpPr/>
+          <p:nvPr/>
+        </p:nvSpPr>
+        <p:spPr>
+          <a:xfrm>
+            <a:off x="10196672" y="3516349"/>
+            <a:ext cx="118872" cy="118872"/>
+          </a:xfrm>
+          <a:prstGeom prst="ellipse">
+            <a:avLst/>
+          </a:prstGeom>
+          <a:solidFill>
+            <a:srgbClr val="1F3A5F">
+              <a:alpha val="90000"/>
+            </a:srgbClr>
+          </a:solidFill>
+          <a:ln w="6350">
+            <a:solidFill>
+              <a:srgbClr val="FFFFFF"/>
+            </a:solidFill>
+            <a:prstDash val="solid"/>
+          </a:ln>
+        </p:spPr>
+      </p:sp>
+      <p:sp>
+        <p:nvSpPr>
+          <p:cNvPr id="68" name="Study 2018 14 d"/>
+          <p:cNvSpPr/>
+          <p:nvPr/>
+        </p:nvSpPr>
+        <p:spPr>
+          <a:xfrm>
+            <a:off x="10314061" y="4705069"/>
+            <a:ext cx="118872" cy="118872"/>
+          </a:xfrm>
+          <a:prstGeom prst="ellipse">
+            <a:avLst/>
+          </a:prstGeom>
+          <a:solidFill>
+            <a:srgbClr val="9AA3AE">
+              <a:alpha val="90000"/>
+            </a:srgbClr>
+          </a:solidFill>
+          <a:ln w="6350">
+            <a:solidFill>
+              <a:srgbClr val="FFFFFF"/>
+            </a:solidFill>
+            <a:prstDash val="solid"/>
+          </a:ln>
+        </p:spPr>
+      </p:sp>
+      <p:sp>
+        <p:nvSpPr>
+          <p:cNvPr id="69" name="Study 2018 21 d"/>
+          <p:cNvSpPr/>
+          <p:nvPr/>
+        </p:nvSpPr>
+        <p:spPr>
+          <a:xfrm>
+            <a:off x="10314061" y="4595582"/>
+            <a:ext cx="118872" cy="118872"/>
+          </a:xfrm>
+          <a:prstGeom prst="ellipse">
+            <a:avLst/>
+          </a:prstGeom>
+          <a:solidFill>
+            <a:srgbClr val="9AA3AE">
+              <a:alpha val="90000"/>
+            </a:srgbClr>
+          </a:solidFill>
+          <a:ln w="6350">
+            <a:solidFill>
+              <a:srgbClr val="FFFFFF"/>
+            </a:solidFill>
+            <a:prstDash val="solid"/>
+          </a:ln>
+        </p:spPr>
+      </p:sp>
+      <p:sp>
+        <p:nvSpPr>
+          <p:cNvPr id="70" name="Study 2019 7 d"/>
+          <p:cNvSpPr/>
+          <p:nvPr/>
+        </p:nvSpPr>
+        <p:spPr>
+          <a:xfrm>
+            <a:off x="10431450" y="4814557"/>
+            <a:ext cx="118872" cy="118872"/>
+          </a:xfrm>
+          <a:prstGeom prst="ellipse">
+            <a:avLst/>
+          </a:prstGeom>
+          <a:solidFill>
+            <a:srgbClr val="9AA3AE">
+              <a:alpha val="90000"/>
+            </a:srgbClr>
+          </a:solidFill>
+          <a:ln w="6350">
+            <a:solidFill>
+              <a:srgbClr val="FFFFFF"/>
+            </a:solidFill>
+            <a:prstDash val="solid"/>
+          </a:ln>
+        </p:spPr>
+      </p:sp>
+      <p:sp>
+        <p:nvSpPr>
+          <p:cNvPr id="71" name="Study 2019 10 d"/>
+          <p:cNvSpPr/>
+          <p:nvPr/>
+        </p:nvSpPr>
+        <p:spPr>
+          <a:xfrm>
+            <a:off x="10431450" y="4767633"/>
+            <a:ext cx="118872" cy="118872"/>
+          </a:xfrm>
+          <a:prstGeom prst="ellipse">
+            <a:avLst/>
+          </a:prstGeom>
+          <a:solidFill>
+            <a:srgbClr val="9AA3AE">
+              <a:alpha val="90000"/>
+            </a:srgbClr>
+          </a:solidFill>
+          <a:ln w="6350">
+            <a:solidFill>
+              <a:srgbClr val="FFFFFF"/>
+            </a:solidFill>
+            <a:prstDash val="solid"/>
+          </a:ln>
+        </p:spPr>
+      </p:sp>
+      <p:sp>
+        <p:nvSpPr>
+          <p:cNvPr id="72" name="Study 2020 21 d"/>
+          <p:cNvSpPr/>
+          <p:nvPr/>
+        </p:nvSpPr>
+        <p:spPr>
+          <a:xfrm>
+            <a:off x="10548840" y="4595582"/>
+            <a:ext cx="118872" cy="118872"/>
+          </a:xfrm>
+          <a:prstGeom prst="ellipse">
+            <a:avLst/>
+          </a:prstGeom>
+          <a:solidFill>
+            <a:srgbClr val="1F3A5F">
+              <a:alpha val="90000"/>
+            </a:srgbClr>
+          </a:solidFill>
+          <a:ln w="6350">
+            <a:solidFill>
+              <a:srgbClr val="FFFFFF"/>
+            </a:solidFill>
+            <a:prstDash val="solid"/>
+          </a:ln>
+        </p:spPr>
+      </p:sp>
+      <p:sp>
+        <p:nvSpPr>
+          <p:cNvPr id="73" name="Study 2021 5 d"/>
+          <p:cNvSpPr/>
+          <p:nvPr/>
+        </p:nvSpPr>
+        <p:spPr>
+          <a:xfrm>
+            <a:off x="10666229" y="4845839"/>
+            <a:ext cx="118872" cy="118872"/>
+          </a:xfrm>
+          <a:prstGeom prst="ellipse">
+            <a:avLst/>
+          </a:prstGeom>
+          <a:solidFill>
+            <a:srgbClr val="9AA3AE">
+              <a:alpha val="90000"/>
+            </a:srgbClr>
+          </a:solidFill>
+          <a:ln w="6350">
+            <a:solidFill>
+              <a:srgbClr val="FFFFFF"/>
+            </a:solidFill>
+            <a:prstDash val="solid"/>
+          </a:ln>
+        </p:spPr>
+      </p:sp>
+      <p:sp>
+        <p:nvSpPr>
+          <p:cNvPr id="74" name="Study 2021 10 d"/>
+          <p:cNvSpPr/>
+          <p:nvPr/>
+        </p:nvSpPr>
+        <p:spPr>
+          <a:xfrm>
+            <a:off x="10666229" y="4767633"/>
+            <a:ext cx="118872" cy="118872"/>
+          </a:xfrm>
+          <a:prstGeom prst="ellipse">
+            <a:avLst/>
+          </a:prstGeom>
+          <a:solidFill>
+            <a:srgbClr val="9AA3AE">
+              <a:alpha val="90000"/>
+            </a:srgbClr>
+          </a:solidFill>
+          <a:ln w="6350">
+            <a:solidFill>
+              <a:srgbClr val="FFFFFF"/>
+            </a:solidFill>
+            <a:prstDash val="solid"/>
+          </a:ln>
+        </p:spPr>
+      </p:sp>
+      <p:sp>
+        <p:nvSpPr>
+          <p:cNvPr id="75" name="Study 2021 60 d"/>
+          <p:cNvSpPr/>
+          <p:nvPr/>
+        </p:nvSpPr>
+        <p:spPr>
+          <a:xfrm>
+            <a:off x="10666229" y="3985581"/>
+            <a:ext cx="118872" cy="118872"/>
+          </a:xfrm>
+          <a:prstGeom prst="ellipse">
+            <a:avLst/>
+          </a:prstGeom>
+          <a:solidFill>
+            <a:srgbClr val="1F3A5F">
+              <a:alpha val="90000"/>
+            </a:srgbClr>
+          </a:solidFill>
+          <a:ln w="6350">
+            <a:solidFill>
+              <a:srgbClr val="FFFFFF"/>
+            </a:solidFill>
+            <a:prstDash val="solid"/>
+          </a:ln>
+        </p:spPr>
+      </p:sp>
+      <p:sp>
+        <p:nvSpPr>
+          <p:cNvPr id="76" name="Study 2021 60 d"/>
+          <p:cNvSpPr/>
+          <p:nvPr/>
+        </p:nvSpPr>
+        <p:spPr>
+          <a:xfrm>
+            <a:off x="10757669" y="3985581"/>
+            <a:ext cx="118872" cy="118872"/>
+          </a:xfrm>
+          <a:prstGeom prst="ellipse">
+            <a:avLst/>
+          </a:prstGeom>
+          <a:solidFill>
+            <a:srgbClr val="1F3A5F">
+              <a:alpha val="90000"/>
+            </a:srgbClr>
+          </a:solidFill>
+          <a:ln w="6350">
+            <a:solidFill>
+              <a:srgbClr val="FFFFFF"/>
+            </a:solidFill>
+            <a:prstDash val="solid"/>
+          </a:ln>
+        </p:spPr>
+      </p:sp>
+      <p:sp>
+        <p:nvSpPr>
+          <p:cNvPr id="77" name="Study 2021 180 d"/>
+          <p:cNvSpPr/>
+          <p:nvPr/>
+        </p:nvSpPr>
+        <p:spPr>
+          <a:xfrm>
+            <a:off x="10666229" y="2108655"/>
+            <a:ext cx="118872" cy="118872"/>
+          </a:xfrm>
+          <a:prstGeom prst="ellipse">
+            <a:avLst/>
+          </a:prstGeom>
+          <a:solidFill>
+            <a:srgbClr val="A23B2A">
+              <a:alpha val="90000"/>
+            </a:srgbClr>
+          </a:solidFill>
+          <a:ln w="6350">
+            <a:solidFill>
+              <a:srgbClr val="FFFFFF"/>
+            </a:solidFill>
+            <a:prstDash val="solid"/>
+          </a:ln>
+        </p:spPr>
+      </p:sp>
+      <p:sp>
+        <p:nvSpPr>
+          <p:cNvPr id="78" name="Study 2022 10 d"/>
+          <p:cNvSpPr/>
+          <p:nvPr/>
+        </p:nvSpPr>
+        <p:spPr>
+          <a:xfrm>
+            <a:off x="10783618" y="4767633"/>
+            <a:ext cx="118872" cy="118872"/>
+          </a:xfrm>
+          <a:prstGeom prst="ellipse">
+            <a:avLst/>
+          </a:prstGeom>
+          <a:solidFill>
+            <a:srgbClr val="9AA3AE">
+              <a:alpha val="90000"/>
+            </a:srgbClr>
+          </a:solidFill>
+          <a:ln w="6350">
+            <a:solidFill>
+              <a:srgbClr val="FFFFFF"/>
+            </a:solidFill>
+            <a:prstDash val="solid"/>
+          </a:ln>
+        </p:spPr>
+      </p:sp>
+      <p:sp>
+        <p:nvSpPr>
+          <p:cNvPr id="79" name="Study 2022 10 d"/>
+          <p:cNvSpPr/>
+          <p:nvPr/>
+        </p:nvSpPr>
+        <p:spPr>
+          <a:xfrm>
+            <a:off x="10875058" y="4767633"/>
+            <a:ext cx="118872" cy="118872"/>
+          </a:xfrm>
+          <a:prstGeom prst="ellipse">
+            <a:avLst/>
+          </a:prstGeom>
+          <a:solidFill>
+            <a:srgbClr val="2E8B57">
+              <a:alpha val="90000"/>
+            </a:srgbClr>
+          </a:solidFill>
+          <a:ln w="6350">
+            <a:solidFill>
+              <a:srgbClr val="FFFFFF"/>
+            </a:solidFill>
+            <a:prstDash val="solid"/>
+          </a:ln>
+        </p:spPr>
+      </p:sp>
+      <p:sp>
+        <p:nvSpPr>
+          <p:cNvPr id="80" name="Study 2022 60 d"/>
+          <p:cNvSpPr/>
+          <p:nvPr/>
+        </p:nvSpPr>
+        <p:spPr>
+          <a:xfrm>
+            <a:off x="10783618" y="3985581"/>
+            <a:ext cx="118872" cy="118872"/>
+          </a:xfrm>
+          <a:prstGeom prst="ellipse">
+            <a:avLst/>
+          </a:prstGeom>
+          <a:solidFill>
+            <a:srgbClr val="1F3A5F">
+              <a:alpha val="90000"/>
+            </a:srgbClr>
+          </a:solidFill>
+          <a:ln w="6350">
+            <a:solidFill>
+              <a:srgbClr val="FFFFFF"/>
+            </a:solidFill>
+            <a:prstDash val="solid"/>
+          </a:ln>
+        </p:spPr>
+      </p:sp>
+      <p:sp>
+        <p:nvSpPr>
+          <p:cNvPr id="81" name="Study 2023 14 d"/>
+          <p:cNvSpPr/>
+          <p:nvPr/>
+        </p:nvSpPr>
+        <p:spPr>
+          <a:xfrm>
+            <a:off x="10901007" y="4705069"/>
+            <a:ext cx="118872" cy="118872"/>
+          </a:xfrm>
+          <a:prstGeom prst="ellipse">
+            <a:avLst/>
+          </a:prstGeom>
+          <a:solidFill>
+            <a:srgbClr val="1F3A5F">
+              <a:alpha val="90000"/>
+            </a:srgbClr>
+          </a:solidFill>
+          <a:ln w="6350">
+            <a:solidFill>
+              <a:srgbClr val="FFFFFF"/>
+            </a:solidFill>
+            <a:prstDash val="solid"/>
+          </a:ln>
+        </p:spPr>
+      </p:sp>
+      <p:sp>
+        <p:nvSpPr>
+          <p:cNvPr id="82" name="Study 2023 90 d"/>
+          <p:cNvSpPr/>
+          <p:nvPr/>
+        </p:nvSpPr>
+        <p:spPr>
+          <a:xfrm>
+            <a:off x="10901007" y="3516349"/>
+            <a:ext cx="118872" cy="118872"/>
+          </a:xfrm>
+          <a:prstGeom prst="ellipse">
+            <a:avLst/>
+          </a:prstGeom>
+          <a:solidFill>
+            <a:srgbClr val="1F3A5F">
+              <a:alpha val="90000"/>
+            </a:srgbClr>
+          </a:solidFill>
+          <a:ln w="6350">
+            <a:solidFill>
+              <a:srgbClr val="FFFFFF"/>
+            </a:solidFill>
+            <a:prstDash val="solid"/>
+          </a:ln>
+        </p:spPr>
+      </p:sp>
+      <p:sp>
+        <p:nvSpPr>
+          <p:cNvPr id="83" name="Study 2024 5 d"/>
+          <p:cNvSpPr/>
+          <p:nvPr/>
+        </p:nvSpPr>
+        <p:spPr>
+          <a:xfrm>
+            <a:off x="11018396" y="4845839"/>
+            <a:ext cx="118872" cy="118872"/>
+          </a:xfrm>
+          <a:prstGeom prst="ellipse">
+            <a:avLst/>
+          </a:prstGeom>
+          <a:solidFill>
+            <a:srgbClr val="9AA3AE">
+              <a:alpha val="90000"/>
+            </a:srgbClr>
+          </a:solidFill>
+          <a:ln w="6350">
+            <a:solidFill>
+              <a:srgbClr val="FFFFFF"/>
+            </a:solidFill>
+            <a:prstDash val="solid"/>
+          </a:ln>
+        </p:spPr>
+      </p:sp>
+      <p:sp>
+        <p:nvSpPr>
+          <p:cNvPr id="84" name="Study 2024 14 d"/>
+          <p:cNvSpPr/>
+          <p:nvPr/>
+        </p:nvSpPr>
+        <p:spPr>
+          <a:xfrm>
+            <a:off x="11018396" y="4705069"/>
+            <a:ext cx="118872" cy="118872"/>
+          </a:xfrm>
+          <a:prstGeom prst="ellipse">
+            <a:avLst/>
+          </a:prstGeom>
+          <a:solidFill>
+            <a:srgbClr val="1F3A5F">
+              <a:alpha val="90000"/>
+            </a:srgbClr>
+          </a:solidFill>
+          <a:ln w="6350">
+            <a:solidFill>
+              <a:srgbClr val="FFFFFF"/>
+            </a:solidFill>
+            <a:prstDash val="solid"/>
+          </a:ln>
+        </p:spPr>
+      </p:sp>
+      <p:sp>
+        <p:nvSpPr>
+          <p:cNvPr id="85" name="Study 2024 60 d"/>
+          <p:cNvSpPr/>
+          <p:nvPr/>
+        </p:nvSpPr>
+        <p:spPr>
+          <a:xfrm>
+            <a:off x="11018396" y="3985581"/>
+            <a:ext cx="118872" cy="118872"/>
+          </a:xfrm>
+          <a:prstGeom prst="ellipse">
+            <a:avLst/>
+          </a:prstGeom>
+          <a:solidFill>
+            <a:srgbClr val="1F3A5F">
+              <a:alpha val="90000"/>
+            </a:srgbClr>
+          </a:solidFill>
+          <a:ln w="6350">
+            <a:solidFill>
+              <a:srgbClr val="FFFFFF"/>
+            </a:solidFill>
+            <a:prstDash val="solid"/>
+          </a:ln>
+        </p:spPr>
+      </p:sp>
+      <p:sp>
+        <p:nvSpPr>
+          <p:cNvPr id="86" name="Study 2024 70 d"/>
+          <p:cNvSpPr/>
+          <p:nvPr/>
+        </p:nvSpPr>
+        <p:spPr>
+          <a:xfrm>
+            <a:off x="11018396" y="3829170"/>
+            <a:ext cx="118872" cy="118872"/>
+          </a:xfrm>
+          <a:prstGeom prst="ellipse">
+            <a:avLst/>
+          </a:prstGeom>
+          <a:solidFill>
+            <a:srgbClr val="1F3A5F">
+              <a:alpha val="90000"/>
+            </a:srgbClr>
+          </a:solidFill>
+          <a:ln w="6350">
+            <a:solidFill>
+              <a:srgbClr val="FFFFFF"/>
+            </a:solidFill>
+            <a:prstDash val="solid"/>
+          </a:ln>
+        </p:spPr>
+      </p:sp>
+      <p:sp>
+        <p:nvSpPr>
+          <p:cNvPr id="87" name="Study 2025 5 d"/>
+          <p:cNvSpPr/>
+          <p:nvPr/>
+        </p:nvSpPr>
+        <p:spPr>
+          <a:xfrm>
+            <a:off x="11135786" y="4845839"/>
+            <a:ext cx="118872" cy="118872"/>
+          </a:xfrm>
+          <a:prstGeom prst="ellipse">
+            <a:avLst/>
+          </a:prstGeom>
+          <a:solidFill>
+            <a:srgbClr val="9AA3AE">
+              <a:alpha val="90000"/>
+            </a:srgbClr>
+          </a:solidFill>
+          <a:ln w="6350">
+            <a:solidFill>
+              <a:srgbClr val="FFFFFF"/>
+            </a:solidFill>
+            <a:prstDash val="solid"/>
+          </a:ln>
+        </p:spPr>
+      </p:sp>
+      <p:sp>
+        <p:nvSpPr>
+          <p:cNvPr id="88" name="Study 2025 14 d"/>
+          <p:cNvSpPr/>
+          <p:nvPr/>
+        </p:nvSpPr>
+        <p:spPr>
+          <a:xfrm>
+            <a:off x="11135786" y="4705069"/>
+            <a:ext cx="118872" cy="118872"/>
+          </a:xfrm>
+          <a:prstGeom prst="ellipse">
+            <a:avLst/>
+          </a:prstGeom>
+          <a:solidFill>
+            <a:srgbClr val="9AA3AE">
+              <a:alpha val="90000"/>
+            </a:srgbClr>
+          </a:solidFill>
+          <a:ln w="6350">
+            <a:solidFill>
+              <a:srgbClr val="FFFFFF"/>
+            </a:solidFill>
+            <a:prstDash val="solid"/>
+          </a:ln>
+        </p:spPr>
+      </p:sp>
+      <p:sp>
+        <p:nvSpPr>
+          <p:cNvPr id="89" name="Study 2025 14 d"/>
+          <p:cNvSpPr/>
+          <p:nvPr/>
+        </p:nvSpPr>
+        <p:spPr>
+          <a:xfrm>
+            <a:off x="11227226" y="4705069"/>
+            <a:ext cx="118872" cy="118872"/>
+          </a:xfrm>
+          <a:prstGeom prst="ellipse">
+            <a:avLst/>
+          </a:prstGeom>
+          <a:solidFill>
+            <a:srgbClr val="9AA3AE">
+              <a:alpha val="90000"/>
+            </a:srgbClr>
+          </a:solidFill>
+          <a:ln w="6350">
+            <a:solidFill>
+              <a:srgbClr val="FFFFFF"/>
+            </a:solidFill>
+            <a:prstDash val="solid"/>
+          </a:ln>
+        </p:spPr>
+      </p:sp>
+      <p:sp>
+        <p:nvSpPr>
+          <p:cNvPr id="90" name="Study 2025 60 d"/>
+          <p:cNvSpPr/>
+          <p:nvPr/>
+        </p:nvSpPr>
+        <p:spPr>
+          <a:xfrm>
+            <a:off x="11135786" y="3985581"/>
+            <a:ext cx="118872" cy="118872"/>
+          </a:xfrm>
+          <a:prstGeom prst="ellipse">
+            <a:avLst/>
+          </a:prstGeom>
+          <a:solidFill>
+            <a:srgbClr val="1F3A5F">
+              <a:alpha val="90000"/>
+            </a:srgbClr>
+          </a:solidFill>
+          <a:ln w="6350">
+            <a:solidFill>
+              <a:srgbClr val="FFFFFF"/>
+            </a:solidFill>
+            <a:prstDash val="solid"/>
+          </a:ln>
+        </p:spPr>
+      </p:sp>
+      <p:sp>
+        <p:nvSpPr>
+          <p:cNvPr id="91" name="Study 2026 5 d"/>
+          <p:cNvSpPr/>
+          <p:nvPr/>
+        </p:nvSpPr>
+        <p:spPr>
+          <a:xfrm>
+            <a:off x="11253175" y="4845839"/>
+            <a:ext cx="118872" cy="118872"/>
+          </a:xfrm>
+          <a:prstGeom prst="ellipse">
+            <a:avLst/>
+          </a:prstGeom>
+          <a:solidFill>
+            <a:srgbClr val="C08A2E">
+              <a:alpha val="90000"/>
+            </a:srgbClr>
+          </a:solidFill>
+          <a:ln w="6350">
+            <a:solidFill>
+              <a:srgbClr val="FFFFFF"/>
+            </a:solidFill>
+            <a:prstDash val="solid"/>
+          </a:ln>
+        </p:spPr>
+      </p:sp>
+      <p:sp>
+        <p:nvSpPr>
+          <p:cNvPr id="92" name="Study 2026 10 d"/>
+          <p:cNvSpPr/>
+          <p:nvPr/>
+        </p:nvSpPr>
+        <p:spPr>
+          <a:xfrm>
+            <a:off x="11253175" y="4767633"/>
+            <a:ext cx="118872" cy="118872"/>
+          </a:xfrm>
+          <a:prstGeom prst="ellipse">
+            <a:avLst/>
+          </a:prstGeom>
+          <a:solidFill>
+            <a:srgbClr val="9AA3AE">
+              <a:alpha val="90000"/>
+            </a:srgbClr>
+          </a:solidFill>
+          <a:ln w="6350">
+            <a:solidFill>
+              <a:srgbClr val="FFFFFF"/>
+            </a:solidFill>
+            <a:prstDash val="solid"/>
+          </a:ln>
+        </p:spPr>
+      </p:sp>
+      <p:sp>
+        <p:nvSpPr>
+          <p:cNvPr id="93" name="Study 2026 14 d"/>
+          <p:cNvSpPr/>
+          <p:nvPr/>
+        </p:nvSpPr>
+        <p:spPr>
+          <a:xfrm>
+            <a:off x="11253175" y="4705069"/>
+            <a:ext cx="118872" cy="118872"/>
+          </a:xfrm>
+          <a:prstGeom prst="ellipse">
+            <a:avLst/>
+          </a:prstGeom>
+          <a:solidFill>
+            <a:srgbClr val="1F3A5F">
+              <a:alpha val="90000"/>
+            </a:srgbClr>
+          </a:solidFill>
+          <a:ln w="6350">
+            <a:solidFill>
+              <a:srgbClr val="FFFFFF"/>
+            </a:solidFill>
+            <a:prstDash val="solid"/>
+          </a:ln>
+        </p:spPr>
+      </p:sp>
+      <p:sp>
+        <p:nvSpPr>
+          <p:cNvPr id="94" name="Study 2026 21 d"/>
+          <p:cNvSpPr/>
+          <p:nvPr/>
+        </p:nvSpPr>
+        <p:spPr>
+          <a:xfrm>
+            <a:off x="11253175" y="4595582"/>
+            <a:ext cx="118872" cy="118872"/>
+          </a:xfrm>
+          <a:prstGeom prst="ellipse">
+            <a:avLst/>
+          </a:prstGeom>
+          <a:solidFill>
+            <a:srgbClr val="1F3A5F">
+              <a:alpha val="90000"/>
+            </a:srgbClr>
+          </a:solidFill>
+          <a:ln w="6350">
+            <a:solidFill>
+              <a:srgbClr val="FFFFFF"/>
+            </a:solidFill>
+            <a:prstDash val="solid"/>
+          </a:ln>
+        </p:spPr>
+      </p:sp>
+      <p:sp>
+        <p:nvSpPr>
+          <p:cNvPr id="95" name="Study 2026 60 d"/>
+          <p:cNvSpPr/>
+          <p:nvPr/>
+        </p:nvSpPr>
+        <p:spPr>
+          <a:xfrm>
+            <a:off x="11253175" y="3985581"/>
+            <a:ext cx="118872" cy="118872"/>
+          </a:xfrm>
+          <a:prstGeom prst="ellipse">
+            <a:avLst/>
+          </a:prstGeom>
+          <a:solidFill>
+            <a:srgbClr val="1F3A5F">
+              <a:alpha val="90000"/>
+            </a:srgbClr>
+          </a:solidFill>
+          <a:ln w="6350">
+            <a:solidFill>
+              <a:srgbClr val="FFFFFF"/>
+            </a:solidFill>
+            <a:prstDash val="solid"/>
+          </a:ln>
+        </p:spPr>
+      </p:sp>
+      <p:sp>
+        <p:nvSpPr>
+          <p:cNvPr id="96" name="Study 2026 90 d"/>
+          <p:cNvSpPr/>
+          <p:nvPr/>
+        </p:nvSpPr>
+        <p:spPr>
+          <a:xfrm>
+            <a:off x="11253175" y="3516349"/>
+            <a:ext cx="118872" cy="118872"/>
+          </a:xfrm>
+          <a:prstGeom prst="ellipse">
+            <a:avLst/>
+          </a:prstGeom>
+          <a:solidFill>
+            <a:srgbClr val="1F3A5F">
+              <a:alpha val="90000"/>
+            </a:srgbClr>
+          </a:solidFill>
+          <a:ln w="6350">
+            <a:solidFill>
+              <a:srgbClr val="FFFFFF"/>
+            </a:solidFill>
+            <a:prstDash val="solid"/>
+          </a:ln>
+        </p:spPr>
+      </p:sp>
+      <p:sp>
+        <p:nvSpPr>
+          <p:cNvPr id="97" name="Study 2026 180 d"/>
+          <p:cNvSpPr/>
+          <p:nvPr/>
+        </p:nvSpPr>
+        <p:spPr>
+          <a:xfrm>
+            <a:off x="11253175" y="2108655"/>
+            <a:ext cx="118872" cy="118872"/>
+          </a:xfrm>
+          <a:prstGeom prst="ellipse">
+            <a:avLst/>
+          </a:prstGeom>
+          <a:solidFill>
+            <a:srgbClr val="A23B2A">
+              <a:alpha val="90000"/>
+            </a:srgbClr>
+          </a:solidFill>
+          <a:ln w="6350">
+            <a:solidFill>
+              <a:srgbClr val="FFFFFF"/>
+            </a:solidFill>
+            <a:prstDash val="solid"/>
+          </a:ln>
+        </p:spPr>
+      </p:sp>
+      <p:sp>
+        <p:nvSpPr>
+          <p:cNvPr id="98" name="Legend Head-down bed rest"/>
+          <p:cNvSpPr/>
+          <p:nvPr/>
+        </p:nvSpPr>
+        <p:spPr>
+          <a:xfrm>
+            <a:off x="6583680" y="5614416"/>
+            <a:ext cx="118872" cy="118872"/>
+          </a:xfrm>
+          <a:prstGeom prst="ellipse">
+            <a:avLst/>
+          </a:prstGeom>
+          <a:solidFill>
+            <a:srgbClr val="1F3A5F"/>
+          </a:solidFill>
+          <a:ln/>
+        </p:spPr>
+      </p:sp>
+      <p:sp>
+        <p:nvSpPr>
+          <p:cNvPr id="99" name="Text 96"/>
+          <p:cNvSpPr txBox="1"/>
+          <p:nvPr/>
+        </p:nvSpPr>
+        <p:spPr>
+          <a:xfrm>
+            <a:off x="6766560" y="5559552"/>
+            <a:ext cx="1508760" cy="228600"/>
+          </a:xfrm>
+          <a:prstGeom prst="rect">
+            <a:avLst/>
+          </a:prstGeom>
+          <a:noFill/>
+          <a:ln/>
+        </p:spPr>
+        <p:txBody>
+          <a:bodyPr wrap="square" lIns="0" tIns="0" rIns="0" bIns="0" rtlCol="0" anchor="t"/>
+          <a:lstStyle/>
+          <a:p>
+            <a:pPr indent="0" marL="0">
+              <a:buNone/>
+            </a:pPr>
+            <a:r>
+              <a:rPr lang="en-US" sz="1050" dirty="0">
                 <a:solidFill>
                   <a:schemeClr val="tx1"/>
                 </a:solidFill>
               </a:rPr>
-              <a:t>Unloading models: head-down and horizontal bed rest, dry immersion, one-leg suspension; spaceflight kept separate</a:t>
-            </a:r>
-            <a:endParaRPr lang="en-US" sz="1400" dirty="0"/>
-          </a:p>
-          <a:p>
-            <a:pPr marL="342900" indent="-342900">
-              <a:spcAft>
-                <a:spcPts val="400"/>
-              </a:spcAft>
-              <a:buSzPct val="100000"/>
-              <a:buChar char="•"/>
-            </a:pPr>
-            <a:r>
-              <a:rPr lang="en-US" sz="1600" dirty="0">
+              <a:t>Head-down bed rest</a:t>
+            </a:r>
+            <a:endParaRPr lang="en-US" sz="1050" dirty="0"/>
+          </a:p>
+        </p:txBody>
+      </p:sp>
+      <p:sp>
+        <p:nvSpPr>
+          <p:cNvPr id="100" name="Legend Horizontal bed rest"/>
+          <p:cNvSpPr/>
+          <p:nvPr/>
+        </p:nvSpPr>
+        <p:spPr>
+          <a:xfrm>
+            <a:off x="8275320" y="5614416"/>
+            <a:ext cx="118872" cy="118872"/>
+          </a:xfrm>
+          <a:prstGeom prst="ellipse">
+            <a:avLst/>
+          </a:prstGeom>
+          <a:solidFill>
+            <a:srgbClr val="9AA3AE"/>
+          </a:solidFill>
+          <a:ln/>
+        </p:spPr>
+      </p:sp>
+      <p:sp>
+        <p:nvSpPr>
+          <p:cNvPr id="101" name="Text 98"/>
+          <p:cNvSpPr txBox="1"/>
+          <p:nvPr/>
+        </p:nvSpPr>
+        <p:spPr>
+          <a:xfrm>
+            <a:off x="8458200" y="5559552"/>
+            <a:ext cx="1508760" cy="228600"/>
+          </a:xfrm>
+          <a:prstGeom prst="rect">
+            <a:avLst/>
+          </a:prstGeom>
+          <a:noFill/>
+          <a:ln/>
+        </p:spPr>
+        <p:txBody>
+          <a:bodyPr wrap="square" lIns="0" tIns="0" rIns="0" bIns="0" rtlCol="0" anchor="t"/>
+          <a:lstStyle/>
+          <a:p>
+            <a:pPr indent="0" marL="0">
+              <a:buNone/>
+            </a:pPr>
+            <a:r>
+              <a:rPr lang="en-US" sz="1050" dirty="0">
                 <a:solidFill>
                   <a:schemeClr val="tx1"/>
                 </a:solidFill>
               </a:rPr>
-              <a:t>At least 5 days of continuous unloading; scans from day 5 to day 119</a:t>
-            </a:r>
-            <a:endParaRPr lang="en-US" sz="1400" dirty="0"/>
-          </a:p>
-          <a:p>
-            <a:pPr marL="342900" indent="-342900">
-              <a:spcAft>
-                <a:spcPts val="400"/>
-              </a:spcAft>
-              <a:buSzPct val="100000"/>
-              <a:buChar char="•"/>
-            </a:pPr>
-            <a:r>
-              <a:rPr lang="en-US" sz="1600" dirty="0">
+              <a:t>Horizontal bed rest</a:t>
+            </a:r>
+            <a:endParaRPr lang="en-US" sz="1050" dirty="0"/>
+          </a:p>
+        </p:txBody>
+      </p:sp>
+      <p:sp>
+        <p:nvSpPr>
+          <p:cNvPr id="102" name="Legend Spaceflight"/>
+          <p:cNvSpPr/>
+          <p:nvPr/>
+        </p:nvSpPr>
+        <p:spPr>
+          <a:xfrm>
+            <a:off x="9966960" y="5614416"/>
+            <a:ext cx="118872" cy="118872"/>
+          </a:xfrm>
+          <a:prstGeom prst="ellipse">
+            <a:avLst/>
+          </a:prstGeom>
+          <a:solidFill>
+            <a:srgbClr val="A23B2A"/>
+          </a:solidFill>
+          <a:ln/>
+        </p:spPr>
+      </p:sp>
+      <p:sp>
+        <p:nvSpPr>
+          <p:cNvPr id="103" name="Text 100"/>
+          <p:cNvSpPr txBox="1"/>
+          <p:nvPr/>
+        </p:nvSpPr>
+        <p:spPr>
+          <a:xfrm>
+            <a:off x="10149840" y="5559552"/>
+            <a:ext cx="1508760" cy="228600"/>
+          </a:xfrm>
+          <a:prstGeom prst="rect">
+            <a:avLst/>
+          </a:prstGeom>
+          <a:noFill/>
+          <a:ln/>
+        </p:spPr>
+        <p:txBody>
+          <a:bodyPr wrap="square" lIns="0" tIns="0" rIns="0" bIns="0" rtlCol="0" anchor="t"/>
+          <a:lstStyle/>
+          <a:p>
+            <a:pPr indent="0" marL="0">
+              <a:buNone/>
+            </a:pPr>
+            <a:r>
+              <a:rPr lang="en-US" sz="1050" dirty="0">
                 <a:solidFill>
                   <a:schemeClr val="tx1"/>
                 </a:solidFill>
               </a:rPr>
-              <a:t>Leg muscle size measured as volume, cross-sectional area, thickness or lean mass, by MRI, CT, DXA, pQCT or ultrasound</a:t>
-            </a:r>
-            <a:endParaRPr lang="en-US" sz="1400" dirty="0"/>
+              <a:t>Spaceflight</a:t>
+            </a:r>
+            <a:endParaRPr lang="en-US" sz="1050" dirty="0"/>
+          </a:p>
+        </p:txBody>
+      </p:sp>
+      <p:sp>
+        <p:nvSpPr>
+          <p:cNvPr id="104" name="Legend Limb suspension"/>
+          <p:cNvSpPr/>
+          <p:nvPr/>
+        </p:nvSpPr>
+        <p:spPr>
+          <a:xfrm>
+            <a:off x="6583680" y="5861304"/>
+            <a:ext cx="118872" cy="118872"/>
+          </a:xfrm>
+          <a:prstGeom prst="ellipse">
+            <a:avLst/>
+          </a:prstGeom>
+          <a:solidFill>
+            <a:srgbClr val="2E8B57"/>
+          </a:solidFill>
+          <a:ln/>
+        </p:spPr>
+      </p:sp>
+      <p:sp>
+        <p:nvSpPr>
+          <p:cNvPr id="105" name="Text 102"/>
+          <p:cNvSpPr txBox="1"/>
+          <p:nvPr/>
+        </p:nvSpPr>
+        <p:spPr>
+          <a:xfrm>
+            <a:off x="6766560" y="5806440"/>
+            <a:ext cx="1508760" cy="228600"/>
+          </a:xfrm>
+          <a:prstGeom prst="rect">
+            <a:avLst/>
+          </a:prstGeom>
+          <a:noFill/>
+          <a:ln/>
+        </p:spPr>
+        <p:txBody>
+          <a:bodyPr wrap="square" lIns="0" tIns="0" rIns="0" bIns="0" rtlCol="0" anchor="t"/>
+          <a:lstStyle/>
+          <a:p>
+            <a:pPr indent="0" marL="0">
+              <a:buNone/>
+            </a:pPr>
+            <a:r>
+              <a:rPr lang="en-US" sz="1050" dirty="0">
+                <a:solidFill>
+                  <a:schemeClr val="tx1"/>
+                </a:solidFill>
+              </a:rPr>
+              <a:t>Limb suspension</a:t>
+            </a:r>
+            <a:endParaRPr lang="en-US" sz="1050" dirty="0"/>
+          </a:p>
+        </p:txBody>
+      </p:sp>
+      <p:sp>
+        <p:nvSpPr>
+          <p:cNvPr id="106" name="Legend Dry immersion"/>
+          <p:cNvSpPr/>
+          <p:nvPr/>
+        </p:nvSpPr>
+        <p:spPr>
+          <a:xfrm>
+            <a:off x="8275320" y="5861304"/>
+            <a:ext cx="118872" cy="118872"/>
+          </a:xfrm>
+          <a:prstGeom prst="ellipse">
+            <a:avLst/>
+          </a:prstGeom>
+          <a:solidFill>
+            <a:srgbClr val="C08A2E"/>
+          </a:solidFill>
+          <a:ln/>
+        </p:spPr>
+      </p:sp>
+      <p:sp>
+        <p:nvSpPr>
+          <p:cNvPr id="107" name="Text 104"/>
+          <p:cNvSpPr txBox="1"/>
+          <p:nvPr/>
+        </p:nvSpPr>
+        <p:spPr>
+          <a:xfrm>
+            <a:off x="8458200" y="5806440"/>
+            <a:ext cx="1508760" cy="228600"/>
+          </a:xfrm>
+          <a:prstGeom prst="rect">
+            <a:avLst/>
+          </a:prstGeom>
+          <a:noFill/>
+          <a:ln/>
+        </p:spPr>
+        <p:txBody>
+          <a:bodyPr wrap="square" lIns="0" tIns="0" rIns="0" bIns="0" rtlCol="0" anchor="t"/>
+          <a:lstStyle/>
+          <a:p>
+            <a:pPr indent="0" marL="0">
+              <a:buNone/>
+            </a:pPr>
+            <a:r>
+              <a:rPr lang="en-US" sz="1050" dirty="0">
+                <a:solidFill>
+                  <a:schemeClr val="tx1"/>
+                </a:solidFill>
+              </a:rPr>
+              <a:t>Dry immersion</a:t>
+            </a:r>
+            <a:endParaRPr lang="en-US" sz="1050" dirty="0"/>
           </a:p>
         </p:txBody>
       </p:sp>

</xml_diff>

<commit_message>
Slide 5: drop years without studies from the per-year chart
Co-Authored-By: Claude Opus 5.5 (1M context) <noreply@anthropic.com>
Claude-Session: https://claude.ai/code/session_01JZtuYERhuCe7nB9VYHwcfv
</commit_message>
<xml_diff>
--- a/presentation/bed-rest-to-mars-talk.pptx
+++ b/presentation/bed-rest-to-mars-talk.pptx
@@ -126,13 +126,13 @@
   <p:extLst>
     <p:ext uri="{521415D9-36F7-43E2-AB2F-B90AF26B5E84}">
       <p14:sectionLst xmlns:p14="http://schemas.microsoft.com/office/powerpoint/2010/main">
-        <p14:section name="Opening" id="{a55e8b52-811a-9921-2b22-f82a1a81b126}">
+        <p14:section name="Opening" id="{8200937f-fca0-9c57-d781-3fa0ab7c8c26}">
           <p14:sldIdLst>
             <p14:sldId id="256"/>
             <p14:sldId id="257"/>
           </p14:sldIdLst>
         </p14:section>
-        <p14:section name="Part 1" id="{ebc53338-b4bc-2bbf-309e-3a6d88551e3e}">
+        <p14:section name="Part 1" id="{235feb38-58c1-c895-4b60-e38eebe42b7c}">
           <p14:sldIdLst>
             <p14:sldId id="258"/>
             <p14:sldId id="259"/>
@@ -143,7 +143,7 @@
             <p14:sldId id="264"/>
           </p14:sldIdLst>
         </p14:section>
-        <p14:section name="Part 2" id="{3d16ab9f-b139-187a-803e-32b9b79517b2}">
+        <p14:section name="Part 2" id="{e61f855c-f054-8d6a-6683-971f2afef114}">
           <p14:sldIdLst>
             <p14:sldId id="265"/>
             <p14:sldId id="266"/>
@@ -154,7 +154,7 @@
             <p14:sldId id="271"/>
           </p14:sldIdLst>
         </p14:section>
-        <p14:section name="Backup" id="{3b979c00-d36c-d9eb-4683-273966c43a47}">
+        <p14:section name="Backup" id="{82bb06b6-91f8-6a1a-bd6c-d9c4131bdbee}">
           <p14:sldIdLst>
             <p14:sldId id="272"/>
             <p14:sldId id="273"/>
@@ -162,13 +162,13 @@
             <p14:sldId id="275"/>
           </p14:sldIdLst>
         </p14:section>
-        <p14:section name="Backup" id="{745247d0-4f82-ce28-e3ea-a26b52b7924a}">
+        <p14:section name="Backup" id="{9af805af-444d-1e42-3655-cbc8672df944}">
           <p14:sldIdLst/>
         </p14:section>
-        <p14:section name="Backup" id="{e361a913-acab-3c97-9f37-48fc5f9d8136}">
+        <p14:section name="Backup" id="{da237d4f-a510-b6d0-e0e7-166592f1f99a}">
           <p14:sldIdLst/>
         </p14:section>
-        <p14:section name="Backup" id="{245be626-f17e-796f-e570-37d78b456c4d}">
+        <p14:section name="Backup" id="{932b1589-abf5-123b-eee3-928fd4745e3d}">
           <p14:sldIdLst/>
         </p14:section>
       </p14:sectionLst>
@@ -206,7 +206,7 @@
                 </a:solidFill>
                 <a:latin typeface="Arial"/>
               </a:rPr>
-              <a:t>Studies published per year, by length of unloading</a:t>
+              <a:t>Studies published per year, by length of unloading (years without studies omitted)</a:t>
             </a:r>
           </a:p>
         </c:rich>
@@ -278,113 +278,68 @@
           </c:dLbls>
           <c:cat>
             <c:multiLvlStrRef>
-              <c:f>Sheet1!$A$2:$A$36</c:f>
+              <c:f>Sheet1!$A$2:$A$21</c:f>
               <c:multiLvlStrCache>
-                <c:ptCount val="35"/>
+                <c:ptCount val="20"/>
                 <c:lvl>
                   <c:pt idx="0">
                     <c:v>1992</c:v>
                   </c:pt>
                   <c:pt idx="1">
-                    <c:v>​</c:v>
+                    <c:v>1994</c:v>
                   </c:pt>
                   <c:pt idx="2">
-                    <c:v>1994</c:v>
+                    <c:v>2004</c:v>
                   </c:pt>
                   <c:pt idx="3">
-                    <c:v>​​​</c:v>
+                    <c:v>2007</c:v>
                   </c:pt>
                   <c:pt idx="4">
-                    <c:v>1996</c:v>
+                    <c:v>2009</c:v>
                   </c:pt>
                   <c:pt idx="5">
-                    <c:v>​​​​​</c:v>
+                    <c:v>2012</c:v>
                   </c:pt>
                   <c:pt idx="6">
-                    <c:v>1998</c:v>
+                    <c:v>2013</c:v>
                   </c:pt>
                   <c:pt idx="7">
-                    <c:v>​​​​​​​</c:v>
+                    <c:v>2014</c:v>
                   </c:pt>
                   <c:pt idx="8">
-                    <c:v>2000</c:v>
+                    <c:v>2015</c:v>
                   </c:pt>
                   <c:pt idx="9">
-                    <c:v>​​​​​​​​​</c:v>
+                    <c:v>2016</c:v>
                   </c:pt>
                   <c:pt idx="10">
-                    <c:v>2002</c:v>
+                    <c:v>2017</c:v>
                   </c:pt>
                   <c:pt idx="11">
-                    <c:v>​​​​​​​​​​​</c:v>
+                    <c:v>2018</c:v>
                   </c:pt>
                   <c:pt idx="12">
-                    <c:v>2004</c:v>
+                    <c:v>2019</c:v>
                   </c:pt>
                   <c:pt idx="13">
-                    <c:v>​​​​​​​​​​​​​</c:v>
+                    <c:v>2020</c:v>
                   </c:pt>
                   <c:pt idx="14">
-                    <c:v>2006</c:v>
+                    <c:v>2021</c:v>
                   </c:pt>
                   <c:pt idx="15">
-                    <c:v>​​​​​​​​​​​​​​​</c:v>
+                    <c:v>2022</c:v>
                   </c:pt>
                   <c:pt idx="16">
-                    <c:v>2008</c:v>
+                    <c:v>2023</c:v>
                   </c:pt>
                   <c:pt idx="17">
-                    <c:v>​​​​​​​​​​​​​​​​​</c:v>
+                    <c:v>2024</c:v>
                   </c:pt>
                   <c:pt idx="18">
-                    <c:v>2010</c:v>
+                    <c:v>2025</c:v>
                   </c:pt>
                   <c:pt idx="19">
-                    <c:v>​​​​​​​​​​​​​​​​​​​</c:v>
-                  </c:pt>
-                  <c:pt idx="20">
-                    <c:v>2012</c:v>
-                  </c:pt>
-                  <c:pt idx="21">
-                    <c:v>​​​​​​​​​​​​​​​​​​​​​</c:v>
-                  </c:pt>
-                  <c:pt idx="22">
-                    <c:v>2014</c:v>
-                  </c:pt>
-                  <c:pt idx="23">
-                    <c:v>​​​​​​​​​​​​​​​​​​​​​​​</c:v>
-                  </c:pt>
-                  <c:pt idx="24">
-                    <c:v>2016</c:v>
-                  </c:pt>
-                  <c:pt idx="25">
-                    <c:v>​​​​​​​​​​​​​​​​​​​​​​​​​</c:v>
-                  </c:pt>
-                  <c:pt idx="26">
-                    <c:v>2018</c:v>
-                  </c:pt>
-                  <c:pt idx="27">
-                    <c:v>​​​​​​​​​​​​​​​​​​​​​​​​​​​</c:v>
-                  </c:pt>
-                  <c:pt idx="28">
-                    <c:v>2020</c:v>
-                  </c:pt>
-                  <c:pt idx="29">
-                    <c:v>​​​​​​​​​​​​​​​​​​​​​​​​​​​​​</c:v>
-                  </c:pt>
-                  <c:pt idx="30">
-                    <c:v>2022</c:v>
-                  </c:pt>
-                  <c:pt idx="31">
-                    <c:v>​​​​​​​​​​​​​​​​​​​​​​​​​​​​​​​</c:v>
-                  </c:pt>
-                  <c:pt idx="32">
-                    <c:v>2024</c:v>
-                  </c:pt>
-                  <c:pt idx="33">
-                    <c:v>​​​​​​​​​​​​​​​​​​​​​​​​​​​​​​​​​</c:v>
-                  </c:pt>
-                  <c:pt idx="34">
                     <c:v>2026</c:v>
                   </c:pt>
                 </c:lvl>
@@ -393,10 +348,10 @@
           </c:cat>
           <c:val>
             <c:numRef>
-              <c:f>Sheet1!$B$2:$B$36</c:f>
+              <c:f>Sheet1!$B$2:$B$21</c:f>
               <c:numCache>
                 <c:formatCode>General</c:formatCode>
-                <c:ptCount val="35"/>
+                <c:ptCount val="20"/>
                 <c:pt idx="0">
                   <c:v>0</c:v>
                 </c:pt>
@@ -410,96 +365,51 @@
                   <c:v>0</c:v>
                 </c:pt>
                 <c:pt idx="4">
-                  <c:v>0</c:v>
+                  <c:v>1</c:v>
                 </c:pt>
                 <c:pt idx="5">
                   <c:v>0</c:v>
                 </c:pt>
                 <c:pt idx="6">
-                  <c:v>0</c:v>
+                  <c:v>1</c:v>
                 </c:pt>
                 <c:pt idx="7">
                   <c:v>0</c:v>
                 </c:pt>
                 <c:pt idx="8">
-                  <c:v>0</c:v>
+                  <c:v>2</c:v>
                 </c:pt>
                 <c:pt idx="9">
-                  <c:v>0</c:v>
+                  <c:v>2</c:v>
                 </c:pt>
                 <c:pt idx="10">
                   <c:v>0</c:v>
                 </c:pt>
                 <c:pt idx="11">
-                  <c:v>0</c:v>
+                  <c:v>1</c:v>
                 </c:pt>
                 <c:pt idx="12">
-                  <c:v>0</c:v>
+                  <c:v>2</c:v>
                 </c:pt>
                 <c:pt idx="13">
                   <c:v>0</c:v>
                 </c:pt>
                 <c:pt idx="14">
-                  <c:v>0</c:v>
+                  <c:v>2</c:v>
                 </c:pt>
                 <c:pt idx="15">
-                  <c:v>0</c:v>
+                  <c:v>2</c:v>
                 </c:pt>
                 <c:pt idx="16">
-                  <c:v>0</c:v>
+                  <c:v>1</c:v>
                 </c:pt>
                 <c:pt idx="17">
-                  <c:v>1</c:v>
+                  <c:v>2</c:v>
                 </c:pt>
                 <c:pt idx="18">
-                  <c:v>0</c:v>
+                  <c:v>3</c:v>
                 </c:pt>
                 <c:pt idx="19">
-                  <c:v>0</c:v>
-                </c:pt>
-                <c:pt idx="20">
-                  <c:v>0</c:v>
-                </c:pt>
-                <c:pt idx="21">
-                  <c:v>1</c:v>
-                </c:pt>
-                <c:pt idx="22">
-                  <c:v>0</c:v>
-                </c:pt>
-                <c:pt idx="23">
-                  <c:v>2</c:v>
-                </c:pt>
-                <c:pt idx="24">
-                  <c:v>2</c:v>
-                </c:pt>
-                <c:pt idx="25">
-                  <c:v>0</c:v>
-                </c:pt>
-                <c:pt idx="26">
-                  <c:v>1</c:v>
-                </c:pt>
-                <c:pt idx="27">
-                  <c:v>2</c:v>
-                </c:pt>
-                <c:pt idx="28">
-                  <c:v>0</c:v>
-                </c:pt>
-                <c:pt idx="29">
-                  <c:v>2</c:v>
-                </c:pt>
-                <c:pt idx="30">
-                  <c:v>2</c:v>
-                </c:pt>
-                <c:pt idx="31">
-                  <c:v>1</c:v>
-                </c:pt>
-                <c:pt idx="32">
-                  <c:v>2</c:v>
-                </c:pt>
-                <c:pt idx="33">
-                  <c:v>3</c:v>
-                </c:pt>
-                <c:pt idx="34">
                   <c:v>3</c:v>
                 </c:pt>
               </c:numCache>
@@ -553,113 +463,68 @@
           </c:dLbls>
           <c:cat>
             <c:multiLvlStrRef>
-              <c:f>Sheet1!$A$2:$A$36</c:f>
+              <c:f>Sheet1!$A$2:$A$21</c:f>
               <c:multiLvlStrCache>
-                <c:ptCount val="35"/>
+                <c:ptCount val="20"/>
                 <c:lvl>
                   <c:pt idx="0">
                     <c:v>1992</c:v>
                   </c:pt>
                   <c:pt idx="1">
-                    <c:v>​</c:v>
+                    <c:v>1994</c:v>
                   </c:pt>
                   <c:pt idx="2">
-                    <c:v>1994</c:v>
+                    <c:v>2004</c:v>
                   </c:pt>
                   <c:pt idx="3">
-                    <c:v>​​​</c:v>
+                    <c:v>2007</c:v>
                   </c:pt>
                   <c:pt idx="4">
-                    <c:v>1996</c:v>
+                    <c:v>2009</c:v>
                   </c:pt>
                   <c:pt idx="5">
-                    <c:v>​​​​​</c:v>
+                    <c:v>2012</c:v>
                   </c:pt>
                   <c:pt idx="6">
-                    <c:v>1998</c:v>
+                    <c:v>2013</c:v>
                   </c:pt>
                   <c:pt idx="7">
-                    <c:v>​​​​​​​</c:v>
+                    <c:v>2014</c:v>
                   </c:pt>
                   <c:pt idx="8">
-                    <c:v>2000</c:v>
+                    <c:v>2015</c:v>
                   </c:pt>
                   <c:pt idx="9">
-                    <c:v>​​​​​​​​​</c:v>
+                    <c:v>2016</c:v>
                   </c:pt>
                   <c:pt idx="10">
-                    <c:v>2002</c:v>
+                    <c:v>2017</c:v>
                   </c:pt>
                   <c:pt idx="11">
-                    <c:v>​​​​​​​​​​​</c:v>
+                    <c:v>2018</c:v>
                   </c:pt>
                   <c:pt idx="12">
-                    <c:v>2004</c:v>
+                    <c:v>2019</c:v>
                   </c:pt>
                   <c:pt idx="13">
-                    <c:v>​​​​​​​​​​​​​</c:v>
+                    <c:v>2020</c:v>
                   </c:pt>
                   <c:pt idx="14">
-                    <c:v>2006</c:v>
+                    <c:v>2021</c:v>
                   </c:pt>
                   <c:pt idx="15">
-                    <c:v>​​​​​​​​​​​​​​​</c:v>
+                    <c:v>2022</c:v>
                   </c:pt>
                   <c:pt idx="16">
-                    <c:v>2008</c:v>
+                    <c:v>2023</c:v>
                   </c:pt>
                   <c:pt idx="17">
-                    <c:v>​​​​​​​​​​​​​​​​​</c:v>
+                    <c:v>2024</c:v>
                   </c:pt>
                   <c:pt idx="18">
-                    <c:v>2010</c:v>
+                    <c:v>2025</c:v>
                   </c:pt>
                   <c:pt idx="19">
-                    <c:v>​​​​​​​​​​​​​​​​​​​</c:v>
-                  </c:pt>
-                  <c:pt idx="20">
-                    <c:v>2012</c:v>
-                  </c:pt>
-                  <c:pt idx="21">
-                    <c:v>​​​​​​​​​​​​​​​​​​​​​</c:v>
-                  </c:pt>
-                  <c:pt idx="22">
-                    <c:v>2014</c:v>
-                  </c:pt>
-                  <c:pt idx="23">
-                    <c:v>​​​​​​​​​​​​​​​​​​​​​​​</c:v>
-                  </c:pt>
-                  <c:pt idx="24">
-                    <c:v>2016</c:v>
-                  </c:pt>
-                  <c:pt idx="25">
-                    <c:v>​​​​​​​​​​​​​​​​​​​​​​​​​</c:v>
-                  </c:pt>
-                  <c:pt idx="26">
-                    <c:v>2018</c:v>
-                  </c:pt>
-                  <c:pt idx="27">
-                    <c:v>​​​​​​​​​​​​​​​​​​​​​​​​​​​</c:v>
-                  </c:pt>
-                  <c:pt idx="28">
-                    <c:v>2020</c:v>
-                  </c:pt>
-                  <c:pt idx="29">
-                    <c:v>​​​​​​​​​​​​​​​​​​​​​​​​​​​​​</c:v>
-                  </c:pt>
-                  <c:pt idx="30">
-                    <c:v>2022</c:v>
-                  </c:pt>
-                  <c:pt idx="31">
-                    <c:v>​​​​​​​​​​​​​​​​​​​​​​​​​​​​​​​</c:v>
-                  </c:pt>
-                  <c:pt idx="32">
-                    <c:v>2024</c:v>
-                  </c:pt>
-                  <c:pt idx="33">
-                    <c:v>​​​​​​​​​​​​​​​​​​​​​​​​​​​​​​​​​</c:v>
-                  </c:pt>
-                  <c:pt idx="34">
                     <c:v>2026</c:v>
                   </c:pt>
                 </c:lvl>
@@ -668,18 +533,18 @@
           </c:cat>
           <c:val>
             <c:numRef>
-              <c:f>Sheet1!$C$2:$C$36</c:f>
+              <c:f>Sheet1!$C$2:$C$21</c:f>
               <c:numCache>
                 <c:formatCode>General</c:formatCode>
-                <c:ptCount val="35"/>
+                <c:ptCount val="20"/>
                 <c:pt idx="0">
                   <c:v>0</c:v>
                 </c:pt>
                 <c:pt idx="1">
-                  <c:v>0</c:v>
+                  <c:v>1</c:v>
                 </c:pt>
                 <c:pt idx="2">
-                  <c:v>1</c:v>
+                  <c:v>0</c:v>
                 </c:pt>
                 <c:pt idx="3">
                   <c:v>0</c:v>
@@ -694,7 +559,7 @@
                   <c:v>0</c:v>
                 </c:pt>
                 <c:pt idx="7">
-                  <c:v>0</c:v>
+                  <c:v>1</c:v>
                 </c:pt>
                 <c:pt idx="8">
                   <c:v>0</c:v>
@@ -706,13 +571,13 @@
                   <c:v>0</c:v>
                 </c:pt>
                 <c:pt idx="11">
-                  <c:v>0</c:v>
+                  <c:v>1</c:v>
                 </c:pt>
                 <c:pt idx="12">
                   <c:v>0</c:v>
                 </c:pt>
                 <c:pt idx="13">
-                  <c:v>0</c:v>
+                  <c:v>1</c:v>
                 </c:pt>
                 <c:pt idx="14">
                   <c:v>0</c:v>
@@ -730,51 +595,6 @@
                   <c:v>0</c:v>
                 </c:pt>
                 <c:pt idx="19">
-                  <c:v>0</c:v>
-                </c:pt>
-                <c:pt idx="20">
-                  <c:v>0</c:v>
-                </c:pt>
-                <c:pt idx="21">
-                  <c:v>0</c:v>
-                </c:pt>
-                <c:pt idx="22">
-                  <c:v>1</c:v>
-                </c:pt>
-                <c:pt idx="23">
-                  <c:v>0</c:v>
-                </c:pt>
-                <c:pt idx="24">
-                  <c:v>0</c:v>
-                </c:pt>
-                <c:pt idx="25">
-                  <c:v>0</c:v>
-                </c:pt>
-                <c:pt idx="26">
-                  <c:v>1</c:v>
-                </c:pt>
-                <c:pt idx="27">
-                  <c:v>0</c:v>
-                </c:pt>
-                <c:pt idx="28">
-                  <c:v>1</c:v>
-                </c:pt>
-                <c:pt idx="29">
-                  <c:v>0</c:v>
-                </c:pt>
-                <c:pt idx="30">
-                  <c:v>0</c:v>
-                </c:pt>
-                <c:pt idx="31">
-                  <c:v>0</c:v>
-                </c:pt>
-                <c:pt idx="32">
-                  <c:v>0</c:v>
-                </c:pt>
-                <c:pt idx="33">
-                  <c:v>0</c:v>
-                </c:pt>
-                <c:pt idx="34">
                   <c:v>1</c:v>
                 </c:pt>
               </c:numCache>
@@ -828,113 +648,68 @@
           </c:dLbls>
           <c:cat>
             <c:multiLvlStrRef>
-              <c:f>Sheet1!$A$2:$A$36</c:f>
+              <c:f>Sheet1!$A$2:$A$21</c:f>
               <c:multiLvlStrCache>
-                <c:ptCount val="35"/>
+                <c:ptCount val="20"/>
                 <c:lvl>
                   <c:pt idx="0">
                     <c:v>1992</c:v>
                   </c:pt>
                   <c:pt idx="1">
-                    <c:v>​</c:v>
+                    <c:v>1994</c:v>
                   </c:pt>
                   <c:pt idx="2">
-                    <c:v>1994</c:v>
+                    <c:v>2004</c:v>
                   </c:pt>
                   <c:pt idx="3">
-                    <c:v>​​​</c:v>
+                    <c:v>2007</c:v>
                   </c:pt>
                   <c:pt idx="4">
-                    <c:v>1996</c:v>
+                    <c:v>2009</c:v>
                   </c:pt>
                   <c:pt idx="5">
-                    <c:v>​​​​​</c:v>
+                    <c:v>2012</c:v>
                   </c:pt>
                   <c:pt idx="6">
-                    <c:v>1998</c:v>
+                    <c:v>2013</c:v>
                   </c:pt>
                   <c:pt idx="7">
-                    <c:v>​​​​​​​</c:v>
+                    <c:v>2014</c:v>
                   </c:pt>
                   <c:pt idx="8">
-                    <c:v>2000</c:v>
+                    <c:v>2015</c:v>
                   </c:pt>
                   <c:pt idx="9">
-                    <c:v>​​​​​​​​​</c:v>
+                    <c:v>2016</c:v>
                   </c:pt>
                   <c:pt idx="10">
-                    <c:v>2002</c:v>
+                    <c:v>2017</c:v>
                   </c:pt>
                   <c:pt idx="11">
-                    <c:v>​​​​​​​​​​​</c:v>
+                    <c:v>2018</c:v>
                   </c:pt>
                   <c:pt idx="12">
-                    <c:v>2004</c:v>
+                    <c:v>2019</c:v>
                   </c:pt>
                   <c:pt idx="13">
-                    <c:v>​​​​​​​​​​​​​</c:v>
+                    <c:v>2020</c:v>
                   </c:pt>
                   <c:pt idx="14">
-                    <c:v>2006</c:v>
+                    <c:v>2021</c:v>
                   </c:pt>
                   <c:pt idx="15">
-                    <c:v>​​​​​​​​​​​​​​​</c:v>
+                    <c:v>2022</c:v>
                   </c:pt>
                   <c:pt idx="16">
-                    <c:v>2008</c:v>
+                    <c:v>2023</c:v>
                   </c:pt>
                   <c:pt idx="17">
-                    <c:v>​​​​​​​​​​​​​​​​​</c:v>
+                    <c:v>2024</c:v>
                   </c:pt>
                   <c:pt idx="18">
-                    <c:v>2010</c:v>
+                    <c:v>2025</c:v>
                   </c:pt>
                   <c:pt idx="19">
-                    <c:v>​​​​​​​​​​​​​​​​​​​</c:v>
-                  </c:pt>
-                  <c:pt idx="20">
-                    <c:v>2012</c:v>
-                  </c:pt>
-                  <c:pt idx="21">
-                    <c:v>​​​​​​​​​​​​​​​​​​​​​</c:v>
-                  </c:pt>
-                  <c:pt idx="22">
-                    <c:v>2014</c:v>
-                  </c:pt>
-                  <c:pt idx="23">
-                    <c:v>​​​​​​​​​​​​​​​​​​​​​​​</c:v>
-                  </c:pt>
-                  <c:pt idx="24">
-                    <c:v>2016</c:v>
-                  </c:pt>
-                  <c:pt idx="25">
-                    <c:v>​​​​​​​​​​​​​​​​​​​​​​​​​</c:v>
-                  </c:pt>
-                  <c:pt idx="26">
-                    <c:v>2018</c:v>
-                  </c:pt>
-                  <c:pt idx="27">
-                    <c:v>​​​​​​​​​​​​​​​​​​​​​​​​​​​</c:v>
-                  </c:pt>
-                  <c:pt idx="28">
-                    <c:v>2020</c:v>
-                  </c:pt>
-                  <c:pt idx="29">
-                    <c:v>​​​​​​​​​​​​​​​​​​​​​​​​​​​​​</c:v>
-                  </c:pt>
-                  <c:pt idx="30">
-                    <c:v>2022</c:v>
-                  </c:pt>
-                  <c:pt idx="31">
-                    <c:v>​​​​​​​​​​​​​​​​​​​​​​​​​​​​​​​</c:v>
-                  </c:pt>
-                  <c:pt idx="32">
-                    <c:v>2024</c:v>
-                  </c:pt>
-                  <c:pt idx="33">
-                    <c:v>​​​​​​​​​​​​​​​​​​​​​​​​​​​​​​​​​</c:v>
-                  </c:pt>
-                  <c:pt idx="34">
                     <c:v>2026</c:v>
                   </c:pt>
                 </c:lvl>
@@ -943,10 +718,10 @@
           </c:cat>
           <c:val>
             <c:numRef>
-              <c:f>Sheet1!$D$2:$D$36</c:f>
+              <c:f>Sheet1!$D$2:$D$21</c:f>
               <c:numCache>
                 <c:formatCode>General</c:formatCode>
-                <c:ptCount val="35"/>
+                <c:ptCount val="20"/>
                 <c:pt idx="0">
                   <c:v>0</c:v>
                 </c:pt>
@@ -957,28 +732,28 @@
                   <c:v>0</c:v>
                 </c:pt>
                 <c:pt idx="3">
-                  <c:v>0</c:v>
+                  <c:v>2</c:v>
                 </c:pt>
                 <c:pt idx="4">
-                  <c:v>0</c:v>
+                  <c:v>1</c:v>
                 </c:pt>
                 <c:pt idx="5">
-                  <c:v>0</c:v>
+                  <c:v>1</c:v>
                 </c:pt>
                 <c:pt idx="6">
                   <c:v>0</c:v>
                 </c:pt>
                 <c:pt idx="7">
-                  <c:v>0</c:v>
+                  <c:v>1</c:v>
                 </c:pt>
                 <c:pt idx="8">
-                  <c:v>0</c:v>
+                  <c:v>1</c:v>
                 </c:pt>
                 <c:pt idx="9">
-                  <c:v>0</c:v>
+                  <c:v>1</c:v>
                 </c:pt>
                 <c:pt idx="10">
-                  <c:v>0</c:v>
+                  <c:v>1</c:v>
                 </c:pt>
                 <c:pt idx="11">
                   <c:v>0</c:v>
@@ -990,10 +765,10 @@
                   <c:v>0</c:v>
                 </c:pt>
                 <c:pt idx="14">
-                  <c:v>0</c:v>
+                  <c:v>2</c:v>
                 </c:pt>
                 <c:pt idx="15">
-                  <c:v>2</c:v>
+                  <c:v>1</c:v>
                 </c:pt>
                 <c:pt idx="16">
                   <c:v>0</c:v>
@@ -1002,54 +777,9 @@
                   <c:v>1</c:v>
                 </c:pt>
                 <c:pt idx="18">
-                  <c:v>0</c:v>
+                  <c:v>1</c:v>
                 </c:pt>
                 <c:pt idx="19">
-                  <c:v>0</c:v>
-                </c:pt>
-                <c:pt idx="20">
-                  <c:v>1</c:v>
-                </c:pt>
-                <c:pt idx="21">
-                  <c:v>0</c:v>
-                </c:pt>
-                <c:pt idx="22">
-                  <c:v>1</c:v>
-                </c:pt>
-                <c:pt idx="23">
-                  <c:v>1</c:v>
-                </c:pt>
-                <c:pt idx="24">
-                  <c:v>1</c:v>
-                </c:pt>
-                <c:pt idx="25">
-                  <c:v>1</c:v>
-                </c:pt>
-                <c:pt idx="26">
-                  <c:v>0</c:v>
-                </c:pt>
-                <c:pt idx="27">
-                  <c:v>0</c:v>
-                </c:pt>
-                <c:pt idx="28">
-                  <c:v>0</c:v>
-                </c:pt>
-                <c:pt idx="29">
-                  <c:v>2</c:v>
-                </c:pt>
-                <c:pt idx="30">
-                  <c:v>1</c:v>
-                </c:pt>
-                <c:pt idx="31">
-                  <c:v>0</c:v>
-                </c:pt>
-                <c:pt idx="32">
-                  <c:v>1</c:v>
-                </c:pt>
-                <c:pt idx="33">
-                  <c:v>1</c:v>
-                </c:pt>
-                <c:pt idx="34">
                   <c:v>1</c:v>
                 </c:pt>
               </c:numCache>
@@ -1103,113 +833,68 @@
           </c:dLbls>
           <c:cat>
             <c:multiLvlStrRef>
-              <c:f>Sheet1!$A$2:$A$36</c:f>
+              <c:f>Sheet1!$A$2:$A$21</c:f>
               <c:multiLvlStrCache>
-                <c:ptCount val="35"/>
+                <c:ptCount val="20"/>
                 <c:lvl>
                   <c:pt idx="0">
                     <c:v>1992</c:v>
                   </c:pt>
                   <c:pt idx="1">
-                    <c:v>​</c:v>
+                    <c:v>1994</c:v>
                   </c:pt>
                   <c:pt idx="2">
-                    <c:v>1994</c:v>
+                    <c:v>2004</c:v>
                   </c:pt>
                   <c:pt idx="3">
-                    <c:v>​​​</c:v>
+                    <c:v>2007</c:v>
                   </c:pt>
                   <c:pt idx="4">
-                    <c:v>1996</c:v>
+                    <c:v>2009</c:v>
                   </c:pt>
                   <c:pt idx="5">
-                    <c:v>​​​​​</c:v>
+                    <c:v>2012</c:v>
                   </c:pt>
                   <c:pt idx="6">
-                    <c:v>1998</c:v>
+                    <c:v>2013</c:v>
                   </c:pt>
                   <c:pt idx="7">
-                    <c:v>​​​​​​​</c:v>
+                    <c:v>2014</c:v>
                   </c:pt>
                   <c:pt idx="8">
-                    <c:v>2000</c:v>
+                    <c:v>2015</c:v>
                   </c:pt>
                   <c:pt idx="9">
-                    <c:v>​​​​​​​​​</c:v>
+                    <c:v>2016</c:v>
                   </c:pt>
                   <c:pt idx="10">
-                    <c:v>2002</c:v>
+                    <c:v>2017</c:v>
                   </c:pt>
                   <c:pt idx="11">
-                    <c:v>​​​​​​​​​​​</c:v>
+                    <c:v>2018</c:v>
                   </c:pt>
                   <c:pt idx="12">
-                    <c:v>2004</c:v>
+                    <c:v>2019</c:v>
                   </c:pt>
                   <c:pt idx="13">
-                    <c:v>​​​​​​​​​​​​​</c:v>
+                    <c:v>2020</c:v>
                   </c:pt>
                   <c:pt idx="14">
-                    <c:v>2006</c:v>
+                    <c:v>2021</c:v>
                   </c:pt>
                   <c:pt idx="15">
-                    <c:v>​​​​​​​​​​​​​​​</c:v>
+                    <c:v>2022</c:v>
                   </c:pt>
                   <c:pt idx="16">
-                    <c:v>2008</c:v>
+                    <c:v>2023</c:v>
                   </c:pt>
                   <c:pt idx="17">
-                    <c:v>​​​​​​​​​​​​​​​​​</c:v>
+                    <c:v>2024</c:v>
                   </c:pt>
                   <c:pt idx="18">
-                    <c:v>2010</c:v>
+                    <c:v>2025</c:v>
                   </c:pt>
                   <c:pt idx="19">
-                    <c:v>​​​​​​​​​​​​​​​​​​​</c:v>
-                  </c:pt>
-                  <c:pt idx="20">
-                    <c:v>2012</c:v>
-                  </c:pt>
-                  <c:pt idx="21">
-                    <c:v>​​​​​​​​​​​​​​​​​​​​​</c:v>
-                  </c:pt>
-                  <c:pt idx="22">
-                    <c:v>2014</c:v>
-                  </c:pt>
-                  <c:pt idx="23">
-                    <c:v>​​​​​​​​​​​​​​​​​​​​​​​</c:v>
-                  </c:pt>
-                  <c:pt idx="24">
-                    <c:v>2016</c:v>
-                  </c:pt>
-                  <c:pt idx="25">
-                    <c:v>​​​​​​​​​​​​​​​​​​​​​​​​​</c:v>
-                  </c:pt>
-                  <c:pt idx="26">
-                    <c:v>2018</c:v>
-                  </c:pt>
-                  <c:pt idx="27">
-                    <c:v>​​​​​​​​​​​​​​​​​​​​​​​​​​​</c:v>
-                  </c:pt>
-                  <c:pt idx="28">
-                    <c:v>2020</c:v>
-                  </c:pt>
-                  <c:pt idx="29">
-                    <c:v>​​​​​​​​​​​​​​​​​​​​​​​​​​​​​</c:v>
-                  </c:pt>
-                  <c:pt idx="30">
-                    <c:v>2022</c:v>
-                  </c:pt>
-                  <c:pt idx="31">
-                    <c:v>​​​​​​​​​​​​​​​​​​​​​​​​​​​​​​​</c:v>
-                  </c:pt>
-                  <c:pt idx="32">
-                    <c:v>2024</c:v>
-                  </c:pt>
-                  <c:pt idx="33">
-                    <c:v>​​​​​​​​​​​​​​​​​​​​​​​​​​​​​​​​​</c:v>
-                  </c:pt>
-                  <c:pt idx="34">
                     <c:v>2026</c:v>
                   </c:pt>
                 </c:lvl>
@@ -1218,10 +903,10 @@
           </c:cat>
           <c:val>
             <c:numRef>
-              <c:f>Sheet1!$E$2:$E$36</c:f>
+              <c:f>Sheet1!$E$2:$E$21</c:f>
               <c:numCache>
                 <c:formatCode>General</c:formatCode>
-                <c:ptCount val="35"/>
+                <c:ptCount val="20"/>
                 <c:pt idx="0">
                   <c:v>1</c:v>
                 </c:pt>
@@ -1229,7 +914,7 @@
                   <c:v>0</c:v>
                 </c:pt>
                 <c:pt idx="2">
-                  <c:v>0</c:v>
+                  <c:v>1</c:v>
                 </c:pt>
                 <c:pt idx="3">
                   <c:v>0</c:v>
@@ -1241,7 +926,7 @@
                   <c:v>0</c:v>
                 </c:pt>
                 <c:pt idx="6">
-                  <c:v>0</c:v>
+                  <c:v>1</c:v>
                 </c:pt>
                 <c:pt idx="7">
                   <c:v>0</c:v>
@@ -1250,16 +935,16 @@
                   <c:v>0</c:v>
                 </c:pt>
                 <c:pt idx="9">
-                  <c:v>0</c:v>
+                  <c:v>1</c:v>
                 </c:pt>
                 <c:pt idx="10">
-                  <c:v>0</c:v>
+                  <c:v>1</c:v>
                 </c:pt>
                 <c:pt idx="11">
                   <c:v>0</c:v>
                 </c:pt>
                 <c:pt idx="12">
-                  <c:v>1</c:v>
+                  <c:v>0</c:v>
                 </c:pt>
                 <c:pt idx="13">
                   <c:v>0</c:v>
@@ -1271,60 +956,15 @@
                   <c:v>0</c:v>
                 </c:pt>
                 <c:pt idx="16">
-                  <c:v>0</c:v>
+                  <c:v>1</c:v>
                 </c:pt>
                 <c:pt idx="17">
-                  <c:v>0</c:v>
+                  <c:v>1</c:v>
                 </c:pt>
                 <c:pt idx="18">
                   <c:v>0</c:v>
                 </c:pt>
                 <c:pt idx="19">
-                  <c:v>0</c:v>
-                </c:pt>
-                <c:pt idx="20">
-                  <c:v>0</c:v>
-                </c:pt>
-                <c:pt idx="21">
-                  <c:v>1</c:v>
-                </c:pt>
-                <c:pt idx="22">
-                  <c:v>0</c:v>
-                </c:pt>
-                <c:pt idx="23">
-                  <c:v>0</c:v>
-                </c:pt>
-                <c:pt idx="24">
-                  <c:v>1</c:v>
-                </c:pt>
-                <c:pt idx="25">
-                  <c:v>1</c:v>
-                </c:pt>
-                <c:pt idx="26">
-                  <c:v>0</c:v>
-                </c:pt>
-                <c:pt idx="27">
-                  <c:v>0</c:v>
-                </c:pt>
-                <c:pt idx="28">
-                  <c:v>0</c:v>
-                </c:pt>
-                <c:pt idx="29">
-                  <c:v>0</c:v>
-                </c:pt>
-                <c:pt idx="30">
-                  <c:v>0</c:v>
-                </c:pt>
-                <c:pt idx="31">
-                  <c:v>1</c:v>
-                </c:pt>
-                <c:pt idx="32">
-                  <c:v>1</c:v>
-                </c:pt>
-                <c:pt idx="33">
-                  <c:v>0</c:v>
-                </c:pt>
-                <c:pt idx="34">
                   <c:v>1</c:v>
                 </c:pt>
               </c:numCache>
@@ -1378,113 +1018,68 @@
           </c:dLbls>
           <c:cat>
             <c:multiLvlStrRef>
-              <c:f>Sheet1!$A$2:$A$36</c:f>
+              <c:f>Sheet1!$A$2:$A$21</c:f>
               <c:multiLvlStrCache>
-                <c:ptCount val="35"/>
+                <c:ptCount val="20"/>
                 <c:lvl>
                   <c:pt idx="0">
                     <c:v>1992</c:v>
                   </c:pt>
                   <c:pt idx="1">
-                    <c:v>​</c:v>
+                    <c:v>1994</c:v>
                   </c:pt>
                   <c:pt idx="2">
-                    <c:v>1994</c:v>
+                    <c:v>2004</c:v>
                   </c:pt>
                   <c:pt idx="3">
-                    <c:v>​​​</c:v>
+                    <c:v>2007</c:v>
                   </c:pt>
                   <c:pt idx="4">
-                    <c:v>1996</c:v>
+                    <c:v>2009</c:v>
                   </c:pt>
                   <c:pt idx="5">
-                    <c:v>​​​​​</c:v>
+                    <c:v>2012</c:v>
                   </c:pt>
                   <c:pt idx="6">
-                    <c:v>1998</c:v>
+                    <c:v>2013</c:v>
                   </c:pt>
                   <c:pt idx="7">
-                    <c:v>​​​​​​​</c:v>
+                    <c:v>2014</c:v>
                   </c:pt>
                   <c:pt idx="8">
-                    <c:v>2000</c:v>
+                    <c:v>2015</c:v>
                   </c:pt>
                   <c:pt idx="9">
-                    <c:v>​​​​​​​​​</c:v>
+                    <c:v>2016</c:v>
                   </c:pt>
                   <c:pt idx="10">
-                    <c:v>2002</c:v>
+                    <c:v>2017</c:v>
                   </c:pt>
                   <c:pt idx="11">
-                    <c:v>​​​​​​​​​​​</c:v>
+                    <c:v>2018</c:v>
                   </c:pt>
                   <c:pt idx="12">
-                    <c:v>2004</c:v>
+                    <c:v>2019</c:v>
                   </c:pt>
                   <c:pt idx="13">
-                    <c:v>​​​​​​​​​​​​​</c:v>
+                    <c:v>2020</c:v>
                   </c:pt>
                   <c:pt idx="14">
-                    <c:v>2006</c:v>
+                    <c:v>2021</c:v>
                   </c:pt>
                   <c:pt idx="15">
-                    <c:v>​​​​​​​​​​​​​​​</c:v>
+                    <c:v>2022</c:v>
                   </c:pt>
                   <c:pt idx="16">
-                    <c:v>2008</c:v>
+                    <c:v>2023</c:v>
                   </c:pt>
                   <c:pt idx="17">
-                    <c:v>​​​​​​​​​​​​​​​​​</c:v>
+                    <c:v>2024</c:v>
                   </c:pt>
                   <c:pt idx="18">
-                    <c:v>2010</c:v>
+                    <c:v>2025</c:v>
                   </c:pt>
                   <c:pt idx="19">
-                    <c:v>​​​​​​​​​​​​​​​​​​​</c:v>
-                  </c:pt>
-                  <c:pt idx="20">
-                    <c:v>2012</c:v>
-                  </c:pt>
-                  <c:pt idx="21">
-                    <c:v>​​​​​​​​​​​​​​​​​​​​​</c:v>
-                  </c:pt>
-                  <c:pt idx="22">
-                    <c:v>2014</c:v>
-                  </c:pt>
-                  <c:pt idx="23">
-                    <c:v>​​​​​​​​​​​​​​​​​​​​​​​</c:v>
-                  </c:pt>
-                  <c:pt idx="24">
-                    <c:v>2016</c:v>
-                  </c:pt>
-                  <c:pt idx="25">
-                    <c:v>​​​​​​​​​​​​​​​​​​​​​​​​​</c:v>
-                  </c:pt>
-                  <c:pt idx="26">
-                    <c:v>2018</c:v>
-                  </c:pt>
-                  <c:pt idx="27">
-                    <c:v>​​​​​​​​​​​​​​​​​​​​​​​​​​​</c:v>
-                  </c:pt>
-                  <c:pt idx="28">
-                    <c:v>2020</c:v>
-                  </c:pt>
-                  <c:pt idx="29">
-                    <c:v>​​​​​​​​​​​​​​​​​​​​​​​​​​​​​</c:v>
-                  </c:pt>
-                  <c:pt idx="30">
-                    <c:v>2022</c:v>
-                  </c:pt>
-                  <c:pt idx="31">
-                    <c:v>​​​​​​​​​​​​​​​​​​​​​​​​​​​​​​​</c:v>
-                  </c:pt>
-                  <c:pt idx="32">
-                    <c:v>2024</c:v>
-                  </c:pt>
-                  <c:pt idx="33">
-                    <c:v>​​​​​​​​​​​​​​​​​​​​​​​​​​​​​​​​​</c:v>
-                  </c:pt>
-                  <c:pt idx="34">
                     <c:v>2026</c:v>
                   </c:pt>
                 </c:lvl>
@@ -1493,10 +1088,10 @@
           </c:cat>
           <c:val>
             <c:numRef>
-              <c:f>Sheet1!$F$2:$F$36</c:f>
+              <c:f>Sheet1!$F$2:$F$21</c:f>
               <c:numCache>
                 <c:formatCode>General</c:formatCode>
-                <c:ptCount val="35"/>
+                <c:ptCount val="20"/>
                 <c:pt idx="0">
                   <c:v>0</c:v>
                 </c:pt>
@@ -1525,7 +1120,7 @@
                   <c:v>0</c:v>
                 </c:pt>
                 <c:pt idx="9">
-                  <c:v>0</c:v>
+                  <c:v>1</c:v>
                 </c:pt>
                 <c:pt idx="10">
                   <c:v>0</c:v>
@@ -1540,7 +1135,7 @@
                   <c:v>0</c:v>
                 </c:pt>
                 <c:pt idx="14">
-                  <c:v>0</c:v>
+                  <c:v>1</c:v>
                 </c:pt>
                 <c:pt idx="15">
                   <c:v>0</c:v>
@@ -1555,51 +1150,6 @@
                   <c:v>0</c:v>
                 </c:pt>
                 <c:pt idx="19">
-                  <c:v>0</c:v>
-                </c:pt>
-                <c:pt idx="20">
-                  <c:v>0</c:v>
-                </c:pt>
-                <c:pt idx="21">
-                  <c:v>0</c:v>
-                </c:pt>
-                <c:pt idx="22">
-                  <c:v>0</c:v>
-                </c:pt>
-                <c:pt idx="23">
-                  <c:v>0</c:v>
-                </c:pt>
-                <c:pt idx="24">
-                  <c:v>1</c:v>
-                </c:pt>
-                <c:pt idx="25">
-                  <c:v>0</c:v>
-                </c:pt>
-                <c:pt idx="26">
-                  <c:v>0</c:v>
-                </c:pt>
-                <c:pt idx="27">
-                  <c:v>0</c:v>
-                </c:pt>
-                <c:pt idx="28">
-                  <c:v>0</c:v>
-                </c:pt>
-                <c:pt idx="29">
-                  <c:v>1</c:v>
-                </c:pt>
-                <c:pt idx="30">
-                  <c:v>0</c:v>
-                </c:pt>
-                <c:pt idx="31">
-                  <c:v>0</c:v>
-                </c:pt>
-                <c:pt idx="32">
-                  <c:v>0</c:v>
-                </c:pt>
-                <c:pt idx="33">
-                  <c:v>0</c:v>
-                </c:pt>
-                <c:pt idx="34">
                   <c:v>1</c:v>
                 </c:pt>
               </c:numCache>

</xml_diff>

<commit_message>
Slide 6: PRISMA-style dataset workflow
Co-Authored-By: Claude Opus 5.5 (1M context) <noreply@anthropic.com>
Claude-Session: https://claude.ai/code/session_01JZtuYERhuCe7nB9VYHwcfv
</commit_message>
<xml_diff>
--- a/presentation/bed-rest-to-mars-talk.pptx
+++ b/presentation/bed-rest-to-mars-talk.pptx
@@ -126,13 +126,13 @@
   <p:extLst>
     <p:ext uri="{521415D9-36F7-43E2-AB2F-B90AF26B5E84}">
       <p14:sectionLst xmlns:p14="http://schemas.microsoft.com/office/powerpoint/2010/main">
-        <p14:section name="Opening" id="{8200937f-fca0-9c57-d781-3fa0ab7c8c26}">
+        <p14:section name="Opening" id="{e5d3bbd1-0136-ea66-e75e-f8424b43077b}">
           <p14:sldIdLst>
             <p14:sldId id="256"/>
             <p14:sldId id="257"/>
           </p14:sldIdLst>
         </p14:section>
-        <p14:section name="Part 1" id="{235feb38-58c1-c895-4b60-e38eebe42b7c}">
+        <p14:section name="Part 1" id="{04d8b939-de5e-b9f6-35f3-f7687f3c59e9}">
           <p14:sldIdLst>
             <p14:sldId id="258"/>
             <p14:sldId id="259"/>
@@ -143,7 +143,7 @@
             <p14:sldId id="264"/>
           </p14:sldIdLst>
         </p14:section>
-        <p14:section name="Part 2" id="{e61f855c-f054-8d6a-6683-971f2afef114}">
+        <p14:section name="Part 2" id="{e6a16378-f193-76f6-84e3-23161c894c38}">
           <p14:sldIdLst>
             <p14:sldId id="265"/>
             <p14:sldId id="266"/>
@@ -154,7 +154,7 @@
             <p14:sldId id="271"/>
           </p14:sldIdLst>
         </p14:section>
-        <p14:section name="Backup" id="{82bb06b6-91f8-6a1a-bd6c-d9c4131bdbee}">
+        <p14:section name="Backup" id="{d8811695-32d0-f670-858d-f48486ad0bd4}">
           <p14:sldIdLst>
             <p14:sldId id="272"/>
             <p14:sldId id="273"/>
@@ -162,13 +162,13 @@
             <p14:sldId id="275"/>
           </p14:sldIdLst>
         </p14:section>
-        <p14:section name="Backup" id="{9af805af-444d-1e42-3655-cbc8672df944}">
+        <p14:section name="Backup" id="{1c7f70d3-4462-d76c-5d0c-c8d1a7bb751d}">
           <p14:sldIdLst/>
         </p14:section>
-        <p14:section name="Backup" id="{da237d4f-a510-b6d0-e0e7-166592f1f99a}">
+        <p14:section name="Backup" id="{b8815342-a8e9-f5d4-2ed1-6745bd0e1a5e}">
           <p14:sldIdLst/>
         </p14:section>
-        <p14:section name="Backup" id="{932b1589-abf5-123b-eee3-928fd4745e3d}">
+        <p14:section name="Backup" id="{ce6a969f-2ae0-100f-c856-f58fedeebc14}">
           <p14:sldIdLst/>
         </p14:section>
       </p14:sectionLst>
@@ -5140,7 +5140,10 @@
           <a:p>
             <a:r>
               <a:rPr lang="en-US" dirty="0"/>
-              <a:t>Placeholder for the co-author's slide. The suggested points are from the final report on branch feat/report; replace them with the final content.</a:t>
+              <a:t>Part 1 (Niloufar), about one minute.
+We searched four databases, PubMed, Scopus, Web of Science and NASA's technical reports, for papers from 2013 onwards, and found 5,731 records. After removing duplicates, we screened 3,590 titles and abstracts. Most were excluded because they did not use an unloading model or did not measure muscle. 1,023 records could not be screened in the time available; they are not exclusions.
+We read 74 full texts. The main loss at this step: 19 studies show their muscle results only as charts, without a baseline value, so we could not extract them. The search gave 42 studies.
+Ten more came from other sources: nine older studies from before 2013, which the date limit of the search excluded, and one campaign from NASA's open bed-rest data. That gives the final dataset: 52 studies, 742 rows and 36 independent campaigns.</a:t>
             </a:r>
             <a:endParaRPr lang="en-US" dirty="0"/>
           </a:p>
@@ -18606,7 +18609,7 @@
                 <a:ea typeface="Cambria" pitchFamily="34" charset="-122"/>
                 <a:cs typeface="Cambria" pitchFamily="34" charset="-120"/>
               </a:rPr>
-              <a:t>How the dataset was built</a:t>
+              <a:t>How did we build the dataset?</a:t>
             </a:r>
             <a:endParaRPr lang="en-US" sz="2800" dirty="0"/>
           </a:p>
@@ -18614,39 +18617,732 @@
       </p:sp>
       <p:sp>
         <p:nvSpPr>
-          <p:cNvPr id="11" name="Placeholder frame"/>
-          <p:cNvSpPr/>
-          <p:nvPr/>
-        </p:nvSpPr>
-        <p:spPr>
-          <a:xfrm>
-            <a:off x="548640" y="1234440"/>
-            <a:ext cx="11064240" cy="4846320"/>
+          <p:cNvPr id="11" name="Text 9"/>
+          <p:cNvSpPr txBox="1"/>
+          <p:nvPr/>
+        </p:nvSpPr>
+        <p:spPr>
+          <a:xfrm>
+            <a:off x="548640" y="1371600"/>
+            <a:ext cx="1920240" cy="228600"/>
+          </a:xfrm>
+          <a:prstGeom prst="rect">
+            <a:avLst/>
+          </a:prstGeom>
+          <a:noFill/>
+          <a:ln/>
+        </p:spPr>
+        <p:txBody>
+          <a:bodyPr wrap="square" lIns="0" tIns="0" rIns="0" bIns="0" rtlCol="0" anchor="t"/>
+          <a:lstStyle/>
+          <a:p>
+            <a:pPr algn="ctr" indent="0" marL="0">
+              <a:buNone/>
+            </a:pPr>
+            <a:r>
+              <a:rPr lang="en-US" sz="1050" b="1" spc="100" kern="0" dirty="0">
+                <a:solidFill>
+                  <a:schemeClr val="accent3"/>
+                </a:solidFill>
+              </a:rPr>
+              <a:t>IDENTIFICATION</a:t>
+            </a:r>
+            <a:endParaRPr lang="en-US" sz="1050" dirty="0"/>
+          </a:p>
+        </p:txBody>
+      </p:sp>
+      <p:sp>
+        <p:nvSpPr>
+          <p:cNvPr id="12" name="Step Identification"/>
+          <p:cNvSpPr/>
+          <p:nvPr/>
+        </p:nvSpPr>
+        <p:spPr>
+          <a:xfrm>
+            <a:off x="548640" y="1691640"/>
+            <a:ext cx="1920240" cy="1325880"/>
           </a:xfrm>
           <a:prstGeom prst="rect">
             <a:avLst/>
           </a:prstGeom>
           <a:solidFill>
-            <a:schemeClr val="bg1"/>
+            <a:srgbClr val="FFFFFF"/>
           </a:solidFill>
           <a:ln w="12700">
             <a:solidFill>
               <a:srgbClr val="9AA3AE"/>
             </a:solidFill>
+            <a:prstDash val="solid"/>
+          </a:ln>
+        </p:spPr>
+      </p:sp>
+      <p:sp>
+        <p:nvSpPr>
+          <p:cNvPr id="13" name="Text 11"/>
+          <p:cNvSpPr txBox="1"/>
+          <p:nvPr/>
+        </p:nvSpPr>
+        <p:spPr>
+          <a:xfrm>
+            <a:off x="640080" y="1764792"/>
+            <a:ext cx="1737360" cy="1179576"/>
+          </a:xfrm>
+          <a:prstGeom prst="rect">
+            <a:avLst/>
+          </a:prstGeom>
+          <a:noFill/>
+          <a:ln/>
+        </p:spPr>
+        <p:txBody>
+          <a:bodyPr wrap="square" lIns="0" tIns="0" rIns="0" bIns="0" rtlCol="0" anchor="ctr"/>
+          <a:lstStyle/>
+          <a:p>
+            <a:pPr algn="ctr" indent="0" marL="0">
+              <a:buNone/>
+            </a:pPr>
+            <a:r>
+              <a:rPr lang="en-US" sz="2600" b="1" dirty="0">
+                <a:solidFill>
+                  <a:schemeClr val="tx2"/>
+                </a:solidFill>
+                <a:latin typeface="Cambria" pitchFamily="34" charset="0"/>
+                <a:ea typeface="Cambria" pitchFamily="34" charset="-122"/>
+                <a:cs typeface="Cambria" pitchFamily="34" charset="-120"/>
+              </a:rPr>
+              <a:t>5,731</a:t>
+            </a:r>
+            <a:endParaRPr lang="en-US" sz="2600" dirty="0"/>
+          </a:p>
+          <a:p>
+            <a:pPr algn="ctr" indent="0" marL="0">
+              <a:buNone/>
+            </a:pPr>
+            <a:r>
+              <a:rPr lang="en-US" sz="1300" dirty="0">
+                <a:solidFill>
+                  <a:schemeClr val="tx1"/>
+                </a:solidFill>
+              </a:rPr>
+              <a:t>records found</a:t>
+            </a:r>
+            <a:endParaRPr lang="en-US" sz="2600" dirty="0"/>
+          </a:p>
+          <a:p>
+            <a:pPr algn="ctr" indent="0" marL="0">
+              <a:buNone/>
+            </a:pPr>
+            <a:r>
+              <a:rPr lang="en-US" sz="1050" i="1" dirty="0">
+                <a:solidFill>
+                  <a:schemeClr val="accent3"/>
+                </a:solidFill>
+              </a:rPr>
+              <a:t>PubMed, Scopus, Web of Science, NASA reports; 2013 onwards</a:t>
+            </a:r>
+            <a:endParaRPr lang="en-US" sz="2600" dirty="0"/>
+          </a:p>
+        </p:txBody>
+      </p:sp>
+      <p:sp>
+        <p:nvSpPr>
+          <p:cNvPr id="14" name="Flow arrow 1"/>
+          <p:cNvSpPr/>
+          <p:nvPr/>
+        </p:nvSpPr>
+        <p:spPr>
+          <a:xfrm>
+            <a:off x="2505456" y="2354580"/>
+            <a:ext cx="246888" cy="0"/>
+          </a:xfrm>
+          <a:prstGeom prst="line">
+            <a:avLst/>
+          </a:prstGeom>
+          <a:noFill/>
+          <a:ln w="15875">
+            <a:solidFill>
+              <a:srgbClr val="1A1A1A"/>
+            </a:solidFill>
+            <a:prstDash val="solid"/>
+            <a:tailEnd type="triangle"/>
+          </a:ln>
+        </p:spPr>
+      </p:sp>
+      <p:sp>
+        <p:nvSpPr>
+          <p:cNvPr id="15" name="Text 13"/>
+          <p:cNvSpPr txBox="1"/>
+          <p:nvPr/>
+        </p:nvSpPr>
+        <p:spPr>
+          <a:xfrm>
+            <a:off x="2788920" y="1371600"/>
+            <a:ext cx="1920240" cy="228600"/>
+          </a:xfrm>
+          <a:prstGeom prst="rect">
+            <a:avLst/>
+          </a:prstGeom>
+          <a:noFill/>
+          <a:ln/>
+        </p:spPr>
+        <p:txBody>
+          <a:bodyPr wrap="square" lIns="0" tIns="0" rIns="0" bIns="0" rtlCol="0" anchor="t"/>
+          <a:lstStyle/>
+          <a:p>
+            <a:pPr algn="ctr" indent="0" marL="0">
+              <a:buNone/>
+            </a:pPr>
+            <a:r>
+              <a:rPr lang="en-US" sz="1050" b="1" spc="100" kern="0" dirty="0">
+                <a:solidFill>
+                  <a:schemeClr val="accent3"/>
+                </a:solidFill>
+              </a:rPr>
+              <a:t>SCREENING</a:t>
+            </a:r>
+            <a:endParaRPr lang="en-US" sz="1050" dirty="0"/>
+          </a:p>
+        </p:txBody>
+      </p:sp>
+      <p:sp>
+        <p:nvSpPr>
+          <p:cNvPr id="16" name="Step Screening"/>
+          <p:cNvSpPr/>
+          <p:nvPr/>
+        </p:nvSpPr>
+        <p:spPr>
+          <a:xfrm>
+            <a:off x="2788920" y="1691640"/>
+            <a:ext cx="1920240" cy="1325880"/>
+          </a:xfrm>
+          <a:prstGeom prst="rect">
+            <a:avLst/>
+          </a:prstGeom>
+          <a:solidFill>
+            <a:srgbClr val="FFFFFF"/>
+          </a:solidFill>
+          <a:ln w="12700">
+            <a:solidFill>
+              <a:srgbClr val="9AA3AE"/>
+            </a:solidFill>
+            <a:prstDash val="solid"/>
+          </a:ln>
+        </p:spPr>
+      </p:sp>
+      <p:sp>
+        <p:nvSpPr>
+          <p:cNvPr id="17" name="Text 15"/>
+          <p:cNvSpPr txBox="1"/>
+          <p:nvPr/>
+        </p:nvSpPr>
+        <p:spPr>
+          <a:xfrm>
+            <a:off x="2880360" y="1764792"/>
+            <a:ext cx="1737360" cy="1179576"/>
+          </a:xfrm>
+          <a:prstGeom prst="rect">
+            <a:avLst/>
+          </a:prstGeom>
+          <a:noFill/>
+          <a:ln/>
+        </p:spPr>
+        <p:txBody>
+          <a:bodyPr wrap="square" lIns="0" tIns="0" rIns="0" bIns="0" rtlCol="0" anchor="ctr"/>
+          <a:lstStyle/>
+          <a:p>
+            <a:pPr algn="ctr" indent="0" marL="0">
+              <a:buNone/>
+            </a:pPr>
+            <a:r>
+              <a:rPr lang="en-US" sz="2600" b="1" dirty="0">
+                <a:solidFill>
+                  <a:schemeClr val="tx2"/>
+                </a:solidFill>
+                <a:latin typeface="Cambria" pitchFamily="34" charset="0"/>
+                <a:ea typeface="Cambria" pitchFamily="34" charset="-122"/>
+                <a:cs typeface="Cambria" pitchFamily="34" charset="-120"/>
+              </a:rPr>
+              <a:t>3,590</a:t>
+            </a:r>
+            <a:endParaRPr lang="en-US" sz="2600" dirty="0"/>
+          </a:p>
+          <a:p>
+            <a:pPr algn="ctr" indent="0" marL="0">
+              <a:buNone/>
+            </a:pPr>
+            <a:r>
+              <a:rPr lang="en-US" sz="1300" dirty="0">
+                <a:solidFill>
+                  <a:schemeClr val="tx1"/>
+                </a:solidFill>
+              </a:rPr>
+              <a:t>titles and abstracts screened</a:t>
+            </a:r>
+            <a:endParaRPr lang="en-US" sz="2600" dirty="0"/>
+          </a:p>
+        </p:txBody>
+      </p:sp>
+      <p:sp>
+        <p:nvSpPr>
+          <p:cNvPr id="18" name="Flow arrow 2"/>
+          <p:cNvSpPr/>
+          <p:nvPr/>
+        </p:nvSpPr>
+        <p:spPr>
+          <a:xfrm>
+            <a:off x="4745736" y="2354580"/>
+            <a:ext cx="246888" cy="0"/>
+          </a:xfrm>
+          <a:prstGeom prst="line">
+            <a:avLst/>
+          </a:prstGeom>
+          <a:noFill/>
+          <a:ln w="15875">
+            <a:solidFill>
+              <a:srgbClr val="1A1A1A"/>
+            </a:solidFill>
+            <a:prstDash val="solid"/>
+            <a:tailEnd type="triangle"/>
+          </a:ln>
+        </p:spPr>
+      </p:sp>
+      <p:sp>
+        <p:nvSpPr>
+          <p:cNvPr id="19" name="Text 17"/>
+          <p:cNvSpPr txBox="1"/>
+          <p:nvPr/>
+        </p:nvSpPr>
+        <p:spPr>
+          <a:xfrm>
+            <a:off x="5029200" y="1371600"/>
+            <a:ext cx="1920240" cy="228600"/>
+          </a:xfrm>
+          <a:prstGeom prst="rect">
+            <a:avLst/>
+          </a:prstGeom>
+          <a:noFill/>
+          <a:ln/>
+        </p:spPr>
+        <p:txBody>
+          <a:bodyPr wrap="square" lIns="0" tIns="0" rIns="0" bIns="0" rtlCol="0" anchor="t"/>
+          <a:lstStyle/>
+          <a:p>
+            <a:pPr algn="ctr" indent="0" marL="0">
+              <a:buNone/>
+            </a:pPr>
+            <a:r>
+              <a:rPr lang="en-US" sz="1050" b="1" spc="100" kern="0" dirty="0">
+                <a:solidFill>
+                  <a:schemeClr val="accent3"/>
+                </a:solidFill>
+              </a:rPr>
+              <a:t>FULL TEXT</a:t>
+            </a:r>
+            <a:endParaRPr lang="en-US" sz="1050" dirty="0"/>
+          </a:p>
+        </p:txBody>
+      </p:sp>
+      <p:sp>
+        <p:nvSpPr>
+          <p:cNvPr id="20" name="Step Full text"/>
+          <p:cNvSpPr/>
+          <p:nvPr/>
+        </p:nvSpPr>
+        <p:spPr>
+          <a:xfrm>
+            <a:off x="5029200" y="1691640"/>
+            <a:ext cx="1920240" cy="1325880"/>
+          </a:xfrm>
+          <a:prstGeom prst="rect">
+            <a:avLst/>
+          </a:prstGeom>
+          <a:solidFill>
+            <a:srgbClr val="FFFFFF"/>
+          </a:solidFill>
+          <a:ln w="12700">
+            <a:solidFill>
+              <a:srgbClr val="9AA3AE"/>
+            </a:solidFill>
+            <a:prstDash val="solid"/>
+          </a:ln>
+        </p:spPr>
+      </p:sp>
+      <p:sp>
+        <p:nvSpPr>
+          <p:cNvPr id="21" name="Text 19"/>
+          <p:cNvSpPr txBox="1"/>
+          <p:nvPr/>
+        </p:nvSpPr>
+        <p:spPr>
+          <a:xfrm>
+            <a:off x="5120640" y="1764792"/>
+            <a:ext cx="1737360" cy="1179576"/>
+          </a:xfrm>
+          <a:prstGeom prst="rect">
+            <a:avLst/>
+          </a:prstGeom>
+          <a:noFill/>
+          <a:ln/>
+        </p:spPr>
+        <p:txBody>
+          <a:bodyPr wrap="square" lIns="0" tIns="0" rIns="0" bIns="0" rtlCol="0" anchor="ctr"/>
+          <a:lstStyle/>
+          <a:p>
+            <a:pPr algn="ctr" indent="0" marL="0">
+              <a:buNone/>
+            </a:pPr>
+            <a:r>
+              <a:rPr lang="en-US" sz="2600" b="1" dirty="0">
+                <a:solidFill>
+                  <a:schemeClr val="tx2"/>
+                </a:solidFill>
+                <a:latin typeface="Cambria" pitchFamily="34" charset="0"/>
+                <a:ea typeface="Cambria" pitchFamily="34" charset="-122"/>
+                <a:cs typeface="Cambria" pitchFamily="34" charset="-120"/>
+              </a:rPr>
+              <a:t>74</a:t>
+            </a:r>
+            <a:endParaRPr lang="en-US" sz="2600" dirty="0"/>
+          </a:p>
+          <a:p>
+            <a:pPr algn="ctr" indent="0" marL="0">
+              <a:buNone/>
+            </a:pPr>
+            <a:r>
+              <a:rPr lang="en-US" sz="1300" dirty="0">
+                <a:solidFill>
+                  <a:schemeClr val="tx1"/>
+                </a:solidFill>
+              </a:rPr>
+              <a:t>full texts read</a:t>
+            </a:r>
+            <a:endParaRPr lang="en-US" sz="2600" dirty="0"/>
+          </a:p>
+        </p:txBody>
+      </p:sp>
+      <p:sp>
+        <p:nvSpPr>
+          <p:cNvPr id="22" name="Flow arrow 3"/>
+          <p:cNvSpPr/>
+          <p:nvPr/>
+        </p:nvSpPr>
+        <p:spPr>
+          <a:xfrm>
+            <a:off x="6986016" y="2354580"/>
+            <a:ext cx="246888" cy="0"/>
+          </a:xfrm>
+          <a:prstGeom prst="line">
+            <a:avLst/>
+          </a:prstGeom>
+          <a:noFill/>
+          <a:ln w="15875">
+            <a:solidFill>
+              <a:srgbClr val="1A1A1A"/>
+            </a:solidFill>
+            <a:prstDash val="solid"/>
+            <a:tailEnd type="triangle"/>
+          </a:ln>
+        </p:spPr>
+      </p:sp>
+      <p:sp>
+        <p:nvSpPr>
+          <p:cNvPr id="23" name="Text 21"/>
+          <p:cNvSpPr txBox="1"/>
+          <p:nvPr/>
+        </p:nvSpPr>
+        <p:spPr>
+          <a:xfrm>
+            <a:off x="7269480" y="1371600"/>
+            <a:ext cx="1920240" cy="228600"/>
+          </a:xfrm>
+          <a:prstGeom prst="rect">
+            <a:avLst/>
+          </a:prstGeom>
+          <a:noFill/>
+          <a:ln/>
+        </p:spPr>
+        <p:txBody>
+          <a:bodyPr wrap="square" lIns="0" tIns="0" rIns="0" bIns="0" rtlCol="0" anchor="t"/>
+          <a:lstStyle/>
+          <a:p>
+            <a:pPr algn="ctr" indent="0" marL="0">
+              <a:buNone/>
+            </a:pPr>
+            <a:r>
+              <a:rPr lang="en-US" sz="1050" b="1" spc="100" kern="0" dirty="0">
+                <a:solidFill>
+                  <a:schemeClr val="accent3"/>
+                </a:solidFill>
+              </a:rPr>
+              <a:t>INCLUDED</a:t>
+            </a:r>
+            <a:endParaRPr lang="en-US" sz="1050" dirty="0"/>
+          </a:p>
+        </p:txBody>
+      </p:sp>
+      <p:sp>
+        <p:nvSpPr>
+          <p:cNvPr id="24" name="Step Included"/>
+          <p:cNvSpPr/>
+          <p:nvPr/>
+        </p:nvSpPr>
+        <p:spPr>
+          <a:xfrm>
+            <a:off x="7269480" y="1691640"/>
+            <a:ext cx="1920240" cy="1325880"/>
+          </a:xfrm>
+          <a:prstGeom prst="rect">
+            <a:avLst/>
+          </a:prstGeom>
+          <a:solidFill>
+            <a:srgbClr val="FFFFFF"/>
+          </a:solidFill>
+          <a:ln w="12700">
+            <a:solidFill>
+              <a:srgbClr val="9AA3AE"/>
+            </a:solidFill>
+            <a:prstDash val="solid"/>
+          </a:ln>
+        </p:spPr>
+      </p:sp>
+      <p:sp>
+        <p:nvSpPr>
+          <p:cNvPr id="25" name="Text 23"/>
+          <p:cNvSpPr txBox="1"/>
+          <p:nvPr/>
+        </p:nvSpPr>
+        <p:spPr>
+          <a:xfrm>
+            <a:off x="7360920" y="1764792"/>
+            <a:ext cx="1737360" cy="1179576"/>
+          </a:xfrm>
+          <a:prstGeom prst="rect">
+            <a:avLst/>
+          </a:prstGeom>
+          <a:noFill/>
+          <a:ln/>
+        </p:spPr>
+        <p:txBody>
+          <a:bodyPr wrap="square" lIns="0" tIns="0" rIns="0" bIns="0" rtlCol="0" anchor="ctr"/>
+          <a:lstStyle/>
+          <a:p>
+            <a:pPr algn="ctr" indent="0" marL="0">
+              <a:buNone/>
+            </a:pPr>
+            <a:r>
+              <a:rPr lang="en-US" sz="2600" b="1" dirty="0">
+                <a:solidFill>
+                  <a:schemeClr val="tx2"/>
+                </a:solidFill>
+                <a:latin typeface="Cambria" pitchFamily="34" charset="0"/>
+                <a:ea typeface="Cambria" pitchFamily="34" charset="-122"/>
+                <a:cs typeface="Cambria" pitchFamily="34" charset="-120"/>
+              </a:rPr>
+              <a:t>42</a:t>
+            </a:r>
+            <a:endParaRPr lang="en-US" sz="2600" dirty="0"/>
+          </a:p>
+          <a:p>
+            <a:pPr algn="ctr" indent="0" marL="0">
+              <a:buNone/>
+            </a:pPr>
+            <a:r>
+              <a:rPr lang="en-US" sz="1300" dirty="0">
+                <a:solidFill>
+                  <a:schemeClr val="tx1"/>
+                </a:solidFill>
+              </a:rPr>
+              <a:t>studies from the search</a:t>
+            </a:r>
+            <a:endParaRPr lang="en-US" sz="2600" dirty="0"/>
+          </a:p>
+        </p:txBody>
+      </p:sp>
+      <p:sp>
+        <p:nvSpPr>
+          <p:cNvPr id="26" name="Flow arrow 4"/>
+          <p:cNvSpPr/>
+          <p:nvPr/>
+        </p:nvSpPr>
+        <p:spPr>
+          <a:xfrm>
+            <a:off x="9226296" y="2354580"/>
+            <a:ext cx="246888" cy="0"/>
+          </a:xfrm>
+          <a:prstGeom prst="line">
+            <a:avLst/>
+          </a:prstGeom>
+          <a:noFill/>
+          <a:ln w="15875">
+            <a:solidFill>
+              <a:srgbClr val="1A1A1A"/>
+            </a:solidFill>
+            <a:prstDash val="solid"/>
+            <a:tailEnd type="triangle"/>
+          </a:ln>
+        </p:spPr>
+      </p:sp>
+      <p:sp>
+        <p:nvSpPr>
+          <p:cNvPr id="27" name="Text 25"/>
+          <p:cNvSpPr txBox="1"/>
+          <p:nvPr/>
+        </p:nvSpPr>
+        <p:spPr>
+          <a:xfrm>
+            <a:off x="9509760" y="1371600"/>
+            <a:ext cx="1920240" cy="228600"/>
+          </a:xfrm>
+          <a:prstGeom prst="rect">
+            <a:avLst/>
+          </a:prstGeom>
+          <a:noFill/>
+          <a:ln/>
+        </p:spPr>
+        <p:txBody>
+          <a:bodyPr wrap="square" lIns="0" tIns="0" rIns="0" bIns="0" rtlCol="0" anchor="t"/>
+          <a:lstStyle/>
+          <a:p>
+            <a:pPr algn="ctr" indent="0" marL="0">
+              <a:buNone/>
+            </a:pPr>
+            <a:r>
+              <a:rPr lang="en-US" sz="1050" b="1" spc="100" kern="0" dirty="0">
+                <a:solidFill>
+                  <a:schemeClr val="accent1"/>
+                </a:solidFill>
+              </a:rPr>
+              <a:t>FINAL DATASET</a:t>
+            </a:r>
+            <a:endParaRPr lang="en-US" sz="1050" dirty="0"/>
+          </a:p>
+        </p:txBody>
+      </p:sp>
+      <p:sp>
+        <p:nvSpPr>
+          <p:cNvPr id="28" name="Step Final dataset"/>
+          <p:cNvSpPr/>
+          <p:nvPr/>
+        </p:nvSpPr>
+        <p:spPr>
+          <a:xfrm>
+            <a:off x="9509760" y="1691640"/>
+            <a:ext cx="1920240" cy="1325880"/>
+          </a:xfrm>
+          <a:prstGeom prst="rect">
+            <a:avLst/>
+          </a:prstGeom>
+          <a:solidFill>
+            <a:srgbClr val="1F3A5F"/>
+          </a:solidFill>
+          <a:ln w="12700">
+            <a:solidFill>
+              <a:srgbClr val="1F3A5F"/>
+            </a:solidFill>
+            <a:prstDash val="solid"/>
+          </a:ln>
+        </p:spPr>
+      </p:sp>
+      <p:sp>
+        <p:nvSpPr>
+          <p:cNvPr id="29" name="Text 27"/>
+          <p:cNvSpPr txBox="1"/>
+          <p:nvPr/>
+        </p:nvSpPr>
+        <p:spPr>
+          <a:xfrm>
+            <a:off x="9601200" y="1764792"/>
+            <a:ext cx="1737360" cy="1179576"/>
+          </a:xfrm>
+          <a:prstGeom prst="rect">
+            <a:avLst/>
+          </a:prstGeom>
+          <a:noFill/>
+          <a:ln/>
+        </p:spPr>
+        <p:txBody>
+          <a:bodyPr wrap="square" lIns="0" tIns="0" rIns="0" bIns="0" rtlCol="0" anchor="ctr"/>
+          <a:lstStyle/>
+          <a:p>
+            <a:pPr algn="ctr" indent="0" marL="0">
+              <a:buNone/>
+            </a:pPr>
+            <a:r>
+              <a:rPr lang="en-US" sz="2600" b="1" dirty="0">
+                <a:solidFill>
+                  <a:schemeClr val="bg1"/>
+                </a:solidFill>
+                <a:latin typeface="Cambria" pitchFamily="34" charset="0"/>
+                <a:ea typeface="Cambria" pitchFamily="34" charset="-122"/>
+                <a:cs typeface="Cambria" pitchFamily="34" charset="-120"/>
+              </a:rPr>
+              <a:t>52</a:t>
+            </a:r>
+            <a:endParaRPr lang="en-US" sz="2600" dirty="0"/>
+          </a:p>
+          <a:p>
+            <a:pPr algn="ctr" indent="0" marL="0">
+              <a:buNone/>
+            </a:pPr>
+            <a:r>
+              <a:rPr lang="en-US" sz="1300" dirty="0">
+                <a:solidFill>
+                  <a:schemeClr val="bg1"/>
+                </a:solidFill>
+              </a:rPr>
+              <a:t>studies</a:t>
+            </a:r>
+            <a:endParaRPr lang="en-US" sz="2600" dirty="0"/>
+          </a:p>
+          <a:p>
+            <a:pPr algn="ctr" indent="0" marL="0">
+              <a:buNone/>
+            </a:pPr>
+            <a:r>
+              <a:rPr lang="en-US" sz="1050" i="1" dirty="0">
+                <a:solidFill>
+                  <a:schemeClr val="bg1"/>
+                </a:solidFill>
+              </a:rPr>
+              <a:t>742 rows · 36 campaigns</a:t>
+            </a:r>
+            <a:endParaRPr lang="en-US" sz="2600" dirty="0"/>
+          </a:p>
+        </p:txBody>
+      </p:sp>
+      <p:sp>
+        <p:nvSpPr>
+          <p:cNvPr id="30" name="Removed 1"/>
+          <p:cNvSpPr/>
+          <p:nvPr/>
+        </p:nvSpPr>
+        <p:spPr>
+          <a:xfrm>
+            <a:off x="2628900" y="2400300"/>
+            <a:ext cx="0" cy="960120"/>
+          </a:xfrm>
+          <a:prstGeom prst="line">
+            <a:avLst/>
+          </a:prstGeom>
+          <a:noFill/>
+          <a:ln w="9525">
+            <a:solidFill>
+              <a:srgbClr val="9AA3AE"/>
+            </a:solidFill>
             <a:prstDash val="dash"/>
+            <a:tailEnd type="triangle"/>
           </a:ln>
         </p:spPr>
       </p:sp>
       <p:sp>
         <p:nvSpPr>
-          <p:cNvPr id="12" name="Text 10"/>
+          <p:cNvPr id="31" name="Text 29"/>
           <p:cNvSpPr txBox="1"/>
           <p:nvPr/>
         </p:nvSpPr>
         <p:spPr>
           <a:xfrm>
-            <a:off x="822960" y="1463040"/>
-            <a:ext cx="10515600" cy="4480560"/>
+            <a:off x="1623060" y="3406140"/>
+            <a:ext cx="2011680" cy="1005840"/>
           </a:xfrm>
           <a:prstGeom prst="rect">
             <a:avLst/>
@@ -18658,121 +19354,338 @@
           <a:bodyPr wrap="square" lIns="0" tIns="0" rIns="0" bIns="0" rtlCol="0" anchor="t"/>
           <a:lstStyle/>
           <a:p>
+            <a:pPr algn="ctr" indent="0" marL="0">
+              <a:buNone/>
+            </a:pPr>
+            <a:r>
+              <a:rPr lang="en-US" sz="1100" dirty="0">
+                <a:solidFill>
+                  <a:schemeClr val="accent3"/>
+                </a:solidFill>
+              </a:rPr>
+              <a:t>2,141 duplicates removed</a:t>
+            </a:r>
+            <a:endParaRPr lang="en-US" sz="1100" dirty="0"/>
+          </a:p>
+        </p:txBody>
+      </p:sp>
+      <p:sp>
+        <p:nvSpPr>
+          <p:cNvPr id="32" name="Removed 2"/>
+          <p:cNvSpPr/>
+          <p:nvPr/>
+        </p:nvSpPr>
+        <p:spPr>
+          <a:xfrm>
+            <a:off x="4869180" y="2400300"/>
+            <a:ext cx="0" cy="960120"/>
+          </a:xfrm>
+          <a:prstGeom prst="line">
+            <a:avLst/>
+          </a:prstGeom>
+          <a:noFill/>
+          <a:ln w="9525">
+            <a:solidFill>
+              <a:srgbClr val="9AA3AE"/>
+            </a:solidFill>
+            <a:prstDash val="dash"/>
+            <a:tailEnd type="triangle"/>
+          </a:ln>
+        </p:spPr>
+      </p:sp>
+      <p:sp>
+        <p:nvSpPr>
+          <p:cNvPr id="33" name="Text 31"/>
+          <p:cNvSpPr txBox="1"/>
+          <p:nvPr/>
+        </p:nvSpPr>
+        <p:spPr>
+          <a:xfrm>
+            <a:off x="3863340" y="3406140"/>
+            <a:ext cx="2011680" cy="1005840"/>
+          </a:xfrm>
+          <a:prstGeom prst="rect">
+            <a:avLst/>
+          </a:prstGeom>
+          <a:noFill/>
+          <a:ln/>
+        </p:spPr>
+        <p:txBody>
+          <a:bodyPr wrap="square" lIns="0" tIns="0" rIns="0" bIns="0" rtlCol="0" anchor="t"/>
+          <a:lstStyle/>
+          <a:p>
+            <a:pPr algn="ctr" indent="0" marL="0">
+              <a:buNone/>
+            </a:pPr>
+            <a:r>
+              <a:rPr lang="en-US" sz="1100" dirty="0">
+                <a:solidFill>
+                  <a:schemeClr val="accent3"/>
+                </a:solidFill>
+              </a:rPr>
+              <a:t>2,493 excluded, mostly no unloading model or no muscle outcome</a:t>
+            </a:r>
+            <a:endParaRPr lang="en-US" sz="1100" dirty="0"/>
+          </a:p>
+          <a:p>
+            <a:pPr algn="ctr" indent="0" marL="0">
+              <a:buNone/>
+            </a:pPr>
+            <a:r>
+              <a:rPr lang="en-US" sz="1100" dirty="0">
+                <a:solidFill>
+                  <a:schemeClr val="accent3"/>
+                </a:solidFill>
+              </a:rPr>
+              <a:t>1,023 not yet screened</a:t>
+            </a:r>
+            <a:endParaRPr lang="en-US" sz="1100" dirty="0"/>
+          </a:p>
+        </p:txBody>
+      </p:sp>
+      <p:sp>
+        <p:nvSpPr>
+          <p:cNvPr id="34" name="Removed 3"/>
+          <p:cNvSpPr/>
+          <p:nvPr/>
+        </p:nvSpPr>
+        <p:spPr>
+          <a:xfrm>
+            <a:off x="7109460" y="2400300"/>
+            <a:ext cx="0" cy="960120"/>
+          </a:xfrm>
+          <a:prstGeom prst="line">
+            <a:avLst/>
+          </a:prstGeom>
+          <a:noFill/>
+          <a:ln w="9525">
+            <a:solidFill>
+              <a:srgbClr val="9AA3AE"/>
+            </a:solidFill>
+            <a:prstDash val="dash"/>
+            <a:tailEnd type="triangle"/>
+          </a:ln>
+        </p:spPr>
+      </p:sp>
+      <p:sp>
+        <p:nvSpPr>
+          <p:cNvPr id="35" name="Text 33"/>
+          <p:cNvSpPr txBox="1"/>
+          <p:nvPr/>
+        </p:nvSpPr>
+        <p:spPr>
+          <a:xfrm>
+            <a:off x="6103620" y="3406140"/>
+            <a:ext cx="2011680" cy="1005840"/>
+          </a:xfrm>
+          <a:prstGeom prst="rect">
+            <a:avLst/>
+          </a:prstGeom>
+          <a:noFill/>
+          <a:ln/>
+        </p:spPr>
+        <p:txBody>
+          <a:bodyPr wrap="square" lIns="0" tIns="0" rIns="0" bIns="0" rtlCol="0" anchor="t"/>
+          <a:lstStyle/>
+          <a:p>
+            <a:pPr algn="ctr" indent="0" marL="0">
+              <a:buNone/>
+            </a:pPr>
+            <a:r>
+              <a:rPr lang="en-US" sz="1100" dirty="0">
+                <a:solidFill>
+                  <a:schemeClr val="accent3"/>
+                </a:solidFill>
+              </a:rPr>
+              <a:t>19 report muscle results only as charts, without a baseline value</a:t>
+            </a:r>
+            <a:endParaRPr lang="en-US" sz="1100" dirty="0"/>
+          </a:p>
+          <a:p>
+            <a:pPr algn="ctr" indent="0" marL="0">
+              <a:buNone/>
+            </a:pPr>
+            <a:r>
+              <a:rPr lang="en-US" sz="1100" dirty="0">
+                <a:solidFill>
+                  <a:schemeClr val="accent3"/>
+                </a:solidFill>
+              </a:rPr>
+              <a:t>4 full texts not available</a:t>
+            </a:r>
+            <a:endParaRPr lang="en-US" sz="1100" dirty="0"/>
+          </a:p>
+        </p:txBody>
+      </p:sp>
+      <p:sp>
+        <p:nvSpPr>
+          <p:cNvPr id="36" name="Other sources"/>
+          <p:cNvSpPr/>
+          <p:nvPr/>
+        </p:nvSpPr>
+        <p:spPr>
+          <a:xfrm>
+            <a:off x="7086600" y="4297680"/>
+            <a:ext cx="2651760" cy="1097280"/>
+          </a:xfrm>
+          <a:prstGeom prst="rect">
+            <a:avLst/>
+          </a:prstGeom>
+          <a:solidFill>
+            <a:schemeClr val="bg2"/>
+          </a:solidFill>
+          <a:ln w="12700">
+            <a:solidFill>
+              <a:srgbClr val="9AA3AE"/>
+            </a:solidFill>
+            <a:prstDash val="solid"/>
+          </a:ln>
+        </p:spPr>
+      </p:sp>
+      <p:sp>
+        <p:nvSpPr>
+          <p:cNvPr id="37" name="Text 35"/>
+          <p:cNvSpPr txBox="1"/>
+          <p:nvPr/>
+        </p:nvSpPr>
+        <p:spPr>
+          <a:xfrm>
+            <a:off x="7178040" y="4343400"/>
+            <a:ext cx="2468880" cy="1005840"/>
+          </a:xfrm>
+          <a:prstGeom prst="rect">
+            <a:avLst/>
+          </a:prstGeom>
+          <a:noFill/>
+          <a:ln/>
+        </p:spPr>
+        <p:txBody>
+          <a:bodyPr wrap="square" lIns="0" tIns="0" rIns="0" bIns="0" rtlCol="0" anchor="ctr"/>
+          <a:lstStyle/>
+          <a:p>
+            <a:pPr algn="ctr" indent="0" marL="0">
+              <a:buNone/>
+            </a:pPr>
+            <a:r>
+              <a:rPr lang="en-US" sz="1300" b="1" dirty="0">
+                <a:solidFill>
+                  <a:schemeClr val="tx1"/>
+                </a:solidFill>
+              </a:rPr>
+              <a:t>+10 from other sources</a:t>
+            </a:r>
+            <a:endParaRPr lang="en-US" sz="1300" dirty="0"/>
+          </a:p>
+          <a:p>
+            <a:pPr algn="ctr" indent="0" marL="0">
+              <a:buNone/>
+            </a:pPr>
+            <a:r>
+              <a:rPr lang="en-US" sz="1100" dirty="0">
+                <a:solidFill>
+                  <a:schemeClr val="accent3"/>
+                </a:solidFill>
+              </a:rPr>
+              <a:t>9 older studies (before 2013)</a:t>
+            </a:r>
+            <a:endParaRPr lang="en-US" sz="1300" dirty="0"/>
+          </a:p>
+          <a:p>
+            <a:pPr algn="ctr" indent="0" marL="0">
+              <a:buNone/>
+            </a:pPr>
+            <a:r>
+              <a:rPr lang="en-US" sz="1100" dirty="0">
+                <a:solidFill>
+                  <a:schemeClr val="accent3"/>
+                </a:solidFill>
+              </a:rPr>
+              <a:t>1 NASA open-data campaign</a:t>
+            </a:r>
+            <a:endParaRPr lang="en-US" sz="1300" dirty="0"/>
+          </a:p>
+        </p:txBody>
+      </p:sp>
+      <p:sp>
+        <p:nvSpPr>
+          <p:cNvPr id="38" name="Other sources line"/>
+          <p:cNvSpPr/>
+          <p:nvPr/>
+        </p:nvSpPr>
+        <p:spPr>
+          <a:xfrm>
+            <a:off x="9738360" y="4846320"/>
+            <a:ext cx="731520" cy="0"/>
+          </a:xfrm>
+          <a:prstGeom prst="line">
+            <a:avLst/>
+          </a:prstGeom>
+          <a:noFill/>
+          <a:ln w="15875">
+            <a:solidFill>
+              <a:srgbClr val="1A1A1A"/>
+            </a:solidFill>
+            <a:prstDash val="solid"/>
+          </a:ln>
+        </p:spPr>
+      </p:sp>
+      <p:sp>
+        <p:nvSpPr>
+          <p:cNvPr id="39" name="Other sources arrow"/>
+          <p:cNvSpPr/>
+          <p:nvPr/>
+        </p:nvSpPr>
+        <p:spPr>
+          <a:xfrm>
+            <a:off x="10469880" y="3054096"/>
+            <a:ext cx="0" cy="1792224"/>
+          </a:xfrm>
+          <a:prstGeom prst="line">
+            <a:avLst/>
+          </a:prstGeom>
+          <a:noFill/>
+          <a:ln w="15875">
+            <a:solidFill>
+              <a:srgbClr val="1A1A1A"/>
+            </a:solidFill>
+            <a:prstDash val="solid"/>
+            <a:headEnd type="triangle"/>
+          </a:ln>
+        </p:spPr>
+      </p:sp>
+      <p:sp>
+        <p:nvSpPr>
+          <p:cNvPr id="40" name="Text 38"/>
+          <p:cNvSpPr txBox="1"/>
+          <p:nvPr/>
+        </p:nvSpPr>
+        <p:spPr>
+          <a:xfrm>
+            <a:off x="548640" y="5806440"/>
+            <a:ext cx="6400800" cy="274320"/>
+          </a:xfrm>
+          <a:prstGeom prst="rect">
+            <a:avLst/>
+          </a:prstGeom>
+          <a:noFill/>
+          <a:ln/>
+        </p:spPr>
+        <p:txBody>
+          <a:bodyPr wrap="square" lIns="0" tIns="0" rIns="0" bIns="0" rtlCol="0" anchor="t"/>
+          <a:lstStyle/>
+          <a:p>
             <a:pPr indent="0" marL="0">
               <a:buNone/>
             </a:pPr>
             <a:r>
-              <a:rPr lang="en-US" sz="1400" b="1" dirty="0">
+              <a:rPr lang="en-US" sz="1100" i="1" dirty="0">
                 <a:solidFill>
                   <a:schemeClr val="accent3"/>
                 </a:solidFill>
               </a:rPr>
-              <a:t>PLACEHOLDER: content by Niloufar</a:t>
-            </a:r>
-            <a:endParaRPr lang="en-US" sz="1400" dirty="0"/>
-          </a:p>
-          <a:p>
-            <a:pPr indent="0" marL="0">
-              <a:spcAft>
-                <a:spcPts val="600"/>
-              </a:spcAft>
-              <a:buNone/>
-            </a:pPr>
-            <a:r>
-              <a:rPr lang="en-US" sz="1400" i="1" dirty="0">
-                <a:solidFill>
-                  <a:schemeClr val="accent3"/>
-                </a:solidFill>
-              </a:rPr>
-              <a:t>Suggested points from the final report:</a:t>
-            </a:r>
-            <a:endParaRPr lang="en-US" sz="1400" dirty="0"/>
-          </a:p>
-          <a:p>
-            <a:pPr marL="342900" indent="-342900">
-              <a:spcAft>
-                <a:spcPts val="400"/>
-              </a:spcAft>
-              <a:buSzPct val="100000"/>
-              <a:buChar char="•"/>
-            </a:pPr>
-            <a:r>
-              <a:rPr lang="en-US" sz="1600" dirty="0">
-                <a:solidFill>
-                  <a:schemeClr val="tx1"/>
-                </a:solidFill>
-              </a:rPr>
-              <a:t>Systematic search of PubMed, Scopus, Web of Science and NASA's technical reports, 2013 onwards: 5,731 records</a:t>
-            </a:r>
-            <a:endParaRPr lang="en-US" sz="1400" dirty="0"/>
-          </a:p>
-          <a:p>
-            <a:pPr marL="342900" indent="-342900">
-              <a:spcAft>
-                <a:spcPts val="400"/>
-              </a:spcAft>
-              <a:buSzPct val="100000"/>
-              <a:buChar char="•"/>
-            </a:pPr>
-            <a:r>
-              <a:rPr lang="en-US" sz="1600" dirty="0">
-                <a:solidFill>
-                  <a:schemeClr val="tx1"/>
-                </a:solidFill>
-              </a:rPr>
-              <a:t>Plus 9 older studies and one campaign from NASA's open bed-rest archive</a:t>
-            </a:r>
-            <a:endParaRPr lang="en-US" sz="1400" dirty="0"/>
-          </a:p>
-          <a:p>
-            <a:pPr marL="342900" indent="-342900">
-              <a:spcAft>
-                <a:spcPts val="400"/>
-              </a:spcAft>
-              <a:buSzPct val="100000"/>
-              <a:buChar char="•"/>
-            </a:pPr>
-            <a:r>
-              <a:rPr lang="en-US" sz="1600" dirty="0">
-                <a:solidFill>
-                  <a:schemeClr val="tx1"/>
-                </a:solidFill>
-              </a:rPr>
-              <a:t>Extraction form fixed before extraction: one row per study, group, muscle and scan day</a:t>
-            </a:r>
-            <a:endParaRPr lang="en-US" sz="1400" dirty="0"/>
-          </a:p>
-          <a:p>
-            <a:pPr marL="342900" indent="-342900">
-              <a:spcAft>
-                <a:spcPts val="400"/>
-              </a:spcAft>
-              <a:buSzPct val="100000"/>
-              <a:buChar char="•"/>
-            </a:pPr>
-            <a:r>
-              <a:rPr lang="en-US" sz="1600" dirty="0">
-                <a:solidFill>
-                  <a:schemeClr val="tx1"/>
-                </a:solidFill>
-              </a:rPr>
-              <a:t>Papers that report the same volunteers merged into one campaign</a:t>
-            </a:r>
-            <a:endParaRPr lang="en-US" sz="1400" dirty="0"/>
-          </a:p>
-          <a:p>
-            <a:pPr indent="0" marL="0">
-              <a:buNone/>
-            </a:pPr>
-            <a:r>
-              <a:rPr lang="en-US" sz="1400" i="1" dirty="0">
-                <a:solidFill>
-                  <a:schemeClr val="accent3"/>
-                </a:solidFill>
-              </a:rPr>
-              <a:t>Possible figure: search flow diagram (figures/F1_corpus)</a:t>
-            </a:r>
-            <a:endParaRPr lang="en-US" sz="1400" dirty="0"/>
+              <a:t>Flow of records in the style of PRISMA 2020, the standard for reporting systematic reviews.</a:t>
+            </a:r>
+            <a:endParaRPr lang="en-US" sz="1100" dirty="0"/>
           </a:p>
         </p:txBody>
       </p:sp>

</xml_diff>

<commit_message>
Slide 6: fold other sources into the flow counts, cohort merge in final step
Co-Authored-By: Claude Opus 5.5 (1M context) <noreply@anthropic.com>
Claude-Session: https://claude.ai/code/session_01JZtuYERhuCe7nB9VYHwcfv
</commit_message>
<xml_diff>
--- a/presentation/bed-rest-to-mars-talk.pptx
+++ b/presentation/bed-rest-to-mars-talk.pptx
@@ -126,13 +126,13 @@
   <p:extLst>
     <p:ext uri="{521415D9-36F7-43E2-AB2F-B90AF26B5E84}">
       <p14:sectionLst xmlns:p14="http://schemas.microsoft.com/office/powerpoint/2010/main">
-        <p14:section name="Opening" id="{e5d3bbd1-0136-ea66-e75e-f8424b43077b}">
+        <p14:section name="Opening" id="{b39decb4-f9fe-7962-a699-f93aa75e7ef6}">
           <p14:sldIdLst>
             <p14:sldId id="256"/>
             <p14:sldId id="257"/>
           </p14:sldIdLst>
         </p14:section>
-        <p14:section name="Part 1" id="{04d8b939-de5e-b9f6-35f3-f7687f3c59e9}">
+        <p14:section name="Part 1" id="{5da06e3a-be7c-2a48-7fd0-479c783341cd}">
           <p14:sldIdLst>
             <p14:sldId id="258"/>
             <p14:sldId id="259"/>
@@ -143,7 +143,7 @@
             <p14:sldId id="264"/>
           </p14:sldIdLst>
         </p14:section>
-        <p14:section name="Part 2" id="{e6a16378-f193-76f6-84e3-23161c894c38}">
+        <p14:section name="Part 2" id="{c2d77d1c-6d45-cfc3-ebbd-31a017a7b51b}">
           <p14:sldIdLst>
             <p14:sldId id="265"/>
             <p14:sldId id="266"/>
@@ -154,7 +154,7 @@
             <p14:sldId id="271"/>
           </p14:sldIdLst>
         </p14:section>
-        <p14:section name="Backup" id="{d8811695-32d0-f670-858d-f48486ad0bd4}">
+        <p14:section name="Backup" id="{ca968be5-448b-2113-adb4-089a98712620}">
           <p14:sldIdLst>
             <p14:sldId id="272"/>
             <p14:sldId id="273"/>
@@ -162,13 +162,13 @@
             <p14:sldId id="275"/>
           </p14:sldIdLst>
         </p14:section>
-        <p14:section name="Backup" id="{1c7f70d3-4462-d76c-5d0c-c8d1a7bb751d}">
+        <p14:section name="Backup" id="{eb383515-5a44-5528-7ab8-287357ea9d7d}">
           <p14:sldIdLst/>
         </p14:section>
-        <p14:section name="Backup" id="{b8815342-a8e9-f5d4-2ed1-6745bd0e1a5e}">
+        <p14:section name="Backup" id="{5382d4b5-af0e-b5c4-cc8c-3a0b4074dab3}">
           <p14:sldIdLst/>
         </p14:section>
-        <p14:section name="Backup" id="{ce6a969f-2ae0-100f-c856-f58fedeebc14}">
+        <p14:section name="Backup" id="{c0062809-6e45-a21b-7821-73bb3c9a29e0}">
           <p14:sldIdLst/>
         </p14:section>
       </p14:sectionLst>
@@ -5141,9 +5141,9 @@
             <a:r>
               <a:rPr lang="en-US" dirty="0"/>
               <a:t>Part 1 (Niloufar), about one minute.
-We searched four databases, PubMed, Scopus, Web of Science and NASA's technical reports, for papers from 2013 onwards, and found 5,731 records. After removing duplicates, we screened 3,590 titles and abstracts. Most were excluded because they did not use an unloading model or did not measure muscle. 1,023 records could not be screened in the time available; they are not exclusions.
-We read 74 full texts. The main loss at this step: 19 studies show their muscle results only as charts, without a baseline value, so we could not extract them. The search gave 42 studies.
-Ten more came from other sources: nine older studies from before 2013, which the date limit of the search excluded, and one campaign from NASA's open bed-rest data. That gives the final dataset: 52 studies, 742 rows and 36 independent campaigns.</a:t>
+We searched four databases, PubMed, Scopus, Web of Science and NASA's technical reports, and added older work we had collected before the search, nine studies from before 2013 and one campaign from NASA's open bed-rest data. In total, 5,741 records. After removing duplicates, we screened 3,600 titles and abstracts. Most were excluded because they did not use an unloading model or did not measure muscle.
+We read 84 full texts. The main loss at this step: 19 studies show their muscle results only as charts, without a baseline value, so we could not extract them. 52 studies were included.
+Several papers often report the same bed-rest campaign, so we merged papers on the same cohort. The final dataset has 36 independent campaigns and 742 rows.</a:t>
             </a:r>
             <a:endParaRPr lang="en-US" dirty="0"/>
           </a:p>
@@ -18623,7 +18623,7 @@
         </p:nvSpPr>
         <p:spPr>
           <a:xfrm>
-            <a:off x="548640" y="1371600"/>
+            <a:off x="548640" y="1965960"/>
             <a:ext cx="1920240" cy="228600"/>
           </a:xfrm>
           <a:prstGeom prst="rect">
@@ -18659,7 +18659,7 @@
         </p:nvSpPr>
         <p:spPr>
           <a:xfrm>
-            <a:off x="548640" y="1691640"/>
+            <a:off x="548640" y="2286000"/>
             <a:ext cx="1920240" cy="1325880"/>
           </a:xfrm>
           <a:prstGeom prst="rect">
@@ -18684,7 +18684,7 @@
         </p:nvSpPr>
         <p:spPr>
           <a:xfrm>
-            <a:off x="640080" y="1764792"/>
+            <a:off x="640080" y="2359152"/>
             <a:ext cx="1737360" cy="1179576"/>
           </a:xfrm>
           <a:prstGeom prst="rect">
@@ -18709,7 +18709,7 @@
                 <a:ea typeface="Cambria" pitchFamily="34" charset="-122"/>
                 <a:cs typeface="Cambria" pitchFamily="34" charset="-120"/>
               </a:rPr>
-              <a:t>5,731</a:t>
+              <a:t>5,741</a:t>
             </a:r>
             <a:endParaRPr lang="en-US" sz="2600" dirty="0"/>
           </a:p>
@@ -18737,7 +18737,7 @@
                   <a:schemeClr val="accent3"/>
                 </a:solidFill>
               </a:rPr>
-              <a:t>PubMed, Scopus, Web of Science, NASA reports; 2013 onwards</a:t>
+              <a:t>PubMed, Scopus, Web of Science, NASA reports, earlier work</a:t>
             </a:r>
             <a:endParaRPr lang="en-US" sz="2600" dirty="0"/>
           </a:p>
@@ -18751,7 +18751,7 @@
         </p:nvSpPr>
         <p:spPr>
           <a:xfrm>
-            <a:off x="2505456" y="2354580"/>
+            <a:off x="2505456" y="2948940"/>
             <a:ext cx="246888" cy="0"/>
           </a:xfrm>
           <a:prstGeom prst="line">
@@ -18775,7 +18775,7 @@
         </p:nvSpPr>
         <p:spPr>
           <a:xfrm>
-            <a:off x="2788920" y="1371600"/>
+            <a:off x="2788920" y="1965960"/>
             <a:ext cx="1920240" cy="228600"/>
           </a:xfrm>
           <a:prstGeom prst="rect">
@@ -18811,7 +18811,7 @@
         </p:nvSpPr>
         <p:spPr>
           <a:xfrm>
-            <a:off x="2788920" y="1691640"/>
+            <a:off x="2788920" y="2286000"/>
             <a:ext cx="1920240" cy="1325880"/>
           </a:xfrm>
           <a:prstGeom prst="rect">
@@ -18836,7 +18836,7 @@
         </p:nvSpPr>
         <p:spPr>
           <a:xfrm>
-            <a:off x="2880360" y="1764792"/>
+            <a:off x="2880360" y="2359152"/>
             <a:ext cx="1737360" cy="1179576"/>
           </a:xfrm>
           <a:prstGeom prst="rect">
@@ -18861,7 +18861,7 @@
                 <a:ea typeface="Cambria" pitchFamily="34" charset="-122"/>
                 <a:cs typeface="Cambria" pitchFamily="34" charset="-120"/>
               </a:rPr>
-              <a:t>3,590</a:t>
+              <a:t>3,600</a:t>
             </a:r>
             <a:endParaRPr lang="en-US" sz="2600" dirty="0"/>
           </a:p>
@@ -18889,7 +18889,7 @@
         </p:nvSpPr>
         <p:spPr>
           <a:xfrm>
-            <a:off x="4745736" y="2354580"/>
+            <a:off x="4745736" y="2948940"/>
             <a:ext cx="246888" cy="0"/>
           </a:xfrm>
           <a:prstGeom prst="line">
@@ -18913,7 +18913,7 @@
         </p:nvSpPr>
         <p:spPr>
           <a:xfrm>
-            <a:off x="5029200" y="1371600"/>
+            <a:off x="5029200" y="1965960"/>
             <a:ext cx="1920240" cy="228600"/>
           </a:xfrm>
           <a:prstGeom prst="rect">
@@ -18949,7 +18949,7 @@
         </p:nvSpPr>
         <p:spPr>
           <a:xfrm>
-            <a:off x="5029200" y="1691640"/>
+            <a:off x="5029200" y="2286000"/>
             <a:ext cx="1920240" cy="1325880"/>
           </a:xfrm>
           <a:prstGeom prst="rect">
@@ -18974,7 +18974,7 @@
         </p:nvSpPr>
         <p:spPr>
           <a:xfrm>
-            <a:off x="5120640" y="1764792"/>
+            <a:off x="5120640" y="2359152"/>
             <a:ext cx="1737360" cy="1179576"/>
           </a:xfrm>
           <a:prstGeom prst="rect">
@@ -18999,7 +18999,7 @@
                 <a:ea typeface="Cambria" pitchFamily="34" charset="-122"/>
                 <a:cs typeface="Cambria" pitchFamily="34" charset="-120"/>
               </a:rPr>
-              <a:t>74</a:t>
+              <a:t>84</a:t>
             </a:r>
             <a:endParaRPr lang="en-US" sz="2600" dirty="0"/>
           </a:p>
@@ -19027,7 +19027,7 @@
         </p:nvSpPr>
         <p:spPr>
           <a:xfrm>
-            <a:off x="6986016" y="2354580"/>
+            <a:off x="6986016" y="2948940"/>
             <a:ext cx="246888" cy="0"/>
           </a:xfrm>
           <a:prstGeom prst="line">
@@ -19051,7 +19051,7 @@
         </p:nvSpPr>
         <p:spPr>
           <a:xfrm>
-            <a:off x="7269480" y="1371600"/>
+            <a:off x="7269480" y="1965960"/>
             <a:ext cx="1920240" cy="228600"/>
           </a:xfrm>
           <a:prstGeom prst="rect">
@@ -19087,7 +19087,7 @@
         </p:nvSpPr>
         <p:spPr>
           <a:xfrm>
-            <a:off x="7269480" y="1691640"/>
+            <a:off x="7269480" y="2286000"/>
             <a:ext cx="1920240" cy="1325880"/>
           </a:xfrm>
           <a:prstGeom prst="rect">
@@ -19112,7 +19112,7 @@
         </p:nvSpPr>
         <p:spPr>
           <a:xfrm>
-            <a:off x="7360920" y="1764792"/>
+            <a:off x="7360920" y="2359152"/>
             <a:ext cx="1737360" cy="1179576"/>
           </a:xfrm>
           <a:prstGeom prst="rect">
@@ -19137,7 +19137,7 @@
                 <a:ea typeface="Cambria" pitchFamily="34" charset="-122"/>
                 <a:cs typeface="Cambria" pitchFamily="34" charset="-120"/>
               </a:rPr>
-              <a:t>42</a:t>
+              <a:t>52</a:t>
             </a:r>
             <a:endParaRPr lang="en-US" sz="2600" dirty="0"/>
           </a:p>
@@ -19151,7 +19151,7 @@
                   <a:schemeClr val="tx1"/>
                 </a:solidFill>
               </a:rPr>
-              <a:t>studies from the search</a:t>
+              <a:t>studies</a:t>
             </a:r>
             <a:endParaRPr lang="en-US" sz="2600" dirty="0"/>
           </a:p>
@@ -19165,7 +19165,7 @@
         </p:nvSpPr>
         <p:spPr>
           <a:xfrm>
-            <a:off x="9226296" y="2354580"/>
+            <a:off x="9226296" y="2948940"/>
             <a:ext cx="246888" cy="0"/>
           </a:xfrm>
           <a:prstGeom prst="line">
@@ -19189,7 +19189,7 @@
         </p:nvSpPr>
         <p:spPr>
           <a:xfrm>
-            <a:off x="9509760" y="1371600"/>
+            <a:off x="9509760" y="1965960"/>
             <a:ext cx="1920240" cy="228600"/>
           </a:xfrm>
           <a:prstGeom prst="rect">
@@ -19225,7 +19225,7 @@
         </p:nvSpPr>
         <p:spPr>
           <a:xfrm>
-            <a:off x="9509760" y="1691640"/>
+            <a:off x="9509760" y="2286000"/>
             <a:ext cx="1920240" cy="1325880"/>
           </a:xfrm>
           <a:prstGeom prst="rect">
@@ -19250,7 +19250,7 @@
         </p:nvSpPr>
         <p:spPr>
           <a:xfrm>
-            <a:off x="9601200" y="1764792"/>
+            <a:off x="9601200" y="2359152"/>
             <a:ext cx="1737360" cy="1179576"/>
           </a:xfrm>
           <a:prstGeom prst="rect">
@@ -19275,7 +19275,7 @@
                 <a:ea typeface="Cambria" pitchFamily="34" charset="-122"/>
                 <a:cs typeface="Cambria" pitchFamily="34" charset="-120"/>
               </a:rPr>
-              <a:t>52</a:t>
+              <a:t>36</a:t>
             </a:r>
             <a:endParaRPr lang="en-US" sz="2600" dirty="0"/>
           </a:p>
@@ -19289,7 +19289,7 @@
                   <a:schemeClr val="bg1"/>
                 </a:solidFill>
               </a:rPr>
-              <a:t>studies</a:t>
+              <a:t>campaigns</a:t>
             </a:r>
             <a:endParaRPr lang="en-US" sz="2600" dirty="0"/>
           </a:p>
@@ -19303,7 +19303,7 @@
                   <a:schemeClr val="bg1"/>
                 </a:solidFill>
               </a:rPr>
-              <a:t>742 rows · 36 campaigns</a:t>
+              <a:t>742 rows; papers on the same cohort merged</a:t>
             </a:r>
             <a:endParaRPr lang="en-US" sz="2600" dirty="0"/>
           </a:p>
@@ -19317,7 +19317,7 @@
         </p:nvSpPr>
         <p:spPr>
           <a:xfrm>
-            <a:off x="2628900" y="2400300"/>
+            <a:off x="2628900" y="2994660"/>
             <a:ext cx="0" cy="960120"/>
           </a:xfrm>
           <a:prstGeom prst="line">
@@ -19341,7 +19341,7 @@
         </p:nvSpPr>
         <p:spPr>
           <a:xfrm>
-            <a:off x="1623060" y="3406140"/>
+            <a:off x="1623060" y="4000500"/>
             <a:ext cx="2011680" cy="1005840"/>
           </a:xfrm>
           <a:prstGeom prst="rect">
@@ -19377,7 +19377,7 @@
         </p:nvSpPr>
         <p:spPr>
           <a:xfrm>
-            <a:off x="4869180" y="2400300"/>
+            <a:off x="4869180" y="2994660"/>
             <a:ext cx="0" cy="960120"/>
           </a:xfrm>
           <a:prstGeom prst="line">
@@ -19401,7 +19401,7 @@
         </p:nvSpPr>
         <p:spPr>
           <a:xfrm>
-            <a:off x="3863340" y="3406140"/>
+            <a:off x="3863340" y="4000500"/>
             <a:ext cx="2011680" cy="1005840"/>
           </a:xfrm>
           <a:prstGeom prst="rect">
@@ -19427,20 +19427,6 @@
             </a:r>
             <a:endParaRPr lang="en-US" sz="1100" dirty="0"/>
           </a:p>
-          <a:p>
-            <a:pPr algn="ctr" indent="0" marL="0">
-              <a:buNone/>
-            </a:pPr>
-            <a:r>
-              <a:rPr lang="en-US" sz="1100" dirty="0">
-                <a:solidFill>
-                  <a:schemeClr val="accent3"/>
-                </a:solidFill>
-              </a:rPr>
-              <a:t>1,023 not yet screened</a:t>
-            </a:r>
-            <a:endParaRPr lang="en-US" sz="1100" dirty="0"/>
-          </a:p>
         </p:txBody>
       </p:sp>
       <p:sp>
@@ -19451,7 +19437,7 @@
         </p:nvSpPr>
         <p:spPr>
           <a:xfrm>
-            <a:off x="7109460" y="2400300"/>
+            <a:off x="7109460" y="2994660"/>
             <a:ext cx="0" cy="960120"/>
           </a:xfrm>
           <a:prstGeom prst="line">
@@ -19475,7 +19461,7 @@
         </p:nvSpPr>
         <p:spPr>
           <a:xfrm>
-            <a:off x="6103620" y="3406140"/>
+            <a:off x="6103620" y="4000500"/>
             <a:ext cx="2011680" cy="1005840"/>
           </a:xfrm>
           <a:prstGeom prst="rect">
@@ -19519,143 +19505,7 @@
       </p:sp>
       <p:sp>
         <p:nvSpPr>
-          <p:cNvPr id="36" name="Other sources"/>
-          <p:cNvSpPr/>
-          <p:nvPr/>
-        </p:nvSpPr>
-        <p:spPr>
-          <a:xfrm>
-            <a:off x="7086600" y="4297680"/>
-            <a:ext cx="2651760" cy="1097280"/>
-          </a:xfrm>
-          <a:prstGeom prst="rect">
-            <a:avLst/>
-          </a:prstGeom>
-          <a:solidFill>
-            <a:schemeClr val="bg2"/>
-          </a:solidFill>
-          <a:ln w="12700">
-            <a:solidFill>
-              <a:srgbClr val="9AA3AE"/>
-            </a:solidFill>
-            <a:prstDash val="solid"/>
-          </a:ln>
-        </p:spPr>
-      </p:sp>
-      <p:sp>
-        <p:nvSpPr>
-          <p:cNvPr id="37" name="Text 35"/>
-          <p:cNvSpPr txBox="1"/>
-          <p:nvPr/>
-        </p:nvSpPr>
-        <p:spPr>
-          <a:xfrm>
-            <a:off x="7178040" y="4343400"/>
-            <a:ext cx="2468880" cy="1005840"/>
-          </a:xfrm>
-          <a:prstGeom prst="rect">
-            <a:avLst/>
-          </a:prstGeom>
-          <a:noFill/>
-          <a:ln/>
-        </p:spPr>
-        <p:txBody>
-          <a:bodyPr wrap="square" lIns="0" tIns="0" rIns="0" bIns="0" rtlCol="0" anchor="ctr"/>
-          <a:lstStyle/>
-          <a:p>
-            <a:pPr algn="ctr" indent="0" marL="0">
-              <a:buNone/>
-            </a:pPr>
-            <a:r>
-              <a:rPr lang="en-US" sz="1300" b="1" dirty="0">
-                <a:solidFill>
-                  <a:schemeClr val="tx1"/>
-                </a:solidFill>
-              </a:rPr>
-              <a:t>+10 from other sources</a:t>
-            </a:r>
-            <a:endParaRPr lang="en-US" sz="1300" dirty="0"/>
-          </a:p>
-          <a:p>
-            <a:pPr algn="ctr" indent="0" marL="0">
-              <a:buNone/>
-            </a:pPr>
-            <a:r>
-              <a:rPr lang="en-US" sz="1100" dirty="0">
-                <a:solidFill>
-                  <a:schemeClr val="accent3"/>
-                </a:solidFill>
-              </a:rPr>
-              <a:t>9 older studies (before 2013)</a:t>
-            </a:r>
-            <a:endParaRPr lang="en-US" sz="1300" dirty="0"/>
-          </a:p>
-          <a:p>
-            <a:pPr algn="ctr" indent="0" marL="0">
-              <a:buNone/>
-            </a:pPr>
-            <a:r>
-              <a:rPr lang="en-US" sz="1100" dirty="0">
-                <a:solidFill>
-                  <a:schemeClr val="accent3"/>
-                </a:solidFill>
-              </a:rPr>
-              <a:t>1 NASA open-data campaign</a:t>
-            </a:r>
-            <a:endParaRPr lang="en-US" sz="1300" dirty="0"/>
-          </a:p>
-        </p:txBody>
-      </p:sp>
-      <p:sp>
-        <p:nvSpPr>
-          <p:cNvPr id="38" name="Other sources line"/>
-          <p:cNvSpPr/>
-          <p:nvPr/>
-        </p:nvSpPr>
-        <p:spPr>
-          <a:xfrm>
-            <a:off x="9738360" y="4846320"/>
-            <a:ext cx="731520" cy="0"/>
-          </a:xfrm>
-          <a:prstGeom prst="line">
-            <a:avLst/>
-          </a:prstGeom>
-          <a:noFill/>
-          <a:ln w="15875">
-            <a:solidFill>
-              <a:srgbClr val="1A1A1A"/>
-            </a:solidFill>
-            <a:prstDash val="solid"/>
-          </a:ln>
-        </p:spPr>
-      </p:sp>
-      <p:sp>
-        <p:nvSpPr>
-          <p:cNvPr id="39" name="Other sources arrow"/>
-          <p:cNvSpPr/>
-          <p:nvPr/>
-        </p:nvSpPr>
-        <p:spPr>
-          <a:xfrm>
-            <a:off x="10469880" y="3054096"/>
-            <a:ext cx="0" cy="1792224"/>
-          </a:xfrm>
-          <a:prstGeom prst="line">
-            <a:avLst/>
-          </a:prstGeom>
-          <a:noFill/>
-          <a:ln w="15875">
-            <a:solidFill>
-              <a:srgbClr val="1A1A1A"/>
-            </a:solidFill>
-            <a:prstDash val="solid"/>
-            <a:headEnd type="triangle"/>
-          </a:ln>
-        </p:spPr>
-      </p:sp>
-      <p:sp>
-        <p:nvSpPr>
-          <p:cNvPr id="40" name="Text 38"/>
+          <p:cNvPr id="36" name="Text 34"/>
           <p:cNvSpPr txBox="1"/>
           <p:nvPr/>
         </p:nvSpPr>

</xml_diff>

<commit_message>
Slide 6: drop 'earlier work' from the sources line
Co-Authored-By: Claude Opus 5.5 (1M context) <noreply@anthropic.com>
Claude-Session: https://claude.ai/code/session_01JZtuYERhuCe7nB9VYHwcfv
</commit_message>
<xml_diff>
--- a/presentation/bed-rest-to-mars-talk.pptx
+++ b/presentation/bed-rest-to-mars-talk.pptx
@@ -126,13 +126,13 @@
   <p:extLst>
     <p:ext uri="{521415D9-36F7-43E2-AB2F-B90AF26B5E84}">
       <p14:sectionLst xmlns:p14="http://schemas.microsoft.com/office/powerpoint/2010/main">
-        <p14:section name="Opening" id="{b39decb4-f9fe-7962-a699-f93aa75e7ef6}">
+        <p14:section name="Opening" id="{5cfff099-8b3c-e504-e703-79b22abe9499}">
           <p14:sldIdLst>
             <p14:sldId id="256"/>
             <p14:sldId id="257"/>
           </p14:sldIdLst>
         </p14:section>
-        <p14:section name="Part 1" id="{5da06e3a-be7c-2a48-7fd0-479c783341cd}">
+        <p14:section name="Part 1" id="{74defe6b-51b3-b5f7-ae78-cbb98e133240}">
           <p14:sldIdLst>
             <p14:sldId id="258"/>
             <p14:sldId id="259"/>
@@ -143,7 +143,7 @@
             <p14:sldId id="264"/>
           </p14:sldIdLst>
         </p14:section>
-        <p14:section name="Part 2" id="{c2d77d1c-6d45-cfc3-ebbd-31a017a7b51b}">
+        <p14:section name="Part 2" id="{1f2a7c96-cfcd-7598-1151-40185d39e361}">
           <p14:sldIdLst>
             <p14:sldId id="265"/>
             <p14:sldId id="266"/>
@@ -154,7 +154,7 @@
             <p14:sldId id="271"/>
           </p14:sldIdLst>
         </p14:section>
-        <p14:section name="Backup" id="{ca968be5-448b-2113-adb4-089a98712620}">
+        <p14:section name="Backup" id="{6ca111da-ee9f-245d-12c3-0a5fc7ab500a}">
           <p14:sldIdLst>
             <p14:sldId id="272"/>
             <p14:sldId id="273"/>
@@ -162,13 +162,13 @@
             <p14:sldId id="275"/>
           </p14:sldIdLst>
         </p14:section>
-        <p14:section name="Backup" id="{eb383515-5a44-5528-7ab8-287357ea9d7d}">
+        <p14:section name="Backup" id="{443e84cd-239a-bc00-f531-b4ba7a613b68}">
           <p14:sldIdLst/>
         </p14:section>
-        <p14:section name="Backup" id="{5382d4b5-af0e-b5c4-cc8c-3a0b4074dab3}">
+        <p14:section name="Backup" id="{882df4d3-57db-3639-e7f8-2f51c84a7d67}">
           <p14:sldIdLst/>
         </p14:section>
-        <p14:section name="Backup" id="{c0062809-6e45-a21b-7821-73bb3c9a29e0}">
+        <p14:section name="Backup" id="{7e49177c-d63d-5041-917e-76c433e398ac}">
           <p14:sldIdLst/>
         </p14:section>
       </p14:sectionLst>
@@ -18737,7 +18737,7 @@
                   <a:schemeClr val="accent3"/>
                 </a:solidFill>
               </a:rPr>
-              <a:t>PubMed, Scopus, Web of Science, NASA reports, earlier work</a:t>
+              <a:t>PubMed, Scopus, Web of Science, NASA reports</a:t>
             </a:r>
             <a:endParaRPr lang="en-US" sz="2600" dirty="0"/>
           </a:p>

</xml_diff>

<commit_message>
Slide 7: replace charts with two summary tables
Co-Authored-By: Claude Opus 5.5 (1M context) <noreply@anthropic.com>
Claude-Session: https://claude.ai/code/session_01JZtuYERhuCe7nB9VYHwcfv
</commit_message>
<xml_diff>
--- a/presentation/bed-rest-to-mars-talk.pptx
+++ b/presentation/bed-rest-to-mars-talk.pptx
@@ -125,13 +125,13 @@
   <p:extLst>
     <p:ext uri="{521415D9-36F7-43E2-AB2F-B90AF26B5E84}">
       <p14:sectionLst xmlns:p14="http://schemas.microsoft.com/office/powerpoint/2010/main">
-        <p14:section name="Opening" id="{7d4ee912-66fc-aee9-ad23-4cabc61f868a}">
+        <p14:section name="Opening" id="{651a0c56-705e-22fb-1095-a5ebcfba93af}">
           <p14:sldIdLst>
             <p14:sldId id="256"/>
             <p14:sldId id="257"/>
           </p14:sldIdLst>
         </p14:section>
-        <p14:section name="Part 1" id="{a7759218-caf7-9f7a-b999-7b78e28aafbf}">
+        <p14:section name="Part 1" id="{6bbe44c9-ad18-16e2-8362-5b485b5d125f}">
           <p14:sldIdLst>
             <p14:sldId id="258"/>
             <p14:sldId id="259"/>
@@ -141,7 +141,7 @@
             <p14:sldId id="263"/>
           </p14:sldIdLst>
         </p14:section>
-        <p14:section name="Part 2" id="{11f055f6-2330-baa0-6a9d-aab9fb09ae7a}">
+        <p14:section name="Part 2" id="{eb6e1c5a-384e-103f-0735-dd16ec5cd5ef}">
           <p14:sldIdLst>
             <p14:sldId id="264"/>
             <p14:sldId id="265"/>
@@ -152,7 +152,7 @@
             <p14:sldId id="270"/>
           </p14:sldIdLst>
         </p14:section>
-        <p14:section name="Backup" id="{52fbde55-391e-51aa-24c2-a21a898a6e22}">
+        <p14:section name="Backup" id="{6c2fc589-fa4f-32f8-554b-35c268ac8fef}">
           <p14:sldIdLst>
             <p14:sldId id="271"/>
             <p14:sldId id="272"/>
@@ -160,13 +160,13 @@
             <p14:sldId id="274"/>
           </p14:sldIdLst>
         </p14:section>
-        <p14:section name="Backup" id="{a27caadb-92c3-f8ea-bdb6-86740c41ad0e}">
+        <p14:section name="Backup" id="{8af084f3-70b1-c163-5858-4d7c8c321f3e}">
           <p14:sldIdLst/>
         </p14:section>
-        <p14:section name="Backup" id="{e58cbd7a-b166-7e34-bcd4-fa45e6fa5e77}">
+        <p14:section name="Backup" id="{5d6f23a0-0fd6-99cc-2846-18b2f8190f68}">
           <p14:sldIdLst/>
         </p14:section>
-        <p14:section name="Backup" id="{7a23ccb1-8b11-01ab-08c6-2e92b95c9752}">
+        <p14:section name="Backup" id="{f24f3d41-693c-2338-1d24-cf8d9d9e872b}">
           <p14:sldIdLst/>
         </p14:section>
       </p14:sectionLst>
@@ -1361,879 +1361,6 @@
             <a:pPr>
               <a:defRPr sz="1300" b="1" i="0" u="none" strike="noStrike">
                 <a:solidFill>
-                  <a:srgbClr val="1F3A5F"/>
-                </a:solidFill>
-                <a:latin typeface="Arial"/>
-              </a:defRPr>
-            </a:pPr>
-            <a:r>
-              <a:rPr sz="1300" b="1" i="0" u="none" strike="noStrike">
-                <a:solidFill>
-                  <a:srgbClr val="1F3A5F"/>
-                </a:solidFill>
-                <a:latin typeface="Arial"/>
-              </a:rPr>
-              <a:t>742 rows across 51 muscles, by muscle group</a:t>
-            </a:r>
-          </a:p>
-        </c:rich>
-      </c:tx>
-      <c:layout/>
-      <c:overlay val="0"/>
-    </c:title>
-    <c:autoTitleDeleted val="0"/>
-    <c:plotArea>
-      <c:layout/>
-      <c:barChart>
-        <c:barDir val="bar"/>
-        <c:grouping val="clustered"/>
-        <c:varyColors val="0"/>
-        <c:ser>
-          <c:idx val="0"/>
-          <c:order val="0"/>
-          <c:tx>
-            <c:strRef>
-              <c:f>Sheet1!$B$1</c:f>
-              <c:strCache>
-                <c:ptCount val="1"/>
-                <c:pt idx="0">
-                  <c:v>Rows</c:v>
-                </c:pt>
-              </c:strCache>
-            </c:strRef>
-          </c:tx>
-          <c:spPr>
-            <a:solidFill>
-              <a:srgbClr val="1F3A5F"/>
-            </a:solidFill>
-            <a:effectLst/>
-          </c:spPr>
-          <c:invertIfNegative val="0"/>
-          <c:dLbls>
-            <c:numFmt formatCode="#,##0" sourceLinked="0"/>
-            <c:txPr>
-              <a:bodyPr/>
-              <a:lstStyle/>
-              <a:p>
-                <a:pPr>
-                  <a:defRPr b="0" i="0" strike="noStrike" sz="1000" u="none">
-                    <a:solidFill>
-                      <a:srgbClr val="1A1A1A"/>
-                    </a:solidFill>
-                    <a:latin typeface="Arial"/>
-                  </a:defRPr>
-                </a:pPr>
-              </a:p>
-            </c:txPr>
-            <c:showLegendKey val="0"/>
-            <c:showVal val="1"/>
-            <c:showCatName val="0"/>
-            <c:showSerName val="0"/>
-            <c:showPercent val="0"/>
-            <c:showBubbleSize val="0"/>
-            <c:showLeaderLines val="0"/>
-          </c:dLbls>
-          <c:cat>
-            <c:multiLvlStrRef>
-              <c:f>Sheet1!$A$2:$A$13</c:f>
-              <c:multiLvlStrCache>
-                <c:ptCount val="12"/>
-                <c:lvl>
-                  <c:pt idx="0">
-                    <c:v>Hip abductors</c:v>
-                  </c:pt>
-                  <c:pt idx="1">
-                    <c:v>Glutes (hip extensors)</c:v>
-                  </c:pt>
-                  <c:pt idx="2">
-                    <c:v>Evertors (outer shin)</c:v>
-                  </c:pt>
-                  <c:pt idx="3">
-                    <c:v>Shin (dorsiflexors)</c:v>
-                  </c:pt>
-                  <c:pt idx="4">
-                    <c:v>Hip rotators</c:v>
-                  </c:pt>
-                  <c:pt idx="5">
-                    <c:v>Hip flexors</c:v>
-                  </c:pt>
-                  <c:pt idx="6">
-                    <c:v>Whole leg</c:v>
-                  </c:pt>
-                  <c:pt idx="7">
-                    <c:v>Inner thigh (hip adductors)</c:v>
-                  </c:pt>
-                  <c:pt idx="8">
-                    <c:v>Lower back (trunk extensors)</c:v>
-                  </c:pt>
-                  <c:pt idx="9">
-                    <c:v>Hamstrings (knee flexors)</c:v>
-                  </c:pt>
-                  <c:pt idx="10">
-                    <c:v>Calf (plantar flexors)</c:v>
-                  </c:pt>
-                  <c:pt idx="11">
-                    <c:v>Front thigh (knee extensors)</c:v>
-                  </c:pt>
-                </c:lvl>
-              </c:multiLvlStrCache>
-            </c:multiLvlStrRef>
-          </c:cat>
-          <c:val>
-            <c:numRef>
-              <c:f>Sheet1!$B$2:$B$13</c:f>
-              <c:numCache>
-                <c:formatCode>General</c:formatCode>
-                <c:ptCount val="12"/>
-                <c:pt idx="0">
-                  <c:v>6</c:v>
-                </c:pt>
-                <c:pt idx="1">
-                  <c:v>17</c:v>
-                </c:pt>
-                <c:pt idx="2">
-                  <c:v>19</c:v>
-                </c:pt>
-                <c:pt idx="3">
-                  <c:v>25</c:v>
-                </c:pt>
-                <c:pt idx="4">
-                  <c:v>36</c:v>
-                </c:pt>
-                <c:pt idx="5">
-                  <c:v>53</c:v>
-                </c:pt>
-                <c:pt idx="6">
-                  <c:v>62</c:v>
-                </c:pt>
-                <c:pt idx="7">
-                  <c:v>71</c:v>
-                </c:pt>
-                <c:pt idx="8">
-                  <c:v>73</c:v>
-                </c:pt>
-                <c:pt idx="9">
-                  <c:v>105</c:v>
-                </c:pt>
-                <c:pt idx="10">
-                  <c:v>135</c:v>
-                </c:pt>
-                <c:pt idx="11">
-                  <c:v>140</c:v>
-                </c:pt>
-              </c:numCache>
-            </c:numRef>
-          </c:val>
-        </c:ser>
-        <c:dLbls>
-          <c:numFmt formatCode="#,##0" sourceLinked="0"/>
-          <c:txPr>
-            <a:bodyPr/>
-            <a:lstStyle/>
-            <a:p>
-              <a:pPr>
-                <a:defRPr b="0" i="0" strike="noStrike" sz="1000" u="none">
-                  <a:solidFill>
-                    <a:srgbClr val="1A1A1A"/>
-                  </a:solidFill>
-                  <a:latin typeface="Arial"/>
-                </a:defRPr>
-              </a:pPr>
-            </a:p>
-          </c:txPr>
-          <c:showLegendKey val="0"/>
-          <c:showVal val="1"/>
-          <c:showCatName val="0"/>
-          <c:showSerName val="0"/>
-          <c:showPercent val="0"/>
-          <c:showBubbleSize val="0"/>
-          <c:showLeaderLines val="0"/>
-        </c:dLbls>
-        <c:gapWidth val="40"/>
-        <c:overlap val="0"/>
-        <c:axId val="2094734554"/>
-        <c:axId val="2094734552"/>
-        <c:axId val="2094734556"/>
-      </c:barChart>
-      <c:catAx>
-        <c:axId val="2094734554"/>
-        <c:scaling>
-          <c:orientation val="minMax"/>
-        </c:scaling>
-        <c:delete val="0"/>
-        <c:axPos val="l"/>
-        <c:numFmt formatCode="General" sourceLinked="1"/>
-        <c:majorTickMark val="out"/>
-        <c:minorTickMark val="none"/>
-        <c:tickLblPos val="nextTo"/>
-        <c:spPr>
-          <a:ln w="12700" cap="flat">
-            <a:solidFill>
-              <a:srgbClr val="9AA3AE"/>
-            </a:solidFill>
-            <a:prstDash val="solid"/>
-            <a:round/>
-          </a:ln>
-        </c:spPr>
-        <c:txPr>
-          <a:bodyPr/>
-          <a:lstStyle/>
-          <a:p>
-            <a:pPr>
-              <a:defRPr sz="1050" b="0" i="0" u="none" strike="noStrike">
-                <a:solidFill>
-                  <a:srgbClr val="1A1A1A"/>
-                </a:solidFill>
-                <a:latin typeface="Arial"/>
-              </a:defRPr>
-            </a:pPr>
-            <a:endParaRPr lang="en-US"/>
-          </a:p>
-        </c:txPr>
-        <c:crossAx val="2094734552"/>
-        <c:crosses val="autoZero"/>
-        <c:auto val="1"/>
-        <c:lblAlgn val="ctr"/>
-        <c:noMultiLvlLbl val="1"/>
-      </c:catAx>
-      <c:valAx>
-        <c:axId val="2094734552"/>
-        <c:scaling>
-          <c:orientation val="minMax"/>
-        </c:scaling>
-        <c:delete val="1"/>
-        <c:axPos val="b"/>
-        <c:numFmt formatCode="General" sourceLinked="0"/>
-        <c:majorTickMark val="out"/>
-        <c:minorTickMark val="none"/>
-        <c:tickLblPos val="low"/>
-        <c:spPr>
-          <a:ln w="12700" cap="flat">
-            <a:solidFill>
-              <a:srgbClr val="888888"/>
-            </a:solidFill>
-            <a:prstDash val="solid"/>
-            <a:round/>
-          </a:ln>
-        </c:spPr>
-        <c:txPr>
-          <a:bodyPr/>
-          <a:lstStyle/>
-          <a:p>
-            <a:pPr>
-              <a:defRPr sz="1200" b="0" i="0" u="none" strike="noStrike">
-                <a:solidFill>
-                  <a:srgbClr val="000000"/>
-                </a:solidFill>
-                <a:latin typeface="Arial"/>
-              </a:defRPr>
-            </a:pPr>
-            <a:endParaRPr lang="en-US"/>
-          </a:p>
-        </c:txPr>
-        <c:crossAx val="2094734554"/>
-        <c:crosses val="autoZero"/>
-        <c:crossBetween val="between"/>
-      </c:valAx>
-      <c:spPr>
-        <a:noFill/>
-        <a:ln>
-          <a:noFill/>
-        </a:ln>
-        <a:effectLst/>
-      </c:spPr>
-    </c:plotArea>
-    <c:plotVisOnly val="1"/>
-    <c:dispBlanksAs val="span"/>
-  </c:chart>
-  <c:spPr>
-    <a:noFill/>
-    <a:ln>
-      <a:noFill/>
-    </a:ln>
-    <a:effectLst/>
-  </c:spPr>
-  <c:externalData r:id="rId1">
-    <c:autoUpdate val="0"/>
-  </c:externalData>
-</c:chartSpace>
-</file>
-
-<file path=ppt/charts/chart3.xml><?xml version="1.0" encoding="utf-8"?>
-<c:chartSpace xmlns:c="http://schemas.openxmlformats.org/drawingml/2006/chart" xmlns:a="http://schemas.openxmlformats.org/drawingml/2006/main" xmlns:r="http://schemas.openxmlformats.org/officeDocument/2006/relationships">
-  <c:date1904 val="0"/>
-  <c:roundedCorners val="1"/>
-  <c:chart>
-    <c:title>
-      <c:tx>
-        <c:rich>
-          <a:bodyPr/>
-          <a:lstStyle/>
-          <a:p>
-            <a:pPr>
-              <a:defRPr sz="1300" b="1" i="0" u="none" strike="noStrike">
-                <a:solidFill>
-                  <a:srgbClr val="1F3A5F"/>
-                </a:solidFill>
-                <a:latin typeface="Arial"/>
-              </a:defRPr>
-            </a:pPr>
-            <a:r>
-              <a:rPr sz="1300" b="1" i="0" u="none" strike="noStrike">
-                <a:solidFill>
-                  <a:srgbClr val="1F3A5F"/>
-                </a:solidFill>
-                <a:latin typeface="Arial"/>
-              </a:rPr>
-              <a:t>Rows by imaging method and size measure</a:t>
-            </a:r>
-          </a:p>
-        </c:rich>
-      </c:tx>
-      <c:layout/>
-      <c:overlay val="0"/>
-    </c:title>
-    <c:autoTitleDeleted val="0"/>
-    <c:plotArea>
-      <c:layout/>
-      <c:barChart>
-        <c:barDir val="bar"/>
-        <c:grouping val="stacked"/>
-        <c:varyColors val="0"/>
-        <c:ser>
-          <c:idx val="0"/>
-          <c:order val="0"/>
-          <c:tx>
-            <c:strRef>
-              <c:f>Sheet1!$B$1</c:f>
-              <c:strCache>
-                <c:ptCount val="1"/>
-                <c:pt idx="0">
-                  <c:v>Volume</c:v>
-                </c:pt>
-              </c:strCache>
-            </c:strRef>
-          </c:tx>
-          <c:spPr>
-            <a:solidFill>
-              <a:srgbClr val="1F3A5F"/>
-            </a:solidFill>
-            <a:effectLst/>
-          </c:spPr>
-          <c:invertIfNegative val="0"/>
-          <c:dLbls>
-            <c:numFmt formatCode="#,##0" sourceLinked="0"/>
-            <c:txPr>
-              <a:bodyPr/>
-              <a:lstStyle/>
-              <a:p>
-                <a:pPr>
-                  <a:defRPr b="0" i="0" strike="noStrike" sz="1200" u="none">
-                    <a:solidFill>
-                      <a:srgbClr val="000000"/>
-                    </a:solidFill>
-                    <a:latin typeface="Arial"/>
-                  </a:defRPr>
-                </a:pPr>
-              </a:p>
-            </c:txPr>
-            <c:showLegendKey val="0"/>
-            <c:showVal val="0"/>
-            <c:showCatName val="0"/>
-            <c:showSerName val="0"/>
-            <c:showPercent val="0"/>
-            <c:showBubbleSize val="0"/>
-            <c:showLeaderLines val="0"/>
-          </c:dLbls>
-          <c:cat>
-            <c:multiLvlStrRef>
-              <c:f>Sheet1!$A$2:$A$5</c:f>
-              <c:multiLvlStrCache>
-                <c:ptCount val="4"/>
-                <c:lvl>
-                  <c:pt idx="0">
-                    <c:v>Ultrasound (20)</c:v>
-                  </c:pt>
-                  <c:pt idx="1">
-                    <c:v>CT (30)</c:v>
-                  </c:pt>
-                  <c:pt idx="2">
-                    <c:v>DXA (37)</c:v>
-                  </c:pt>
-                  <c:pt idx="3">
-                    <c:v>MRI (655)</c:v>
-                  </c:pt>
-                </c:lvl>
-              </c:multiLvlStrCache>
-            </c:multiLvlStrRef>
-          </c:cat>
-          <c:val>
-            <c:numRef>
-              <c:f>Sheet1!$B$2:$B$5</c:f>
-              <c:numCache>
-                <c:formatCode>General</c:formatCode>
-                <c:ptCount val="4"/>
-                <c:pt idx="0">
-                  <c:v>0</c:v>
-                </c:pt>
-                <c:pt idx="1">
-                  <c:v>0</c:v>
-                </c:pt>
-                <c:pt idx="2">
-                  <c:v>0</c:v>
-                </c:pt>
-                <c:pt idx="3">
-                  <c:v>594</c:v>
-                </c:pt>
-              </c:numCache>
-            </c:numRef>
-          </c:val>
-        </c:ser>
-        <c:ser>
-          <c:idx val="1"/>
-          <c:order val="1"/>
-          <c:tx>
-            <c:strRef>
-              <c:f>Sheet1!$C$1</c:f>
-              <c:strCache>
-                <c:ptCount val="1"/>
-                <c:pt idx="0">
-                  <c:v>Cross-sectional area</c:v>
-                </c:pt>
-              </c:strCache>
-            </c:strRef>
-          </c:tx>
-          <c:spPr>
-            <a:solidFill>
-              <a:srgbClr val="56739A"/>
-            </a:solidFill>
-            <a:effectLst/>
-          </c:spPr>
-          <c:invertIfNegative val="0"/>
-          <c:dLbls>
-            <c:numFmt formatCode="#,##0" sourceLinked="0"/>
-            <c:txPr>
-              <a:bodyPr/>
-              <a:lstStyle/>
-              <a:p>
-                <a:pPr>
-                  <a:defRPr b="0" i="0" strike="noStrike" sz="1200" u="none">
-                    <a:solidFill>
-                      <a:srgbClr val="000000"/>
-                    </a:solidFill>
-                    <a:latin typeface="Arial"/>
-                  </a:defRPr>
-                </a:pPr>
-              </a:p>
-            </c:txPr>
-            <c:showLegendKey val="0"/>
-            <c:showVal val="0"/>
-            <c:showCatName val="0"/>
-            <c:showSerName val="0"/>
-            <c:showPercent val="0"/>
-            <c:showBubbleSize val="0"/>
-            <c:showLeaderLines val="0"/>
-          </c:dLbls>
-          <c:cat>
-            <c:multiLvlStrRef>
-              <c:f>Sheet1!$A$2:$A$5</c:f>
-              <c:multiLvlStrCache>
-                <c:ptCount val="4"/>
-                <c:lvl>
-                  <c:pt idx="0">
-                    <c:v>Ultrasound (20)</c:v>
-                  </c:pt>
-                  <c:pt idx="1">
-                    <c:v>CT (30)</c:v>
-                  </c:pt>
-                  <c:pt idx="2">
-                    <c:v>DXA (37)</c:v>
-                  </c:pt>
-                  <c:pt idx="3">
-                    <c:v>MRI (655)</c:v>
-                  </c:pt>
-                </c:lvl>
-              </c:multiLvlStrCache>
-            </c:multiLvlStrRef>
-          </c:cat>
-          <c:val>
-            <c:numRef>
-              <c:f>Sheet1!$C$2:$C$5</c:f>
-              <c:numCache>
-                <c:formatCode>General</c:formatCode>
-                <c:ptCount val="4"/>
-                <c:pt idx="0">
-                  <c:v>9</c:v>
-                </c:pt>
-                <c:pt idx="1">
-                  <c:v>30</c:v>
-                </c:pt>
-                <c:pt idx="2">
-                  <c:v>0</c:v>
-                </c:pt>
-                <c:pt idx="3">
-                  <c:v>61</c:v>
-                </c:pt>
-              </c:numCache>
-            </c:numRef>
-          </c:val>
-        </c:ser>
-        <c:ser>
-          <c:idx val="2"/>
-          <c:order val="2"/>
-          <c:tx>
-            <c:strRef>
-              <c:f>Sheet1!$D$1</c:f>
-              <c:strCache>
-                <c:ptCount val="1"/>
-                <c:pt idx="0">
-                  <c:v>Lean mass</c:v>
-                </c:pt>
-              </c:strCache>
-            </c:strRef>
-          </c:tx>
-          <c:spPr>
-            <a:solidFill>
-              <a:srgbClr val="A7AEB8"/>
-            </a:solidFill>
-            <a:effectLst/>
-          </c:spPr>
-          <c:invertIfNegative val="0"/>
-          <c:dLbls>
-            <c:numFmt formatCode="#,##0" sourceLinked="0"/>
-            <c:txPr>
-              <a:bodyPr/>
-              <a:lstStyle/>
-              <a:p>
-                <a:pPr>
-                  <a:defRPr b="0" i="0" strike="noStrike" sz="1200" u="none">
-                    <a:solidFill>
-                      <a:srgbClr val="000000"/>
-                    </a:solidFill>
-                    <a:latin typeface="Arial"/>
-                  </a:defRPr>
-                </a:pPr>
-              </a:p>
-            </c:txPr>
-            <c:showLegendKey val="0"/>
-            <c:showVal val="0"/>
-            <c:showCatName val="0"/>
-            <c:showSerName val="0"/>
-            <c:showPercent val="0"/>
-            <c:showBubbleSize val="0"/>
-            <c:showLeaderLines val="0"/>
-          </c:dLbls>
-          <c:cat>
-            <c:multiLvlStrRef>
-              <c:f>Sheet1!$A$2:$A$5</c:f>
-              <c:multiLvlStrCache>
-                <c:ptCount val="4"/>
-                <c:lvl>
-                  <c:pt idx="0">
-                    <c:v>Ultrasound (20)</c:v>
-                  </c:pt>
-                  <c:pt idx="1">
-                    <c:v>CT (30)</c:v>
-                  </c:pt>
-                  <c:pt idx="2">
-                    <c:v>DXA (37)</c:v>
-                  </c:pt>
-                  <c:pt idx="3">
-                    <c:v>MRI (655)</c:v>
-                  </c:pt>
-                </c:lvl>
-              </c:multiLvlStrCache>
-            </c:multiLvlStrRef>
-          </c:cat>
-          <c:val>
-            <c:numRef>
-              <c:f>Sheet1!$D$2:$D$5</c:f>
-              <c:numCache>
-                <c:formatCode>General</c:formatCode>
-                <c:ptCount val="4"/>
-                <c:pt idx="0">
-                  <c:v>0</c:v>
-                </c:pt>
-                <c:pt idx="1">
-                  <c:v>0</c:v>
-                </c:pt>
-                <c:pt idx="2">
-                  <c:v>37</c:v>
-                </c:pt>
-                <c:pt idx="3">
-                  <c:v>0</c:v>
-                </c:pt>
-              </c:numCache>
-            </c:numRef>
-          </c:val>
-        </c:ser>
-        <c:ser>
-          <c:idx val="3"/>
-          <c:order val="3"/>
-          <c:tx>
-            <c:strRef>
-              <c:f>Sheet1!$E$1</c:f>
-              <c:strCache>
-                <c:ptCount val="1"/>
-                <c:pt idx="0">
-                  <c:v>Thickness</c:v>
-                </c:pt>
-              </c:strCache>
-            </c:strRef>
-          </c:tx>
-          <c:spPr>
-            <a:solidFill>
-              <a:srgbClr val="A23B2A"/>
-            </a:solidFill>
-            <a:effectLst/>
-          </c:spPr>
-          <c:invertIfNegative val="0"/>
-          <c:dLbls>
-            <c:numFmt formatCode="#,##0" sourceLinked="0"/>
-            <c:txPr>
-              <a:bodyPr/>
-              <a:lstStyle/>
-              <a:p>
-                <a:pPr>
-                  <a:defRPr b="0" i="0" strike="noStrike" sz="1200" u="none">
-                    <a:solidFill>
-                      <a:srgbClr val="000000"/>
-                    </a:solidFill>
-                    <a:latin typeface="Arial"/>
-                  </a:defRPr>
-                </a:pPr>
-              </a:p>
-            </c:txPr>
-            <c:showLegendKey val="0"/>
-            <c:showVal val="0"/>
-            <c:showCatName val="0"/>
-            <c:showSerName val="0"/>
-            <c:showPercent val="0"/>
-            <c:showBubbleSize val="0"/>
-            <c:showLeaderLines val="0"/>
-          </c:dLbls>
-          <c:cat>
-            <c:multiLvlStrRef>
-              <c:f>Sheet1!$A$2:$A$5</c:f>
-              <c:multiLvlStrCache>
-                <c:ptCount val="4"/>
-                <c:lvl>
-                  <c:pt idx="0">
-                    <c:v>Ultrasound (20)</c:v>
-                  </c:pt>
-                  <c:pt idx="1">
-                    <c:v>CT (30)</c:v>
-                  </c:pt>
-                  <c:pt idx="2">
-                    <c:v>DXA (37)</c:v>
-                  </c:pt>
-                  <c:pt idx="3">
-                    <c:v>MRI (655)</c:v>
-                  </c:pt>
-                </c:lvl>
-              </c:multiLvlStrCache>
-            </c:multiLvlStrRef>
-          </c:cat>
-          <c:val>
-            <c:numRef>
-              <c:f>Sheet1!$E$2:$E$5</c:f>
-              <c:numCache>
-                <c:formatCode>General</c:formatCode>
-                <c:ptCount val="4"/>
-                <c:pt idx="0">
-                  <c:v>11</c:v>
-                </c:pt>
-                <c:pt idx="1">
-                  <c:v>0</c:v>
-                </c:pt>
-                <c:pt idx="2">
-                  <c:v>0</c:v>
-                </c:pt>
-                <c:pt idx="3">
-                  <c:v>0</c:v>
-                </c:pt>
-              </c:numCache>
-            </c:numRef>
-          </c:val>
-        </c:ser>
-        <c:dLbls>
-          <c:numFmt formatCode="#,##0" sourceLinked="0"/>
-          <c:txPr>
-            <a:bodyPr/>
-            <a:lstStyle/>
-            <a:p>
-              <a:pPr>
-                <a:defRPr b="0" i="0" strike="noStrike" sz="1200" u="none">
-                  <a:solidFill>
-                    <a:srgbClr val="000000"/>
-                  </a:solidFill>
-                  <a:latin typeface="Arial"/>
-                </a:defRPr>
-              </a:pPr>
-            </a:p>
-          </c:txPr>
-          <c:showLegendKey val="0"/>
-          <c:showVal val="0"/>
-          <c:showCatName val="0"/>
-          <c:showSerName val="0"/>
-          <c:showPercent val="0"/>
-          <c:showBubbleSize val="0"/>
-          <c:showLeaderLines val="0"/>
-        </c:dLbls>
-        <c:gapWidth val="45"/>
-        <c:overlap val="100"/>
-        <c:axId val="2094734554"/>
-        <c:axId val="2094734552"/>
-        <c:axId val="2094734556"/>
-      </c:barChart>
-      <c:catAx>
-        <c:axId val="2094734554"/>
-        <c:scaling>
-          <c:orientation val="minMax"/>
-        </c:scaling>
-        <c:delete val="0"/>
-        <c:axPos val="l"/>
-        <c:numFmt formatCode="General" sourceLinked="1"/>
-        <c:majorTickMark val="out"/>
-        <c:minorTickMark val="none"/>
-        <c:tickLblPos val="nextTo"/>
-        <c:spPr>
-          <a:ln w="12700" cap="flat">
-            <a:solidFill>
-              <a:srgbClr val="9AA3AE"/>
-            </a:solidFill>
-            <a:prstDash val="solid"/>
-            <a:round/>
-          </a:ln>
-        </c:spPr>
-        <c:txPr>
-          <a:bodyPr/>
-          <a:lstStyle/>
-          <a:p>
-            <a:pPr>
-              <a:defRPr sz="1100" b="0" i="0" u="none" strike="noStrike">
-                <a:solidFill>
-                  <a:srgbClr val="1A1A1A"/>
-                </a:solidFill>
-                <a:latin typeface="Arial"/>
-              </a:defRPr>
-            </a:pPr>
-            <a:endParaRPr lang="en-US"/>
-          </a:p>
-        </c:txPr>
-        <c:crossAx val="2094734552"/>
-        <c:crosses val="autoZero"/>
-        <c:auto val="1"/>
-        <c:lblAlgn val="ctr"/>
-        <c:noMultiLvlLbl val="1"/>
-      </c:catAx>
-      <c:valAx>
-        <c:axId val="2094734552"/>
-        <c:scaling>
-          <c:orientation val="minMax"/>
-          <c:max val="700"/>
-          <c:min val="0"/>
-        </c:scaling>
-        <c:delete val="0"/>
-        <c:axPos val="b"/>
-        <c:majorGridlines>
-          <c:spPr>
-            <a:ln w="9525" cap="flat">
-              <a:solidFill>
-                <a:srgbClr val="E5E7EB"/>
-              </a:solidFill>
-              <a:prstDash val="solid"/>
-              <a:round/>
-            </a:ln>
-          </c:spPr>
-        </c:majorGridlines>
-        <c:numFmt formatCode="General" sourceLinked="0"/>
-        <c:majorTickMark val="out"/>
-        <c:minorTickMark val="none"/>
-        <c:tickLblPos val="low"/>
-        <c:spPr>
-          <a:ln w="12700" cap="flat">
-            <a:noFill/>
-            <a:prstDash val="solid"/>
-            <a:round/>
-          </a:ln>
-        </c:spPr>
-        <c:txPr>
-          <a:bodyPr/>
-          <a:lstStyle/>
-          <a:p>
-            <a:pPr>
-              <a:defRPr sz="1000" b="0" i="0" u="none" strike="noStrike">
-                <a:solidFill>
-                  <a:srgbClr val="6B7280"/>
-                </a:solidFill>
-                <a:latin typeface="Arial"/>
-              </a:defRPr>
-            </a:pPr>
-            <a:endParaRPr lang="en-US"/>
-          </a:p>
-        </c:txPr>
-        <c:crossAx val="2094734554"/>
-        <c:crosses val="autoZero"/>
-        <c:crossBetween val="between"/>
-        <c:majorUnit val="100"/>
-      </c:valAx>
-      <c:spPr>
-        <a:noFill/>
-        <a:ln>
-          <a:noFill/>
-        </a:ln>
-        <a:effectLst/>
-      </c:spPr>
-    </c:plotArea>
-    <c:legend>
-      <c:legendPos val="b"/>
-      <c:overlay val="0"/>
-      <c:txPr>
-        <a:bodyPr/>
-        <a:lstStyle/>
-        <a:p>
-          <a:pPr>
-            <a:defRPr sz="1050">
-              <a:solidFill>
-                <a:srgbClr val="1A1A1A"/>
-              </a:solidFill>
-            </a:defRPr>
-          </a:pPr>
-          <a:endParaRPr lang="en-US"/>
-        </a:p>
-      </c:txPr>
-    </c:legend>
-    <c:plotVisOnly val="1"/>
-    <c:dispBlanksAs val="span"/>
-  </c:chart>
-  <c:spPr>
-    <a:noFill/>
-    <a:ln>
-      <a:noFill/>
-    </a:ln>
-    <a:effectLst/>
-  </c:spPr>
-  <c:externalData r:id="rId1">
-    <c:autoUpdate val="0"/>
-  </c:externalData>
-</c:chartSpace>
-</file>
-
-<file path=ppt/charts/chart4.xml><?xml version="1.0" encoding="utf-8"?>
-<c:chartSpace xmlns:c="http://schemas.openxmlformats.org/drawingml/2006/chart" xmlns:a="http://schemas.openxmlformats.org/drawingml/2006/main" xmlns:r="http://schemas.openxmlformats.org/officeDocument/2006/relationships">
-  <c:date1904 val="0"/>
-  <c:roundedCorners val="1"/>
-  <c:chart>
-    <c:title>
-      <c:tx>
-        <c:rich>
-          <a:bodyPr/>
-          <a:lstStyle/>
-          <a:p>
-            <a:pPr>
-              <a:defRPr sz="1300" b="1" i="0" u="none" strike="noStrike">
-                <a:solidFill>
                   <a:srgbClr val="1A1A1A"/>
                 </a:solidFill>
                 <a:latin typeface="+mn-lt"/>
@@ -2574,7 +1701,7 @@
 </c:chartSpace>
 </file>
 
-<file path=ppt/charts/chart5.xml><?xml version="1.0" encoding="utf-8"?>
+<file path=ppt/charts/chart3.xml><?xml version="1.0" encoding="utf-8"?>
 <c:chartSpace xmlns:c="http://schemas.openxmlformats.org/drawingml/2006/chart" xmlns:a="http://schemas.openxmlformats.org/drawingml/2006/main" xmlns:r="http://schemas.openxmlformats.org/officeDocument/2006/relationships">
   <c:date1904 val="0"/>
   <c:roundedCorners val="1"/>
@@ -2928,7 +2055,7 @@
 </c:chartSpace>
 </file>
 
-<file path=ppt/charts/chart6.xml><?xml version="1.0" encoding="utf-8"?>
+<file path=ppt/charts/chart4.xml><?xml version="1.0" encoding="utf-8"?>
 <c:chartSpace xmlns:c="http://schemas.openxmlformats.org/drawingml/2006/chart" xmlns:a="http://schemas.openxmlformats.org/drawingml/2006/main" xmlns:r="http://schemas.openxmlformats.org/officeDocument/2006/relationships">
   <c:date1904 val="0"/>
   <c:roundedCorners val="1"/>
@@ -3438,7 +2565,7 @@
 </c:chartSpace>
 </file>
 
-<file path=ppt/charts/chart7.xml><?xml version="1.0" encoding="utf-8"?>
+<file path=ppt/charts/chart5.xml><?xml version="1.0" encoding="utf-8"?>
 <c:chartSpace xmlns:c="http://schemas.openxmlformats.org/drawingml/2006/chart" xmlns:a="http://schemas.openxmlformats.org/drawingml/2006/main" xmlns:r="http://schemas.openxmlformats.org/officeDocument/2006/relationships">
   <c:date1904 val="0"/>
   <c:roundedCorners val="1"/>
@@ -3809,7 +2936,7 @@
 </c:chartSpace>
 </file>
 
-<file path=ppt/charts/chart8.xml><?xml version="1.0" encoding="utf-8"?>
+<file path=ppt/charts/chart6.xml><?xml version="1.0" encoding="utf-8"?>
 <c:chartSpace xmlns:c="http://schemas.openxmlformats.org/drawingml/2006/chart" xmlns:a="http://schemas.openxmlformats.org/drawingml/2006/main" xmlns:r="http://schemas.openxmlformats.org/officeDocument/2006/relationships">
   <c:date1904 val="0"/>
   <c:roundedCorners val="1"/>
@@ -6017,7 +5144,8 @@
               <a:t>Part 1 (Niloufar), about one minute.
 The final dataset has 742 rows. Each row is one muscle outcome: one muscle, in one group, at one scan day. One campaign can therefore give many rows, for several muscles, time points or groups.
 The top strip is a real row. For each outcome we extracted the length of unloading, the day of the scan, the muscle, the participants (group size, share of women, age), whether the group had a countermeasure, the imaging method, and how muscle size was measured. Our prediction target is the percentage change in muscle size from baseline, here minus 9.4 percent.
-Bottom left: the rows cover 51 muscles or muscle groups; the front thigh and the calf are measured most often. Bottom right: most rows are MRI volumes. CT gives cross-sectional area, DXA gives lean mass of the leg, and ultrasound gives thickness or area.</a:t>
+Left table: 742 rows from 52 studies and 36 independent campaigns, covering 51 muscles or muscle groups; 470 rows are control groups and 272 countermeasure groups; 478 were measured during bed rest and 264 in recovery. 742 rows does not mean 742 people: one campaign gives rows for several muscles, groups and scan days.
+Right table: most rows are MRI volumes. CT gives cross-sectional area, DXA gives lean mass of the leg, and ultrasound gives thickness or area.</a:t>
             </a:r>
             <a:endParaRPr lang="en-US" dirty="0"/>
           </a:p>
@@ -21078,35 +20206,2003 @@
           </a:p>
         </p:txBody>
       </p:sp>
+      <p:sp>
+        <p:nvSpPr>
+          <p:cNvPr id="38" name="Text 36"/>
+          <p:cNvSpPr txBox="1"/>
+          <p:nvPr/>
+        </p:nvSpPr>
+        <p:spPr>
+          <a:xfrm>
+            <a:off x="548640" y="2697480"/>
+            <a:ext cx="5394960" cy="292608"/>
+          </a:xfrm>
+          <a:prstGeom prst="rect">
+            <a:avLst/>
+          </a:prstGeom>
+          <a:noFill/>
+          <a:ln/>
+        </p:spPr>
+        <p:txBody>
+          <a:bodyPr wrap="square" lIns="0" tIns="0" rIns="0" bIns="0" rtlCol="0" anchor="t"/>
+          <a:lstStyle/>
+          <a:p>
+            <a:pPr indent="0" marL="0">
+              <a:buNone/>
+            </a:pPr>
+            <a:r>
+              <a:rPr lang="en-US" sz="1500" b="1" dirty="0">
+                <a:solidFill>
+                  <a:schemeClr val="tx2"/>
+                </a:solidFill>
+              </a:rPr>
+              <a:t>Final dataset at a glance</a:t>
+            </a:r>
+            <a:endParaRPr lang="en-US" sz="1500" dirty="0"/>
+          </a:p>
+        </p:txBody>
+      </p:sp>
       <p:graphicFrame>
         <p:nvGraphicFramePr>
-          <p:cNvPr id="38" name="Chart 0" descr=""/>
-          <p:cNvGraphicFramePr/>
-          <p:nvPr/>
+          <p:cNvPr id="8" name="Table 0"/>
+          <p:cNvGraphicFramePr>
+            <a:graphicFrameLocks noGrp="1"/>
+          </p:cNvGraphicFramePr>
+          <p:nvPr>
+            <p:extLst>
+              <p:ext uri="{D42A27DB-BD31-4B8C-83A1-F6EECF244321}">
+                <p14:modId xmlns:p14="http://schemas.microsoft.com/office/powerpoint/2010/main" val="1579011935"/>
+              </p:ext>
+            </p:extLst>
+          </p:nvPr>
         </p:nvGraphicFramePr>
         <p:xfrm>
-          <a:off x="548640" y="2697480"/>
-          <a:ext cx="5669280" cy="3474720"/>
+          <a:off x="548640" y="3063240"/>
+          <a:ext cx="5394960" cy="914400"/>
         </p:xfrm>
-        <a:graphic xmlns:a="http://schemas.openxmlformats.org/drawingml/2006/main">
-          <a:graphicData uri="http://schemas.openxmlformats.org/drawingml/2006/chart">
-            <c:chart xmlns:c="http://schemas.openxmlformats.org/drawingml/2006/chart" r:id="rId1"/>
+        <a:graphic>
+          <a:graphicData uri="http://schemas.openxmlformats.org/drawingml/2006/table">
+            <a:tbl>
+              <a:tblPr/>
+              <a:tblGrid>
+                <a:gridCol w="3749040"/>
+                <a:gridCol w="1645920"/>
+              </a:tblGrid>
+              <a:tr h="365760">
+                <a:tc>
+                  <a:txBody>
+                    <a:bodyPr/>
+                    <a:lstStyle/>
+                    <a:p>
+                      <a:pPr algn="l" indent="0" marL="0">
+                        <a:buNone/>
+                      </a:pPr>
+                      <a:r>
+                        <a:rPr lang="en-US" sz="1300" b="1" dirty="0">
+                          <a:solidFill>
+                            <a:srgbClr val="FFFFFF"/>
+                          </a:solidFill>
+                          <a:latin typeface="Calibri" pitchFamily="34" charset="0"/>
+                          <a:ea typeface="Calibri" pitchFamily="34" charset="-122"/>
+                          <a:cs typeface="Calibri" pitchFamily="34" charset="-120"/>
+                        </a:rPr>
+                        <a:t>Feature</a:t>
+                      </a:r>
+                      <a:endParaRPr lang="en-US" sz="1300" dirty="0">
+                        <a:latin typeface="Calibri" charset="0"/>
+                        <a:ea typeface="Calibri" charset="0"/>
+                        <a:cs typeface="Calibri" charset="0"/>
+                      </a:endParaRPr>
+                    </a:p>
+                  </a:txBody>
+                  <a:tcPr marL="91440" marR="91440" marT="27432" marB="27432" anchor="ctr">
+                    <a:lnL w="0" cap="flat" cmpd="sng" algn="ctr">
+                      <a:noFill/>
+                    </a:lnL>
+                    <a:lnR w="0" cap="flat" cmpd="sng" algn="ctr">
+                      <a:noFill/>
+                    </a:lnR>
+                    <a:lnT w="0" cap="flat" cmpd="sng" algn="ctr">
+                      <a:noFill/>
+                    </a:lnT>
+                    <a:lnB w="9525" cap="flat" cmpd="sng" algn="ctr">
+                      <a:solidFill>
+                        <a:srgbClr val="E5E7EB"/>
+                      </a:solidFill>
+                      <a:prstDash val="solid"/>
+                      <a:round/>
+                      <a:headEnd type="none" w="med" len="med"/>
+                      <a:tailEnd type="none" w="med" len="med"/>
+                    </a:lnB>
+                    <a:solidFill>
+                      <a:srgbClr val="1F3A5F"/>
+                    </a:solidFill>
+                  </a:tcPr>
+                </a:tc>
+                <a:tc>
+                  <a:txBody>
+                    <a:bodyPr/>
+                    <a:lstStyle/>
+                    <a:p>
+                      <a:pPr algn="r" indent="0" marL="0">
+                        <a:buNone/>
+                      </a:pPr>
+                      <a:r>
+                        <a:rPr lang="en-US" sz="1300" b="1" dirty="0">
+                          <a:solidFill>
+                            <a:srgbClr val="FFFFFF"/>
+                          </a:solidFill>
+                          <a:latin typeface="Calibri" pitchFamily="34" charset="0"/>
+                          <a:ea typeface="Calibri" pitchFamily="34" charset="-122"/>
+                          <a:cs typeface="Calibri" pitchFamily="34" charset="-120"/>
+                        </a:rPr>
+                        <a:t>n</a:t>
+                      </a:r>
+                      <a:endParaRPr lang="en-US" sz="1300" dirty="0">
+                        <a:latin typeface="Calibri" charset="0"/>
+                        <a:ea typeface="Calibri" charset="0"/>
+                        <a:cs typeface="Calibri" charset="0"/>
+                      </a:endParaRPr>
+                    </a:p>
+                  </a:txBody>
+                  <a:tcPr marL="91440" marR="91440" marT="27432" marB="27432" anchor="ctr">
+                    <a:lnL w="0" cap="flat" cmpd="sng" algn="ctr">
+                      <a:noFill/>
+                    </a:lnL>
+                    <a:lnR w="0" cap="flat" cmpd="sng" algn="ctr">
+                      <a:noFill/>
+                    </a:lnR>
+                    <a:lnT w="0" cap="flat" cmpd="sng" algn="ctr">
+                      <a:noFill/>
+                    </a:lnT>
+                    <a:lnB w="9525" cap="flat" cmpd="sng" algn="ctr">
+                      <a:solidFill>
+                        <a:srgbClr val="E5E7EB"/>
+                      </a:solidFill>
+                      <a:prstDash val="solid"/>
+                      <a:round/>
+                      <a:headEnd type="none" w="med" len="med"/>
+                      <a:tailEnd type="none" w="med" len="med"/>
+                    </a:lnB>
+                    <a:solidFill>
+                      <a:srgbClr val="1F3A5F"/>
+                    </a:solidFill>
+                  </a:tcPr>
+                </a:tc>
+              </a:tr>
+              <a:tr h="365760">
+                <a:tc>
+                  <a:txBody>
+                    <a:bodyPr/>
+                    <a:lstStyle/>
+                    <a:p>
+                      <a:pPr algn="l" indent="0" marL="0">
+                        <a:buNone/>
+                      </a:pPr>
+                      <a:r>
+                        <a:rPr lang="en-US" sz="1300" dirty="0">
+                          <a:solidFill>
+                            <a:srgbClr val="1A1A1A"/>
+                          </a:solidFill>
+                          <a:latin typeface="Calibri" pitchFamily="34" charset="0"/>
+                          <a:ea typeface="Calibri" pitchFamily="34" charset="-122"/>
+                          <a:cs typeface="Calibri" pitchFamily="34" charset="-120"/>
+                        </a:rPr>
+                        <a:t>Observations (rows)</a:t>
+                      </a:r>
+                      <a:endParaRPr lang="en-US" sz="1300" dirty="0">
+                        <a:latin typeface="Calibri" charset="0"/>
+                        <a:ea typeface="Calibri" charset="0"/>
+                        <a:cs typeface="Calibri" charset="0"/>
+                      </a:endParaRPr>
+                    </a:p>
+                  </a:txBody>
+                  <a:tcPr marL="91440" marR="91440" marT="27432" marB="27432" anchor="ctr">
+                    <a:lnL w="0" cap="flat" cmpd="sng" algn="ctr">
+                      <a:noFill/>
+                    </a:lnL>
+                    <a:lnR w="0" cap="flat" cmpd="sng" algn="ctr">
+                      <a:noFill/>
+                    </a:lnR>
+                    <a:lnT w="0" cap="flat" cmpd="sng" algn="ctr">
+                      <a:noFill/>
+                    </a:lnT>
+                    <a:lnB w="9525" cap="flat" cmpd="sng" algn="ctr">
+                      <a:solidFill>
+                        <a:srgbClr val="E5E7EB"/>
+                      </a:solidFill>
+                      <a:prstDash val="solid"/>
+                      <a:round/>
+                      <a:headEnd type="none" w="med" len="med"/>
+                      <a:tailEnd type="none" w="med" len="med"/>
+                    </a:lnB>
+                  </a:tcPr>
+                </a:tc>
+                <a:tc>
+                  <a:txBody>
+                    <a:bodyPr/>
+                    <a:lstStyle/>
+                    <a:p>
+                      <a:pPr algn="r" indent="0" marL="0">
+                        <a:buNone/>
+                      </a:pPr>
+                      <a:r>
+                        <a:rPr lang="en-US" sz="1300" b="1" dirty="0">
+                          <a:solidFill>
+                            <a:srgbClr val="1A1A1A"/>
+                          </a:solidFill>
+                          <a:latin typeface="Calibri" pitchFamily="34" charset="0"/>
+                          <a:ea typeface="Calibri" pitchFamily="34" charset="-122"/>
+                          <a:cs typeface="Calibri" pitchFamily="34" charset="-120"/>
+                        </a:rPr>
+                        <a:t>742</a:t>
+                      </a:r>
+                      <a:endParaRPr lang="en-US" sz="1300" dirty="0">
+                        <a:latin typeface="Calibri" charset="0"/>
+                        <a:ea typeface="Calibri" charset="0"/>
+                        <a:cs typeface="Calibri" charset="0"/>
+                      </a:endParaRPr>
+                    </a:p>
+                  </a:txBody>
+                  <a:tcPr marL="91440" marR="91440" marT="27432" marB="27432" anchor="ctr">
+                    <a:lnL w="0" cap="flat" cmpd="sng" algn="ctr">
+                      <a:noFill/>
+                    </a:lnL>
+                    <a:lnR w="0" cap="flat" cmpd="sng" algn="ctr">
+                      <a:noFill/>
+                    </a:lnR>
+                    <a:lnT w="0" cap="flat" cmpd="sng" algn="ctr">
+                      <a:noFill/>
+                    </a:lnT>
+                    <a:lnB w="9525" cap="flat" cmpd="sng" algn="ctr">
+                      <a:solidFill>
+                        <a:srgbClr val="E5E7EB"/>
+                      </a:solidFill>
+                      <a:prstDash val="solid"/>
+                      <a:round/>
+                      <a:headEnd type="none" w="med" len="med"/>
+                      <a:tailEnd type="none" w="med" len="med"/>
+                    </a:lnB>
+                  </a:tcPr>
+                </a:tc>
+              </a:tr>
+              <a:tr h="365760">
+                <a:tc>
+                  <a:txBody>
+                    <a:bodyPr/>
+                    <a:lstStyle/>
+                    <a:p>
+                      <a:pPr algn="l" indent="0" marL="0">
+                        <a:buNone/>
+                      </a:pPr>
+                      <a:r>
+                        <a:rPr lang="en-US" sz="1300" dirty="0">
+                          <a:solidFill>
+                            <a:srgbClr val="1A1A1A"/>
+                          </a:solidFill>
+                          <a:latin typeface="Calibri" pitchFamily="34" charset="0"/>
+                          <a:ea typeface="Calibri" pitchFamily="34" charset="-122"/>
+                          <a:cs typeface="Calibri" pitchFamily="34" charset="-120"/>
+                        </a:rPr>
+                        <a:t>Studies</a:t>
+                      </a:r>
+                      <a:endParaRPr lang="en-US" sz="1300" dirty="0">
+                        <a:latin typeface="Calibri" charset="0"/>
+                        <a:ea typeface="Calibri" charset="0"/>
+                        <a:cs typeface="Calibri" charset="0"/>
+                      </a:endParaRPr>
+                    </a:p>
+                  </a:txBody>
+                  <a:tcPr marL="91440" marR="91440" marT="27432" marB="27432" anchor="ctr">
+                    <a:lnL w="0" cap="flat" cmpd="sng" algn="ctr">
+                      <a:noFill/>
+                    </a:lnL>
+                    <a:lnR w="0" cap="flat" cmpd="sng" algn="ctr">
+                      <a:noFill/>
+                    </a:lnR>
+                    <a:lnT w="0" cap="flat" cmpd="sng" algn="ctr">
+                      <a:noFill/>
+                    </a:lnT>
+                    <a:lnB w="9525" cap="flat" cmpd="sng" algn="ctr">
+                      <a:solidFill>
+                        <a:srgbClr val="E5E7EB"/>
+                      </a:solidFill>
+                      <a:prstDash val="solid"/>
+                      <a:round/>
+                      <a:headEnd type="none" w="med" len="med"/>
+                      <a:tailEnd type="none" w="med" len="med"/>
+                    </a:lnB>
+                  </a:tcPr>
+                </a:tc>
+                <a:tc>
+                  <a:txBody>
+                    <a:bodyPr/>
+                    <a:lstStyle/>
+                    <a:p>
+                      <a:pPr algn="r" indent="0" marL="0">
+                        <a:buNone/>
+                      </a:pPr>
+                      <a:r>
+                        <a:rPr lang="en-US" sz="1300" b="1" dirty="0">
+                          <a:solidFill>
+                            <a:srgbClr val="1A1A1A"/>
+                          </a:solidFill>
+                          <a:latin typeface="Calibri" pitchFamily="34" charset="0"/>
+                          <a:ea typeface="Calibri" pitchFamily="34" charset="-122"/>
+                          <a:cs typeface="Calibri" pitchFamily="34" charset="-120"/>
+                        </a:rPr>
+                        <a:t>52</a:t>
+                      </a:r>
+                      <a:endParaRPr lang="en-US" sz="1300" dirty="0">
+                        <a:latin typeface="Calibri" charset="0"/>
+                        <a:ea typeface="Calibri" charset="0"/>
+                        <a:cs typeface="Calibri" charset="0"/>
+                      </a:endParaRPr>
+                    </a:p>
+                  </a:txBody>
+                  <a:tcPr marL="91440" marR="91440" marT="27432" marB="27432" anchor="ctr">
+                    <a:lnL w="0" cap="flat" cmpd="sng" algn="ctr">
+                      <a:noFill/>
+                    </a:lnL>
+                    <a:lnR w="0" cap="flat" cmpd="sng" algn="ctr">
+                      <a:noFill/>
+                    </a:lnR>
+                    <a:lnT w="0" cap="flat" cmpd="sng" algn="ctr">
+                      <a:noFill/>
+                    </a:lnT>
+                    <a:lnB w="9525" cap="flat" cmpd="sng" algn="ctr">
+                      <a:solidFill>
+                        <a:srgbClr val="E5E7EB"/>
+                      </a:solidFill>
+                      <a:prstDash val="solid"/>
+                      <a:round/>
+                      <a:headEnd type="none" w="med" len="med"/>
+                      <a:tailEnd type="none" w="med" len="med"/>
+                    </a:lnB>
+                  </a:tcPr>
+                </a:tc>
+              </a:tr>
+              <a:tr h="365760">
+                <a:tc>
+                  <a:txBody>
+                    <a:bodyPr/>
+                    <a:lstStyle/>
+                    <a:p>
+                      <a:pPr algn="l" indent="0" marL="0">
+                        <a:buNone/>
+                      </a:pPr>
+                      <a:r>
+                        <a:rPr lang="en-US" sz="1300" dirty="0">
+                          <a:solidFill>
+                            <a:srgbClr val="1A1A1A"/>
+                          </a:solidFill>
+                          <a:latin typeface="Calibri" pitchFamily="34" charset="0"/>
+                          <a:ea typeface="Calibri" pitchFamily="34" charset="-122"/>
+                          <a:cs typeface="Calibri" pitchFamily="34" charset="-120"/>
+                        </a:rPr>
+                        <a:t>Independent campaigns</a:t>
+                      </a:r>
+                      <a:endParaRPr lang="en-US" sz="1300" dirty="0">
+                        <a:latin typeface="Calibri" charset="0"/>
+                        <a:ea typeface="Calibri" charset="0"/>
+                        <a:cs typeface="Calibri" charset="0"/>
+                      </a:endParaRPr>
+                    </a:p>
+                  </a:txBody>
+                  <a:tcPr marL="91440" marR="91440" marT="27432" marB="27432" anchor="ctr">
+                    <a:lnL w="0" cap="flat" cmpd="sng" algn="ctr">
+                      <a:noFill/>
+                    </a:lnL>
+                    <a:lnR w="0" cap="flat" cmpd="sng" algn="ctr">
+                      <a:noFill/>
+                    </a:lnR>
+                    <a:lnT w="0" cap="flat" cmpd="sng" algn="ctr">
+                      <a:noFill/>
+                    </a:lnT>
+                    <a:lnB w="9525" cap="flat" cmpd="sng" algn="ctr">
+                      <a:solidFill>
+                        <a:srgbClr val="E5E7EB"/>
+                      </a:solidFill>
+                      <a:prstDash val="solid"/>
+                      <a:round/>
+                      <a:headEnd type="none" w="med" len="med"/>
+                      <a:tailEnd type="none" w="med" len="med"/>
+                    </a:lnB>
+                  </a:tcPr>
+                </a:tc>
+                <a:tc>
+                  <a:txBody>
+                    <a:bodyPr/>
+                    <a:lstStyle/>
+                    <a:p>
+                      <a:pPr algn="r" indent="0" marL="0">
+                        <a:buNone/>
+                      </a:pPr>
+                      <a:r>
+                        <a:rPr lang="en-US" sz="1300" b="1" dirty="0">
+                          <a:solidFill>
+                            <a:srgbClr val="1A1A1A"/>
+                          </a:solidFill>
+                          <a:latin typeface="Calibri" pitchFamily="34" charset="0"/>
+                          <a:ea typeface="Calibri" pitchFamily="34" charset="-122"/>
+                          <a:cs typeface="Calibri" pitchFamily="34" charset="-120"/>
+                        </a:rPr>
+                        <a:t>36</a:t>
+                      </a:r>
+                      <a:endParaRPr lang="en-US" sz="1300" dirty="0">
+                        <a:latin typeface="Calibri" charset="0"/>
+                        <a:ea typeface="Calibri" charset="0"/>
+                        <a:cs typeface="Calibri" charset="0"/>
+                      </a:endParaRPr>
+                    </a:p>
+                  </a:txBody>
+                  <a:tcPr marL="91440" marR="91440" marT="27432" marB="27432" anchor="ctr">
+                    <a:lnL w="0" cap="flat" cmpd="sng" algn="ctr">
+                      <a:noFill/>
+                    </a:lnL>
+                    <a:lnR w="0" cap="flat" cmpd="sng" algn="ctr">
+                      <a:noFill/>
+                    </a:lnR>
+                    <a:lnT w="0" cap="flat" cmpd="sng" algn="ctr">
+                      <a:noFill/>
+                    </a:lnT>
+                    <a:lnB w="9525" cap="flat" cmpd="sng" algn="ctr">
+                      <a:solidFill>
+                        <a:srgbClr val="E5E7EB"/>
+                      </a:solidFill>
+                      <a:prstDash val="solid"/>
+                      <a:round/>
+                      <a:headEnd type="none" w="med" len="med"/>
+                      <a:tailEnd type="none" w="med" len="med"/>
+                    </a:lnB>
+                  </a:tcPr>
+                </a:tc>
+              </a:tr>
+              <a:tr h="365760">
+                <a:tc>
+                  <a:txBody>
+                    <a:bodyPr/>
+                    <a:lstStyle/>
+                    <a:p>
+                      <a:pPr algn="l" indent="0" marL="0">
+                        <a:buNone/>
+                      </a:pPr>
+                      <a:r>
+                        <a:rPr lang="en-US" sz="1300" dirty="0">
+                          <a:solidFill>
+                            <a:srgbClr val="1A1A1A"/>
+                          </a:solidFill>
+                          <a:latin typeface="Calibri" pitchFamily="34" charset="0"/>
+                          <a:ea typeface="Calibri" pitchFamily="34" charset="-122"/>
+                          <a:cs typeface="Calibri" pitchFamily="34" charset="-120"/>
+                        </a:rPr>
+                        <a:t>Muscles or muscle groups</a:t>
+                      </a:r>
+                      <a:endParaRPr lang="en-US" sz="1300" dirty="0">
+                        <a:latin typeface="Calibri" charset="0"/>
+                        <a:ea typeface="Calibri" charset="0"/>
+                        <a:cs typeface="Calibri" charset="0"/>
+                      </a:endParaRPr>
+                    </a:p>
+                  </a:txBody>
+                  <a:tcPr marL="91440" marR="91440" marT="27432" marB="27432" anchor="ctr">
+                    <a:lnL w="0" cap="flat" cmpd="sng" algn="ctr">
+                      <a:noFill/>
+                    </a:lnL>
+                    <a:lnR w="0" cap="flat" cmpd="sng" algn="ctr">
+                      <a:noFill/>
+                    </a:lnR>
+                    <a:lnT w="0" cap="flat" cmpd="sng" algn="ctr">
+                      <a:noFill/>
+                    </a:lnT>
+                    <a:lnB w="9525" cap="flat" cmpd="sng" algn="ctr">
+                      <a:solidFill>
+                        <a:srgbClr val="E5E7EB"/>
+                      </a:solidFill>
+                      <a:prstDash val="solid"/>
+                      <a:round/>
+                      <a:headEnd type="none" w="med" len="med"/>
+                      <a:tailEnd type="none" w="med" len="med"/>
+                    </a:lnB>
+                  </a:tcPr>
+                </a:tc>
+                <a:tc>
+                  <a:txBody>
+                    <a:bodyPr/>
+                    <a:lstStyle/>
+                    <a:p>
+                      <a:pPr algn="r" indent="0" marL="0">
+                        <a:buNone/>
+                      </a:pPr>
+                      <a:r>
+                        <a:rPr lang="en-US" sz="1300" b="1" dirty="0">
+                          <a:solidFill>
+                            <a:srgbClr val="1A1A1A"/>
+                          </a:solidFill>
+                          <a:latin typeface="Calibri" pitchFamily="34" charset="0"/>
+                          <a:ea typeface="Calibri" pitchFamily="34" charset="-122"/>
+                          <a:cs typeface="Calibri" pitchFamily="34" charset="-120"/>
+                        </a:rPr>
+                        <a:t>51</a:t>
+                      </a:r>
+                      <a:endParaRPr lang="en-US" sz="1300" dirty="0">
+                        <a:latin typeface="Calibri" charset="0"/>
+                        <a:ea typeface="Calibri" charset="0"/>
+                        <a:cs typeface="Calibri" charset="0"/>
+                      </a:endParaRPr>
+                    </a:p>
+                  </a:txBody>
+                  <a:tcPr marL="91440" marR="91440" marT="27432" marB="27432" anchor="ctr">
+                    <a:lnL w="0" cap="flat" cmpd="sng" algn="ctr">
+                      <a:noFill/>
+                    </a:lnL>
+                    <a:lnR w="0" cap="flat" cmpd="sng" algn="ctr">
+                      <a:noFill/>
+                    </a:lnR>
+                    <a:lnT w="0" cap="flat" cmpd="sng" algn="ctr">
+                      <a:noFill/>
+                    </a:lnT>
+                    <a:lnB w="9525" cap="flat" cmpd="sng" algn="ctr">
+                      <a:solidFill>
+                        <a:srgbClr val="E5E7EB"/>
+                      </a:solidFill>
+                      <a:prstDash val="solid"/>
+                      <a:round/>
+                      <a:headEnd type="none" w="med" len="med"/>
+                      <a:tailEnd type="none" w="med" len="med"/>
+                    </a:lnB>
+                  </a:tcPr>
+                </a:tc>
+              </a:tr>
+              <a:tr h="365760">
+                <a:tc>
+                  <a:txBody>
+                    <a:bodyPr/>
+                    <a:lstStyle/>
+                    <a:p>
+                      <a:pPr algn="l" indent="0" marL="0">
+                        <a:buNone/>
+                      </a:pPr>
+                      <a:r>
+                        <a:rPr lang="en-US" sz="1300" dirty="0">
+                          <a:solidFill>
+                            <a:srgbClr val="1A1A1A"/>
+                          </a:solidFill>
+                          <a:latin typeface="Calibri" pitchFamily="34" charset="0"/>
+                          <a:ea typeface="Calibri" pitchFamily="34" charset="-122"/>
+                          <a:cs typeface="Calibri" pitchFamily="34" charset="-120"/>
+                        </a:rPr>
+                        <a:t>Rows: control / countermeasure</a:t>
+                      </a:r>
+                      <a:endParaRPr lang="en-US" sz="1300" dirty="0">
+                        <a:latin typeface="Calibri" charset="0"/>
+                        <a:ea typeface="Calibri" charset="0"/>
+                        <a:cs typeface="Calibri" charset="0"/>
+                      </a:endParaRPr>
+                    </a:p>
+                  </a:txBody>
+                  <a:tcPr marL="91440" marR="91440" marT="27432" marB="27432" anchor="ctr">
+                    <a:lnL w="0" cap="flat" cmpd="sng" algn="ctr">
+                      <a:noFill/>
+                    </a:lnL>
+                    <a:lnR w="0" cap="flat" cmpd="sng" algn="ctr">
+                      <a:noFill/>
+                    </a:lnR>
+                    <a:lnT w="0" cap="flat" cmpd="sng" algn="ctr">
+                      <a:noFill/>
+                    </a:lnT>
+                    <a:lnB w="9525" cap="flat" cmpd="sng" algn="ctr">
+                      <a:solidFill>
+                        <a:srgbClr val="E5E7EB"/>
+                      </a:solidFill>
+                      <a:prstDash val="solid"/>
+                      <a:round/>
+                      <a:headEnd type="none" w="med" len="med"/>
+                      <a:tailEnd type="none" w="med" len="med"/>
+                    </a:lnB>
+                  </a:tcPr>
+                </a:tc>
+                <a:tc>
+                  <a:txBody>
+                    <a:bodyPr/>
+                    <a:lstStyle/>
+                    <a:p>
+                      <a:pPr algn="r" indent="0" marL="0">
+                        <a:buNone/>
+                      </a:pPr>
+                      <a:r>
+                        <a:rPr lang="en-US" sz="1300" b="1" dirty="0">
+                          <a:solidFill>
+                            <a:srgbClr val="1A1A1A"/>
+                          </a:solidFill>
+                          <a:latin typeface="Calibri" pitchFamily="34" charset="0"/>
+                          <a:ea typeface="Calibri" pitchFamily="34" charset="-122"/>
+                          <a:cs typeface="Calibri" pitchFamily="34" charset="-120"/>
+                        </a:rPr>
+                        <a:t>470 / 272</a:t>
+                      </a:r>
+                      <a:endParaRPr lang="en-US" sz="1300" dirty="0">
+                        <a:latin typeface="Calibri" charset="0"/>
+                        <a:ea typeface="Calibri" charset="0"/>
+                        <a:cs typeface="Calibri" charset="0"/>
+                      </a:endParaRPr>
+                    </a:p>
+                  </a:txBody>
+                  <a:tcPr marL="91440" marR="91440" marT="27432" marB="27432" anchor="ctr">
+                    <a:lnL w="0" cap="flat" cmpd="sng" algn="ctr">
+                      <a:noFill/>
+                    </a:lnL>
+                    <a:lnR w="0" cap="flat" cmpd="sng" algn="ctr">
+                      <a:noFill/>
+                    </a:lnR>
+                    <a:lnT w="0" cap="flat" cmpd="sng" algn="ctr">
+                      <a:noFill/>
+                    </a:lnT>
+                    <a:lnB w="9525" cap="flat" cmpd="sng" algn="ctr">
+                      <a:solidFill>
+                        <a:srgbClr val="E5E7EB"/>
+                      </a:solidFill>
+                      <a:prstDash val="solid"/>
+                      <a:round/>
+                      <a:headEnd type="none" w="med" len="med"/>
+                      <a:tailEnd type="none" w="med" len="med"/>
+                    </a:lnB>
+                  </a:tcPr>
+                </a:tc>
+              </a:tr>
+              <a:tr h="365760">
+                <a:tc>
+                  <a:txBody>
+                    <a:bodyPr/>
+                    <a:lstStyle/>
+                    <a:p>
+                      <a:pPr algn="l" indent="0" marL="0">
+                        <a:buNone/>
+                      </a:pPr>
+                      <a:r>
+                        <a:rPr lang="en-US" sz="1300" dirty="0">
+                          <a:solidFill>
+                            <a:srgbClr val="1A1A1A"/>
+                          </a:solidFill>
+                          <a:latin typeface="Calibri" pitchFamily="34" charset="0"/>
+                          <a:ea typeface="Calibri" pitchFamily="34" charset="-122"/>
+                          <a:cs typeface="Calibri" pitchFamily="34" charset="-120"/>
+                        </a:rPr>
+                        <a:t>Rows: during bed rest / recovery</a:t>
+                      </a:r>
+                      <a:endParaRPr lang="en-US" sz="1300" dirty="0">
+                        <a:latin typeface="Calibri" charset="0"/>
+                        <a:ea typeface="Calibri" charset="0"/>
+                        <a:cs typeface="Calibri" charset="0"/>
+                      </a:endParaRPr>
+                    </a:p>
+                  </a:txBody>
+                  <a:tcPr marL="91440" marR="91440" marT="27432" marB="27432" anchor="ctr">
+                    <a:lnL w="0" cap="flat" cmpd="sng" algn="ctr">
+                      <a:noFill/>
+                    </a:lnL>
+                    <a:lnR w="0" cap="flat" cmpd="sng" algn="ctr">
+                      <a:noFill/>
+                    </a:lnR>
+                    <a:lnT w="0" cap="flat" cmpd="sng" algn="ctr">
+                      <a:noFill/>
+                    </a:lnT>
+                    <a:lnB w="9525" cap="flat" cmpd="sng" algn="ctr">
+                      <a:solidFill>
+                        <a:srgbClr val="E5E7EB"/>
+                      </a:solidFill>
+                      <a:prstDash val="solid"/>
+                      <a:round/>
+                      <a:headEnd type="none" w="med" len="med"/>
+                      <a:tailEnd type="none" w="med" len="med"/>
+                    </a:lnB>
+                  </a:tcPr>
+                </a:tc>
+                <a:tc>
+                  <a:txBody>
+                    <a:bodyPr/>
+                    <a:lstStyle/>
+                    <a:p>
+                      <a:pPr algn="r" indent="0" marL="0">
+                        <a:buNone/>
+                      </a:pPr>
+                      <a:r>
+                        <a:rPr lang="en-US" sz="1300" b="1" dirty="0">
+                          <a:solidFill>
+                            <a:srgbClr val="1A1A1A"/>
+                          </a:solidFill>
+                          <a:latin typeface="Calibri" pitchFamily="34" charset="0"/>
+                          <a:ea typeface="Calibri" pitchFamily="34" charset="-122"/>
+                          <a:cs typeface="Calibri" pitchFamily="34" charset="-120"/>
+                        </a:rPr>
+                        <a:t>478 / 264</a:t>
+                      </a:r>
+                      <a:endParaRPr lang="en-US" sz="1300" dirty="0">
+                        <a:latin typeface="Calibri" charset="0"/>
+                        <a:ea typeface="Calibri" charset="0"/>
+                        <a:cs typeface="Calibri" charset="0"/>
+                      </a:endParaRPr>
+                    </a:p>
+                  </a:txBody>
+                  <a:tcPr marL="91440" marR="91440" marT="27432" marB="27432" anchor="ctr">
+                    <a:lnL w="0" cap="flat" cmpd="sng" algn="ctr">
+                      <a:noFill/>
+                    </a:lnL>
+                    <a:lnR w="0" cap="flat" cmpd="sng" algn="ctr">
+                      <a:noFill/>
+                    </a:lnR>
+                    <a:lnT w="0" cap="flat" cmpd="sng" algn="ctr">
+                      <a:noFill/>
+                    </a:lnT>
+                    <a:lnB w="9525" cap="flat" cmpd="sng" algn="ctr">
+                      <a:solidFill>
+                        <a:srgbClr val="E5E7EB"/>
+                      </a:solidFill>
+                      <a:prstDash val="solid"/>
+                      <a:round/>
+                      <a:headEnd type="none" w="med" len="med"/>
+                      <a:tailEnd type="none" w="med" len="med"/>
+                    </a:lnB>
+                  </a:tcPr>
+                </a:tc>
+              </a:tr>
+            </a:tbl>
           </a:graphicData>
         </a:graphic>
       </p:graphicFrame>
+      <p:sp>
+        <p:nvSpPr>
+          <p:cNvPr id="40" name="Text 37"/>
+          <p:cNvSpPr txBox="1"/>
+          <p:nvPr/>
+        </p:nvSpPr>
+        <p:spPr>
+          <a:xfrm>
+            <a:off x="548640" y="5715000"/>
+            <a:ext cx="5394960" cy="411480"/>
+          </a:xfrm>
+          <a:prstGeom prst="rect">
+            <a:avLst/>
+          </a:prstGeom>
+          <a:noFill/>
+          <a:ln/>
+        </p:spPr>
+        <p:txBody>
+          <a:bodyPr wrap="square" lIns="0" tIns="0" rIns="0" bIns="0" rtlCol="0" anchor="t"/>
+          <a:lstStyle/>
+          <a:p>
+            <a:pPr indent="0" marL="0">
+              <a:buNone/>
+            </a:pPr>
+            <a:r>
+              <a:rPr lang="en-US" sz="1050" i="1" dirty="0">
+                <a:solidFill>
+                  <a:schemeClr val="accent3"/>
+                </a:solidFill>
+              </a:rPr>
+              <a:t>742 observations ≠ 742 independent participants: one campaign gives rows for several muscles, groups and scan days.</a:t>
+            </a:r>
+            <a:endParaRPr lang="en-US" sz="1050" dirty="0"/>
+          </a:p>
+        </p:txBody>
+      </p:sp>
+      <p:sp>
+        <p:nvSpPr>
+          <p:cNvPr id="41" name="Text 38"/>
+          <p:cNvSpPr txBox="1"/>
+          <p:nvPr/>
+        </p:nvSpPr>
+        <p:spPr>
+          <a:xfrm>
+            <a:off x="6400800" y="2697480"/>
+            <a:ext cx="5239512" cy="292608"/>
+          </a:xfrm>
+          <a:prstGeom prst="rect">
+            <a:avLst/>
+          </a:prstGeom>
+          <a:noFill/>
+          <a:ln/>
+        </p:spPr>
+        <p:txBody>
+          <a:bodyPr wrap="square" lIns="0" tIns="0" rIns="0" bIns="0" rtlCol="0" anchor="t"/>
+          <a:lstStyle/>
+          <a:p>
+            <a:pPr indent="0" marL="0">
+              <a:buNone/>
+            </a:pPr>
+            <a:r>
+              <a:rPr lang="en-US" sz="1500" b="1" dirty="0">
+                <a:solidFill>
+                  <a:schemeClr val="tx2"/>
+                </a:solidFill>
+              </a:rPr>
+              <a:t>Imaging method and size measure</a:t>
+            </a:r>
+            <a:endParaRPr lang="en-US" sz="1500" dirty="0"/>
+          </a:p>
+        </p:txBody>
+      </p:sp>
       <p:graphicFrame>
         <p:nvGraphicFramePr>
-          <p:cNvPr id="39" name="Chart 1" descr=""/>
-          <p:cNvGraphicFramePr/>
-          <p:nvPr/>
+          <p:cNvPr id="15" name="Table 1"/>
+          <p:cNvGraphicFramePr>
+            <a:graphicFrameLocks noGrp="1"/>
+          </p:cNvGraphicFramePr>
+          <p:nvPr>
+            <p:extLst>
+              <p:ext uri="{D42A27DB-BD31-4B8C-83A1-F6EECF244321}">
+                <p14:modId xmlns:p14="http://schemas.microsoft.com/office/powerpoint/2010/main" val="1579011935"/>
+              </p:ext>
+            </p:extLst>
+          </p:nvPr>
         </p:nvGraphicFramePr>
         <p:xfrm>
-          <a:off x="6400800" y="2697480"/>
-          <a:ext cx="5239512" cy="3474720"/>
+          <a:off x="6400800" y="3063240"/>
+          <a:ext cx="5239512" cy="914400"/>
         </p:xfrm>
-        <a:graphic xmlns:a="http://schemas.openxmlformats.org/drawingml/2006/main">
-          <a:graphicData uri="http://schemas.openxmlformats.org/drawingml/2006/chart">
-            <c:chart xmlns:c="http://schemas.openxmlformats.org/drawingml/2006/chart" r:id="rId2"/>
+        <a:graphic>
+          <a:graphicData uri="http://schemas.openxmlformats.org/drawingml/2006/table">
+            <a:tbl>
+              <a:tblPr/>
+              <a:tblGrid>
+                <a:gridCol w="1325880"/>
+                <a:gridCol w="777240"/>
+                <a:gridCol w="2267712"/>
+                <a:gridCol w="868680"/>
+              </a:tblGrid>
+              <a:tr h="365760">
+                <a:tc>
+                  <a:txBody>
+                    <a:bodyPr/>
+                    <a:lstStyle/>
+                    <a:p>
+                      <a:pPr algn="l" indent="0" marL="0">
+                        <a:buNone/>
+                      </a:pPr>
+                      <a:r>
+                        <a:rPr lang="en-US" sz="1300" b="1" dirty="0">
+                          <a:solidFill>
+                            <a:srgbClr val="FFFFFF"/>
+                          </a:solidFill>
+                          <a:latin typeface="Calibri" pitchFamily="34" charset="0"/>
+                          <a:ea typeface="Calibri" pitchFamily="34" charset="-122"/>
+                          <a:cs typeface="Calibri" pitchFamily="34" charset="-120"/>
+                        </a:rPr>
+                        <a:t>Method</a:t>
+                      </a:r>
+                      <a:endParaRPr lang="en-US" sz="1300" dirty="0">
+                        <a:latin typeface="Calibri" charset="0"/>
+                        <a:ea typeface="Calibri" charset="0"/>
+                        <a:cs typeface="Calibri" charset="0"/>
+                      </a:endParaRPr>
+                    </a:p>
+                  </a:txBody>
+                  <a:tcPr marL="91440" marR="91440" marT="27432" marB="27432" anchor="ctr">
+                    <a:lnL w="0" cap="flat" cmpd="sng" algn="ctr">
+                      <a:noFill/>
+                    </a:lnL>
+                    <a:lnR w="0" cap="flat" cmpd="sng" algn="ctr">
+                      <a:noFill/>
+                    </a:lnR>
+                    <a:lnT w="0" cap="flat" cmpd="sng" algn="ctr">
+                      <a:noFill/>
+                    </a:lnT>
+                    <a:lnB w="9525" cap="flat" cmpd="sng" algn="ctr">
+                      <a:solidFill>
+                        <a:srgbClr val="E5E7EB"/>
+                      </a:solidFill>
+                      <a:prstDash val="solid"/>
+                      <a:round/>
+                      <a:headEnd type="none" w="med" len="med"/>
+                      <a:tailEnd type="none" w="med" len="med"/>
+                    </a:lnB>
+                    <a:solidFill>
+                      <a:srgbClr val="1F3A5F"/>
+                    </a:solidFill>
+                  </a:tcPr>
+                </a:tc>
+                <a:tc>
+                  <a:txBody>
+                    <a:bodyPr/>
+                    <a:lstStyle/>
+                    <a:p>
+                      <a:pPr algn="r" indent="0" marL="0">
+                        <a:buNone/>
+                      </a:pPr>
+                      <a:r>
+                        <a:rPr lang="en-US" sz="1300" b="1" dirty="0">
+                          <a:solidFill>
+                            <a:srgbClr val="FFFFFF"/>
+                          </a:solidFill>
+                          <a:latin typeface="Calibri" pitchFamily="34" charset="0"/>
+                          <a:ea typeface="Calibri" pitchFamily="34" charset="-122"/>
+                          <a:cs typeface="Calibri" pitchFamily="34" charset="-120"/>
+                        </a:rPr>
+                        <a:t>n</a:t>
+                      </a:r>
+                      <a:endParaRPr lang="en-US" sz="1300" dirty="0">
+                        <a:latin typeface="Calibri" charset="0"/>
+                        <a:ea typeface="Calibri" charset="0"/>
+                        <a:cs typeface="Calibri" charset="0"/>
+                      </a:endParaRPr>
+                    </a:p>
+                  </a:txBody>
+                  <a:tcPr marL="91440" marR="91440" marT="27432" marB="27432" anchor="ctr">
+                    <a:lnL w="0" cap="flat" cmpd="sng" algn="ctr">
+                      <a:noFill/>
+                    </a:lnL>
+                    <a:lnR w="0" cap="flat" cmpd="sng" algn="ctr">
+                      <a:noFill/>
+                    </a:lnR>
+                    <a:lnT w="0" cap="flat" cmpd="sng" algn="ctr">
+                      <a:noFill/>
+                    </a:lnT>
+                    <a:lnB w="9525" cap="flat" cmpd="sng" algn="ctr">
+                      <a:solidFill>
+                        <a:srgbClr val="E5E7EB"/>
+                      </a:solidFill>
+                      <a:prstDash val="solid"/>
+                      <a:round/>
+                      <a:headEnd type="none" w="med" len="med"/>
+                      <a:tailEnd type="none" w="med" len="med"/>
+                    </a:lnB>
+                    <a:solidFill>
+                      <a:srgbClr val="1F3A5F"/>
+                    </a:solidFill>
+                  </a:tcPr>
+                </a:tc>
+                <a:tc>
+                  <a:txBody>
+                    <a:bodyPr/>
+                    <a:lstStyle/>
+                    <a:p>
+                      <a:pPr algn="l" indent="0" marL="0">
+                        <a:buNone/>
+                      </a:pPr>
+                      <a:r>
+                        <a:rPr lang="en-US" sz="1300" b="1" dirty="0">
+                          <a:solidFill>
+                            <a:srgbClr val="FFFFFF"/>
+                          </a:solidFill>
+                          <a:latin typeface="Calibri" pitchFamily="34" charset="0"/>
+                          <a:ea typeface="Calibri" pitchFamily="34" charset="-122"/>
+                          <a:cs typeface="Calibri" pitchFamily="34" charset="-120"/>
+                        </a:rPr>
+                        <a:t>Size measure</a:t>
+                      </a:r>
+                      <a:endParaRPr lang="en-US" sz="1300" dirty="0">
+                        <a:latin typeface="Calibri" charset="0"/>
+                        <a:ea typeface="Calibri" charset="0"/>
+                        <a:cs typeface="Calibri" charset="0"/>
+                      </a:endParaRPr>
+                    </a:p>
+                  </a:txBody>
+                  <a:tcPr marL="91440" marR="91440" marT="27432" marB="27432" anchor="ctr">
+                    <a:lnL w="0" cap="flat" cmpd="sng" algn="ctr">
+                      <a:noFill/>
+                    </a:lnL>
+                    <a:lnR w="0" cap="flat" cmpd="sng" algn="ctr">
+                      <a:noFill/>
+                    </a:lnR>
+                    <a:lnT w="0" cap="flat" cmpd="sng" algn="ctr">
+                      <a:noFill/>
+                    </a:lnT>
+                    <a:lnB w="9525" cap="flat" cmpd="sng" algn="ctr">
+                      <a:solidFill>
+                        <a:srgbClr val="E5E7EB"/>
+                      </a:solidFill>
+                      <a:prstDash val="solid"/>
+                      <a:round/>
+                      <a:headEnd type="none" w="med" len="med"/>
+                      <a:tailEnd type="none" w="med" len="med"/>
+                    </a:lnB>
+                    <a:solidFill>
+                      <a:srgbClr val="1F3A5F"/>
+                    </a:solidFill>
+                  </a:tcPr>
+                </a:tc>
+                <a:tc>
+                  <a:txBody>
+                    <a:bodyPr/>
+                    <a:lstStyle/>
+                    <a:p>
+                      <a:pPr algn="r" indent="0" marL="0">
+                        <a:buNone/>
+                      </a:pPr>
+                      <a:r>
+                        <a:rPr lang="en-US" sz="1300" b="1" dirty="0">
+                          <a:solidFill>
+                            <a:srgbClr val="FFFFFF"/>
+                          </a:solidFill>
+                          <a:latin typeface="Calibri" pitchFamily="34" charset="0"/>
+                          <a:ea typeface="Calibri" pitchFamily="34" charset="-122"/>
+                          <a:cs typeface="Calibri" pitchFamily="34" charset="-120"/>
+                        </a:rPr>
+                        <a:t>n</a:t>
+                      </a:r>
+                      <a:endParaRPr lang="en-US" sz="1300" dirty="0">
+                        <a:latin typeface="Calibri" charset="0"/>
+                        <a:ea typeface="Calibri" charset="0"/>
+                        <a:cs typeface="Calibri" charset="0"/>
+                      </a:endParaRPr>
+                    </a:p>
+                  </a:txBody>
+                  <a:tcPr marL="91440" marR="91440" marT="27432" marB="27432" anchor="ctr">
+                    <a:lnL w="0" cap="flat" cmpd="sng" algn="ctr">
+                      <a:noFill/>
+                    </a:lnL>
+                    <a:lnR w="0" cap="flat" cmpd="sng" algn="ctr">
+                      <a:noFill/>
+                    </a:lnR>
+                    <a:lnT w="0" cap="flat" cmpd="sng" algn="ctr">
+                      <a:noFill/>
+                    </a:lnT>
+                    <a:lnB w="9525" cap="flat" cmpd="sng" algn="ctr">
+                      <a:solidFill>
+                        <a:srgbClr val="E5E7EB"/>
+                      </a:solidFill>
+                      <a:prstDash val="solid"/>
+                      <a:round/>
+                      <a:headEnd type="none" w="med" len="med"/>
+                      <a:tailEnd type="none" w="med" len="med"/>
+                    </a:lnB>
+                    <a:solidFill>
+                      <a:srgbClr val="1F3A5F"/>
+                    </a:solidFill>
+                  </a:tcPr>
+                </a:tc>
+              </a:tr>
+              <a:tr h="365760">
+                <a:tc>
+                  <a:txBody>
+                    <a:bodyPr/>
+                    <a:lstStyle/>
+                    <a:p>
+                      <a:pPr algn="l" indent="0" marL="0">
+                        <a:buNone/>
+                      </a:pPr>
+                      <a:r>
+                        <a:rPr lang="en-US" sz="1300" dirty="0">
+                          <a:solidFill>
+                            <a:srgbClr val="1A1A1A"/>
+                          </a:solidFill>
+                          <a:latin typeface="Calibri" pitchFamily="34" charset="0"/>
+                          <a:ea typeface="Calibri" pitchFamily="34" charset="-122"/>
+                          <a:cs typeface="Calibri" pitchFamily="34" charset="-120"/>
+                        </a:rPr>
+                        <a:t>MRI</a:t>
+                      </a:r>
+                      <a:endParaRPr lang="en-US" sz="1300" dirty="0">
+                        <a:latin typeface="Calibri" charset="0"/>
+                        <a:ea typeface="Calibri" charset="0"/>
+                        <a:cs typeface="Calibri" charset="0"/>
+                      </a:endParaRPr>
+                    </a:p>
+                  </a:txBody>
+                  <a:tcPr marL="91440" marR="91440" marT="27432" marB="27432" anchor="ctr">
+                    <a:lnL w="0" cap="flat" cmpd="sng" algn="ctr">
+                      <a:noFill/>
+                    </a:lnL>
+                    <a:lnR w="0" cap="flat" cmpd="sng" algn="ctr">
+                      <a:noFill/>
+                    </a:lnR>
+                    <a:lnT w="0" cap="flat" cmpd="sng" algn="ctr">
+                      <a:noFill/>
+                    </a:lnT>
+                    <a:lnB w="9525" cap="flat" cmpd="sng" algn="ctr">
+                      <a:solidFill>
+                        <a:srgbClr val="E5E7EB"/>
+                      </a:solidFill>
+                      <a:prstDash val="solid"/>
+                      <a:round/>
+                      <a:headEnd type="none" w="med" len="med"/>
+                      <a:tailEnd type="none" w="med" len="med"/>
+                    </a:lnB>
+                  </a:tcPr>
+                </a:tc>
+                <a:tc>
+                  <a:txBody>
+                    <a:bodyPr/>
+                    <a:lstStyle/>
+                    <a:p>
+                      <a:pPr algn="r" indent="0" marL="0">
+                        <a:buNone/>
+                      </a:pPr>
+                      <a:r>
+                        <a:rPr lang="en-US" sz="1300" b="1" dirty="0">
+                          <a:solidFill>
+                            <a:srgbClr val="1A1A1A"/>
+                          </a:solidFill>
+                          <a:latin typeface="Calibri" pitchFamily="34" charset="0"/>
+                          <a:ea typeface="Calibri" pitchFamily="34" charset="-122"/>
+                          <a:cs typeface="Calibri" pitchFamily="34" charset="-120"/>
+                        </a:rPr>
+                        <a:t>655</a:t>
+                      </a:r>
+                      <a:endParaRPr lang="en-US" sz="1300" dirty="0">
+                        <a:latin typeface="Calibri" charset="0"/>
+                        <a:ea typeface="Calibri" charset="0"/>
+                        <a:cs typeface="Calibri" charset="0"/>
+                      </a:endParaRPr>
+                    </a:p>
+                  </a:txBody>
+                  <a:tcPr marL="91440" marR="91440" marT="27432" marB="27432" anchor="ctr">
+                    <a:lnL w="0" cap="flat" cmpd="sng" algn="ctr">
+                      <a:noFill/>
+                    </a:lnL>
+                    <a:lnR w="0" cap="flat" cmpd="sng" algn="ctr">
+                      <a:noFill/>
+                    </a:lnR>
+                    <a:lnT w="0" cap="flat" cmpd="sng" algn="ctr">
+                      <a:noFill/>
+                    </a:lnT>
+                    <a:lnB w="9525" cap="flat" cmpd="sng" algn="ctr">
+                      <a:solidFill>
+                        <a:srgbClr val="E5E7EB"/>
+                      </a:solidFill>
+                      <a:prstDash val="solid"/>
+                      <a:round/>
+                      <a:headEnd type="none" w="med" len="med"/>
+                      <a:tailEnd type="none" w="med" len="med"/>
+                    </a:lnB>
+                  </a:tcPr>
+                </a:tc>
+                <a:tc>
+                  <a:txBody>
+                    <a:bodyPr/>
+                    <a:lstStyle/>
+                    <a:p>
+                      <a:pPr algn="l" indent="0" marL="0">
+                        <a:buNone/>
+                      </a:pPr>
+                      <a:r>
+                        <a:rPr lang="en-US" sz="1300" dirty="0">
+                          <a:solidFill>
+                            <a:srgbClr val="1A1A1A"/>
+                          </a:solidFill>
+                          <a:latin typeface="Calibri" pitchFamily="34" charset="0"/>
+                          <a:ea typeface="Calibri" pitchFamily="34" charset="-122"/>
+                          <a:cs typeface="Calibri" pitchFamily="34" charset="-120"/>
+                        </a:rPr>
+                        <a:t>Volume</a:t>
+                      </a:r>
+                      <a:endParaRPr lang="en-US" sz="1300" dirty="0">
+                        <a:latin typeface="Calibri" charset="0"/>
+                        <a:ea typeface="Calibri" charset="0"/>
+                        <a:cs typeface="Calibri" charset="0"/>
+                      </a:endParaRPr>
+                    </a:p>
+                  </a:txBody>
+                  <a:tcPr marL="91440" marR="91440" marT="27432" marB="27432" anchor="ctr">
+                    <a:lnL w="0" cap="flat" cmpd="sng" algn="ctr">
+                      <a:noFill/>
+                    </a:lnL>
+                    <a:lnR w="0" cap="flat" cmpd="sng" algn="ctr">
+                      <a:noFill/>
+                    </a:lnR>
+                    <a:lnT w="0" cap="flat" cmpd="sng" algn="ctr">
+                      <a:noFill/>
+                    </a:lnT>
+                    <a:lnB w="9525" cap="flat" cmpd="sng" algn="ctr">
+                      <a:solidFill>
+                        <a:srgbClr val="E5E7EB"/>
+                      </a:solidFill>
+                      <a:prstDash val="solid"/>
+                      <a:round/>
+                      <a:headEnd type="none" w="med" len="med"/>
+                      <a:tailEnd type="none" w="med" len="med"/>
+                    </a:lnB>
+                  </a:tcPr>
+                </a:tc>
+                <a:tc>
+                  <a:txBody>
+                    <a:bodyPr/>
+                    <a:lstStyle/>
+                    <a:p>
+                      <a:pPr algn="r" indent="0" marL="0">
+                        <a:buNone/>
+                      </a:pPr>
+                      <a:r>
+                        <a:rPr lang="en-US" sz="1300" b="1" dirty="0">
+                          <a:solidFill>
+                            <a:srgbClr val="1A1A1A"/>
+                          </a:solidFill>
+                          <a:latin typeface="Calibri" pitchFamily="34" charset="0"/>
+                          <a:ea typeface="Calibri" pitchFamily="34" charset="-122"/>
+                          <a:cs typeface="Calibri" pitchFamily="34" charset="-120"/>
+                        </a:rPr>
+                        <a:t>594</a:t>
+                      </a:r>
+                      <a:endParaRPr lang="en-US" sz="1300" dirty="0">
+                        <a:latin typeface="Calibri" charset="0"/>
+                        <a:ea typeface="Calibri" charset="0"/>
+                        <a:cs typeface="Calibri" charset="0"/>
+                      </a:endParaRPr>
+                    </a:p>
+                  </a:txBody>
+                  <a:tcPr marL="91440" marR="91440" marT="27432" marB="27432" anchor="ctr">
+                    <a:lnL w="0" cap="flat" cmpd="sng" algn="ctr">
+                      <a:noFill/>
+                    </a:lnL>
+                    <a:lnR w="0" cap="flat" cmpd="sng" algn="ctr">
+                      <a:noFill/>
+                    </a:lnR>
+                    <a:lnT w="0" cap="flat" cmpd="sng" algn="ctr">
+                      <a:noFill/>
+                    </a:lnT>
+                    <a:lnB w="9525" cap="flat" cmpd="sng" algn="ctr">
+                      <a:solidFill>
+                        <a:srgbClr val="E5E7EB"/>
+                      </a:solidFill>
+                      <a:prstDash val="solid"/>
+                      <a:round/>
+                      <a:headEnd type="none" w="med" len="med"/>
+                      <a:tailEnd type="none" w="med" len="med"/>
+                    </a:lnB>
+                  </a:tcPr>
+                </a:tc>
+              </a:tr>
+              <a:tr h="365760">
+                <a:tc>
+                  <a:txBody>
+                    <a:bodyPr/>
+                    <a:lstStyle/>
+                    <a:p>
+                      <a:pPr algn="l" indent="0" marL="0">
+                        <a:buNone/>
+                      </a:pPr>
+                      <a:r>
+                        <a:rPr lang="en-US" sz="1300" dirty="0">
+                          <a:solidFill>
+                            <a:srgbClr val="1A1A1A"/>
+                          </a:solidFill>
+                          <a:latin typeface="Calibri" pitchFamily="34" charset="0"/>
+                          <a:ea typeface="Calibri" pitchFamily="34" charset="-122"/>
+                          <a:cs typeface="Calibri" pitchFamily="34" charset="-120"/>
+                        </a:rPr>
+                        <a:t>DXA</a:t>
+                      </a:r>
+                      <a:endParaRPr lang="en-US" sz="1300" dirty="0">
+                        <a:latin typeface="Calibri" charset="0"/>
+                        <a:ea typeface="Calibri" charset="0"/>
+                        <a:cs typeface="Calibri" charset="0"/>
+                      </a:endParaRPr>
+                    </a:p>
+                  </a:txBody>
+                  <a:tcPr marL="91440" marR="91440" marT="27432" marB="27432" anchor="ctr">
+                    <a:lnL w="0" cap="flat" cmpd="sng" algn="ctr">
+                      <a:noFill/>
+                    </a:lnL>
+                    <a:lnR w="0" cap="flat" cmpd="sng" algn="ctr">
+                      <a:noFill/>
+                    </a:lnR>
+                    <a:lnT w="0" cap="flat" cmpd="sng" algn="ctr">
+                      <a:noFill/>
+                    </a:lnT>
+                    <a:lnB w="9525" cap="flat" cmpd="sng" algn="ctr">
+                      <a:solidFill>
+                        <a:srgbClr val="E5E7EB"/>
+                      </a:solidFill>
+                      <a:prstDash val="solid"/>
+                      <a:round/>
+                      <a:headEnd type="none" w="med" len="med"/>
+                      <a:tailEnd type="none" w="med" len="med"/>
+                    </a:lnB>
+                  </a:tcPr>
+                </a:tc>
+                <a:tc>
+                  <a:txBody>
+                    <a:bodyPr/>
+                    <a:lstStyle/>
+                    <a:p>
+                      <a:pPr algn="r" indent="0" marL="0">
+                        <a:buNone/>
+                      </a:pPr>
+                      <a:r>
+                        <a:rPr lang="en-US" sz="1300" b="1" dirty="0">
+                          <a:solidFill>
+                            <a:srgbClr val="1A1A1A"/>
+                          </a:solidFill>
+                          <a:latin typeface="Calibri" pitchFamily="34" charset="0"/>
+                          <a:ea typeface="Calibri" pitchFamily="34" charset="-122"/>
+                          <a:cs typeface="Calibri" pitchFamily="34" charset="-120"/>
+                        </a:rPr>
+                        <a:t>37</a:t>
+                      </a:r>
+                      <a:endParaRPr lang="en-US" sz="1300" dirty="0">
+                        <a:latin typeface="Calibri" charset="0"/>
+                        <a:ea typeface="Calibri" charset="0"/>
+                        <a:cs typeface="Calibri" charset="0"/>
+                      </a:endParaRPr>
+                    </a:p>
+                  </a:txBody>
+                  <a:tcPr marL="91440" marR="91440" marT="27432" marB="27432" anchor="ctr">
+                    <a:lnL w="0" cap="flat" cmpd="sng" algn="ctr">
+                      <a:noFill/>
+                    </a:lnL>
+                    <a:lnR w="0" cap="flat" cmpd="sng" algn="ctr">
+                      <a:noFill/>
+                    </a:lnR>
+                    <a:lnT w="0" cap="flat" cmpd="sng" algn="ctr">
+                      <a:noFill/>
+                    </a:lnT>
+                    <a:lnB w="9525" cap="flat" cmpd="sng" algn="ctr">
+                      <a:solidFill>
+                        <a:srgbClr val="E5E7EB"/>
+                      </a:solidFill>
+                      <a:prstDash val="solid"/>
+                      <a:round/>
+                      <a:headEnd type="none" w="med" len="med"/>
+                      <a:tailEnd type="none" w="med" len="med"/>
+                    </a:lnB>
+                  </a:tcPr>
+                </a:tc>
+                <a:tc>
+                  <a:txBody>
+                    <a:bodyPr/>
+                    <a:lstStyle/>
+                    <a:p>
+                      <a:pPr algn="l" indent="0" marL="0">
+                        <a:buNone/>
+                      </a:pPr>
+                      <a:r>
+                        <a:rPr lang="en-US" sz="1300" dirty="0">
+                          <a:solidFill>
+                            <a:srgbClr val="1A1A1A"/>
+                          </a:solidFill>
+                          <a:latin typeface="Calibri" pitchFamily="34" charset="0"/>
+                          <a:ea typeface="Calibri" pitchFamily="34" charset="-122"/>
+                          <a:cs typeface="Calibri" pitchFamily="34" charset="-120"/>
+                        </a:rPr>
+                        <a:t>Cross-sectional area</a:t>
+                      </a:r>
+                      <a:endParaRPr lang="en-US" sz="1300" dirty="0">
+                        <a:latin typeface="Calibri" charset="0"/>
+                        <a:ea typeface="Calibri" charset="0"/>
+                        <a:cs typeface="Calibri" charset="0"/>
+                      </a:endParaRPr>
+                    </a:p>
+                  </a:txBody>
+                  <a:tcPr marL="91440" marR="91440" marT="27432" marB="27432" anchor="ctr">
+                    <a:lnL w="0" cap="flat" cmpd="sng" algn="ctr">
+                      <a:noFill/>
+                    </a:lnL>
+                    <a:lnR w="0" cap="flat" cmpd="sng" algn="ctr">
+                      <a:noFill/>
+                    </a:lnR>
+                    <a:lnT w="0" cap="flat" cmpd="sng" algn="ctr">
+                      <a:noFill/>
+                    </a:lnT>
+                    <a:lnB w="9525" cap="flat" cmpd="sng" algn="ctr">
+                      <a:solidFill>
+                        <a:srgbClr val="E5E7EB"/>
+                      </a:solidFill>
+                      <a:prstDash val="solid"/>
+                      <a:round/>
+                      <a:headEnd type="none" w="med" len="med"/>
+                      <a:tailEnd type="none" w="med" len="med"/>
+                    </a:lnB>
+                  </a:tcPr>
+                </a:tc>
+                <a:tc>
+                  <a:txBody>
+                    <a:bodyPr/>
+                    <a:lstStyle/>
+                    <a:p>
+                      <a:pPr algn="r" indent="0" marL="0">
+                        <a:buNone/>
+                      </a:pPr>
+                      <a:r>
+                        <a:rPr lang="en-US" sz="1300" b="1" dirty="0">
+                          <a:solidFill>
+                            <a:srgbClr val="1A1A1A"/>
+                          </a:solidFill>
+                          <a:latin typeface="Calibri" pitchFamily="34" charset="0"/>
+                          <a:ea typeface="Calibri" pitchFamily="34" charset="-122"/>
+                          <a:cs typeface="Calibri" pitchFamily="34" charset="-120"/>
+                        </a:rPr>
+                        <a:t>100</a:t>
+                      </a:r>
+                      <a:endParaRPr lang="en-US" sz="1300" dirty="0">
+                        <a:latin typeface="Calibri" charset="0"/>
+                        <a:ea typeface="Calibri" charset="0"/>
+                        <a:cs typeface="Calibri" charset="0"/>
+                      </a:endParaRPr>
+                    </a:p>
+                  </a:txBody>
+                  <a:tcPr marL="91440" marR="91440" marT="27432" marB="27432" anchor="ctr">
+                    <a:lnL w="0" cap="flat" cmpd="sng" algn="ctr">
+                      <a:noFill/>
+                    </a:lnL>
+                    <a:lnR w="0" cap="flat" cmpd="sng" algn="ctr">
+                      <a:noFill/>
+                    </a:lnR>
+                    <a:lnT w="0" cap="flat" cmpd="sng" algn="ctr">
+                      <a:noFill/>
+                    </a:lnT>
+                    <a:lnB w="9525" cap="flat" cmpd="sng" algn="ctr">
+                      <a:solidFill>
+                        <a:srgbClr val="E5E7EB"/>
+                      </a:solidFill>
+                      <a:prstDash val="solid"/>
+                      <a:round/>
+                      <a:headEnd type="none" w="med" len="med"/>
+                      <a:tailEnd type="none" w="med" len="med"/>
+                    </a:lnB>
+                  </a:tcPr>
+                </a:tc>
+              </a:tr>
+              <a:tr h="365760">
+                <a:tc>
+                  <a:txBody>
+                    <a:bodyPr/>
+                    <a:lstStyle/>
+                    <a:p>
+                      <a:pPr algn="l" indent="0" marL="0">
+                        <a:buNone/>
+                      </a:pPr>
+                      <a:r>
+                        <a:rPr lang="en-US" sz="1300" dirty="0">
+                          <a:solidFill>
+                            <a:srgbClr val="1A1A1A"/>
+                          </a:solidFill>
+                          <a:latin typeface="Calibri" pitchFamily="34" charset="0"/>
+                          <a:ea typeface="Calibri" pitchFamily="34" charset="-122"/>
+                          <a:cs typeface="Calibri" pitchFamily="34" charset="-120"/>
+                        </a:rPr>
+                        <a:t>CT</a:t>
+                      </a:r>
+                      <a:endParaRPr lang="en-US" sz="1300" dirty="0">
+                        <a:latin typeface="Calibri" charset="0"/>
+                        <a:ea typeface="Calibri" charset="0"/>
+                        <a:cs typeface="Calibri" charset="0"/>
+                      </a:endParaRPr>
+                    </a:p>
+                  </a:txBody>
+                  <a:tcPr marL="91440" marR="91440" marT="27432" marB="27432" anchor="ctr">
+                    <a:lnL w="0" cap="flat" cmpd="sng" algn="ctr">
+                      <a:noFill/>
+                    </a:lnL>
+                    <a:lnR w="0" cap="flat" cmpd="sng" algn="ctr">
+                      <a:noFill/>
+                    </a:lnR>
+                    <a:lnT w="0" cap="flat" cmpd="sng" algn="ctr">
+                      <a:noFill/>
+                    </a:lnT>
+                    <a:lnB w="9525" cap="flat" cmpd="sng" algn="ctr">
+                      <a:solidFill>
+                        <a:srgbClr val="E5E7EB"/>
+                      </a:solidFill>
+                      <a:prstDash val="solid"/>
+                      <a:round/>
+                      <a:headEnd type="none" w="med" len="med"/>
+                      <a:tailEnd type="none" w="med" len="med"/>
+                    </a:lnB>
+                  </a:tcPr>
+                </a:tc>
+                <a:tc>
+                  <a:txBody>
+                    <a:bodyPr/>
+                    <a:lstStyle/>
+                    <a:p>
+                      <a:pPr algn="r" indent="0" marL="0">
+                        <a:buNone/>
+                      </a:pPr>
+                      <a:r>
+                        <a:rPr lang="en-US" sz="1300" b="1" dirty="0">
+                          <a:solidFill>
+                            <a:srgbClr val="1A1A1A"/>
+                          </a:solidFill>
+                          <a:latin typeface="Calibri" pitchFamily="34" charset="0"/>
+                          <a:ea typeface="Calibri" pitchFamily="34" charset="-122"/>
+                          <a:cs typeface="Calibri" pitchFamily="34" charset="-120"/>
+                        </a:rPr>
+                        <a:t>30</a:t>
+                      </a:r>
+                      <a:endParaRPr lang="en-US" sz="1300" dirty="0">
+                        <a:latin typeface="Calibri" charset="0"/>
+                        <a:ea typeface="Calibri" charset="0"/>
+                        <a:cs typeface="Calibri" charset="0"/>
+                      </a:endParaRPr>
+                    </a:p>
+                  </a:txBody>
+                  <a:tcPr marL="91440" marR="91440" marT="27432" marB="27432" anchor="ctr">
+                    <a:lnL w="0" cap="flat" cmpd="sng" algn="ctr">
+                      <a:noFill/>
+                    </a:lnL>
+                    <a:lnR w="0" cap="flat" cmpd="sng" algn="ctr">
+                      <a:noFill/>
+                    </a:lnR>
+                    <a:lnT w="0" cap="flat" cmpd="sng" algn="ctr">
+                      <a:noFill/>
+                    </a:lnT>
+                    <a:lnB w="9525" cap="flat" cmpd="sng" algn="ctr">
+                      <a:solidFill>
+                        <a:srgbClr val="E5E7EB"/>
+                      </a:solidFill>
+                      <a:prstDash val="solid"/>
+                      <a:round/>
+                      <a:headEnd type="none" w="med" len="med"/>
+                      <a:tailEnd type="none" w="med" len="med"/>
+                    </a:lnB>
+                  </a:tcPr>
+                </a:tc>
+                <a:tc>
+                  <a:txBody>
+                    <a:bodyPr/>
+                    <a:lstStyle/>
+                    <a:p>
+                      <a:pPr algn="l" indent="0" marL="0">
+                        <a:buNone/>
+                      </a:pPr>
+                      <a:r>
+                        <a:rPr lang="en-US" sz="1300" dirty="0">
+                          <a:solidFill>
+                            <a:srgbClr val="1A1A1A"/>
+                          </a:solidFill>
+                          <a:latin typeface="Calibri" pitchFamily="34" charset="0"/>
+                          <a:ea typeface="Calibri" pitchFamily="34" charset="-122"/>
+                          <a:cs typeface="Calibri" pitchFamily="34" charset="-120"/>
+                        </a:rPr>
+                        <a:t>Lean mass</a:t>
+                      </a:r>
+                      <a:endParaRPr lang="en-US" sz="1300" dirty="0">
+                        <a:latin typeface="Calibri" charset="0"/>
+                        <a:ea typeface="Calibri" charset="0"/>
+                        <a:cs typeface="Calibri" charset="0"/>
+                      </a:endParaRPr>
+                    </a:p>
+                  </a:txBody>
+                  <a:tcPr marL="91440" marR="91440" marT="27432" marB="27432" anchor="ctr">
+                    <a:lnL w="0" cap="flat" cmpd="sng" algn="ctr">
+                      <a:noFill/>
+                    </a:lnL>
+                    <a:lnR w="0" cap="flat" cmpd="sng" algn="ctr">
+                      <a:noFill/>
+                    </a:lnR>
+                    <a:lnT w="0" cap="flat" cmpd="sng" algn="ctr">
+                      <a:noFill/>
+                    </a:lnT>
+                    <a:lnB w="9525" cap="flat" cmpd="sng" algn="ctr">
+                      <a:solidFill>
+                        <a:srgbClr val="E5E7EB"/>
+                      </a:solidFill>
+                      <a:prstDash val="solid"/>
+                      <a:round/>
+                      <a:headEnd type="none" w="med" len="med"/>
+                      <a:tailEnd type="none" w="med" len="med"/>
+                    </a:lnB>
+                  </a:tcPr>
+                </a:tc>
+                <a:tc>
+                  <a:txBody>
+                    <a:bodyPr/>
+                    <a:lstStyle/>
+                    <a:p>
+                      <a:pPr algn="r" indent="0" marL="0">
+                        <a:buNone/>
+                      </a:pPr>
+                      <a:r>
+                        <a:rPr lang="en-US" sz="1300" b="1" dirty="0">
+                          <a:solidFill>
+                            <a:srgbClr val="1A1A1A"/>
+                          </a:solidFill>
+                          <a:latin typeface="Calibri" pitchFamily="34" charset="0"/>
+                          <a:ea typeface="Calibri" pitchFamily="34" charset="-122"/>
+                          <a:cs typeface="Calibri" pitchFamily="34" charset="-120"/>
+                        </a:rPr>
+                        <a:t>37</a:t>
+                      </a:r>
+                      <a:endParaRPr lang="en-US" sz="1300" dirty="0">
+                        <a:latin typeface="Calibri" charset="0"/>
+                        <a:ea typeface="Calibri" charset="0"/>
+                        <a:cs typeface="Calibri" charset="0"/>
+                      </a:endParaRPr>
+                    </a:p>
+                  </a:txBody>
+                  <a:tcPr marL="91440" marR="91440" marT="27432" marB="27432" anchor="ctr">
+                    <a:lnL w="0" cap="flat" cmpd="sng" algn="ctr">
+                      <a:noFill/>
+                    </a:lnL>
+                    <a:lnR w="0" cap="flat" cmpd="sng" algn="ctr">
+                      <a:noFill/>
+                    </a:lnR>
+                    <a:lnT w="0" cap="flat" cmpd="sng" algn="ctr">
+                      <a:noFill/>
+                    </a:lnT>
+                    <a:lnB w="9525" cap="flat" cmpd="sng" algn="ctr">
+                      <a:solidFill>
+                        <a:srgbClr val="E5E7EB"/>
+                      </a:solidFill>
+                      <a:prstDash val="solid"/>
+                      <a:round/>
+                      <a:headEnd type="none" w="med" len="med"/>
+                      <a:tailEnd type="none" w="med" len="med"/>
+                    </a:lnB>
+                  </a:tcPr>
+                </a:tc>
+              </a:tr>
+              <a:tr h="365760">
+                <a:tc>
+                  <a:txBody>
+                    <a:bodyPr/>
+                    <a:lstStyle/>
+                    <a:p>
+                      <a:pPr algn="l" indent="0" marL="0">
+                        <a:buNone/>
+                      </a:pPr>
+                      <a:r>
+                        <a:rPr lang="en-US" sz="1300" dirty="0">
+                          <a:solidFill>
+                            <a:srgbClr val="1A1A1A"/>
+                          </a:solidFill>
+                          <a:latin typeface="Calibri" pitchFamily="34" charset="0"/>
+                          <a:ea typeface="Calibri" pitchFamily="34" charset="-122"/>
+                          <a:cs typeface="Calibri" pitchFamily="34" charset="-120"/>
+                        </a:rPr>
+                        <a:t>Ultrasound</a:t>
+                      </a:r>
+                      <a:endParaRPr lang="en-US" sz="1300" dirty="0">
+                        <a:latin typeface="Calibri" charset="0"/>
+                        <a:ea typeface="Calibri" charset="0"/>
+                        <a:cs typeface="Calibri" charset="0"/>
+                      </a:endParaRPr>
+                    </a:p>
+                  </a:txBody>
+                  <a:tcPr marL="91440" marR="91440" marT="27432" marB="27432" anchor="ctr">
+                    <a:lnL w="0" cap="flat" cmpd="sng" algn="ctr">
+                      <a:noFill/>
+                    </a:lnL>
+                    <a:lnR w="0" cap="flat" cmpd="sng" algn="ctr">
+                      <a:noFill/>
+                    </a:lnR>
+                    <a:lnT w="0" cap="flat" cmpd="sng" algn="ctr">
+                      <a:noFill/>
+                    </a:lnT>
+                    <a:lnB w="9525" cap="flat" cmpd="sng" algn="ctr">
+                      <a:solidFill>
+                        <a:srgbClr val="E5E7EB"/>
+                      </a:solidFill>
+                      <a:prstDash val="solid"/>
+                      <a:round/>
+                      <a:headEnd type="none" w="med" len="med"/>
+                      <a:tailEnd type="none" w="med" len="med"/>
+                    </a:lnB>
+                  </a:tcPr>
+                </a:tc>
+                <a:tc>
+                  <a:txBody>
+                    <a:bodyPr/>
+                    <a:lstStyle/>
+                    <a:p>
+                      <a:pPr algn="r" indent="0" marL="0">
+                        <a:buNone/>
+                      </a:pPr>
+                      <a:r>
+                        <a:rPr lang="en-US" sz="1300" b="1" dirty="0">
+                          <a:solidFill>
+                            <a:srgbClr val="1A1A1A"/>
+                          </a:solidFill>
+                          <a:latin typeface="Calibri" pitchFamily="34" charset="0"/>
+                          <a:ea typeface="Calibri" pitchFamily="34" charset="-122"/>
+                          <a:cs typeface="Calibri" pitchFamily="34" charset="-120"/>
+                        </a:rPr>
+                        <a:t>20</a:t>
+                      </a:r>
+                      <a:endParaRPr lang="en-US" sz="1300" dirty="0">
+                        <a:latin typeface="Calibri" charset="0"/>
+                        <a:ea typeface="Calibri" charset="0"/>
+                        <a:cs typeface="Calibri" charset="0"/>
+                      </a:endParaRPr>
+                    </a:p>
+                  </a:txBody>
+                  <a:tcPr marL="91440" marR="91440" marT="27432" marB="27432" anchor="ctr">
+                    <a:lnL w="0" cap="flat" cmpd="sng" algn="ctr">
+                      <a:noFill/>
+                    </a:lnL>
+                    <a:lnR w="0" cap="flat" cmpd="sng" algn="ctr">
+                      <a:noFill/>
+                    </a:lnR>
+                    <a:lnT w="0" cap="flat" cmpd="sng" algn="ctr">
+                      <a:noFill/>
+                    </a:lnT>
+                    <a:lnB w="9525" cap="flat" cmpd="sng" algn="ctr">
+                      <a:solidFill>
+                        <a:srgbClr val="E5E7EB"/>
+                      </a:solidFill>
+                      <a:prstDash val="solid"/>
+                      <a:round/>
+                      <a:headEnd type="none" w="med" len="med"/>
+                      <a:tailEnd type="none" w="med" len="med"/>
+                    </a:lnB>
+                  </a:tcPr>
+                </a:tc>
+                <a:tc>
+                  <a:txBody>
+                    <a:bodyPr/>
+                    <a:lstStyle/>
+                    <a:p>
+                      <a:pPr algn="l" indent="0" marL="0">
+                        <a:buNone/>
+                      </a:pPr>
+                      <a:r>
+                        <a:rPr lang="en-US" sz="1300" dirty="0">
+                          <a:solidFill>
+                            <a:srgbClr val="1A1A1A"/>
+                          </a:solidFill>
+                          <a:latin typeface="Calibri" pitchFamily="34" charset="0"/>
+                          <a:ea typeface="Calibri" pitchFamily="34" charset="-122"/>
+                          <a:cs typeface="Calibri" pitchFamily="34" charset="-120"/>
+                        </a:rPr>
+                        <a:t>Thickness</a:t>
+                      </a:r>
+                      <a:endParaRPr lang="en-US" sz="1300" dirty="0">
+                        <a:latin typeface="Calibri" charset="0"/>
+                        <a:ea typeface="Calibri" charset="0"/>
+                        <a:cs typeface="Calibri" charset="0"/>
+                      </a:endParaRPr>
+                    </a:p>
+                  </a:txBody>
+                  <a:tcPr marL="91440" marR="91440" marT="27432" marB="27432" anchor="ctr">
+                    <a:lnL w="0" cap="flat" cmpd="sng" algn="ctr">
+                      <a:noFill/>
+                    </a:lnL>
+                    <a:lnR w="0" cap="flat" cmpd="sng" algn="ctr">
+                      <a:noFill/>
+                    </a:lnR>
+                    <a:lnT w="0" cap="flat" cmpd="sng" algn="ctr">
+                      <a:noFill/>
+                    </a:lnT>
+                    <a:lnB w="9525" cap="flat" cmpd="sng" algn="ctr">
+                      <a:solidFill>
+                        <a:srgbClr val="E5E7EB"/>
+                      </a:solidFill>
+                      <a:prstDash val="solid"/>
+                      <a:round/>
+                      <a:headEnd type="none" w="med" len="med"/>
+                      <a:tailEnd type="none" w="med" len="med"/>
+                    </a:lnB>
+                  </a:tcPr>
+                </a:tc>
+                <a:tc>
+                  <a:txBody>
+                    <a:bodyPr/>
+                    <a:lstStyle/>
+                    <a:p>
+                      <a:pPr algn="r" indent="0" marL="0">
+                        <a:buNone/>
+                      </a:pPr>
+                      <a:r>
+                        <a:rPr lang="en-US" sz="1300" b="1" dirty="0">
+                          <a:solidFill>
+                            <a:srgbClr val="1A1A1A"/>
+                          </a:solidFill>
+                          <a:latin typeface="Calibri" pitchFamily="34" charset="0"/>
+                          <a:ea typeface="Calibri" pitchFamily="34" charset="-122"/>
+                          <a:cs typeface="Calibri" pitchFamily="34" charset="-120"/>
+                        </a:rPr>
+                        <a:t>11</a:t>
+                      </a:r>
+                      <a:endParaRPr lang="en-US" sz="1300" dirty="0">
+                        <a:latin typeface="Calibri" charset="0"/>
+                        <a:ea typeface="Calibri" charset="0"/>
+                        <a:cs typeface="Calibri" charset="0"/>
+                      </a:endParaRPr>
+                    </a:p>
+                  </a:txBody>
+                  <a:tcPr marL="91440" marR="91440" marT="27432" marB="27432" anchor="ctr">
+                    <a:lnL w="0" cap="flat" cmpd="sng" algn="ctr">
+                      <a:noFill/>
+                    </a:lnL>
+                    <a:lnR w="0" cap="flat" cmpd="sng" algn="ctr">
+                      <a:noFill/>
+                    </a:lnR>
+                    <a:lnT w="0" cap="flat" cmpd="sng" algn="ctr">
+                      <a:noFill/>
+                    </a:lnT>
+                    <a:lnB w="9525" cap="flat" cmpd="sng" algn="ctr">
+                      <a:solidFill>
+                        <a:srgbClr val="E5E7EB"/>
+                      </a:solidFill>
+                      <a:prstDash val="solid"/>
+                      <a:round/>
+                      <a:headEnd type="none" w="med" len="med"/>
+                      <a:tailEnd type="none" w="med" len="med"/>
+                    </a:lnB>
+                  </a:tcPr>
+                </a:tc>
+              </a:tr>
+              <a:tr h="365760">
+                <a:tc>
+                  <a:txBody>
+                    <a:bodyPr/>
+                    <a:lstStyle/>
+                    <a:p>
+                      <a:pPr algn="l" indent="0" marL="0">
+                        <a:buNone/>
+                      </a:pPr>
+                      <a:r>
+                        <a:rPr lang="en-US" sz="1300" b="1" dirty="0">
+                          <a:solidFill>
+                            <a:srgbClr val="1A1A1A"/>
+                          </a:solidFill>
+                          <a:latin typeface="Calibri" pitchFamily="34" charset="0"/>
+                          <a:ea typeface="Calibri" pitchFamily="34" charset="-122"/>
+                          <a:cs typeface="Calibri" pitchFamily="34" charset="-120"/>
+                        </a:rPr>
+                        <a:t>Total</a:t>
+                      </a:r>
+                      <a:endParaRPr lang="en-US" sz="1300" dirty="0">
+                        <a:latin typeface="Calibri" charset="0"/>
+                        <a:ea typeface="Calibri" charset="0"/>
+                        <a:cs typeface="Calibri" charset="0"/>
+                      </a:endParaRPr>
+                    </a:p>
+                  </a:txBody>
+                  <a:tcPr marL="91440" marR="91440" marT="27432" marB="27432" anchor="ctr">
+                    <a:lnL w="0" cap="flat" cmpd="sng" algn="ctr">
+                      <a:noFill/>
+                    </a:lnL>
+                    <a:lnR w="0" cap="flat" cmpd="sng" algn="ctr">
+                      <a:noFill/>
+                    </a:lnR>
+                    <a:lnT w="0" cap="flat" cmpd="sng" algn="ctr">
+                      <a:noFill/>
+                    </a:lnT>
+                    <a:lnB w="9525" cap="flat" cmpd="sng" algn="ctr">
+                      <a:solidFill>
+                        <a:srgbClr val="E5E7EB"/>
+                      </a:solidFill>
+                      <a:prstDash val="solid"/>
+                      <a:round/>
+                      <a:headEnd type="none" w="med" len="med"/>
+                      <a:tailEnd type="none" w="med" len="med"/>
+                    </a:lnB>
+                  </a:tcPr>
+                </a:tc>
+                <a:tc>
+                  <a:txBody>
+                    <a:bodyPr/>
+                    <a:lstStyle/>
+                    <a:p>
+                      <a:pPr algn="r" indent="0" marL="0">
+                        <a:buNone/>
+                      </a:pPr>
+                      <a:r>
+                        <a:rPr lang="en-US" sz="1300" b="1" dirty="0">
+                          <a:solidFill>
+                            <a:srgbClr val="1A1A1A"/>
+                          </a:solidFill>
+                          <a:latin typeface="Calibri" pitchFamily="34" charset="0"/>
+                          <a:ea typeface="Calibri" pitchFamily="34" charset="-122"/>
+                          <a:cs typeface="Calibri" pitchFamily="34" charset="-120"/>
+                        </a:rPr>
+                        <a:t>742</a:t>
+                      </a:r>
+                      <a:endParaRPr lang="en-US" sz="1300" dirty="0">
+                        <a:latin typeface="Calibri" charset="0"/>
+                        <a:ea typeface="Calibri" charset="0"/>
+                        <a:cs typeface="Calibri" charset="0"/>
+                      </a:endParaRPr>
+                    </a:p>
+                  </a:txBody>
+                  <a:tcPr marL="91440" marR="91440" marT="27432" marB="27432" anchor="ctr">
+                    <a:lnL w="0" cap="flat" cmpd="sng" algn="ctr">
+                      <a:noFill/>
+                    </a:lnL>
+                    <a:lnR w="0" cap="flat" cmpd="sng" algn="ctr">
+                      <a:noFill/>
+                    </a:lnR>
+                    <a:lnT w="0" cap="flat" cmpd="sng" algn="ctr">
+                      <a:noFill/>
+                    </a:lnT>
+                    <a:lnB w="9525" cap="flat" cmpd="sng" algn="ctr">
+                      <a:solidFill>
+                        <a:srgbClr val="E5E7EB"/>
+                      </a:solidFill>
+                      <a:prstDash val="solid"/>
+                      <a:round/>
+                      <a:headEnd type="none" w="med" len="med"/>
+                      <a:tailEnd type="none" w="med" len="med"/>
+                    </a:lnB>
+                  </a:tcPr>
+                </a:tc>
+                <a:tc>
+                  <a:txBody>
+                    <a:bodyPr/>
+                    <a:lstStyle/>
+                    <a:p>
+                      <a:pPr algn="l" indent="0" marL="0">
+                        <a:buNone/>
+                      </a:pPr>
+                      <a:r>
+                        <a:rPr lang="en-US" sz="1300" b="1" dirty="0">
+                          <a:solidFill>
+                            <a:srgbClr val="1A1A1A"/>
+                          </a:solidFill>
+                          <a:latin typeface="Calibri" pitchFamily="34" charset="0"/>
+                          <a:ea typeface="Calibri" pitchFamily="34" charset="-122"/>
+                          <a:cs typeface="Calibri" pitchFamily="34" charset="-120"/>
+                        </a:rPr>
+                        <a:t>Total</a:t>
+                      </a:r>
+                      <a:endParaRPr lang="en-US" sz="1300" dirty="0">
+                        <a:latin typeface="Calibri" charset="0"/>
+                        <a:ea typeface="Calibri" charset="0"/>
+                        <a:cs typeface="Calibri" charset="0"/>
+                      </a:endParaRPr>
+                    </a:p>
+                  </a:txBody>
+                  <a:tcPr marL="91440" marR="91440" marT="27432" marB="27432" anchor="ctr">
+                    <a:lnL w="0" cap="flat" cmpd="sng" algn="ctr">
+                      <a:noFill/>
+                    </a:lnL>
+                    <a:lnR w="0" cap="flat" cmpd="sng" algn="ctr">
+                      <a:noFill/>
+                    </a:lnR>
+                    <a:lnT w="0" cap="flat" cmpd="sng" algn="ctr">
+                      <a:noFill/>
+                    </a:lnT>
+                    <a:lnB w="9525" cap="flat" cmpd="sng" algn="ctr">
+                      <a:solidFill>
+                        <a:srgbClr val="E5E7EB"/>
+                      </a:solidFill>
+                      <a:prstDash val="solid"/>
+                      <a:round/>
+                      <a:headEnd type="none" w="med" len="med"/>
+                      <a:tailEnd type="none" w="med" len="med"/>
+                    </a:lnB>
+                  </a:tcPr>
+                </a:tc>
+                <a:tc>
+                  <a:txBody>
+                    <a:bodyPr/>
+                    <a:lstStyle/>
+                    <a:p>
+                      <a:pPr algn="r" indent="0" marL="0">
+                        <a:buNone/>
+                      </a:pPr>
+                      <a:r>
+                        <a:rPr lang="en-US" sz="1300" b="1" dirty="0">
+                          <a:solidFill>
+                            <a:srgbClr val="1A1A1A"/>
+                          </a:solidFill>
+                          <a:latin typeface="Calibri" pitchFamily="34" charset="0"/>
+                          <a:ea typeface="Calibri" pitchFamily="34" charset="-122"/>
+                          <a:cs typeface="Calibri" pitchFamily="34" charset="-120"/>
+                        </a:rPr>
+                        <a:t>742</a:t>
+                      </a:r>
+                      <a:endParaRPr lang="en-US" sz="1300" dirty="0">
+                        <a:latin typeface="Calibri" charset="0"/>
+                        <a:ea typeface="Calibri" charset="0"/>
+                        <a:cs typeface="Calibri" charset="0"/>
+                      </a:endParaRPr>
+                    </a:p>
+                  </a:txBody>
+                  <a:tcPr marL="91440" marR="91440" marT="27432" marB="27432" anchor="ctr">
+                    <a:lnL w="0" cap="flat" cmpd="sng" algn="ctr">
+                      <a:noFill/>
+                    </a:lnL>
+                    <a:lnR w="0" cap="flat" cmpd="sng" algn="ctr">
+                      <a:noFill/>
+                    </a:lnR>
+                    <a:lnT w="0" cap="flat" cmpd="sng" algn="ctr">
+                      <a:noFill/>
+                    </a:lnT>
+                    <a:lnB w="9525" cap="flat" cmpd="sng" algn="ctr">
+                      <a:solidFill>
+                        <a:srgbClr val="E5E7EB"/>
+                      </a:solidFill>
+                      <a:prstDash val="solid"/>
+                      <a:round/>
+                      <a:headEnd type="none" w="med" len="med"/>
+                      <a:tailEnd type="none" w="med" len="med"/>
+                    </a:lnB>
+                  </a:tcPr>
+                </a:tc>
+              </a:tr>
+            </a:tbl>
           </a:graphicData>
         </a:graphic>
       </p:graphicFrame>

</xml_diff>

<commit_message>
Slide 7: tables only, caveat as a callout
Co-Authored-By: Claude Opus 5.5 (1M context) <noreply@anthropic.com>
Claude-Session: https://claude.ai/code/session_01JZtuYERhuCe7nB9VYHwcfv
</commit_message>
<xml_diff>
--- a/presentation/bed-rest-to-mars-talk.pptx
+++ b/presentation/bed-rest-to-mars-talk.pptx
@@ -125,13 +125,13 @@
   <p:extLst>
     <p:ext uri="{521415D9-36F7-43E2-AB2F-B90AF26B5E84}">
       <p14:sectionLst xmlns:p14="http://schemas.microsoft.com/office/powerpoint/2010/main">
-        <p14:section name="Opening" id="{651a0c56-705e-22fb-1095-a5ebcfba93af}">
+        <p14:section name="Opening" id="{f860d6cb-0d50-dc31-f7ca-22743eedf205}">
           <p14:sldIdLst>
             <p14:sldId id="256"/>
             <p14:sldId id="257"/>
           </p14:sldIdLst>
         </p14:section>
-        <p14:section name="Part 1" id="{6bbe44c9-ad18-16e2-8362-5b485b5d125f}">
+        <p14:section name="Part 1" id="{aa60e39c-637c-1712-5ddd-f5974cb4ef14}">
           <p14:sldIdLst>
             <p14:sldId id="258"/>
             <p14:sldId id="259"/>
@@ -141,7 +141,7 @@
             <p14:sldId id="263"/>
           </p14:sldIdLst>
         </p14:section>
-        <p14:section name="Part 2" id="{eb6e1c5a-384e-103f-0735-dd16ec5cd5ef}">
+        <p14:section name="Part 2" id="{a21d90e0-87d5-9f15-3b14-899fd4a1c019}">
           <p14:sldIdLst>
             <p14:sldId id="264"/>
             <p14:sldId id="265"/>
@@ -152,7 +152,7 @@
             <p14:sldId id="270"/>
           </p14:sldIdLst>
         </p14:section>
-        <p14:section name="Backup" id="{6c2fc589-fa4f-32f8-554b-35c268ac8fef}">
+        <p14:section name="Backup" id="{aed73a93-cd1a-66a8-3960-3694dcbe9438}">
           <p14:sldIdLst>
             <p14:sldId id="271"/>
             <p14:sldId id="272"/>
@@ -160,13 +160,13 @@
             <p14:sldId id="274"/>
           </p14:sldIdLst>
         </p14:section>
-        <p14:section name="Backup" id="{8af084f3-70b1-c163-5858-4d7c8c321f3e}">
+        <p14:section name="Backup" id="{70a7aae6-7b55-3a5b-84f6-5c287df1a9e2}">
           <p14:sldIdLst/>
         </p14:section>
-        <p14:section name="Backup" id="{5d6f23a0-0fd6-99cc-2846-18b2f8190f68}">
+        <p14:section name="Backup" id="{2f076825-ecf4-d845-2394-b0eb9bf2fd1f}">
           <p14:sldIdLst/>
         </p14:section>
-        <p14:section name="Backup" id="{f24f3d41-693c-2338-1d24-cf8d9d9e872b}">
+        <p14:section name="Backup" id="{ce9d4330-8a3a-3cc3-d3a3-49ff1e6c991a}">
           <p14:sldIdLst/>
         </p14:section>
       </p14:sectionLst>
@@ -5143,7 +5143,7 @@
               <a:rPr lang="en-US" dirty="0"/>
               <a:t>Part 1 (Niloufar), about one minute.
 The final dataset has 742 rows. Each row is one muscle outcome: one muscle, in one group, at one scan day. One campaign can therefore give many rows, for several muscles, time points or groups.
-The top strip is a real row. For each outcome we extracted the length of unloading, the day of the scan, the muscle, the participants (group size, share of women, age), whether the group had a countermeasure, the imaging method, and how muscle size was measured. Our prediction target is the percentage change in muscle size from baseline, here minus 9.4 percent.
+For each outcome we extracted the length of unloading, the day of the scan, the muscle, the participants (group size, share of women, age), whether the group had a countermeasure, the imaging method, and how muscle size was measured. Our prediction target is the percentage change in muscle size from baseline.
 Left table: 742 rows from 52 studies and 36 independent campaigns, covering 51 muscles or muscle groups; 470 rows are control groups and 272 countermeasure groups; 478 were measured during bed rest and 264 in recovery. 742 rows does not mean 742 people: one campaign gives rows for several muscles, groups and scan days.
 Right table: most rows are MRI volumes. CT gives cross-sectional area, DXA gives lean mass of the leg, and ultrasound gives thickness or area.</a:t>
             </a:r>
@@ -19347,874 +19347,7 @@
         </p:nvSpPr>
         <p:spPr>
           <a:xfrm>
-            <a:off x="548640" y="1143000"/>
-            <a:ext cx="11064240" cy="292608"/>
-          </a:xfrm>
-          <a:prstGeom prst="rect">
-            <a:avLst/>
-          </a:prstGeom>
-          <a:noFill/>
-          <a:ln/>
-        </p:spPr>
-        <p:txBody>
-          <a:bodyPr wrap="square" lIns="0" tIns="0" rIns="0" bIns="0" rtlCol="0" anchor="t"/>
-          <a:lstStyle/>
-          <a:p>
-            <a:pPr indent="0" marL="0">
-              <a:buNone/>
-            </a:pPr>
-            <a:r>
-              <a:rPr lang="en-US" sz="1500" b="1" dirty="0">
-                <a:solidFill>
-                  <a:schemeClr val="tx2"/>
-                </a:solidFill>
-              </a:rPr>
-              <a:t>One row = one muscle outcome of one group at one scan day</a:t>
-            </a:r>
-            <a:endParaRPr lang="en-US" sz="1500" dirty="0"/>
-          </a:p>
-        </p:txBody>
-      </p:sp>
-      <p:sp>
-        <p:nvSpPr>
-          <p:cNvPr id="12" name="Text 10"/>
-          <p:cNvSpPr txBox="1"/>
-          <p:nvPr/>
-        </p:nvSpPr>
-        <p:spPr>
-          <a:xfrm>
-            <a:off x="548640" y="1536192"/>
-            <a:ext cx="1097280" cy="228600"/>
-          </a:xfrm>
-          <a:prstGeom prst="rect">
-            <a:avLst/>
-          </a:prstGeom>
-          <a:noFill/>
-          <a:ln/>
-        </p:spPr>
-        <p:txBody>
-          <a:bodyPr wrap="square" lIns="0" tIns="0" rIns="0" bIns="0" rtlCol="0" anchor="t"/>
-          <a:lstStyle/>
-          <a:p>
-            <a:pPr algn="ctr" indent="0" marL="0">
-              <a:buNone/>
-            </a:pPr>
-            <a:r>
-              <a:rPr lang="en-US" sz="1050" dirty="0">
-                <a:solidFill>
-                  <a:schemeClr val="accent3"/>
-                </a:solidFill>
-              </a:rPr>
-              <a:t>Unloading</a:t>
-            </a:r>
-            <a:endParaRPr lang="en-US" sz="1050" dirty="0"/>
-          </a:p>
-        </p:txBody>
-      </p:sp>
-      <p:sp>
-        <p:nvSpPr>
-          <p:cNvPr id="13" name="Field Unloading"/>
-          <p:cNvSpPr/>
-          <p:nvPr/>
-        </p:nvSpPr>
-        <p:spPr>
-          <a:xfrm>
-            <a:off x="548640" y="1783080"/>
-            <a:ext cx="1097280" cy="457200"/>
-          </a:xfrm>
-          <a:prstGeom prst="rect">
-            <a:avLst/>
-          </a:prstGeom>
-          <a:solidFill>
-            <a:srgbClr val="FFFFFF"/>
-          </a:solidFill>
-          <a:ln w="12700">
-            <a:solidFill>
-              <a:srgbClr val="9AA3AE"/>
-            </a:solidFill>
-            <a:prstDash val="solid"/>
-          </a:ln>
-        </p:spPr>
-      </p:sp>
-      <p:sp>
-        <p:nvSpPr>
-          <p:cNvPr id="14" name="Text 12"/>
-          <p:cNvSpPr txBox="1"/>
-          <p:nvPr/>
-        </p:nvSpPr>
-        <p:spPr>
-          <a:xfrm>
-            <a:off x="548640" y="1783080"/>
-            <a:ext cx="1097280" cy="457200"/>
-          </a:xfrm>
-          <a:prstGeom prst="rect">
-            <a:avLst/>
-          </a:prstGeom>
-          <a:noFill/>
-          <a:ln/>
-        </p:spPr>
-        <p:txBody>
-          <a:bodyPr wrap="square" lIns="0" tIns="0" rIns="0" bIns="0" rtlCol="0" anchor="ctr"/>
-          <a:lstStyle/>
-          <a:p>
-            <a:pPr algn="ctr" indent="0" marL="0">
-              <a:buNone/>
-            </a:pPr>
-            <a:r>
-              <a:rPr lang="en-US" sz="1250" dirty="0">
-                <a:solidFill>
-                  <a:schemeClr val="tx1"/>
-                </a:solidFill>
-              </a:rPr>
-              <a:t>60 days</a:t>
-            </a:r>
-            <a:endParaRPr lang="en-US" sz="1250" dirty="0"/>
-          </a:p>
-        </p:txBody>
-      </p:sp>
-      <p:sp>
-        <p:nvSpPr>
-          <p:cNvPr id="15" name="Text 13"/>
-          <p:cNvSpPr txBox="1"/>
-          <p:nvPr/>
-        </p:nvSpPr>
-        <p:spPr>
-          <a:xfrm>
-            <a:off x="1682496" y="1536192"/>
-            <a:ext cx="868680" cy="228600"/>
-          </a:xfrm>
-          <a:prstGeom prst="rect">
-            <a:avLst/>
-          </a:prstGeom>
-          <a:noFill/>
-          <a:ln/>
-        </p:spPr>
-        <p:txBody>
-          <a:bodyPr wrap="square" lIns="0" tIns="0" rIns="0" bIns="0" rtlCol="0" anchor="t"/>
-          <a:lstStyle/>
-          <a:p>
-            <a:pPr algn="ctr" indent="0" marL="0">
-              <a:buNone/>
-            </a:pPr>
-            <a:r>
-              <a:rPr lang="en-US" sz="1050" dirty="0">
-                <a:solidFill>
-                  <a:schemeClr val="accent3"/>
-                </a:solidFill>
-              </a:rPr>
-              <a:t>Scan day</a:t>
-            </a:r>
-            <a:endParaRPr lang="en-US" sz="1050" dirty="0"/>
-          </a:p>
-        </p:txBody>
-      </p:sp>
-      <p:sp>
-        <p:nvSpPr>
-          <p:cNvPr id="16" name="Field Scan day"/>
-          <p:cNvSpPr/>
-          <p:nvPr/>
-        </p:nvSpPr>
-        <p:spPr>
-          <a:xfrm>
-            <a:off x="1682496" y="1783080"/>
-            <a:ext cx="868680" cy="457200"/>
-          </a:xfrm>
-          <a:prstGeom prst="rect">
-            <a:avLst/>
-          </a:prstGeom>
-          <a:solidFill>
-            <a:srgbClr val="FFFFFF"/>
-          </a:solidFill>
-          <a:ln w="12700">
-            <a:solidFill>
-              <a:srgbClr val="9AA3AE"/>
-            </a:solidFill>
-            <a:prstDash val="solid"/>
-          </a:ln>
-        </p:spPr>
-      </p:sp>
-      <p:sp>
-        <p:nvSpPr>
-          <p:cNvPr id="17" name="Text 15"/>
-          <p:cNvSpPr txBox="1"/>
-          <p:nvPr/>
-        </p:nvSpPr>
-        <p:spPr>
-          <a:xfrm>
-            <a:off x="1682496" y="1783080"/>
-            <a:ext cx="868680" cy="457200"/>
-          </a:xfrm>
-          <a:prstGeom prst="rect">
-            <a:avLst/>
-          </a:prstGeom>
-          <a:noFill/>
-          <a:ln/>
-        </p:spPr>
-        <p:txBody>
-          <a:bodyPr wrap="square" lIns="0" tIns="0" rIns="0" bIns="0" rtlCol="0" anchor="ctr"/>
-          <a:lstStyle/>
-          <a:p>
-            <a:pPr algn="ctr" indent="0" marL="0">
-              <a:buNone/>
-            </a:pPr>
-            <a:r>
-              <a:rPr lang="en-US" sz="1250" dirty="0">
-                <a:solidFill>
-                  <a:schemeClr val="tx1"/>
-                </a:solidFill>
-              </a:rPr>
-              <a:t>59</a:t>
-            </a:r>
-            <a:endParaRPr lang="en-US" sz="1250" dirty="0"/>
-          </a:p>
-        </p:txBody>
-      </p:sp>
-      <p:sp>
-        <p:nvSpPr>
-          <p:cNvPr id="18" name="Text 16"/>
-          <p:cNvSpPr txBox="1"/>
-          <p:nvPr/>
-        </p:nvSpPr>
-        <p:spPr>
-          <a:xfrm>
-            <a:off x="2587752" y="1536192"/>
-            <a:ext cx="1508760" cy="228600"/>
-          </a:xfrm>
-          <a:prstGeom prst="rect">
-            <a:avLst/>
-          </a:prstGeom>
-          <a:noFill/>
-          <a:ln/>
-        </p:spPr>
-        <p:txBody>
-          <a:bodyPr wrap="square" lIns="0" tIns="0" rIns="0" bIns="0" rtlCol="0" anchor="t"/>
-          <a:lstStyle/>
-          <a:p>
-            <a:pPr algn="ctr" indent="0" marL="0">
-              <a:buNone/>
-            </a:pPr>
-            <a:r>
-              <a:rPr lang="en-US" sz="1050" dirty="0">
-                <a:solidFill>
-                  <a:schemeClr val="accent3"/>
-                </a:solidFill>
-              </a:rPr>
-              <a:t>Muscle</a:t>
-            </a:r>
-            <a:endParaRPr lang="en-US" sz="1050" dirty="0"/>
-          </a:p>
-        </p:txBody>
-      </p:sp>
-      <p:sp>
-        <p:nvSpPr>
-          <p:cNvPr id="19" name="Field Muscle"/>
-          <p:cNvSpPr/>
-          <p:nvPr/>
-        </p:nvSpPr>
-        <p:spPr>
-          <a:xfrm>
-            <a:off x="2587752" y="1783080"/>
-            <a:ext cx="1508760" cy="457200"/>
-          </a:xfrm>
-          <a:prstGeom prst="rect">
-            <a:avLst/>
-          </a:prstGeom>
-          <a:solidFill>
-            <a:srgbClr val="FFFFFF"/>
-          </a:solidFill>
-          <a:ln w="12700">
-            <a:solidFill>
-              <a:srgbClr val="9AA3AE"/>
-            </a:solidFill>
-            <a:prstDash val="solid"/>
-          </a:ln>
-        </p:spPr>
-      </p:sp>
-      <p:sp>
-        <p:nvSpPr>
-          <p:cNvPr id="20" name="Text 18"/>
-          <p:cNvSpPr txBox="1"/>
-          <p:nvPr/>
-        </p:nvSpPr>
-        <p:spPr>
-          <a:xfrm>
-            <a:off x="2587752" y="1783080"/>
-            <a:ext cx="1508760" cy="457200"/>
-          </a:xfrm>
-          <a:prstGeom prst="rect">
-            <a:avLst/>
-          </a:prstGeom>
-          <a:noFill/>
-          <a:ln/>
-        </p:spPr>
-        <p:txBody>
-          <a:bodyPr wrap="square" lIns="0" tIns="0" rIns="0" bIns="0" rtlCol="0" anchor="ctr"/>
-          <a:lstStyle/>
-          <a:p>
-            <a:pPr algn="ctr" indent="0" marL="0">
-              <a:buNone/>
-            </a:pPr>
-            <a:r>
-              <a:rPr lang="en-US" sz="1250" dirty="0">
-                <a:solidFill>
-                  <a:schemeClr val="tx1"/>
-                </a:solidFill>
-              </a:rPr>
-              <a:t>gluteus maximus</a:t>
-            </a:r>
-            <a:endParaRPr lang="en-US" sz="1250" dirty="0"/>
-          </a:p>
-        </p:txBody>
-      </p:sp>
-      <p:sp>
-        <p:nvSpPr>
-          <p:cNvPr id="21" name="Text 19"/>
-          <p:cNvSpPr txBox="1"/>
-          <p:nvPr/>
-        </p:nvSpPr>
-        <p:spPr>
-          <a:xfrm>
-            <a:off x="4133088" y="1536192"/>
-            <a:ext cx="1965960" cy="228600"/>
-          </a:xfrm>
-          <a:prstGeom prst="rect">
-            <a:avLst/>
-          </a:prstGeom>
-          <a:noFill/>
-          <a:ln/>
-        </p:spPr>
-        <p:txBody>
-          <a:bodyPr wrap="square" lIns="0" tIns="0" rIns="0" bIns="0" rtlCol="0" anchor="t"/>
-          <a:lstStyle/>
-          <a:p>
-            <a:pPr algn="ctr" indent="0" marL="0">
-              <a:buNone/>
-            </a:pPr>
-            <a:r>
-              <a:rPr lang="en-US" sz="1050" dirty="0">
-                <a:solidFill>
-                  <a:schemeClr val="accent3"/>
-                </a:solidFill>
-              </a:rPr>
-              <a:t>Participants</a:t>
-            </a:r>
-            <a:endParaRPr lang="en-US" sz="1050" dirty="0"/>
-          </a:p>
-        </p:txBody>
-      </p:sp>
-      <p:sp>
-        <p:nvSpPr>
-          <p:cNvPr id="22" name="Field Participants"/>
-          <p:cNvSpPr/>
-          <p:nvPr/>
-        </p:nvSpPr>
-        <p:spPr>
-          <a:xfrm>
-            <a:off x="4133088" y="1783080"/>
-            <a:ext cx="1965960" cy="457200"/>
-          </a:xfrm>
-          <a:prstGeom prst="rect">
-            <a:avLst/>
-          </a:prstGeom>
-          <a:solidFill>
-            <a:srgbClr val="FFFFFF"/>
-          </a:solidFill>
-          <a:ln w="12700">
-            <a:solidFill>
-              <a:srgbClr val="9AA3AE"/>
-            </a:solidFill>
-            <a:prstDash val="solid"/>
-          </a:ln>
-        </p:spPr>
-      </p:sp>
-      <p:sp>
-        <p:nvSpPr>
-          <p:cNvPr id="23" name="Text 21"/>
-          <p:cNvSpPr txBox="1"/>
-          <p:nvPr/>
-        </p:nvSpPr>
-        <p:spPr>
-          <a:xfrm>
-            <a:off x="4133088" y="1783080"/>
-            <a:ext cx="1965960" cy="457200"/>
-          </a:xfrm>
-          <a:prstGeom prst="rect">
-            <a:avLst/>
-          </a:prstGeom>
-          <a:noFill/>
-          <a:ln/>
-        </p:spPr>
-        <p:txBody>
-          <a:bodyPr wrap="square" lIns="0" tIns="0" rIns="0" bIns="0" rtlCol="0" anchor="ctr"/>
-          <a:lstStyle/>
-          <a:p>
-            <a:pPr algn="ctr" indent="0" marL="0">
-              <a:buNone/>
-            </a:pPr>
-            <a:r>
-              <a:rPr lang="en-US" sz="1250" dirty="0">
-                <a:solidFill>
-                  <a:schemeClr val="tx1"/>
-                </a:solidFill>
-              </a:rPr>
-              <a:t>8; 25% women; age 34</a:t>
-            </a:r>
-            <a:endParaRPr lang="en-US" sz="1250" dirty="0"/>
-          </a:p>
-        </p:txBody>
-      </p:sp>
-      <p:sp>
-        <p:nvSpPr>
-          <p:cNvPr id="24" name="Text 22"/>
-          <p:cNvSpPr txBox="1"/>
-          <p:nvPr/>
-        </p:nvSpPr>
-        <p:spPr>
-          <a:xfrm>
-            <a:off x="6135624" y="1536192"/>
-            <a:ext cx="1417320" cy="228600"/>
-          </a:xfrm>
-          <a:prstGeom prst="rect">
-            <a:avLst/>
-          </a:prstGeom>
-          <a:noFill/>
-          <a:ln/>
-        </p:spPr>
-        <p:txBody>
-          <a:bodyPr wrap="square" lIns="0" tIns="0" rIns="0" bIns="0" rtlCol="0" anchor="t"/>
-          <a:lstStyle/>
-          <a:p>
-            <a:pPr algn="ctr" indent="0" marL="0">
-              <a:buNone/>
-            </a:pPr>
-            <a:r>
-              <a:rPr lang="en-US" sz="1050" dirty="0">
-                <a:solidFill>
-                  <a:schemeClr val="accent3"/>
-                </a:solidFill>
-              </a:rPr>
-              <a:t>Countermeasure</a:t>
-            </a:r>
-            <a:endParaRPr lang="en-US" sz="1050" dirty="0"/>
-          </a:p>
-        </p:txBody>
-      </p:sp>
-      <p:sp>
-        <p:nvSpPr>
-          <p:cNvPr id="25" name="Field Countermeasure"/>
-          <p:cNvSpPr/>
-          <p:nvPr/>
-        </p:nvSpPr>
-        <p:spPr>
-          <a:xfrm>
-            <a:off x="6135624" y="1783080"/>
-            <a:ext cx="1417320" cy="457200"/>
-          </a:xfrm>
-          <a:prstGeom prst="rect">
-            <a:avLst/>
-          </a:prstGeom>
-          <a:solidFill>
-            <a:srgbClr val="FFFFFF"/>
-          </a:solidFill>
-          <a:ln w="12700">
-            <a:solidFill>
-              <a:srgbClr val="9AA3AE"/>
-            </a:solidFill>
-            <a:prstDash val="solid"/>
-          </a:ln>
-        </p:spPr>
-      </p:sp>
-      <p:sp>
-        <p:nvSpPr>
-          <p:cNvPr id="26" name="Text 24"/>
-          <p:cNvSpPr txBox="1"/>
-          <p:nvPr/>
-        </p:nvSpPr>
-        <p:spPr>
-          <a:xfrm>
-            <a:off x="6135624" y="1783080"/>
-            <a:ext cx="1417320" cy="457200"/>
-          </a:xfrm>
-          <a:prstGeom prst="rect">
-            <a:avLst/>
-          </a:prstGeom>
-          <a:noFill/>
-          <a:ln/>
-        </p:spPr>
-        <p:txBody>
-          <a:bodyPr wrap="square" lIns="0" tIns="0" rIns="0" bIns="0" rtlCol="0" anchor="ctr"/>
-          <a:lstStyle/>
-          <a:p>
-            <a:pPr algn="ctr" indent="0" marL="0">
-              <a:buNone/>
-            </a:pPr>
-            <a:r>
-              <a:rPr lang="en-US" sz="1250" dirty="0">
-                <a:solidFill>
-                  <a:schemeClr val="tx1"/>
-                </a:solidFill>
-              </a:rPr>
-              <a:t>none (control)</a:t>
-            </a:r>
-            <a:endParaRPr lang="en-US" sz="1250" dirty="0"/>
-          </a:p>
-        </p:txBody>
-      </p:sp>
-      <p:sp>
-        <p:nvSpPr>
-          <p:cNvPr id="27" name="Text 25"/>
-          <p:cNvSpPr txBox="1"/>
-          <p:nvPr/>
-        </p:nvSpPr>
-        <p:spPr>
-          <a:xfrm>
-            <a:off x="7589520" y="1536192"/>
-            <a:ext cx="822960" cy="228600"/>
-          </a:xfrm>
-          <a:prstGeom prst="rect">
-            <a:avLst/>
-          </a:prstGeom>
-          <a:noFill/>
-          <a:ln/>
-        </p:spPr>
-        <p:txBody>
-          <a:bodyPr wrap="square" lIns="0" tIns="0" rIns="0" bIns="0" rtlCol="0" anchor="t"/>
-          <a:lstStyle/>
-          <a:p>
-            <a:pPr algn="ctr" indent="0" marL="0">
-              <a:buNone/>
-            </a:pPr>
-            <a:r>
-              <a:rPr lang="en-US" sz="1050" dirty="0">
-                <a:solidFill>
-                  <a:schemeClr val="accent3"/>
-                </a:solidFill>
-              </a:rPr>
-              <a:t>Method</a:t>
-            </a:r>
-            <a:endParaRPr lang="en-US" sz="1050" dirty="0"/>
-          </a:p>
-        </p:txBody>
-      </p:sp>
-      <p:sp>
-        <p:nvSpPr>
-          <p:cNvPr id="28" name="Field Method"/>
-          <p:cNvSpPr/>
-          <p:nvPr/>
-        </p:nvSpPr>
-        <p:spPr>
-          <a:xfrm>
-            <a:off x="7589520" y="1783080"/>
-            <a:ext cx="822960" cy="457200"/>
-          </a:xfrm>
-          <a:prstGeom prst="rect">
-            <a:avLst/>
-          </a:prstGeom>
-          <a:solidFill>
-            <a:srgbClr val="FFFFFF"/>
-          </a:solidFill>
-          <a:ln w="12700">
-            <a:solidFill>
-              <a:srgbClr val="9AA3AE"/>
-            </a:solidFill>
-            <a:prstDash val="solid"/>
-          </a:ln>
-        </p:spPr>
-      </p:sp>
-      <p:sp>
-        <p:nvSpPr>
-          <p:cNvPr id="29" name="Text 27"/>
-          <p:cNvSpPr txBox="1"/>
-          <p:nvPr/>
-        </p:nvSpPr>
-        <p:spPr>
-          <a:xfrm>
-            <a:off x="7589520" y="1783080"/>
-            <a:ext cx="822960" cy="457200"/>
-          </a:xfrm>
-          <a:prstGeom prst="rect">
-            <a:avLst/>
-          </a:prstGeom>
-          <a:noFill/>
-          <a:ln/>
-        </p:spPr>
-        <p:txBody>
-          <a:bodyPr wrap="square" lIns="0" tIns="0" rIns="0" bIns="0" rtlCol="0" anchor="ctr"/>
-          <a:lstStyle/>
-          <a:p>
-            <a:pPr algn="ctr" indent="0" marL="0">
-              <a:buNone/>
-            </a:pPr>
-            <a:r>
-              <a:rPr lang="en-US" sz="1250" dirty="0">
-                <a:solidFill>
-                  <a:schemeClr val="tx1"/>
-                </a:solidFill>
-              </a:rPr>
-              <a:t>MRI</a:t>
-            </a:r>
-            <a:endParaRPr lang="en-US" sz="1250" dirty="0"/>
-          </a:p>
-        </p:txBody>
-      </p:sp>
-      <p:sp>
-        <p:nvSpPr>
-          <p:cNvPr id="30" name="Text 28"/>
-          <p:cNvSpPr txBox="1"/>
-          <p:nvPr/>
-        </p:nvSpPr>
-        <p:spPr>
-          <a:xfrm>
-            <a:off x="8449056" y="1536192"/>
-            <a:ext cx="1051560" cy="228600"/>
-          </a:xfrm>
-          <a:prstGeom prst="rect">
-            <a:avLst/>
-          </a:prstGeom>
-          <a:noFill/>
-          <a:ln/>
-        </p:spPr>
-        <p:txBody>
-          <a:bodyPr wrap="square" lIns="0" tIns="0" rIns="0" bIns="0" rtlCol="0" anchor="t"/>
-          <a:lstStyle/>
-          <a:p>
-            <a:pPr algn="ctr" indent="0" marL="0">
-              <a:buNone/>
-            </a:pPr>
-            <a:r>
-              <a:rPr lang="en-US" sz="1050" dirty="0">
-                <a:solidFill>
-                  <a:schemeClr val="accent3"/>
-                </a:solidFill>
-              </a:rPr>
-              <a:t>Size measure</a:t>
-            </a:r>
-            <a:endParaRPr lang="en-US" sz="1050" dirty="0"/>
-          </a:p>
-        </p:txBody>
-      </p:sp>
-      <p:sp>
-        <p:nvSpPr>
-          <p:cNvPr id="31" name="Field Size measure"/>
-          <p:cNvSpPr/>
-          <p:nvPr/>
-        </p:nvSpPr>
-        <p:spPr>
-          <a:xfrm>
-            <a:off x="8449056" y="1783080"/>
-            <a:ext cx="1051560" cy="457200"/>
-          </a:xfrm>
-          <a:prstGeom prst="rect">
-            <a:avLst/>
-          </a:prstGeom>
-          <a:solidFill>
-            <a:srgbClr val="FFFFFF"/>
-          </a:solidFill>
-          <a:ln w="12700">
-            <a:solidFill>
-              <a:srgbClr val="9AA3AE"/>
-            </a:solidFill>
-            <a:prstDash val="solid"/>
-          </a:ln>
-        </p:spPr>
-      </p:sp>
-      <p:sp>
-        <p:nvSpPr>
-          <p:cNvPr id="32" name="Text 30"/>
-          <p:cNvSpPr txBox="1"/>
-          <p:nvPr/>
-        </p:nvSpPr>
-        <p:spPr>
-          <a:xfrm>
-            <a:off x="8449056" y="1783080"/>
-            <a:ext cx="1051560" cy="457200"/>
-          </a:xfrm>
-          <a:prstGeom prst="rect">
-            <a:avLst/>
-          </a:prstGeom>
-          <a:noFill/>
-          <a:ln/>
-        </p:spPr>
-        <p:txBody>
-          <a:bodyPr wrap="square" lIns="0" tIns="0" rIns="0" bIns="0" rtlCol="0" anchor="ctr"/>
-          <a:lstStyle/>
-          <a:p>
-            <a:pPr algn="ctr" indent="0" marL="0">
-              <a:buNone/>
-            </a:pPr>
-            <a:r>
-              <a:rPr lang="en-US" sz="1250" dirty="0">
-                <a:solidFill>
-                  <a:schemeClr val="tx1"/>
-                </a:solidFill>
-              </a:rPr>
-              <a:t>volume</a:t>
-            </a:r>
-            <a:endParaRPr lang="en-US" sz="1250" dirty="0"/>
-          </a:p>
-        </p:txBody>
-      </p:sp>
-      <p:sp>
-        <p:nvSpPr>
-          <p:cNvPr id="33" name="Row to target"/>
-          <p:cNvSpPr/>
-          <p:nvPr/>
-        </p:nvSpPr>
-        <p:spPr>
-          <a:xfrm>
-            <a:off x="9592056" y="2011680"/>
-            <a:ext cx="384048" cy="0"/>
-          </a:xfrm>
-          <a:prstGeom prst="line">
-            <a:avLst/>
-          </a:prstGeom>
-          <a:noFill/>
-          <a:ln w="15875">
-            <a:solidFill>
-              <a:srgbClr val="1A1A1A"/>
-            </a:solidFill>
-            <a:prstDash val="solid"/>
-            <a:tailEnd type="triangle"/>
-          </a:ln>
-        </p:spPr>
-      </p:sp>
-      <p:sp>
-        <p:nvSpPr>
-          <p:cNvPr id="34" name="Text 32"/>
-          <p:cNvSpPr txBox="1"/>
-          <p:nvPr/>
-        </p:nvSpPr>
-        <p:spPr>
-          <a:xfrm>
-            <a:off x="9765792" y="1536192"/>
-            <a:ext cx="1847088" cy="228600"/>
-          </a:xfrm>
-          <a:prstGeom prst="rect">
-            <a:avLst/>
-          </a:prstGeom>
-          <a:noFill/>
-          <a:ln/>
-        </p:spPr>
-        <p:txBody>
-          <a:bodyPr wrap="square" lIns="0" tIns="0" rIns="0" bIns="0" rtlCol="0" anchor="t"/>
-          <a:lstStyle/>
-          <a:p>
-            <a:pPr algn="ctr" indent="0" marL="0">
-              <a:buNone/>
-            </a:pPr>
-            <a:r>
-              <a:rPr lang="en-US" sz="1050" b="1" dirty="0">
-                <a:solidFill>
-                  <a:schemeClr val="accent1"/>
-                </a:solidFill>
-              </a:rPr>
-              <a:t>Target: % change</a:t>
-            </a:r>
-            <a:endParaRPr lang="en-US" sz="1050" dirty="0"/>
-          </a:p>
-        </p:txBody>
-      </p:sp>
-      <p:sp>
-        <p:nvSpPr>
-          <p:cNvPr id="35" name="Target"/>
-          <p:cNvSpPr/>
-          <p:nvPr/>
-        </p:nvSpPr>
-        <p:spPr>
-          <a:xfrm>
-            <a:off x="10040112" y="1783080"/>
-            <a:ext cx="1572768" cy="457200"/>
-          </a:xfrm>
-          <a:prstGeom prst="rect">
-            <a:avLst/>
-          </a:prstGeom>
-          <a:solidFill>
-            <a:srgbClr val="A23B2A"/>
-          </a:solidFill>
-          <a:ln/>
-        </p:spPr>
-      </p:sp>
-      <p:sp>
-        <p:nvSpPr>
-          <p:cNvPr id="36" name="Text 34"/>
-          <p:cNvSpPr txBox="1"/>
-          <p:nvPr/>
-        </p:nvSpPr>
-        <p:spPr>
-          <a:xfrm>
-            <a:off x="10040112" y="1783080"/>
-            <a:ext cx="1572768" cy="457200"/>
-          </a:xfrm>
-          <a:prstGeom prst="rect">
-            <a:avLst/>
-          </a:prstGeom>
-          <a:noFill/>
-          <a:ln/>
-        </p:spPr>
-        <p:txBody>
-          <a:bodyPr wrap="square" lIns="0" tIns="0" rIns="0" bIns="0" rtlCol="0" anchor="ctr"/>
-          <a:lstStyle/>
-          <a:p>
-            <a:pPr algn="ctr" indent="0" marL="0">
-              <a:buNone/>
-            </a:pPr>
-            <a:r>
-              <a:rPr lang="en-US" sz="1600" b="1" dirty="0">
-                <a:solidFill>
-                  <a:schemeClr val="bg1"/>
-                </a:solidFill>
-              </a:rPr>
-              <a:t>−9.4%</a:t>
-            </a:r>
-            <a:endParaRPr lang="en-US" sz="1600" dirty="0"/>
-          </a:p>
-        </p:txBody>
-      </p:sp>
-      <p:sp>
-        <p:nvSpPr>
-          <p:cNvPr id="37" name="Text 35"/>
-          <p:cNvSpPr txBox="1"/>
-          <p:nvPr/>
-        </p:nvSpPr>
-        <p:spPr>
-          <a:xfrm>
-            <a:off x="548640" y="2313432"/>
-            <a:ext cx="11064240" cy="228600"/>
-          </a:xfrm>
-          <a:prstGeom prst="rect">
-            <a:avLst/>
-          </a:prstGeom>
-          <a:noFill/>
-          <a:ln/>
-        </p:spPr>
-        <p:txBody>
-          <a:bodyPr wrap="square" lIns="0" tIns="0" rIns="0" bIns="0" rtlCol="0" anchor="t"/>
-          <a:lstStyle/>
-          <a:p>
-            <a:pPr indent="0" marL="0">
-              <a:buNone/>
-            </a:pPr>
-            <a:r>
-              <a:rPr lang="en-US" sz="1050" i="1" dirty="0">
-                <a:solidFill>
-                  <a:schemeClr val="accent3"/>
-                </a:solidFill>
-              </a:rPr>
-              <a:t>Example row from the AGBRESA bed-rest campaign (Tran et al., 2021). Target: percentage change in muscle size from before unloading.</a:t>
-            </a:r>
-            <a:endParaRPr lang="en-US" sz="1050" dirty="0"/>
-          </a:p>
-        </p:txBody>
-      </p:sp>
-      <p:sp>
-        <p:nvSpPr>
-          <p:cNvPr id="38" name="Text 36"/>
-          <p:cNvSpPr txBox="1"/>
-          <p:nvPr/>
-        </p:nvSpPr>
-        <p:spPr>
-          <a:xfrm>
-            <a:off x="548640" y="2697480"/>
+            <a:off x="548640" y="1325880"/>
             <a:ext cx="5394960" cy="292608"/>
           </a:xfrm>
           <a:prstGeom prst="rect">
@@ -20257,7 +19390,7 @@
           </p:nvPr>
         </p:nvGraphicFramePr>
         <p:xfrm>
-          <a:off x="548640" y="3063240"/>
+          <a:off x="548640" y="1737360"/>
           <a:ext cx="5394960" cy="914400"/>
         </p:xfrm>
         <a:graphic>
@@ -20268,7 +19401,7 @@
                 <a:gridCol w="3749040"/>
                 <a:gridCol w="1645920"/>
               </a:tblGrid>
-              <a:tr h="365760">
+              <a:tr h="457200">
                 <a:tc>
                   <a:txBody>
                     <a:bodyPr/>
@@ -20370,7 +19503,7 @@
                   </a:tcPr>
                 </a:tc>
               </a:tr>
-              <a:tr h="365760">
+              <a:tr h="457200">
                 <a:tc>
                   <a:txBody>
                     <a:bodyPr/>
@@ -20466,7 +19599,7 @@
                   </a:tcPr>
                 </a:tc>
               </a:tr>
-              <a:tr h="365760">
+              <a:tr h="457200">
                 <a:tc>
                   <a:txBody>
                     <a:bodyPr/>
@@ -20562,7 +19695,7 @@
                   </a:tcPr>
                 </a:tc>
               </a:tr>
-              <a:tr h="365760">
+              <a:tr h="457200">
                 <a:tc>
                   <a:txBody>
                     <a:bodyPr/>
@@ -20658,7 +19791,7 @@
                   </a:tcPr>
                 </a:tc>
               </a:tr>
-              <a:tr h="365760">
+              <a:tr h="457200">
                 <a:tc>
                   <a:txBody>
                     <a:bodyPr/>
@@ -20754,7 +19887,7 @@
                   </a:tcPr>
                 </a:tc>
               </a:tr>
-              <a:tr h="365760">
+              <a:tr h="457200">
                 <a:tc>
                   <a:txBody>
                     <a:bodyPr/>
@@ -20850,7 +19983,7 @@
                   </a:tcPr>
                 </a:tc>
               </a:tr>
-              <a:tr h="365760">
+              <a:tr h="457200">
                 <a:tc>
                   <a:txBody>
                     <a:bodyPr/>
@@ -20952,14 +20085,54 @@
       </p:graphicFrame>
       <p:sp>
         <p:nvSpPr>
-          <p:cNvPr id="40" name="Text 37"/>
+          <p:cNvPr id="13" name="Caveat box"/>
+          <p:cNvSpPr/>
+          <p:nvPr/>
+        </p:nvSpPr>
+        <p:spPr>
+          <a:xfrm>
+            <a:off x="548640" y="5257800"/>
+            <a:ext cx="11091672" cy="731520"/>
+          </a:xfrm>
+          <a:prstGeom prst="rect">
+            <a:avLst/>
+          </a:prstGeom>
+          <a:solidFill>
+            <a:schemeClr val="bg2"/>
+          </a:solidFill>
+          <a:ln/>
+        </p:spPr>
+      </p:sp>
+      <p:sp>
+        <p:nvSpPr>
+          <p:cNvPr id="14" name="Caveat bar"/>
+          <p:cNvSpPr/>
+          <p:nvPr/>
+        </p:nvSpPr>
+        <p:spPr>
+          <a:xfrm>
+            <a:off x="548640" y="5257800"/>
+            <a:ext cx="73152" cy="731520"/>
+          </a:xfrm>
+          <a:prstGeom prst="rect">
+            <a:avLst/>
+          </a:prstGeom>
+          <a:solidFill>
+            <a:srgbClr val="A23B2A"/>
+          </a:solidFill>
+          <a:ln/>
+        </p:spPr>
+      </p:sp>
+      <p:sp>
+        <p:nvSpPr>
+          <p:cNvPr id="15" name="Text 12"/>
           <p:cNvSpPr txBox="1"/>
           <p:nvPr/>
         </p:nvSpPr>
         <p:spPr>
           <a:xfrm>
-            <a:off x="548640" y="5715000"/>
-            <a:ext cx="5394960" cy="411480"/>
+            <a:off x="777240" y="5257800"/>
+            <a:ext cx="10698480" cy="731520"/>
           </a:xfrm>
           <a:prstGeom prst="rect">
             <a:avLst/>
@@ -20968,33 +20141,47 @@
           <a:ln/>
         </p:spPr>
         <p:txBody>
-          <a:bodyPr wrap="square" lIns="0" tIns="0" rIns="0" bIns="0" rtlCol="0" anchor="t"/>
+          <a:bodyPr wrap="square" lIns="0" tIns="0" rIns="0" bIns="0" rtlCol="0" anchor="ctr"/>
           <a:lstStyle/>
           <a:p>
             <a:pPr indent="0" marL="0">
               <a:buNone/>
             </a:pPr>
             <a:r>
-              <a:rPr lang="en-US" sz="1050" i="1" dirty="0">
-                <a:solidFill>
-                  <a:schemeClr val="accent3"/>
-                </a:solidFill>
-              </a:rPr>
-              <a:t>742 observations ≠ 742 independent participants: one campaign gives rows for several muscles, groups and scan days.</a:t>
-            </a:r>
-            <a:endParaRPr lang="en-US" sz="1050" dirty="0"/>
+              <a:rPr lang="en-US" sz="1700" b="1" dirty="0">
+                <a:solidFill>
+                  <a:schemeClr val="accent1"/>
+                </a:solidFill>
+              </a:rPr>
+              <a:t>742 observations ≠ 742 independent participants</a:t>
+            </a:r>
+            <a:endParaRPr lang="en-US" sz="1700" dirty="0"/>
+          </a:p>
+          <a:p>
+            <a:pPr indent="0" marL="0">
+              <a:buNone/>
+            </a:pPr>
+            <a:r>
+              <a:rPr lang="en-US" sz="1300" dirty="0">
+                <a:solidFill>
+                  <a:schemeClr val="tx1"/>
+                </a:solidFill>
+              </a:rPr>
+              <a:t>One campaign gives rows for several muscles, groups and scan days.</a:t>
+            </a:r>
+            <a:endParaRPr lang="en-US" sz="1700" dirty="0"/>
           </a:p>
         </p:txBody>
       </p:sp>
       <p:sp>
         <p:nvSpPr>
-          <p:cNvPr id="41" name="Text 38"/>
+          <p:cNvPr id="16" name="Text 13"/>
           <p:cNvSpPr txBox="1"/>
           <p:nvPr/>
         </p:nvSpPr>
         <p:spPr>
           <a:xfrm>
-            <a:off x="6400800" y="2697480"/>
+            <a:off x="6400800" y="1325880"/>
             <a:ext cx="5239512" cy="292608"/>
           </a:xfrm>
           <a:prstGeom prst="rect">
@@ -21037,7 +20224,7 @@
           </p:nvPr>
         </p:nvGraphicFramePr>
         <p:xfrm>
-          <a:off x="6400800" y="3063240"/>
+          <a:off x="6400800" y="1737360"/>
           <a:ext cx="5239512" cy="914400"/>
         </p:xfrm>
         <a:graphic>
@@ -21050,7 +20237,7 @@
                 <a:gridCol w="2267712"/>
                 <a:gridCol w="868680"/>
               </a:tblGrid>
-              <a:tr h="365760">
+              <a:tr h="457200">
                 <a:tc>
                   <a:txBody>
                     <a:bodyPr/>
@@ -21252,7 +20439,7 @@
                   </a:tcPr>
                 </a:tc>
               </a:tr>
-              <a:tr h="365760">
+              <a:tr h="457200">
                 <a:tc>
                   <a:txBody>
                     <a:bodyPr/>
@@ -21442,7 +20629,7 @@
                   </a:tcPr>
                 </a:tc>
               </a:tr>
-              <a:tr h="365760">
+              <a:tr h="457200">
                 <a:tc>
                   <a:txBody>
                     <a:bodyPr/>
@@ -21632,7 +20819,7 @@
                   </a:tcPr>
                 </a:tc>
               </a:tr>
-              <a:tr h="365760">
+              <a:tr h="457200">
                 <a:tc>
                   <a:txBody>
                     <a:bodyPr/>
@@ -21822,7 +21009,7 @@
                   </a:tcPr>
                 </a:tc>
               </a:tr>
-              <a:tr h="365760">
+              <a:tr h="457200">
                 <a:tc>
                   <a:txBody>
                     <a:bodyPr/>
@@ -22012,7 +21199,7 @@
                   </a:tcPr>
                 </a:tc>
               </a:tr>
-              <a:tr h="365760">
+              <a:tr h="457200">
                 <a:tc>
                   <a:txBody>
                     <a:bodyPr/>

</xml_diff>

<commit_message>
Slide 7: caveat as plain text
Co-Authored-By: Claude Opus 5.5 (1M context) <noreply@anthropic.com>
Claude-Session: https://claude.ai/code/session_01JZtuYERhuCe7nB9VYHwcfv
</commit_message>
<xml_diff>
--- a/presentation/bed-rest-to-mars-talk.pptx
+++ b/presentation/bed-rest-to-mars-talk.pptx
@@ -125,13 +125,13 @@
   <p:extLst>
     <p:ext uri="{521415D9-36F7-43E2-AB2F-B90AF26B5E84}">
       <p14:sectionLst xmlns:p14="http://schemas.microsoft.com/office/powerpoint/2010/main">
-        <p14:section name="Opening" id="{f860d6cb-0d50-dc31-f7ca-22743eedf205}">
+        <p14:section name="Opening" id="{b64c7714-1ae9-6779-9a26-79b48a73ce59}">
           <p14:sldIdLst>
             <p14:sldId id="256"/>
             <p14:sldId id="257"/>
           </p14:sldIdLst>
         </p14:section>
-        <p14:section name="Part 1" id="{aa60e39c-637c-1712-5ddd-f5974cb4ef14}">
+        <p14:section name="Part 1" id="{09defb29-c23f-4b7b-5297-e4317d9b7461}">
           <p14:sldIdLst>
             <p14:sldId id="258"/>
             <p14:sldId id="259"/>
@@ -141,7 +141,7 @@
             <p14:sldId id="263"/>
           </p14:sldIdLst>
         </p14:section>
-        <p14:section name="Part 2" id="{a21d90e0-87d5-9f15-3b14-899fd4a1c019}">
+        <p14:section name="Part 2" id="{e968585d-0fb5-5be4-f74a-eb0747b98ee6}">
           <p14:sldIdLst>
             <p14:sldId id="264"/>
             <p14:sldId id="265"/>
@@ -152,7 +152,7 @@
             <p14:sldId id="270"/>
           </p14:sldIdLst>
         </p14:section>
-        <p14:section name="Backup" id="{aed73a93-cd1a-66a8-3960-3694dcbe9438}">
+        <p14:section name="Backup" id="{e1bbd095-6869-d80b-ab9f-1c6f1fd95206}">
           <p14:sldIdLst>
             <p14:sldId id="271"/>
             <p14:sldId id="272"/>
@@ -160,13 +160,13 @@
             <p14:sldId id="274"/>
           </p14:sldIdLst>
         </p14:section>
-        <p14:section name="Backup" id="{70a7aae6-7b55-3a5b-84f6-5c287df1a9e2}">
+        <p14:section name="Backup" id="{c3b3503e-cc54-a33e-1f39-5eec48d9e61d}">
           <p14:sldIdLst/>
         </p14:section>
-        <p14:section name="Backup" id="{2f076825-ecf4-d845-2394-b0eb9bf2fd1f}">
+        <p14:section name="Backup" id="{c8c271af-9c67-d898-6cd3-457cb527eaed}">
           <p14:sldIdLst/>
         </p14:section>
-        <p14:section name="Backup" id="{ce9d4330-8a3a-3cc3-d3a3-49ff1e6c991a}">
+        <p14:section name="Backup" id="{218de06a-a305-7cc8-8f23-4267909b03c7}">
           <p14:sldIdLst/>
         </p14:section>
       </p14:sectionLst>
@@ -20085,54 +20085,14 @@
       </p:graphicFrame>
       <p:sp>
         <p:nvSpPr>
-          <p:cNvPr id="13" name="Caveat box"/>
-          <p:cNvSpPr/>
-          <p:nvPr/>
-        </p:nvSpPr>
-        <p:spPr>
-          <a:xfrm>
-            <a:off x="548640" y="5257800"/>
-            <a:ext cx="11091672" cy="731520"/>
-          </a:xfrm>
-          <a:prstGeom prst="rect">
-            <a:avLst/>
-          </a:prstGeom>
-          <a:solidFill>
-            <a:schemeClr val="bg2"/>
-          </a:solidFill>
-          <a:ln/>
-        </p:spPr>
-      </p:sp>
-      <p:sp>
-        <p:nvSpPr>
-          <p:cNvPr id="14" name="Caveat bar"/>
-          <p:cNvSpPr/>
-          <p:nvPr/>
-        </p:nvSpPr>
-        <p:spPr>
-          <a:xfrm>
-            <a:off x="548640" y="5257800"/>
-            <a:ext cx="73152" cy="731520"/>
-          </a:xfrm>
-          <a:prstGeom prst="rect">
-            <a:avLst/>
-          </a:prstGeom>
-          <a:solidFill>
-            <a:srgbClr val="A23B2A"/>
-          </a:solidFill>
-          <a:ln/>
-        </p:spPr>
-      </p:sp>
-      <p:sp>
-        <p:nvSpPr>
-          <p:cNvPr id="15" name="Text 12"/>
+          <p:cNvPr id="13" name="Text 10"/>
           <p:cNvSpPr txBox="1"/>
           <p:nvPr/>
         </p:nvSpPr>
         <p:spPr>
           <a:xfrm>
-            <a:off x="777240" y="5257800"/>
-            <a:ext cx="10698480" cy="731520"/>
+            <a:off x="548640" y="5349240"/>
+            <a:ext cx="11064240" cy="640080"/>
           </a:xfrm>
           <a:prstGeom prst="rect">
             <a:avLst/>
@@ -20141,41 +20101,38 @@
           <a:ln/>
         </p:spPr>
         <p:txBody>
-          <a:bodyPr wrap="square" lIns="0" tIns="0" rIns="0" bIns="0" rtlCol="0" anchor="ctr"/>
+          <a:bodyPr wrap="square" lIns="0" tIns="0" rIns="0" bIns="0" rtlCol="0" anchor="t"/>
           <a:lstStyle/>
           <a:p>
             <a:pPr indent="0" marL="0">
               <a:buNone/>
             </a:pPr>
             <a:r>
-              <a:rPr lang="en-US" sz="1700" b="1" dirty="0">
-                <a:solidFill>
-                  <a:schemeClr val="accent1"/>
-                </a:solidFill>
-              </a:rPr>
-              <a:t>742 observations ≠ 742 independent participants</a:t>
-            </a:r>
-            <a:endParaRPr lang="en-US" sz="1700" dirty="0"/>
-          </a:p>
-          <a:p>
+              <a:rPr lang="en-US" sz="1400" b="1" dirty="0">
+                <a:solidFill>
+                  <a:schemeClr val="tx1"/>
+                </a:solidFill>
+              </a:rPr>
+              <a:t>742 observations are not 742 independent participants: </a:t>
+            </a:r>
             <a:pPr indent="0" marL="0">
               <a:buNone/>
             </a:pPr>
             <a:r>
-              <a:rPr lang="en-US" sz="1300" dirty="0">
+              <a:rPr lang="en-US" sz="1400" dirty="0">
                 <a:solidFill>
                   <a:schemeClr val="tx1"/>
                 </a:solidFill>
               </a:rPr>
-              <a:t>One campaign gives rows for several muscles, groups and scan days.</a:t>
-            </a:r>
-            <a:endParaRPr lang="en-US" sz="1700" dirty="0"/>
+              <a:t>one campaign gives rows for several muscles, groups and scan days.</a:t>
+            </a:r>
+            <a:endParaRPr lang="en-US" sz="1400" dirty="0"/>
           </a:p>
         </p:txBody>
       </p:sp>
       <p:sp>
         <p:nvSpPr>
-          <p:cNvPr id="16" name="Text 13"/>
+          <p:cNvPr id="14" name="Text 11"/>
           <p:cNvSpPr txBox="1"/>
           <p:nvPr/>
         </p:nvSpPr>

</xml_diff>

<commit_message>
Slide 8: muscle-group loss curves with day-60 reading line and muscle icons
Co-Authored-By: Claude Opus 5.5 (1M context) <noreply@anthropic.com>
Claude-Session: https://claude.ai/code/session_01JZtuYERhuCe7nB9VYHwcfv
</commit_message>
<xml_diff>
--- a/presentation/bed-rest-to-mars-talk.pptx
+++ b/presentation/bed-rest-to-mars-talk.pptx
@@ -125,13 +125,13 @@
   <p:extLst>
     <p:ext uri="{521415D9-36F7-43E2-AB2F-B90AF26B5E84}">
       <p14:sectionLst xmlns:p14="http://schemas.microsoft.com/office/powerpoint/2010/main">
-        <p14:section name="Opening" id="{b64c7714-1ae9-6779-9a26-79b48a73ce59}">
+        <p14:section name="Opening" id="{4a53e688-2e21-8c2b-1a24-5e798fa46410}">
           <p14:sldIdLst>
             <p14:sldId id="256"/>
             <p14:sldId id="257"/>
           </p14:sldIdLst>
         </p14:section>
-        <p14:section name="Part 1" id="{09defb29-c23f-4b7b-5297-e4317d9b7461}">
+        <p14:section name="Part 1" id="{63bd19e1-d437-4572-f696-0b7488e85fae}">
           <p14:sldIdLst>
             <p14:sldId id="258"/>
             <p14:sldId id="259"/>
@@ -141,7 +141,7 @@
             <p14:sldId id="263"/>
           </p14:sldIdLst>
         </p14:section>
-        <p14:section name="Part 2" id="{e968585d-0fb5-5be4-f74a-eb0747b98ee6}">
+        <p14:section name="Part 2" id="{d2a90e6d-e19e-8963-8bcc-ab7b306a04ca}">
           <p14:sldIdLst>
             <p14:sldId id="264"/>
             <p14:sldId id="265"/>
@@ -152,7 +152,7 @@
             <p14:sldId id="270"/>
           </p14:sldIdLst>
         </p14:section>
-        <p14:section name="Backup" id="{e1bbd095-6869-d80b-ab9f-1c6f1fd95206}">
+        <p14:section name="Backup" id="{dfe84075-61ce-0855-83e8-ae82d642f54c}">
           <p14:sldIdLst>
             <p14:sldId id="271"/>
             <p14:sldId id="272"/>
@@ -160,13 +160,13 @@
             <p14:sldId id="274"/>
           </p14:sldIdLst>
         </p14:section>
-        <p14:section name="Backup" id="{c3b3503e-cc54-a33e-1f39-5eec48d9e61d}">
+        <p14:section name="Backup" id="{714d95a6-f93d-82ac-42dc-1be9ea284433}">
           <p14:sldIdLst/>
         </p14:section>
-        <p14:section name="Backup" id="{c8c271af-9c67-d898-6cd3-457cb527eaed}">
+        <p14:section name="Backup" id="{039f007a-f391-9ffd-568d-558666c65e3f}">
           <p14:sldIdLst/>
         </p14:section>
-        <p14:section name="Backup" id="{218de06a-a305-7cc8-8f23-4267909b03c7}">
+        <p14:section name="Backup" id="{c5a9821c-c009-8860-4101-b118a9f0963f}">
           <p14:sldIdLst/>
         </p14:section>
       </p14:sectionLst>
@@ -5233,7 +5233,10 @@
           <a:p>
             <a:r>
               <a:rPr lang="en-US" dirty="0"/>
-              <a:t>Placeholder for the co-author's slide. The suggested points are from the final report on branch feat/report; replace them with the final content.</a:t>
+              <a:t>Part 1 (Niloufar), about one minute.
+No, muscles are not affected equally. Each line shows how much a muscle group shrinks over the days of bed rest, for groups without a countermeasure. The dashed line reads the values at day 60.
+The calf, the plantar flexors, loses most: about 16 percent at day 60, almost 6 percentage points more than the front thigh. The shin, the front thigh and the back thigh lose about 10 percent. Hip muscles lose least.
+How the lines are drawn: the day-60 values are the estimates of our meta-regression for each muscle group. The shape over time is the one curve the model fits to all muscles, rising fast in the first weeks and levelling off; time constant 60 days. Hip rotators and outer hip rest on a single campaign each, so treat those two with care.</a:t>
             </a:r>
             <a:endParaRPr lang="en-US" dirty="0"/>
           </a:p>
@@ -21672,24 +21675,687 @@
       </p:sp>
       <p:sp>
         <p:nvSpPr>
-          <p:cNvPr id="11" name="Placeholder frame"/>
+          <p:cNvPr id="11" name="Grid 0"/>
           <p:cNvSpPr/>
           <p:nvPr/>
         </p:nvSpPr>
         <p:spPr>
           <a:xfrm>
-            <a:off x="548640" y="1234440"/>
-            <a:ext cx="11064240" cy="4846320"/>
-          </a:xfrm>
-          <a:prstGeom prst="rect">
-            <a:avLst/>
-          </a:prstGeom>
-          <a:solidFill>
-            <a:schemeClr val="bg1"/>
-          </a:solidFill>
+            <a:off x="1234440" y="1371600"/>
+            <a:ext cx="6309360" cy="0"/>
+          </a:xfrm>
+          <a:prstGeom prst="line">
+            <a:avLst/>
+          </a:prstGeom>
+          <a:noFill/>
+          <a:ln w="9525">
+            <a:solidFill>
+              <a:srgbClr val="6B7280"/>
+            </a:solidFill>
+            <a:prstDash val="solid"/>
+          </a:ln>
+        </p:spPr>
+      </p:sp>
+      <p:sp>
+        <p:nvSpPr>
+          <p:cNvPr id="12" name="Text 10"/>
+          <p:cNvSpPr txBox="1"/>
+          <p:nvPr/>
+        </p:nvSpPr>
+        <p:spPr>
+          <a:xfrm>
+            <a:off x="667512" y="1271016"/>
+            <a:ext cx="475488" cy="201168"/>
+          </a:xfrm>
+          <a:prstGeom prst="rect">
+            <a:avLst/>
+          </a:prstGeom>
+          <a:noFill/>
+          <a:ln/>
+        </p:spPr>
+        <p:txBody>
+          <a:bodyPr wrap="square" lIns="0" tIns="0" rIns="0" bIns="0" rtlCol="0" anchor="t"/>
+          <a:lstStyle/>
+          <a:p>
+            <a:pPr algn="r" indent="0" marL="0">
+              <a:buNone/>
+            </a:pPr>
+            <a:r>
+              <a:rPr lang="en-US" sz="1000" dirty="0">
+                <a:solidFill>
+                  <a:schemeClr val="accent3"/>
+                </a:solidFill>
+              </a:rPr>
+              <a:t>0%</a:t>
+            </a:r>
+            <a:endParaRPr lang="en-US" sz="1000" dirty="0"/>
+          </a:p>
+        </p:txBody>
+      </p:sp>
+      <p:sp>
+        <p:nvSpPr>
+          <p:cNvPr id="13" name="Grid -4"/>
+          <p:cNvSpPr/>
+          <p:nvPr/>
+        </p:nvSpPr>
+        <p:spPr>
+          <a:xfrm>
+            <a:off x="1234440" y="2019300"/>
+            <a:ext cx="6309360" cy="0"/>
+          </a:xfrm>
+          <a:prstGeom prst="line">
+            <a:avLst/>
+          </a:prstGeom>
+          <a:noFill/>
+          <a:ln w="9525">
+            <a:solidFill>
+              <a:srgbClr val="E5E7EB"/>
+            </a:solidFill>
+            <a:prstDash val="solid"/>
+          </a:ln>
+        </p:spPr>
+      </p:sp>
+      <p:sp>
+        <p:nvSpPr>
+          <p:cNvPr id="14" name="Text 12"/>
+          <p:cNvSpPr txBox="1"/>
+          <p:nvPr/>
+        </p:nvSpPr>
+        <p:spPr>
+          <a:xfrm>
+            <a:off x="667512" y="1918716"/>
+            <a:ext cx="475488" cy="201168"/>
+          </a:xfrm>
+          <a:prstGeom prst="rect">
+            <a:avLst/>
+          </a:prstGeom>
+          <a:noFill/>
+          <a:ln/>
+        </p:spPr>
+        <p:txBody>
+          <a:bodyPr wrap="square" lIns="0" tIns="0" rIns="0" bIns="0" rtlCol="0" anchor="t"/>
+          <a:lstStyle/>
+          <a:p>
+            <a:pPr algn="r" indent="0" marL="0">
+              <a:buNone/>
+            </a:pPr>
+            <a:r>
+              <a:rPr lang="en-US" sz="1000" dirty="0">
+                <a:solidFill>
+                  <a:schemeClr val="accent3"/>
+                </a:solidFill>
+              </a:rPr>
+              <a:t>−4%</a:t>
+            </a:r>
+            <a:endParaRPr lang="en-US" sz="1000" dirty="0"/>
+          </a:p>
+        </p:txBody>
+      </p:sp>
+      <p:sp>
+        <p:nvSpPr>
+          <p:cNvPr id="15" name="Grid -8"/>
+          <p:cNvSpPr/>
+          <p:nvPr/>
+        </p:nvSpPr>
+        <p:spPr>
+          <a:xfrm>
+            <a:off x="1234440" y="2667000"/>
+            <a:ext cx="6309360" cy="0"/>
+          </a:xfrm>
+          <a:prstGeom prst="line">
+            <a:avLst/>
+          </a:prstGeom>
+          <a:noFill/>
+          <a:ln w="9525">
+            <a:solidFill>
+              <a:srgbClr val="E5E7EB"/>
+            </a:solidFill>
+            <a:prstDash val="solid"/>
+          </a:ln>
+        </p:spPr>
+      </p:sp>
+      <p:sp>
+        <p:nvSpPr>
+          <p:cNvPr id="16" name="Text 14"/>
+          <p:cNvSpPr txBox="1"/>
+          <p:nvPr/>
+        </p:nvSpPr>
+        <p:spPr>
+          <a:xfrm>
+            <a:off x="667512" y="2566416"/>
+            <a:ext cx="475488" cy="201168"/>
+          </a:xfrm>
+          <a:prstGeom prst="rect">
+            <a:avLst/>
+          </a:prstGeom>
+          <a:noFill/>
+          <a:ln/>
+        </p:spPr>
+        <p:txBody>
+          <a:bodyPr wrap="square" lIns="0" tIns="0" rIns="0" bIns="0" rtlCol="0" anchor="t"/>
+          <a:lstStyle/>
+          <a:p>
+            <a:pPr algn="r" indent="0" marL="0">
+              <a:buNone/>
+            </a:pPr>
+            <a:r>
+              <a:rPr lang="en-US" sz="1000" dirty="0">
+                <a:solidFill>
+                  <a:schemeClr val="accent3"/>
+                </a:solidFill>
+              </a:rPr>
+              <a:t>−8%</a:t>
+            </a:r>
+            <a:endParaRPr lang="en-US" sz="1000" dirty="0"/>
+          </a:p>
+        </p:txBody>
+      </p:sp>
+      <p:sp>
+        <p:nvSpPr>
+          <p:cNvPr id="17" name="Grid -12"/>
+          <p:cNvSpPr/>
+          <p:nvPr/>
+        </p:nvSpPr>
+        <p:spPr>
+          <a:xfrm>
+            <a:off x="1234440" y="3314700"/>
+            <a:ext cx="6309360" cy="0"/>
+          </a:xfrm>
+          <a:prstGeom prst="line">
+            <a:avLst/>
+          </a:prstGeom>
+          <a:noFill/>
+          <a:ln w="9525">
+            <a:solidFill>
+              <a:srgbClr val="E5E7EB"/>
+            </a:solidFill>
+            <a:prstDash val="solid"/>
+          </a:ln>
+        </p:spPr>
+      </p:sp>
+      <p:sp>
+        <p:nvSpPr>
+          <p:cNvPr id="18" name="Text 16"/>
+          <p:cNvSpPr txBox="1"/>
+          <p:nvPr/>
+        </p:nvSpPr>
+        <p:spPr>
+          <a:xfrm>
+            <a:off x="667512" y="3214116"/>
+            <a:ext cx="475488" cy="201168"/>
+          </a:xfrm>
+          <a:prstGeom prst="rect">
+            <a:avLst/>
+          </a:prstGeom>
+          <a:noFill/>
+          <a:ln/>
+        </p:spPr>
+        <p:txBody>
+          <a:bodyPr wrap="square" lIns="0" tIns="0" rIns="0" bIns="0" rtlCol="0" anchor="t"/>
+          <a:lstStyle/>
+          <a:p>
+            <a:pPr algn="r" indent="0" marL="0">
+              <a:buNone/>
+            </a:pPr>
+            <a:r>
+              <a:rPr lang="en-US" sz="1000" dirty="0">
+                <a:solidFill>
+                  <a:schemeClr val="accent3"/>
+                </a:solidFill>
+              </a:rPr>
+              <a:t>−12%</a:t>
+            </a:r>
+            <a:endParaRPr lang="en-US" sz="1000" dirty="0"/>
+          </a:p>
+        </p:txBody>
+      </p:sp>
+      <p:sp>
+        <p:nvSpPr>
+          <p:cNvPr id="19" name="Grid -16"/>
+          <p:cNvSpPr/>
+          <p:nvPr/>
+        </p:nvSpPr>
+        <p:spPr>
+          <a:xfrm>
+            <a:off x="1234440" y="3962400"/>
+            <a:ext cx="6309360" cy="0"/>
+          </a:xfrm>
+          <a:prstGeom prst="line">
+            <a:avLst/>
+          </a:prstGeom>
+          <a:noFill/>
+          <a:ln w="9525">
+            <a:solidFill>
+              <a:srgbClr val="E5E7EB"/>
+            </a:solidFill>
+            <a:prstDash val="solid"/>
+          </a:ln>
+        </p:spPr>
+      </p:sp>
+      <p:sp>
+        <p:nvSpPr>
+          <p:cNvPr id="20" name="Text 18"/>
+          <p:cNvSpPr txBox="1"/>
+          <p:nvPr/>
+        </p:nvSpPr>
+        <p:spPr>
+          <a:xfrm>
+            <a:off x="667512" y="3861816"/>
+            <a:ext cx="475488" cy="201168"/>
+          </a:xfrm>
+          <a:prstGeom prst="rect">
+            <a:avLst/>
+          </a:prstGeom>
+          <a:noFill/>
+          <a:ln/>
+        </p:spPr>
+        <p:txBody>
+          <a:bodyPr wrap="square" lIns="0" tIns="0" rIns="0" bIns="0" rtlCol="0" anchor="t"/>
+          <a:lstStyle/>
+          <a:p>
+            <a:pPr algn="r" indent="0" marL="0">
+              <a:buNone/>
+            </a:pPr>
+            <a:r>
+              <a:rPr lang="en-US" sz="1000" dirty="0">
+                <a:solidFill>
+                  <a:schemeClr val="accent3"/>
+                </a:solidFill>
+              </a:rPr>
+              <a:t>−16%</a:t>
+            </a:r>
+            <a:endParaRPr lang="en-US" sz="1000" dirty="0"/>
+          </a:p>
+        </p:txBody>
+      </p:sp>
+      <p:sp>
+        <p:nvSpPr>
+          <p:cNvPr id="21" name="Grid -20"/>
+          <p:cNvSpPr/>
+          <p:nvPr/>
+        </p:nvSpPr>
+        <p:spPr>
+          <a:xfrm>
+            <a:off x="1234440" y="4610100"/>
+            <a:ext cx="6309360" cy="0"/>
+          </a:xfrm>
+          <a:prstGeom prst="line">
+            <a:avLst/>
+          </a:prstGeom>
+          <a:noFill/>
+          <a:ln w="9525">
+            <a:solidFill>
+              <a:srgbClr val="E5E7EB"/>
+            </a:solidFill>
+            <a:prstDash val="solid"/>
+          </a:ln>
+        </p:spPr>
+      </p:sp>
+      <p:sp>
+        <p:nvSpPr>
+          <p:cNvPr id="22" name="Text 20"/>
+          <p:cNvSpPr txBox="1"/>
+          <p:nvPr/>
+        </p:nvSpPr>
+        <p:spPr>
+          <a:xfrm>
+            <a:off x="667512" y="4509516"/>
+            <a:ext cx="475488" cy="201168"/>
+          </a:xfrm>
+          <a:prstGeom prst="rect">
+            <a:avLst/>
+          </a:prstGeom>
+          <a:noFill/>
+          <a:ln/>
+        </p:spPr>
+        <p:txBody>
+          <a:bodyPr wrap="square" lIns="0" tIns="0" rIns="0" bIns="0" rtlCol="0" anchor="t"/>
+          <a:lstStyle/>
+          <a:p>
+            <a:pPr algn="r" indent="0" marL="0">
+              <a:buNone/>
+            </a:pPr>
+            <a:r>
+              <a:rPr lang="en-US" sz="1000" dirty="0">
+                <a:solidFill>
+                  <a:schemeClr val="accent3"/>
+                </a:solidFill>
+              </a:rPr>
+              <a:t>−20%</a:t>
+            </a:r>
+            <a:endParaRPr lang="en-US" sz="1000" dirty="0"/>
+          </a:p>
+        </p:txBody>
+      </p:sp>
+      <p:sp>
+        <p:nvSpPr>
+          <p:cNvPr id="23" name="Grid -24"/>
+          <p:cNvSpPr/>
+          <p:nvPr/>
+        </p:nvSpPr>
+        <p:spPr>
+          <a:xfrm>
+            <a:off x="1234440" y="5257800"/>
+            <a:ext cx="6309360" cy="0"/>
+          </a:xfrm>
+          <a:prstGeom prst="line">
+            <a:avLst/>
+          </a:prstGeom>
+          <a:noFill/>
+          <a:ln w="9525">
+            <a:solidFill>
+              <a:srgbClr val="E5E7EB"/>
+            </a:solidFill>
+            <a:prstDash val="solid"/>
+          </a:ln>
+        </p:spPr>
+      </p:sp>
+      <p:sp>
+        <p:nvSpPr>
+          <p:cNvPr id="24" name="Text 22"/>
+          <p:cNvSpPr txBox="1"/>
+          <p:nvPr/>
+        </p:nvSpPr>
+        <p:spPr>
+          <a:xfrm>
+            <a:off x="667512" y="5157216"/>
+            <a:ext cx="475488" cy="201168"/>
+          </a:xfrm>
+          <a:prstGeom prst="rect">
+            <a:avLst/>
+          </a:prstGeom>
+          <a:noFill/>
+          <a:ln/>
+        </p:spPr>
+        <p:txBody>
+          <a:bodyPr wrap="square" lIns="0" tIns="0" rIns="0" bIns="0" rtlCol="0" anchor="t"/>
+          <a:lstStyle/>
+          <a:p>
+            <a:pPr algn="r" indent="0" marL="0">
+              <a:buNone/>
+            </a:pPr>
+            <a:r>
+              <a:rPr lang="en-US" sz="1000" dirty="0">
+                <a:solidFill>
+                  <a:schemeClr val="accent3"/>
+                </a:solidFill>
+              </a:rPr>
+              <a:t>−24%</a:t>
+            </a:r>
+            <a:endParaRPr lang="en-US" sz="1000" dirty="0"/>
+          </a:p>
+        </p:txBody>
+      </p:sp>
+      <p:sp>
+        <p:nvSpPr>
+          <p:cNvPr id="25" name="Text 23"/>
+          <p:cNvSpPr txBox="1"/>
+          <p:nvPr/>
+        </p:nvSpPr>
+        <p:spPr>
+          <a:xfrm>
+            <a:off x="960120" y="5312664"/>
+            <a:ext cx="548640" cy="201168"/>
+          </a:xfrm>
+          <a:prstGeom prst="rect">
+            <a:avLst/>
+          </a:prstGeom>
+          <a:noFill/>
+          <a:ln/>
+        </p:spPr>
+        <p:txBody>
+          <a:bodyPr wrap="square" lIns="0" tIns="0" rIns="0" bIns="0" rtlCol="0" anchor="t"/>
+          <a:lstStyle/>
+          <a:p>
+            <a:pPr algn="ctr" indent="0" marL="0">
+              <a:buNone/>
+            </a:pPr>
+            <a:r>
+              <a:rPr lang="en-US" sz="1000" dirty="0">
+                <a:solidFill>
+                  <a:schemeClr val="accent3"/>
+                </a:solidFill>
+              </a:rPr>
+              <a:t>0</a:t>
+            </a:r>
+            <a:endParaRPr lang="en-US" sz="1000" dirty="0"/>
+          </a:p>
+        </p:txBody>
+      </p:sp>
+      <p:sp>
+        <p:nvSpPr>
+          <p:cNvPr id="26" name="Text 24"/>
+          <p:cNvSpPr txBox="1"/>
+          <p:nvPr/>
+        </p:nvSpPr>
+        <p:spPr>
+          <a:xfrm>
+            <a:off x="2537460" y="5312664"/>
+            <a:ext cx="548640" cy="201168"/>
+          </a:xfrm>
+          <a:prstGeom prst="rect">
+            <a:avLst/>
+          </a:prstGeom>
+          <a:noFill/>
+          <a:ln/>
+        </p:spPr>
+        <p:txBody>
+          <a:bodyPr wrap="square" lIns="0" tIns="0" rIns="0" bIns="0" rtlCol="0" anchor="t"/>
+          <a:lstStyle/>
+          <a:p>
+            <a:pPr algn="ctr" indent="0" marL="0">
+              <a:buNone/>
+            </a:pPr>
+            <a:r>
+              <a:rPr lang="en-US" sz="1000" dirty="0">
+                <a:solidFill>
+                  <a:schemeClr val="accent3"/>
+                </a:solidFill>
+              </a:rPr>
+              <a:t>30</a:t>
+            </a:r>
+            <a:endParaRPr lang="en-US" sz="1000" dirty="0"/>
+          </a:p>
+        </p:txBody>
+      </p:sp>
+      <p:sp>
+        <p:nvSpPr>
+          <p:cNvPr id="27" name="Text 25"/>
+          <p:cNvSpPr txBox="1"/>
+          <p:nvPr/>
+        </p:nvSpPr>
+        <p:spPr>
+          <a:xfrm>
+            <a:off x="4114800" y="5312664"/>
+            <a:ext cx="548640" cy="201168"/>
+          </a:xfrm>
+          <a:prstGeom prst="rect">
+            <a:avLst/>
+          </a:prstGeom>
+          <a:noFill/>
+          <a:ln/>
+        </p:spPr>
+        <p:txBody>
+          <a:bodyPr wrap="square" lIns="0" tIns="0" rIns="0" bIns="0" rtlCol="0" anchor="t"/>
+          <a:lstStyle/>
+          <a:p>
+            <a:pPr algn="ctr" indent="0" marL="0">
+              <a:buNone/>
+            </a:pPr>
+            <a:r>
+              <a:rPr lang="en-US" sz="1000" dirty="0">
+                <a:solidFill>
+                  <a:schemeClr val="accent3"/>
+                </a:solidFill>
+              </a:rPr>
+              <a:t>60</a:t>
+            </a:r>
+            <a:endParaRPr lang="en-US" sz="1000" dirty="0"/>
+          </a:p>
+        </p:txBody>
+      </p:sp>
+      <p:sp>
+        <p:nvSpPr>
+          <p:cNvPr id="28" name="Text 26"/>
+          <p:cNvSpPr txBox="1"/>
+          <p:nvPr/>
+        </p:nvSpPr>
+        <p:spPr>
+          <a:xfrm>
+            <a:off x="5692140" y="5312664"/>
+            <a:ext cx="548640" cy="201168"/>
+          </a:xfrm>
+          <a:prstGeom prst="rect">
+            <a:avLst/>
+          </a:prstGeom>
+          <a:noFill/>
+          <a:ln/>
+        </p:spPr>
+        <p:txBody>
+          <a:bodyPr wrap="square" lIns="0" tIns="0" rIns="0" bIns="0" rtlCol="0" anchor="t"/>
+          <a:lstStyle/>
+          <a:p>
+            <a:pPr algn="ctr" indent="0" marL="0">
+              <a:buNone/>
+            </a:pPr>
+            <a:r>
+              <a:rPr lang="en-US" sz="1000" dirty="0">
+                <a:solidFill>
+                  <a:schemeClr val="accent3"/>
+                </a:solidFill>
+              </a:rPr>
+              <a:t>90</a:t>
+            </a:r>
+            <a:endParaRPr lang="en-US" sz="1000" dirty="0"/>
+          </a:p>
+        </p:txBody>
+      </p:sp>
+      <p:sp>
+        <p:nvSpPr>
+          <p:cNvPr id="29" name="Text 27"/>
+          <p:cNvSpPr txBox="1"/>
+          <p:nvPr/>
+        </p:nvSpPr>
+        <p:spPr>
+          <a:xfrm>
+            <a:off x="7269480" y="5312664"/>
+            <a:ext cx="548640" cy="201168"/>
+          </a:xfrm>
+          <a:prstGeom prst="rect">
+            <a:avLst/>
+          </a:prstGeom>
+          <a:noFill/>
+          <a:ln/>
+        </p:spPr>
+        <p:txBody>
+          <a:bodyPr wrap="square" lIns="0" tIns="0" rIns="0" bIns="0" rtlCol="0" anchor="t"/>
+          <a:lstStyle/>
+          <a:p>
+            <a:pPr algn="ctr" indent="0" marL="0">
+              <a:buNone/>
+            </a:pPr>
+            <a:r>
+              <a:rPr lang="en-US" sz="1000" dirty="0">
+                <a:solidFill>
+                  <a:schemeClr val="accent3"/>
+                </a:solidFill>
+              </a:rPr>
+              <a:t>120</a:t>
+            </a:r>
+            <a:endParaRPr lang="en-US" sz="1000" dirty="0"/>
+          </a:p>
+        </p:txBody>
+      </p:sp>
+      <p:sp>
+        <p:nvSpPr>
+          <p:cNvPr id="30" name="Text 28"/>
+          <p:cNvSpPr txBox="1"/>
+          <p:nvPr/>
+        </p:nvSpPr>
+        <p:spPr>
+          <a:xfrm>
+            <a:off x="1234440" y="5532120"/>
+            <a:ext cx="6309360" cy="228600"/>
+          </a:xfrm>
+          <a:prstGeom prst="rect">
+            <a:avLst/>
+          </a:prstGeom>
+          <a:noFill/>
+          <a:ln/>
+        </p:spPr>
+        <p:txBody>
+          <a:bodyPr wrap="square" lIns="0" tIns="0" rIns="0" bIns="0" rtlCol="0" anchor="t"/>
+          <a:lstStyle/>
+          <a:p>
+            <a:pPr algn="ctr" indent="0" marL="0">
+              <a:buNone/>
+            </a:pPr>
+            <a:r>
+              <a:rPr lang="en-US" sz="1100" dirty="0">
+                <a:solidFill>
+                  <a:schemeClr val="accent3"/>
+                </a:solidFill>
+              </a:rPr>
+              <a:t>Day of unloading</a:t>
+            </a:r>
+            <a:endParaRPr lang="en-US" sz="1100" dirty="0"/>
+          </a:p>
+        </p:txBody>
+      </p:sp>
+      <p:sp>
+        <p:nvSpPr>
+          <p:cNvPr id="31" name="Text 29"/>
+          <p:cNvSpPr txBox="1"/>
+          <p:nvPr/>
+        </p:nvSpPr>
+        <p:spPr>
+          <a:xfrm>
+            <a:off x="548640" y="1024128"/>
+            <a:ext cx="2286000" cy="228600"/>
+          </a:xfrm>
+          <a:prstGeom prst="rect">
+            <a:avLst/>
+          </a:prstGeom>
+          <a:noFill/>
+          <a:ln/>
+        </p:spPr>
+        <p:txBody>
+          <a:bodyPr wrap="square" lIns="0" tIns="0" rIns="0" bIns="0" rtlCol="0" anchor="t"/>
+          <a:lstStyle/>
+          <a:p>
+            <a:pPr indent="0" marL="0">
+              <a:buNone/>
+            </a:pPr>
+            <a:r>
+              <a:rPr lang="en-US" sz="1100" dirty="0">
+                <a:solidFill>
+                  <a:schemeClr val="accent3"/>
+                </a:solidFill>
+              </a:rPr>
+              <a:t>Change in muscle size</a:t>
+            </a:r>
+            <a:endParaRPr lang="en-US" sz="1100" dirty="0"/>
+          </a:p>
+        </p:txBody>
+      </p:sp>
+      <p:sp>
+        <p:nvSpPr>
+          <p:cNvPr id="32" name="Day 60 line"/>
+          <p:cNvSpPr/>
+          <p:nvPr/>
+        </p:nvSpPr>
+        <p:spPr>
+          <a:xfrm>
+            <a:off x="4389120" y="1280160"/>
+            <a:ext cx="0" cy="3977640"/>
+          </a:xfrm>
+          <a:prstGeom prst="line">
+            <a:avLst/>
+          </a:prstGeom>
+          <a:noFill/>
           <a:ln w="12700">
             <a:solidFill>
-              <a:srgbClr val="9AA3AE"/>
+              <a:srgbClr val="1A1A1A"/>
             </a:solidFill>
             <a:prstDash val="dash"/>
           </a:ln>
@@ -21697,14 +22363,14 @@
       </p:sp>
       <p:sp>
         <p:nvSpPr>
-          <p:cNvPr id="12" name="Text 10"/>
+          <p:cNvPr id="33" name="Text 31"/>
           <p:cNvSpPr txBox="1"/>
           <p:nvPr/>
         </p:nvSpPr>
         <p:spPr>
           <a:xfrm>
-            <a:off x="822960" y="1463040"/>
-            <a:ext cx="10515600" cy="4480560"/>
+            <a:off x="4434840" y="1261872"/>
+            <a:ext cx="731520" cy="201168"/>
           </a:xfrm>
           <a:prstGeom prst="rect">
             <a:avLst/>
@@ -21720,117 +22386,3245 @@
               <a:buNone/>
             </a:pPr>
             <a:r>
-              <a:rPr lang="en-US" sz="1400" b="1" dirty="0">
+              <a:rPr lang="en-US" sz="1050" b="1" dirty="0">
+                <a:solidFill>
+                  <a:schemeClr val="tx1"/>
+                </a:solidFill>
+              </a:rPr>
+              <a:t>day 60</a:t>
+            </a:r>
+            <a:endParaRPr lang="en-US" sz="1050" dirty="0"/>
+          </a:p>
+        </p:txBody>
+      </p:sp>
+      <p:sp>
+        <p:nvSpPr>
+          <p:cNvPr id="34" name="Deep hip rotators curve"/>
+          <p:cNvSpPr/>
+          <p:nvPr/>
+        </p:nvSpPr>
+        <p:spPr>
+          <a:xfrm>
+            <a:off x="1497330" y="1371600"/>
+            <a:ext cx="5993892" cy="419731"/>
+          </a:xfrm>
+          <a:custGeom>
+            <a:avLst/>
+            <a:gdLst/>
+            <a:ahLst/>
+            <a:cxnLst/>
+            <a:rect l="l" t="t" r="r" b="b"/>
+            <a:pathLst>
+              <a:path w="5993892" h="419731">
+                <a:moveTo>
+                  <a:pt x="0" y="38915"/>
+                </a:moveTo>
+                <a:lnTo>
+                  <a:pt x="105156" y="53595"/>
+                </a:lnTo>
+                <a:lnTo>
+                  <a:pt x="210312" y="67794"/>
+                </a:lnTo>
+                <a:lnTo>
+                  <a:pt x="315468" y="81528"/>
+                </a:lnTo>
+                <a:lnTo>
+                  <a:pt x="420624" y="94811"/>
+                </a:lnTo>
+                <a:lnTo>
+                  <a:pt x="525780" y="107659"/>
+                </a:lnTo>
+                <a:lnTo>
+                  <a:pt x="630936" y="120086"/>
+                </a:lnTo>
+                <a:lnTo>
+                  <a:pt x="736092" y="132105"/>
+                </a:lnTo>
+                <a:lnTo>
+                  <a:pt x="841248" y="143730"/>
+                </a:lnTo>
+                <a:lnTo>
+                  <a:pt x="946404" y="154974"/>
+                </a:lnTo>
+                <a:lnTo>
+                  <a:pt x="1051560" y="165850"/>
+                </a:lnTo>
+                <a:lnTo>
+                  <a:pt x="1156716" y="176369"/>
+                </a:lnTo>
+                <a:lnTo>
+                  <a:pt x="1261872" y="186543"/>
+                </a:lnTo>
+                <a:lnTo>
+                  <a:pt x="1367028" y="196384"/>
+                </a:lnTo>
+                <a:lnTo>
+                  <a:pt x="1472184" y="205901"/>
+                </a:lnTo>
+                <a:lnTo>
+                  <a:pt x="1577340" y="215107"/>
+                </a:lnTo>
+                <a:lnTo>
+                  <a:pt x="1682496" y="224011"/>
+                </a:lnTo>
+                <a:lnTo>
+                  <a:pt x="1787652" y="232624"/>
+                </a:lnTo>
+                <a:lnTo>
+                  <a:pt x="1892808" y="240954"/>
+                </a:lnTo>
+                <a:lnTo>
+                  <a:pt x="1997964" y="249010"/>
+                </a:lnTo>
+                <a:lnTo>
+                  <a:pt x="2103120" y="256803"/>
+                </a:lnTo>
+                <a:lnTo>
+                  <a:pt x="2208276" y="264340"/>
+                </a:lnTo>
+                <a:lnTo>
+                  <a:pt x="2313432" y="271630"/>
+                </a:lnTo>
+                <a:lnTo>
+                  <a:pt x="2418588" y="278681"/>
+                </a:lnTo>
+                <a:lnTo>
+                  <a:pt x="2523744" y="285501"/>
+                </a:lnTo>
+                <a:lnTo>
+                  <a:pt x="2628900" y="292097"/>
+                </a:lnTo>
+                <a:lnTo>
+                  <a:pt x="2734056" y="298477"/>
+                </a:lnTo>
+                <a:lnTo>
+                  <a:pt x="2839212" y="304648"/>
+                </a:lnTo>
+                <a:lnTo>
+                  <a:pt x="2944368" y="310617"/>
+                </a:lnTo>
+                <a:lnTo>
+                  <a:pt x="3049524" y="316390"/>
+                </a:lnTo>
+                <a:lnTo>
+                  <a:pt x="3154680" y="321974"/>
+                </a:lnTo>
+                <a:lnTo>
+                  <a:pt x="3259836" y="327374"/>
+                </a:lnTo>
+                <a:lnTo>
+                  <a:pt x="3364992" y="332598"/>
+                </a:lnTo>
+                <a:lnTo>
+                  <a:pt x="3470148" y="337650"/>
+                </a:lnTo>
+                <a:lnTo>
+                  <a:pt x="3575304" y="342537"/>
+                </a:lnTo>
+                <a:lnTo>
+                  <a:pt x="3680460" y="347263"/>
+                </a:lnTo>
+                <a:lnTo>
+                  <a:pt x="3785616" y="351835"/>
+                </a:lnTo>
+                <a:lnTo>
+                  <a:pt x="3890772" y="356256"/>
+                </a:lnTo>
+                <a:lnTo>
+                  <a:pt x="3995928" y="360533"/>
+                </a:lnTo>
+                <a:lnTo>
+                  <a:pt x="4101084" y="364669"/>
+                </a:lnTo>
+                <a:lnTo>
+                  <a:pt x="4206240" y="368670"/>
+                </a:lnTo>
+                <a:lnTo>
+                  <a:pt x="4311396" y="372540"/>
+                </a:lnTo>
+                <a:lnTo>
+                  <a:pt x="4416552" y="376283"/>
+                </a:lnTo>
+                <a:lnTo>
+                  <a:pt x="4521708" y="379903"/>
+                </a:lnTo>
+                <a:lnTo>
+                  <a:pt x="4626864" y="383404"/>
+                </a:lnTo>
+                <a:lnTo>
+                  <a:pt x="4732020" y="386791"/>
+                </a:lnTo>
+                <a:lnTo>
+                  <a:pt x="4837176" y="390067"/>
+                </a:lnTo>
+                <a:lnTo>
+                  <a:pt x="4942332" y="393235"/>
+                </a:lnTo>
+                <a:lnTo>
+                  <a:pt x="5047488" y="396299"/>
+                </a:lnTo>
+                <a:lnTo>
+                  <a:pt x="5152644" y="399263"/>
+                </a:lnTo>
+                <a:lnTo>
+                  <a:pt x="5257800" y="402130"/>
+                </a:lnTo>
+                <a:lnTo>
+                  <a:pt x="5362956" y="404903"/>
+                </a:lnTo>
+                <a:lnTo>
+                  <a:pt x="5468112" y="407585"/>
+                </a:lnTo>
+                <a:lnTo>
+                  <a:pt x="5573268" y="410179"/>
+                </a:lnTo>
+                <a:lnTo>
+                  <a:pt x="5678424" y="412687"/>
+                </a:lnTo>
+                <a:lnTo>
+                  <a:pt x="5783580" y="415114"/>
+                </a:lnTo>
+                <a:lnTo>
+                  <a:pt x="5888736" y="417461"/>
+                </a:lnTo>
+                <a:lnTo>
+                  <a:pt x="5993892" y="419731"/>
+                </a:lnTo>
+                <a:lnTo>
+                  <a:pt x="5993892" y="419731"/>
+                </a:lnTo>
+              </a:path>
+            </a:pathLst>
+          </a:custGeom>
+          <a:ln w="25400">
+            <a:solidFill>
+              <a:srgbClr val="6B7280"/>
+            </a:solidFill>
+            <a:prstDash val="solid"/>
+          </a:ln>
+        </p:spPr>
+      </p:sp>
+      <p:sp>
+        <p:nvSpPr>
+          <p:cNvPr id="35" name="Deep hip rotators at day 60"/>
+          <p:cNvSpPr/>
+          <p:nvPr/>
+        </p:nvSpPr>
+        <p:spPr>
+          <a:xfrm>
+            <a:off x="4338828" y="1628966"/>
+            <a:ext cx="100584" cy="100584"/>
+          </a:xfrm>
+          <a:prstGeom prst="ellipse">
+            <a:avLst/>
+          </a:prstGeom>
+          <a:solidFill>
+            <a:srgbClr val="6B7280"/>
+          </a:solidFill>
+          <a:ln w="6350">
+            <a:solidFill>
+              <a:srgbClr val="FFFFFF"/>
+            </a:solidFill>
+            <a:prstDash val="solid"/>
+          </a:ln>
+        </p:spPr>
+      </p:sp>
+      <p:sp>
+        <p:nvSpPr>
+          <p:cNvPr id="36" name="Inner thigh (hip adductors) curve"/>
+          <p:cNvSpPr/>
+          <p:nvPr/>
+        </p:nvSpPr>
+        <p:spPr>
+          <a:xfrm>
+            <a:off x="1497330" y="1371600"/>
+            <a:ext cx="5993892" cy="1192921"/>
+          </a:xfrm>
+          <a:custGeom>
+            <a:avLst/>
+            <a:gdLst/>
+            <a:ahLst/>
+            <a:cxnLst/>
+            <a:rect l="l" t="t" r="r" b="b"/>
+            <a:pathLst>
+              <a:path w="5993892" h="1192921">
+                <a:moveTo>
+                  <a:pt x="0" y="110600"/>
+                </a:moveTo>
+                <a:lnTo>
+                  <a:pt x="105156" y="152324"/>
+                </a:lnTo>
+                <a:lnTo>
+                  <a:pt x="210312" y="192679"/>
+                </a:lnTo>
+                <a:lnTo>
+                  <a:pt x="315468" y="231711"/>
+                </a:lnTo>
+                <a:lnTo>
+                  <a:pt x="420624" y="269464"/>
+                </a:lnTo>
+                <a:lnTo>
+                  <a:pt x="525780" y="305979"/>
+                </a:lnTo>
+                <a:lnTo>
+                  <a:pt x="630936" y="341297"/>
+                </a:lnTo>
+                <a:lnTo>
+                  <a:pt x="736092" y="375457"/>
+                </a:lnTo>
+                <a:lnTo>
+                  <a:pt x="841248" y="408497"/>
+                </a:lnTo>
+                <a:lnTo>
+                  <a:pt x="946404" y="440454"/>
+                </a:lnTo>
+                <a:lnTo>
+                  <a:pt x="1051560" y="471363"/>
+                </a:lnTo>
+                <a:lnTo>
+                  <a:pt x="1156716" y="501259"/>
+                </a:lnTo>
+                <a:lnTo>
+                  <a:pt x="1261872" y="530175"/>
+                </a:lnTo>
+                <a:lnTo>
+                  <a:pt x="1367028" y="558143"/>
+                </a:lnTo>
+                <a:lnTo>
+                  <a:pt x="1472184" y="585194"/>
+                </a:lnTo>
+                <a:lnTo>
+                  <a:pt x="1577340" y="611358"/>
+                </a:lnTo>
+                <a:lnTo>
+                  <a:pt x="1682496" y="636664"/>
+                </a:lnTo>
+                <a:lnTo>
+                  <a:pt x="1787652" y="661141"/>
+                </a:lnTo>
+                <a:lnTo>
+                  <a:pt x="1892808" y="684815"/>
+                </a:lnTo>
+                <a:lnTo>
+                  <a:pt x="1997964" y="707713"/>
+                </a:lnTo>
+                <a:lnTo>
+                  <a:pt x="2103120" y="729861"/>
+                </a:lnTo>
+                <a:lnTo>
+                  <a:pt x="2208276" y="751282"/>
+                </a:lnTo>
+                <a:lnTo>
+                  <a:pt x="2313432" y="772001"/>
+                </a:lnTo>
+                <a:lnTo>
+                  <a:pt x="2418588" y="792041"/>
+                </a:lnTo>
+                <a:lnTo>
+                  <a:pt x="2523744" y="811424"/>
+                </a:lnTo>
+                <a:lnTo>
+                  <a:pt x="2628900" y="830171"/>
+                </a:lnTo>
+                <a:lnTo>
+                  <a:pt x="2734056" y="848304"/>
+                </a:lnTo>
+                <a:lnTo>
+                  <a:pt x="2839212" y="865843"/>
+                </a:lnTo>
+                <a:lnTo>
+                  <a:pt x="2944368" y="882806"/>
+                </a:lnTo>
+                <a:lnTo>
+                  <a:pt x="3049524" y="899213"/>
+                </a:lnTo>
+                <a:lnTo>
+                  <a:pt x="3154680" y="915083"/>
+                </a:lnTo>
+                <a:lnTo>
+                  <a:pt x="3259836" y="930432"/>
+                </a:lnTo>
+                <a:lnTo>
+                  <a:pt x="3364992" y="945278"/>
+                </a:lnTo>
+                <a:lnTo>
+                  <a:pt x="3470148" y="959637"/>
+                </a:lnTo>
+                <a:lnTo>
+                  <a:pt x="3575304" y="973525"/>
+                </a:lnTo>
+                <a:lnTo>
+                  <a:pt x="3680460" y="986958"/>
+                </a:lnTo>
+                <a:lnTo>
+                  <a:pt x="3785616" y="999951"/>
+                </a:lnTo>
+                <a:lnTo>
+                  <a:pt x="3890772" y="1012518"/>
+                </a:lnTo>
+                <a:lnTo>
+                  <a:pt x="3995928" y="1024673"/>
+                </a:lnTo>
+                <a:lnTo>
+                  <a:pt x="4101084" y="1036429"/>
+                </a:lnTo>
+                <a:lnTo>
+                  <a:pt x="4206240" y="1047800"/>
+                </a:lnTo>
+                <a:lnTo>
+                  <a:pt x="4311396" y="1058798"/>
+                </a:lnTo>
+                <a:lnTo>
+                  <a:pt x="4416552" y="1069435"/>
+                </a:lnTo>
+                <a:lnTo>
+                  <a:pt x="4521708" y="1079724"/>
+                </a:lnTo>
+                <a:lnTo>
+                  <a:pt x="4626864" y="1089676"/>
+                </a:lnTo>
+                <a:lnTo>
+                  <a:pt x="4732020" y="1099301"/>
+                </a:lnTo>
+                <a:lnTo>
+                  <a:pt x="4837176" y="1108611"/>
+                </a:lnTo>
+                <a:lnTo>
+                  <a:pt x="4942332" y="1117615"/>
+                </a:lnTo>
+                <a:lnTo>
+                  <a:pt x="5047488" y="1126324"/>
+                </a:lnTo>
+                <a:lnTo>
+                  <a:pt x="5152644" y="1134748"/>
+                </a:lnTo>
+                <a:lnTo>
+                  <a:pt x="5257800" y="1142896"/>
+                </a:lnTo>
+                <a:lnTo>
+                  <a:pt x="5362956" y="1150776"/>
+                </a:lnTo>
+                <a:lnTo>
+                  <a:pt x="5468112" y="1158398"/>
+                </a:lnTo>
+                <a:lnTo>
+                  <a:pt x="5573268" y="1165771"/>
+                </a:lnTo>
+                <a:lnTo>
+                  <a:pt x="5678424" y="1172901"/>
+                </a:lnTo>
+                <a:lnTo>
+                  <a:pt x="5783580" y="1179798"/>
+                </a:lnTo>
+                <a:lnTo>
+                  <a:pt x="5888736" y="1186469"/>
+                </a:lnTo>
+                <a:lnTo>
+                  <a:pt x="5993892" y="1192921"/>
+                </a:lnTo>
+                <a:lnTo>
+                  <a:pt x="5993892" y="1192921"/>
+                </a:lnTo>
+              </a:path>
+            </a:pathLst>
+          </a:custGeom>
+          <a:ln w="25400">
+            <a:solidFill>
+              <a:srgbClr val="17A2B8"/>
+            </a:solidFill>
+            <a:prstDash val="solid"/>
+          </a:ln>
+        </p:spPr>
+      </p:sp>
+      <p:sp>
+        <p:nvSpPr>
+          <p:cNvPr id="37" name="Inner thigh (hip adductors) at day 60"/>
+          <p:cNvSpPr/>
+          <p:nvPr/>
+        </p:nvSpPr>
+        <p:spPr>
+          <a:xfrm>
+            <a:off x="4338828" y="2195703"/>
+            <a:ext cx="100584" cy="100584"/>
+          </a:xfrm>
+          <a:prstGeom prst="ellipse">
+            <a:avLst/>
+          </a:prstGeom>
+          <a:solidFill>
+            <a:srgbClr val="17A2B8"/>
+          </a:solidFill>
+          <a:ln w="6350">
+            <a:solidFill>
+              <a:srgbClr val="FFFFFF"/>
+            </a:solidFill>
+            <a:prstDash val="solid"/>
+          </a:ln>
+        </p:spPr>
+      </p:sp>
+      <p:sp>
+        <p:nvSpPr>
+          <p:cNvPr id="38" name="Glutes (hip extensors) curve"/>
+          <p:cNvSpPr/>
+          <p:nvPr/>
+        </p:nvSpPr>
+        <p:spPr>
+          <a:xfrm>
+            <a:off x="1497330" y="1371600"/>
+            <a:ext cx="5993892" cy="1347559"/>
+          </a:xfrm>
+          <a:custGeom>
+            <a:avLst/>
+            <a:gdLst/>
+            <a:ahLst/>
+            <a:cxnLst/>
+            <a:rect l="l" t="t" r="r" b="b"/>
+            <a:pathLst>
+              <a:path w="5993892" h="1347559">
+                <a:moveTo>
+                  <a:pt x="0" y="124937"/>
+                </a:moveTo>
+                <a:lnTo>
+                  <a:pt x="105156" y="172069"/>
+                </a:lnTo>
+                <a:lnTo>
+                  <a:pt x="210312" y="217656"/>
+                </a:lnTo>
+                <a:lnTo>
+                  <a:pt x="315468" y="261748"/>
+                </a:lnTo>
+                <a:lnTo>
+                  <a:pt x="420624" y="304394"/>
+                </a:lnTo>
+                <a:lnTo>
+                  <a:pt x="525780" y="345643"/>
+                </a:lnTo>
+                <a:lnTo>
+                  <a:pt x="630936" y="385539"/>
+                </a:lnTo>
+                <a:lnTo>
+                  <a:pt x="736092" y="424127"/>
+                </a:lnTo>
+                <a:lnTo>
+                  <a:pt x="841248" y="461450"/>
+                </a:lnTo>
+                <a:lnTo>
+                  <a:pt x="946404" y="497550"/>
+                </a:lnTo>
+                <a:lnTo>
+                  <a:pt x="1051560" y="532466"/>
+                </a:lnTo>
+                <a:lnTo>
+                  <a:pt x="1156716" y="566237"/>
+                </a:lnTo>
+                <a:lnTo>
+                  <a:pt x="1261872" y="598901"/>
+                </a:lnTo>
+                <a:lnTo>
+                  <a:pt x="1367028" y="630495"/>
+                </a:lnTo>
+                <a:lnTo>
+                  <a:pt x="1472184" y="661052"/>
+                </a:lnTo>
+                <a:lnTo>
+                  <a:pt x="1577340" y="690608"/>
+                </a:lnTo>
+                <a:lnTo>
+                  <a:pt x="1682496" y="719195"/>
+                </a:lnTo>
+                <a:lnTo>
+                  <a:pt x="1787652" y="746844"/>
+                </a:lnTo>
+                <a:lnTo>
+                  <a:pt x="1892808" y="773588"/>
+                </a:lnTo>
+                <a:lnTo>
+                  <a:pt x="1997964" y="799454"/>
+                </a:lnTo>
+                <a:lnTo>
+                  <a:pt x="2103120" y="824472"/>
+                </a:lnTo>
+                <a:lnTo>
+                  <a:pt x="2208276" y="848671"/>
+                </a:lnTo>
+                <a:lnTo>
+                  <a:pt x="2313432" y="872076"/>
+                </a:lnTo>
+                <a:lnTo>
+                  <a:pt x="2418588" y="894713"/>
+                </a:lnTo>
+                <a:lnTo>
+                  <a:pt x="2523744" y="916609"/>
+                </a:lnTo>
+                <a:lnTo>
+                  <a:pt x="2628900" y="937786"/>
+                </a:lnTo>
+                <a:lnTo>
+                  <a:pt x="2734056" y="958270"/>
+                </a:lnTo>
+                <a:lnTo>
+                  <a:pt x="2839212" y="978081"/>
+                </a:lnTo>
+                <a:lnTo>
+                  <a:pt x="2944368" y="997244"/>
+                </a:lnTo>
+                <a:lnTo>
+                  <a:pt x="3049524" y="1015778"/>
+                </a:lnTo>
+                <a:lnTo>
+                  <a:pt x="3154680" y="1033704"/>
+                </a:lnTo>
+                <a:lnTo>
+                  <a:pt x="3259836" y="1051043"/>
+                </a:lnTo>
+                <a:lnTo>
+                  <a:pt x="3364992" y="1067814"/>
+                </a:lnTo>
+                <a:lnTo>
+                  <a:pt x="3470148" y="1084034"/>
+                </a:lnTo>
+                <a:lnTo>
+                  <a:pt x="3575304" y="1099723"/>
+                </a:lnTo>
+                <a:lnTo>
+                  <a:pt x="3680460" y="1114897"/>
+                </a:lnTo>
+                <a:lnTo>
+                  <a:pt x="3785616" y="1129574"/>
+                </a:lnTo>
+                <a:lnTo>
+                  <a:pt x="3890772" y="1143770"/>
+                </a:lnTo>
+                <a:lnTo>
+                  <a:pt x="3995928" y="1157501"/>
+                </a:lnTo>
+                <a:lnTo>
+                  <a:pt x="4101084" y="1170781"/>
+                </a:lnTo>
+                <a:lnTo>
+                  <a:pt x="4206240" y="1183626"/>
+                </a:lnTo>
+                <a:lnTo>
+                  <a:pt x="4311396" y="1196049"/>
+                </a:lnTo>
+                <a:lnTo>
+                  <a:pt x="4416552" y="1208066"/>
+                </a:lnTo>
+                <a:lnTo>
+                  <a:pt x="4521708" y="1219688"/>
+                </a:lnTo>
+                <a:lnTo>
+                  <a:pt x="4626864" y="1230930"/>
+                </a:lnTo>
+                <a:lnTo>
+                  <a:pt x="4732020" y="1241803"/>
+                </a:lnTo>
+                <a:lnTo>
+                  <a:pt x="4837176" y="1252319"/>
+                </a:lnTo>
+                <a:lnTo>
+                  <a:pt x="4942332" y="1262491"/>
+                </a:lnTo>
+                <a:lnTo>
+                  <a:pt x="5047488" y="1272329"/>
+                </a:lnTo>
+                <a:lnTo>
+                  <a:pt x="5152644" y="1281845"/>
+                </a:lnTo>
+                <a:lnTo>
+                  <a:pt x="5257800" y="1291049"/>
+                </a:lnTo>
+                <a:lnTo>
+                  <a:pt x="5362956" y="1299951"/>
+                </a:lnTo>
+                <a:lnTo>
+                  <a:pt x="5468112" y="1308561"/>
+                </a:lnTo>
+                <a:lnTo>
+                  <a:pt x="5573268" y="1316889"/>
+                </a:lnTo>
+                <a:lnTo>
+                  <a:pt x="5678424" y="1324944"/>
+                </a:lnTo>
+                <a:lnTo>
+                  <a:pt x="5783580" y="1332735"/>
+                </a:lnTo>
+                <a:lnTo>
+                  <a:pt x="5888736" y="1340270"/>
+                </a:lnTo>
+                <a:lnTo>
+                  <a:pt x="5993892" y="1347559"/>
+                </a:lnTo>
+                <a:lnTo>
+                  <a:pt x="5993892" y="1347559"/>
+                </a:lnTo>
+              </a:path>
+            </a:pathLst>
+          </a:custGeom>
+          <a:ln w="25400">
+            <a:solidFill>
+              <a:srgbClr val="8C564B"/>
+            </a:solidFill>
+            <a:prstDash val="solid"/>
+          </a:ln>
+        </p:spPr>
+      </p:sp>
+      <p:sp>
+        <p:nvSpPr>
+          <p:cNvPr id="39" name="Glutes (hip extensors) at day 60"/>
+          <p:cNvSpPr/>
+          <p:nvPr/>
+        </p:nvSpPr>
+        <p:spPr>
+          <a:xfrm>
+            <a:off x="4338828" y="2309050"/>
+            <a:ext cx="100584" cy="100584"/>
+          </a:xfrm>
+          <a:prstGeom prst="ellipse">
+            <a:avLst/>
+          </a:prstGeom>
+          <a:solidFill>
+            <a:srgbClr val="8C564B"/>
+          </a:solidFill>
+          <a:ln w="6350">
+            <a:solidFill>
+              <a:srgbClr val="FFFFFF"/>
+            </a:solidFill>
+            <a:prstDash val="solid"/>
+          </a:ln>
+        </p:spPr>
+      </p:sp>
+      <p:sp>
+        <p:nvSpPr>
+          <p:cNvPr id="40" name="Hip flexors curve"/>
+          <p:cNvSpPr/>
+          <p:nvPr/>
+        </p:nvSpPr>
+        <p:spPr>
+          <a:xfrm>
+            <a:off x="1497330" y="1371600"/>
+            <a:ext cx="5993892" cy="1502196"/>
+          </a:xfrm>
+          <a:custGeom>
+            <a:avLst/>
+            <a:gdLst/>
+            <a:ahLst/>
+            <a:cxnLst/>
+            <a:rect l="l" t="t" r="r" b="b"/>
+            <a:pathLst>
+              <a:path w="5993892" h="1502196">
+                <a:moveTo>
+                  <a:pt x="0" y="139275"/>
+                </a:moveTo>
+                <a:lnTo>
+                  <a:pt x="105156" y="191815"/>
+                </a:lnTo>
+                <a:lnTo>
+                  <a:pt x="210312" y="242633"/>
+                </a:lnTo>
+                <a:lnTo>
+                  <a:pt x="315468" y="291784"/>
+                </a:lnTo>
+                <a:lnTo>
+                  <a:pt x="420624" y="339325"/>
+                </a:lnTo>
+                <a:lnTo>
+                  <a:pt x="525780" y="385307"/>
+                </a:lnTo>
+                <a:lnTo>
+                  <a:pt x="630936" y="429781"/>
+                </a:lnTo>
+                <a:lnTo>
+                  <a:pt x="736092" y="472797"/>
+                </a:lnTo>
+                <a:lnTo>
+                  <a:pt x="841248" y="514403"/>
+                </a:lnTo>
+                <a:lnTo>
+                  <a:pt x="946404" y="554646"/>
+                </a:lnTo>
+                <a:lnTo>
+                  <a:pt x="1051560" y="593568"/>
+                </a:lnTo>
+                <a:lnTo>
+                  <a:pt x="1156716" y="631215"/>
+                </a:lnTo>
+                <a:lnTo>
+                  <a:pt x="1261872" y="667628"/>
+                </a:lnTo>
+                <a:lnTo>
+                  <a:pt x="1367028" y="702846"/>
+                </a:lnTo>
+                <a:lnTo>
+                  <a:pt x="1472184" y="736911"/>
+                </a:lnTo>
+                <a:lnTo>
+                  <a:pt x="1577340" y="769858"/>
+                </a:lnTo>
+                <a:lnTo>
+                  <a:pt x="1682496" y="801725"/>
+                </a:lnTo>
+                <a:lnTo>
+                  <a:pt x="1787652" y="832548"/>
+                </a:lnTo>
+                <a:lnTo>
+                  <a:pt x="1892808" y="862360"/>
+                </a:lnTo>
+                <a:lnTo>
+                  <a:pt x="1997964" y="891195"/>
+                </a:lnTo>
+                <a:lnTo>
+                  <a:pt x="2103120" y="919084"/>
+                </a:lnTo>
+                <a:lnTo>
+                  <a:pt x="2208276" y="946059"/>
+                </a:lnTo>
+                <a:lnTo>
+                  <a:pt x="2313432" y="972150"/>
+                </a:lnTo>
+                <a:lnTo>
+                  <a:pt x="2418588" y="997385"/>
+                </a:lnTo>
+                <a:lnTo>
+                  <a:pt x="2523744" y="1021793"/>
+                </a:lnTo>
+                <a:lnTo>
+                  <a:pt x="2628900" y="1045401"/>
+                </a:lnTo>
+                <a:lnTo>
+                  <a:pt x="2734056" y="1068235"/>
+                </a:lnTo>
+                <a:lnTo>
+                  <a:pt x="2839212" y="1090320"/>
+                </a:lnTo>
+                <a:lnTo>
+                  <a:pt x="2944368" y="1111682"/>
+                </a:lnTo>
+                <a:lnTo>
+                  <a:pt x="3049524" y="1132343"/>
+                </a:lnTo>
+                <a:lnTo>
+                  <a:pt x="3154680" y="1152326"/>
+                </a:lnTo>
+                <a:lnTo>
+                  <a:pt x="3259836" y="1171655"/>
+                </a:lnTo>
+                <a:lnTo>
+                  <a:pt x="3364992" y="1190350"/>
+                </a:lnTo>
+                <a:lnTo>
+                  <a:pt x="3470148" y="1208431"/>
+                </a:lnTo>
+                <a:lnTo>
+                  <a:pt x="3575304" y="1225921"/>
+                </a:lnTo>
+                <a:lnTo>
+                  <a:pt x="3680460" y="1242836"/>
+                </a:lnTo>
+                <a:lnTo>
+                  <a:pt x="3785616" y="1259198"/>
+                </a:lnTo>
+                <a:lnTo>
+                  <a:pt x="3890772" y="1275022"/>
+                </a:lnTo>
+                <a:lnTo>
+                  <a:pt x="3995928" y="1290328"/>
+                </a:lnTo>
+                <a:lnTo>
+                  <a:pt x="4101084" y="1305133"/>
+                </a:lnTo>
+                <a:lnTo>
+                  <a:pt x="4206240" y="1319452"/>
+                </a:lnTo>
+                <a:lnTo>
+                  <a:pt x="4311396" y="1333301"/>
+                </a:lnTo>
+                <a:lnTo>
+                  <a:pt x="4416552" y="1346696"/>
+                </a:lnTo>
+                <a:lnTo>
+                  <a:pt x="4521708" y="1359653"/>
+                </a:lnTo>
+                <a:lnTo>
+                  <a:pt x="4626864" y="1372184"/>
+                </a:lnTo>
+                <a:lnTo>
+                  <a:pt x="4732020" y="1384305"/>
+                </a:lnTo>
+                <a:lnTo>
+                  <a:pt x="4837176" y="1396028"/>
+                </a:lnTo>
+                <a:lnTo>
+                  <a:pt x="4942332" y="1407367"/>
+                </a:lnTo>
+                <a:lnTo>
+                  <a:pt x="5047488" y="1418334"/>
+                </a:lnTo>
+                <a:lnTo>
+                  <a:pt x="5152644" y="1428942"/>
+                </a:lnTo>
+                <a:lnTo>
+                  <a:pt x="5257800" y="1439202"/>
+                </a:lnTo>
+                <a:lnTo>
+                  <a:pt x="5362956" y="1449126"/>
+                </a:lnTo>
+                <a:lnTo>
+                  <a:pt x="5468112" y="1458724"/>
+                </a:lnTo>
+                <a:lnTo>
+                  <a:pt x="5573268" y="1468008"/>
+                </a:lnTo>
+                <a:lnTo>
+                  <a:pt x="5678424" y="1476987"/>
+                </a:lnTo>
+                <a:lnTo>
+                  <a:pt x="5783580" y="1485672"/>
+                </a:lnTo>
+                <a:lnTo>
+                  <a:pt x="5888736" y="1494072"/>
+                </a:lnTo>
+                <a:lnTo>
+                  <a:pt x="5993892" y="1502196"/>
+                </a:lnTo>
+                <a:lnTo>
+                  <a:pt x="5993892" y="1502196"/>
+                </a:lnTo>
+              </a:path>
+            </a:pathLst>
+          </a:custGeom>
+          <a:ln w="25400">
+            <a:solidFill>
+              <a:srgbClr val="2E8B57"/>
+            </a:solidFill>
+            <a:prstDash val="solid"/>
+          </a:ln>
+        </p:spPr>
+      </p:sp>
+      <p:sp>
+        <p:nvSpPr>
+          <p:cNvPr id="41" name="Hip flexors at day 60"/>
+          <p:cNvSpPr/>
+          <p:nvPr/>
+        </p:nvSpPr>
+        <p:spPr>
+          <a:xfrm>
+            <a:off x="4338828" y="2422398"/>
+            <a:ext cx="100584" cy="100584"/>
+          </a:xfrm>
+          <a:prstGeom prst="ellipse">
+            <a:avLst/>
+          </a:prstGeom>
+          <a:solidFill>
+            <a:srgbClr val="2E8B57"/>
+          </a:solidFill>
+          <a:ln w="6350">
+            <a:solidFill>
+              <a:srgbClr val="FFFFFF"/>
+            </a:solidFill>
+            <a:prstDash val="solid"/>
+          </a:ln>
+        </p:spPr>
+      </p:sp>
+      <p:sp>
+        <p:nvSpPr>
+          <p:cNvPr id="42" name="Outer hip (hip abductors) curve"/>
+          <p:cNvSpPr/>
+          <p:nvPr/>
+        </p:nvSpPr>
+        <p:spPr>
+          <a:xfrm>
+            <a:off x="1497330" y="1371600"/>
+            <a:ext cx="5993892" cy="2010292"/>
+          </a:xfrm>
+          <a:custGeom>
+            <a:avLst/>
+            <a:gdLst/>
+            <a:ahLst/>
+            <a:cxnLst/>
+            <a:rect l="l" t="t" r="r" b="b"/>
+            <a:pathLst>
+              <a:path w="5993892" h="2010292">
+                <a:moveTo>
+                  <a:pt x="0" y="186382"/>
+                </a:moveTo>
+                <a:lnTo>
+                  <a:pt x="105156" y="256693"/>
+                </a:lnTo>
+                <a:lnTo>
+                  <a:pt x="210312" y="324700"/>
+                </a:lnTo>
+                <a:lnTo>
+                  <a:pt x="315468" y="390476"/>
+                </a:lnTo>
+                <a:lnTo>
+                  <a:pt x="420624" y="454096"/>
+                </a:lnTo>
+                <a:lnTo>
+                  <a:pt x="525780" y="515631"/>
+                </a:lnTo>
+                <a:lnTo>
+                  <a:pt x="630936" y="575148"/>
+                </a:lnTo>
+                <a:lnTo>
+                  <a:pt x="736092" y="632714"/>
+                </a:lnTo>
+                <a:lnTo>
+                  <a:pt x="841248" y="688393"/>
+                </a:lnTo>
+                <a:lnTo>
+                  <a:pt x="946404" y="742246"/>
+                </a:lnTo>
+                <a:lnTo>
+                  <a:pt x="1051560" y="794334"/>
+                </a:lnTo>
+                <a:lnTo>
+                  <a:pt x="1156716" y="844714"/>
+                </a:lnTo>
+                <a:lnTo>
+                  <a:pt x="1261872" y="893443"/>
+                </a:lnTo>
+                <a:lnTo>
+                  <a:pt x="1367028" y="940574"/>
+                </a:lnTo>
+                <a:lnTo>
+                  <a:pt x="1472184" y="986160"/>
+                </a:lnTo>
+                <a:lnTo>
+                  <a:pt x="1577340" y="1030251"/>
+                </a:lnTo>
+                <a:lnTo>
+                  <a:pt x="1682496" y="1072897"/>
+                </a:lnTo>
+                <a:lnTo>
+                  <a:pt x="1787652" y="1114145"/>
+                </a:lnTo>
+                <a:lnTo>
+                  <a:pt x="1892808" y="1154040"/>
+                </a:lnTo>
+                <a:lnTo>
+                  <a:pt x="1997964" y="1192628"/>
+                </a:lnTo>
+                <a:lnTo>
+                  <a:pt x="2103120" y="1229951"/>
+                </a:lnTo>
+                <a:lnTo>
+                  <a:pt x="2208276" y="1266050"/>
+                </a:lnTo>
+                <a:lnTo>
+                  <a:pt x="2313432" y="1300965"/>
+                </a:lnTo>
+                <a:lnTo>
+                  <a:pt x="2418588" y="1334736"/>
+                </a:lnTo>
+                <a:lnTo>
+                  <a:pt x="2523744" y="1367400"/>
+                </a:lnTo>
+                <a:lnTo>
+                  <a:pt x="2628900" y="1398993"/>
+                </a:lnTo>
+                <a:lnTo>
+                  <a:pt x="2734056" y="1429550"/>
+                </a:lnTo>
+                <a:lnTo>
+                  <a:pt x="2839212" y="1459105"/>
+                </a:lnTo>
+                <a:lnTo>
+                  <a:pt x="2944368" y="1487692"/>
+                </a:lnTo>
+                <a:lnTo>
+                  <a:pt x="3049524" y="1515341"/>
+                </a:lnTo>
+                <a:lnTo>
+                  <a:pt x="3154680" y="1542084"/>
+                </a:lnTo>
+                <a:lnTo>
+                  <a:pt x="3259836" y="1567950"/>
+                </a:lnTo>
+                <a:lnTo>
+                  <a:pt x="3364992" y="1592968"/>
+                </a:lnTo>
+                <a:lnTo>
+                  <a:pt x="3470148" y="1617166"/>
+                </a:lnTo>
+                <a:lnTo>
+                  <a:pt x="3575304" y="1640570"/>
+                </a:lnTo>
+                <a:lnTo>
+                  <a:pt x="3680460" y="1663208"/>
+                </a:lnTo>
+                <a:lnTo>
+                  <a:pt x="3785616" y="1685103"/>
+                </a:lnTo>
+                <a:lnTo>
+                  <a:pt x="3890772" y="1706280"/>
+                </a:lnTo>
+                <a:lnTo>
+                  <a:pt x="3995928" y="1726763"/>
+                </a:lnTo>
+                <a:lnTo>
+                  <a:pt x="4101084" y="1746575"/>
+                </a:lnTo>
+                <a:lnTo>
+                  <a:pt x="4206240" y="1765737"/>
+                </a:lnTo>
+                <a:lnTo>
+                  <a:pt x="4311396" y="1784271"/>
+                </a:lnTo>
+                <a:lnTo>
+                  <a:pt x="4416552" y="1802197"/>
+                </a:lnTo>
+                <a:lnTo>
+                  <a:pt x="4521708" y="1819535"/>
+                </a:lnTo>
+                <a:lnTo>
+                  <a:pt x="4626864" y="1836305"/>
+                </a:lnTo>
+                <a:lnTo>
+                  <a:pt x="4732020" y="1852526"/>
+                </a:lnTo>
+                <a:lnTo>
+                  <a:pt x="4837176" y="1868214"/>
+                </a:lnTo>
+                <a:lnTo>
+                  <a:pt x="4942332" y="1883389"/>
+                </a:lnTo>
+                <a:lnTo>
+                  <a:pt x="5047488" y="1898065"/>
+                </a:lnTo>
+                <a:lnTo>
+                  <a:pt x="5152644" y="1912261"/>
+                </a:lnTo>
+                <a:lnTo>
+                  <a:pt x="5257800" y="1925991"/>
+                </a:lnTo>
+                <a:lnTo>
+                  <a:pt x="5362956" y="1939271"/>
+                </a:lnTo>
+                <a:lnTo>
+                  <a:pt x="5468112" y="1952116"/>
+                </a:lnTo>
+                <a:lnTo>
+                  <a:pt x="5573268" y="1964539"/>
+                </a:lnTo>
+                <a:lnTo>
+                  <a:pt x="5678424" y="1976556"/>
+                </a:lnTo>
+                <a:lnTo>
+                  <a:pt x="5783580" y="1988178"/>
+                </a:lnTo>
+                <a:lnTo>
+                  <a:pt x="5888736" y="1999419"/>
+                </a:lnTo>
+                <a:lnTo>
+                  <a:pt x="5993892" y="2010292"/>
+                </a:lnTo>
+                <a:lnTo>
+                  <a:pt x="5993892" y="2010292"/>
+                </a:lnTo>
+              </a:path>
+            </a:pathLst>
+          </a:custGeom>
+          <a:ln w="25400">
+            <a:solidFill>
+              <a:srgbClr val="7B6BA8"/>
+            </a:solidFill>
+            <a:prstDash val="solid"/>
+          </a:ln>
+        </p:spPr>
+      </p:sp>
+      <p:sp>
+        <p:nvSpPr>
+          <p:cNvPr id="43" name="Outer hip (hip abductors) at day 60"/>
+          <p:cNvSpPr/>
+          <p:nvPr/>
+        </p:nvSpPr>
+        <p:spPr>
+          <a:xfrm>
+            <a:off x="4338828" y="2794825"/>
+            <a:ext cx="100584" cy="100584"/>
+          </a:xfrm>
+          <a:prstGeom prst="ellipse">
+            <a:avLst/>
+          </a:prstGeom>
+          <a:solidFill>
+            <a:srgbClr val="7B6BA8"/>
+          </a:solidFill>
+          <a:ln w="6350">
+            <a:solidFill>
+              <a:srgbClr val="FFFFFF"/>
+            </a:solidFill>
+            <a:prstDash val="solid"/>
+          </a:ln>
+        </p:spPr>
+      </p:sp>
+      <p:sp>
+        <p:nvSpPr>
+          <p:cNvPr id="44" name="Back thigh (knee flexors) curve"/>
+          <p:cNvSpPr/>
+          <p:nvPr/>
+        </p:nvSpPr>
+        <p:spPr>
+          <a:xfrm>
+            <a:off x="1497330" y="1371600"/>
+            <a:ext cx="5993892" cy="2164930"/>
+          </a:xfrm>
+          <a:custGeom>
+            <a:avLst/>
+            <a:gdLst/>
+            <a:ahLst/>
+            <a:cxnLst/>
+            <a:rect l="l" t="t" r="r" b="b"/>
+            <a:pathLst>
+              <a:path w="5993892" h="2164930">
+                <a:moveTo>
+                  <a:pt x="0" y="200719"/>
+                </a:moveTo>
+                <a:lnTo>
+                  <a:pt x="105156" y="276439"/>
+                </a:lnTo>
+                <a:lnTo>
+                  <a:pt x="210312" y="349676"/>
+                </a:lnTo>
+                <a:lnTo>
+                  <a:pt x="315468" y="420513"/>
+                </a:lnTo>
+                <a:lnTo>
+                  <a:pt x="420624" y="489027"/>
+                </a:lnTo>
+                <a:lnTo>
+                  <a:pt x="525780" y="555295"/>
+                </a:lnTo>
+                <a:lnTo>
+                  <a:pt x="630936" y="619390"/>
+                </a:lnTo>
+                <a:lnTo>
+                  <a:pt x="736092" y="681384"/>
+                </a:lnTo>
+                <a:lnTo>
+                  <a:pt x="841248" y="741346"/>
+                </a:lnTo>
+                <a:lnTo>
+                  <a:pt x="946404" y="799342"/>
+                </a:lnTo>
+                <a:lnTo>
+                  <a:pt x="1051560" y="855437"/>
+                </a:lnTo>
+                <a:lnTo>
+                  <a:pt x="1156716" y="909692"/>
+                </a:lnTo>
+                <a:lnTo>
+                  <a:pt x="1261872" y="962169"/>
+                </a:lnTo>
+                <a:lnTo>
+                  <a:pt x="1367028" y="1012926"/>
+                </a:lnTo>
+                <a:lnTo>
+                  <a:pt x="1472184" y="1062018"/>
+                </a:lnTo>
+                <a:lnTo>
+                  <a:pt x="1577340" y="1109501"/>
+                </a:lnTo>
+                <a:lnTo>
+                  <a:pt x="1682496" y="1155428"/>
+                </a:lnTo>
+                <a:lnTo>
+                  <a:pt x="1787652" y="1199848"/>
+                </a:lnTo>
+                <a:lnTo>
+                  <a:pt x="1892808" y="1242813"/>
+                </a:lnTo>
+                <a:lnTo>
+                  <a:pt x="1997964" y="1284369"/>
+                </a:lnTo>
+                <a:lnTo>
+                  <a:pt x="2103120" y="1324562"/>
+                </a:lnTo>
+                <a:lnTo>
+                  <a:pt x="2208276" y="1363438"/>
+                </a:lnTo>
+                <a:lnTo>
+                  <a:pt x="2313432" y="1401039"/>
+                </a:lnTo>
+                <a:lnTo>
+                  <a:pt x="2418588" y="1437408"/>
+                </a:lnTo>
+                <a:lnTo>
+                  <a:pt x="2523744" y="1472584"/>
+                </a:lnTo>
+                <a:lnTo>
+                  <a:pt x="2628900" y="1506608"/>
+                </a:lnTo>
+                <a:lnTo>
+                  <a:pt x="2734056" y="1539515"/>
+                </a:lnTo>
+                <a:lnTo>
+                  <a:pt x="2839212" y="1571344"/>
+                </a:lnTo>
+                <a:lnTo>
+                  <a:pt x="2944368" y="1602129"/>
+                </a:lnTo>
+                <a:lnTo>
+                  <a:pt x="3049524" y="1631906"/>
+                </a:lnTo>
+                <a:lnTo>
+                  <a:pt x="3154680" y="1660705"/>
+                </a:lnTo>
+                <a:lnTo>
+                  <a:pt x="3259836" y="1688561"/>
+                </a:lnTo>
+                <a:lnTo>
+                  <a:pt x="3364992" y="1715504"/>
+                </a:lnTo>
+                <a:lnTo>
+                  <a:pt x="3470148" y="1741563"/>
+                </a:lnTo>
+                <a:lnTo>
+                  <a:pt x="3575304" y="1766768"/>
+                </a:lnTo>
+                <a:lnTo>
+                  <a:pt x="3680460" y="1791147"/>
+                </a:lnTo>
+                <a:lnTo>
+                  <a:pt x="3785616" y="1814726"/>
+                </a:lnTo>
+                <a:lnTo>
+                  <a:pt x="3890772" y="1837532"/>
+                </a:lnTo>
+                <a:lnTo>
+                  <a:pt x="3995928" y="1859591"/>
+                </a:lnTo>
+                <a:lnTo>
+                  <a:pt x="4101084" y="1880927"/>
+                </a:lnTo>
+                <a:lnTo>
+                  <a:pt x="4206240" y="1901563"/>
+                </a:lnTo>
+                <a:lnTo>
+                  <a:pt x="4311396" y="1921522"/>
+                </a:lnTo>
+                <a:lnTo>
+                  <a:pt x="4416552" y="1940827"/>
+                </a:lnTo>
+                <a:lnTo>
+                  <a:pt x="4521708" y="1959500"/>
+                </a:lnTo>
+                <a:lnTo>
+                  <a:pt x="4626864" y="1977560"/>
+                </a:lnTo>
+                <a:lnTo>
+                  <a:pt x="4732020" y="1995028"/>
+                </a:lnTo>
+                <a:lnTo>
+                  <a:pt x="4837176" y="2011923"/>
+                </a:lnTo>
+                <a:lnTo>
+                  <a:pt x="4942332" y="2028265"/>
+                </a:lnTo>
+                <a:lnTo>
+                  <a:pt x="5047488" y="2044070"/>
+                </a:lnTo>
+                <a:lnTo>
+                  <a:pt x="5152644" y="2059358"/>
+                </a:lnTo>
+                <a:lnTo>
+                  <a:pt x="5257800" y="2074144"/>
+                </a:lnTo>
+                <a:lnTo>
+                  <a:pt x="5362956" y="2088446"/>
+                </a:lnTo>
+                <a:lnTo>
+                  <a:pt x="5468112" y="2102279"/>
+                </a:lnTo>
+                <a:lnTo>
+                  <a:pt x="5573268" y="2115658"/>
+                </a:lnTo>
+                <a:lnTo>
+                  <a:pt x="5678424" y="2128599"/>
+                </a:lnTo>
+                <a:lnTo>
+                  <a:pt x="5783580" y="2141115"/>
+                </a:lnTo>
+                <a:lnTo>
+                  <a:pt x="5888736" y="2153221"/>
+                </a:lnTo>
+                <a:lnTo>
+                  <a:pt x="5993892" y="2164930"/>
+                </a:lnTo>
+                <a:lnTo>
+                  <a:pt x="5993892" y="2164930"/>
+                </a:lnTo>
+              </a:path>
+            </a:pathLst>
+          </a:custGeom>
+          <a:ln w="25400">
+            <a:solidFill>
+              <a:srgbClr val="4C78A8"/>
+            </a:solidFill>
+            <a:prstDash val="solid"/>
+          </a:ln>
+        </p:spPr>
+      </p:sp>
+      <p:sp>
+        <p:nvSpPr>
+          <p:cNvPr id="45" name="Back thigh (knee flexors) at day 60"/>
+          <p:cNvSpPr/>
+          <p:nvPr/>
+        </p:nvSpPr>
+        <p:spPr>
+          <a:xfrm>
+            <a:off x="4338828" y="2908173"/>
+            <a:ext cx="100584" cy="100584"/>
+          </a:xfrm>
+          <a:prstGeom prst="ellipse">
+            <a:avLst/>
+          </a:prstGeom>
+          <a:solidFill>
+            <a:srgbClr val="4C78A8"/>
+          </a:solidFill>
+          <a:ln w="6350">
+            <a:solidFill>
+              <a:srgbClr val="FFFFFF"/>
+            </a:solidFill>
+            <a:prstDash val="solid"/>
+          </a:ln>
+        </p:spPr>
+      </p:sp>
+      <p:sp>
+        <p:nvSpPr>
+          <p:cNvPr id="46" name="Front thigh (knee extensors) curve"/>
+          <p:cNvSpPr/>
+          <p:nvPr/>
+        </p:nvSpPr>
+        <p:spPr>
+          <a:xfrm>
+            <a:off x="1497330" y="1371600"/>
+            <a:ext cx="5993892" cy="2231204"/>
+          </a:xfrm>
+          <a:custGeom>
+            <a:avLst/>
+            <a:gdLst/>
+            <a:ahLst/>
+            <a:cxnLst/>
+            <a:rect l="l" t="t" r="r" b="b"/>
+            <a:pathLst>
+              <a:path w="5993892" h="2231204">
+                <a:moveTo>
+                  <a:pt x="0" y="206864"/>
+                </a:moveTo>
+                <a:lnTo>
+                  <a:pt x="105156" y="284901"/>
+                </a:lnTo>
+                <a:lnTo>
+                  <a:pt x="210312" y="360381"/>
+                </a:lnTo>
+                <a:lnTo>
+                  <a:pt x="315468" y="433386"/>
+                </a:lnTo>
+                <a:lnTo>
+                  <a:pt x="420624" y="503997"/>
+                </a:lnTo>
+                <a:lnTo>
+                  <a:pt x="525780" y="572294"/>
+                </a:lnTo>
+                <a:lnTo>
+                  <a:pt x="630936" y="638351"/>
+                </a:lnTo>
+                <a:lnTo>
+                  <a:pt x="736092" y="702243"/>
+                </a:lnTo>
+                <a:lnTo>
+                  <a:pt x="841248" y="764040"/>
+                </a:lnTo>
+                <a:lnTo>
+                  <a:pt x="946404" y="823812"/>
+                </a:lnTo>
+                <a:lnTo>
+                  <a:pt x="1051560" y="881624"/>
+                </a:lnTo>
+                <a:lnTo>
+                  <a:pt x="1156716" y="937540"/>
+                </a:lnTo>
+                <a:lnTo>
+                  <a:pt x="1261872" y="991623"/>
+                </a:lnTo>
+                <a:lnTo>
+                  <a:pt x="1367028" y="1043934"/>
+                </a:lnTo>
+                <a:lnTo>
+                  <a:pt x="1472184" y="1094529"/>
+                </a:lnTo>
+                <a:lnTo>
+                  <a:pt x="1577340" y="1143466"/>
+                </a:lnTo>
+                <a:lnTo>
+                  <a:pt x="1682496" y="1190798"/>
+                </a:lnTo>
+                <a:lnTo>
+                  <a:pt x="1787652" y="1236578"/>
+                </a:lnTo>
+                <a:lnTo>
+                  <a:pt x="1892808" y="1280858"/>
+                </a:lnTo>
+                <a:lnTo>
+                  <a:pt x="1997964" y="1323686"/>
+                </a:lnTo>
+                <a:lnTo>
+                  <a:pt x="2103120" y="1365110"/>
+                </a:lnTo>
+                <a:lnTo>
+                  <a:pt x="2208276" y="1405176"/>
+                </a:lnTo>
+                <a:lnTo>
+                  <a:pt x="2313432" y="1443928"/>
+                </a:lnTo>
+                <a:lnTo>
+                  <a:pt x="2418588" y="1481410"/>
+                </a:lnTo>
+                <a:lnTo>
+                  <a:pt x="2523744" y="1517664"/>
+                </a:lnTo>
+                <a:lnTo>
+                  <a:pt x="2628900" y="1552728"/>
+                </a:lnTo>
+                <a:lnTo>
+                  <a:pt x="2734056" y="1586643"/>
+                </a:lnTo>
+                <a:lnTo>
+                  <a:pt x="2839212" y="1619446"/>
+                </a:lnTo>
+                <a:lnTo>
+                  <a:pt x="2944368" y="1651174"/>
+                </a:lnTo>
+                <a:lnTo>
+                  <a:pt x="3049524" y="1681862"/>
+                </a:lnTo>
+                <a:lnTo>
+                  <a:pt x="3154680" y="1711543"/>
+                </a:lnTo>
+                <a:lnTo>
+                  <a:pt x="3259836" y="1740252"/>
+                </a:lnTo>
+                <a:lnTo>
+                  <a:pt x="3364992" y="1768019"/>
+                </a:lnTo>
+                <a:lnTo>
+                  <a:pt x="3470148" y="1794876"/>
+                </a:lnTo>
+                <a:lnTo>
+                  <a:pt x="3575304" y="1820853"/>
+                </a:lnTo>
+                <a:lnTo>
+                  <a:pt x="3680460" y="1845978"/>
+                </a:lnTo>
+                <a:lnTo>
+                  <a:pt x="3785616" y="1870279"/>
+                </a:lnTo>
+                <a:lnTo>
+                  <a:pt x="3890772" y="1893783"/>
+                </a:lnTo>
+                <a:lnTo>
+                  <a:pt x="3995928" y="1916517"/>
+                </a:lnTo>
+                <a:lnTo>
+                  <a:pt x="4101084" y="1938506"/>
+                </a:lnTo>
+                <a:lnTo>
+                  <a:pt x="4206240" y="1959774"/>
+                </a:lnTo>
+                <a:lnTo>
+                  <a:pt x="4311396" y="1980344"/>
+                </a:lnTo>
+                <a:lnTo>
+                  <a:pt x="4416552" y="2000240"/>
+                </a:lnTo>
+                <a:lnTo>
+                  <a:pt x="4521708" y="2019484"/>
+                </a:lnTo>
+                <a:lnTo>
+                  <a:pt x="4626864" y="2038097"/>
+                </a:lnTo>
+                <a:lnTo>
+                  <a:pt x="4732020" y="2056100"/>
+                </a:lnTo>
+                <a:lnTo>
+                  <a:pt x="4837176" y="2073513"/>
+                </a:lnTo>
+                <a:lnTo>
+                  <a:pt x="4942332" y="2090354"/>
+                </a:lnTo>
+                <a:lnTo>
+                  <a:pt x="5047488" y="2106644"/>
+                </a:lnTo>
+                <a:lnTo>
+                  <a:pt x="5152644" y="2122399"/>
+                </a:lnTo>
+                <a:lnTo>
+                  <a:pt x="5257800" y="2137638"/>
+                </a:lnTo>
+                <a:lnTo>
+                  <a:pt x="5362956" y="2152378"/>
+                </a:lnTo>
+                <a:lnTo>
+                  <a:pt x="5468112" y="2166634"/>
+                </a:lnTo>
+                <a:lnTo>
+                  <a:pt x="5573268" y="2180423"/>
+                </a:lnTo>
+                <a:lnTo>
+                  <a:pt x="5678424" y="2193760"/>
+                </a:lnTo>
+                <a:lnTo>
+                  <a:pt x="5783580" y="2206659"/>
+                </a:lnTo>
+                <a:lnTo>
+                  <a:pt x="5888736" y="2219136"/>
+                </a:lnTo>
+                <a:lnTo>
+                  <a:pt x="5993892" y="2231204"/>
+                </a:lnTo>
+                <a:lnTo>
+                  <a:pt x="5993892" y="2231204"/>
+                </a:lnTo>
+              </a:path>
+            </a:pathLst>
+          </a:custGeom>
+          <a:ln w="25400">
+            <a:solidFill>
+              <a:srgbClr val="1F3A5F"/>
+            </a:solidFill>
+            <a:prstDash val="solid"/>
+          </a:ln>
+        </p:spPr>
+      </p:sp>
+      <p:sp>
+        <p:nvSpPr>
+          <p:cNvPr id="47" name="Front thigh (knee extensors) at day 60"/>
+          <p:cNvSpPr/>
+          <p:nvPr/>
+        </p:nvSpPr>
+        <p:spPr>
+          <a:xfrm>
+            <a:off x="4338828" y="2956751"/>
+            <a:ext cx="100584" cy="100584"/>
+          </a:xfrm>
+          <a:prstGeom prst="ellipse">
+            <a:avLst/>
+          </a:prstGeom>
+          <a:solidFill>
+            <a:srgbClr val="1F3A5F"/>
+          </a:solidFill>
+          <a:ln w="6350">
+            <a:solidFill>
+              <a:srgbClr val="FFFFFF"/>
+            </a:solidFill>
+            <a:prstDash val="solid"/>
+          </a:ln>
+        </p:spPr>
+      </p:sp>
+      <p:sp>
+        <p:nvSpPr>
+          <p:cNvPr id="48" name="Shin (dorsiflexors) curve"/>
+          <p:cNvSpPr/>
+          <p:nvPr/>
+        </p:nvSpPr>
+        <p:spPr>
+          <a:xfrm>
+            <a:off x="1497330" y="1371600"/>
+            <a:ext cx="5993892" cy="2253295"/>
+          </a:xfrm>
+          <a:custGeom>
+            <a:avLst/>
+            <a:gdLst/>
+            <a:ahLst/>
+            <a:cxnLst/>
+            <a:rect l="l" t="t" r="r" b="b"/>
+            <a:pathLst>
+              <a:path w="5993892" h="2253295">
+                <a:moveTo>
+                  <a:pt x="0" y="208912"/>
+                </a:moveTo>
+                <a:lnTo>
+                  <a:pt x="105156" y="287722"/>
+                </a:lnTo>
+                <a:lnTo>
+                  <a:pt x="210312" y="363949"/>
+                </a:lnTo>
+                <a:lnTo>
+                  <a:pt x="315468" y="437677"/>
+                </a:lnTo>
+                <a:lnTo>
+                  <a:pt x="420624" y="508987"/>
+                </a:lnTo>
+                <a:lnTo>
+                  <a:pt x="525780" y="577960"/>
+                </a:lnTo>
+                <a:lnTo>
+                  <a:pt x="630936" y="644672"/>
+                </a:lnTo>
+                <a:lnTo>
+                  <a:pt x="736092" y="709196"/>
+                </a:lnTo>
+                <a:lnTo>
+                  <a:pt x="841248" y="771605"/>
+                </a:lnTo>
+                <a:lnTo>
+                  <a:pt x="946404" y="831968"/>
+                </a:lnTo>
+                <a:lnTo>
+                  <a:pt x="1051560" y="890352"/>
+                </a:lnTo>
+                <a:lnTo>
+                  <a:pt x="1156716" y="946823"/>
+                </a:lnTo>
+                <a:lnTo>
+                  <a:pt x="1261872" y="1001441"/>
+                </a:lnTo>
+                <a:lnTo>
+                  <a:pt x="1367028" y="1054270"/>
+                </a:lnTo>
+                <a:lnTo>
+                  <a:pt x="1472184" y="1105366"/>
+                </a:lnTo>
+                <a:lnTo>
+                  <a:pt x="1577340" y="1154787"/>
+                </a:lnTo>
+                <a:lnTo>
+                  <a:pt x="1682496" y="1202588"/>
+                </a:lnTo>
+                <a:lnTo>
+                  <a:pt x="1787652" y="1248822"/>
+                </a:lnTo>
+                <a:lnTo>
+                  <a:pt x="1892808" y="1293540"/>
+                </a:lnTo>
+                <a:lnTo>
+                  <a:pt x="1997964" y="1336792"/>
+                </a:lnTo>
+                <a:lnTo>
+                  <a:pt x="2103120" y="1378626"/>
+                </a:lnTo>
+                <a:lnTo>
+                  <a:pt x="2208276" y="1419089"/>
+                </a:lnTo>
+                <a:lnTo>
+                  <a:pt x="2313432" y="1458225"/>
+                </a:lnTo>
+                <a:lnTo>
+                  <a:pt x="2418588" y="1496078"/>
+                </a:lnTo>
+                <a:lnTo>
+                  <a:pt x="2523744" y="1532690"/>
+                </a:lnTo>
+                <a:lnTo>
+                  <a:pt x="2628900" y="1568102"/>
+                </a:lnTo>
+                <a:lnTo>
+                  <a:pt x="2734056" y="1602353"/>
+                </a:lnTo>
+                <a:lnTo>
+                  <a:pt x="2839212" y="1635481"/>
+                </a:lnTo>
+                <a:lnTo>
+                  <a:pt x="2944368" y="1667522"/>
+                </a:lnTo>
+                <a:lnTo>
+                  <a:pt x="3049524" y="1698514"/>
+                </a:lnTo>
+                <a:lnTo>
+                  <a:pt x="3154680" y="1728489"/>
+                </a:lnTo>
+                <a:lnTo>
+                  <a:pt x="3259836" y="1757482"/>
+                </a:lnTo>
+                <a:lnTo>
+                  <a:pt x="3364992" y="1785524"/>
+                </a:lnTo>
+                <a:lnTo>
+                  <a:pt x="3470148" y="1812647"/>
+                </a:lnTo>
+                <a:lnTo>
+                  <a:pt x="3575304" y="1838881"/>
+                </a:lnTo>
+                <a:lnTo>
+                  <a:pt x="3680460" y="1864255"/>
+                </a:lnTo>
+                <a:lnTo>
+                  <a:pt x="3785616" y="1888796"/>
+                </a:lnTo>
+                <a:lnTo>
+                  <a:pt x="3890772" y="1912534"/>
+                </a:lnTo>
+                <a:lnTo>
+                  <a:pt x="3995928" y="1935493"/>
+                </a:lnTo>
+                <a:lnTo>
+                  <a:pt x="4101084" y="1957699"/>
+                </a:lnTo>
+                <a:lnTo>
+                  <a:pt x="4206240" y="1979177"/>
+                </a:lnTo>
+                <a:lnTo>
+                  <a:pt x="4311396" y="1999952"/>
+                </a:lnTo>
+                <a:lnTo>
+                  <a:pt x="4416552" y="2020045"/>
+                </a:lnTo>
+                <a:lnTo>
+                  <a:pt x="4521708" y="2039479"/>
+                </a:lnTo>
+                <a:lnTo>
+                  <a:pt x="4626864" y="2058276"/>
+                </a:lnTo>
+                <a:lnTo>
+                  <a:pt x="4732020" y="2076457"/>
+                </a:lnTo>
+                <a:lnTo>
+                  <a:pt x="4837176" y="2094042"/>
+                </a:lnTo>
+                <a:lnTo>
+                  <a:pt x="4942332" y="2111051"/>
+                </a:lnTo>
+                <a:lnTo>
+                  <a:pt x="5047488" y="2127502"/>
+                </a:lnTo>
+                <a:lnTo>
+                  <a:pt x="5152644" y="2143413"/>
+                </a:lnTo>
+                <a:lnTo>
+                  <a:pt x="5257800" y="2158803"/>
+                </a:lnTo>
+                <a:lnTo>
+                  <a:pt x="5362956" y="2173689"/>
+                </a:lnTo>
+                <a:lnTo>
+                  <a:pt x="5468112" y="2188086"/>
+                </a:lnTo>
+                <a:lnTo>
+                  <a:pt x="5573268" y="2202011"/>
+                </a:lnTo>
+                <a:lnTo>
+                  <a:pt x="5678424" y="2215480"/>
+                </a:lnTo>
+                <a:lnTo>
+                  <a:pt x="5783580" y="2228507"/>
+                </a:lnTo>
+                <a:lnTo>
+                  <a:pt x="5888736" y="2241108"/>
+                </a:lnTo>
+                <a:lnTo>
+                  <a:pt x="5993892" y="2253295"/>
+                </a:lnTo>
+                <a:lnTo>
+                  <a:pt x="5993892" y="2253295"/>
+                </a:lnTo>
+              </a:path>
+            </a:pathLst>
+          </a:custGeom>
+          <a:ln w="25400">
+            <a:solidFill>
+              <a:srgbClr val="D08C34"/>
+            </a:solidFill>
+            <a:prstDash val="solid"/>
+          </a:ln>
+        </p:spPr>
+      </p:sp>
+      <p:sp>
+        <p:nvSpPr>
+          <p:cNvPr id="49" name="Shin (dorsiflexors) at day 60"/>
+          <p:cNvSpPr/>
+          <p:nvPr/>
+        </p:nvSpPr>
+        <p:spPr>
+          <a:xfrm>
+            <a:off x="4338828" y="2972943"/>
+            <a:ext cx="100584" cy="100584"/>
+          </a:xfrm>
+          <a:prstGeom prst="ellipse">
+            <a:avLst/>
+          </a:prstGeom>
+          <a:solidFill>
+            <a:srgbClr val="D08C34"/>
+          </a:solidFill>
+          <a:ln w="6350">
+            <a:solidFill>
+              <a:srgbClr val="FFFFFF"/>
+            </a:solidFill>
+            <a:prstDash val="solid"/>
+          </a:ln>
+        </p:spPr>
+      </p:sp>
+      <p:sp>
+        <p:nvSpPr>
+          <p:cNvPr id="50" name="Calf (plantar flexors) curve"/>
+          <p:cNvSpPr/>
+          <p:nvPr/>
+        </p:nvSpPr>
+        <p:spPr>
+          <a:xfrm>
+            <a:off x="1497330" y="1371600"/>
+            <a:ext cx="5993892" cy="3490398"/>
+          </a:xfrm>
+          <a:custGeom>
+            <a:avLst/>
+            <a:gdLst/>
+            <a:ahLst/>
+            <a:cxnLst/>
+            <a:rect l="l" t="t" r="r" b="b"/>
+            <a:pathLst>
+              <a:path w="5993892" h="3490398">
+                <a:moveTo>
+                  <a:pt x="0" y="323608"/>
+                </a:moveTo>
+                <a:lnTo>
+                  <a:pt x="105156" y="445687"/>
+                </a:lnTo>
+                <a:lnTo>
+                  <a:pt x="210312" y="563764"/>
+                </a:lnTo>
+                <a:lnTo>
+                  <a:pt x="315468" y="677970"/>
+                </a:lnTo>
+                <a:lnTo>
+                  <a:pt x="420624" y="788431"/>
+                </a:lnTo>
+                <a:lnTo>
+                  <a:pt x="525780" y="895271"/>
+                </a:lnTo>
+                <a:lnTo>
+                  <a:pt x="630936" y="998609"/>
+                </a:lnTo>
+                <a:lnTo>
+                  <a:pt x="736092" y="1098559"/>
+                </a:lnTo>
+                <a:lnTo>
+                  <a:pt x="841248" y="1195232"/>
+                </a:lnTo>
+                <a:lnTo>
+                  <a:pt x="946404" y="1288735"/>
+                </a:lnTo>
+                <a:lnTo>
+                  <a:pt x="1051560" y="1379173"/>
+                </a:lnTo>
+                <a:lnTo>
+                  <a:pt x="1156716" y="1466647"/>
+                </a:lnTo>
+                <a:lnTo>
+                  <a:pt x="1261872" y="1551252"/>
+                </a:lnTo>
+                <a:lnTo>
+                  <a:pt x="1367028" y="1633084"/>
+                </a:lnTo>
+                <a:lnTo>
+                  <a:pt x="1472184" y="1712233"/>
+                </a:lnTo>
+                <a:lnTo>
+                  <a:pt x="1577340" y="1788788"/>
+                </a:lnTo>
+                <a:lnTo>
+                  <a:pt x="1682496" y="1862832"/>
+                </a:lnTo>
+                <a:lnTo>
+                  <a:pt x="1787652" y="1934449"/>
+                </a:lnTo>
+                <a:lnTo>
+                  <a:pt x="1892808" y="2003719"/>
+                </a:lnTo>
+                <a:lnTo>
+                  <a:pt x="1997964" y="2070717"/>
+                </a:lnTo>
+                <a:lnTo>
+                  <a:pt x="2103120" y="2135519"/>
+                </a:lnTo>
+                <a:lnTo>
+                  <a:pt x="2208276" y="2198196"/>
+                </a:lnTo>
+                <a:lnTo>
+                  <a:pt x="2313432" y="2258819"/>
+                </a:lnTo>
+                <a:lnTo>
+                  <a:pt x="2418588" y="2317454"/>
+                </a:lnTo>
+                <a:lnTo>
+                  <a:pt x="2523744" y="2374167"/>
+                </a:lnTo>
+                <a:lnTo>
+                  <a:pt x="2628900" y="2429020"/>
+                </a:lnTo>
+                <a:lnTo>
+                  <a:pt x="2734056" y="2482076"/>
+                </a:lnTo>
+                <a:lnTo>
+                  <a:pt x="2839212" y="2533391"/>
+                </a:lnTo>
+                <a:lnTo>
+                  <a:pt x="2944368" y="2583025"/>
+                </a:lnTo>
+                <a:lnTo>
+                  <a:pt x="3049524" y="2631031"/>
+                </a:lnTo>
+                <a:lnTo>
+                  <a:pt x="3154680" y="2677464"/>
+                </a:lnTo>
+                <a:lnTo>
+                  <a:pt x="3259836" y="2722374"/>
+                </a:lnTo>
+                <a:lnTo>
+                  <a:pt x="3364992" y="2765812"/>
+                </a:lnTo>
+                <a:lnTo>
+                  <a:pt x="3470148" y="2807826"/>
+                </a:lnTo>
+                <a:lnTo>
+                  <a:pt x="3575304" y="2848463"/>
+                </a:lnTo>
+                <a:lnTo>
+                  <a:pt x="3680460" y="2887767"/>
+                </a:lnTo>
+                <a:lnTo>
+                  <a:pt x="3785616" y="2925783"/>
+                </a:lnTo>
+                <a:lnTo>
+                  <a:pt x="3890772" y="2962552"/>
+                </a:lnTo>
+                <a:lnTo>
+                  <a:pt x="3995928" y="2998116"/>
+                </a:lnTo>
+                <a:lnTo>
+                  <a:pt x="4101084" y="3032514"/>
+                </a:lnTo>
+                <a:lnTo>
+                  <a:pt x="4206240" y="3065785"/>
+                </a:lnTo>
+                <a:lnTo>
+                  <a:pt x="4311396" y="3097964"/>
+                </a:lnTo>
+                <a:lnTo>
+                  <a:pt x="4416552" y="3129089"/>
+                </a:lnTo>
+                <a:lnTo>
+                  <a:pt x="4521708" y="3159193"/>
+                </a:lnTo>
+                <a:lnTo>
+                  <a:pt x="4626864" y="3188310"/>
+                </a:lnTo>
+                <a:lnTo>
+                  <a:pt x="4732020" y="3216473"/>
+                </a:lnTo>
+                <a:lnTo>
+                  <a:pt x="4837176" y="3243713"/>
+                </a:lnTo>
+                <a:lnTo>
+                  <a:pt x="4942332" y="3270059"/>
+                </a:lnTo>
+                <a:lnTo>
+                  <a:pt x="5047488" y="3295542"/>
+                </a:lnTo>
+                <a:lnTo>
+                  <a:pt x="5152644" y="3320189"/>
+                </a:lnTo>
+                <a:lnTo>
+                  <a:pt x="5257800" y="3344028"/>
+                </a:lnTo>
+                <a:lnTo>
+                  <a:pt x="5362956" y="3367086"/>
+                </a:lnTo>
+                <a:lnTo>
+                  <a:pt x="5468112" y="3389388"/>
+                </a:lnTo>
+                <a:lnTo>
+                  <a:pt x="5573268" y="3410959"/>
+                </a:lnTo>
+                <a:lnTo>
+                  <a:pt x="5678424" y="3431822"/>
+                </a:lnTo>
+                <a:lnTo>
+                  <a:pt x="5783580" y="3452002"/>
+                </a:lnTo>
+                <a:lnTo>
+                  <a:pt x="5888736" y="3471520"/>
+                </a:lnTo>
+                <a:lnTo>
+                  <a:pt x="5993892" y="3490398"/>
+                </a:lnTo>
+                <a:lnTo>
+                  <a:pt x="5993892" y="3490398"/>
+                </a:lnTo>
+              </a:path>
+            </a:pathLst>
+          </a:custGeom>
+          <a:ln w="38100">
+            <a:solidFill>
+              <a:srgbClr val="A23B2A"/>
+            </a:solidFill>
+            <a:prstDash val="solid"/>
+          </a:ln>
+        </p:spPr>
+      </p:sp>
+      <p:sp>
+        <p:nvSpPr>
+          <p:cNvPr id="51" name="Calf (plantar flexors) at day 60"/>
+          <p:cNvSpPr/>
+          <p:nvPr/>
+        </p:nvSpPr>
+        <p:spPr>
+          <a:xfrm>
+            <a:off x="4338828" y="3879723"/>
+            <a:ext cx="100584" cy="100584"/>
+          </a:xfrm>
+          <a:prstGeom prst="ellipse">
+            <a:avLst/>
+          </a:prstGeom>
+          <a:solidFill>
+            <a:srgbClr val="A23B2A"/>
+          </a:solidFill>
+          <a:ln w="6350">
+            <a:solidFill>
+              <a:srgbClr val="FFFFFF"/>
+            </a:solidFill>
+            <a:prstDash val="solid"/>
+          </a:ln>
+        </p:spPr>
+      </p:sp>
+      <p:sp>
+        <p:nvSpPr>
+          <p:cNvPr id="52" name="Text 50"/>
+          <p:cNvSpPr txBox="1"/>
+          <p:nvPr/>
+        </p:nvSpPr>
+        <p:spPr>
+          <a:xfrm>
+            <a:off x="10698480" y="987552"/>
+            <a:ext cx="932688" cy="228600"/>
+          </a:xfrm>
+          <a:prstGeom prst="rect">
+            <a:avLst/>
+          </a:prstGeom>
+          <a:noFill/>
+          <a:ln/>
+        </p:spPr>
+        <p:txBody>
+          <a:bodyPr wrap="square" lIns="0" tIns="0" rIns="0" bIns="0" rtlCol="0" anchor="t"/>
+          <a:lstStyle/>
+          <a:p>
+            <a:pPr algn="r" indent="0" marL="0">
+              <a:buNone/>
+            </a:pPr>
+            <a:r>
+              <a:rPr lang="en-US" sz="1050" b="1" dirty="0">
                 <a:solidFill>
                   <a:schemeClr val="accent3"/>
                 </a:solidFill>
               </a:rPr>
-              <a:t>PLACEHOLDER: content by Niloufar</a:t>
-            </a:r>
-            <a:endParaRPr lang="en-US" sz="1400" dirty="0"/>
-          </a:p>
-          <a:p>
-            <a:pPr indent="0" marL="0">
-              <a:spcAft>
-                <a:spcPts val="600"/>
-              </a:spcAft>
-              <a:buNone/>
-            </a:pPr>
-            <a:r>
-              <a:rPr lang="en-US" sz="1400" i="1" dirty="0">
-                <a:solidFill>
-                  <a:schemeClr val="accent3"/>
-                </a:solidFill>
-              </a:rPr>
-              <a:t>Suggested points from the final report:</a:t>
-            </a:r>
-            <a:endParaRPr lang="en-US" sz="1400" dirty="0"/>
-          </a:p>
-          <a:p>
-            <a:pPr marL="342900" indent="-342900">
-              <a:spcAft>
-                <a:spcPts val="400"/>
-              </a:spcAft>
-              <a:buSzPct val="100000"/>
-              <a:buChar char="•"/>
-            </a:pPr>
-            <a:r>
-              <a:rPr lang="en-US" sz="1600" dirty="0">
-                <a:solidFill>
-                  <a:schemeClr val="tx1"/>
-                </a:solidFill>
-              </a:rPr>
-              <a:t>No. Calf muscles (plantar flexors) lose most: −15.8% at day 60, 5.7 pp more than the front thigh</a:t>
-            </a:r>
-            <a:endParaRPr lang="en-US" sz="1400" dirty="0"/>
-          </a:p>
-          <a:p>
-            <a:pPr marL="342900" indent="-342900">
-              <a:spcAft>
-                <a:spcPts val="400"/>
-              </a:spcAft>
-              <a:buSzPct val="100000"/>
-              <a:buChar char="•"/>
-            </a:pPr>
-            <a:r>
-              <a:rPr lang="en-US" sz="1600" dirty="0">
-                <a:solidFill>
-                  <a:schemeClr val="tx1"/>
-                </a:solidFill>
-              </a:rPr>
-              <a:t>Front thigh, back thigh and shin muscles lose around 10%; hip muscles least</a:t>
-            </a:r>
-            <a:endParaRPr lang="en-US" sz="1400" dirty="0"/>
-          </a:p>
-          <a:p>
-            <a:pPr marL="342900" indent="-342900">
-              <a:spcAft>
-                <a:spcPts val="400"/>
-              </a:spcAft>
-              <a:buSzPct val="100000"/>
-              <a:buChar char="•"/>
-            </a:pPr>
-            <a:r>
-              <a:rPr lang="en-US" sz="1600" dirty="0">
-                <a:solidFill>
-                  <a:schemeClr val="tx1"/>
-                </a:solidFill>
-              </a:rPr>
-              <a:t>30% of the differences between measurements lie between muscles within the same study</a:t>
-            </a:r>
-            <a:endParaRPr lang="en-US" sz="1400" dirty="0"/>
-          </a:p>
-          <a:p>
-            <a:pPr marL="342900" indent="-342900">
-              <a:spcAft>
-                <a:spcPts val="400"/>
-              </a:spcAft>
-              <a:buSzPct val="100000"/>
-              <a:buChar char="•"/>
-            </a:pPr>
-            <a:r>
-              <a:rPr lang="en-US" sz="1600" dirty="0">
-                <a:solidFill>
-                  <a:schemeClr val="tx1"/>
-                </a:solidFill>
-              </a:rPr>
-              <a:t>Groups with countermeasures lose 3.7 pp less than controls</a:t>
-            </a:r>
-            <a:endParaRPr lang="en-US" sz="1400" dirty="0"/>
-          </a:p>
+              <a:t>At day 60</a:t>
+            </a:r>
+            <a:endParaRPr lang="en-US" sz="1050" dirty="0"/>
+          </a:p>
+        </p:txBody>
+      </p:sp>
+      <p:sp>
+        <p:nvSpPr>
+          <p:cNvPr id="53" name="Deep hip rotators leader"/>
+          <p:cNvSpPr/>
+          <p:nvPr/>
+        </p:nvSpPr>
+        <p:spPr>
+          <a:xfrm flipV="1">
+            <a:off x="7518654" y="1508760"/>
+            <a:ext cx="646938" cy="282571"/>
+          </a:xfrm>
+          <a:prstGeom prst="line">
+            <a:avLst/>
+          </a:prstGeom>
+          <a:noFill/>
+          <a:ln w="9525">
+            <a:solidFill>
+              <a:srgbClr val="6B7280"/>
+            </a:solidFill>
+            <a:prstDash val="solid"/>
+          </a:ln>
+        </p:spPr>
+      </p:sp>
+      <p:pic>
+        <p:nvPicPr>
+          <p:cNvPr id="54" name="Image 0" descr="Deep hip rotators (highlighted on a leg outline)">    </p:cNvPr>
+          <p:cNvPicPr>
+            <a:picLocks noChangeAspect="1"/>
+          </p:cNvPicPr>
+          <p:nvPr/>
+        </p:nvPicPr>
+        <p:blipFill>
+          <a:blip r:embed="rId1"/>
+          <a:stretch>
+            <a:fillRect/>
+          </a:stretch>
+        </p:blipFill>
+        <p:spPr>
+          <a:xfrm>
+            <a:off x="8229600" y="1280160"/>
+            <a:ext cx="304800" cy="457200"/>
+          </a:xfrm>
+          <a:prstGeom prst="rect">
+            <a:avLst/>
+          </a:prstGeom>
+        </p:spPr>
+      </p:pic>
+      <p:sp>
+        <p:nvSpPr>
+          <p:cNvPr id="55" name="Text 52"/>
+          <p:cNvSpPr txBox="1"/>
+          <p:nvPr/>
+        </p:nvSpPr>
+        <p:spPr>
+          <a:xfrm>
+            <a:off x="8613648" y="1261872"/>
+            <a:ext cx="2286000" cy="493776"/>
+          </a:xfrm>
+          <a:prstGeom prst="rect">
+            <a:avLst/>
+          </a:prstGeom>
+          <a:noFill/>
+          <a:ln/>
+        </p:spPr>
+        <p:txBody>
+          <a:bodyPr wrap="square" lIns="0" tIns="0" rIns="0" bIns="0" rtlCol="0" anchor="ctr"/>
+          <a:lstStyle/>
           <a:p>
             <a:pPr indent="0" marL="0">
               <a:buNone/>
             </a:pPr>
             <a:r>
-              <a:rPr lang="en-US" sz="1400" i="1" dirty="0">
+              <a:rPr lang="en-US" sz="1200" dirty="0">
+                <a:solidFill>
+                  <a:schemeClr val="tx1"/>
+                </a:solidFill>
+              </a:rPr>
+              <a:t>Deep hip rotators</a:t>
+            </a:r>
+            <a:endParaRPr lang="en-US" sz="1200" dirty="0"/>
+          </a:p>
+        </p:txBody>
+      </p:sp>
+      <p:sp>
+        <p:nvSpPr>
+          <p:cNvPr id="56" name="Text 53"/>
+          <p:cNvSpPr txBox="1"/>
+          <p:nvPr/>
+        </p:nvSpPr>
+        <p:spPr>
+          <a:xfrm>
+            <a:off x="10881360" y="1261872"/>
+            <a:ext cx="749808" cy="493776"/>
+          </a:xfrm>
+          <a:prstGeom prst="rect">
+            <a:avLst/>
+          </a:prstGeom>
+          <a:noFill/>
+          <a:ln/>
+        </p:spPr>
+        <p:txBody>
+          <a:bodyPr wrap="square" lIns="0" tIns="0" rIns="0" bIns="0" rtlCol="0" anchor="ctr"/>
+          <a:lstStyle/>
+          <a:p>
+            <a:pPr algn="r" indent="0" marL="0">
+              <a:buNone/>
+            </a:pPr>
+            <a:r>
+              <a:rPr lang="en-US" sz="1300" b="1" dirty="0">
+                <a:solidFill>
+                  <a:srgbClr val="6B7280"/>
+                </a:solidFill>
+              </a:rPr>
+              <a:t>−1.9%</a:t>
+            </a:r>
+            <a:endParaRPr lang="en-US" sz="1300" dirty="0"/>
+          </a:p>
+        </p:txBody>
+      </p:sp>
+      <p:sp>
+        <p:nvSpPr>
+          <p:cNvPr id="57" name="Inner thigh (hip adductors) leader"/>
+          <p:cNvSpPr/>
+          <p:nvPr/>
+        </p:nvSpPr>
+        <p:spPr>
+          <a:xfrm flipV="1">
+            <a:off x="7518654" y="2002536"/>
+            <a:ext cx="646938" cy="561985"/>
+          </a:xfrm>
+          <a:prstGeom prst="line">
+            <a:avLst/>
+          </a:prstGeom>
+          <a:noFill/>
+          <a:ln w="9525">
+            <a:solidFill>
+              <a:srgbClr val="17A2B8"/>
+            </a:solidFill>
+            <a:prstDash val="solid"/>
+          </a:ln>
+        </p:spPr>
+      </p:sp>
+      <p:pic>
+        <p:nvPicPr>
+          <p:cNvPr id="58" name="Image 1" descr="Inner thigh (hip adductors) (highlighted on a leg outline)">    </p:cNvPr>
+          <p:cNvPicPr>
+            <a:picLocks noChangeAspect="1"/>
+          </p:cNvPicPr>
+          <p:nvPr/>
+        </p:nvPicPr>
+        <p:blipFill>
+          <a:blip r:embed="rId2"/>
+          <a:stretch>
+            <a:fillRect/>
+          </a:stretch>
+        </p:blipFill>
+        <p:spPr>
+          <a:xfrm>
+            <a:off x="8229600" y="1773936"/>
+            <a:ext cx="304800" cy="457200"/>
+          </a:xfrm>
+          <a:prstGeom prst="rect">
+            <a:avLst/>
+          </a:prstGeom>
+        </p:spPr>
+      </p:pic>
+      <p:sp>
+        <p:nvSpPr>
+          <p:cNvPr id="59" name="Text 55"/>
+          <p:cNvSpPr txBox="1"/>
+          <p:nvPr/>
+        </p:nvSpPr>
+        <p:spPr>
+          <a:xfrm>
+            <a:off x="8613648" y="1755648"/>
+            <a:ext cx="2286000" cy="493776"/>
+          </a:xfrm>
+          <a:prstGeom prst="rect">
+            <a:avLst/>
+          </a:prstGeom>
+          <a:noFill/>
+          <a:ln/>
+        </p:spPr>
+        <p:txBody>
+          <a:bodyPr wrap="square" lIns="0" tIns="0" rIns="0" bIns="0" rtlCol="0" anchor="ctr"/>
+          <a:lstStyle/>
+          <a:p>
+            <a:pPr indent="0" marL="0">
+              <a:buNone/>
+            </a:pPr>
+            <a:r>
+              <a:rPr lang="en-US" sz="1200" dirty="0">
+                <a:solidFill>
+                  <a:schemeClr val="tx1"/>
+                </a:solidFill>
+              </a:rPr>
+              <a:t>Inner thigh (hip adductors)</a:t>
+            </a:r>
+            <a:endParaRPr lang="en-US" sz="1200" dirty="0"/>
+          </a:p>
+        </p:txBody>
+      </p:sp>
+      <p:sp>
+        <p:nvSpPr>
+          <p:cNvPr id="60" name="Text 56"/>
+          <p:cNvSpPr txBox="1"/>
+          <p:nvPr/>
+        </p:nvSpPr>
+        <p:spPr>
+          <a:xfrm>
+            <a:off x="10881360" y="1755648"/>
+            <a:ext cx="749808" cy="493776"/>
+          </a:xfrm>
+          <a:prstGeom prst="rect">
+            <a:avLst/>
+          </a:prstGeom>
+          <a:noFill/>
+          <a:ln/>
+        </p:spPr>
+        <p:txBody>
+          <a:bodyPr wrap="square" lIns="0" tIns="0" rIns="0" bIns="0" rtlCol="0" anchor="ctr"/>
+          <a:lstStyle/>
+          <a:p>
+            <a:pPr algn="r" indent="0" marL="0">
+              <a:buNone/>
+            </a:pPr>
+            <a:r>
+              <a:rPr lang="en-US" sz="1300" b="1" dirty="0">
+                <a:solidFill>
+                  <a:srgbClr val="17A2B8"/>
+                </a:solidFill>
+              </a:rPr>
+              <a:t>−5.4%</a:t>
+            </a:r>
+            <a:endParaRPr lang="en-US" sz="1300" dirty="0"/>
+          </a:p>
+        </p:txBody>
+      </p:sp>
+      <p:sp>
+        <p:nvSpPr>
+          <p:cNvPr id="61" name="Glutes (hip extensors) leader"/>
+          <p:cNvSpPr/>
+          <p:nvPr/>
+        </p:nvSpPr>
+        <p:spPr>
+          <a:xfrm flipV="1">
+            <a:off x="7518654" y="2496312"/>
+            <a:ext cx="646938" cy="222847"/>
+          </a:xfrm>
+          <a:prstGeom prst="line">
+            <a:avLst/>
+          </a:prstGeom>
+          <a:noFill/>
+          <a:ln w="9525">
+            <a:solidFill>
+              <a:srgbClr val="8C564B"/>
+            </a:solidFill>
+            <a:prstDash val="solid"/>
+          </a:ln>
+        </p:spPr>
+      </p:sp>
+      <p:pic>
+        <p:nvPicPr>
+          <p:cNvPr id="62" name="Image 2" descr="Glutes (hip extensors) (highlighted on a leg outline)">    </p:cNvPr>
+          <p:cNvPicPr>
+            <a:picLocks noChangeAspect="1"/>
+          </p:cNvPicPr>
+          <p:nvPr/>
+        </p:nvPicPr>
+        <p:blipFill>
+          <a:blip r:embed="rId3"/>
+          <a:stretch>
+            <a:fillRect/>
+          </a:stretch>
+        </p:blipFill>
+        <p:spPr>
+          <a:xfrm>
+            <a:off x="8229600" y="2267712"/>
+            <a:ext cx="304800" cy="457200"/>
+          </a:xfrm>
+          <a:prstGeom prst="rect">
+            <a:avLst/>
+          </a:prstGeom>
+        </p:spPr>
+      </p:pic>
+      <p:sp>
+        <p:nvSpPr>
+          <p:cNvPr id="63" name="Text 58"/>
+          <p:cNvSpPr txBox="1"/>
+          <p:nvPr/>
+        </p:nvSpPr>
+        <p:spPr>
+          <a:xfrm>
+            <a:off x="8613648" y="2249424"/>
+            <a:ext cx="2286000" cy="493776"/>
+          </a:xfrm>
+          <a:prstGeom prst="rect">
+            <a:avLst/>
+          </a:prstGeom>
+          <a:noFill/>
+          <a:ln/>
+        </p:spPr>
+        <p:txBody>
+          <a:bodyPr wrap="square" lIns="0" tIns="0" rIns="0" bIns="0" rtlCol="0" anchor="ctr"/>
+          <a:lstStyle/>
+          <a:p>
+            <a:pPr indent="0" marL="0">
+              <a:buNone/>
+            </a:pPr>
+            <a:r>
+              <a:rPr lang="en-US" sz="1200" dirty="0">
+                <a:solidFill>
+                  <a:schemeClr val="tx1"/>
+                </a:solidFill>
+              </a:rPr>
+              <a:t>Glutes (hip extensors)</a:t>
+            </a:r>
+            <a:endParaRPr lang="en-US" sz="1200" dirty="0"/>
+          </a:p>
+        </p:txBody>
+      </p:sp>
+      <p:sp>
+        <p:nvSpPr>
+          <p:cNvPr id="64" name="Text 59"/>
+          <p:cNvSpPr txBox="1"/>
+          <p:nvPr/>
+        </p:nvSpPr>
+        <p:spPr>
+          <a:xfrm>
+            <a:off x="10881360" y="2249424"/>
+            <a:ext cx="749808" cy="493776"/>
+          </a:xfrm>
+          <a:prstGeom prst="rect">
+            <a:avLst/>
+          </a:prstGeom>
+          <a:noFill/>
+          <a:ln/>
+        </p:spPr>
+        <p:txBody>
+          <a:bodyPr wrap="square" lIns="0" tIns="0" rIns="0" bIns="0" rtlCol="0" anchor="ctr"/>
+          <a:lstStyle/>
+          <a:p>
+            <a:pPr algn="r" indent="0" marL="0">
+              <a:buNone/>
+            </a:pPr>
+            <a:r>
+              <a:rPr lang="en-US" sz="1300" b="1" dirty="0">
+                <a:solidFill>
+                  <a:srgbClr val="8C564B"/>
+                </a:solidFill>
+              </a:rPr>
+              <a:t>−6.1%</a:t>
+            </a:r>
+            <a:endParaRPr lang="en-US" sz="1300" dirty="0"/>
+          </a:p>
+        </p:txBody>
+      </p:sp>
+      <p:sp>
+        <p:nvSpPr>
+          <p:cNvPr id="65" name="Hip flexors leader"/>
+          <p:cNvSpPr/>
+          <p:nvPr/>
+        </p:nvSpPr>
+        <p:spPr>
+          <a:xfrm>
+            <a:off x="7518654" y="2873796"/>
+            <a:ext cx="646938" cy="116292"/>
+          </a:xfrm>
+          <a:prstGeom prst="line">
+            <a:avLst/>
+          </a:prstGeom>
+          <a:noFill/>
+          <a:ln w="9525">
+            <a:solidFill>
+              <a:srgbClr val="2E8B57"/>
+            </a:solidFill>
+            <a:prstDash val="solid"/>
+          </a:ln>
+        </p:spPr>
+      </p:sp>
+      <p:pic>
+        <p:nvPicPr>
+          <p:cNvPr id="66" name="Image 3" descr="Hip flexors (highlighted on a leg outline)">    </p:cNvPr>
+          <p:cNvPicPr>
+            <a:picLocks noChangeAspect="1"/>
+          </p:cNvPicPr>
+          <p:nvPr/>
+        </p:nvPicPr>
+        <p:blipFill>
+          <a:blip r:embed="rId4"/>
+          <a:stretch>
+            <a:fillRect/>
+          </a:stretch>
+        </p:blipFill>
+        <p:spPr>
+          <a:xfrm>
+            <a:off x="8229600" y="2761488"/>
+            <a:ext cx="304800" cy="457200"/>
+          </a:xfrm>
+          <a:prstGeom prst="rect">
+            <a:avLst/>
+          </a:prstGeom>
+        </p:spPr>
+      </p:pic>
+      <p:sp>
+        <p:nvSpPr>
+          <p:cNvPr id="67" name="Text 61"/>
+          <p:cNvSpPr txBox="1"/>
+          <p:nvPr/>
+        </p:nvSpPr>
+        <p:spPr>
+          <a:xfrm>
+            <a:off x="8613648" y="2743200"/>
+            <a:ext cx="2286000" cy="493776"/>
+          </a:xfrm>
+          <a:prstGeom prst="rect">
+            <a:avLst/>
+          </a:prstGeom>
+          <a:noFill/>
+          <a:ln/>
+        </p:spPr>
+        <p:txBody>
+          <a:bodyPr wrap="square" lIns="0" tIns="0" rIns="0" bIns="0" rtlCol="0" anchor="ctr"/>
+          <a:lstStyle/>
+          <a:p>
+            <a:pPr indent="0" marL="0">
+              <a:buNone/>
+            </a:pPr>
+            <a:r>
+              <a:rPr lang="en-US" sz="1200" dirty="0">
+                <a:solidFill>
+                  <a:schemeClr val="tx1"/>
+                </a:solidFill>
+              </a:rPr>
+              <a:t>Hip flexors</a:t>
+            </a:r>
+            <a:endParaRPr lang="en-US" sz="1200" dirty="0"/>
+          </a:p>
+        </p:txBody>
+      </p:sp>
+      <p:sp>
+        <p:nvSpPr>
+          <p:cNvPr id="68" name="Text 62"/>
+          <p:cNvSpPr txBox="1"/>
+          <p:nvPr/>
+        </p:nvSpPr>
+        <p:spPr>
+          <a:xfrm>
+            <a:off x="10881360" y="2743200"/>
+            <a:ext cx="749808" cy="493776"/>
+          </a:xfrm>
+          <a:prstGeom prst="rect">
+            <a:avLst/>
+          </a:prstGeom>
+          <a:noFill/>
+          <a:ln/>
+        </p:spPr>
+        <p:txBody>
+          <a:bodyPr wrap="square" lIns="0" tIns="0" rIns="0" bIns="0" rtlCol="0" anchor="ctr"/>
+          <a:lstStyle/>
+          <a:p>
+            <a:pPr algn="r" indent="0" marL="0">
+              <a:buNone/>
+            </a:pPr>
+            <a:r>
+              <a:rPr lang="en-US" sz="1300" b="1" dirty="0">
+                <a:solidFill>
+                  <a:srgbClr val="2E8B57"/>
+                </a:solidFill>
+              </a:rPr>
+              <a:t>−6.8%</a:t>
+            </a:r>
+            <a:endParaRPr lang="en-US" sz="1300" dirty="0"/>
+          </a:p>
+        </p:txBody>
+      </p:sp>
+      <p:sp>
+        <p:nvSpPr>
+          <p:cNvPr id="69" name="Outer hip (hip abductors) leader"/>
+          <p:cNvSpPr/>
+          <p:nvPr/>
+        </p:nvSpPr>
+        <p:spPr>
+          <a:xfrm>
+            <a:off x="7518654" y="3381892"/>
+            <a:ext cx="646938" cy="101972"/>
+          </a:xfrm>
+          <a:prstGeom prst="line">
+            <a:avLst/>
+          </a:prstGeom>
+          <a:noFill/>
+          <a:ln w="9525">
+            <a:solidFill>
+              <a:srgbClr val="7B6BA8"/>
+            </a:solidFill>
+            <a:prstDash val="solid"/>
+          </a:ln>
+        </p:spPr>
+      </p:sp>
+      <p:pic>
+        <p:nvPicPr>
+          <p:cNvPr id="70" name="Image 4" descr="Outer hip (hip abductors) (highlighted on a leg outline)">    </p:cNvPr>
+          <p:cNvPicPr>
+            <a:picLocks noChangeAspect="1"/>
+          </p:cNvPicPr>
+          <p:nvPr/>
+        </p:nvPicPr>
+        <p:blipFill>
+          <a:blip r:embed="rId5"/>
+          <a:stretch>
+            <a:fillRect/>
+          </a:stretch>
+        </p:blipFill>
+        <p:spPr>
+          <a:xfrm>
+            <a:off x="8229600" y="3255264"/>
+            <a:ext cx="304800" cy="457200"/>
+          </a:xfrm>
+          <a:prstGeom prst="rect">
+            <a:avLst/>
+          </a:prstGeom>
+        </p:spPr>
+      </p:pic>
+      <p:sp>
+        <p:nvSpPr>
+          <p:cNvPr id="71" name="Text 64"/>
+          <p:cNvSpPr txBox="1"/>
+          <p:nvPr/>
+        </p:nvSpPr>
+        <p:spPr>
+          <a:xfrm>
+            <a:off x="8613648" y="3236976"/>
+            <a:ext cx="2286000" cy="493776"/>
+          </a:xfrm>
+          <a:prstGeom prst="rect">
+            <a:avLst/>
+          </a:prstGeom>
+          <a:noFill/>
+          <a:ln/>
+        </p:spPr>
+        <p:txBody>
+          <a:bodyPr wrap="square" lIns="0" tIns="0" rIns="0" bIns="0" rtlCol="0" anchor="ctr"/>
+          <a:lstStyle/>
+          <a:p>
+            <a:pPr indent="0" marL="0">
+              <a:buNone/>
+            </a:pPr>
+            <a:r>
+              <a:rPr lang="en-US" sz="1200" dirty="0">
+                <a:solidFill>
+                  <a:schemeClr val="tx1"/>
+                </a:solidFill>
+              </a:rPr>
+              <a:t>Outer hip (hip abductors)</a:t>
+            </a:r>
+            <a:endParaRPr lang="en-US" sz="1200" dirty="0"/>
+          </a:p>
+        </p:txBody>
+      </p:sp>
+      <p:sp>
+        <p:nvSpPr>
+          <p:cNvPr id="72" name="Text 65"/>
+          <p:cNvSpPr txBox="1"/>
+          <p:nvPr/>
+        </p:nvSpPr>
+        <p:spPr>
+          <a:xfrm>
+            <a:off x="10881360" y="3236976"/>
+            <a:ext cx="749808" cy="493776"/>
+          </a:xfrm>
+          <a:prstGeom prst="rect">
+            <a:avLst/>
+          </a:prstGeom>
+          <a:noFill/>
+          <a:ln/>
+        </p:spPr>
+        <p:txBody>
+          <a:bodyPr wrap="square" lIns="0" tIns="0" rIns="0" bIns="0" rtlCol="0" anchor="ctr"/>
+          <a:lstStyle/>
+          <a:p>
+            <a:pPr algn="r" indent="0" marL="0">
+              <a:buNone/>
+            </a:pPr>
+            <a:r>
+              <a:rPr lang="en-US" sz="1300" b="1" dirty="0">
+                <a:solidFill>
+                  <a:srgbClr val="7B6BA8"/>
+                </a:solidFill>
+              </a:rPr>
+              <a:t>−9.1%</a:t>
+            </a:r>
+            <a:endParaRPr lang="en-US" sz="1300" dirty="0"/>
+          </a:p>
+        </p:txBody>
+      </p:sp>
+      <p:sp>
+        <p:nvSpPr>
+          <p:cNvPr id="73" name="Back thigh (knee flexors) leader"/>
+          <p:cNvSpPr/>
+          <p:nvPr/>
+        </p:nvSpPr>
+        <p:spPr>
+          <a:xfrm>
+            <a:off x="7518654" y="3536530"/>
+            <a:ext cx="646938" cy="441110"/>
+          </a:xfrm>
+          <a:prstGeom prst="line">
+            <a:avLst/>
+          </a:prstGeom>
+          <a:noFill/>
+          <a:ln w="9525">
+            <a:solidFill>
+              <a:srgbClr val="4C78A8"/>
+            </a:solidFill>
+            <a:prstDash val="solid"/>
+          </a:ln>
+        </p:spPr>
+      </p:sp>
+      <p:pic>
+        <p:nvPicPr>
+          <p:cNvPr id="74" name="Image 5" descr="Back thigh (knee flexors) (highlighted on a leg outline)">    </p:cNvPr>
+          <p:cNvPicPr>
+            <a:picLocks noChangeAspect="1"/>
+          </p:cNvPicPr>
+          <p:nvPr/>
+        </p:nvPicPr>
+        <p:blipFill>
+          <a:blip r:embed="rId6"/>
+          <a:stretch>
+            <a:fillRect/>
+          </a:stretch>
+        </p:blipFill>
+        <p:spPr>
+          <a:xfrm>
+            <a:off x="8229600" y="3749040"/>
+            <a:ext cx="304800" cy="457200"/>
+          </a:xfrm>
+          <a:prstGeom prst="rect">
+            <a:avLst/>
+          </a:prstGeom>
+        </p:spPr>
+      </p:pic>
+      <p:sp>
+        <p:nvSpPr>
+          <p:cNvPr id="75" name="Text 67"/>
+          <p:cNvSpPr txBox="1"/>
+          <p:nvPr/>
+        </p:nvSpPr>
+        <p:spPr>
+          <a:xfrm>
+            <a:off x="8613648" y="3730752"/>
+            <a:ext cx="2286000" cy="493776"/>
+          </a:xfrm>
+          <a:prstGeom prst="rect">
+            <a:avLst/>
+          </a:prstGeom>
+          <a:noFill/>
+          <a:ln/>
+        </p:spPr>
+        <p:txBody>
+          <a:bodyPr wrap="square" lIns="0" tIns="0" rIns="0" bIns="0" rtlCol="0" anchor="ctr"/>
+          <a:lstStyle/>
+          <a:p>
+            <a:pPr indent="0" marL="0">
+              <a:buNone/>
+            </a:pPr>
+            <a:r>
+              <a:rPr lang="en-US" sz="1200" dirty="0">
+                <a:solidFill>
+                  <a:schemeClr val="tx1"/>
+                </a:solidFill>
+              </a:rPr>
+              <a:t>Back thigh (knee flexors)</a:t>
+            </a:r>
+            <a:endParaRPr lang="en-US" sz="1200" dirty="0"/>
+          </a:p>
+        </p:txBody>
+      </p:sp>
+      <p:sp>
+        <p:nvSpPr>
+          <p:cNvPr id="76" name="Text 68"/>
+          <p:cNvSpPr txBox="1"/>
+          <p:nvPr/>
+        </p:nvSpPr>
+        <p:spPr>
+          <a:xfrm>
+            <a:off x="10881360" y="3730752"/>
+            <a:ext cx="749808" cy="493776"/>
+          </a:xfrm>
+          <a:prstGeom prst="rect">
+            <a:avLst/>
+          </a:prstGeom>
+          <a:noFill/>
+          <a:ln/>
+        </p:spPr>
+        <p:txBody>
+          <a:bodyPr wrap="square" lIns="0" tIns="0" rIns="0" bIns="0" rtlCol="0" anchor="ctr"/>
+          <a:lstStyle/>
+          <a:p>
+            <a:pPr algn="r" indent="0" marL="0">
+              <a:buNone/>
+            </a:pPr>
+            <a:r>
+              <a:rPr lang="en-US" sz="1300" b="1" dirty="0">
+                <a:solidFill>
+                  <a:srgbClr val="4C78A8"/>
+                </a:solidFill>
+              </a:rPr>
+              <a:t>−9.8%</a:t>
+            </a:r>
+            <a:endParaRPr lang="en-US" sz="1300" dirty="0"/>
+          </a:p>
+        </p:txBody>
+      </p:sp>
+      <p:sp>
+        <p:nvSpPr>
+          <p:cNvPr id="77" name="Front thigh (knee extensors) leader"/>
+          <p:cNvSpPr/>
+          <p:nvPr/>
+        </p:nvSpPr>
+        <p:spPr>
+          <a:xfrm>
+            <a:off x="7518654" y="3602804"/>
+            <a:ext cx="646938" cy="868612"/>
+          </a:xfrm>
+          <a:prstGeom prst="line">
+            <a:avLst/>
+          </a:prstGeom>
+          <a:noFill/>
+          <a:ln w="9525">
+            <a:solidFill>
+              <a:srgbClr val="1F3A5F"/>
+            </a:solidFill>
+            <a:prstDash val="solid"/>
+          </a:ln>
+        </p:spPr>
+      </p:sp>
+      <p:pic>
+        <p:nvPicPr>
+          <p:cNvPr id="78" name="Image 6" descr="Front thigh (knee extensors) (highlighted on a leg outline)">    </p:cNvPr>
+          <p:cNvPicPr>
+            <a:picLocks noChangeAspect="1"/>
+          </p:cNvPicPr>
+          <p:nvPr/>
+        </p:nvPicPr>
+        <p:blipFill>
+          <a:blip r:embed="rId7"/>
+          <a:stretch>
+            <a:fillRect/>
+          </a:stretch>
+        </p:blipFill>
+        <p:spPr>
+          <a:xfrm>
+            <a:off x="8229600" y="4242816"/>
+            <a:ext cx="304800" cy="457200"/>
+          </a:xfrm>
+          <a:prstGeom prst="rect">
+            <a:avLst/>
+          </a:prstGeom>
+        </p:spPr>
+      </p:pic>
+      <p:sp>
+        <p:nvSpPr>
+          <p:cNvPr id="79" name="Text 70"/>
+          <p:cNvSpPr txBox="1"/>
+          <p:nvPr/>
+        </p:nvSpPr>
+        <p:spPr>
+          <a:xfrm>
+            <a:off x="8613648" y="4224528"/>
+            <a:ext cx="2286000" cy="493776"/>
+          </a:xfrm>
+          <a:prstGeom prst="rect">
+            <a:avLst/>
+          </a:prstGeom>
+          <a:noFill/>
+          <a:ln/>
+        </p:spPr>
+        <p:txBody>
+          <a:bodyPr wrap="square" lIns="0" tIns="0" rIns="0" bIns="0" rtlCol="0" anchor="ctr"/>
+          <a:lstStyle/>
+          <a:p>
+            <a:pPr indent="0" marL="0">
+              <a:buNone/>
+            </a:pPr>
+            <a:r>
+              <a:rPr lang="en-US" sz="1200" dirty="0">
+                <a:solidFill>
+                  <a:schemeClr val="tx1"/>
+                </a:solidFill>
+              </a:rPr>
+              <a:t>Front thigh (knee extensors)</a:t>
+            </a:r>
+            <a:endParaRPr lang="en-US" sz="1200" dirty="0"/>
+          </a:p>
+        </p:txBody>
+      </p:sp>
+      <p:sp>
+        <p:nvSpPr>
+          <p:cNvPr id="80" name="Text 71"/>
+          <p:cNvSpPr txBox="1"/>
+          <p:nvPr/>
+        </p:nvSpPr>
+        <p:spPr>
+          <a:xfrm>
+            <a:off x="10881360" y="4224528"/>
+            <a:ext cx="749808" cy="493776"/>
+          </a:xfrm>
+          <a:prstGeom prst="rect">
+            <a:avLst/>
+          </a:prstGeom>
+          <a:noFill/>
+          <a:ln/>
+        </p:spPr>
+        <p:txBody>
+          <a:bodyPr wrap="square" lIns="0" tIns="0" rIns="0" bIns="0" rtlCol="0" anchor="ctr"/>
+          <a:lstStyle/>
+          <a:p>
+            <a:pPr algn="r" indent="0" marL="0">
+              <a:buNone/>
+            </a:pPr>
+            <a:r>
+              <a:rPr lang="en-US" sz="1300" b="1" dirty="0">
+                <a:solidFill>
+                  <a:srgbClr val="1F3A5F"/>
+                </a:solidFill>
+              </a:rPr>
+              <a:t>−10.1%</a:t>
+            </a:r>
+            <a:endParaRPr lang="en-US" sz="1300" dirty="0"/>
+          </a:p>
+        </p:txBody>
+      </p:sp>
+      <p:sp>
+        <p:nvSpPr>
+          <p:cNvPr id="81" name="Shin (dorsiflexors) leader"/>
+          <p:cNvSpPr/>
+          <p:nvPr/>
+        </p:nvSpPr>
+        <p:spPr>
+          <a:xfrm>
+            <a:off x="7518654" y="3624895"/>
+            <a:ext cx="646938" cy="1340297"/>
+          </a:xfrm>
+          <a:prstGeom prst="line">
+            <a:avLst/>
+          </a:prstGeom>
+          <a:noFill/>
+          <a:ln w="9525">
+            <a:solidFill>
+              <a:srgbClr val="D08C34"/>
+            </a:solidFill>
+            <a:prstDash val="solid"/>
+          </a:ln>
+        </p:spPr>
+      </p:sp>
+      <p:pic>
+        <p:nvPicPr>
+          <p:cNvPr id="82" name="Image 7" descr="Shin (dorsiflexors) (highlighted on a leg outline)">    </p:cNvPr>
+          <p:cNvPicPr>
+            <a:picLocks noChangeAspect="1"/>
+          </p:cNvPicPr>
+          <p:nvPr/>
+        </p:nvPicPr>
+        <p:blipFill>
+          <a:blip r:embed="rId8"/>
+          <a:stretch>
+            <a:fillRect/>
+          </a:stretch>
+        </p:blipFill>
+        <p:spPr>
+          <a:xfrm>
+            <a:off x="8229600" y="4736592"/>
+            <a:ext cx="304800" cy="457200"/>
+          </a:xfrm>
+          <a:prstGeom prst="rect">
+            <a:avLst/>
+          </a:prstGeom>
+        </p:spPr>
+      </p:pic>
+      <p:sp>
+        <p:nvSpPr>
+          <p:cNvPr id="83" name="Text 73"/>
+          <p:cNvSpPr txBox="1"/>
+          <p:nvPr/>
+        </p:nvSpPr>
+        <p:spPr>
+          <a:xfrm>
+            <a:off x="8613648" y="4718304"/>
+            <a:ext cx="2286000" cy="493776"/>
+          </a:xfrm>
+          <a:prstGeom prst="rect">
+            <a:avLst/>
+          </a:prstGeom>
+          <a:noFill/>
+          <a:ln/>
+        </p:spPr>
+        <p:txBody>
+          <a:bodyPr wrap="square" lIns="0" tIns="0" rIns="0" bIns="0" rtlCol="0" anchor="ctr"/>
+          <a:lstStyle/>
+          <a:p>
+            <a:pPr indent="0" marL="0">
+              <a:buNone/>
+            </a:pPr>
+            <a:r>
+              <a:rPr lang="en-US" sz="1200" dirty="0">
+                <a:solidFill>
+                  <a:schemeClr val="tx1"/>
+                </a:solidFill>
+              </a:rPr>
+              <a:t>Shin (dorsiflexors)</a:t>
+            </a:r>
+            <a:endParaRPr lang="en-US" sz="1200" dirty="0"/>
+          </a:p>
+        </p:txBody>
+      </p:sp>
+      <p:sp>
+        <p:nvSpPr>
+          <p:cNvPr id="84" name="Text 74"/>
+          <p:cNvSpPr txBox="1"/>
+          <p:nvPr/>
+        </p:nvSpPr>
+        <p:spPr>
+          <a:xfrm>
+            <a:off x="10881360" y="4718304"/>
+            <a:ext cx="749808" cy="493776"/>
+          </a:xfrm>
+          <a:prstGeom prst="rect">
+            <a:avLst/>
+          </a:prstGeom>
+          <a:noFill/>
+          <a:ln/>
+        </p:spPr>
+        <p:txBody>
+          <a:bodyPr wrap="square" lIns="0" tIns="0" rIns="0" bIns="0" rtlCol="0" anchor="ctr"/>
+          <a:lstStyle/>
+          <a:p>
+            <a:pPr algn="r" indent="0" marL="0">
+              <a:buNone/>
+            </a:pPr>
+            <a:r>
+              <a:rPr lang="en-US" sz="1300" b="1" dirty="0">
+                <a:solidFill>
+                  <a:srgbClr val="D08C34"/>
+                </a:solidFill>
+              </a:rPr>
+              <a:t>−10.2%</a:t>
+            </a:r>
+            <a:endParaRPr lang="en-US" sz="1300" dirty="0"/>
+          </a:p>
+        </p:txBody>
+      </p:sp>
+      <p:sp>
+        <p:nvSpPr>
+          <p:cNvPr id="85" name="Calf (plantar flexors) leader"/>
+          <p:cNvSpPr/>
+          <p:nvPr/>
+        </p:nvSpPr>
+        <p:spPr>
+          <a:xfrm>
+            <a:off x="7518654" y="4861998"/>
+            <a:ext cx="646938" cy="596970"/>
+          </a:xfrm>
+          <a:prstGeom prst="line">
+            <a:avLst/>
+          </a:prstGeom>
+          <a:noFill/>
+          <a:ln w="9525">
+            <a:solidFill>
+              <a:srgbClr val="A23B2A"/>
+            </a:solidFill>
+            <a:prstDash val="solid"/>
+          </a:ln>
+        </p:spPr>
+      </p:sp>
+      <p:pic>
+        <p:nvPicPr>
+          <p:cNvPr id="86" name="Image 8" descr="Calf (plantar flexors) (highlighted on a leg outline)">    </p:cNvPr>
+          <p:cNvPicPr>
+            <a:picLocks noChangeAspect="1"/>
+          </p:cNvPicPr>
+          <p:nvPr/>
+        </p:nvPicPr>
+        <p:blipFill>
+          <a:blip r:embed="rId9"/>
+          <a:stretch>
+            <a:fillRect/>
+          </a:stretch>
+        </p:blipFill>
+        <p:spPr>
+          <a:xfrm>
+            <a:off x="8229600" y="5230368"/>
+            <a:ext cx="304800" cy="457200"/>
+          </a:xfrm>
+          <a:prstGeom prst="rect">
+            <a:avLst/>
+          </a:prstGeom>
+        </p:spPr>
+      </p:pic>
+      <p:sp>
+        <p:nvSpPr>
+          <p:cNvPr id="87" name="Text 76"/>
+          <p:cNvSpPr txBox="1"/>
+          <p:nvPr/>
+        </p:nvSpPr>
+        <p:spPr>
+          <a:xfrm>
+            <a:off x="8613648" y="5212080"/>
+            <a:ext cx="2286000" cy="493776"/>
+          </a:xfrm>
+          <a:prstGeom prst="rect">
+            <a:avLst/>
+          </a:prstGeom>
+          <a:noFill/>
+          <a:ln/>
+        </p:spPr>
+        <p:txBody>
+          <a:bodyPr wrap="square" lIns="0" tIns="0" rIns="0" bIns="0" rtlCol="0" anchor="ctr"/>
+          <a:lstStyle/>
+          <a:p>
+            <a:pPr indent="0" marL="0">
+              <a:buNone/>
+            </a:pPr>
+            <a:r>
+              <a:rPr lang="en-US" sz="1200" dirty="0">
+                <a:solidFill>
+                  <a:schemeClr val="tx1"/>
+                </a:solidFill>
+              </a:rPr>
+              <a:t>Calf (plantar flexors)</a:t>
+            </a:r>
+            <a:endParaRPr lang="en-US" sz="1200" dirty="0"/>
+          </a:p>
+        </p:txBody>
+      </p:sp>
+      <p:sp>
+        <p:nvSpPr>
+          <p:cNvPr id="88" name="Text 77"/>
+          <p:cNvSpPr txBox="1"/>
+          <p:nvPr/>
+        </p:nvSpPr>
+        <p:spPr>
+          <a:xfrm>
+            <a:off x="10881360" y="5212080"/>
+            <a:ext cx="749808" cy="493776"/>
+          </a:xfrm>
+          <a:prstGeom prst="rect">
+            <a:avLst/>
+          </a:prstGeom>
+          <a:noFill/>
+          <a:ln/>
+        </p:spPr>
+        <p:txBody>
+          <a:bodyPr wrap="square" lIns="0" tIns="0" rIns="0" bIns="0" rtlCol="0" anchor="ctr"/>
+          <a:lstStyle/>
+          <a:p>
+            <a:pPr algn="r" indent="0" marL="0">
+              <a:buNone/>
+            </a:pPr>
+            <a:r>
+              <a:rPr lang="en-US" sz="1300" b="1" dirty="0">
+                <a:solidFill>
+                  <a:srgbClr val="A23B2A"/>
+                </a:solidFill>
+              </a:rPr>
+              <a:t>−15.8%</a:t>
+            </a:r>
+            <a:endParaRPr lang="en-US" sz="1300" dirty="0"/>
+          </a:p>
+        </p:txBody>
+      </p:sp>
+      <p:sp>
+        <p:nvSpPr>
+          <p:cNvPr id="89" name="Text 78"/>
+          <p:cNvSpPr txBox="1"/>
+          <p:nvPr/>
+        </p:nvSpPr>
+        <p:spPr>
+          <a:xfrm>
+            <a:off x="548640" y="5897880"/>
+            <a:ext cx="11064240" cy="228600"/>
+          </a:xfrm>
+          <a:prstGeom prst="rect">
+            <a:avLst/>
+          </a:prstGeom>
+          <a:noFill/>
+          <a:ln/>
+        </p:spPr>
+        <p:txBody>
+          <a:bodyPr wrap="square" lIns="0" tIns="0" rIns="0" bIns="0" rtlCol="0" anchor="t"/>
+          <a:lstStyle/>
+          <a:p>
+            <a:pPr indent="0" marL="0">
+              <a:buNone/>
+            </a:pPr>
+            <a:r>
+              <a:rPr lang="en-US" sz="1050" i="1" dirty="0">
                 <a:solidFill>
                   <a:schemeClr val="accent3"/>
                 </a:solidFill>
               </a:rPr>
-              <a:t>Possible figure: muscle ranking (figures/F3_muscles)</a:t>
-            </a:r>
-            <a:endParaRPr lang="en-US" sz="1400" dirty="0"/>
+              <a:t>Lines: one shared time course (saturating, τ = 60 days) scaled to each group's estimate at day 60. Control groups, days 5 to 119.</a:t>
+            </a:r>
+            <a:endParaRPr lang="en-US" sz="1050" dirty="0"/>
           </a:p>
         </p:txBody>
       </p:sp>

</xml_diff>

<commit_message>
Further work: link muscles and estimate strength loss; backup slide with search sources and queries
Co-Authored-By: Claude Opus 5.5 (1M context) <noreply@anthropic.com>
Claude-Session: https://claude.ai/code/session_01JZtuYERhuCe7nB9VYHwcfv
</commit_message>
<xml_diff>
--- a/presentation/bed-rest-to-mars-talk.pptx
+++ b/presentation/bed-rest-to-mars-talk.pptx
@@ -23,9 +23,10 @@
     <p:sldId id="271" r:id="rId17"/>
     <p:sldId id="272" r:id="rId18"/>
     <p:sldId id="273" r:id="rId19"/>
+    <p:sldId id="274" r:id="rId20"/>
   </p:sldIdLst>
   <p:notesMasterIdLst>
-    <p:notesMasterId r:id="rId20"/>
+    <p:notesMasterId r:id="rId21"/>
   </p:notesMasterIdLst>
   <p:sldSz cx="12192000" cy="6858000"/>
   <p:notesSz cx="6858000" cy="12192000"/>
@@ -124,13 +125,13 @@
   <p:extLst>
     <p:ext uri="{521415D9-36F7-43E2-AB2F-B90AF26B5E84}">
       <p14:sectionLst xmlns:p14="http://schemas.microsoft.com/office/powerpoint/2010/main">
-        <p14:section name="Opening" id="{6b3cec44-95c1-4a95-9731-878a2c5fe0af}">
+        <p14:section name="Opening" id="{526fc13d-fb17-54af-6762-04e56dc821a5}">
           <p14:sldIdLst>
             <p14:sldId id="256"/>
             <p14:sldId id="257"/>
           </p14:sldIdLst>
         </p14:section>
-        <p14:section name="Part 1" id="{fbb1d69c-5f0b-63b6-26f7-641d25bd3a9d}">
+        <p14:section name="Part 1" id="{ab1a16bf-aee8-34a1-d528-114e8daf14bc}">
           <p14:sldIdLst>
             <p14:sldId id="258"/>
             <p14:sldId id="259"/>
@@ -140,7 +141,7 @@
             <p14:sldId id="263"/>
           </p14:sldIdLst>
         </p14:section>
-        <p14:section name="Part 2" id="{9d816eed-52c2-dd81-4a75-f9e9ebb4f245}">
+        <p14:section name="Part 2" id="{80e50084-c193-696c-424d-953daa226d7c}">
           <p14:sldIdLst>
             <p14:sldId id="264"/>
             <p14:sldId id="265"/>
@@ -150,21 +151,25 @@
             <p14:sldId id="269"/>
           </p14:sldIdLst>
         </p14:section>
-        <p14:section name="Backup" id="{6ad0872b-063b-429d-0fb3-e0817e547509}">
+        <p14:section name="Backup" id="{ec5bc6d1-8e81-265e-d340-e4c48910919c}">
           <p14:sldIdLst>
             <p14:sldId id="270"/>
             <p14:sldId id="271"/>
             <p14:sldId id="272"/>
             <p14:sldId id="273"/>
+            <p14:sldId id="274"/>
           </p14:sldIdLst>
         </p14:section>
-        <p14:section name="Backup" id="{9ac391e1-a08b-3871-c0d5-71d9d7adf517}">
+        <p14:section name="Backup" id="{912689a9-1921-5b9c-58b9-183ee3f18a7f}">
           <p14:sldIdLst/>
         </p14:section>
-        <p14:section name="Backup" id="{991dee23-8c06-a46e-2c1c-3f34fbdb5c3c}">
+        <p14:section name="Backup" id="{2c5a0850-2e59-4a66-4cf9-2751c7fdd720}">
           <p14:sldIdLst/>
         </p14:section>
-        <p14:section name="Backup" id="{8ca0429e-2b93-d334-89fd-ef180cd368e1}">
+        <p14:section name="Backup" id="{e7864e46-bb1e-dd55-ac52-5e90a1bc4447}">
+          <p14:sldIdLst/>
+        </p14:section>
+        <p14:section name="Backup" id="{93952182-36e6-281f-0674-9c6c6d94c781}">
           <p14:sldIdLst/>
         </p14:section>
       </p14:sectionLst>
@@ -4333,7 +4338,7 @@
           <a:p>
             <a:r>
               <a:rPr lang="en-US" dirty="0"/>
-              <a:t>Backup. The two starred numbers are our own calculation from results/forecast_predictions.csv, not in the report. Without the three studies that carry most of the gain, the interval touches zero; say so if asked.</a:t>
+              <a:t>Backup. All four strings are in the report appendix, copied from docs/literature-review/search_log.md. PubMed uses the same two blocks with MeSH terms and the humans filter; Scopus and Web of Science exclude animal studies in the query. The 2013 limit is the main weakness: only two of ten known modelling papers fall inside the window, and the known-item test without the limit was not run. Embase was not searched for lack of access; it indexes conference abstracts the other databases miss.</a:t>
             </a:r>
             <a:endParaRPr lang="en-US" dirty="0"/>
           </a:p>
@@ -4421,7 +4426,7 @@
           <a:p>
             <a:r>
               <a:rPr lang="en-US" dirty="0"/>
-              <a:t>Backup. The honest gap here is the nearest-neighbour control: we cannot yet say whether a simple similarity method would match the LLM.</a:t>
+              <a:t>Backup. The two starred numbers are our own calculation from results/forecast_predictions.csv, not in the report. Without the three studies that carry most of the gain, the interval touches zero; say so if asked.</a:t>
             </a:r>
             <a:endParaRPr lang="en-US" dirty="0"/>
           </a:p>
@@ -4509,7 +4514,7 @@
           <a:p>
             <a:r>
               <a:rPr lang="en-US" dirty="0"/>
-              <a:t>Backup. The supported planning statements, within 5 to 119 days and for groups: most loss happens in the first weeks, calf muscles need protecting first, and countermeasure groups lose less.</a:t>
+              <a:t>Backup. The honest gap here is the nearest-neighbour control: we cannot yet say whether a simple similarity method would match the LLM.</a:t>
             </a:r>
             <a:endParaRPr lang="en-US" dirty="0"/>
           </a:p>
@@ -4533,6 +4538,94 @@
             <a:fld id="{F7021451-1387-4CA6-816F-3879F97B5CBC}" type="slidenum">
               <a:rPr lang="en-US"/>
               <a:t>18</a:t>
+            </a:fld>
+            <a:endParaRPr lang="en-US"/>
+          </a:p>
+        </p:txBody>
+      </p:sp>
+    </p:spTree>
+    <p:extLst>
+      <p:ext uri="{BB962C8B-B14F-4D97-AF65-F5344CB8AC3E}">
+        <p14:creationId xmlns:p14="http://schemas.microsoft.com/office/powerpoint/2010/main" val="1024086991"/>
+      </p:ext>
+    </p:extLst>
+  </p:cSld>
+  <p:clrMapOvr>
+    <a:masterClrMapping/>
+  </p:clrMapOvr>
+</p:notes>
+</file>
+
+<file path=ppt/notesSlides/notesSlide19.xml><?xml version="1.0" encoding="utf-8"?>
+<p:notes xmlns:a="http://schemas.openxmlformats.org/drawingml/2006/main" xmlns:r="http://schemas.openxmlformats.org/officeDocument/2006/relationships" xmlns:p="http://schemas.openxmlformats.org/presentationml/2006/main">
+  <p:cSld>
+    <p:spTree>
+      <p:nvGrpSpPr>
+        <p:cNvPr id="1" name=""/>
+        <p:cNvGrpSpPr/>
+        <p:nvPr/>
+      </p:nvGrpSpPr>
+      <p:grpSpPr>
+        <a:xfrm>
+          <a:off x="0" y="0"/>
+          <a:ext cx="0" cy="0"/>
+          <a:chOff x="0" y="0"/>
+          <a:chExt cx="0" cy="0"/>
+        </a:xfrm>
+      </p:grpSpPr>
+      <p:sp>
+        <p:nvSpPr>
+          <p:cNvPr id="2" name="Slide Image Placeholder 1"/>
+          <p:cNvSpPr>
+            <a:spLocks noGrp="1" noRot="1" noChangeAspect="1"/>
+          </p:cNvSpPr>
+          <p:nvPr>
+            <p:ph type="sldImg"/>
+          </p:nvPr>
+        </p:nvSpPr>
+        <p:spPr/>
+      </p:sp>
+      <p:sp>
+        <p:nvSpPr>
+          <p:cNvPr id="3" name="Notes Placeholder 2"/>
+          <p:cNvSpPr>
+            <a:spLocks noGrp="1"/>
+          </p:cNvSpPr>
+          <p:nvPr>
+            <p:ph type="body" idx="1"/>
+          </p:nvPr>
+        </p:nvSpPr>
+        <p:spPr/>
+        <p:txBody>
+          <a:bodyPr/>
+          <a:lstStyle/>
+          <a:p>
+            <a:r>
+              <a:rPr lang="en-US" dirty="0"/>
+              <a:t>Backup. The supported planning statements, within 5 to 119 days and for groups: most loss happens in the first weeks, calf muscles need protecting first, and countermeasure groups lose less.</a:t>
+            </a:r>
+            <a:endParaRPr lang="en-US" dirty="0"/>
+          </a:p>
+        </p:txBody>
+      </p:sp>
+      <p:sp>
+        <p:nvSpPr>
+          <p:cNvPr id="4" name="Slide Number Placeholder 3"/>
+          <p:cNvSpPr>
+            <a:spLocks noGrp="1"/>
+          </p:cNvSpPr>
+          <p:nvPr>
+            <p:ph type="sldNum" sz="quarter" idx="10"/>
+          </p:nvPr>
+        </p:nvSpPr>
+        <p:spPr/>
+        <p:txBody>
+          <a:bodyPr/>
+          <a:lstStyle/>
+          <a:p>
+            <a:fld id="{F7021451-1387-4CA6-816F-3879F97B5CBC}" type="slidenum">
+              <a:rPr lang="en-US"/>
+              <a:t>19</a:t>
             </a:fld>
             <a:endParaRPr lang="en-US"/>
           </a:p>
@@ -9146,6 +9239,24 @@
             </a:r>
             <a:endParaRPr lang="en-US" sz="2000" dirty="0"/>
           </a:p>
+          <a:p>
+            <a:pPr marL="342900" indent="-342900">
+              <a:spcAft>
+                <a:spcPts val="400"/>
+              </a:spcAft>
+              <a:buSzPct val="100000"/>
+              <a:buChar char="•"/>
+            </a:pPr>
+            <a:r>
+              <a:rPr lang="en-US" sz="1800" dirty="0">
+                <a:solidFill>
+                  <a:schemeClr val="tx1"/>
+                </a:solidFill>
+              </a:rPr>
+              <a:t>Link the muscles: predict one muscle's loss from another's, and weight them into an estimate of strength loss</a:t>
+            </a:r>
+            <a:endParaRPr lang="en-US" sz="2000" dirty="0"/>
+          </a:p>
         </p:txBody>
       </p:sp>
       <p:sp>
@@ -9700,7 +9811,7 @@
                 <a:ea typeface="Cambria" pitchFamily="34" charset="-122"/>
                 <a:cs typeface="Cambria" pitchFamily="34" charset="-120"/>
               </a:rPr>
-              <a:t>Backup: is the LLM gain real, and does it matter?</a:t>
+              <a:t>Backup: how did we search the literature?</a:t>
             </a:r>
             <a:endParaRPr lang="en-US" sz="2800" dirty="0"/>
           </a:p>
@@ -9751,7 +9862,7 @@
         <p:spPr>
           <a:xfrm>
             <a:off x="548640" y="1188720"/>
-            <a:ext cx="5394960" cy="2377440"/>
+            <a:ext cx="5120640" cy="292608"/>
           </a:xfrm>
           <a:prstGeom prst="rect">
             <a:avLst/>
@@ -9764,9 +9875,6 @@
           <a:lstStyle/>
           <a:p>
             <a:pPr indent="0" marL="0">
-              <a:spcAft>
-                <a:spcPts val="400"/>
-              </a:spcAft>
               <a:buNone/>
             </a:pPr>
             <a:r>
@@ -9775,10 +9883,740 @@
                   <a:schemeClr val="tx2"/>
                 </a:solidFill>
               </a:rPr>
-              <a:t>Is 0.42 pp worth anything?</a:t>
+              <a:t>Sources (searched 4 September 2026)</a:t>
             </a:r>
             <a:endParaRPr lang="en-US" sz="1500" dirty="0"/>
           </a:p>
+        </p:txBody>
+      </p:sp>
+      <p:graphicFrame>
+        <p:nvGraphicFramePr>
+          <p:cNvPr id="17" name="Table 0"/>
+          <p:cNvGraphicFramePr>
+            <a:graphicFrameLocks noGrp="1"/>
+          </p:cNvGraphicFramePr>
+          <p:nvPr>
+            <p:extLst>
+              <p:ext uri="{D42A27DB-BD31-4B8C-83A1-F6EECF244321}">
+                <p14:modId xmlns:p14="http://schemas.microsoft.com/office/powerpoint/2010/main" val="1579011935"/>
+              </p:ext>
+            </p:extLst>
+          </p:nvPr>
+        </p:nvGraphicFramePr>
+        <p:xfrm>
+          <a:off x="548640" y="1554480"/>
+          <a:ext cx="5120640" cy="914400"/>
+        </p:xfrm>
+        <a:graphic>
+          <a:graphicData uri="http://schemas.openxmlformats.org/drawingml/2006/table">
+            <a:tbl>
+              <a:tblPr/>
+              <a:tblGrid>
+                <a:gridCol w="3931920"/>
+                <a:gridCol w="1188720"/>
+              </a:tblGrid>
+              <a:tr h="347472">
+                <a:tc>
+                  <a:txBody>
+                    <a:bodyPr/>
+                    <a:lstStyle/>
+                    <a:p>
+                      <a:pPr algn="l" indent="0" marL="0">
+                        <a:buNone/>
+                      </a:pPr>
+                      <a:r>
+                        <a:rPr lang="en-US" sz="1300" b="1" dirty="0">
+                          <a:solidFill>
+                            <a:srgbClr val="FFFFFF"/>
+                          </a:solidFill>
+                          <a:latin typeface="Calibri" pitchFamily="34" charset="0"/>
+                          <a:ea typeface="Calibri" pitchFamily="34" charset="-122"/>
+                          <a:cs typeface="Calibri" pitchFamily="34" charset="-120"/>
+                        </a:rPr>
+                        <a:t>Source</a:t>
+                      </a:r>
+                      <a:endParaRPr lang="en-US" sz="1300" dirty="0">
+                        <a:latin typeface="Calibri" charset="0"/>
+                        <a:ea typeface="Calibri" charset="0"/>
+                        <a:cs typeface="Calibri" charset="0"/>
+                      </a:endParaRPr>
+                    </a:p>
+                  </a:txBody>
+                  <a:tcPr marL="91440" marR="91440" marT="27432" marB="27432" anchor="ctr">
+                    <a:lnL w="0" cap="flat" cmpd="sng" algn="ctr">
+                      <a:noFill/>
+                    </a:lnL>
+                    <a:lnR w="0" cap="flat" cmpd="sng" algn="ctr">
+                      <a:noFill/>
+                    </a:lnR>
+                    <a:lnT w="0" cap="flat" cmpd="sng" algn="ctr">
+                      <a:noFill/>
+                    </a:lnT>
+                    <a:lnB w="9525" cap="flat" cmpd="sng" algn="ctr">
+                      <a:solidFill>
+                        <a:srgbClr val="E5E7EB"/>
+                      </a:solidFill>
+                      <a:prstDash val="solid"/>
+                      <a:round/>
+                      <a:headEnd type="none" w="med" len="med"/>
+                      <a:tailEnd type="none" w="med" len="med"/>
+                    </a:lnB>
+                    <a:solidFill>
+                      <a:srgbClr val="1F3A5F"/>
+                    </a:solidFill>
+                  </a:tcPr>
+                </a:tc>
+                <a:tc>
+                  <a:txBody>
+                    <a:bodyPr/>
+                    <a:lstStyle/>
+                    <a:p>
+                      <a:pPr algn="r" indent="0" marL="0">
+                        <a:buNone/>
+                      </a:pPr>
+                      <a:r>
+                        <a:rPr lang="en-US" sz="1300" b="1" dirty="0">
+                          <a:solidFill>
+                            <a:srgbClr val="FFFFFF"/>
+                          </a:solidFill>
+                          <a:latin typeface="Calibri" pitchFamily="34" charset="0"/>
+                          <a:ea typeface="Calibri" pitchFamily="34" charset="-122"/>
+                          <a:cs typeface="Calibri" pitchFamily="34" charset="-120"/>
+                        </a:rPr>
+                        <a:t>Records</a:t>
+                      </a:r>
+                      <a:endParaRPr lang="en-US" sz="1300" dirty="0">
+                        <a:latin typeface="Calibri" charset="0"/>
+                        <a:ea typeface="Calibri" charset="0"/>
+                        <a:cs typeface="Calibri" charset="0"/>
+                      </a:endParaRPr>
+                    </a:p>
+                  </a:txBody>
+                  <a:tcPr marL="91440" marR="91440" marT="27432" marB="27432" anchor="ctr">
+                    <a:lnL w="0" cap="flat" cmpd="sng" algn="ctr">
+                      <a:noFill/>
+                    </a:lnL>
+                    <a:lnR w="0" cap="flat" cmpd="sng" algn="ctr">
+                      <a:noFill/>
+                    </a:lnR>
+                    <a:lnT w="0" cap="flat" cmpd="sng" algn="ctr">
+                      <a:noFill/>
+                    </a:lnT>
+                    <a:lnB w="9525" cap="flat" cmpd="sng" algn="ctr">
+                      <a:solidFill>
+                        <a:srgbClr val="E5E7EB"/>
+                      </a:solidFill>
+                      <a:prstDash val="solid"/>
+                      <a:round/>
+                      <a:headEnd type="none" w="med" len="med"/>
+                      <a:tailEnd type="none" w="med" len="med"/>
+                    </a:lnB>
+                    <a:solidFill>
+                      <a:srgbClr val="1F3A5F"/>
+                    </a:solidFill>
+                  </a:tcPr>
+                </a:tc>
+              </a:tr>
+              <a:tr h="347472">
+                <a:tc>
+                  <a:txBody>
+                    <a:bodyPr/>
+                    <a:lstStyle/>
+                    <a:p>
+                      <a:pPr algn="l" indent="0" marL="0">
+                        <a:buNone/>
+                      </a:pPr>
+                      <a:r>
+                        <a:rPr lang="en-US" sz="1300" dirty="0">
+                          <a:solidFill>
+                            <a:srgbClr val="1A1A1A"/>
+                          </a:solidFill>
+                          <a:latin typeface="Calibri" pitchFamily="34" charset="0"/>
+                          <a:ea typeface="Calibri" pitchFamily="34" charset="-122"/>
+                          <a:cs typeface="Calibri" pitchFamily="34" charset="-120"/>
+                        </a:rPr>
+                        <a:t>PubMed</a:t>
+                      </a:r>
+                      <a:endParaRPr lang="en-US" sz="1300" dirty="0">
+                        <a:latin typeface="Calibri" charset="0"/>
+                        <a:ea typeface="Calibri" charset="0"/>
+                        <a:cs typeface="Calibri" charset="0"/>
+                      </a:endParaRPr>
+                    </a:p>
+                  </a:txBody>
+                  <a:tcPr marL="91440" marR="91440" marT="27432" marB="27432" anchor="ctr">
+                    <a:lnL w="0" cap="flat" cmpd="sng" algn="ctr">
+                      <a:noFill/>
+                    </a:lnL>
+                    <a:lnR w="0" cap="flat" cmpd="sng" algn="ctr">
+                      <a:noFill/>
+                    </a:lnR>
+                    <a:lnT w="0" cap="flat" cmpd="sng" algn="ctr">
+                      <a:noFill/>
+                    </a:lnT>
+                    <a:lnB w="9525" cap="flat" cmpd="sng" algn="ctr">
+                      <a:solidFill>
+                        <a:srgbClr val="E5E7EB"/>
+                      </a:solidFill>
+                      <a:prstDash val="solid"/>
+                      <a:round/>
+                      <a:headEnd type="none" w="med" len="med"/>
+                      <a:tailEnd type="none" w="med" len="med"/>
+                    </a:lnB>
+                  </a:tcPr>
+                </a:tc>
+                <a:tc>
+                  <a:txBody>
+                    <a:bodyPr/>
+                    <a:lstStyle/>
+                    <a:p>
+                      <a:pPr algn="r" indent="0" marL="0">
+                        <a:buNone/>
+                      </a:pPr>
+                      <a:r>
+                        <a:rPr lang="en-US" sz="1300" dirty="0">
+                          <a:solidFill>
+                            <a:srgbClr val="1A1A1A"/>
+                          </a:solidFill>
+                          <a:latin typeface="Calibri" pitchFamily="34" charset="0"/>
+                          <a:ea typeface="Calibri" pitchFamily="34" charset="-122"/>
+                          <a:cs typeface="Calibri" pitchFamily="34" charset="-120"/>
+                        </a:rPr>
+                        <a:t>1,412</a:t>
+                      </a:r>
+                      <a:endParaRPr lang="en-US" sz="1300" dirty="0">
+                        <a:latin typeface="Calibri" charset="0"/>
+                        <a:ea typeface="Calibri" charset="0"/>
+                        <a:cs typeface="Calibri" charset="0"/>
+                      </a:endParaRPr>
+                    </a:p>
+                  </a:txBody>
+                  <a:tcPr marL="91440" marR="91440" marT="27432" marB="27432" anchor="ctr">
+                    <a:lnL w="0" cap="flat" cmpd="sng" algn="ctr">
+                      <a:noFill/>
+                    </a:lnL>
+                    <a:lnR w="0" cap="flat" cmpd="sng" algn="ctr">
+                      <a:noFill/>
+                    </a:lnR>
+                    <a:lnT w="0" cap="flat" cmpd="sng" algn="ctr">
+                      <a:noFill/>
+                    </a:lnT>
+                    <a:lnB w="9525" cap="flat" cmpd="sng" algn="ctr">
+                      <a:solidFill>
+                        <a:srgbClr val="E5E7EB"/>
+                      </a:solidFill>
+                      <a:prstDash val="solid"/>
+                      <a:round/>
+                      <a:headEnd type="none" w="med" len="med"/>
+                      <a:tailEnd type="none" w="med" len="med"/>
+                    </a:lnB>
+                  </a:tcPr>
+                </a:tc>
+              </a:tr>
+              <a:tr h="347472">
+                <a:tc>
+                  <a:txBody>
+                    <a:bodyPr/>
+                    <a:lstStyle/>
+                    <a:p>
+                      <a:pPr algn="l" indent="0" marL="0">
+                        <a:buNone/>
+                      </a:pPr>
+                      <a:r>
+                        <a:rPr lang="en-US" sz="1300" dirty="0">
+                          <a:solidFill>
+                            <a:srgbClr val="1A1A1A"/>
+                          </a:solidFill>
+                          <a:latin typeface="Calibri" pitchFamily="34" charset="0"/>
+                          <a:ea typeface="Calibri" pitchFamily="34" charset="-122"/>
+                          <a:cs typeface="Calibri" pitchFamily="34" charset="-120"/>
+                        </a:rPr>
+                        <a:t>Scopus</a:t>
+                      </a:r>
+                      <a:endParaRPr lang="en-US" sz="1300" dirty="0">
+                        <a:latin typeface="Calibri" charset="0"/>
+                        <a:ea typeface="Calibri" charset="0"/>
+                        <a:cs typeface="Calibri" charset="0"/>
+                      </a:endParaRPr>
+                    </a:p>
+                  </a:txBody>
+                  <a:tcPr marL="91440" marR="91440" marT="27432" marB="27432" anchor="ctr">
+                    <a:lnL w="0" cap="flat" cmpd="sng" algn="ctr">
+                      <a:noFill/>
+                    </a:lnL>
+                    <a:lnR w="0" cap="flat" cmpd="sng" algn="ctr">
+                      <a:noFill/>
+                    </a:lnR>
+                    <a:lnT w="0" cap="flat" cmpd="sng" algn="ctr">
+                      <a:noFill/>
+                    </a:lnT>
+                    <a:lnB w="9525" cap="flat" cmpd="sng" algn="ctr">
+                      <a:solidFill>
+                        <a:srgbClr val="E5E7EB"/>
+                      </a:solidFill>
+                      <a:prstDash val="solid"/>
+                      <a:round/>
+                      <a:headEnd type="none" w="med" len="med"/>
+                      <a:tailEnd type="none" w="med" len="med"/>
+                    </a:lnB>
+                  </a:tcPr>
+                </a:tc>
+                <a:tc>
+                  <a:txBody>
+                    <a:bodyPr/>
+                    <a:lstStyle/>
+                    <a:p>
+                      <a:pPr algn="r" indent="0" marL="0">
+                        <a:buNone/>
+                      </a:pPr>
+                      <a:r>
+                        <a:rPr lang="en-US" sz="1300" dirty="0">
+                          <a:solidFill>
+                            <a:srgbClr val="1A1A1A"/>
+                          </a:solidFill>
+                          <a:latin typeface="Calibri" pitchFamily="34" charset="0"/>
+                          <a:ea typeface="Calibri" pitchFamily="34" charset="-122"/>
+                          <a:cs typeface="Calibri" pitchFamily="34" charset="-120"/>
+                        </a:rPr>
+                        <a:t>1,757</a:t>
+                      </a:r>
+                      <a:endParaRPr lang="en-US" sz="1300" dirty="0">
+                        <a:latin typeface="Calibri" charset="0"/>
+                        <a:ea typeface="Calibri" charset="0"/>
+                        <a:cs typeface="Calibri" charset="0"/>
+                      </a:endParaRPr>
+                    </a:p>
+                  </a:txBody>
+                  <a:tcPr marL="91440" marR="91440" marT="27432" marB="27432" anchor="ctr">
+                    <a:lnL w="0" cap="flat" cmpd="sng" algn="ctr">
+                      <a:noFill/>
+                    </a:lnL>
+                    <a:lnR w="0" cap="flat" cmpd="sng" algn="ctr">
+                      <a:noFill/>
+                    </a:lnR>
+                    <a:lnT w="0" cap="flat" cmpd="sng" algn="ctr">
+                      <a:noFill/>
+                    </a:lnT>
+                    <a:lnB w="9525" cap="flat" cmpd="sng" algn="ctr">
+                      <a:solidFill>
+                        <a:srgbClr val="E5E7EB"/>
+                      </a:solidFill>
+                      <a:prstDash val="solid"/>
+                      <a:round/>
+                      <a:headEnd type="none" w="med" len="med"/>
+                      <a:tailEnd type="none" w="med" len="med"/>
+                    </a:lnB>
+                  </a:tcPr>
+                </a:tc>
+              </a:tr>
+              <a:tr h="347472">
+                <a:tc>
+                  <a:txBody>
+                    <a:bodyPr/>
+                    <a:lstStyle/>
+                    <a:p>
+                      <a:pPr algn="l" indent="0" marL="0">
+                        <a:buNone/>
+                      </a:pPr>
+                      <a:r>
+                        <a:rPr lang="en-US" sz="1300" dirty="0">
+                          <a:solidFill>
+                            <a:srgbClr val="1A1A1A"/>
+                          </a:solidFill>
+                          <a:latin typeface="Calibri" pitchFamily="34" charset="0"/>
+                          <a:ea typeface="Calibri" pitchFamily="34" charset="-122"/>
+                          <a:cs typeface="Calibri" pitchFamily="34" charset="-120"/>
+                        </a:rPr>
+                        <a:t>Web of Science Core Collection</a:t>
+                      </a:r>
+                      <a:endParaRPr lang="en-US" sz="1300" dirty="0">
+                        <a:latin typeface="Calibri" charset="0"/>
+                        <a:ea typeface="Calibri" charset="0"/>
+                        <a:cs typeface="Calibri" charset="0"/>
+                      </a:endParaRPr>
+                    </a:p>
+                  </a:txBody>
+                  <a:tcPr marL="91440" marR="91440" marT="27432" marB="27432" anchor="ctr">
+                    <a:lnL w="0" cap="flat" cmpd="sng" algn="ctr">
+                      <a:noFill/>
+                    </a:lnL>
+                    <a:lnR w="0" cap="flat" cmpd="sng" algn="ctr">
+                      <a:noFill/>
+                    </a:lnR>
+                    <a:lnT w="0" cap="flat" cmpd="sng" algn="ctr">
+                      <a:noFill/>
+                    </a:lnT>
+                    <a:lnB w="9525" cap="flat" cmpd="sng" algn="ctr">
+                      <a:solidFill>
+                        <a:srgbClr val="E5E7EB"/>
+                      </a:solidFill>
+                      <a:prstDash val="solid"/>
+                      <a:round/>
+                      <a:headEnd type="none" w="med" len="med"/>
+                      <a:tailEnd type="none" w="med" len="med"/>
+                    </a:lnB>
+                  </a:tcPr>
+                </a:tc>
+                <a:tc>
+                  <a:txBody>
+                    <a:bodyPr/>
+                    <a:lstStyle/>
+                    <a:p>
+                      <a:pPr algn="r" indent="0" marL="0">
+                        <a:buNone/>
+                      </a:pPr>
+                      <a:r>
+                        <a:rPr lang="en-US" sz="1300" dirty="0">
+                          <a:solidFill>
+                            <a:srgbClr val="1A1A1A"/>
+                          </a:solidFill>
+                          <a:latin typeface="Calibri" pitchFamily="34" charset="0"/>
+                          <a:ea typeface="Calibri" pitchFamily="34" charset="-122"/>
+                          <a:cs typeface="Calibri" pitchFamily="34" charset="-120"/>
+                        </a:rPr>
+                        <a:t>1,876</a:t>
+                      </a:r>
+                      <a:endParaRPr lang="en-US" sz="1300" dirty="0">
+                        <a:latin typeface="Calibri" charset="0"/>
+                        <a:ea typeface="Calibri" charset="0"/>
+                        <a:cs typeface="Calibri" charset="0"/>
+                      </a:endParaRPr>
+                    </a:p>
+                  </a:txBody>
+                  <a:tcPr marL="91440" marR="91440" marT="27432" marB="27432" anchor="ctr">
+                    <a:lnL w="0" cap="flat" cmpd="sng" algn="ctr">
+                      <a:noFill/>
+                    </a:lnL>
+                    <a:lnR w="0" cap="flat" cmpd="sng" algn="ctr">
+                      <a:noFill/>
+                    </a:lnR>
+                    <a:lnT w="0" cap="flat" cmpd="sng" algn="ctr">
+                      <a:noFill/>
+                    </a:lnT>
+                    <a:lnB w="9525" cap="flat" cmpd="sng" algn="ctr">
+                      <a:solidFill>
+                        <a:srgbClr val="E5E7EB"/>
+                      </a:solidFill>
+                      <a:prstDash val="solid"/>
+                      <a:round/>
+                      <a:headEnd type="none" w="med" len="med"/>
+                      <a:tailEnd type="none" w="med" len="med"/>
+                    </a:lnB>
+                  </a:tcPr>
+                </a:tc>
+              </a:tr>
+              <a:tr h="347472">
+                <a:tc>
+                  <a:txBody>
+                    <a:bodyPr/>
+                    <a:lstStyle/>
+                    <a:p>
+                      <a:pPr algn="l" indent="0" marL="0">
+                        <a:buNone/>
+                      </a:pPr>
+                      <a:r>
+                        <a:rPr lang="en-US" sz="1300" dirty="0">
+                          <a:solidFill>
+                            <a:srgbClr val="1A1A1A"/>
+                          </a:solidFill>
+                          <a:latin typeface="Calibri" pitchFamily="34" charset="0"/>
+                          <a:ea typeface="Calibri" pitchFamily="34" charset="-122"/>
+                          <a:cs typeface="Calibri" pitchFamily="34" charset="-120"/>
+                        </a:rPr>
+                        <a:t>NASA Technical Reports Server</a:t>
+                      </a:r>
+                      <a:endParaRPr lang="en-US" sz="1300" dirty="0">
+                        <a:latin typeface="Calibri" charset="0"/>
+                        <a:ea typeface="Calibri" charset="0"/>
+                        <a:cs typeface="Calibri" charset="0"/>
+                      </a:endParaRPr>
+                    </a:p>
+                  </a:txBody>
+                  <a:tcPr marL="91440" marR="91440" marT="27432" marB="27432" anchor="ctr">
+                    <a:lnL w="0" cap="flat" cmpd="sng" algn="ctr">
+                      <a:noFill/>
+                    </a:lnL>
+                    <a:lnR w="0" cap="flat" cmpd="sng" algn="ctr">
+                      <a:noFill/>
+                    </a:lnR>
+                    <a:lnT w="0" cap="flat" cmpd="sng" algn="ctr">
+                      <a:noFill/>
+                    </a:lnT>
+                    <a:lnB w="9525" cap="flat" cmpd="sng" algn="ctr">
+                      <a:solidFill>
+                        <a:srgbClr val="E5E7EB"/>
+                      </a:solidFill>
+                      <a:prstDash val="solid"/>
+                      <a:round/>
+                      <a:headEnd type="none" w="med" len="med"/>
+                      <a:tailEnd type="none" w="med" len="med"/>
+                    </a:lnB>
+                  </a:tcPr>
+                </a:tc>
+                <a:tc>
+                  <a:txBody>
+                    <a:bodyPr/>
+                    <a:lstStyle/>
+                    <a:p>
+                      <a:pPr algn="r" indent="0" marL="0">
+                        <a:buNone/>
+                      </a:pPr>
+                      <a:r>
+                        <a:rPr lang="en-US" sz="1300" dirty="0">
+                          <a:solidFill>
+                            <a:srgbClr val="1A1A1A"/>
+                          </a:solidFill>
+                          <a:latin typeface="Calibri" pitchFamily="34" charset="0"/>
+                          <a:ea typeface="Calibri" pitchFamily="34" charset="-122"/>
+                          <a:cs typeface="Calibri" pitchFamily="34" charset="-120"/>
+                        </a:rPr>
+                        <a:t>686</a:t>
+                      </a:r>
+                      <a:endParaRPr lang="en-US" sz="1300" dirty="0">
+                        <a:latin typeface="Calibri" charset="0"/>
+                        <a:ea typeface="Calibri" charset="0"/>
+                        <a:cs typeface="Calibri" charset="0"/>
+                      </a:endParaRPr>
+                    </a:p>
+                  </a:txBody>
+                  <a:tcPr marL="91440" marR="91440" marT="27432" marB="27432" anchor="ctr">
+                    <a:lnL w="0" cap="flat" cmpd="sng" algn="ctr">
+                      <a:noFill/>
+                    </a:lnL>
+                    <a:lnR w="0" cap="flat" cmpd="sng" algn="ctr">
+                      <a:noFill/>
+                    </a:lnR>
+                    <a:lnT w="0" cap="flat" cmpd="sng" algn="ctr">
+                      <a:noFill/>
+                    </a:lnT>
+                    <a:lnB w="9525" cap="flat" cmpd="sng" algn="ctr">
+                      <a:solidFill>
+                        <a:srgbClr val="E5E7EB"/>
+                      </a:solidFill>
+                      <a:prstDash val="solid"/>
+                      <a:round/>
+                      <a:headEnd type="none" w="med" len="med"/>
+                      <a:tailEnd type="none" w="med" len="med"/>
+                    </a:lnB>
+                  </a:tcPr>
+                </a:tc>
+              </a:tr>
+              <a:tr h="347472">
+                <a:tc>
+                  <a:txBody>
+                    <a:bodyPr/>
+                    <a:lstStyle/>
+                    <a:p>
+                      <a:pPr algn="l" indent="0" marL="0">
+                        <a:buNone/>
+                      </a:pPr>
+                      <a:r>
+                        <a:rPr lang="en-US" sz="1300" dirty="0">
+                          <a:solidFill>
+                            <a:srgbClr val="1A1A1A"/>
+                          </a:solidFill>
+                          <a:latin typeface="Calibri" pitchFamily="34" charset="0"/>
+                          <a:ea typeface="Calibri" pitchFamily="34" charset="-122"/>
+                          <a:cs typeface="Calibri" pitchFamily="34" charset="-120"/>
+                        </a:rPr>
+                        <a:t>Earlier studies and NASA open data</a:t>
+                      </a:r>
+                      <a:endParaRPr lang="en-US" sz="1300" dirty="0">
+                        <a:latin typeface="Calibri" charset="0"/>
+                        <a:ea typeface="Calibri" charset="0"/>
+                        <a:cs typeface="Calibri" charset="0"/>
+                      </a:endParaRPr>
+                    </a:p>
+                  </a:txBody>
+                  <a:tcPr marL="91440" marR="91440" marT="27432" marB="27432" anchor="ctr">
+                    <a:lnL w="0" cap="flat" cmpd="sng" algn="ctr">
+                      <a:noFill/>
+                    </a:lnL>
+                    <a:lnR w="0" cap="flat" cmpd="sng" algn="ctr">
+                      <a:noFill/>
+                    </a:lnR>
+                    <a:lnT w="0" cap="flat" cmpd="sng" algn="ctr">
+                      <a:noFill/>
+                    </a:lnT>
+                    <a:lnB w="9525" cap="flat" cmpd="sng" algn="ctr">
+                      <a:solidFill>
+                        <a:srgbClr val="E5E7EB"/>
+                      </a:solidFill>
+                      <a:prstDash val="solid"/>
+                      <a:round/>
+                      <a:headEnd type="none" w="med" len="med"/>
+                      <a:tailEnd type="none" w="med" len="med"/>
+                    </a:lnB>
+                  </a:tcPr>
+                </a:tc>
+                <a:tc>
+                  <a:txBody>
+                    <a:bodyPr/>
+                    <a:lstStyle/>
+                    <a:p>
+                      <a:pPr algn="r" indent="0" marL="0">
+                        <a:buNone/>
+                      </a:pPr>
+                      <a:r>
+                        <a:rPr lang="en-US" sz="1300" dirty="0">
+                          <a:solidFill>
+                            <a:srgbClr val="1A1A1A"/>
+                          </a:solidFill>
+                          <a:latin typeface="Calibri" pitchFamily="34" charset="0"/>
+                          <a:ea typeface="Calibri" pitchFamily="34" charset="-122"/>
+                          <a:cs typeface="Calibri" pitchFamily="34" charset="-120"/>
+                        </a:rPr>
+                        <a:t>10</a:t>
+                      </a:r>
+                      <a:endParaRPr lang="en-US" sz="1300" dirty="0">
+                        <a:latin typeface="Calibri" charset="0"/>
+                        <a:ea typeface="Calibri" charset="0"/>
+                        <a:cs typeface="Calibri" charset="0"/>
+                      </a:endParaRPr>
+                    </a:p>
+                  </a:txBody>
+                  <a:tcPr marL="91440" marR="91440" marT="27432" marB="27432" anchor="ctr">
+                    <a:lnL w="0" cap="flat" cmpd="sng" algn="ctr">
+                      <a:noFill/>
+                    </a:lnL>
+                    <a:lnR w="0" cap="flat" cmpd="sng" algn="ctr">
+                      <a:noFill/>
+                    </a:lnR>
+                    <a:lnT w="0" cap="flat" cmpd="sng" algn="ctr">
+                      <a:noFill/>
+                    </a:lnT>
+                    <a:lnB w="9525" cap="flat" cmpd="sng" algn="ctr">
+                      <a:solidFill>
+                        <a:srgbClr val="E5E7EB"/>
+                      </a:solidFill>
+                      <a:prstDash val="solid"/>
+                      <a:round/>
+                      <a:headEnd type="none" w="med" len="med"/>
+                      <a:tailEnd type="none" w="med" len="med"/>
+                    </a:lnB>
+                  </a:tcPr>
+                </a:tc>
+              </a:tr>
+              <a:tr h="347472">
+                <a:tc>
+                  <a:txBody>
+                    <a:bodyPr/>
+                    <a:lstStyle/>
+                    <a:p>
+                      <a:pPr algn="l" indent="0" marL="0">
+                        <a:buNone/>
+                      </a:pPr>
+                      <a:r>
+                        <a:rPr lang="en-US" sz="1300" b="1" dirty="0">
+                          <a:solidFill>
+                            <a:srgbClr val="1A1A1A"/>
+                          </a:solidFill>
+                          <a:latin typeface="Calibri" pitchFamily="34" charset="0"/>
+                          <a:ea typeface="Calibri" pitchFamily="34" charset="-122"/>
+                          <a:cs typeface="Calibri" pitchFamily="34" charset="-120"/>
+                        </a:rPr>
+                        <a:t>Total</a:t>
+                      </a:r>
+                      <a:endParaRPr lang="en-US" sz="1300" dirty="0">
+                        <a:latin typeface="Calibri" charset="0"/>
+                        <a:ea typeface="Calibri" charset="0"/>
+                        <a:cs typeface="Calibri" charset="0"/>
+                      </a:endParaRPr>
+                    </a:p>
+                  </a:txBody>
+                  <a:tcPr marL="91440" marR="91440" marT="27432" marB="27432" anchor="ctr">
+                    <a:lnL w="0" cap="flat" cmpd="sng" algn="ctr">
+                      <a:noFill/>
+                    </a:lnL>
+                    <a:lnR w="0" cap="flat" cmpd="sng" algn="ctr">
+                      <a:noFill/>
+                    </a:lnR>
+                    <a:lnT w="0" cap="flat" cmpd="sng" algn="ctr">
+                      <a:noFill/>
+                    </a:lnT>
+                    <a:lnB w="9525" cap="flat" cmpd="sng" algn="ctr">
+                      <a:solidFill>
+                        <a:srgbClr val="E5E7EB"/>
+                      </a:solidFill>
+                      <a:prstDash val="solid"/>
+                      <a:round/>
+                      <a:headEnd type="none" w="med" len="med"/>
+                      <a:tailEnd type="none" w="med" len="med"/>
+                    </a:lnB>
+                  </a:tcPr>
+                </a:tc>
+                <a:tc>
+                  <a:txBody>
+                    <a:bodyPr/>
+                    <a:lstStyle/>
+                    <a:p>
+                      <a:pPr algn="r" indent="0" marL="0">
+                        <a:buNone/>
+                      </a:pPr>
+                      <a:r>
+                        <a:rPr lang="en-US" sz="1300" b="1" dirty="0">
+                          <a:solidFill>
+                            <a:srgbClr val="1A1A1A"/>
+                          </a:solidFill>
+                          <a:latin typeface="Calibri" pitchFamily="34" charset="0"/>
+                          <a:ea typeface="Calibri" pitchFamily="34" charset="-122"/>
+                          <a:cs typeface="Calibri" pitchFamily="34" charset="-120"/>
+                        </a:rPr>
+                        <a:t>5,741</a:t>
+                      </a:r>
+                      <a:endParaRPr lang="en-US" sz="1300" dirty="0">
+                        <a:latin typeface="Calibri" charset="0"/>
+                        <a:ea typeface="Calibri" charset="0"/>
+                        <a:cs typeface="Calibri" charset="0"/>
+                      </a:endParaRPr>
+                    </a:p>
+                  </a:txBody>
+                  <a:tcPr marL="91440" marR="91440" marT="27432" marB="27432" anchor="ctr">
+                    <a:lnL w="0" cap="flat" cmpd="sng" algn="ctr">
+                      <a:noFill/>
+                    </a:lnL>
+                    <a:lnR w="0" cap="flat" cmpd="sng" algn="ctr">
+                      <a:noFill/>
+                    </a:lnR>
+                    <a:lnT w="0" cap="flat" cmpd="sng" algn="ctr">
+                      <a:noFill/>
+                    </a:lnT>
+                    <a:lnB w="9525" cap="flat" cmpd="sng" algn="ctr">
+                      <a:solidFill>
+                        <a:srgbClr val="E5E7EB"/>
+                      </a:solidFill>
+                      <a:prstDash val="solid"/>
+                      <a:round/>
+                      <a:headEnd type="none" w="med" len="med"/>
+                      <a:tailEnd type="none" w="med" len="med"/>
+                    </a:lnB>
+                  </a:tcPr>
+                </a:tc>
+              </a:tr>
+            </a:tbl>
+          </a:graphicData>
+        </a:graphic>
+      </p:graphicFrame>
+      <p:sp>
+        <p:nvSpPr>
+          <p:cNvPr id="6" name="Text 3"/>
+          <p:cNvSpPr txBox="1"/>
+          <p:nvPr/>
+        </p:nvSpPr>
+        <p:spPr>
+          <a:xfrm>
+            <a:off x="548640" y="4114800"/>
+            <a:ext cx="5120640" cy="2011680"/>
+          </a:xfrm>
+          <a:prstGeom prst="rect">
+            <a:avLst/>
+          </a:prstGeom>
+          <a:noFill/>
+          <a:ln/>
+        </p:spPr>
+        <p:txBody>
+          <a:bodyPr wrap="square" lIns="0" tIns="0" rIns="0" bIns="0" rtlCol="0" anchor="t"/>
+          <a:lstStyle/>
           <a:p>
             <a:pPr marL="342900" indent="-342900">
               <a:spcAft>
@@ -9788,14 +10626,14 @@
               <a:buChar char="•"/>
             </a:pPr>
             <a:r>
-              <a:rPr lang="en-US" sz="1400" dirty="0">
+              <a:rPr lang="en-US" sz="1300" dirty="0">
                 <a:solidFill>
                   <a:schemeClr val="tx1"/>
                 </a:solidFill>
               </a:rPr>
-              <a:t>It is 13% lower error than the curve (3.13 to 2.71 pp)</a:t>
-            </a:r>
-            <a:endParaRPr lang="en-US" sz="1500" dirty="0"/>
+              <a:t>Journal databases: publications from 2013 onwards</a:t>
+            </a:r>
+            <a:endParaRPr lang="en-US" sz="1300" dirty="0"/>
           </a:p>
           <a:p>
             <a:pPr marL="342900" indent="-342900">
@@ -9806,53 +10644,14 @@
               <a:buChar char="•"/>
             </a:pPr>
             <a:r>
-              <a:rPr lang="en-US" sz="1400" dirty="0">
+              <a:rPr lang="en-US" sz="1300" dirty="0">
                 <a:solidFill>
                   <a:schemeClr val="tx1"/>
                 </a:solidFill>
               </a:rPr>
-              <a:t>Small: we report it as a finding, not the headline</a:t>
-            </a:r>
-            <a:endParaRPr lang="en-US" sz="1500" dirty="0"/>
-          </a:p>
-        </p:txBody>
-      </p:sp>
-      <p:sp>
-        <p:nvSpPr>
-          <p:cNvPr id="5" name="Text 3"/>
-          <p:cNvSpPr txBox="1"/>
-          <p:nvPr/>
-        </p:nvSpPr>
-        <p:spPr>
-          <a:xfrm>
-            <a:off x="6217920" y="1188720"/>
-            <a:ext cx="5394960" cy="2377440"/>
-          </a:xfrm>
-          <a:prstGeom prst="rect">
-            <a:avLst/>
-          </a:prstGeom>
-          <a:noFill/>
-          <a:ln/>
-        </p:spPr>
-        <p:txBody>
-          <a:bodyPr wrap="square" lIns="0" tIns="0" rIns="0" bIns="0" rtlCol="0" anchor="t"/>
-          <a:lstStyle/>
-          <a:p>
-            <a:pPr indent="0" marL="0">
-              <a:spcAft>
-                <a:spcPts val="400"/>
-              </a:spcAft>
-              <a:buNone/>
-            </a:pPr>
-            <a:r>
-              <a:rPr lang="en-US" sz="1500" b="1" dirty="0">
-                <a:solidFill>
-                  <a:schemeClr val="tx2"/>
-                </a:solidFill>
-              </a:rPr>
-              <a:t>20 of 32 studies is close to a coin flip</a:t>
-            </a:r>
-            <a:endParaRPr lang="en-US" sz="1500" dirty="0"/>
+              <a:t>Older work enters through studies we held before the search (9) and one NASA open-data campaign</a:t>
+            </a:r>
+            <a:endParaRPr lang="en-US" sz="1300" dirty="0"/>
           </a:p>
           <a:p>
             <a:pPr marL="342900" indent="-342900">
@@ -9863,14 +10662,14 @@
               <a:buChar char="•"/>
             </a:pPr>
             <a:r>
-              <a:rPr lang="en-US" sz="1400" dirty="0">
+              <a:rPr lang="en-US" sz="1300" dirty="0">
                 <a:solidFill>
                   <a:schemeClr val="tx1"/>
                 </a:solidFill>
               </a:rPr>
-              <a:t>Counting wins only: p = 0.22 (sign test)*</a:t>
-            </a:r>
-            <a:endParaRPr lang="en-US" sz="1500" dirty="0"/>
+              <a:t>NASA reports: five short keyword queries, e.g. "bed rest" "muscle volume"</a:t>
+            </a:r>
+            <a:endParaRPr lang="en-US" sz="1300" dirty="0"/>
           </a:p>
           <a:p>
             <a:pPr marL="342900" indent="-342900">
@@ -9881,27 +10680,27 @@
               <a:buChar char="•"/>
             </a:pPr>
             <a:r>
-              <a:rPr lang="en-US" sz="1400" dirty="0">
+              <a:rPr lang="en-US" sz="1300" dirty="0">
                 <a:solidFill>
                   <a:schemeClr val="tx1"/>
                 </a:solidFill>
               </a:rPr>
-              <a:t>The size of the wins matters: mean gain 0.42 pp, 95% CI 0.13 to 0.73</a:t>
-            </a:r>
-            <a:endParaRPr lang="en-US" sz="1500" dirty="0"/>
+              <a:t>Not searched: Embase (no institutional access), Cochrane CENTRAL, trial registries, citation chasing</a:t>
+            </a:r>
+            <a:endParaRPr lang="en-US" sz="1300" dirty="0"/>
           </a:p>
         </p:txBody>
       </p:sp>
       <p:sp>
         <p:nvSpPr>
-          <p:cNvPr id="6" name="Text 4"/>
+          <p:cNvPr id="7" name="Text 4"/>
           <p:cNvSpPr txBox="1"/>
           <p:nvPr/>
         </p:nvSpPr>
         <p:spPr>
           <a:xfrm>
-            <a:off x="548640" y="3703320"/>
-            <a:ext cx="5394960" cy="2377440"/>
+            <a:off x="6035040" y="1188720"/>
+            <a:ext cx="5577840" cy="292608"/>
           </a:xfrm>
           <a:prstGeom prst="rect">
             <a:avLst/>
@@ -9914,9 +10713,6 @@
           <a:lstStyle/>
           <a:p>
             <a:pPr indent="0" marL="0">
-              <a:spcAft>
-                <a:spcPts val="400"/>
-              </a:spcAft>
               <a:buNone/>
             </a:pPr>
             <a:r>
@@ -9925,58 +10721,319 @@
                   <a:schemeClr val="tx2"/>
                 </a:solidFill>
               </a:rPr>
-              <a:t>Does it rest on a few studies?</a:t>
+              <a:t>Query: two required blocks</a:t>
             </a:r>
             <a:endParaRPr lang="en-US" sz="1500" dirty="0"/>
           </a:p>
-          <a:p>
-            <a:pPr marL="342900" indent="-342900">
-              <a:spcAft>
-                <a:spcPts val="400"/>
-              </a:spcAft>
-              <a:buSzPct val="100000"/>
-              <a:buChar char="•"/>
-            </a:pPr>
-            <a:r>
-              <a:rPr lang="en-US" sz="1400" dirty="0">
+        </p:txBody>
+      </p:sp>
+      <p:sp>
+        <p:nvSpPr>
+          <p:cNvPr id="8" name="Block Unloading model"/>
+          <p:cNvSpPr/>
+          <p:nvPr/>
+        </p:nvSpPr>
+        <p:spPr>
+          <a:xfrm>
+            <a:off x="6035040" y="1572768"/>
+            <a:ext cx="1600200" cy="1463040"/>
+          </a:xfrm>
+          <a:prstGeom prst="rect">
+            <a:avLst/>
+          </a:prstGeom>
+          <a:solidFill>
+            <a:srgbClr val="FFFFFF"/>
+          </a:solidFill>
+          <a:ln w="12700">
+            <a:solidFill>
+              <a:srgbClr val="9AA3AE"/>
+            </a:solidFill>
+            <a:prstDash val="solid"/>
+          </a:ln>
+        </p:spPr>
+      </p:sp>
+      <p:sp>
+        <p:nvSpPr>
+          <p:cNvPr id="9" name="Text 6"/>
+          <p:cNvSpPr txBox="1"/>
+          <p:nvPr/>
+        </p:nvSpPr>
+        <p:spPr>
+          <a:xfrm>
+            <a:off x="6108192" y="1627632"/>
+            <a:ext cx="1453896" cy="1371600"/>
+          </a:xfrm>
+          <a:prstGeom prst="rect">
+            <a:avLst/>
+          </a:prstGeom>
+          <a:noFill/>
+          <a:ln/>
+        </p:spPr>
+        <p:txBody>
+          <a:bodyPr wrap="square" lIns="0" tIns="0" rIns="0" bIns="0" rtlCol="0" anchor="ctr"/>
+          <a:lstStyle/>
+          <a:p>
+            <a:pPr algn="ctr" indent="0" marL="0">
+              <a:buNone/>
+            </a:pPr>
+            <a:r>
+              <a:rPr lang="en-US" sz="1200" b="1" dirty="0">
+                <a:solidFill>
+                  <a:schemeClr val="tx2"/>
+                </a:solidFill>
+              </a:rPr>
+              <a:t>Unloading model</a:t>
+            </a:r>
+            <a:endParaRPr lang="en-US" sz="1200" dirty="0"/>
+          </a:p>
+          <a:p>
+            <a:pPr algn="ctr" indent="0" marL="0">
+              <a:buNone/>
+            </a:pPr>
+            <a:r>
+              <a:rPr lang="en-US" sz="1050" dirty="0">
                 <a:solidFill>
                   <a:schemeClr val="tx1"/>
                 </a:solidFill>
               </a:rPr>
-              <a:t>3 long MRI studies (NASA SPRINT, Berlin BBR2-2, MEDES LTBR) give 56% of the gain; without them 0.20 pp, CI −0.01 to 0.43*</a:t>
-            </a:r>
-            <a:endParaRPr lang="en-US" sz="1500" dirty="0"/>
-          </a:p>
-          <a:p>
-            <a:pPr marL="342900" indent="-342900">
-              <a:spcAft>
-                <a:spcPts val="400"/>
-              </a:spcAft>
-              <a:buSzPct val="100000"/>
-              <a:buChar char="•"/>
-            </a:pPr>
-            <a:r>
-              <a:rPr lang="en-US" sz="1400" dirty="0">
+              <a:t>bed rest, head-down tilt, dry immersion, limb suspension, simulated microgravity, disuse</a:t>
+            </a:r>
+            <a:endParaRPr lang="en-US" sz="1200" dirty="0"/>
+          </a:p>
+        </p:txBody>
+      </p:sp>
+      <p:sp>
+        <p:nvSpPr>
+          <p:cNvPr id="10" name="Text 7"/>
+          <p:cNvSpPr txBox="1"/>
+          <p:nvPr/>
+        </p:nvSpPr>
+        <p:spPr>
+          <a:xfrm>
+            <a:off x="7635240" y="1572768"/>
+            <a:ext cx="388620" cy="1463040"/>
+          </a:xfrm>
+          <a:prstGeom prst="rect">
+            <a:avLst/>
+          </a:prstGeom>
+          <a:noFill/>
+          <a:ln/>
+        </p:spPr>
+        <p:txBody>
+          <a:bodyPr wrap="square" lIns="0" tIns="0" rIns="0" bIns="0" rtlCol="0" anchor="ctr"/>
+          <a:lstStyle/>
+          <a:p>
+            <a:pPr algn="ctr" indent="0" marL="0">
+              <a:buNone/>
+            </a:pPr>
+            <a:r>
+              <a:rPr lang="en-US" sz="1100" b="1" dirty="0">
+                <a:solidFill>
+                  <a:schemeClr val="accent1"/>
+                </a:solidFill>
+              </a:rPr>
+              <a:t>AND</a:t>
+            </a:r>
+            <a:endParaRPr lang="en-US" sz="1100" dirty="0"/>
+          </a:p>
+        </p:txBody>
+      </p:sp>
+      <p:sp>
+        <p:nvSpPr>
+          <p:cNvPr id="11" name="Block Muscle outcome"/>
+          <p:cNvSpPr/>
+          <p:nvPr/>
+        </p:nvSpPr>
+        <p:spPr>
+          <a:xfrm>
+            <a:off x="8023860" y="1572768"/>
+            <a:ext cx="1600200" cy="1463040"/>
+          </a:xfrm>
+          <a:prstGeom prst="rect">
+            <a:avLst/>
+          </a:prstGeom>
+          <a:solidFill>
+            <a:srgbClr val="FFFFFF"/>
+          </a:solidFill>
+          <a:ln w="12700">
+            <a:solidFill>
+              <a:srgbClr val="9AA3AE"/>
+            </a:solidFill>
+            <a:prstDash val="solid"/>
+          </a:ln>
+        </p:spPr>
+      </p:sp>
+      <p:sp>
+        <p:nvSpPr>
+          <p:cNvPr id="12" name="Text 9"/>
+          <p:cNvSpPr txBox="1"/>
+          <p:nvPr/>
+        </p:nvSpPr>
+        <p:spPr>
+          <a:xfrm>
+            <a:off x="8097012" y="1627632"/>
+            <a:ext cx="1453896" cy="1371600"/>
+          </a:xfrm>
+          <a:prstGeom prst="rect">
+            <a:avLst/>
+          </a:prstGeom>
+          <a:noFill/>
+          <a:ln/>
+        </p:spPr>
+        <p:txBody>
+          <a:bodyPr wrap="square" lIns="0" tIns="0" rIns="0" bIns="0" rtlCol="0" anchor="ctr"/>
+          <a:lstStyle/>
+          <a:p>
+            <a:pPr algn="ctr" indent="0" marL="0">
+              <a:buNone/>
+            </a:pPr>
+            <a:r>
+              <a:rPr lang="en-US" sz="1200" b="1" dirty="0">
+                <a:solidFill>
+                  <a:schemeClr val="tx2"/>
+                </a:solidFill>
+              </a:rPr>
+              <a:t>Muscle outcome</a:t>
+            </a:r>
+            <a:endParaRPr lang="en-US" sz="1200" dirty="0"/>
+          </a:p>
+          <a:p>
+            <a:pPr algn="ctr" indent="0" marL="0">
+              <a:buNone/>
+            </a:pPr>
+            <a:r>
+              <a:rPr lang="en-US" sz="1050" dirty="0">
                 <a:solidFill>
                   <a:schemeClr val="tx1"/>
                 </a:solidFill>
               </a:rPr>
-              <a:t>Only SPRINT is recognised, and with study details removed the LLM still wins there (3.79 vs 5.92 pp)</a:t>
-            </a:r>
-            <a:endParaRPr lang="en-US" sz="1500" dirty="0"/>
+              <a:t>atrophy, muscle volume, mass, size, cross-sectional area, lean mass, thickness, main leg muscles</a:t>
+            </a:r>
+            <a:endParaRPr lang="en-US" sz="1200" dirty="0"/>
           </a:p>
         </p:txBody>
       </p:sp>
       <p:sp>
         <p:nvSpPr>
-          <p:cNvPr id="7" name="Text 5"/>
+          <p:cNvPr id="13" name="Text 10"/>
           <p:cNvSpPr txBox="1"/>
           <p:nvPr/>
         </p:nvSpPr>
         <p:spPr>
           <a:xfrm>
-            <a:off x="6217920" y="3703320"/>
-            <a:ext cx="5394960" cy="2377440"/>
+            <a:off x="9624060" y="1572768"/>
+            <a:ext cx="388620" cy="1463040"/>
+          </a:xfrm>
+          <a:prstGeom prst="rect">
+            <a:avLst/>
+          </a:prstGeom>
+          <a:noFill/>
+          <a:ln/>
+        </p:spPr>
+        <p:txBody>
+          <a:bodyPr wrap="square" lIns="0" tIns="0" rIns="0" bIns="0" rtlCol="0" anchor="ctr"/>
+          <a:lstStyle/>
+          <a:p>
+            <a:pPr algn="ctr" indent="0" marL="0">
+              <a:buNone/>
+            </a:pPr>
+            <a:r>
+              <a:rPr lang="en-US" sz="1100" b="1" dirty="0">
+                <a:solidFill>
+                  <a:schemeClr val="accent1"/>
+                </a:solidFill>
+              </a:rPr>
+              <a:t>NOT</a:t>
+            </a:r>
+            <a:endParaRPr lang="en-US" sz="1100" dirty="0"/>
+          </a:p>
+        </p:txBody>
+      </p:sp>
+      <p:sp>
+        <p:nvSpPr>
+          <p:cNvPr id="14" name="Block Excluded"/>
+          <p:cNvSpPr/>
+          <p:nvPr/>
+        </p:nvSpPr>
+        <p:spPr>
+          <a:xfrm>
+            <a:off x="10012680" y="1572768"/>
+            <a:ext cx="1600200" cy="1463040"/>
+          </a:xfrm>
+          <a:prstGeom prst="rect">
+            <a:avLst/>
+          </a:prstGeom>
+          <a:solidFill>
+            <a:schemeClr val="bg2"/>
+          </a:solidFill>
+          <a:ln w="12700">
+            <a:solidFill>
+              <a:srgbClr val="9AA3AE"/>
+            </a:solidFill>
+            <a:prstDash val="dash"/>
+          </a:ln>
+        </p:spPr>
+      </p:sp>
+      <p:sp>
+        <p:nvSpPr>
+          <p:cNvPr id="15" name="Text 12"/>
+          <p:cNvSpPr txBox="1"/>
+          <p:nvPr/>
+        </p:nvSpPr>
+        <p:spPr>
+          <a:xfrm>
+            <a:off x="10085832" y="1627632"/>
+            <a:ext cx="1453896" cy="1371600"/>
+          </a:xfrm>
+          <a:prstGeom prst="rect">
+            <a:avLst/>
+          </a:prstGeom>
+          <a:noFill/>
+          <a:ln/>
+        </p:spPr>
+        <p:txBody>
+          <a:bodyPr wrap="square" lIns="0" tIns="0" rIns="0" bIns="0" rtlCol="0" anchor="ctr"/>
+          <a:lstStyle/>
+          <a:p>
+            <a:pPr algn="ctr" indent="0" marL="0">
+              <a:buNone/>
+            </a:pPr>
+            <a:r>
+              <a:rPr lang="en-US" sz="1200" b="1" dirty="0">
+                <a:solidFill>
+                  <a:schemeClr val="tx2"/>
+                </a:solidFill>
+              </a:rPr>
+              <a:t>Excluded</a:t>
+            </a:r>
+            <a:endParaRPr lang="en-US" sz="1200" dirty="0"/>
+          </a:p>
+          <a:p>
+            <a:pPr algn="ctr" indent="0" marL="0">
+              <a:buNone/>
+            </a:pPr>
+            <a:r>
+              <a:rPr lang="en-US" sz="1050" dirty="0">
+                <a:solidFill>
+                  <a:schemeClr val="tx1"/>
+                </a:solidFill>
+              </a:rPr>
+              <a:t>rat, mouse, rodent, hindlimb</a:t>
+            </a:r>
+            <a:endParaRPr lang="en-US" sz="1200" dirty="0"/>
+          </a:p>
+        </p:txBody>
+      </p:sp>
+      <p:sp>
+        <p:nvSpPr>
+          <p:cNvPr id="16" name="Text 13"/>
+          <p:cNvSpPr txBox="1"/>
+          <p:nvPr/>
+        </p:nvSpPr>
+        <p:spPr>
+          <a:xfrm>
+            <a:off x="6035040" y="3200400"/>
+            <a:ext cx="5577840" cy="228600"/>
           </a:xfrm>
           <a:prstGeom prst="rect">
             <a:avLst/>
@@ -9989,69 +11046,50 @@
           <a:lstStyle/>
           <a:p>
             <a:pPr indent="0" marL="0">
-              <a:spcAft>
-                <a:spcPts val="400"/>
-              </a:spcAft>
               <a:buNone/>
             </a:pPr>
             <a:r>
-              <a:rPr lang="en-US" sz="1500" b="1" dirty="0">
-                <a:solidFill>
-                  <a:schemeClr val="tx2"/>
-                </a:solidFill>
-              </a:rPr>
-              <a:t>Did it read these papers in training? Was it added after the fact?</a:t>
-            </a:r>
-            <a:endParaRPr lang="en-US" sz="1500" dirty="0"/>
-          </a:p>
-          <a:p>
-            <a:pPr marL="342900" indent="-342900">
-              <a:spcAft>
-                <a:spcPts val="400"/>
-              </a:spcAft>
-              <a:buSzPct val="100000"/>
-              <a:buChar char="•"/>
-            </a:pPr>
-            <a:r>
-              <a:rPr lang="en-US" sz="1400" dirty="0">
-                <a:solidFill>
-                  <a:schemeClr val="tx1"/>
-                </a:solidFill>
-              </a:rPr>
-              <a:t>Training exposure cannot be ruled out by any test; hiding study details and the naming test are the strongest checks available</a:t>
-            </a:r>
-            <a:endParaRPr lang="en-US" sz="1500" dirty="0"/>
-          </a:p>
-          <a:p>
-            <a:pPr marL="342900" indent="-342900">
-              <a:spcAft>
-                <a:spcPts val="400"/>
-              </a:spcAft>
-              <a:buSzPct val="100000"/>
-              <a:buChar char="•"/>
-            </a:pPr>
-            <a:r>
-              <a:rPr lang="en-US" sz="1400" dirty="0">
-                <a:solidFill>
-                  <a:schemeClr val="tx1"/>
-                </a:solidFill>
-              </a:rPr>
-              <a:t>Added after the ML result, but every check and target was committed before the first answer</a:t>
-            </a:r>
-            <a:endParaRPr lang="en-US" sz="1500" dirty="0"/>
+              <a:rPr lang="en-US" sz="1100" b="1" dirty="0">
+                <a:solidFill>
+                  <a:schemeClr val="accent3"/>
+                </a:solidFill>
+              </a:rPr>
+              <a:t>Web of Science string, verbatim</a:t>
+            </a:r>
+            <a:endParaRPr lang="en-US" sz="1100" dirty="0"/>
           </a:p>
         </p:txBody>
       </p:sp>
       <p:sp>
         <p:nvSpPr>
-          <p:cNvPr id="8" name="Text 6"/>
+          <p:cNvPr id="17" name="Query panel"/>
+          <p:cNvSpPr/>
+          <p:nvPr/>
+        </p:nvSpPr>
+        <p:spPr>
+          <a:xfrm>
+            <a:off x="6035040" y="3456432"/>
+            <a:ext cx="5605272" cy="2240280"/>
+          </a:xfrm>
+          <a:prstGeom prst="rect">
+            <a:avLst/>
+          </a:prstGeom>
+          <a:solidFill>
+            <a:schemeClr val="bg2"/>
+          </a:solidFill>
+          <a:ln/>
+        </p:spPr>
+      </p:sp>
+      <p:sp>
+        <p:nvSpPr>
+          <p:cNvPr id="18" name="Text 15"/>
           <p:cNvSpPr txBox="1"/>
           <p:nvPr/>
         </p:nvSpPr>
         <p:spPr>
           <a:xfrm>
-            <a:off x="548640" y="6035040"/>
-            <a:ext cx="9144000" cy="274320"/>
+            <a:off x="6144768" y="3547872"/>
+            <a:ext cx="5440680" cy="2103120"/>
           </a:xfrm>
           <a:prstGeom prst="rect">
             <a:avLst/>
@@ -10067,14 +11105,187 @@
               <a:buNone/>
             </a:pPr>
             <a:r>
-              <a:rPr lang="en-US" sz="1100" i="1" dirty="0">
-                <a:solidFill>
-                  <a:schemeClr val="accent3"/>
-                </a:solidFill>
-              </a:rPr>
-              <a:t>* Our calculation from results/forecast_predictions.csv; not in the report.</a:t>
-            </a:r>
-            <a:endParaRPr lang="en-US" sz="1100" dirty="0"/>
+              <a:rPr lang="en-US" sz="900" dirty="0">
+                <a:solidFill>
+                  <a:schemeClr val="tx1"/>
+                </a:solidFill>
+                <a:latin typeface="Courier New" pitchFamily="34" charset="0"/>
+                <a:ea typeface="Courier New" pitchFamily="34" charset="-122"/>
+                <a:cs typeface="Courier New" pitchFamily="34" charset="-120"/>
+              </a:rPr>
+              <a:t>TS=(("bed rest" OR bedrest OR "head-down tilt" OR "head down bed rest" OR HDBR</a:t>
+            </a:r>
+            <a:endParaRPr lang="en-US" sz="900" dirty="0"/>
+          </a:p>
+          <a:p>
+            <a:pPr indent="0" marL="0">
+              <a:buNone/>
+            </a:pPr>
+            <a:r>
+              <a:rPr lang="en-US" sz="900" dirty="0">
+                <a:solidFill>
+                  <a:schemeClr val="tx1"/>
+                </a:solidFill>
+                <a:latin typeface="Courier New" pitchFamily="34" charset="0"/>
+                <a:ea typeface="Courier New" pitchFamily="34" charset="-122"/>
+                <a:cs typeface="Courier New" pitchFamily="34" charset="-120"/>
+              </a:rPr>
+              <a:t>  OR antiorthostatic OR hypokinesia OR hypodynamia OR "dry immersion"</a:t>
+            </a:r>
+            <a:endParaRPr lang="en-US" sz="900" dirty="0"/>
+          </a:p>
+          <a:p>
+            <a:pPr indent="0" marL="0">
+              <a:buNone/>
+            </a:pPr>
+            <a:r>
+              <a:rPr lang="en-US" sz="900" dirty="0">
+                <a:solidFill>
+                  <a:schemeClr val="tx1"/>
+                </a:solidFill>
+                <a:latin typeface="Courier New" pitchFamily="34" charset="0"/>
+                <a:ea typeface="Courier New" pitchFamily="34" charset="-122"/>
+                <a:cs typeface="Courier New" pitchFamily="34" charset="-120"/>
+              </a:rPr>
+              <a:t>  OR "limb suspension" OR ULLS OR "simulated microgravity"</a:t>
+            </a:r>
+            <a:endParaRPr lang="en-US" sz="900" dirty="0"/>
+          </a:p>
+          <a:p>
+            <a:pPr indent="0" marL="0">
+              <a:buNone/>
+            </a:pPr>
+            <a:r>
+              <a:rPr lang="en-US" sz="900" dirty="0">
+                <a:solidFill>
+                  <a:schemeClr val="tx1"/>
+                </a:solidFill>
+                <a:latin typeface="Courier New" pitchFamily="34" charset="0"/>
+                <a:ea typeface="Courier New" pitchFamily="34" charset="-122"/>
+                <a:cs typeface="Courier New" pitchFamily="34" charset="-120"/>
+              </a:rPr>
+              <a:t>  OR "microgravity analog*" OR "spaceflight analog*" OR "mechanical unloading"</a:t>
+            </a:r>
+            <a:endParaRPr lang="en-US" sz="900" dirty="0"/>
+          </a:p>
+          <a:p>
+            <a:pPr indent="0" marL="0">
+              <a:buNone/>
+            </a:pPr>
+            <a:r>
+              <a:rPr lang="en-US" sz="900" dirty="0">
+                <a:solidFill>
+                  <a:schemeClr val="tx1"/>
+                </a:solidFill>
+                <a:latin typeface="Courier New" pitchFamily="34" charset="0"/>
+                <a:ea typeface="Courier New" pitchFamily="34" charset="-122"/>
+                <a:cs typeface="Courier New" pitchFamily="34" charset="-120"/>
+              </a:rPr>
+              <a:t>  OR "muscle unloading" OR disuse)</a:t>
+            </a:r>
+            <a:endParaRPr lang="en-US" sz="900" dirty="0"/>
+          </a:p>
+          <a:p>
+            <a:pPr indent="0" marL="0">
+              <a:buNone/>
+            </a:pPr>
+            <a:r>
+              <a:rPr lang="en-US" sz="900" dirty="0">
+                <a:solidFill>
+                  <a:schemeClr val="tx1"/>
+                </a:solidFill>
+                <a:latin typeface="Courier New" pitchFamily="34" charset="0"/>
+                <a:ea typeface="Courier New" pitchFamily="34" charset="-122"/>
+                <a:cs typeface="Courier New" pitchFamily="34" charset="-120"/>
+              </a:rPr>
+              <a:t> AND</a:t>
+            </a:r>
+            <a:endParaRPr lang="en-US" sz="900" dirty="0"/>
+          </a:p>
+          <a:p>
+            <a:pPr indent="0" marL="0">
+              <a:buNone/>
+            </a:pPr>
+            <a:r>
+              <a:rPr lang="en-US" sz="900" dirty="0">
+                <a:solidFill>
+                  <a:schemeClr val="tx1"/>
+                </a:solidFill>
+                <a:latin typeface="Courier New" pitchFamily="34" charset="0"/>
+                <a:ea typeface="Courier New" pitchFamily="34" charset="-122"/>
+                <a:cs typeface="Courier New" pitchFamily="34" charset="-120"/>
+              </a:rPr>
+              <a:t> (atroph* OR "muscle volume" OR "muscle mass" OR "muscle size"</a:t>
+            </a:r>
+            <a:endParaRPr lang="en-US" sz="900" dirty="0"/>
+          </a:p>
+          <a:p>
+            <a:pPr indent="0" marL="0">
+              <a:buNone/>
+            </a:pPr>
+            <a:r>
+              <a:rPr lang="en-US" sz="900" dirty="0">
+                <a:solidFill>
+                  <a:schemeClr val="tx1"/>
+                </a:solidFill>
+                <a:latin typeface="Courier New" pitchFamily="34" charset="0"/>
+                <a:ea typeface="Courier New" pitchFamily="34" charset="-122"/>
+                <a:cs typeface="Courier New" pitchFamily="34" charset="-120"/>
+              </a:rPr>
+              <a:t>  OR "cross-sectional area" OR PCSA OR "lean mass" OR "muscle thickness"</a:t>
+            </a:r>
+            <a:endParaRPr lang="en-US" sz="900" dirty="0"/>
+          </a:p>
+          <a:p>
+            <a:pPr indent="0" marL="0">
+              <a:buNone/>
+            </a:pPr>
+            <a:r>
+              <a:rPr lang="en-US" sz="900" dirty="0">
+                <a:solidFill>
+                  <a:schemeClr val="tx1"/>
+                </a:solidFill>
+                <a:latin typeface="Courier New" pitchFamily="34" charset="0"/>
+                <a:ea typeface="Courier New" pitchFamily="34" charset="-122"/>
+                <a:cs typeface="Courier New" pitchFamily="34" charset="-120"/>
+              </a:rPr>
+              <a:t>  OR "muscle wasting" OR deconditioning OR soleus OR gastrocnemius</a:t>
+            </a:r>
+            <a:endParaRPr lang="en-US" sz="900" dirty="0"/>
+          </a:p>
+          <a:p>
+            <a:pPr indent="0" marL="0">
+              <a:buNone/>
+            </a:pPr>
+            <a:r>
+              <a:rPr lang="en-US" sz="900" dirty="0">
+                <a:solidFill>
+                  <a:schemeClr val="tx1"/>
+                </a:solidFill>
+                <a:latin typeface="Courier New" pitchFamily="34" charset="0"/>
+                <a:ea typeface="Courier New" pitchFamily="34" charset="-122"/>
+                <a:cs typeface="Courier New" pitchFamily="34" charset="-120"/>
+              </a:rPr>
+              <a:t>  OR "triceps surae" OR quadriceps OR "vastus lateralis" OR "knee extensor"))</a:t>
+            </a:r>
+            <a:endParaRPr lang="en-US" sz="900" dirty="0"/>
+          </a:p>
+          <a:p>
+            <a:pPr indent="0" marL="0">
+              <a:buNone/>
+            </a:pPr>
+            <a:r>
+              <a:rPr lang="en-US" sz="900" dirty="0">
+                <a:solidFill>
+                  <a:schemeClr val="tx1"/>
+                </a:solidFill>
+                <a:latin typeface="Courier New" pitchFamily="34" charset="0"/>
+                <a:ea typeface="Courier New" pitchFamily="34" charset="-122"/>
+                <a:cs typeface="Courier New" pitchFamily="34" charset="-120"/>
+              </a:rPr>
+              <a:t>NOT TS=(rat OR rats OR mice OR mouse OR rodent OR hindlimb OR "hind limb")</a:t>
+            </a:r>
+            <a:endParaRPr lang="en-US" sz="900" dirty="0"/>
           </a:p>
         </p:txBody>
       </p:sp>
@@ -10183,7 +11394,7 @@
                 <a:ea typeface="Cambria" pitchFamily="34" charset="-122"/>
                 <a:cs typeface="Cambria" pitchFamily="34" charset="-120"/>
               </a:rPr>
-              <a:t>Backup: why did ML fail, and was the comparison fair?</a:t>
+              <a:t>Backup: is the LLM gain real, and does it matter?</a:t>
             </a:r>
             <a:endParaRPr lang="en-US" sz="2800" dirty="0"/>
           </a:p>
@@ -10258,7 +11469,7 @@
                   <a:schemeClr val="tx2"/>
                 </a:solidFill>
               </a:rPr>
-              <a:t>Did the ML models get a fair chance?</a:t>
+              <a:t>Is 0.42 pp worth anything?</a:t>
             </a:r>
             <a:endParaRPr lang="en-US" sz="1500" dirty="0"/>
           </a:p>
@@ -10276,7 +11487,7 @@
                   <a:schemeClr val="tx1"/>
                 </a:solidFill>
               </a:rPr>
-              <a:t>Tuned inside each training fold, grouped by study; TabPFN needs no tuning</a:t>
+              <a:t>It is 13% lower error than the curve (3.13 to 2.71 pp)</a:t>
             </a:r>
             <a:endParaRPr lang="en-US" sz="1500" dirty="0"/>
           </a:p>
@@ -10294,7 +11505,7 @@
                   <a:schemeClr val="tx1"/>
                 </a:solidFill>
               </a:rPr>
-              <a:t>All models saw the same inputs, folds and scoring</a:t>
+              <a:t>Small: we report it as a finding, not the headline</a:t>
             </a:r>
             <a:endParaRPr lang="en-US" sz="1500" dirty="0"/>
           </a:p>
@@ -10333,7 +11544,7 @@
                   <a:schemeClr val="tx2"/>
                 </a:solidFill>
               </a:rPr>
-              <a:t>Why not add age, sex or countermeasure type?</a:t>
+              <a:t>20 of 32 studies is close to a coin flip</a:t>
             </a:r>
             <a:endParaRPr lang="en-US" sz="1500" dirty="0"/>
           </a:p>
@@ -10351,7 +11562,7 @@
                   <a:schemeClr val="tx1"/>
                 </a:solidFill>
               </a:rPr>
-              <a:t>32 studies leave room for about 3 study-level inputs (about 10 studies per input)</a:t>
+              <a:t>Counting wins only: p = 0.22 (sign test)*</a:t>
             </a:r>
             <a:endParaRPr lang="en-US" sz="1500" dirty="0"/>
           </a:p>
@@ -10369,7 +11580,7 @@
                   <a:schemeClr val="tx1"/>
                 </a:solidFill>
               </a:rPr>
-              <a:t>Age and sex are fixed within a study (347 of 425 rows men-only), so they act as a study label; 126 countermeasure rows spread over 9 types</a:t>
+              <a:t>The size of the wins matters: mean gain 0.42 pp, 95% CI 0.13 to 0.73</a:t>
             </a:r>
             <a:endParaRPr lang="en-US" sz="1500" dirty="0"/>
           </a:p>
@@ -10408,7 +11619,7 @@
                   <a:schemeClr val="tx2"/>
                 </a:solidFill>
               </a:rPr>
-              <a:t>Is the duration curve a straw man?</a:t>
+              <a:t>Does it rest on a few studies?</a:t>
             </a:r>
             <a:endParaRPr lang="en-US" sz="1500" dirty="0"/>
           </a:p>
@@ -10426,7 +11637,7 @@
                   <a:schemeClr val="tx1"/>
                 </a:solidFill>
               </a:rPr>
-              <a:t>Ridge regression uses days, muscle and every other input: 3.28 vs 3.16 pp</a:t>
+              <a:t>3 long MRI studies (NASA SPRINT, Berlin BBR2-2, MEDES LTBR) give 56% of the gain; without them 0.20 pp, CI −0.01 to 0.43*</a:t>
             </a:r>
             <a:endParaRPr lang="en-US" sz="1500" dirty="0"/>
           </a:p>
@@ -10444,7 +11655,7 @@
                   <a:schemeClr val="tx1"/>
                 </a:solidFill>
               </a:rPr>
-              <a:t>Knowing the muscle raises R² but not the error on a new study</a:t>
+              <a:t>Only SPRINT is recognised, and with study details removed the LLM still wins there (3.79 vs 5.92 pp)</a:t>
             </a:r>
             <a:endParaRPr lang="en-US" sz="1500" dirty="0"/>
           </a:p>
@@ -10483,7 +11694,7 @@
                   <a:schemeClr val="tx2"/>
                 </a:solidFill>
               </a:rPr>
-              <a:t>Would a nearest-neighbour method match the LLM?</a:t>
+              <a:t>Did it read these papers in training? Was it added after the fact?</a:t>
             </a:r>
             <a:endParaRPr lang="en-US" sz="1500" dirty="0"/>
           </a:p>
@@ -10501,9 +11712,63 @@
                   <a:schemeClr val="tx1"/>
                 </a:solidFill>
               </a:rPr>
-              <a:t>Not tested. If the gain comes from picking similar rows, this is the obvious next control</a:t>
+              <a:t>Training exposure cannot be ruled out by any test; hiding study details and the naming test are the strongest checks available</a:t>
             </a:r>
             <a:endParaRPr lang="en-US" sz="1500" dirty="0"/>
+          </a:p>
+          <a:p>
+            <a:pPr marL="342900" indent="-342900">
+              <a:spcAft>
+                <a:spcPts val="400"/>
+              </a:spcAft>
+              <a:buSzPct val="100000"/>
+              <a:buChar char="•"/>
+            </a:pPr>
+            <a:r>
+              <a:rPr lang="en-US" sz="1400" dirty="0">
+                <a:solidFill>
+                  <a:schemeClr val="tx1"/>
+                </a:solidFill>
+              </a:rPr>
+              <a:t>Added after the ML result, but every check and target was committed before the first answer</a:t>
+            </a:r>
+            <a:endParaRPr lang="en-US" sz="1500" dirty="0"/>
+          </a:p>
+        </p:txBody>
+      </p:sp>
+      <p:sp>
+        <p:nvSpPr>
+          <p:cNvPr id="8" name="Text 6"/>
+          <p:cNvSpPr txBox="1"/>
+          <p:nvPr/>
+        </p:nvSpPr>
+        <p:spPr>
+          <a:xfrm>
+            <a:off x="548640" y="6035040"/>
+            <a:ext cx="9144000" cy="274320"/>
+          </a:xfrm>
+          <a:prstGeom prst="rect">
+            <a:avLst/>
+          </a:prstGeom>
+          <a:noFill/>
+          <a:ln/>
+        </p:spPr>
+        <p:txBody>
+          <a:bodyPr wrap="square" lIns="0" tIns="0" rIns="0" bIns="0" rtlCol="0" anchor="t"/>
+          <a:lstStyle/>
+          <a:p>
+            <a:pPr indent="0" marL="0">
+              <a:buNone/>
+            </a:pPr>
+            <a:r>
+              <a:rPr lang="en-US" sz="1100" i="1" dirty="0">
+                <a:solidFill>
+                  <a:schemeClr val="accent3"/>
+                </a:solidFill>
+              </a:rPr>
+              <a:t>* Our calculation from results/forecast_predictions.csv; not in the report.</a:t>
+            </a:r>
+            <a:endParaRPr lang="en-US" sz="1100" dirty="0"/>
           </a:p>
         </p:txBody>
       </p:sp>
@@ -10612,7 +11877,7 @@
                 <a:ea typeface="Cambria" pitchFamily="34" charset="-122"/>
                 <a:cs typeface="Cambria" pitchFamily="34" charset="-120"/>
               </a:rPr>
-              <a:t>Backup: can this be used to plan a Mars mission?</a:t>
+              <a:t>Backup: why did ML fail, and was the comparison fair?</a:t>
             </a:r>
             <a:endParaRPr lang="en-US" sz="2800" dirty="0"/>
           </a:p>
@@ -10687,7 +11952,7 @@
                   <a:schemeClr val="tx2"/>
                 </a:solidFill>
               </a:rPr>
-              <a:t>A Mars transit is about 180 days; the data stop at 119</a:t>
+              <a:t>Did the ML models get a fair chance?</a:t>
             </a:r>
             <a:endParaRPr lang="en-US" sz="1500" dirty="0"/>
           </a:p>
@@ -10705,7 +11970,7 @@
                   <a:schemeClr val="tx1"/>
                 </a:solidFill>
               </a:rPr>
-              <a:t>Only one study reaches 119 days</a:t>
+              <a:t>Tuned inside each training fold, grouped by study; TabPFN needs no tuning</a:t>
             </a:r>
             <a:endParaRPr lang="en-US" sz="1500" dirty="0"/>
           </a:p>
@@ -10723,7 +11988,7 @@
                   <a:schemeClr val="tx1"/>
                 </a:solidFill>
               </a:rPr>
-              <a:t>A 180-day estimate is planned from the duration curve only, with an uncertainty range, labelled as an assumption</a:t>
+              <a:t>All models saw the same inputs, folds and scoring</a:t>
             </a:r>
             <a:endParaRPr lang="en-US" sz="1500" dirty="0"/>
           </a:p>
@@ -10762,7 +12027,7 @@
                   <a:schemeClr val="tx2"/>
                 </a:solidFill>
               </a:rPr>
-              <a:t>Bed rest is not spaceflight</a:t>
+              <a:t>Why not add age, sex or countermeasure type?</a:t>
             </a:r>
             <a:endParaRPr lang="en-US" sz="1500" dirty="0"/>
           </a:p>
@@ -10780,46 +12045,7 @@
                   <a:schemeClr val="tx1"/>
                 </a:solidFill>
               </a:rPr>
-              <a:t>Only 14 spaceflight rows, 8 of them one back muscle: too few to test transfer</a:t>
-            </a:r>
-            <a:endParaRPr lang="en-US" sz="1500" dirty="0"/>
-          </a:p>
-        </p:txBody>
-      </p:sp>
-      <p:sp>
-        <p:nvSpPr>
-          <p:cNvPr id="6" name="Text 4"/>
-          <p:cNvSpPr txBox="1"/>
-          <p:nvPr/>
-        </p:nvSpPr>
-        <p:spPr>
-          <a:xfrm>
-            <a:off x="548640" y="3703320"/>
-            <a:ext cx="5394960" cy="2377440"/>
-          </a:xfrm>
-          <a:prstGeom prst="rect">
-            <a:avLst/>
-          </a:prstGeom>
-          <a:noFill/>
-          <a:ln/>
-        </p:spPr>
-        <p:txBody>
-          <a:bodyPr wrap="square" lIns="0" tIns="0" rIns="0" bIns="0" rtlCol="0" anchor="t"/>
-          <a:lstStyle/>
-          <a:p>
-            <a:pPr indent="0" marL="0">
-              <a:spcAft>
-                <a:spcPts val="400"/>
-              </a:spcAft>
-              <a:buNone/>
-            </a:pPr>
-            <a:r>
-              <a:rPr lang="en-US" sz="1500" b="1" dirty="0">
-                <a:solidFill>
-                  <a:schemeClr val="tx2"/>
-                </a:solidFill>
-              </a:rPr>
-              <a:t>Which countermeasure works? What about individuals?</a:t>
+              <a:t>32 studies leave room for about 3 study-level inputs (about 10 studies per input)</a:t>
             </a:r>
             <a:endParaRPr lang="en-US" sz="1500" dirty="0"/>
           </a:p>
@@ -10837,7 +12063,46 @@
                   <a:schemeClr val="tx1"/>
                 </a:solidFill>
               </a:rPr>
-              <a:t>Countermeasure groups lose 3.7 pp less (95% CI 1.5 to 5.9), all types pooled</a:t>
+              <a:t>Age and sex are fixed within a study (347 of 425 rows men-only), so they act as a study label; 126 countermeasure rows spread over 9 types</a:t>
+            </a:r>
+            <a:endParaRPr lang="en-US" sz="1500" dirty="0"/>
+          </a:p>
+        </p:txBody>
+      </p:sp>
+      <p:sp>
+        <p:nvSpPr>
+          <p:cNvPr id="6" name="Text 4"/>
+          <p:cNvSpPr txBox="1"/>
+          <p:nvPr/>
+        </p:nvSpPr>
+        <p:spPr>
+          <a:xfrm>
+            <a:off x="548640" y="3703320"/>
+            <a:ext cx="5394960" cy="2377440"/>
+          </a:xfrm>
+          <a:prstGeom prst="rect">
+            <a:avLst/>
+          </a:prstGeom>
+          <a:noFill/>
+          <a:ln/>
+        </p:spPr>
+        <p:txBody>
+          <a:bodyPr wrap="square" lIns="0" tIns="0" rIns="0" bIns="0" rtlCol="0" anchor="t"/>
+          <a:lstStyle/>
+          <a:p>
+            <a:pPr indent="0" marL="0">
+              <a:spcAft>
+                <a:spcPts val="400"/>
+              </a:spcAft>
+              <a:buNone/>
+            </a:pPr>
+            <a:r>
+              <a:rPr lang="en-US" sz="1500" b="1" dirty="0">
+                <a:solidFill>
+                  <a:schemeClr val="tx2"/>
+                </a:solidFill>
+              </a:rPr>
+              <a:t>Is the duration curve a straw man?</a:t>
             </a:r>
             <a:endParaRPr lang="en-US" sz="1500" dirty="0"/>
           </a:p>
@@ -10855,46 +12120,7 @@
                   <a:schemeClr val="tx1"/>
                 </a:solidFill>
               </a:rPr>
-              <a:t>Every row is a group average; nothing about individual risk</a:t>
-            </a:r>
-            <a:endParaRPr lang="en-US" sz="1500" dirty="0"/>
-          </a:p>
-        </p:txBody>
-      </p:sp>
-      <p:sp>
-        <p:nvSpPr>
-          <p:cNvPr id="7" name="Text 5"/>
-          <p:cNvSpPr txBox="1"/>
-          <p:nvPr/>
-        </p:nvSpPr>
-        <p:spPr>
-          <a:xfrm>
-            <a:off x="6217920" y="3703320"/>
-            <a:ext cx="5394960" cy="2377440"/>
-          </a:xfrm>
-          <a:prstGeom prst="rect">
-            <a:avLst/>
-          </a:prstGeom>
-          <a:noFill/>
-          <a:ln/>
-        </p:spPr>
-        <p:txBody>
-          <a:bodyPr wrap="square" lIns="0" tIns="0" rIns="0" bIns="0" rtlCol="0" anchor="t"/>
-          <a:lstStyle/>
-          <a:p>
-            <a:pPr indent="0" marL="0">
-              <a:spcAft>
-                <a:spcPts val="400"/>
-              </a:spcAft>
-              <a:buNone/>
-            </a:pPr>
-            <a:r>
-              <a:rPr lang="en-US" sz="1500" b="1" dirty="0">
-                <a:solidFill>
-                  <a:schemeClr val="tx2"/>
-                </a:solidFill>
-              </a:rPr>
-              <a:t>Can anyone reproduce an LLM result?</a:t>
+              <a:t>Ridge regression uses days, muscle and every other input: 3.28 vs 3.16 pp</a:t>
             </a:r>
             <a:endParaRPr lang="en-US" sz="1500" dirty="0"/>
           </a:p>
@@ -10912,7 +12138,46 @@
                   <a:schemeClr val="tx1"/>
                 </a:solidFill>
               </a:rPr>
-              <a:t>Fixed model version; all 430 answers saved, so every number rebuilds without the model</a:t>
+              <a:t>Knowing the muscle raises R² but not the error on a new study</a:t>
+            </a:r>
+            <a:endParaRPr lang="en-US" sz="1500" dirty="0"/>
+          </a:p>
+        </p:txBody>
+      </p:sp>
+      <p:sp>
+        <p:nvSpPr>
+          <p:cNvPr id="7" name="Text 5"/>
+          <p:cNvSpPr txBox="1"/>
+          <p:nvPr/>
+        </p:nvSpPr>
+        <p:spPr>
+          <a:xfrm>
+            <a:off x="6217920" y="3703320"/>
+            <a:ext cx="5394960" cy="2377440"/>
+          </a:xfrm>
+          <a:prstGeom prst="rect">
+            <a:avLst/>
+          </a:prstGeom>
+          <a:noFill/>
+          <a:ln/>
+        </p:spPr>
+        <p:txBody>
+          <a:bodyPr wrap="square" lIns="0" tIns="0" rIns="0" bIns="0" rtlCol="0" anchor="t"/>
+          <a:lstStyle/>
+          <a:p>
+            <a:pPr indent="0" marL="0">
+              <a:spcAft>
+                <a:spcPts val="400"/>
+              </a:spcAft>
+              <a:buNone/>
+            </a:pPr>
+            <a:r>
+              <a:rPr lang="en-US" sz="1500" b="1" dirty="0">
+                <a:solidFill>
+                  <a:schemeClr val="tx2"/>
+                </a:solidFill>
+              </a:rPr>
+              <a:t>Would a nearest-neighbour method match the LLM?</a:t>
             </a:r>
             <a:endParaRPr lang="en-US" sz="1500" dirty="0"/>
           </a:p>
@@ -10930,7 +12195,7 @@
                   <a:schemeClr val="tx1"/>
                 </a:solidFill>
               </a:rPr>
-              <a:t>Identical requests differ by 0.17 pp on average</a:t>
+              <a:t>Not tested. If the gain comes from picking similar rows, this is the obvious next control</a:t>
             </a:r>
             <a:endParaRPr lang="en-US" sz="1500" dirty="0"/>
           </a:p>
@@ -10976,6 +12241,435 @@
             <a:fld id="{F7021451-1387-4CA6-816F-3879F97B5CBC}" type="slidenum">
               <a:rPr b="0" lang="en-US"/>
               <a:t>18</a:t>
+            </a:fld>
+            <a:endParaRPr lang="en-US"/>
+          </a:p>
+        </p:txBody>
+      </p:sp>
+    </p:spTree>
+  </p:cSld>
+  <p:clrMapOvr>
+    <a:masterClrMapping/>
+  </p:clrMapOvr>
+</p:sld>
+</file>
+
+<file path=ppt/slides/slide19.xml><?xml version="1.0" encoding="utf-8"?>
+<p:sld xmlns:a="http://schemas.openxmlformats.org/drawingml/2006/main" xmlns:r="http://schemas.openxmlformats.org/officeDocument/2006/relationships" xmlns:p="http://schemas.openxmlformats.org/presentationml/2006/main">
+  <p:cSld name="Slide 19">
+    <p:spTree>
+      <p:nvGrpSpPr>
+        <p:cNvPr id="1" name=""/>
+        <p:cNvGrpSpPr/>
+        <p:nvPr/>
+      </p:nvGrpSpPr>
+      <p:grpSpPr>
+        <a:xfrm>
+          <a:off x="0" y="0"/>
+          <a:ext cx="0" cy="0"/>
+          <a:chOff x="0" y="0"/>
+          <a:chExt cx="0" cy="0"/>
+        </a:xfrm>
+      </p:grpSpPr>
+      <p:sp>
+        <p:nvSpPr>
+          <p:cNvPr id="2" name="Text 0"/>
+          <p:cNvSpPr/>
+          <p:nvPr>
+            <p:ph idx="100" type="title" hasCustomPrompt="1"/>
+          </p:nvPr>
+        </p:nvSpPr>
+        <p:spPr>
+          <a:xfrm>
+            <a:off x="548640" y="320040"/>
+            <a:ext cx="11064240" cy="731520"/>
+          </a:xfrm>
+          <a:prstGeom prst="rect">
+            <a:avLst/>
+          </a:prstGeom>
+          <a:noFill/>
+          <a:ln/>
+        </p:spPr>
+        <p:txBody>
+          <a:bodyPr wrap="square" lIns="0" tIns="0" rIns="0" bIns="0" rtlCol="0" anchor="ctr"/>
+          <a:lstStyle/>
+          <a:p>
+            <a:pPr algn="l" indent="0" marL="0">
+              <a:buNone/>
+            </a:pPr>
+            <a:r>
+              <a:rPr lang="en-US" sz="2800" b="1" dirty="0">
+                <a:solidFill>
+                  <a:schemeClr val="tx2"/>
+                </a:solidFill>
+                <a:latin typeface="Cambria" pitchFamily="34" charset="0"/>
+                <a:ea typeface="Cambria" pitchFamily="34" charset="-122"/>
+                <a:cs typeface="Cambria" pitchFamily="34" charset="-120"/>
+              </a:rPr>
+              <a:t>Backup: can this be used to plan a Mars mission?</a:t>
+            </a:r>
+            <a:endParaRPr lang="en-US" sz="2800" dirty="0"/>
+          </a:p>
+        </p:txBody>
+      </p:sp>
+      <p:sp>
+        <p:nvSpPr>
+          <p:cNvPr id="3" name="Text 1"/>
+          <p:cNvSpPr txBox="1"/>
+          <p:nvPr/>
+        </p:nvSpPr>
+        <p:spPr>
+          <a:xfrm>
+            <a:off x="9784080" y="6355080"/>
+            <a:ext cx="1188720" cy="274320"/>
+          </a:xfrm>
+          <a:prstGeom prst="rect">
+            <a:avLst/>
+          </a:prstGeom>
+          <a:noFill/>
+          <a:ln/>
+        </p:spPr>
+        <p:txBody>
+          <a:bodyPr wrap="square" lIns="0" tIns="0" rIns="0" bIns="0" rtlCol="0" anchor="ctr"/>
+          <a:lstStyle/>
+          <a:p>
+            <a:pPr algn="r" indent="0" marL="0">
+              <a:buNone/>
+            </a:pPr>
+            <a:r>
+              <a:rPr lang="en-US" sz="1000" b="1" dirty="0">
+                <a:solidFill>
+                  <a:schemeClr val="accent3"/>
+                </a:solidFill>
+              </a:rPr>
+              <a:t>BACKUP</a:t>
+            </a:r>
+            <a:endParaRPr lang="en-US" sz="1000" dirty="0"/>
+          </a:p>
+        </p:txBody>
+      </p:sp>
+      <p:sp>
+        <p:nvSpPr>
+          <p:cNvPr id="4" name="Text 2"/>
+          <p:cNvSpPr txBox="1"/>
+          <p:nvPr/>
+        </p:nvSpPr>
+        <p:spPr>
+          <a:xfrm>
+            <a:off x="548640" y="1188720"/>
+            <a:ext cx="5394960" cy="2377440"/>
+          </a:xfrm>
+          <a:prstGeom prst="rect">
+            <a:avLst/>
+          </a:prstGeom>
+          <a:noFill/>
+          <a:ln/>
+        </p:spPr>
+        <p:txBody>
+          <a:bodyPr wrap="square" lIns="0" tIns="0" rIns="0" bIns="0" rtlCol="0" anchor="t"/>
+          <a:lstStyle/>
+          <a:p>
+            <a:pPr indent="0" marL="0">
+              <a:spcAft>
+                <a:spcPts val="400"/>
+              </a:spcAft>
+              <a:buNone/>
+            </a:pPr>
+            <a:r>
+              <a:rPr lang="en-US" sz="1500" b="1" dirty="0">
+                <a:solidFill>
+                  <a:schemeClr val="tx2"/>
+                </a:solidFill>
+              </a:rPr>
+              <a:t>A Mars transit is about 180 days; the data stop at 119</a:t>
+            </a:r>
+            <a:endParaRPr lang="en-US" sz="1500" dirty="0"/>
+          </a:p>
+          <a:p>
+            <a:pPr marL="342900" indent="-342900">
+              <a:spcAft>
+                <a:spcPts val="400"/>
+              </a:spcAft>
+              <a:buSzPct val="100000"/>
+              <a:buChar char="•"/>
+            </a:pPr>
+            <a:r>
+              <a:rPr lang="en-US" sz="1400" dirty="0">
+                <a:solidFill>
+                  <a:schemeClr val="tx1"/>
+                </a:solidFill>
+              </a:rPr>
+              <a:t>Only one study reaches 119 days</a:t>
+            </a:r>
+            <a:endParaRPr lang="en-US" sz="1500" dirty="0"/>
+          </a:p>
+          <a:p>
+            <a:pPr marL="342900" indent="-342900">
+              <a:spcAft>
+                <a:spcPts val="400"/>
+              </a:spcAft>
+              <a:buSzPct val="100000"/>
+              <a:buChar char="•"/>
+            </a:pPr>
+            <a:r>
+              <a:rPr lang="en-US" sz="1400" dirty="0">
+                <a:solidFill>
+                  <a:schemeClr val="tx1"/>
+                </a:solidFill>
+              </a:rPr>
+              <a:t>A 180-day estimate is planned from the duration curve only, with an uncertainty range, labelled as an assumption</a:t>
+            </a:r>
+            <a:endParaRPr lang="en-US" sz="1500" dirty="0"/>
+          </a:p>
+        </p:txBody>
+      </p:sp>
+      <p:sp>
+        <p:nvSpPr>
+          <p:cNvPr id="5" name="Text 3"/>
+          <p:cNvSpPr txBox="1"/>
+          <p:nvPr/>
+        </p:nvSpPr>
+        <p:spPr>
+          <a:xfrm>
+            <a:off x="6217920" y="1188720"/>
+            <a:ext cx="5394960" cy="2377440"/>
+          </a:xfrm>
+          <a:prstGeom prst="rect">
+            <a:avLst/>
+          </a:prstGeom>
+          <a:noFill/>
+          <a:ln/>
+        </p:spPr>
+        <p:txBody>
+          <a:bodyPr wrap="square" lIns="0" tIns="0" rIns="0" bIns="0" rtlCol="0" anchor="t"/>
+          <a:lstStyle/>
+          <a:p>
+            <a:pPr indent="0" marL="0">
+              <a:spcAft>
+                <a:spcPts val="400"/>
+              </a:spcAft>
+              <a:buNone/>
+            </a:pPr>
+            <a:r>
+              <a:rPr lang="en-US" sz="1500" b="1" dirty="0">
+                <a:solidFill>
+                  <a:schemeClr val="tx2"/>
+                </a:solidFill>
+              </a:rPr>
+              <a:t>Bed rest is not spaceflight</a:t>
+            </a:r>
+            <a:endParaRPr lang="en-US" sz="1500" dirty="0"/>
+          </a:p>
+          <a:p>
+            <a:pPr marL="342900" indent="-342900">
+              <a:spcAft>
+                <a:spcPts val="400"/>
+              </a:spcAft>
+              <a:buSzPct val="100000"/>
+              <a:buChar char="•"/>
+            </a:pPr>
+            <a:r>
+              <a:rPr lang="en-US" sz="1400" dirty="0">
+                <a:solidFill>
+                  <a:schemeClr val="tx1"/>
+                </a:solidFill>
+              </a:rPr>
+              <a:t>Only 14 spaceflight rows, 8 of them one back muscle: too few to test transfer</a:t>
+            </a:r>
+            <a:endParaRPr lang="en-US" sz="1500" dirty="0"/>
+          </a:p>
+        </p:txBody>
+      </p:sp>
+      <p:sp>
+        <p:nvSpPr>
+          <p:cNvPr id="6" name="Text 4"/>
+          <p:cNvSpPr txBox="1"/>
+          <p:nvPr/>
+        </p:nvSpPr>
+        <p:spPr>
+          <a:xfrm>
+            <a:off x="548640" y="3703320"/>
+            <a:ext cx="5394960" cy="2377440"/>
+          </a:xfrm>
+          <a:prstGeom prst="rect">
+            <a:avLst/>
+          </a:prstGeom>
+          <a:noFill/>
+          <a:ln/>
+        </p:spPr>
+        <p:txBody>
+          <a:bodyPr wrap="square" lIns="0" tIns="0" rIns="0" bIns="0" rtlCol="0" anchor="t"/>
+          <a:lstStyle/>
+          <a:p>
+            <a:pPr indent="0" marL="0">
+              <a:spcAft>
+                <a:spcPts val="400"/>
+              </a:spcAft>
+              <a:buNone/>
+            </a:pPr>
+            <a:r>
+              <a:rPr lang="en-US" sz="1500" b="1" dirty="0">
+                <a:solidFill>
+                  <a:schemeClr val="tx2"/>
+                </a:solidFill>
+              </a:rPr>
+              <a:t>Which countermeasure works? What about individuals?</a:t>
+            </a:r>
+            <a:endParaRPr lang="en-US" sz="1500" dirty="0"/>
+          </a:p>
+          <a:p>
+            <a:pPr marL="342900" indent="-342900">
+              <a:spcAft>
+                <a:spcPts val="400"/>
+              </a:spcAft>
+              <a:buSzPct val="100000"/>
+              <a:buChar char="•"/>
+            </a:pPr>
+            <a:r>
+              <a:rPr lang="en-US" sz="1400" dirty="0">
+                <a:solidFill>
+                  <a:schemeClr val="tx1"/>
+                </a:solidFill>
+              </a:rPr>
+              <a:t>Countermeasure groups lose 3.7 pp less (95% CI 1.5 to 5.9), all types pooled</a:t>
+            </a:r>
+            <a:endParaRPr lang="en-US" sz="1500" dirty="0"/>
+          </a:p>
+          <a:p>
+            <a:pPr marL="342900" indent="-342900">
+              <a:spcAft>
+                <a:spcPts val="400"/>
+              </a:spcAft>
+              <a:buSzPct val="100000"/>
+              <a:buChar char="•"/>
+            </a:pPr>
+            <a:r>
+              <a:rPr lang="en-US" sz="1400" dirty="0">
+                <a:solidFill>
+                  <a:schemeClr val="tx1"/>
+                </a:solidFill>
+              </a:rPr>
+              <a:t>Every row is a group average; nothing about individual risk</a:t>
+            </a:r>
+            <a:endParaRPr lang="en-US" sz="1500" dirty="0"/>
+          </a:p>
+        </p:txBody>
+      </p:sp>
+      <p:sp>
+        <p:nvSpPr>
+          <p:cNvPr id="7" name="Text 5"/>
+          <p:cNvSpPr txBox="1"/>
+          <p:nvPr/>
+        </p:nvSpPr>
+        <p:spPr>
+          <a:xfrm>
+            <a:off x="6217920" y="3703320"/>
+            <a:ext cx="5394960" cy="2377440"/>
+          </a:xfrm>
+          <a:prstGeom prst="rect">
+            <a:avLst/>
+          </a:prstGeom>
+          <a:noFill/>
+          <a:ln/>
+        </p:spPr>
+        <p:txBody>
+          <a:bodyPr wrap="square" lIns="0" tIns="0" rIns="0" bIns="0" rtlCol="0" anchor="t"/>
+          <a:lstStyle/>
+          <a:p>
+            <a:pPr indent="0" marL="0">
+              <a:spcAft>
+                <a:spcPts val="400"/>
+              </a:spcAft>
+              <a:buNone/>
+            </a:pPr>
+            <a:r>
+              <a:rPr lang="en-US" sz="1500" b="1" dirty="0">
+                <a:solidFill>
+                  <a:schemeClr val="tx2"/>
+                </a:solidFill>
+              </a:rPr>
+              <a:t>Can anyone reproduce an LLM result?</a:t>
+            </a:r>
+            <a:endParaRPr lang="en-US" sz="1500" dirty="0"/>
+          </a:p>
+          <a:p>
+            <a:pPr marL="342900" indent="-342900">
+              <a:spcAft>
+                <a:spcPts val="400"/>
+              </a:spcAft>
+              <a:buSzPct val="100000"/>
+              <a:buChar char="•"/>
+            </a:pPr>
+            <a:r>
+              <a:rPr lang="en-US" sz="1400" dirty="0">
+                <a:solidFill>
+                  <a:schemeClr val="tx1"/>
+                </a:solidFill>
+              </a:rPr>
+              <a:t>Fixed model version; all 430 answers saved, so every number rebuilds without the model</a:t>
+            </a:r>
+            <a:endParaRPr lang="en-US" sz="1500" dirty="0"/>
+          </a:p>
+          <a:p>
+            <a:pPr marL="342900" indent="-342900">
+              <a:spcAft>
+                <a:spcPts val="400"/>
+              </a:spcAft>
+              <a:buSzPct val="100000"/>
+              <a:buChar char="•"/>
+            </a:pPr>
+            <a:r>
+              <a:rPr lang="en-US" sz="1400" dirty="0">
+                <a:solidFill>
+                  <a:schemeClr val="tx1"/>
+                </a:solidFill>
+              </a:rPr>
+              <a:t>Identical requests differ by 0.17 pp on average</a:t>
+            </a:r>
+            <a:endParaRPr lang="en-US" sz="1500" dirty="0"/>
+          </a:p>
+        </p:txBody>
+      </p:sp>
+      <p:sp>
+        <p:nvSpPr>
+          <p:cNvPr id="25" name="Slide Number Placeholder 0"/>
+          <p:cNvSpPr>
+            <a:spLocks noGrp="1"/>
+          </p:cNvSpPr>
+          <p:nvPr>
+            <p:ph type="sldNum" sz="quarter" idx="4294967295"/>
+          </p:nvPr>
+        </p:nvSpPr>
+        <p:spPr>
+          <a:xfrm>
+            <a:off x="11155680" y="6355080"/>
+            <a:ext cx="457200" cy="274320"/>
+          </a:xfrm>
+          <a:prstGeom prst="rect">
+            <a:avLst/>
+          </a:prstGeom>
+          <a:extLst>
+            <a:ext uri="{C572A759-6A51-4108-AA02-DFA0A04FC94B}">
+              <ma14:wrappingTextBoxFlag xmlns:ma14="http://schemas.microsoft.com/office/mac/drawingml/2011/main" val="0"/>
+            </a:ext>
+          </a:extLst>
+        </p:spPr>
+        <p:txBody>
+          <a:bodyPr/>
+          <a:lstStyle>
+            <a:lvl1pPr>
+              <a:defRPr sz="1000">
+                <a:solidFill>
+                  <a:schemeClr val="accent3"/>
+                </a:solidFill>
+              </a:defRPr>
+            </a:lvl1pPr>
+          </a:lstStyle>
+          <a:p>
+            <a:pPr algn="r"/>
+            <a:fld id="{F7021451-1387-4CA6-816F-3879F97B5CBC}" type="slidenum">
+              <a:rPr b="0" lang="en-US"/>
+              <a:t>19</a:t>
             </a:fld>
             <a:endParaRPr lang="en-US"/>
           </a:p>

</xml_diff>

<commit_message>
Deck review: campaign terminology in part 2, no-ai-slop fixes, review notes
Co-Authored-By: Claude Opus 5.5 (1M context) <noreply@anthropic.com>
Claude-Session: https://claude.ai/code/session_01JZtuYERhuCe7nB9VYHwcfv
</commit_message>
<xml_diff>
--- a/presentation/bed-rest-to-mars-talk.pptx
+++ b/presentation/bed-rest-to-mars-talk.pptx
@@ -125,13 +125,13 @@
   <p:extLst>
     <p:ext uri="{521415D9-36F7-43E2-AB2F-B90AF26B5E84}">
       <p14:sectionLst xmlns:p14="http://schemas.microsoft.com/office/powerpoint/2010/main">
-        <p14:section name="Opening" id="{526fc13d-fb17-54af-6762-04e56dc821a5}">
+        <p14:section name="Opening" id="{2421f92f-619b-92f5-eda2-a523eb5a0978}">
           <p14:sldIdLst>
             <p14:sldId id="256"/>
             <p14:sldId id="257"/>
           </p14:sldIdLst>
         </p14:section>
-        <p14:section name="Part 1" id="{ab1a16bf-aee8-34a1-d528-114e8daf14bc}">
+        <p14:section name="Part 1" id="{8b5df16e-cad6-40eb-a460-5563f7ffde41}">
           <p14:sldIdLst>
             <p14:sldId id="258"/>
             <p14:sldId id="259"/>
@@ -141,7 +141,7 @@
             <p14:sldId id="263"/>
           </p14:sldIdLst>
         </p14:section>
-        <p14:section name="Part 2" id="{80e50084-c193-696c-424d-953daa226d7c}">
+        <p14:section name="Part 2" id="{80c09609-ec9c-5623-5f66-e25b372f01dd}">
           <p14:sldIdLst>
             <p14:sldId id="264"/>
             <p14:sldId id="265"/>
@@ -151,7 +151,7 @@
             <p14:sldId id="269"/>
           </p14:sldIdLst>
         </p14:section>
-        <p14:section name="Backup" id="{ec5bc6d1-8e81-265e-d340-e4c48910919c}">
+        <p14:section name="Backup" id="{e58a330e-d7c4-5bb8-3747-ab00fa234367}">
           <p14:sldIdLst>
             <p14:sldId id="270"/>
             <p14:sldId id="271"/>
@@ -160,16 +160,16 @@
             <p14:sldId id="274"/>
           </p14:sldIdLst>
         </p14:section>
-        <p14:section name="Backup" id="{912689a9-1921-5b9c-58b9-183ee3f18a7f}">
+        <p14:section name="Backup" id="{9290a141-ea83-e486-bac4-c4fab1c91a3f}">
           <p14:sldIdLst/>
         </p14:section>
-        <p14:section name="Backup" id="{2c5a0850-2e59-4a66-4cf9-2751c7fdd720}">
+        <p14:section name="Backup" id="{f7f90a6a-9edf-a351-1ead-24258aa548cd}">
           <p14:sldIdLst/>
         </p14:section>
-        <p14:section name="Backup" id="{e7864e46-bb1e-dd55-ac52-5e90a1bc4447}">
+        <p14:section name="Backup" id="{62a5d96d-3bb4-632f-9113-ee8d282f8c7d}">
           <p14:sldIdLst/>
         </p14:section>
-        <p14:section name="Backup" id="{93952182-36e6-281f-0674-9c6c6d94c781}">
+        <p14:section name="Backup" id="{5615ba96-2802-64bb-7fca-d8636d793ae5}">
           <p14:sldIdLst/>
         </p14:section>
       </p14:sectionLst>
@@ -1376,7 +1376,7 @@
                 </a:solidFill>
                 <a:latin typeface="+mn-lt"/>
               </a:rPr>
-              <a:t>Error on held-out study (pp, lower = better)</a:t>
+              <a:t>Error on held-out campaign (pp, lower = better)</a:t>
             </a:r>
           </a:p>
         </c:rich>
@@ -2594,7 +2594,7 @@
                 </a:solidFill>
                 <a:latin typeface="+mn-lt"/>
               </a:rPr>
-              <a:t>Error on held-out study (pp, lower = better)</a:t>
+              <a:t>Error on held-out campaign (pp, lower = better)</a:t>
             </a:r>
           </a:p>
         </c:rich>
@@ -3795,8 +3795,8 @@
               <a:rPr lang="en-US" dirty="0"/>
               <a:t>About one minute.
 We compared four standard models, ridge regression, random forest, support vector regression and gradient boosting, tuned inside each training fold. We later added TabPFN, a neural network pretrained for small tables.
-On the left is the error on the held-out study. The duration curve scores 3.16 percentage points and the best model, the random forest, 3.18. None of them is lower than the curve.
-On the right, the ML models explain two to three times more variance. R squared is computed over all rows together, so it rewards getting the differences between muscles right, and the models do learn that the calf loses more than the hip. The error is averaged per study, and most of what remains is a shift that applies to a whole study, from its scanner, its volunteers or its protocol. None of our columns describes that, so 32 studies give the models nothing to learn it from. We had committed in advance to report this result whichever way it came out.</a:t>
+On the left is the error on the held-out campaign. The duration curve scores 3.16 percentage points and the best model, the random forest, 3.18. None of them is lower than the curve.
+On the right, the ML models explain two to three times more variance. R squared is computed over all rows together, so it rewards getting the differences between muscles right, and the models do learn that the calf loses more than the hip. The error is averaged per campaign, and most of what remains is a shift that applies to a whole campaign, from its scanner, its volunteers or its protocol. None of our columns describes that, so 32 campaigns give the models nothing to learn it from. We had committed in advance to report this result whichever way it came out.</a:t>
             </a:r>
             <a:endParaRPr lang="en-US" dirty="0"/>
           </a:p>
@@ -3886,9 +3886,9 @@
               <a:rPr lang="en-US" dirty="0"/>
               <a:t>About a minute and a half.
 The ML models only saw coded columns. Here we gave each measurement, written out in words, to a newly released language model built for probabilistic classification. You give it a described situation and a fixed list of options, and it returns a probability for each option.
-On the left is a real request from our cache. It describes the volunteers, the protocol, the muscle and how it was scanned, and the day. It also contains the duration curve fitted on the other 31 studies and as many rows from those studies as fit, most similar first. The question asks which of 19 ranges the change will fall in.
+On the left is a real request from our cache. It describes the volunteers, the protocol, the muscle and how it was scanned, and the day. It also contains the duration curve fitted on the other 31 campaigns and as many rows from those campaigns as fit, most similar first. The question asks which of 19 ranges the change will fall in.
 On the right is what came back for this row: a probability for each range. We never ask the model for a number. Our code turns the probabilities into a forecast, here minus 6.6 percent against an observed minus 9.4. We chose this row because its error is the model's median error.
-The request never contains the held-out study's own data or any name that could identify a paper, and the code checks that on every request. Every answer is cached, so all our numbers can be rebuilt without calling the model again.</a:t>
+The request never contains the held-out campaign's own data or any name that could identify a paper, and the code checks that on every request. Every answer is cached, so all our numbers can be rebuilt without calling the model again.</a:t>
             </a:r>
             <a:endParaRPr lang="en-US" dirty="0"/>
           </a:p>
@@ -3978,7 +3978,7 @@
               <a:rPr lang="en-US" dirty="0"/>
               <a:t>About forty-five seconds.
 These are the same two charts with the language model added at the bottom. Its error is 2.71 percentage points, the lowest of all models, and it explains the most variance, 0.43.
-Compared with the curve on the same rows and scored the same way, the error falls from 3.13 to 2.71, a gain of 0.42 points. The 95 percent confidence interval runs from 0.13 to 0.73, so even the most pessimistic estimate is an improvement. It is closer than the curve in 20 of the 32 studies. No other method has a gain whose interval stays above zero.
+Compared with the curve on the same rows and scored the same way, the error falls from 3.13 to 2.71, a gain of 0.42 points. The 95 percent confidence interval runs from 0.13 to 0.73, so even the most pessimistic estimate is an improvement. It is closer than the curve in 20 of the 32 campaigns. No other method has a gain whose interval stays above zero.
 If asked about a target: we had set a 15 percent improvement target. The error improvement is 13.3 percent and the probabilistic score improvement 17.7 percent.</a:t>
             </a:r>
             <a:endParaRPr lang="en-US" dirty="0"/>
@@ -4069,10 +4069,10 @@
               <a:rPr lang="en-US" dirty="0"/>
               <a:t>About a minute and a quarter.
 We wrote down each check and its pass rule, and committed them to the repository, before running it.
-Language models have read many papers, so the model might recognise a published study and recall its result. With every identifying detail removed, the gain is 0.30 points and its interval stays above zero. When we asked the model to choose the study's name from a list of options, it was right 19 percent of the time, where guessing gives 8 percent. If asked: of the three studies behind most of the gain, it named only one.
-When we shuffle the other studies' values, the gain turns into a loss of 1.25 points, and with no reference data the error rises to 5.85. The gain comes from reading those data.
+Language models have read many papers, so the model might recognise a published campaign and recall its result. With every identifying detail removed, the gain is 0.30 points and its interval stays above zero. When we asked the model to choose the campaign's name from a list of options, it was right 19 percent of the time, where guessing gives 8 percent. If asked: of the three campaigns behind most of the gain, it named only one.
+When we shuffle the other campaigns' values, the gain turns into a loss of 1.25 points, and with no reference data the error rises to 5.85. The gain comes from reading those data.
 Reordering the rows or shifting the range edges changes the error by 1 to 3 percent. Repeating 20 requests moves the forecasts by 0.17 points on average, well under the 0.42 gain.
-Three limitations: we added this model after the ML result; its 80 percent ranges contain the truth only 62 percent of the time, so we quote only point forecasts; and when given a study's own earlier scans, it does not use them.</a:t>
+Three limitations: we added this model after the ML result; its 80 percent ranges contain the truth only 62 percent of the time, so we quote only point forecasts; and when given a campaign's own earlier scans, it does not use them.</a:t>
             </a:r>
             <a:endParaRPr lang="en-US" dirty="0"/>
           </a:p>
@@ -4161,7 +4161,7 @@
             <a:r>
               <a:rPr lang="en-US" dirty="0"/>
               <a:t>About thirty seconds.
-With 32 independent studies, standard ML models and TabPFN do not beat a curve that only knows the number of days. A language model that reads each study's description and the other studies' data reduces the error from 3.13 to 2.71 points. The limitations and next steps are on the slide; the main one is that 32 studies is a small sample.
+With 32 independent campaigns, standard ML models and TabPFN do not beat a curve that only knows the number of days. A language model that reads each campaign's description and the other campaigns' data reduces the error from 3.13 to 2.71 points. The limitations and next steps are on the slide; the main one is that 32 campaigns is a small sample.
 Thank you.</a:t>
             </a:r>
             <a:endParaRPr lang="en-US" dirty="0"/>
@@ -4426,7 +4426,7 @@
           <a:p>
             <a:r>
               <a:rPr lang="en-US" dirty="0"/>
-              <a:t>Backup. The two starred numbers are our own calculation from results/forecast_predictions.csv, not in the report. Without the three studies that carry most of the gain, the interval touches zero; say so if asked.</a:t>
+              <a:t>Backup. The two starred numbers are our own calculation from results/forecast_predictions.csv, not in the report. Without the three campaigns that carry most of the gain, the interval touches zero; say so if asked.</a:t>
             </a:r>
             <a:endParaRPr lang="en-US" dirty="0"/>
           </a:p>
@@ -5326,8 +5326,8 @@
               <a:rPr lang="en-US" dirty="0"/>
               <a:t>About one minute.
 Each row in our data is one measurement: a group of volunteers, one muscle, one day of bed rest. The inputs are the day of the scan, the muscle family, whether the group did a countermeasure, how the muscle was imaged, and whether the value covers a group of muscles. The output is the percentage change in muscle size from before bed rest.
-We have 346 rows, but they come from 32 independent studies, because several papers report the same volunteers. So we test by holding out one whole study, training on the other 31 and predicting the held-out one, 32 times. The code checks that no study appears on both sides of a split.
-The score is the mean absolute error in percentage points, averaged so that each study counts once. Every model is compared with a duration-only curve, which uses the number of days and nothing else.</a:t>
+We have 346 rows, but they come from 32 independent campaigns, because several papers report the same volunteers. So we test by holding out one whole campaign, training on the other 31 and predicting the held-out one, 32 times. The code checks that no campaign appears on both sides of a split.
+The score is the mean absolute error in percentage points, averaged so that each campaign counts once. Every model is compared with a duration-only curve, which uses the number of days and nothing else.</a:t>
             </a:r>
             <a:endParaRPr lang="en-US" dirty="0"/>
           </a:p>
@@ -6573,7 +6573,7 @@
                   <a:schemeClr val="tx1"/>
                 </a:solidFill>
               </a:rPr>
-              <a:t>Their error on a new study is still no lower. Most of the error left is a shift that affects a whole study (its scanner, volunteers, protocol), and none of our inputs describe it.</a:t>
+              <a:t>Their error on a new campaign is still no lower. Most of the error left is a shift that affects a whole campaign (its scanner, volunteers, protocol), and none of our inputs describe it.</a:t>
             </a:r>
             <a:endParaRPr lang="en-US" sz="1400" dirty="0"/>
           </a:p>
@@ -7159,7 +7159,7 @@
                   <a:schemeClr val="tx1"/>
                 </a:solidFill>
               </a:rPr>
-              <a:t>duration curve fitted on the other 31 studies</a:t>
+              <a:t>duration curve fitted on the other 31 campaigns</a:t>
             </a:r>
             <a:endParaRPr lang="en-US" sz="1600" dirty="0"/>
           </a:p>
@@ -7196,7 +7196,7 @@
                   <a:schemeClr val="tx1"/>
                 </a:solidFill>
               </a:rPr>
-              <a:t>rows from the other 31 studies, most similar first, up to about 26,000 tokens</a:t>
+              <a:t>rows from the other 31 campaigns, most similar first, up to about 26,000 tokens</a:t>
             </a:r>
             <a:endParaRPr lang="en-US" sz="1600" dirty="0"/>
           </a:p>
@@ -7234,23 +7234,6 @@
                 </a:solidFill>
               </a:rPr>
               <a:t>Which range will the change fall in? 19 options: below −30%, 2-point ranges up to +4%, +4% and above</a:t>
-            </a:r>
-            <a:endParaRPr lang="en-US" sz="1600" dirty="0"/>
-          </a:p>
-          <a:p>
-            <a:pPr indent="0" marL="0">
-              <a:spcAft>
-                <a:spcPts val="100"/>
-              </a:spcAft>
-              <a:buNone/>
-            </a:pPr>
-            <a:r>
-              <a:rPr lang="en-US" sz="1100" i="1" dirty="0">
-                <a:solidFill>
-                  <a:schemeClr val="accent3"/>
-                </a:solidFill>
-              </a:rPr>
-              <a:t>Field names as sent; "campaign" means study.</a:t>
             </a:r>
             <a:endParaRPr lang="en-US" sz="1600" dirty="0"/>
           </a:p>
@@ -7494,7 +7477,7 @@
                   <a:schemeClr val="tx1"/>
                 </a:solidFill>
               </a:rPr>
-              <a:t>the held-out study's measurements, and any paper, author or study name. All 430 answers are saved, so every result can be rebuilt without calling the model again.</a:t>
+              <a:t>the held-out campaign's measurements, and any paper, author or campaign name. All 430 answers are saved, so every result can be rebuilt without calling the model again.</a:t>
             </a:r>
             <a:endParaRPr lang="en-US" sz="1300" dirty="0"/>
           </a:p>
@@ -7886,7 +7869,7 @@
                   <a:schemeClr val="tx1"/>
                 </a:solidFill>
               </a:rPr>
-              <a:t>Same measurements, scored the same way: error 2.71 vs 3.13 pp, so 0.42 pp smaller. Closer than the curve in 20 of 32 studies.</a:t>
+              <a:t>Same measurements, scored the same way: error 2.71 vs 3.13 pp, so 0.42 pp smaller. Closer than the curve in 20 of 32 campaigns.</a:t>
             </a:r>
             <a:endParaRPr lang="en-US" sz="1400" dirty="0"/>
           </a:p>
@@ -7904,7 +7887,7 @@
                   <a:schemeClr val="tx1"/>
                 </a:solidFill>
               </a:rPr>
-              <a:t>95% confidence interval of that difference: 0.13 to 0.73 pp. The whole range is above zero, so it is unlikely to be luck. No other model achieves this.</a:t>
+              <a:t>95% confidence interval of that difference: 0.13 to 0.73 pp. The whole range is above zero, so it is unlikely to be luck.</a:t>
             </a:r>
             <a:endParaRPr lang="en-US" sz="1400" dirty="0"/>
           </a:p>
@@ -8332,7 +8315,7 @@
                   <a:schemeClr val="tx2"/>
                 </a:solidFill>
               </a:rPr>
-              <a:t>Does it recognise published studies?</a:t>
+              <a:t>Does it recognise a known campaign?</a:t>
             </a:r>
             <a:endParaRPr lang="en-US" sz="1600" dirty="0"/>
           </a:p>
@@ -8350,7 +8333,7 @@
                   <a:schemeClr val="tx1"/>
                 </a:solidFill>
               </a:rPr>
-              <a:t>Everything identifying a study removed: gain still 0.30 pp, interval above zero</a:t>
+              <a:t>Everything identifying a campaign removed: gain still 0.30 pp, interval above zero</a:t>
             </a:r>
             <a:endParaRPr lang="en-US" sz="1600" dirty="0"/>
           </a:p>
@@ -8368,7 +8351,7 @@
                   <a:schemeClr val="tx1"/>
                 </a:solidFill>
               </a:rPr>
-              <a:t>Asked to choose the study's name from a list of options: right 19% of the time, where guessing gives 8%</a:t>
+              <a:t>Asked to choose the campaign's name from a list of options: right 19% of the time, where guessing gives 8%</a:t>
             </a:r>
             <a:endParaRPr lang="en-US" sz="1600" dirty="0"/>
           </a:p>
@@ -8385,7 +8368,7 @@
                   <a:schemeClr val="tx2"/>
                 </a:solidFill>
               </a:rPr>
-              <a:t>Does it use the other studies' data?</a:t>
+              <a:t>Does it use the other campaigns' data?</a:t>
             </a:r>
             <a:endParaRPr lang="en-US" sz="1600" dirty="0"/>
           </a:p>
@@ -8475,7 +8458,7 @@
                   <a:schemeClr val="tx1"/>
                 </a:solidFill>
               </a:rPr>
-              <a:t>Other studies' rows in a different order: error changes 3%</a:t>
+              <a:t>Other campaigns' rows in a different order: error changes 3%</a:t>
             </a:r>
             <a:endParaRPr lang="en-US" sz="1600" dirty="0"/>
           </a:p>
@@ -8582,7 +8565,7 @@
                   <a:schemeClr val="tx1"/>
                 </a:solidFill>
               </a:rPr>
-              <a:t>Added after the ML result was known, so it was not part of the original plan</a:t>
+              <a:t>Added after the ML result was known; not in the original plan</a:t>
             </a:r>
             <a:endParaRPr lang="en-US" sz="1600" dirty="0"/>
           </a:p>
@@ -8600,7 +8583,7 @@
                   <a:schemeClr val="tx1"/>
                 </a:solidFill>
               </a:rPr>
-              <a:t>Overconfident: when it is 80% sure the value is in a range, it is there only 62% of the time. We therefore report only its single-number forecast.</a:t>
+              <a:t>Overconfident ranges: its 80% ranges hold the measured value 62% of the time, so we report only its single-number forecast</a:t>
             </a:r>
             <a:endParaRPr lang="en-US" sz="1600" dirty="0"/>
           </a:p>
@@ -8618,7 +8601,7 @@
                   <a:schemeClr val="tx1"/>
                 </a:solidFill>
               </a:rPr>
-              <a:t>When also given a study's own earlier scans, it does not make use of them</a:t>
+              <a:t>Given a campaign's own earlier scans, it does not use them</a:t>
             </a:r>
             <a:endParaRPr lang="en-US" sz="1600" dirty="0"/>
           </a:p>
@@ -8995,7 +8978,7 @@
                   <a:schemeClr val="tx1"/>
                 </a:solidFill>
               </a:rPr>
-              <a:t>With 32 independent studies, no ML model forecasts better than a curve based on days alone (best 3.18 vs 3.16 pp error).</a:t>
+              <a:t>With 32 independent campaigns, no ML model forecasts better than a curve based on days alone (best 3.18 vs 3.16 pp error).</a:t>
             </a:r>
             <a:endParaRPr lang="en-US" sz="2000" dirty="0"/>
           </a:p>
@@ -9013,7 +8996,7 @@
                   <a:schemeClr val="tx1"/>
                 </a:solidFill>
               </a:rPr>
-              <a:t>An LLM that reads each study's description and the other studies' data cuts the error to 2.71 pp (curve 3.13 pp), and this holds under every check.</a:t>
+              <a:t>An LLM that reads each campaign's description and the other campaigns' data cuts the error to 2.71 pp (curve 3.13 pp); the gain remains when everything identifying a campaign is hidden.</a:t>
             </a:r>
             <a:endParaRPr lang="en-US" sz="2000" dirty="0"/>
           </a:p>
@@ -9070,7 +9053,7 @@
                   <a:schemeClr val="tx1"/>
                 </a:solidFill>
               </a:rPr>
-              <a:t>Only 32 independent studies</a:t>
+              <a:t>Only 32 independent campaigns</a:t>
             </a:r>
             <a:endParaRPr lang="en-US" sz="2000" dirty="0"/>
           </a:p>
@@ -9217,7 +9200,7 @@
                   <a:schemeClr val="tx1"/>
                 </a:solidFill>
               </a:rPr>
-              <a:t>Check results without the largest study, and with MRI scans only</a:t>
+              <a:t>Check results without the largest campaign, and with MRI scans only</a:t>
             </a:r>
             <a:endParaRPr lang="en-US" sz="2000" dirty="0"/>
           </a:p>
@@ -9457,7 +9440,7 @@
                   <a:schemeClr val="tx1"/>
                 </a:solidFill>
               </a:rPr>
-              <a:t>Searched PubMed, Scopus, Web of Science and NASA reports from 2013 on (5,731 records), plus 9 older studies</a:t>
+              <a:t>Four sources searched from 2013 on, plus 10 older or open-data studies (sources and queries on the next slide)</a:t>
             </a:r>
             <a:endParaRPr lang="en-US" sz="1500" dirty="0"/>
           </a:p>
@@ -9514,7 +9497,7 @@
                   <a:schemeClr val="tx2"/>
                 </a:solidFill>
               </a:rPr>
-              <a:t>One study dominates the data</a:t>
+              <a:t>One campaign dominates the data</a:t>
             </a:r>
             <a:endParaRPr lang="en-US" sz="1500" dirty="0"/>
           </a:p>
@@ -9550,7 +9533,7 @@
                   <a:schemeClr val="tx1"/>
                 </a:solidFill>
               </a:rPr>
-              <a:t>Scoring gives each study one vote; the re-run without it is still to do</a:t>
+              <a:t>Scoring gives each campaign one vote; the re-run without it is still to do</a:t>
             </a:r>
             <a:endParaRPr lang="en-US" sz="1500" dirty="0"/>
           </a:p>
@@ -11505,7 +11488,7 @@
                   <a:schemeClr val="tx1"/>
                 </a:solidFill>
               </a:rPr>
-              <a:t>Small: we report it as a finding, not the headline</a:t>
+              <a:t>Small; we present it as a secondary finding</a:t>
             </a:r>
             <a:endParaRPr lang="en-US" sz="1500" dirty="0"/>
           </a:p>
@@ -11544,7 +11527,7 @@
                   <a:schemeClr val="tx2"/>
                 </a:solidFill>
               </a:rPr>
-              <a:t>20 of 32 studies is close to a coin flip</a:t>
+              <a:t>20 of 32 campaigns is close to a coin flip</a:t>
             </a:r>
             <a:endParaRPr lang="en-US" sz="1500" dirty="0"/>
           </a:p>
@@ -11580,7 +11563,7 @@
                   <a:schemeClr val="tx1"/>
                 </a:solidFill>
               </a:rPr>
-              <a:t>The size of the wins matters: mean gain 0.42 pp, 95% CI 0.13 to 0.73</a:t>
+              <a:t>Using the size of each win: mean gain 0.42 pp, 95% CI 0.13 to 0.73</a:t>
             </a:r>
             <a:endParaRPr lang="en-US" sz="1500" dirty="0"/>
           </a:p>
@@ -11619,7 +11602,7 @@
                   <a:schemeClr val="tx2"/>
                 </a:solidFill>
               </a:rPr>
-              <a:t>Does it rest on a few studies?</a:t>
+              <a:t>Does it rest on a few campaigns?</a:t>
             </a:r>
             <a:endParaRPr lang="en-US" sz="1500" dirty="0"/>
           </a:p>
@@ -11637,7 +11620,7 @@
                   <a:schemeClr val="tx1"/>
                 </a:solidFill>
               </a:rPr>
-              <a:t>3 long MRI studies (NASA SPRINT, Berlin BBR2-2, MEDES LTBR) give 56% of the gain; without them 0.20 pp, CI −0.01 to 0.43*</a:t>
+              <a:t>3 long MRI campaigns (NASA SPRINT, Berlin BBR2-2, MEDES LTBR) give 56% of the gain; without them 0.20 pp, CI −0.01 to 0.43*</a:t>
             </a:r>
             <a:endParaRPr lang="en-US" sz="1500" dirty="0"/>
           </a:p>
@@ -11655,7 +11638,7 @@
                   <a:schemeClr val="tx1"/>
                 </a:solidFill>
               </a:rPr>
-              <a:t>Only SPRINT is recognised, and with study details removed the LLM still wins there (3.79 vs 5.92 pp)</a:t>
+              <a:t>Only SPRINT is recognised, and with campaign details removed the LLM still wins there (3.79 vs 5.92 pp)</a:t>
             </a:r>
             <a:endParaRPr lang="en-US" sz="1500" dirty="0"/>
           </a:p>
@@ -11712,7 +11695,7 @@
                   <a:schemeClr val="tx1"/>
                 </a:solidFill>
               </a:rPr>
-              <a:t>Training exposure cannot be ruled out by any test; hiding study details and the naming test are the strongest checks available</a:t>
+              <a:t>Training exposure cannot be ruled out by any test; hiding campaign details and the naming test are the strongest checks available</a:t>
             </a:r>
             <a:endParaRPr lang="en-US" sz="1500" dirty="0"/>
           </a:p>
@@ -11970,7 +11953,7 @@
                   <a:schemeClr val="tx1"/>
                 </a:solidFill>
               </a:rPr>
-              <a:t>Tuned inside each training fold, grouped by study; TabPFN needs no tuning</a:t>
+              <a:t>Tuned inside each training fold, grouped by campaign; TabPFN needs no tuning</a:t>
             </a:r>
             <a:endParaRPr lang="en-US" sz="1500" dirty="0"/>
           </a:p>
@@ -12045,7 +12028,7 @@
                   <a:schemeClr val="tx1"/>
                 </a:solidFill>
               </a:rPr>
-              <a:t>32 studies leave room for about 3 study-level inputs (about 10 studies per input)</a:t>
+              <a:t>32 campaigns leave room for about 3 campaign-level inputs (about 10 campaigns per input)</a:t>
             </a:r>
             <a:endParaRPr lang="en-US" sz="1500" dirty="0"/>
           </a:p>
@@ -12063,7 +12046,7 @@
                   <a:schemeClr val="tx1"/>
                 </a:solidFill>
               </a:rPr>
-              <a:t>Age and sex are fixed within a study (347 of 425 rows men-only), so they act as a study label; 126 countermeasure rows spread over 9 types</a:t>
+              <a:t>Age and sex are fixed within a campaign (347 of 425 rows men-only), so they act as a campaign label; 126 countermeasure rows spread over 9 types</a:t>
             </a:r>
             <a:endParaRPr lang="en-US" sz="1500" dirty="0"/>
           </a:p>
@@ -12138,7 +12121,7 @@
                   <a:schemeClr val="tx1"/>
                 </a:solidFill>
               </a:rPr>
-              <a:t>Knowing the muscle raises R² but not the error on a new study</a:t>
+              <a:t>Knowing the muscle raises R² but not the error on a new campaign</a:t>
             </a:r>
             <a:endParaRPr lang="en-US" sz="1500" dirty="0"/>
           </a:p>
@@ -12195,7 +12178,7 @@
                   <a:schemeClr val="tx1"/>
                 </a:solidFill>
               </a:rPr>
-              <a:t>Not tested. If the gain comes from picking similar rows, this is the obvious next control</a:t>
+              <a:t>Not tested. If the gain comes from picking similar rows, this is the next control to run</a:t>
             </a:r>
             <a:endParaRPr lang="en-US" sz="1500" dirty="0"/>
           </a:p>
@@ -12399,7 +12382,7 @@
                   <a:schemeClr val="tx1"/>
                 </a:solidFill>
               </a:rPr>
-              <a:t>Only one study reaches 119 days</a:t>
+              <a:t>Only one campaign reaches 119 days</a:t>
             </a:r>
             <a:endParaRPr lang="en-US" sz="1500" dirty="0"/>
           </a:p>
@@ -15054,7 +15037,7 @@
                   <a:schemeClr val="tx1"/>
                 </a:solidFill>
               </a:rPr>
-              <a:t>A Mars mission lasts years, not days: about 6 months of transit each way</a:t>
+              <a:t>A Mars mission lasts about 2.5 years, with about 6 months of transit each way</a:t>
             </a:r>
             <a:endParaRPr lang="en-US" sz="1700" dirty="0"/>
           </a:p>
@@ -25853,7 +25836,7 @@
                 <a:ea typeface="Cambria" pitchFamily="34" charset="-122"/>
                 <a:cs typeface="Cambria" pitchFamily="34" charset="-120"/>
               </a:rPr>
-              <a:t>Every model is tested on a study it has not seen</a:t>
+              <a:t>Every model is tested on a campaign it has not seen</a:t>
             </a:r>
             <a:endParaRPr lang="en-US" sz="2800" dirty="0"/>
           </a:p>
@@ -26310,7 +26293,7 @@
                   <a:schemeClr val="tx2"/>
                 </a:solidFill>
               </a:rPr>
-              <a:t>Testing: hold out one study, train on the rest, repeat 32 times</a:t>
+              <a:t>Testing: hold out one campaign, train on the rest, repeat 32 times</a:t>
             </a:r>
             <a:endParaRPr lang="en-US" sz="1500" dirty="0"/>
           </a:p>
@@ -26318,7 +26301,7 @@
       </p:sp>
       <p:sp>
         <p:nvSpPr>
-          <p:cNvPr id="20" name="Training study 1"/>
+          <p:cNvPr id="20" name="Training campaign 1"/>
           <p:cNvSpPr/>
           <p:nvPr/>
         </p:nvSpPr>
@@ -26343,7 +26326,7 @@
       </p:sp>
       <p:sp>
         <p:nvSpPr>
-          <p:cNvPr id="21" name="Training study 2"/>
+          <p:cNvPr id="21" name="Training campaign 2"/>
           <p:cNvSpPr/>
           <p:nvPr/>
         </p:nvSpPr>
@@ -26368,7 +26351,7 @@
       </p:sp>
       <p:sp>
         <p:nvSpPr>
-          <p:cNvPr id="22" name="Training study 3"/>
+          <p:cNvPr id="22" name="Training campaign 3"/>
           <p:cNvSpPr/>
           <p:nvPr/>
         </p:nvSpPr>
@@ -26393,7 +26376,7 @@
       </p:sp>
       <p:sp>
         <p:nvSpPr>
-          <p:cNvPr id="23" name="Training study 4"/>
+          <p:cNvPr id="23" name="Training campaign 4"/>
           <p:cNvSpPr/>
           <p:nvPr/>
         </p:nvSpPr>
@@ -26418,7 +26401,7 @@
       </p:sp>
       <p:sp>
         <p:nvSpPr>
-          <p:cNvPr id="24" name="Training study 5"/>
+          <p:cNvPr id="24" name="Training campaign 5"/>
           <p:cNvSpPr/>
           <p:nvPr/>
         </p:nvSpPr>
@@ -26443,7 +26426,7 @@
       </p:sp>
       <p:sp>
         <p:nvSpPr>
-          <p:cNvPr id="25" name="Training study 6"/>
+          <p:cNvPr id="25" name="Training campaign 6"/>
           <p:cNvSpPr/>
           <p:nvPr/>
         </p:nvSpPr>
@@ -26468,7 +26451,7 @@
       </p:sp>
       <p:sp>
         <p:nvSpPr>
-          <p:cNvPr id="26" name="Training study 7"/>
+          <p:cNvPr id="26" name="Training campaign 7"/>
           <p:cNvSpPr/>
           <p:nvPr/>
         </p:nvSpPr>
@@ -26493,7 +26476,7 @@
       </p:sp>
       <p:sp>
         <p:nvSpPr>
-          <p:cNvPr id="27" name="Training study 8"/>
+          <p:cNvPr id="27" name="Training campaign 8"/>
           <p:cNvSpPr/>
           <p:nvPr/>
         </p:nvSpPr>
@@ -26518,7 +26501,7 @@
       </p:sp>
       <p:sp>
         <p:nvSpPr>
-          <p:cNvPr id="28" name="Training study 9"/>
+          <p:cNvPr id="28" name="Training campaign 9"/>
           <p:cNvSpPr/>
           <p:nvPr/>
         </p:nvSpPr>
@@ -26543,7 +26526,7 @@
       </p:sp>
       <p:sp>
         <p:nvSpPr>
-          <p:cNvPr id="29" name="Training study 10"/>
+          <p:cNvPr id="29" name="Training campaign 10"/>
           <p:cNvSpPr/>
           <p:nvPr/>
         </p:nvSpPr>
@@ -26568,7 +26551,7 @@
       </p:sp>
       <p:sp>
         <p:nvSpPr>
-          <p:cNvPr id="30" name="Training study 11"/>
+          <p:cNvPr id="30" name="Training campaign 11"/>
           <p:cNvSpPr/>
           <p:nvPr/>
         </p:nvSpPr>
@@ -26593,7 +26576,7 @@
       </p:sp>
       <p:sp>
         <p:nvSpPr>
-          <p:cNvPr id="31" name="Training study 12"/>
+          <p:cNvPr id="31" name="Training campaign 12"/>
           <p:cNvSpPr/>
           <p:nvPr/>
         </p:nvSpPr>
@@ -26618,7 +26601,7 @@
       </p:sp>
       <p:sp>
         <p:nvSpPr>
-          <p:cNvPr id="32" name="Training study 13"/>
+          <p:cNvPr id="32" name="Training campaign 13"/>
           <p:cNvSpPr/>
           <p:nvPr/>
         </p:nvSpPr>
@@ -26643,7 +26626,7 @@
       </p:sp>
       <p:sp>
         <p:nvSpPr>
-          <p:cNvPr id="33" name="Test study"/>
+          <p:cNvPr id="33" name="Test campaign"/>
           <p:cNvSpPr/>
           <p:nvPr/>
         </p:nvSpPr>
@@ -26668,7 +26651,7 @@
       </p:sp>
       <p:sp>
         <p:nvSpPr>
-          <p:cNvPr id="34" name="Training study 15"/>
+          <p:cNvPr id="34" name="Training campaign 15"/>
           <p:cNvSpPr/>
           <p:nvPr/>
         </p:nvSpPr>
@@ -26693,7 +26676,7 @@
       </p:sp>
       <p:sp>
         <p:nvSpPr>
-          <p:cNvPr id="35" name="Training study 16"/>
+          <p:cNvPr id="35" name="Training campaign 16"/>
           <p:cNvSpPr/>
           <p:nvPr/>
         </p:nvSpPr>
@@ -26718,7 +26701,7 @@
       </p:sp>
       <p:sp>
         <p:nvSpPr>
-          <p:cNvPr id="36" name="Training study 17"/>
+          <p:cNvPr id="36" name="Training campaign 17"/>
           <p:cNvSpPr/>
           <p:nvPr/>
         </p:nvSpPr>
@@ -26743,7 +26726,7 @@
       </p:sp>
       <p:sp>
         <p:nvSpPr>
-          <p:cNvPr id="37" name="Training study 18"/>
+          <p:cNvPr id="37" name="Training campaign 18"/>
           <p:cNvSpPr/>
           <p:nvPr/>
         </p:nvSpPr>
@@ -26768,7 +26751,7 @@
       </p:sp>
       <p:sp>
         <p:nvSpPr>
-          <p:cNvPr id="38" name="Training study 19"/>
+          <p:cNvPr id="38" name="Training campaign 19"/>
           <p:cNvSpPr/>
           <p:nvPr/>
         </p:nvSpPr>
@@ -26793,7 +26776,7 @@
       </p:sp>
       <p:sp>
         <p:nvSpPr>
-          <p:cNvPr id="39" name="Training study 20"/>
+          <p:cNvPr id="39" name="Training campaign 20"/>
           <p:cNvSpPr/>
           <p:nvPr/>
         </p:nvSpPr>
@@ -26818,7 +26801,7 @@
       </p:sp>
       <p:sp>
         <p:nvSpPr>
-          <p:cNvPr id="40" name="Training study 21"/>
+          <p:cNvPr id="40" name="Training campaign 21"/>
           <p:cNvSpPr/>
           <p:nvPr/>
         </p:nvSpPr>
@@ -26843,7 +26826,7 @@
       </p:sp>
       <p:sp>
         <p:nvSpPr>
-          <p:cNvPr id="41" name="Training study 22"/>
+          <p:cNvPr id="41" name="Training campaign 22"/>
           <p:cNvSpPr/>
           <p:nvPr/>
         </p:nvSpPr>
@@ -26868,7 +26851,7 @@
       </p:sp>
       <p:sp>
         <p:nvSpPr>
-          <p:cNvPr id="42" name="Training study 23"/>
+          <p:cNvPr id="42" name="Training campaign 23"/>
           <p:cNvSpPr/>
           <p:nvPr/>
         </p:nvSpPr>
@@ -26893,7 +26876,7 @@
       </p:sp>
       <p:sp>
         <p:nvSpPr>
-          <p:cNvPr id="43" name="Training study 24"/>
+          <p:cNvPr id="43" name="Training campaign 24"/>
           <p:cNvSpPr/>
           <p:nvPr/>
         </p:nvSpPr>
@@ -26918,7 +26901,7 @@
       </p:sp>
       <p:sp>
         <p:nvSpPr>
-          <p:cNvPr id="44" name="Training study 25"/>
+          <p:cNvPr id="44" name="Training campaign 25"/>
           <p:cNvSpPr/>
           <p:nvPr/>
         </p:nvSpPr>
@@ -26943,7 +26926,7 @@
       </p:sp>
       <p:sp>
         <p:nvSpPr>
-          <p:cNvPr id="45" name="Training study 26"/>
+          <p:cNvPr id="45" name="Training campaign 26"/>
           <p:cNvSpPr/>
           <p:nvPr/>
         </p:nvSpPr>
@@ -26968,7 +26951,7 @@
       </p:sp>
       <p:sp>
         <p:nvSpPr>
-          <p:cNvPr id="46" name="Training study 27"/>
+          <p:cNvPr id="46" name="Training campaign 27"/>
           <p:cNvSpPr/>
           <p:nvPr/>
         </p:nvSpPr>
@@ -26993,7 +26976,7 @@
       </p:sp>
       <p:sp>
         <p:nvSpPr>
-          <p:cNvPr id="47" name="Training study 28"/>
+          <p:cNvPr id="47" name="Training campaign 28"/>
           <p:cNvSpPr/>
           <p:nvPr/>
         </p:nvSpPr>
@@ -27018,7 +27001,7 @@
       </p:sp>
       <p:sp>
         <p:nvSpPr>
-          <p:cNvPr id="48" name="Training study 29"/>
+          <p:cNvPr id="48" name="Training campaign 29"/>
           <p:cNvSpPr/>
           <p:nvPr/>
         </p:nvSpPr>
@@ -27043,7 +27026,7 @@
       </p:sp>
       <p:sp>
         <p:nvSpPr>
-          <p:cNvPr id="49" name="Training study 30"/>
+          <p:cNvPr id="49" name="Training campaign 30"/>
           <p:cNvSpPr/>
           <p:nvPr/>
         </p:nvSpPr>
@@ -27068,7 +27051,7 @@
       </p:sp>
       <p:sp>
         <p:nvSpPr>
-          <p:cNvPr id="50" name="Training study 31"/>
+          <p:cNvPr id="50" name="Training campaign 31"/>
           <p:cNvSpPr/>
           <p:nvPr/>
         </p:nvSpPr>
@@ -27093,7 +27076,7 @@
       </p:sp>
       <p:sp>
         <p:nvSpPr>
-          <p:cNvPr id="51" name="Training study 32"/>
+          <p:cNvPr id="51" name="Training campaign 32"/>
           <p:cNvSpPr/>
           <p:nvPr/>
         </p:nvSpPr>
@@ -27146,7 +27129,7 @@
                   <a:schemeClr val="tx1"/>
                 </a:solidFill>
               </a:rPr>
-              <a:t>Grey: 31 training studies.  </a:t>
+              <a:t>Grey: 31 training campaigns.  </a:t>
             </a:r>
             <a:pPr indent="0" marL="0">
               <a:buNone/>
@@ -27157,7 +27140,7 @@
                   <a:schemeClr val="accent1"/>
                 </a:solidFill>
               </a:rPr>
-              <a:t>Red: the held-out test study.</a:t>
+              <a:t>Red: the held-out test campaign.</a:t>
             </a:r>
             <a:pPr indent="0" marL="0">
               <a:buNone/>
@@ -27168,7 +27151,7 @@
                   <a:schemeClr val="tx1"/>
                 </a:solidFill>
               </a:rPr>
-              <a:t>  Each study is held out once.</a:t>
+              <a:t>  Each campaign is held out once.</a:t>
             </a:r>
             <a:endParaRPr lang="en-US" sz="1400" dirty="0"/>
           </a:p>
@@ -27208,7 +27191,7 @@
                   <a:schemeClr val="tx1"/>
                 </a:solidFill>
               </a:rPr>
-              <a:t>Why studies, not measurements: the 346 measurements come from only 32 independent studies, because several papers report the same volunteers.</a:t>
+              <a:t>Why campaigns, not measurements: the 346 rows used for modelling come from 32 of the 36 campaigns, and rows of one campaign share volunteers.</a:t>
             </a:r>
             <a:endParaRPr lang="en-US" sz="1400" dirty="0"/>
           </a:p>
@@ -27226,7 +27209,7 @@
                   <a:schemeClr val="tx1"/>
                 </a:solidFill>
               </a:rPr>
-              <a:t>Score: average error in percentage points (pp). Forecast −10%, measured −13%: error 3 pp. Each study counts once.</a:t>
+              <a:t>Score: average error in percentage points (pp), each campaign counted once. Forecast −10%, measured −13%: error 3 pp.</a:t>
             </a:r>
             <a:endParaRPr lang="en-US" sz="1400" dirty="0"/>
           </a:p>

</xml_diff>

<commit_message>
Remove repetition: no calf number on slide 3, new panel title, drop repeated rows on slide 7
Co-Authored-By: Claude Opus 5.5 (1M context) <noreply@anthropic.com>
Claude-Session: https://claude.ai/code/session_01JZtuYERhuCe7nB9VYHwcfv
</commit_message>
<xml_diff>
--- a/presentation/bed-rest-to-mars-talk.pptx
+++ b/presentation/bed-rest-to-mars-talk.pptx
@@ -125,13 +125,13 @@
   <p:extLst>
     <p:ext uri="{521415D9-36F7-43E2-AB2F-B90AF26B5E84}">
       <p14:sectionLst xmlns:p14="http://schemas.microsoft.com/office/powerpoint/2010/main">
-        <p14:section name="Opening" id="{2421f92f-619b-92f5-eda2-a523eb5a0978}">
+        <p14:section name="Opening" id="{41d6901e-8f4b-358a-5b05-a32ef120c988}">
           <p14:sldIdLst>
             <p14:sldId id="256"/>
             <p14:sldId id="257"/>
           </p14:sldIdLst>
         </p14:section>
-        <p14:section name="Part 1" id="{8b5df16e-cad6-40eb-a460-5563f7ffde41}">
+        <p14:section name="Part 1" id="{4130e22a-0581-ff77-c967-82a0149704db}">
           <p14:sldIdLst>
             <p14:sldId id="258"/>
             <p14:sldId id="259"/>
@@ -141,7 +141,7 @@
             <p14:sldId id="263"/>
           </p14:sldIdLst>
         </p14:section>
-        <p14:section name="Part 2" id="{80c09609-ec9c-5623-5f66-e25b372f01dd}">
+        <p14:section name="Part 2" id="{b9a037bd-d9ff-fa69-7f6c-372c6598aaf9}">
           <p14:sldIdLst>
             <p14:sldId id="264"/>
             <p14:sldId id="265"/>
@@ -151,7 +151,7 @@
             <p14:sldId id="269"/>
           </p14:sldIdLst>
         </p14:section>
-        <p14:section name="Backup" id="{e58a330e-d7c4-5bb8-3747-ab00fa234367}">
+        <p14:section name="Backup" id="{c5134959-8f8b-2614-c60c-f3be206704e5}">
           <p14:sldIdLst>
             <p14:sldId id="270"/>
             <p14:sldId id="271"/>
@@ -160,16 +160,16 @@
             <p14:sldId id="274"/>
           </p14:sldIdLst>
         </p14:section>
-        <p14:section name="Backup" id="{9290a141-ea83-e486-bac4-c4fab1c91a3f}">
+        <p14:section name="Backup" id="{3d644f97-554a-2b42-1414-28091eab21da}">
           <p14:sldIdLst/>
         </p14:section>
-        <p14:section name="Backup" id="{f7f90a6a-9edf-a351-1ead-24258aa548cd}">
+        <p14:section name="Backup" id="{55c9f080-b17d-4bed-599c-1010bdad61cd}">
           <p14:sldIdLst/>
         </p14:section>
-        <p14:section name="Backup" id="{62a5d96d-3bb4-632f-9113-ee8d282f8c7d}">
+        <p14:section name="Backup" id="{0a469fd9-ec07-7b2d-96d2-a248feac1a7d}">
           <p14:sldIdLst/>
         </p14:section>
-        <p14:section name="Backup" id="{5615ba96-2802-64bb-7fca-d8636d793ae5}">
+        <p14:section name="Backup" id="{43d29db5-1aa5-eabf-2834-9e4b9b2f0da8}">
           <p14:sldIdLst/>
         </p14:section>
       </p14:sectionLst>
@@ -4781,7 +4781,7 @@
               <a:t>Opening of part 1 (Niloufar), about forty-five seconds.
 Muscle atrophy, especially in the legs, is one of the main problems of long-duration spaceflight. Our question was whether the amount of atrophy can be predicted. To answer it, we built a dataset from the published literature and a machine-learning framework on top of it.
 Why it matters: a prediction lets crews and planners act early, match exercise and nutrition to the expected loss, focus monitoring on the muscles that lose most, protect strength and function, and plan long missions where exercise equipment is limited.
-On the right is the ground model we rely on: volunteers lie in bed tilted six degrees head-down for weeks to months. The circles show a calf cross-section drawn to scale: after 60 days of bed rest, control groups lose about 16 percent of calf muscle in our model.</a:t>
+On the right is the ground model we rely on: volunteers lie in bed tilted six degrees head-down for weeks to months. The circles show a calf cross-section before and after unloading; how much each muscle loses comes later, in the muscle section.</a:t>
             </a:r>
             <a:endParaRPr lang="en-US" dirty="0"/>
           </a:p>
@@ -14230,7 +14230,7 @@
                   <a:schemeClr val="tx2"/>
                 </a:solidFill>
               </a:rPr>
-              <a:t>Ground analogue: 6° head-down bed rest</a:t>
+              <a:t>Unloading shrinks leg muscles</a:t>
             </a:r>
             <a:endParaRPr lang="en-US" sz="1400" dirty="0"/>
           </a:p>
@@ -14550,7 +14550,7 @@
                   <a:schemeClr val="accent1"/>
                 </a:solidFill>
               </a:rPr>
-              <a:t>Day 60: −16%</a:t>
+              <a:t>After unloading</a:t>
             </a:r>
             <a:endParaRPr lang="en-US" sz="1300" dirty="0"/>
           </a:p>
@@ -14586,7 +14586,7 @@
                   <a:schemeClr val="accent3"/>
                 </a:solidFill>
               </a:rPr>
-              <a:t>Calf cross-section to scale; dashed line = size before. Model estimate for control groups (plantar flexors, −15.8% at day 60).</a:t>
+              <a:t>Schematic calf cross-section; dashed line = size before unloading.</a:t>
             </a:r>
             <a:endParaRPr lang="en-US" sz="1100" dirty="0"/>
           </a:p>
@@ -19397,294 +19397,6 @@
                     <a:solidFill>
                       <a:srgbClr val="1F3A5F"/>
                     </a:solidFill>
-                  </a:tcPr>
-                </a:tc>
-              </a:tr>
-              <a:tr h="457200">
-                <a:tc>
-                  <a:txBody>
-                    <a:bodyPr/>
-                    <a:lstStyle/>
-                    <a:p>
-                      <a:pPr algn="l" indent="0" marL="0">
-                        <a:buNone/>
-                      </a:pPr>
-                      <a:r>
-                        <a:rPr lang="en-US" sz="1300" dirty="0">
-                          <a:solidFill>
-                            <a:srgbClr val="1A1A1A"/>
-                          </a:solidFill>
-                          <a:latin typeface="Calibri" pitchFamily="34" charset="0"/>
-                          <a:ea typeface="Calibri" pitchFamily="34" charset="-122"/>
-                          <a:cs typeface="Calibri" pitchFamily="34" charset="-120"/>
-                        </a:rPr>
-                        <a:t>Observations (rows)</a:t>
-                      </a:r>
-                      <a:endParaRPr lang="en-US" sz="1300" dirty="0">
-                        <a:latin typeface="Calibri" charset="0"/>
-                        <a:ea typeface="Calibri" charset="0"/>
-                        <a:cs typeface="Calibri" charset="0"/>
-                      </a:endParaRPr>
-                    </a:p>
-                  </a:txBody>
-                  <a:tcPr marL="91440" marR="91440" marT="27432" marB="27432" anchor="ctr">
-                    <a:lnL w="0" cap="flat" cmpd="sng" algn="ctr">
-                      <a:noFill/>
-                    </a:lnL>
-                    <a:lnR w="0" cap="flat" cmpd="sng" algn="ctr">
-                      <a:noFill/>
-                    </a:lnR>
-                    <a:lnT w="0" cap="flat" cmpd="sng" algn="ctr">
-                      <a:noFill/>
-                    </a:lnT>
-                    <a:lnB w="9525" cap="flat" cmpd="sng" algn="ctr">
-                      <a:solidFill>
-                        <a:srgbClr val="E5E7EB"/>
-                      </a:solidFill>
-                      <a:prstDash val="solid"/>
-                      <a:round/>
-                      <a:headEnd type="none" w="med" len="med"/>
-                      <a:tailEnd type="none" w="med" len="med"/>
-                    </a:lnB>
-                  </a:tcPr>
-                </a:tc>
-                <a:tc>
-                  <a:txBody>
-                    <a:bodyPr/>
-                    <a:lstStyle/>
-                    <a:p>
-                      <a:pPr algn="r" indent="0" marL="0">
-                        <a:buNone/>
-                      </a:pPr>
-                      <a:r>
-                        <a:rPr lang="en-US" sz="1300" b="1" dirty="0">
-                          <a:solidFill>
-                            <a:srgbClr val="1A1A1A"/>
-                          </a:solidFill>
-                          <a:latin typeface="Calibri" pitchFamily="34" charset="0"/>
-                          <a:ea typeface="Calibri" pitchFamily="34" charset="-122"/>
-                          <a:cs typeface="Calibri" pitchFamily="34" charset="-120"/>
-                        </a:rPr>
-                        <a:t>742</a:t>
-                      </a:r>
-                      <a:endParaRPr lang="en-US" sz="1300" dirty="0">
-                        <a:latin typeface="Calibri" charset="0"/>
-                        <a:ea typeface="Calibri" charset="0"/>
-                        <a:cs typeface="Calibri" charset="0"/>
-                      </a:endParaRPr>
-                    </a:p>
-                  </a:txBody>
-                  <a:tcPr marL="91440" marR="91440" marT="27432" marB="27432" anchor="ctr">
-                    <a:lnL w="0" cap="flat" cmpd="sng" algn="ctr">
-                      <a:noFill/>
-                    </a:lnL>
-                    <a:lnR w="0" cap="flat" cmpd="sng" algn="ctr">
-                      <a:noFill/>
-                    </a:lnR>
-                    <a:lnT w="0" cap="flat" cmpd="sng" algn="ctr">
-                      <a:noFill/>
-                    </a:lnT>
-                    <a:lnB w="9525" cap="flat" cmpd="sng" algn="ctr">
-                      <a:solidFill>
-                        <a:srgbClr val="E5E7EB"/>
-                      </a:solidFill>
-                      <a:prstDash val="solid"/>
-                      <a:round/>
-                      <a:headEnd type="none" w="med" len="med"/>
-                      <a:tailEnd type="none" w="med" len="med"/>
-                    </a:lnB>
-                  </a:tcPr>
-                </a:tc>
-              </a:tr>
-              <a:tr h="457200">
-                <a:tc>
-                  <a:txBody>
-                    <a:bodyPr/>
-                    <a:lstStyle/>
-                    <a:p>
-                      <a:pPr algn="l" indent="0" marL="0">
-                        <a:buNone/>
-                      </a:pPr>
-                      <a:r>
-                        <a:rPr lang="en-US" sz="1300" dirty="0">
-                          <a:solidFill>
-                            <a:srgbClr val="1A1A1A"/>
-                          </a:solidFill>
-                          <a:latin typeface="Calibri" pitchFamily="34" charset="0"/>
-                          <a:ea typeface="Calibri" pitchFamily="34" charset="-122"/>
-                          <a:cs typeface="Calibri" pitchFamily="34" charset="-120"/>
-                        </a:rPr>
-                        <a:t>Studies</a:t>
-                      </a:r>
-                      <a:endParaRPr lang="en-US" sz="1300" dirty="0">
-                        <a:latin typeface="Calibri" charset="0"/>
-                        <a:ea typeface="Calibri" charset="0"/>
-                        <a:cs typeface="Calibri" charset="0"/>
-                      </a:endParaRPr>
-                    </a:p>
-                  </a:txBody>
-                  <a:tcPr marL="91440" marR="91440" marT="27432" marB="27432" anchor="ctr">
-                    <a:lnL w="0" cap="flat" cmpd="sng" algn="ctr">
-                      <a:noFill/>
-                    </a:lnL>
-                    <a:lnR w="0" cap="flat" cmpd="sng" algn="ctr">
-                      <a:noFill/>
-                    </a:lnR>
-                    <a:lnT w="0" cap="flat" cmpd="sng" algn="ctr">
-                      <a:noFill/>
-                    </a:lnT>
-                    <a:lnB w="9525" cap="flat" cmpd="sng" algn="ctr">
-                      <a:solidFill>
-                        <a:srgbClr val="E5E7EB"/>
-                      </a:solidFill>
-                      <a:prstDash val="solid"/>
-                      <a:round/>
-                      <a:headEnd type="none" w="med" len="med"/>
-                      <a:tailEnd type="none" w="med" len="med"/>
-                    </a:lnB>
-                  </a:tcPr>
-                </a:tc>
-                <a:tc>
-                  <a:txBody>
-                    <a:bodyPr/>
-                    <a:lstStyle/>
-                    <a:p>
-                      <a:pPr algn="r" indent="0" marL="0">
-                        <a:buNone/>
-                      </a:pPr>
-                      <a:r>
-                        <a:rPr lang="en-US" sz="1300" b="1" dirty="0">
-                          <a:solidFill>
-                            <a:srgbClr val="1A1A1A"/>
-                          </a:solidFill>
-                          <a:latin typeface="Calibri" pitchFamily="34" charset="0"/>
-                          <a:ea typeface="Calibri" pitchFamily="34" charset="-122"/>
-                          <a:cs typeface="Calibri" pitchFamily="34" charset="-120"/>
-                        </a:rPr>
-                        <a:t>52</a:t>
-                      </a:r>
-                      <a:endParaRPr lang="en-US" sz="1300" dirty="0">
-                        <a:latin typeface="Calibri" charset="0"/>
-                        <a:ea typeface="Calibri" charset="0"/>
-                        <a:cs typeface="Calibri" charset="0"/>
-                      </a:endParaRPr>
-                    </a:p>
-                  </a:txBody>
-                  <a:tcPr marL="91440" marR="91440" marT="27432" marB="27432" anchor="ctr">
-                    <a:lnL w="0" cap="flat" cmpd="sng" algn="ctr">
-                      <a:noFill/>
-                    </a:lnL>
-                    <a:lnR w="0" cap="flat" cmpd="sng" algn="ctr">
-                      <a:noFill/>
-                    </a:lnR>
-                    <a:lnT w="0" cap="flat" cmpd="sng" algn="ctr">
-                      <a:noFill/>
-                    </a:lnT>
-                    <a:lnB w="9525" cap="flat" cmpd="sng" algn="ctr">
-                      <a:solidFill>
-                        <a:srgbClr val="E5E7EB"/>
-                      </a:solidFill>
-                      <a:prstDash val="solid"/>
-                      <a:round/>
-                      <a:headEnd type="none" w="med" len="med"/>
-                      <a:tailEnd type="none" w="med" len="med"/>
-                    </a:lnB>
-                  </a:tcPr>
-                </a:tc>
-              </a:tr>
-              <a:tr h="457200">
-                <a:tc>
-                  <a:txBody>
-                    <a:bodyPr/>
-                    <a:lstStyle/>
-                    <a:p>
-                      <a:pPr algn="l" indent="0" marL="0">
-                        <a:buNone/>
-                      </a:pPr>
-                      <a:r>
-                        <a:rPr lang="en-US" sz="1300" dirty="0">
-                          <a:solidFill>
-                            <a:srgbClr val="1A1A1A"/>
-                          </a:solidFill>
-                          <a:latin typeface="Calibri" pitchFamily="34" charset="0"/>
-                          <a:ea typeface="Calibri" pitchFamily="34" charset="-122"/>
-                          <a:cs typeface="Calibri" pitchFamily="34" charset="-120"/>
-                        </a:rPr>
-                        <a:t>Independent campaigns</a:t>
-                      </a:r>
-                      <a:endParaRPr lang="en-US" sz="1300" dirty="0">
-                        <a:latin typeface="Calibri" charset="0"/>
-                        <a:ea typeface="Calibri" charset="0"/>
-                        <a:cs typeface="Calibri" charset="0"/>
-                      </a:endParaRPr>
-                    </a:p>
-                  </a:txBody>
-                  <a:tcPr marL="91440" marR="91440" marT="27432" marB="27432" anchor="ctr">
-                    <a:lnL w="0" cap="flat" cmpd="sng" algn="ctr">
-                      <a:noFill/>
-                    </a:lnL>
-                    <a:lnR w="0" cap="flat" cmpd="sng" algn="ctr">
-                      <a:noFill/>
-                    </a:lnR>
-                    <a:lnT w="0" cap="flat" cmpd="sng" algn="ctr">
-                      <a:noFill/>
-                    </a:lnT>
-                    <a:lnB w="9525" cap="flat" cmpd="sng" algn="ctr">
-                      <a:solidFill>
-                        <a:srgbClr val="E5E7EB"/>
-                      </a:solidFill>
-                      <a:prstDash val="solid"/>
-                      <a:round/>
-                      <a:headEnd type="none" w="med" len="med"/>
-                      <a:tailEnd type="none" w="med" len="med"/>
-                    </a:lnB>
-                  </a:tcPr>
-                </a:tc>
-                <a:tc>
-                  <a:txBody>
-                    <a:bodyPr/>
-                    <a:lstStyle/>
-                    <a:p>
-                      <a:pPr algn="r" indent="0" marL="0">
-                        <a:buNone/>
-                      </a:pPr>
-                      <a:r>
-                        <a:rPr lang="en-US" sz="1300" b="1" dirty="0">
-                          <a:solidFill>
-                            <a:srgbClr val="1A1A1A"/>
-                          </a:solidFill>
-                          <a:latin typeface="Calibri" pitchFamily="34" charset="0"/>
-                          <a:ea typeface="Calibri" pitchFamily="34" charset="-122"/>
-                          <a:cs typeface="Calibri" pitchFamily="34" charset="-120"/>
-                        </a:rPr>
-                        <a:t>36</a:t>
-                      </a:r>
-                      <a:endParaRPr lang="en-US" sz="1300" dirty="0">
-                        <a:latin typeface="Calibri" charset="0"/>
-                        <a:ea typeface="Calibri" charset="0"/>
-                        <a:cs typeface="Calibri" charset="0"/>
-                      </a:endParaRPr>
-                    </a:p>
-                  </a:txBody>
-                  <a:tcPr marL="91440" marR="91440" marT="27432" marB="27432" anchor="ctr">
-                    <a:lnL w="0" cap="flat" cmpd="sng" algn="ctr">
-                      <a:noFill/>
-                    </a:lnL>
-                    <a:lnR w="0" cap="flat" cmpd="sng" algn="ctr">
-                      <a:noFill/>
-                    </a:lnR>
-                    <a:lnT w="0" cap="flat" cmpd="sng" algn="ctr">
-                      <a:noFill/>
-                    </a:lnT>
-                    <a:lnB w="9525" cap="flat" cmpd="sng" algn="ctr">
-                      <a:solidFill>
-                        <a:srgbClr val="E5E7EB"/>
-                      </a:solidFill>
-                      <a:prstDash val="solid"/>
-                      <a:round/>
-                      <a:headEnd type="none" w="med" len="med"/>
-                      <a:tailEnd type="none" w="med" len="med"/>
-                    </a:lnB>
                   </a:tcPr>
                 </a:tc>
               </a:tr>
@@ -19988,7 +19700,7 @@
         </p:nvSpPr>
         <p:spPr>
           <a:xfrm>
-            <a:off x="548640" y="5349240"/>
+            <a:off x="548640" y="4251960"/>
             <a:ext cx="11064240" cy="640080"/>
           </a:xfrm>
           <a:prstGeom prst="rect">

</xml_diff>

<commit_message>
Use 'prediction' throughout, refine agenda and tracker labels, fix slide 7 overlap
Co-Authored-By: Claude Opus 5.5 (1M context) <noreply@anthropic.com>
Claude-Session: https://claude.ai/code/session_01JZtuYERhuCe7nB9VYHwcfv
</commit_message>
<xml_diff>
--- a/presentation/bed-rest-to-mars-talk.pptx
+++ b/presentation/bed-rest-to-mars-talk.pptx
@@ -125,13 +125,13 @@
   <p:extLst>
     <p:ext uri="{521415D9-36F7-43E2-AB2F-B90AF26B5E84}">
       <p14:sectionLst xmlns:p14="http://schemas.microsoft.com/office/powerpoint/2010/main">
-        <p14:section name="Opening" id="{41d6901e-8f4b-358a-5b05-a32ef120c988}">
+        <p14:section name="Opening" id="{04854e55-f17f-a7a3-7097-4b6a8bcfc816}">
           <p14:sldIdLst>
             <p14:sldId id="256"/>
             <p14:sldId id="257"/>
           </p14:sldIdLst>
         </p14:section>
-        <p14:section name="Part 1" id="{4130e22a-0581-ff77-c967-82a0149704db}">
+        <p14:section name="Part 1" id="{fdd9be1d-b320-fb8c-ba59-699e7e56cdc7}">
           <p14:sldIdLst>
             <p14:sldId id="258"/>
             <p14:sldId id="259"/>
@@ -141,7 +141,7 @@
             <p14:sldId id="263"/>
           </p14:sldIdLst>
         </p14:section>
-        <p14:section name="Part 2" id="{b9a037bd-d9ff-fa69-7f6c-372c6598aaf9}">
+        <p14:section name="Part 2" id="{b762a22e-8a02-a47a-4298-965eff46725d}">
           <p14:sldIdLst>
             <p14:sldId id="264"/>
             <p14:sldId id="265"/>
@@ -151,7 +151,7 @@
             <p14:sldId id="269"/>
           </p14:sldIdLst>
         </p14:section>
-        <p14:section name="Backup" id="{c5134959-8f8b-2614-c60c-f3be206704e5}">
+        <p14:section name="Backup" id="{426e4b9e-ab3e-8f39-2694-45b92e8e46d6}">
           <p14:sldIdLst>
             <p14:sldId id="270"/>
             <p14:sldId id="271"/>
@@ -160,16 +160,16 @@
             <p14:sldId id="274"/>
           </p14:sldIdLst>
         </p14:section>
-        <p14:section name="Backup" id="{3d644f97-554a-2b42-1414-28091eab21da}">
+        <p14:section name="Backup" id="{f0771c00-5892-6346-4460-e674807a76a6}">
           <p14:sldIdLst/>
         </p14:section>
-        <p14:section name="Backup" id="{55c9f080-b17d-4bed-599c-1010bdad61cd}">
+        <p14:section name="Backup" id="{ae9ab280-9f8c-2065-ef18-da98985a3966}">
           <p14:sldIdLst/>
         </p14:section>
-        <p14:section name="Backup" id="{0a469fd9-ec07-7b2d-96d2-a248feac1a7d}">
+        <p14:section name="Backup" id="{2f7fc2cb-edb4-5a16-7027-8d816ec04e7e}">
           <p14:sldIdLst/>
         </p14:section>
-        <p14:section name="Backup" id="{43d29db5-1aa5-eabf-2834-9e4b9b2f0da8}">
+        <p14:section name="Backup" id="{bdc415c2-d913-6173-46db-190d8288a2f1}">
           <p14:sldIdLst/>
         </p14:section>
       </p14:sectionLst>
@@ -2756,7 +2756,7 @@
                     <c:v>Duration curve</c:v>
                   </c:pt>
                   <c:pt idx="6">
-                    <c:v>LLM forecast</c:v>
+                    <c:v>LLM prediction</c:v>
                   </c:pt>
                 </c:lvl>
               </c:multiLvlStrCache>
@@ -3127,7 +3127,7 @@
                     <c:v>Duration curve</c:v>
                   </c:pt>
                   <c:pt idx="6">
-                    <c:v>LLM forecast</c:v>
+                    <c:v>LLM prediction</c:v>
                   </c:pt>
                 </c:lvl>
               </c:multiLvlStrCache>
@@ -3887,7 +3887,7 @@
               <a:t>About a minute and a half.
 The ML models only saw coded columns. Here we gave each measurement, written out in words, to a newly released language model built for probabilistic classification. You give it a described situation and a fixed list of options, and it returns a probability for each option.
 On the left is a real request from our cache. It describes the volunteers, the protocol, the muscle and how it was scanned, and the day. It also contains the duration curve fitted on the other 31 campaigns and as many rows from those campaigns as fit, most similar first. The question asks which of 19 ranges the change will fall in.
-On the right is what came back for this row: a probability for each range. We never ask the model for a number. Our code turns the probabilities into a forecast, here minus 6.6 percent against an observed minus 9.4. We chose this row because its error is the model's median error.
+On the right is what came back for this row: a probability for each range. We never ask the model for a number. Our code turns the probabilities into a prediction, here minus 6.6 percent against an observed minus 9.4. We chose this row because its error is the model's median error.
 The request never contains the held-out campaign's own data or any name that could identify a paper, and the code checks that on every request. Every answer is cached, so all our numbers can be rebuilt without calling the model again.</a:t>
             </a:r>
             <a:endParaRPr lang="en-US" dirty="0"/>
@@ -4071,8 +4071,8 @@
 We wrote down each check and its pass rule, and committed them to the repository, before running it.
 Language models have read many papers, so the model might recognise a published campaign and recall its result. With every identifying detail removed, the gain is 0.30 points and its interval stays above zero. When we asked the model to choose the campaign's name from a list of options, it was right 19 percent of the time, where guessing gives 8 percent. If asked: of the three campaigns behind most of the gain, it named only one.
 When we shuffle the other campaigns' values, the gain turns into a loss of 1.25 points, and with no reference data the error rises to 5.85. The gain comes from reading those data.
-Reordering the rows or shifting the range edges changes the error by 1 to 3 percent. Repeating 20 requests moves the forecasts by 0.17 points on average, well under the 0.42 gain.
-Three limitations: we added this model after the ML result; its 80 percent ranges contain the truth only 62 percent of the time, so we quote only point forecasts; and when given a campaign's own earlier scans, it does not use them.</a:t>
+Reordering the rows or shifting the range edges changes the error by 1 to 3 percent. Repeating 20 requests moves the predictions by 0.17 points on average, well under the 0.42 gain.
+Three limitations: we added this model after the ML result; its 80 percent ranges contain the truth only 62 percent of the time, so we quote only point predictions; and when given a campaign's own earlier scans, it does not use them.</a:t>
             </a:r>
             <a:endParaRPr lang="en-US" dirty="0"/>
           </a:p>
@@ -4690,7 +4690,7 @@
           <a:p>
             <a:r>
               <a:rPr lang="en-US" dirty="0"/>
-              <a:t>Agenda. Part 1 (co-author): why this matters, why bed rest, the dataset, and which muscles lose most. Part 2: how we tested models, the LLM forecast, and conclusions.</a:t>
+              <a:t>Agenda. Part 1 (co-author): why this matters, why bed rest, the dataset, and which muscles lose most. Part 2: how we tested models, the LLM prediction, and conclusions.</a:t>
             </a:r>
             <a:endParaRPr lang="en-US" dirty="0"/>
           </a:p>
@@ -6339,7 +6339,7 @@
       </p:sp>
       <p:sp>
         <p:nvSpPr>
-          <p:cNvPr id="6" name="Tracker 4 Models"/>
+          <p:cNvPr id="6" name="Tracker 4 ML models"/>
           <p:cNvSpPr/>
           <p:nvPr/>
         </p:nvSpPr>
@@ -6364,7 +6364,7 @@
       </p:sp>
       <p:sp>
         <p:nvSpPr>
-          <p:cNvPr id="7" name="Tracker 5 LLM forecast"/>
+          <p:cNvPr id="7" name="Tracker 5 LLM prediction"/>
           <p:cNvSpPr/>
           <p:nvPr/>
         </p:nvSpPr>
@@ -6442,7 +6442,7 @@
                   <a:schemeClr val="accent1"/>
                 </a:solidFill>
               </a:rPr>
-              <a:t>4  Models</a:t>
+              <a:t>4  ML models</a:t>
             </a:r>
             <a:endParaRPr lang="en-US" sz="1000" dirty="0"/>
           </a:p>
@@ -6749,7 +6749,7 @@
       </p:sp>
       <p:sp>
         <p:nvSpPr>
-          <p:cNvPr id="6" name="Tracker 4 Models"/>
+          <p:cNvPr id="6" name="Tracker 4 ML models"/>
           <p:cNvSpPr/>
           <p:nvPr/>
         </p:nvSpPr>
@@ -6774,7 +6774,7 @@
       </p:sp>
       <p:sp>
         <p:nvSpPr>
-          <p:cNvPr id="7" name="Tracker 5 LLM forecast"/>
+          <p:cNvPr id="7" name="Tracker 5 LLM prediction"/>
           <p:cNvSpPr/>
           <p:nvPr/>
         </p:nvSpPr>
@@ -6852,7 +6852,7 @@
                   <a:schemeClr val="accent1"/>
                 </a:solidFill>
               </a:rPr>
-              <a:t>5  LLM forecast</a:t>
+              <a:t>5  LLM prediction</a:t>
             </a:r>
             <a:endParaRPr lang="en-US" sz="1000" dirty="0"/>
           </a:p>
@@ -6893,7 +6893,7 @@
                 <a:ea typeface="Cambria" pitchFamily="34" charset="-122"/>
                 <a:cs typeface="Cambria" pitchFamily="34" charset="-120"/>
               </a:rPr>
-              <a:t>LLM forecast: what is sent and what comes back</a:t>
+              <a:t>LLM prediction: what is sent and what comes back</a:t>
             </a:r>
             <a:endParaRPr lang="en-US" sz="2800" dirty="0"/>
           </a:p>
@@ -7412,7 +7412,7 @@
                   <a:schemeClr val="tx1"/>
                 </a:solidFill>
               </a:rPr>
-              <a:t>Our code turns the probabilities into one forecast, their weighted average: −6.6%</a:t>
+              <a:t>Our code turns the probabilities into one prediction, their weighted average: −6.6%</a:t>
             </a:r>
             <a:endParaRPr lang="en-US" sz="1300" dirty="0"/>
           </a:p>
@@ -7653,7 +7653,7 @@
       </p:sp>
       <p:sp>
         <p:nvSpPr>
-          <p:cNvPr id="6" name="Tracker 4 Models"/>
+          <p:cNvPr id="6" name="Tracker 4 ML models"/>
           <p:cNvSpPr/>
           <p:nvPr/>
         </p:nvSpPr>
@@ -7678,7 +7678,7 @@
       </p:sp>
       <p:sp>
         <p:nvSpPr>
-          <p:cNvPr id="7" name="Tracker 5 LLM forecast"/>
+          <p:cNvPr id="7" name="Tracker 5 LLM prediction"/>
           <p:cNvSpPr/>
           <p:nvPr/>
         </p:nvSpPr>
@@ -7756,7 +7756,7 @@
                   <a:schemeClr val="accent1"/>
                 </a:solidFill>
               </a:rPr>
-              <a:t>5  LLM forecast</a:t>
+              <a:t>5  LLM prediction</a:t>
             </a:r>
             <a:endParaRPr lang="en-US" sz="1000" dirty="0"/>
           </a:p>
@@ -7797,7 +7797,7 @@
                 <a:ea typeface="Cambria" pitchFamily="34" charset="-122"/>
                 <a:cs typeface="Cambria" pitchFamily="34" charset="-120"/>
               </a:rPr>
-              <a:t>The LLM forecast has the lowest error of all models</a:t>
+              <a:t>The LLM prediction has the lowest error of all models</a:t>
             </a:r>
             <a:endParaRPr lang="en-US" sz="2800" dirty="0"/>
           </a:p>
@@ -8099,7 +8099,7 @@
       </p:sp>
       <p:sp>
         <p:nvSpPr>
-          <p:cNvPr id="6" name="Tracker 4 Models"/>
+          <p:cNvPr id="6" name="Tracker 4 ML models"/>
           <p:cNvSpPr/>
           <p:nvPr/>
         </p:nvSpPr>
@@ -8124,7 +8124,7 @@
       </p:sp>
       <p:sp>
         <p:nvSpPr>
-          <p:cNvPr id="7" name="Tracker 5 LLM forecast"/>
+          <p:cNvPr id="7" name="Tracker 5 LLM prediction"/>
           <p:cNvSpPr/>
           <p:nvPr/>
         </p:nvSpPr>
@@ -8202,7 +8202,7 @@
                   <a:schemeClr val="accent1"/>
                 </a:solidFill>
               </a:rPr>
-              <a:t>5  LLM forecast</a:t>
+              <a:t>5  LLM prediction</a:t>
             </a:r>
             <a:endParaRPr lang="en-US" sz="1000" dirty="0"/>
           </a:p>
@@ -8243,7 +8243,7 @@
                 <a:ea typeface="Cambria" pitchFamily="34" charset="-122"/>
                 <a:cs typeface="Cambria" pitchFamily="34" charset="-120"/>
               </a:rPr>
-              <a:t>Validity checks on the LLM forecast</a:t>
+              <a:t>Validity checks on the LLM prediction</a:t>
             </a:r>
             <a:endParaRPr lang="en-US" sz="2800" dirty="0"/>
           </a:p>
@@ -8511,7 +8511,7 @@
                   <a:schemeClr val="tx1"/>
                 </a:solidFill>
               </a:rPr>
-              <a:t>20 identical requests resent: forecasts differ by 0.17 pp on average, well below the 0.42 pp gain</a:t>
+              <a:t>20 identical requests resent: predictions differ by 0.17 pp on average, well below the 0.42 pp gain</a:t>
             </a:r>
             <a:endParaRPr lang="en-US" sz="1600" dirty="0"/>
           </a:p>
@@ -8583,7 +8583,7 @@
                   <a:schemeClr val="tx1"/>
                 </a:solidFill>
               </a:rPr>
-              <a:t>Overconfident ranges: its 80% ranges hold the measured value 62% of the time, so we report only its single-number forecast</a:t>
+              <a:t>Overconfident ranges: its 80% ranges hold the measured value 62% of the time, so we report only its single-number prediction</a:t>
             </a:r>
             <a:endParaRPr lang="en-US" sz="1600" dirty="0"/>
           </a:p>
@@ -8777,7 +8777,7 @@
       </p:sp>
       <p:sp>
         <p:nvSpPr>
-          <p:cNvPr id="6" name="Tracker 4 Models"/>
+          <p:cNvPr id="6" name="Tracker 4 ML models"/>
           <p:cNvSpPr/>
           <p:nvPr/>
         </p:nvSpPr>
@@ -8802,7 +8802,7 @@
       </p:sp>
       <p:sp>
         <p:nvSpPr>
-          <p:cNvPr id="7" name="Tracker 5 LLM forecast"/>
+          <p:cNvPr id="7" name="Tracker 5 LLM prediction"/>
           <p:cNvSpPr/>
           <p:nvPr/>
         </p:nvSpPr>
@@ -8978,7 +8978,7 @@
                   <a:schemeClr val="tx1"/>
                 </a:solidFill>
               </a:rPr>
-              <a:t>With 32 independent campaigns, no ML model forecasts better than a curve based on days alone (best 3.18 vs 3.16 pp error).</a:t>
+              <a:t>With 32 independent campaigns, no ML model predicts better than a curve based on days alone (best 3.18 vs 3.16 pp error).</a:t>
             </a:r>
             <a:endParaRPr lang="en-US" sz="2000" dirty="0"/>
           </a:p>
@@ -9218,7 +9218,7 @@
                   <a:schemeClr val="tx1"/>
                 </a:solidFill>
               </a:rPr>
-              <a:t>Extend the forecast to a 180-day mission, with an uncertainty range</a:t>
+              <a:t>Extend the prediction to a 180-day mission, with an uncertainty range</a:t>
             </a:r>
             <a:endParaRPr lang="en-US" sz="2000" dirty="0"/>
           </a:p>
@@ -11749,7 +11749,7 @@
                   <a:schemeClr val="accent3"/>
                 </a:solidFill>
               </a:rPr>
-              <a:t>* Our calculation from results/forecast_predictions.csv; not in the report.</a:t>
+              <a:t>* Our calculation from the saved LLM predictions; not in the report.</a:t>
             </a:r>
             <a:endParaRPr lang="en-US" sz="1100" dirty="0"/>
           </a:p>
@@ -12965,7 +12965,7 @@
                   <a:schemeClr val="tx2"/>
                 </a:solidFill>
               </a:rPr>
-              <a:t>Part 2: modelling and forecasting</a:t>
+              <a:t>Part 2: modelling and prediction</a:t>
             </a:r>
             <a:endParaRPr lang="en-US" sz="1600" dirty="0"/>
           </a:p>
@@ -13085,7 +13085,7 @@
                   <a:schemeClr val="tx1"/>
                 </a:solidFill>
               </a:rPr>
-              <a:t>Why forecast muscle loss, and why bed rest</a:t>
+              <a:t>Why predict muscle loss; from bed rest to Mars</a:t>
             </a:r>
             <a:endParaRPr lang="en-US" sz="1600" dirty="0"/>
           </a:p>
@@ -13191,7 +13191,7 @@
                   <a:schemeClr val="tx1"/>
                 </a:solidFill>
               </a:rPr>
-              <a:t>Range of unloading, search and dataset</a:t>
+              <a:t>Range studied, search, dataset</a:t>
             </a:r>
             <a:endParaRPr lang="en-US" sz="1600" dirty="0"/>
           </a:p>
@@ -13389,7 +13389,7 @@
                   <a:schemeClr val="tx2"/>
                 </a:solidFill>
               </a:rPr>
-              <a:t>Models</a:t>
+              <a:t>ML models</a:t>
             </a:r>
             <a:endParaRPr lang="en-US" sz="1600" dirty="0"/>
           </a:p>
@@ -13495,7 +13495,7 @@
                   <a:schemeClr val="tx2"/>
                 </a:solidFill>
               </a:rPr>
-              <a:t>LLM forecast</a:t>
+              <a:t>LLM prediction</a:t>
             </a:r>
             <a:endParaRPr lang="en-US" sz="1600" dirty="0"/>
           </a:p>
@@ -13509,7 +13509,7 @@
                   <a:schemeClr val="tx1"/>
                 </a:solidFill>
               </a:rPr>
-              <a:t>What it sees, results, checks</a:t>
+              <a:t>Input and output, results, validity checks</a:t>
             </a:r>
             <a:endParaRPr lang="en-US" sz="1600" dirty="0"/>
           </a:p>
@@ -13615,7 +13615,7 @@
                   <a:schemeClr val="tx1"/>
                 </a:solidFill>
               </a:rPr>
-              <a:t>Findings, limits, next steps</a:t>
+              <a:t>Findings, limitations, further work</a:t>
             </a:r>
             <a:endParaRPr lang="en-US" sz="1600" dirty="0"/>
           </a:p>
@@ -13827,7 +13827,7 @@
       </p:sp>
       <p:sp>
         <p:nvSpPr>
-          <p:cNvPr id="6" name="Tracker 4 Models"/>
+          <p:cNvPr id="6" name="Tracker 4 ML models"/>
           <p:cNvSpPr/>
           <p:nvPr/>
         </p:nvSpPr>
@@ -13852,7 +13852,7 @@
       </p:sp>
       <p:sp>
         <p:nvSpPr>
-          <p:cNvPr id="7" name="Tracker 5 LLM forecast"/>
+          <p:cNvPr id="7" name="Tracker 5 LLM prediction"/>
           <p:cNvSpPr/>
           <p:nvPr/>
         </p:nvSpPr>
@@ -14762,7 +14762,7 @@
       </p:sp>
       <p:sp>
         <p:nvSpPr>
-          <p:cNvPr id="6" name="Tracker 4 Models"/>
+          <p:cNvPr id="6" name="Tracker 4 ML models"/>
           <p:cNvSpPr/>
           <p:nvPr/>
         </p:nvSpPr>
@@ -14787,7 +14787,7 @@
       </p:sp>
       <p:sp>
         <p:nvSpPr>
-          <p:cNvPr id="7" name="Tracker 5 LLM forecast"/>
+          <p:cNvPr id="7" name="Tracker 5 LLM prediction"/>
           <p:cNvSpPr/>
           <p:nvPr/>
         </p:nvSpPr>
@@ -16658,7 +16658,7 @@
       </p:sp>
       <p:sp>
         <p:nvSpPr>
-          <p:cNvPr id="6" name="Tracker 4 Models"/>
+          <p:cNvPr id="6" name="Tracker 4 ML models"/>
           <p:cNvSpPr/>
           <p:nvPr/>
         </p:nvSpPr>
@@ -16683,7 +16683,7 @@
       </p:sp>
       <p:sp>
         <p:nvSpPr>
-          <p:cNvPr id="7" name="Tracker 5 LLM forecast"/>
+          <p:cNvPr id="7" name="Tracker 5 LLM prediction"/>
           <p:cNvSpPr/>
           <p:nvPr/>
         </p:nvSpPr>
@@ -17842,7 +17842,7 @@
       </p:sp>
       <p:sp>
         <p:nvSpPr>
-          <p:cNvPr id="6" name="Tracker 4 Models"/>
+          <p:cNvPr id="6" name="Tracker 4 ML models"/>
           <p:cNvSpPr/>
           <p:nvPr/>
         </p:nvSpPr>
@@ -17867,7 +17867,7 @@
       </p:sp>
       <p:sp>
         <p:nvSpPr>
-          <p:cNvPr id="7" name="Tracker 5 LLM forecast"/>
+          <p:cNvPr id="7" name="Tracker 5 LLM prediction"/>
           <p:cNvSpPr/>
           <p:nvPr/>
         </p:nvSpPr>
@@ -19086,7 +19086,7 @@
       </p:sp>
       <p:sp>
         <p:nvSpPr>
-          <p:cNvPr id="6" name="Tracker 4 Models"/>
+          <p:cNvPr id="6" name="Tracker 4 ML models"/>
           <p:cNvSpPr/>
           <p:nvPr/>
         </p:nvSpPr>
@@ -19111,7 +19111,7 @@
       </p:sp>
       <p:sp>
         <p:nvSpPr>
-          <p:cNvPr id="7" name="Tracker 5 LLM forecast"/>
+          <p:cNvPr id="7" name="Tracker 5 LLM prediction"/>
           <p:cNvSpPr/>
           <p:nvPr/>
         </p:nvSpPr>
@@ -19700,7 +19700,7 @@
         </p:nvSpPr>
         <p:spPr>
           <a:xfrm>
-            <a:off x="548640" y="4251960"/>
+            <a:off x="548640" y="4846320"/>
             <a:ext cx="11064240" cy="640080"/>
           </a:xfrm>
           <a:prstGeom prst="rect">
@@ -21129,7 +21129,7 @@
       </p:sp>
       <p:sp>
         <p:nvSpPr>
-          <p:cNvPr id="6" name="Tracker 4 Models"/>
+          <p:cNvPr id="6" name="Tracker 4 ML models"/>
           <p:cNvSpPr/>
           <p:nvPr/>
         </p:nvSpPr>
@@ -21154,7 +21154,7 @@
       </p:sp>
       <p:sp>
         <p:nvSpPr>
-          <p:cNvPr id="7" name="Tracker 5 LLM forecast"/>
+          <p:cNvPr id="7" name="Tracker 5 LLM prediction"/>
           <p:cNvSpPr/>
           <p:nvPr/>
         </p:nvSpPr>
@@ -25404,7 +25404,7 @@
       </p:sp>
       <p:sp>
         <p:nvSpPr>
-          <p:cNvPr id="6" name="Tracker 4 Models"/>
+          <p:cNvPr id="6" name="Tracker 4 ML models"/>
           <p:cNvSpPr/>
           <p:nvPr/>
         </p:nvSpPr>
@@ -25429,7 +25429,7 @@
       </p:sp>
       <p:sp>
         <p:nvSpPr>
-          <p:cNvPr id="7" name="Tracker 5 LLM forecast"/>
+          <p:cNvPr id="7" name="Tracker 5 LLM prediction"/>
           <p:cNvSpPr/>
           <p:nvPr/>
         </p:nvSpPr>
@@ -25507,7 +25507,7 @@
                   <a:schemeClr val="accent1"/>
                 </a:solidFill>
               </a:rPr>
-              <a:t>4  Models</a:t>
+              <a:t>4  ML models</a:t>
             </a:r>
             <a:endParaRPr lang="en-US" sz="1000" dirty="0"/>
           </a:p>
@@ -25856,7 +25856,7 @@
                   <a:schemeClr val="tx1"/>
                 </a:solidFill>
               </a:rPr>
-              <a:t>LLM forecast</a:t>
+              <a:t>LLM prediction</a:t>
             </a:r>
             <a:endParaRPr lang="en-US" sz="1600" dirty="0"/>
           </a:p>
@@ -26921,7 +26921,7 @@
                   <a:schemeClr val="tx1"/>
                 </a:solidFill>
               </a:rPr>
-              <a:t>Score: average error in percentage points (pp), each campaign counted once. Forecast −10%, measured −13%: error 3 pp.</a:t>
+              <a:t>Score: average error in percentage points (pp), each campaign counted once. Predicted −10%, measured −13%: error 3 pp.</a:t>
             </a:r>
             <a:endParaRPr lang="en-US" sz="1400" dirty="0"/>
           </a:p>

</xml_diff>

<commit_message>
Use academic slide titles instead of questions
Co-Authored-By: Claude Opus 5.5 (1M context) <noreply@anthropic.com>
Claude-Session: https://claude.ai/code/session_01JZtuYERhuCe7nB9VYHwcfv
</commit_message>
<xml_diff>
--- a/presentation/bed-rest-to-mars-talk.pptx
+++ b/presentation/bed-rest-to-mars-talk.pptx
@@ -124,13 +124,13 @@
   <p:extLst>
     <p:ext uri="{521415D9-36F7-43E2-AB2F-B90AF26B5E84}">
       <p14:sectionLst xmlns:p14="http://schemas.microsoft.com/office/powerpoint/2010/main">
-        <p14:section name="Opening" id="{1f52d662-2b16-443c-3a1e-819ff3b7bf12}">
+        <p14:section name="Opening" id="{15f9e6c8-feac-3362-5083-fe818791ec50}">
           <p14:sldIdLst>
             <p14:sldId id="256"/>
             <p14:sldId id="257"/>
           </p14:sldIdLst>
         </p14:section>
-        <p14:section name="Part 1" id="{f6553fc3-ae20-2f24-f650-dd445cb5bec4}">
+        <p14:section name="Part 1" id="{b4c8ca27-aa04-3e6f-4ccf-f23cf5473ee2}">
           <p14:sldIdLst>
             <p14:sldId id="258"/>
             <p14:sldId id="259"/>
@@ -140,7 +140,7 @@
             <p14:sldId id="263"/>
           </p14:sldIdLst>
         </p14:section>
-        <p14:section name="Part 2" id="{8a63f07a-e28a-876f-e84e-3f01d9140f31}">
+        <p14:section name="Part 2" id="{a1b40400-7a6f-21ff-a1ea-e16e27550581}">
           <p14:sldIdLst>
             <p14:sldId id="264"/>
             <p14:sldId id="265"/>
@@ -149,7 +149,7 @@
             <p14:sldId id="268"/>
           </p14:sldIdLst>
         </p14:section>
-        <p14:section name="Backup" id="{1bd555b7-e76a-8cc5-63b1-23c59866518c}">
+        <p14:section name="Backup" id="{1d075a77-97f9-0c35-6fff-9c468231a2a4}">
           <p14:sldIdLst>
             <p14:sldId id="269"/>
             <p14:sldId id="270"/>
@@ -158,16 +158,16 @@
             <p14:sldId id="273"/>
           </p14:sldIdLst>
         </p14:section>
-        <p14:section name="Backup" id="{5c597753-41da-bb2c-8a22-cb09ffb5c134}">
+        <p14:section name="Backup" id="{44e7f95f-5461-cae3-e12a-8e122e24b6d2}">
           <p14:sldIdLst/>
         </p14:section>
-        <p14:section name="Backup" id="{84a4425f-970f-6a63-1128-7c4907b7dd7a}">
+        <p14:section name="Backup" id="{1b86eb8d-ffc5-b3c4-a071-5da520d696b1}">
           <p14:sldIdLst/>
         </p14:section>
-        <p14:section name="Backup" id="{49ddf9fb-bbe8-7dd7-b941-f9cb396309c9}">
+        <p14:section name="Backup" id="{c7090d8b-3682-1ccf-318d-a7f73ffa1b31}">
           <p14:sldIdLst/>
         </p14:section>
-        <p14:section name="Backup" id="{14c8cb95-81c5-3d0f-7831-8e55cd6cbb8f}">
+        <p14:section name="Backup" id="{11504acf-3da4-7c71-b40b-1bd6caf2ceed}">
           <p14:sldIdLst/>
         </p14:section>
       </p14:sectionLst>
@@ -5607,7 +5607,7 @@
                 <a:ea typeface="Cambria" pitchFamily="34" charset="-122"/>
                 <a:cs typeface="Cambria" pitchFamily="34" charset="-120"/>
               </a:rPr>
-              <a:t>LLM prediction: what is sent and what comes back</a:t>
+              <a:t>LLM prediction: input and output</a:t>
             </a:r>
             <a:endParaRPr lang="en-US" sz="2800" dirty="0"/>
           </a:p>
@@ -6511,7 +6511,7 @@
                 <a:ea typeface="Cambria" pitchFamily="34" charset="-122"/>
                 <a:cs typeface="Cambria" pitchFamily="34" charset="-120"/>
               </a:rPr>
-              <a:t>The LLM prediction has the lowest error of all models</a:t>
+              <a:t>Model comparison on held-out campaigns</a:t>
             </a:r>
             <a:endParaRPr lang="en-US" sz="2800" dirty="0"/>
           </a:p>
@@ -6975,7 +6975,7 @@
                 <a:ea typeface="Cambria" pitchFamily="34" charset="-122"/>
                 <a:cs typeface="Cambria" pitchFamily="34" charset="-120"/>
               </a:rPr>
-              <a:t>Validity checks on the LLM prediction</a:t>
+              <a:t>Validity checks of the LLM prediction</a:t>
             </a:r>
             <a:endParaRPr lang="en-US" sz="2800" dirty="0"/>
           </a:p>
@@ -8079,7 +8079,7 @@
                 <a:ea typeface="Cambria" pitchFamily="34" charset="-122"/>
                 <a:cs typeface="Cambria" pitchFamily="34" charset="-120"/>
               </a:rPr>
-              <a:t>Backup: is the dataset good enough?</a:t>
+              <a:t>Backup: dataset coverage and limitations</a:t>
             </a:r>
             <a:endParaRPr lang="en-US" sz="2800" dirty="0"/>
           </a:p>
@@ -8526,7 +8526,7 @@
                 <a:ea typeface="Cambria" pitchFamily="34" charset="-122"/>
                 <a:cs typeface="Cambria" pitchFamily="34" charset="-120"/>
               </a:rPr>
-              <a:t>Backup: how did we search the literature?</a:t>
+              <a:t>Backup: literature search sources and query</a:t>
             </a:r>
             <a:endParaRPr lang="en-US" sz="2800" dirty="0"/>
           </a:p>
@@ -10109,7 +10109,7 @@
                 <a:ea typeface="Cambria" pitchFamily="34" charset="-122"/>
                 <a:cs typeface="Cambria" pitchFamily="34" charset="-120"/>
               </a:rPr>
-              <a:t>Backup: is the LLM gain real, and does it matter?</a:t>
+              <a:t>Backup: significance and relevance of the LLM gain</a:t>
             </a:r>
             <a:endParaRPr lang="en-US" sz="2800" dirty="0"/>
           </a:p>
@@ -10592,7 +10592,7 @@
                 <a:ea typeface="Cambria" pitchFamily="34" charset="-122"/>
                 <a:cs typeface="Cambria" pitchFamily="34" charset="-120"/>
               </a:rPr>
-              <a:t>Backup: why did ML fail, and was the comparison fair?</a:t>
+              <a:t>Backup: ML results and fairness of the comparison</a:t>
             </a:r>
             <a:endParaRPr lang="en-US" sz="2800" dirty="0"/>
           </a:p>
@@ -11021,7 +11021,7 @@
                 <a:ea typeface="Cambria" pitchFamily="34" charset="-122"/>
                 <a:cs typeface="Cambria" pitchFamily="34" charset="-120"/>
               </a:rPr>
-              <a:t>Backup: can this be used to plan a Mars mission?</a:t>
+              <a:t>Backup: applicability to Mars mission planning</a:t>
             </a:r>
             <a:endParaRPr lang="en-US" sz="2800" dirty="0"/>
           </a:p>
@@ -12703,7 +12703,7 @@
                 <a:ea typeface="Cambria" pitchFamily="34" charset="-122"/>
                 <a:cs typeface="Cambria" pitchFamily="34" charset="-120"/>
               </a:rPr>
-              <a:t>Motivation: can we predict muscle atrophy?</a:t>
+              <a:t>Motivation: predicting lower-limb muscle atrophy</a:t>
             </a:r>
             <a:endParaRPr lang="en-US" sz="2800" dirty="0"/>
           </a:p>
@@ -13564,7 +13564,7 @@
                 <a:ea typeface="Cambria" pitchFamily="34" charset="-122"/>
                 <a:cs typeface="Cambria" pitchFamily="34" charset="-120"/>
               </a:rPr>
-              <a:t>Why from bed rest to Mars?</a:t>
+              <a:t>From bed rest to Mars: analogue and application</a:t>
             </a:r>
             <a:endParaRPr lang="en-US" sz="2800" dirty="0"/>
           </a:p>
@@ -15406,7 +15406,7 @@
                 <a:ea typeface="Cambria" pitchFamily="34" charset="-122"/>
                 <a:cs typeface="Cambria" pitchFamily="34" charset="-120"/>
               </a:rPr>
-              <a:t>What range did we study?</a:t>
+              <a:t>Range of unloading durations and studies</a:t>
             </a:r>
             <a:endParaRPr lang="en-US" sz="2800" dirty="0"/>
           </a:p>
@@ -16978,7 +16978,7 @@
                 <a:ea typeface="Cambria" pitchFamily="34" charset="-122"/>
                 <a:cs typeface="Cambria" pitchFamily="34" charset="-120"/>
               </a:rPr>
-              <a:t>How did we build the dataset?</a:t>
+              <a:t>Literature search and study selection</a:t>
             </a:r>
             <a:endParaRPr lang="en-US" sz="2800" dirty="0"/>
           </a:p>
@@ -18222,7 +18222,7 @@
                 <a:ea typeface="Cambria" pitchFamily="34" charset="-122"/>
                 <a:cs typeface="Cambria" pitchFamily="34" charset="-120"/>
               </a:rPr>
-              <a:t>What does the dataset look like?</a:t>
+              <a:t>Dataset composition</a:t>
             </a:r>
             <a:endParaRPr lang="en-US" sz="2800" dirty="0"/>
           </a:p>
@@ -20265,7 +20265,7 @@
                 <a:ea typeface="Cambria" pitchFamily="34" charset="-122"/>
                 <a:cs typeface="Cambria" pitchFamily="34" charset="-120"/>
               </a:rPr>
-              <a:t>Are all muscles affected the same?</a:t>
+              <a:t>Muscle atrophy by muscle group</a:t>
             </a:r>
             <a:endParaRPr lang="en-US" sz="2800" dirty="0"/>
           </a:p>
@@ -24540,7 +24540,7 @@
                 <a:ea typeface="Cambria" pitchFamily="34" charset="-122"/>
                 <a:cs typeface="Cambria" pitchFamily="34" charset="-120"/>
               </a:rPr>
-              <a:t>Every model is tested on a campaign it has not seen</a:t>
+              <a:t>Evaluation: leave-one-campaign-out validation</a:t>
             </a:r>
             <a:endParaRPr lang="en-US" sz="2800" dirty="0"/>
           </a:p>

</xml_diff>

<commit_message>
Describe the LLM as a probabilistic classifier, not a chat model
Co-Authored-By: Claude Opus 5.5 (1M context) <noreply@anthropic.com>
Claude-Session: https://claude.ai/code/session_01JZtuYERhuCe7nB9VYHwcfv
</commit_message>
<xml_diff>
--- a/presentation/bed-rest-to-mars-talk.pptx
+++ b/presentation/bed-rest-to-mars-talk.pptx
@@ -124,13 +124,13 @@
   <p:extLst>
     <p:ext uri="{521415D9-36F7-43E2-AB2F-B90AF26B5E84}">
       <p14:sectionLst xmlns:p14="http://schemas.microsoft.com/office/powerpoint/2010/main">
-        <p14:section name="Opening" id="{15f9e6c8-feac-3362-5083-fe818791ec50}">
+        <p14:section name="Opening" id="{4c7c5853-9b75-8d20-6277-af2760e44f27}">
           <p14:sldIdLst>
             <p14:sldId id="256"/>
             <p14:sldId id="257"/>
           </p14:sldIdLst>
         </p14:section>
-        <p14:section name="Part 1" id="{b4c8ca27-aa04-3e6f-4ccf-f23cf5473ee2}">
+        <p14:section name="Part 1" id="{52d66020-36dc-7417-fc75-e3aa7241e793}">
           <p14:sldIdLst>
             <p14:sldId id="258"/>
             <p14:sldId id="259"/>
@@ -140,7 +140,7 @@
             <p14:sldId id="263"/>
           </p14:sldIdLst>
         </p14:section>
-        <p14:section name="Part 2" id="{a1b40400-7a6f-21ff-a1ea-e16e27550581}">
+        <p14:section name="Part 2" id="{df437b2e-7504-f6db-4bda-6cd464c49fba}">
           <p14:sldIdLst>
             <p14:sldId id="264"/>
             <p14:sldId id="265"/>
@@ -149,7 +149,7 @@
             <p14:sldId id="268"/>
           </p14:sldIdLst>
         </p14:section>
-        <p14:section name="Backup" id="{1d075a77-97f9-0c35-6fff-9c468231a2a4}">
+        <p14:section name="Backup" id="{0dea138c-c9ac-0675-a8e3-a170706e787e}">
           <p14:sldIdLst>
             <p14:sldId id="269"/>
             <p14:sldId id="270"/>
@@ -158,16 +158,16 @@
             <p14:sldId id="273"/>
           </p14:sldIdLst>
         </p14:section>
-        <p14:section name="Backup" id="{44e7f95f-5461-cae3-e12a-8e122e24b6d2}">
+        <p14:section name="Backup" id="{bc8cd86e-8b0b-371c-ade6-47f5957bbb73}">
           <p14:sldIdLst/>
         </p14:section>
-        <p14:section name="Backup" id="{1b86eb8d-ffc5-b3c4-a071-5da520d696b1}">
+        <p14:section name="Backup" id="{9ed93948-e53f-e178-3eeb-def88d495ce3}">
           <p14:sldIdLst/>
         </p14:section>
-        <p14:section name="Backup" id="{c7090d8b-3682-1ccf-318d-a7f73ffa1b31}">
+        <p14:section name="Backup" id="{7e95f7d3-eca4-7d6a-9cd9-20e7ad478fd8}">
           <p14:sldIdLst/>
         </p14:section>
-        <p14:section name="Backup" id="{11504acf-3da4-7c71-b40b-1bd6caf2ceed}">
+        <p14:section name="Backup" id="{516286b5-9eda-0efd-d532-2e521f734bfb}">
           <p14:sldIdLst/>
         </p14:section>
       </p14:sectionLst>
@@ -3008,7 +3008,7 @@
             <a:r>
               <a:rPr lang="en-US" dirty="0"/>
               <a:t>About a minute and a half.
-The ML models only saw coded columns. Here we gave each measurement, written out in words, to a newly released language model built for probabilistic classification. You give it a described situation and a fixed list of options, and it returns a probability for each option.
+The ML models only saw coded columns. Here we gave each measurement, written out in words, to a newly released language model built for probabilistic classification. It is not a chat model that writes text: you give it a described situation and a fixed list of options, and it returns a probability for each option, nothing else.
 On the left is a real request from our cache. It describes the volunteers, the protocol, the muscle and how it was scanned, and the day. It also contains the duration curve fitted on the other 31 campaigns and as many rows from those campaigns as fit, most similar first. The question asks which of 19 ranges the change will fall in.
 On the right is what came back for this row: a probability for each range. We never ask the model for a number. Our code turns the probabilities into a prediction, here minus 6.6 percent against an observed minus 9.4. We chose this row because its error is the model's median error.
 The request never contains the held-out campaign's own data or any name that could identify a paper, and the code checks that on every request. Every answer is cached, so all our numbers can be rebuilt without calling the model again.</a:t>
@@ -3285,7 +3285,7 @@
             <a:r>
               <a:rPr lang="en-US" dirty="0"/>
               <a:t>About thirty seconds.
-With 32 independent campaigns, standard ML models and TabPFN do not beat a curve that only knows the number of days. A language model that reads each campaign's description and the other campaigns' data reduces the error from 3.13 to 2.71 points. The limitations and next steps are on the slide; the main one is that 32 campaigns is a small sample.
+With 32 independent campaigns, standard ML models and TabPFN do not beat a curve that only knows the number of days. An LLM-based probabilistic classifier that reads each campaign's description and the other campaigns' data reduces the error from 3.13 to 2.71 points. The limitations and next steps are on the slide; the main one is that 32 campaigns is a small sample.
 Thank you.</a:t>
             </a:r>
             <a:endParaRPr lang="en-US" dirty="0"/>
@@ -5607,7 +5607,7 @@
                 <a:ea typeface="Cambria" pitchFamily="34" charset="-122"/>
                 <a:cs typeface="Cambria" pitchFamily="34" charset="-120"/>
               </a:rPr>
-              <a:t>LLM prediction: input and output</a:t>
+              <a:t>LLM-based probabilistic classifier: input and output</a:t>
             </a:r>
             <a:endParaRPr lang="en-US" sz="2800" dirty="0"/>
           </a:p>
@@ -6041,7 +6041,21 @@
               <a:buNone/>
             </a:pPr>
             <a:r>
-              <a:rPr lang="en-US" sz="1200" dirty="0">
+              <a:rPr lang="en-US" sz="1400" b="1" dirty="0">
+                <a:solidFill>
+                  <a:schemeClr val="tx2"/>
+                </a:solidFill>
+              </a:rPr>
+              <a:t>classifier</a:t>
+            </a:r>
+            <a:endParaRPr lang="en-US" sz="1600" dirty="0"/>
+          </a:p>
+          <a:p>
+            <a:pPr algn="ctr" indent="0" marL="0">
+              <a:buNone/>
+            </a:pPr>
+            <a:r>
+              <a:rPr lang="en-US" sz="1100" dirty="0">
                 <a:solidFill>
                   <a:schemeClr val="accent3"/>
                 </a:solidFill>
@@ -6076,9 +6090,45 @@
           </a:ln>
         </p:spPr>
       </p:sp>
+      <p:sp>
+        <p:nvSpPr>
+          <p:cNvPr id="17" name="Text 15"/>
+          <p:cNvSpPr txBox="1"/>
+          <p:nvPr/>
+        </p:nvSpPr>
+        <p:spPr>
+          <a:xfrm>
+            <a:off x="5486400" y="4069080"/>
+            <a:ext cx="2240280" cy="1188720"/>
+          </a:xfrm>
+          <a:prstGeom prst="rect">
+            <a:avLst/>
+          </a:prstGeom>
+          <a:noFill/>
+          <a:ln/>
+        </p:spPr>
+        <p:txBody>
+          <a:bodyPr wrap="square" lIns="0" tIns="0" rIns="0" bIns="0" rtlCol="0" anchor="t"/>
+          <a:lstStyle/>
+          <a:p>
+            <a:pPr algn="ctr" indent="0" marL="0">
+              <a:buNone/>
+            </a:pPr>
+            <a:r>
+              <a:rPr lang="en-US" sz="1100" i="1" dirty="0">
+                <a:solidFill>
+                  <a:schemeClr val="accent3"/>
+                </a:solidFill>
+              </a:rPr>
+              <a:t>Not a chat model: it is built for classification and returns only a probability for each listed option, never free text.</a:t>
+            </a:r>
+            <a:endParaRPr lang="en-US" sz="1100" dirty="0"/>
+          </a:p>
+        </p:txBody>
+      </p:sp>
       <p:graphicFrame>
         <p:nvGraphicFramePr>
-          <p:cNvPr id="17" name="Example answer chart" descr=""/>
+          <p:cNvPr id="18" name="Example answer chart" descr=""/>
           <p:cNvGraphicFramePr/>
           <p:nvPr/>
         </p:nvGraphicFramePr>
@@ -6094,7 +6144,7 @@
       </p:graphicFrame>
       <p:sp>
         <p:nvSpPr>
-          <p:cNvPr id="18" name="Text 15"/>
+          <p:cNvPr id="19" name="Text 16"/>
           <p:cNvSpPr txBox="1"/>
           <p:nvPr/>
         </p:nvSpPr>
@@ -6152,7 +6202,7 @@
       </p:sp>
       <p:sp>
         <p:nvSpPr>
-          <p:cNvPr id="19" name="Text 16"/>
+          <p:cNvPr id="20" name="Text 17"/>
           <p:cNvSpPr txBox="1"/>
           <p:nvPr/>
         </p:nvSpPr>
@@ -24848,7 +24898,7 @@
                   <a:schemeClr val="tx1"/>
                 </a:solidFill>
               </a:rPr>
-              <a:t>LLM prediction</a:t>
+              <a:t>LLM classifier: returns a probability per range</a:t>
             </a:r>
             <a:endParaRPr lang="en-US" sz="1600" dirty="0"/>
           </a:p>

</xml_diff>

<commit_message>
Switch to a Color Hunt palette; number figures and tables separately
Co-Authored-By: Claude Opus 5.5 (1M context) <noreply@anthropic.com>
Claude-Session: https://claude.ai/code/session_01JZtuYERhuCe7nB9VYHwcfv
</commit_message>
<xml_diff>
--- a/presentation/bed-rest-to-mars-talk.pptx
+++ b/presentation/bed-rest-to-mars-talk.pptx
@@ -124,13 +124,13 @@
   <p:extLst>
     <p:ext uri="{521415D9-36F7-43E2-AB2F-B90AF26B5E84}">
       <p14:sectionLst xmlns:p14="http://schemas.microsoft.com/office/powerpoint/2010/main">
-        <p14:section name="Opening" id="{4c7c5853-9b75-8d20-6277-af2760e44f27}">
+        <p14:section name="Opening" id="{155af95b-af42-929f-ad95-5c5b6b343bf7}">
           <p14:sldIdLst>
             <p14:sldId id="256"/>
             <p14:sldId id="257"/>
           </p14:sldIdLst>
         </p14:section>
-        <p14:section name="Part 1" id="{52d66020-36dc-7417-fc75-e3aa7241e793}">
+        <p14:section name="Part 1" id="{3bcafe2d-b464-76d2-84b2-86e0ada3aa2c}">
           <p14:sldIdLst>
             <p14:sldId id="258"/>
             <p14:sldId id="259"/>
@@ -140,7 +140,7 @@
             <p14:sldId id="263"/>
           </p14:sldIdLst>
         </p14:section>
-        <p14:section name="Part 2" id="{df437b2e-7504-f6db-4bda-6cd464c49fba}">
+        <p14:section name="Part 2" id="{e6a289ef-bcf1-5acd-6b91-70a2d7def056}">
           <p14:sldIdLst>
             <p14:sldId id="264"/>
             <p14:sldId id="265"/>
@@ -149,7 +149,7 @@
             <p14:sldId id="268"/>
           </p14:sldIdLst>
         </p14:section>
-        <p14:section name="Backup" id="{0dea138c-c9ac-0675-a8e3-a170706e787e}">
+        <p14:section name="Backup" id="{725ad00d-eb6e-39b6-af67-d3ddae28cceb}">
           <p14:sldIdLst>
             <p14:sldId id="269"/>
             <p14:sldId id="270"/>
@@ -158,16 +158,16 @@
             <p14:sldId id="273"/>
           </p14:sldIdLst>
         </p14:section>
-        <p14:section name="Backup" id="{bc8cd86e-8b0b-371c-ade6-47f5957bbb73}">
+        <p14:section name="Backup" id="{e90acfed-5f95-1f6a-9d34-214730e3a323}">
           <p14:sldIdLst/>
         </p14:section>
-        <p14:section name="Backup" id="{9ed93948-e53f-e178-3eeb-def88d495ce3}">
+        <p14:section name="Backup" id="{941f4a64-99f9-3bcc-7aab-6095f5c103b5}">
           <p14:sldIdLst/>
         </p14:section>
-        <p14:section name="Backup" id="{7e95f7d3-eca4-7d6a-9cd9-20e7ad478fd8}">
+        <p14:section name="Backup" id="{d384def7-c818-61d1-5b98-2b0fac56c7a9}">
           <p14:sldIdLst/>
         </p14:section>
-        <p14:section name="Backup" id="{516286b5-9eda-0efd-d532-2e521f734bfb}">
+        <p14:section name="Backup" id="{48716a63-e2fe-94d1-facb-0163cd72abcb}">
           <p14:sldIdLst/>
         </p14:section>
       </p14:sectionLst>
@@ -217,7 +217,7 @@
           </c:tx>
           <c:spPr>
             <a:solidFill>
-              <a:srgbClr val="C9D2DD"/>
+              <a:srgbClr val="DCD7C9"/>
             </a:solidFill>
             <a:effectLst/>
           </c:spPr>
@@ -402,7 +402,7 @@
           </c:tx>
           <c:spPr>
             <a:solidFill>
-              <a:srgbClr val="8FA3BB"/>
+              <a:srgbClr val="B3AD9E"/>
             </a:solidFill>
             <a:effectLst/>
           </c:spPr>
@@ -587,7 +587,7 @@
           </c:tx>
           <c:spPr>
             <a:solidFill>
-              <a:srgbClr val="56739A"/>
+              <a:srgbClr val="7D8A89"/>
             </a:solidFill>
             <a:effectLst/>
           </c:spPr>
@@ -772,7 +772,7 @@
           </c:tx>
           <c:spPr>
             <a:solidFill>
-              <a:srgbClr val="1F3A5F"/>
+              <a:srgbClr val="3F4E4F"/>
             </a:solidFill>
             <a:effectLst/>
           </c:spPr>
@@ -957,7 +957,7 @@
           </c:tx>
           <c:spPr>
             <a:solidFill>
-              <a:srgbClr val="A23B2A"/>
+              <a:srgbClr val="A27B5C"/>
             </a:solidFill>
             <a:effectLst/>
           </c:spPr>
@@ -1170,7 +1170,7 @@
         <c:spPr>
           <a:ln w="12700" cap="flat">
             <a:solidFill>
-              <a:srgbClr val="9AA3AE"/>
+              <a:srgbClr val="A9A598"/>
             </a:solidFill>
             <a:prstDash val="solid"/>
             <a:round/>
@@ -1183,7 +1183,7 @@
             <a:pPr>
               <a:defRPr sz="1000" b="0" i="0" u="none" strike="noStrike">
                 <a:solidFill>
-                  <a:srgbClr val="6B7280"/>
+                  <a:srgbClr val="6F7877"/>
                 </a:solidFill>
                 <a:latin typeface="Arial"/>
               </a:defRPr>
@@ -1210,7 +1210,7 @@
           <c:spPr>
             <a:ln w="9525" cap="flat">
               <a:solidFill>
-                <a:srgbClr val="E5E7EB"/>
+                <a:srgbClr val="E8E4DA"/>
               </a:solidFill>
               <a:prstDash val="solid"/>
               <a:round/>
@@ -1235,7 +1235,7 @@
             <a:pPr>
               <a:defRPr sz="1000" b="0" i="0" u="none" strike="noStrike">
                 <a:solidFill>
-                  <a:srgbClr val="6B7280"/>
+                  <a:srgbClr val="6F7877"/>
                 </a:solidFill>
                 <a:latin typeface="Arial"/>
               </a:defRPr>
@@ -1286,7 +1286,7 @@
             <a:pPr>
               <a:defRPr sz="1300" b="1" i="0" u="none" strike="noStrike">
                 <a:solidFill>
-                  <a:srgbClr val="1A1A1A"/>
+                  <a:srgbClr val="2C3639"/>
                 </a:solidFill>
                 <a:latin typeface="+mn-lt"/>
               </a:defRPr>
@@ -1294,11 +1294,11 @@
             <a:r>
               <a:rPr sz="1300" b="1" i="0" u="none" strike="noStrike">
                 <a:solidFill>
-                  <a:srgbClr val="1A1A1A"/>
+                  <a:srgbClr val="2C3639"/>
                 </a:solidFill>
                 <a:latin typeface="+mn-lt"/>
               </a:rPr>
-              <a:t>Answer: probability per range</a:t>
+              <a:t>Figure 9. Probability per range</a:t>
             </a:r>
           </a:p>
         </c:rich>
@@ -1329,7 +1329,7 @@
           </c:tx>
           <c:spPr>
             <a:solidFill>
-              <a:srgbClr val="A23B2A"/>
+              <a:srgbClr val="A27B5C"/>
             </a:solidFill>
             <a:effectLst/>
           </c:spPr>
@@ -1466,7 +1466,7 @@
           </c:tx>
           <c:spPr>
             <a:solidFill>
-              <a:srgbClr val="A7AEB8"/>
+              <a:srgbClr val="C4BEB0"/>
             </a:solidFill>
             <a:effectLst/>
           </c:spPr>
@@ -1633,7 +1633,7 @@
                 <a:pPr>
                   <a:defRPr sz="1000" b="0" i="0" u="none" strike="noStrike">
                     <a:solidFill>
-                      <a:srgbClr val="6B7280"/>
+                      <a:srgbClr val="6F7877"/>
                     </a:solidFill>
                     <a:latin typeface="Arial"/>
                   </a:defRPr>
@@ -1641,7 +1641,7 @@
                 <a:r>
                   <a:rPr sz="1000" b="0" i="0" u="none" strike="noStrike">
                     <a:solidFill>
-                      <a:srgbClr val="6B7280"/>
+                      <a:srgbClr val="6F7877"/>
                     </a:solidFill>
                     <a:latin typeface="Arial"/>
                   </a:rPr>
@@ -1673,7 +1673,7 @@
             <a:pPr>
               <a:defRPr sz="1000" b="0" i="0" u="none" strike="noStrike">
                 <a:solidFill>
-                  <a:srgbClr val="1A1A1A"/>
+                  <a:srgbClr val="2C3639"/>
                 </a:solidFill>
                 <a:latin typeface="+mn-lt"/>
               </a:defRPr>
@@ -1701,7 +1701,7 @@
           <c:spPr>
             <a:ln w="9525" cap="flat">
               <a:solidFill>
-                <a:srgbClr val="E5E7EB"/>
+                <a:srgbClr val="E8E4DA"/>
               </a:solidFill>
               <a:prstDash val="solid"/>
               <a:round/>
@@ -1728,7 +1728,7 @@
             <a:pPr>
               <a:defRPr sz="1000" b="0" i="0" u="none" strike="noStrike">
                 <a:solidFill>
-                  <a:srgbClr val="6B7280"/>
+                  <a:srgbClr val="6F7877"/>
                 </a:solidFill>
                 <a:latin typeface="+mn-lt"/>
               </a:defRPr>
@@ -1796,7 +1796,7 @@
             <a:pPr>
               <a:defRPr sz="1300" b="1" i="0" u="none" strike="noStrike">
                 <a:solidFill>
-                  <a:srgbClr val="1A1A1A"/>
+                  <a:srgbClr val="2C3639"/>
                 </a:solidFill>
                 <a:latin typeface="+mn-lt"/>
               </a:defRPr>
@@ -1804,11 +1804,11 @@
             <a:r>
               <a:rPr sz="1300" b="1" i="0" u="none" strike="noStrike">
                 <a:solidFill>
-                  <a:srgbClr val="1A1A1A"/>
+                  <a:srgbClr val="2C3639"/>
                 </a:solidFill>
                 <a:latin typeface="+mn-lt"/>
               </a:rPr>
-              <a:t>Error on held-out campaign (pp, lower = better)</a:t>
+              <a:t>Figure 10. Error, pp (lower = better)</a:t>
             </a:r>
           </a:p>
         </c:rich>
@@ -1839,7 +1839,7 @@
           </c:tx>
           <c:spPr>
             <a:solidFill>
-              <a:srgbClr val="A7AEB8"/>
+              <a:srgbClr val="C4BEB0"/>
             </a:solidFill>
             <a:effectLst/>
           </c:spPr>
@@ -1853,7 +1853,7 @@
                 <a:pPr>
                   <a:defRPr b="0" i="0" strike="noStrike" sz="1300" u="none">
                     <a:solidFill>
-                      <a:srgbClr val="1A1A1A"/>
+                      <a:srgbClr val="2C3639"/>
                     </a:solidFill>
                     <a:latin typeface="+mn-lt"/>
                   </a:defRPr>
@@ -1874,7 +1874,7 @@
             <c:bubble3D val="0"/>
             <c:spPr>
               <a:solidFill>
-                <a:srgbClr val="A7AEB8"/>
+                <a:srgbClr val="C4BEB0"/>
               </a:solidFill>
               <a:effectLst/>
             </c:spPr>
@@ -1885,7 +1885,7 @@
             <c:bubble3D val="0"/>
             <c:spPr>
               <a:solidFill>
-                <a:srgbClr val="A7AEB8"/>
+                <a:srgbClr val="C4BEB0"/>
               </a:solidFill>
               <a:effectLst/>
             </c:spPr>
@@ -1896,7 +1896,7 @@
             <c:bubble3D val="0"/>
             <c:spPr>
               <a:solidFill>
-                <a:srgbClr val="A7AEB8"/>
+                <a:srgbClr val="C4BEB0"/>
               </a:solidFill>
               <a:effectLst/>
             </c:spPr>
@@ -1907,7 +1907,7 @@
             <c:bubble3D val="0"/>
             <c:spPr>
               <a:solidFill>
-                <a:srgbClr val="A7AEB8"/>
+                <a:srgbClr val="C4BEB0"/>
               </a:solidFill>
               <a:effectLst/>
             </c:spPr>
@@ -1918,7 +1918,7 @@
             <c:bubble3D val="0"/>
             <c:spPr>
               <a:solidFill>
-                <a:srgbClr val="A7AEB8"/>
+                <a:srgbClr val="C4BEB0"/>
               </a:solidFill>
               <a:effectLst/>
             </c:spPr>
@@ -1929,7 +1929,7 @@
             <c:bubble3D val="0"/>
             <c:spPr>
               <a:solidFill>
-                <a:srgbClr val="1F3A5F"/>
+                <a:srgbClr val="2C3639"/>
               </a:solidFill>
               <a:effectLst/>
             </c:spPr>
@@ -1940,7 +1940,7 @@
             <c:bubble3D val="0"/>
             <c:spPr>
               <a:solidFill>
-                <a:srgbClr val="A23B2A"/>
+                <a:srgbClr val="A27B5C"/>
               </a:solidFill>
               <a:effectLst/>
             </c:spPr>
@@ -2016,7 +2016,7 @@
               <a:pPr>
                 <a:defRPr b="0" i="0" strike="noStrike" sz="1300" u="none">
                   <a:solidFill>
-                    <a:srgbClr val="1A1A1A"/>
+                    <a:srgbClr val="2C3639"/>
                   </a:solidFill>
                   <a:latin typeface="+mn-lt"/>
                 </a:defRPr>
@@ -2051,7 +2051,7 @@
         <c:spPr>
           <a:ln w="12700" cap="flat">
             <a:solidFill>
-              <a:srgbClr val="9AA3AE"/>
+              <a:srgbClr val="A9A598"/>
             </a:solidFill>
             <a:prstDash val="solid"/>
             <a:round/>
@@ -2064,7 +2064,7 @@
             <a:pPr>
               <a:defRPr sz="1400" b="0" i="0" u="none" strike="noStrike">
                 <a:solidFill>
-                  <a:srgbClr val="1A1A1A"/>
+                  <a:srgbClr val="2C3639"/>
                 </a:solidFill>
                 <a:latin typeface="+mn-lt"/>
               </a:defRPr>
@@ -2091,7 +2091,7 @@
           <c:spPr>
             <a:ln w="9525" cap="flat">
               <a:solidFill>
-                <a:srgbClr val="E5E7EB"/>
+                <a:srgbClr val="E8E4DA"/>
               </a:solidFill>
               <a:prstDash val="solid"/>
               <a:round/>
@@ -2116,7 +2116,7 @@
             <a:pPr>
               <a:defRPr sz="1200" b="0" i="0" u="none" strike="noStrike">
                 <a:solidFill>
-                  <a:srgbClr val="6B7280"/>
+                  <a:srgbClr val="6F7877"/>
                 </a:solidFill>
                 <a:latin typeface="+mn-lt"/>
               </a:defRPr>
@@ -2167,7 +2167,7 @@
             <a:pPr>
               <a:defRPr sz="1300" b="1" i="0" u="none" strike="noStrike">
                 <a:solidFill>
-                  <a:srgbClr val="1A1A1A"/>
+                  <a:srgbClr val="2C3639"/>
                 </a:solidFill>
                 <a:latin typeface="+mn-lt"/>
               </a:defRPr>
@@ -2175,11 +2175,11 @@
             <a:r>
               <a:rPr sz="1300" b="1" i="0" u="none" strike="noStrike">
                 <a:solidFill>
-                  <a:srgbClr val="1A1A1A"/>
+                  <a:srgbClr val="2C3639"/>
                 </a:solidFill>
                 <a:latin typeface="+mn-lt"/>
               </a:rPr>
-              <a:t>Differences explained (R², higher = better)</a:t>
+              <a:t>Figure 11. R² (higher = better)</a:t>
             </a:r>
           </a:p>
         </c:rich>
@@ -2210,7 +2210,7 @@
           </c:tx>
           <c:spPr>
             <a:solidFill>
-              <a:srgbClr val="A7AEB8"/>
+              <a:srgbClr val="C4BEB0"/>
             </a:solidFill>
             <a:effectLst/>
           </c:spPr>
@@ -2224,7 +2224,7 @@
                 <a:pPr>
                   <a:defRPr b="0" i="0" strike="noStrike" sz="1300" u="none">
                     <a:solidFill>
-                      <a:srgbClr val="1A1A1A"/>
+                      <a:srgbClr val="2C3639"/>
                     </a:solidFill>
                     <a:latin typeface="+mn-lt"/>
                   </a:defRPr>
@@ -2245,7 +2245,7 @@
             <c:bubble3D val="0"/>
             <c:spPr>
               <a:solidFill>
-                <a:srgbClr val="A7AEB8"/>
+                <a:srgbClr val="C4BEB0"/>
               </a:solidFill>
               <a:effectLst/>
             </c:spPr>
@@ -2256,7 +2256,7 @@
             <c:bubble3D val="0"/>
             <c:spPr>
               <a:solidFill>
-                <a:srgbClr val="A7AEB8"/>
+                <a:srgbClr val="C4BEB0"/>
               </a:solidFill>
               <a:effectLst/>
             </c:spPr>
@@ -2267,7 +2267,7 @@
             <c:bubble3D val="0"/>
             <c:spPr>
               <a:solidFill>
-                <a:srgbClr val="A7AEB8"/>
+                <a:srgbClr val="C4BEB0"/>
               </a:solidFill>
               <a:effectLst/>
             </c:spPr>
@@ -2278,7 +2278,7 @@
             <c:bubble3D val="0"/>
             <c:spPr>
               <a:solidFill>
-                <a:srgbClr val="A7AEB8"/>
+                <a:srgbClr val="C4BEB0"/>
               </a:solidFill>
               <a:effectLst/>
             </c:spPr>
@@ -2289,7 +2289,7 @@
             <c:bubble3D val="0"/>
             <c:spPr>
               <a:solidFill>
-                <a:srgbClr val="A7AEB8"/>
+                <a:srgbClr val="C4BEB0"/>
               </a:solidFill>
               <a:effectLst/>
             </c:spPr>
@@ -2300,7 +2300,7 @@
             <c:bubble3D val="0"/>
             <c:spPr>
               <a:solidFill>
-                <a:srgbClr val="1F3A5F"/>
+                <a:srgbClr val="2C3639"/>
               </a:solidFill>
               <a:effectLst/>
             </c:spPr>
@@ -2311,7 +2311,7 @@
             <c:bubble3D val="0"/>
             <c:spPr>
               <a:solidFill>
-                <a:srgbClr val="A23B2A"/>
+                <a:srgbClr val="A27B5C"/>
               </a:solidFill>
               <a:effectLst/>
             </c:spPr>
@@ -2387,7 +2387,7 @@
               <a:pPr>
                 <a:defRPr b="0" i="0" strike="noStrike" sz="1300" u="none">
                   <a:solidFill>
-                    <a:srgbClr val="1A1A1A"/>
+                    <a:srgbClr val="2C3639"/>
                   </a:solidFill>
                   <a:latin typeface="+mn-lt"/>
                 </a:defRPr>
@@ -2422,7 +2422,7 @@
         <c:spPr>
           <a:ln w="12700" cap="flat">
             <a:solidFill>
-              <a:srgbClr val="9AA3AE"/>
+              <a:srgbClr val="A9A598"/>
             </a:solidFill>
             <a:prstDash val="solid"/>
             <a:round/>
@@ -2435,7 +2435,7 @@
             <a:pPr>
               <a:defRPr sz="1400" b="0" i="0" u="none" strike="noStrike">
                 <a:solidFill>
-                  <a:srgbClr val="1A1A1A"/>
+                  <a:srgbClr val="2C3639"/>
                 </a:solidFill>
                 <a:latin typeface="+mn-lt"/>
               </a:defRPr>
@@ -2462,7 +2462,7 @@
           <c:spPr>
             <a:ln w="9525" cap="flat">
               <a:solidFill>
-                <a:srgbClr val="E5E7EB"/>
+                <a:srgbClr val="E8E4DA"/>
               </a:solidFill>
               <a:prstDash val="solid"/>
               <a:round/>
@@ -2487,7 +2487,7 @@
             <a:pPr>
               <a:defRPr sz="1200" b="0" i="0" u="none" strike="noStrike">
                 <a:solidFill>
-                  <a:srgbClr val="6B7280"/>
+                  <a:srgbClr val="6F7877"/>
                 </a:solidFill>
                 <a:latin typeface="+mn-lt"/>
               </a:defRPr>
@@ -4085,7 +4085,7 @@
             <a:r>
               <a:rPr lang="en-US" dirty="0"/>
               <a:t>Part 1 (Niloufar), about forty-five seconds.
-When we submitted the abstract, our dataset held 15 bed-rest studies, covering 14 to 119 days of unloading. After submission we extended it. The final dataset has 52 studies, published from 1992 to 2026, and covers 5 to 180 days. The red part of the lower bar is not bed rest: the stretch beyond 119 days comes from spaceflight, where three studies measured crews after about 180 days.
+When we submitted the abstract, our dataset held 15 bed-rest studies, covering 14 to 119 days of unloading. After submission we extended it. The final dataset has 52 studies, published from 1992 to 2026, and covers 5 to 180 days. The brown part of the lower bar is not bed rest: the stretch beyond 119 days comes from spaceflight, where three studies measured crews after about 180 days.
 The chart below shows how many of these studies were published each year, and the colours show how long the unloading lasted. Most of the literature is recent: 37 of the 52 studies are from 2016 or later. Short studies of up to two weeks are the most common; long campaigns of two to four months are rarer.</a:t>
             </a:r>
             <a:endParaRPr lang="en-US" dirty="0"/>
@@ -5380,7 +5380,7 @@
           <a:noFill/>
           <a:ln w="9525">
             <a:solidFill>
-              <a:srgbClr val="9AA3AE"/>
+              <a:srgbClr val="A9A598"/>
             </a:solidFill>
             <a:prstDash val="solid"/>
           </a:ln>
@@ -5405,7 +5405,7 @@
           </a:solidFill>
           <a:ln w="9525">
             <a:solidFill>
-              <a:srgbClr val="1F3A5F"/>
+              <a:srgbClr val="2C3639"/>
             </a:solidFill>
             <a:prstDash val="solid"/>
           </a:ln>
@@ -5430,7 +5430,7 @@
           </a:solidFill>
           <a:ln w="9525">
             <a:solidFill>
-              <a:srgbClr val="1F3A5F"/>
+              <a:srgbClr val="2C3639"/>
             </a:solidFill>
             <a:prstDash val="solid"/>
           </a:ln>
@@ -5455,7 +5455,7 @@
           </a:solidFill>
           <a:ln w="9525">
             <a:solidFill>
-              <a:srgbClr val="1F3A5F"/>
+              <a:srgbClr val="2C3639"/>
             </a:solidFill>
             <a:prstDash val="solid"/>
           </a:ln>
@@ -5480,7 +5480,7 @@
           </a:solidFill>
           <a:ln w="9525">
             <a:solidFill>
-              <a:srgbClr val="1F3A5F"/>
+              <a:srgbClr val="2C3639"/>
             </a:solidFill>
             <a:prstDash val="solid"/>
           </a:ln>
@@ -5505,7 +5505,7 @@
           </a:solidFill>
           <a:ln w="9525">
             <a:solidFill>
-              <a:srgbClr val="A23B2A"/>
+              <a:srgbClr val="A27B5C"/>
             </a:solidFill>
             <a:prstDash val="solid"/>
           </a:ln>
@@ -5530,7 +5530,7 @@
           </a:solidFill>
           <a:ln w="9525">
             <a:solidFill>
-              <a:srgbClr val="9AA3AE"/>
+              <a:srgbClr val="A9A598"/>
             </a:solidFill>
             <a:prstDash val="solid"/>
           </a:ln>
@@ -5632,7 +5632,7 @@
           </a:solidFill>
           <a:ln w="12700">
             <a:solidFill>
-              <a:srgbClr val="9AA3AE"/>
+              <a:srgbClr val="A9A598"/>
             </a:solidFill>
             <a:prstDash val="solid"/>
           </a:ln>
@@ -5970,7 +5970,7 @@
           <a:noFill/>
           <a:ln w="15875">
             <a:solidFill>
-              <a:srgbClr val="1A1A1A"/>
+              <a:srgbClr val="2C3639"/>
             </a:solidFill>
             <a:prstDash val="solid"/>
             <a:tailEnd type="triangle"/>
@@ -5996,7 +5996,7 @@
           </a:solidFill>
           <a:ln w="12700">
             <a:solidFill>
-              <a:srgbClr val="9AA3AE"/>
+              <a:srgbClr val="A9A598"/>
             </a:solidFill>
             <a:prstDash val="solid"/>
           </a:ln>
@@ -6083,7 +6083,7 @@
           <a:noFill/>
           <a:ln w="15875">
             <a:solidFill>
-              <a:srgbClr val="1A1A1A"/>
+              <a:srgbClr val="2C3639"/>
             </a:solidFill>
             <a:prstDash val="solid"/>
             <a:tailEnd type="triangle"/>
@@ -6334,7 +6334,7 @@
           <a:noFill/>
           <a:ln w="9525">
             <a:solidFill>
-              <a:srgbClr val="9AA3AE"/>
+              <a:srgbClr val="A9A598"/>
             </a:solidFill>
             <a:prstDash val="solid"/>
           </a:ln>
@@ -6359,7 +6359,7 @@
           </a:solidFill>
           <a:ln w="9525">
             <a:solidFill>
-              <a:srgbClr val="1F3A5F"/>
+              <a:srgbClr val="2C3639"/>
             </a:solidFill>
             <a:prstDash val="solid"/>
           </a:ln>
@@ -6384,7 +6384,7 @@
           </a:solidFill>
           <a:ln w="9525">
             <a:solidFill>
-              <a:srgbClr val="1F3A5F"/>
+              <a:srgbClr val="2C3639"/>
             </a:solidFill>
             <a:prstDash val="solid"/>
           </a:ln>
@@ -6409,7 +6409,7 @@
           </a:solidFill>
           <a:ln w="9525">
             <a:solidFill>
-              <a:srgbClr val="1F3A5F"/>
+              <a:srgbClr val="2C3639"/>
             </a:solidFill>
             <a:prstDash val="solid"/>
           </a:ln>
@@ -6434,7 +6434,7 @@
           </a:solidFill>
           <a:ln w="9525">
             <a:solidFill>
-              <a:srgbClr val="1F3A5F"/>
+              <a:srgbClr val="2C3639"/>
             </a:solidFill>
             <a:prstDash val="solid"/>
           </a:ln>
@@ -6459,7 +6459,7 @@
           </a:solidFill>
           <a:ln w="9525">
             <a:solidFill>
-              <a:srgbClr val="A23B2A"/>
+              <a:srgbClr val="A27B5C"/>
             </a:solidFill>
             <a:prstDash val="solid"/>
           </a:ln>
@@ -6484,7 +6484,7 @@
           </a:solidFill>
           <a:ln w="9525">
             <a:solidFill>
-              <a:srgbClr val="9AA3AE"/>
+              <a:srgbClr val="A9A598"/>
             </a:solidFill>
             <a:prstDash val="solid"/>
           </a:ln>
@@ -6798,7 +6798,7 @@
           <a:noFill/>
           <a:ln w="9525">
             <a:solidFill>
-              <a:srgbClr val="9AA3AE"/>
+              <a:srgbClr val="A9A598"/>
             </a:solidFill>
             <a:prstDash val="solid"/>
           </a:ln>
@@ -6823,7 +6823,7 @@
           </a:solidFill>
           <a:ln w="9525">
             <a:solidFill>
-              <a:srgbClr val="1F3A5F"/>
+              <a:srgbClr val="2C3639"/>
             </a:solidFill>
             <a:prstDash val="solid"/>
           </a:ln>
@@ -6848,7 +6848,7 @@
           </a:solidFill>
           <a:ln w="9525">
             <a:solidFill>
-              <a:srgbClr val="1F3A5F"/>
+              <a:srgbClr val="2C3639"/>
             </a:solidFill>
             <a:prstDash val="solid"/>
           </a:ln>
@@ -6873,7 +6873,7 @@
           </a:solidFill>
           <a:ln w="9525">
             <a:solidFill>
-              <a:srgbClr val="1F3A5F"/>
+              <a:srgbClr val="2C3639"/>
             </a:solidFill>
             <a:prstDash val="solid"/>
           </a:ln>
@@ -6898,7 +6898,7 @@
           </a:solidFill>
           <a:ln w="9525">
             <a:solidFill>
-              <a:srgbClr val="1F3A5F"/>
+              <a:srgbClr val="2C3639"/>
             </a:solidFill>
             <a:prstDash val="solid"/>
           </a:ln>
@@ -6923,7 +6923,7 @@
           </a:solidFill>
           <a:ln w="9525">
             <a:solidFill>
-              <a:srgbClr val="A23B2A"/>
+              <a:srgbClr val="A27B5C"/>
             </a:solidFill>
             <a:prstDash val="solid"/>
           </a:ln>
@@ -6948,7 +6948,7 @@
           </a:solidFill>
           <a:ln w="9525">
             <a:solidFill>
-              <a:srgbClr val="9AA3AE"/>
+              <a:srgbClr val="A9A598"/>
             </a:solidFill>
             <a:prstDash val="solid"/>
           </a:ln>
@@ -7476,7 +7476,7 @@
           <a:noFill/>
           <a:ln w="9525">
             <a:solidFill>
-              <a:srgbClr val="9AA3AE"/>
+              <a:srgbClr val="A9A598"/>
             </a:solidFill>
             <a:prstDash val="solid"/>
           </a:ln>
@@ -7501,7 +7501,7 @@
           </a:solidFill>
           <a:ln w="9525">
             <a:solidFill>
-              <a:srgbClr val="1F3A5F"/>
+              <a:srgbClr val="2C3639"/>
             </a:solidFill>
             <a:prstDash val="solid"/>
           </a:ln>
@@ -7526,7 +7526,7 @@
           </a:solidFill>
           <a:ln w="9525">
             <a:solidFill>
-              <a:srgbClr val="1F3A5F"/>
+              <a:srgbClr val="2C3639"/>
             </a:solidFill>
             <a:prstDash val="solid"/>
           </a:ln>
@@ -7551,7 +7551,7 @@
           </a:solidFill>
           <a:ln w="9525">
             <a:solidFill>
-              <a:srgbClr val="1F3A5F"/>
+              <a:srgbClr val="2C3639"/>
             </a:solidFill>
             <a:prstDash val="solid"/>
           </a:ln>
@@ -7576,7 +7576,7 @@
           </a:solidFill>
           <a:ln w="9525">
             <a:solidFill>
-              <a:srgbClr val="1F3A5F"/>
+              <a:srgbClr val="2C3639"/>
             </a:solidFill>
             <a:prstDash val="solid"/>
           </a:ln>
@@ -7601,7 +7601,7 @@
           </a:solidFill>
           <a:ln w="9525">
             <a:solidFill>
-              <a:srgbClr val="1F3A5F"/>
+              <a:srgbClr val="2C3639"/>
             </a:solidFill>
             <a:prstDash val="solid"/>
           </a:ln>
@@ -7626,7 +7626,7 @@
           </a:solidFill>
           <a:ln w="9525">
             <a:solidFill>
-              <a:srgbClr val="A23B2A"/>
+              <a:srgbClr val="A27B5C"/>
             </a:solidFill>
             <a:prstDash val="solid"/>
           </a:ln>
@@ -8648,7 +8648,7 @@
                   <a:schemeClr val="tx2"/>
                 </a:solidFill>
               </a:rPr>
-              <a:t>Sources (searched 4 September 2026)</a:t>
+              <a:t>Table 3. Sources (searched 4 September 2026)</a:t>
             </a:r>
             <a:endParaRPr lang="en-US" sz="1500" dirty="0"/>
           </a:p>
@@ -8719,7 +8719,7 @@
                     </a:lnT>
                     <a:lnB w="9525" cap="flat" cmpd="sng" algn="ctr">
                       <a:solidFill>
-                        <a:srgbClr val="E5E7EB"/>
+                        <a:srgbClr val="E8E4DA"/>
                       </a:solidFill>
                       <a:prstDash val="solid"/>
                       <a:round/>
@@ -8727,7 +8727,7 @@
                       <a:tailEnd type="none" w="med" len="med"/>
                     </a:lnB>
                     <a:solidFill>
-                      <a:srgbClr val="1F3A5F"/>
+                      <a:srgbClr val="2C3639"/>
                     </a:solidFill>
                   </a:tcPr>
                 </a:tc>
@@ -8769,7 +8769,7 @@
                     </a:lnT>
                     <a:lnB w="9525" cap="flat" cmpd="sng" algn="ctr">
                       <a:solidFill>
-                        <a:srgbClr val="E5E7EB"/>
+                        <a:srgbClr val="E8E4DA"/>
                       </a:solidFill>
                       <a:prstDash val="solid"/>
                       <a:round/>
@@ -8777,7 +8777,7 @@
                       <a:tailEnd type="none" w="med" len="med"/>
                     </a:lnB>
                     <a:solidFill>
-                      <a:srgbClr val="1F3A5F"/>
+                      <a:srgbClr val="2C3639"/>
                     </a:solidFill>
                   </a:tcPr>
                 </a:tc>
@@ -8794,7 +8794,7 @@
                       <a:r>
                         <a:rPr lang="en-US" sz="1300" dirty="0">
                           <a:solidFill>
-                            <a:srgbClr val="1A1A1A"/>
+                            <a:srgbClr val="2C3639"/>
                           </a:solidFill>
                           <a:latin typeface="Calibri" pitchFamily="34" charset="0"/>
                           <a:ea typeface="Calibri" pitchFamily="34" charset="-122"/>
@@ -8821,7 +8821,7 @@
                     </a:lnT>
                     <a:lnB w="9525" cap="flat" cmpd="sng" algn="ctr">
                       <a:solidFill>
-                        <a:srgbClr val="E5E7EB"/>
+                        <a:srgbClr val="E8E4DA"/>
                       </a:solidFill>
                       <a:prstDash val="solid"/>
                       <a:round/>
@@ -8841,7 +8841,7 @@
                       <a:r>
                         <a:rPr lang="en-US" sz="1300" dirty="0">
                           <a:solidFill>
-                            <a:srgbClr val="1A1A1A"/>
+                            <a:srgbClr val="2C3639"/>
                           </a:solidFill>
                           <a:latin typeface="Calibri" pitchFamily="34" charset="0"/>
                           <a:ea typeface="Calibri" pitchFamily="34" charset="-122"/>
@@ -8868,7 +8868,7 @@
                     </a:lnT>
                     <a:lnB w="9525" cap="flat" cmpd="sng" algn="ctr">
                       <a:solidFill>
-                        <a:srgbClr val="E5E7EB"/>
+                        <a:srgbClr val="E8E4DA"/>
                       </a:solidFill>
                       <a:prstDash val="solid"/>
                       <a:round/>
@@ -8890,7 +8890,7 @@
                       <a:r>
                         <a:rPr lang="en-US" sz="1300" dirty="0">
                           <a:solidFill>
-                            <a:srgbClr val="1A1A1A"/>
+                            <a:srgbClr val="2C3639"/>
                           </a:solidFill>
                           <a:latin typeface="Calibri" pitchFamily="34" charset="0"/>
                           <a:ea typeface="Calibri" pitchFamily="34" charset="-122"/>
@@ -8917,7 +8917,7 @@
                     </a:lnT>
                     <a:lnB w="9525" cap="flat" cmpd="sng" algn="ctr">
                       <a:solidFill>
-                        <a:srgbClr val="E5E7EB"/>
+                        <a:srgbClr val="E8E4DA"/>
                       </a:solidFill>
                       <a:prstDash val="solid"/>
                       <a:round/>
@@ -8937,7 +8937,7 @@
                       <a:r>
                         <a:rPr lang="en-US" sz="1300" dirty="0">
                           <a:solidFill>
-                            <a:srgbClr val="1A1A1A"/>
+                            <a:srgbClr val="2C3639"/>
                           </a:solidFill>
                           <a:latin typeface="Calibri" pitchFamily="34" charset="0"/>
                           <a:ea typeface="Calibri" pitchFamily="34" charset="-122"/>
@@ -8964,7 +8964,7 @@
                     </a:lnT>
                     <a:lnB w="9525" cap="flat" cmpd="sng" algn="ctr">
                       <a:solidFill>
-                        <a:srgbClr val="E5E7EB"/>
+                        <a:srgbClr val="E8E4DA"/>
                       </a:solidFill>
                       <a:prstDash val="solid"/>
                       <a:round/>
@@ -8986,7 +8986,7 @@
                       <a:r>
                         <a:rPr lang="en-US" sz="1300" dirty="0">
                           <a:solidFill>
-                            <a:srgbClr val="1A1A1A"/>
+                            <a:srgbClr val="2C3639"/>
                           </a:solidFill>
                           <a:latin typeface="Calibri" pitchFamily="34" charset="0"/>
                           <a:ea typeface="Calibri" pitchFamily="34" charset="-122"/>
@@ -9013,7 +9013,7 @@
                     </a:lnT>
                     <a:lnB w="9525" cap="flat" cmpd="sng" algn="ctr">
                       <a:solidFill>
-                        <a:srgbClr val="E5E7EB"/>
+                        <a:srgbClr val="E8E4DA"/>
                       </a:solidFill>
                       <a:prstDash val="solid"/>
                       <a:round/>
@@ -9033,7 +9033,7 @@
                       <a:r>
                         <a:rPr lang="en-US" sz="1300" dirty="0">
                           <a:solidFill>
-                            <a:srgbClr val="1A1A1A"/>
+                            <a:srgbClr val="2C3639"/>
                           </a:solidFill>
                           <a:latin typeface="Calibri" pitchFamily="34" charset="0"/>
                           <a:ea typeface="Calibri" pitchFamily="34" charset="-122"/>
@@ -9060,7 +9060,7 @@
                     </a:lnT>
                     <a:lnB w="9525" cap="flat" cmpd="sng" algn="ctr">
                       <a:solidFill>
-                        <a:srgbClr val="E5E7EB"/>
+                        <a:srgbClr val="E8E4DA"/>
                       </a:solidFill>
                       <a:prstDash val="solid"/>
                       <a:round/>
@@ -9082,7 +9082,7 @@
                       <a:r>
                         <a:rPr lang="en-US" sz="1300" dirty="0">
                           <a:solidFill>
-                            <a:srgbClr val="1A1A1A"/>
+                            <a:srgbClr val="2C3639"/>
                           </a:solidFill>
                           <a:latin typeface="Calibri" pitchFamily="34" charset="0"/>
                           <a:ea typeface="Calibri" pitchFamily="34" charset="-122"/>
@@ -9109,7 +9109,7 @@
                     </a:lnT>
                     <a:lnB w="9525" cap="flat" cmpd="sng" algn="ctr">
                       <a:solidFill>
-                        <a:srgbClr val="E5E7EB"/>
+                        <a:srgbClr val="E8E4DA"/>
                       </a:solidFill>
                       <a:prstDash val="solid"/>
                       <a:round/>
@@ -9129,7 +9129,7 @@
                       <a:r>
                         <a:rPr lang="en-US" sz="1300" dirty="0">
                           <a:solidFill>
-                            <a:srgbClr val="1A1A1A"/>
+                            <a:srgbClr val="2C3639"/>
                           </a:solidFill>
                           <a:latin typeface="Calibri" pitchFamily="34" charset="0"/>
                           <a:ea typeface="Calibri" pitchFamily="34" charset="-122"/>
@@ -9156,7 +9156,7 @@
                     </a:lnT>
                     <a:lnB w="9525" cap="flat" cmpd="sng" algn="ctr">
                       <a:solidFill>
-                        <a:srgbClr val="E5E7EB"/>
+                        <a:srgbClr val="E8E4DA"/>
                       </a:solidFill>
                       <a:prstDash val="solid"/>
                       <a:round/>
@@ -9178,7 +9178,7 @@
                       <a:r>
                         <a:rPr lang="en-US" sz="1300" dirty="0">
                           <a:solidFill>
-                            <a:srgbClr val="1A1A1A"/>
+                            <a:srgbClr val="2C3639"/>
                           </a:solidFill>
                           <a:latin typeface="Calibri" pitchFamily="34" charset="0"/>
                           <a:ea typeface="Calibri" pitchFamily="34" charset="-122"/>
@@ -9205,7 +9205,7 @@
                     </a:lnT>
                     <a:lnB w="9525" cap="flat" cmpd="sng" algn="ctr">
                       <a:solidFill>
-                        <a:srgbClr val="E5E7EB"/>
+                        <a:srgbClr val="E8E4DA"/>
                       </a:solidFill>
                       <a:prstDash val="solid"/>
                       <a:round/>
@@ -9225,7 +9225,7 @@
                       <a:r>
                         <a:rPr lang="en-US" sz="1300" dirty="0">
                           <a:solidFill>
-                            <a:srgbClr val="1A1A1A"/>
+                            <a:srgbClr val="2C3639"/>
                           </a:solidFill>
                           <a:latin typeface="Calibri" pitchFamily="34" charset="0"/>
                           <a:ea typeface="Calibri" pitchFamily="34" charset="-122"/>
@@ -9252,7 +9252,7 @@
                     </a:lnT>
                     <a:lnB w="9525" cap="flat" cmpd="sng" algn="ctr">
                       <a:solidFill>
-                        <a:srgbClr val="E5E7EB"/>
+                        <a:srgbClr val="E8E4DA"/>
                       </a:solidFill>
                       <a:prstDash val="solid"/>
                       <a:round/>
@@ -9274,7 +9274,7 @@
                       <a:r>
                         <a:rPr lang="en-US" sz="1300" b="1" dirty="0">
                           <a:solidFill>
-                            <a:srgbClr val="1A1A1A"/>
+                            <a:srgbClr val="2C3639"/>
                           </a:solidFill>
                           <a:latin typeface="Calibri" pitchFamily="34" charset="0"/>
                           <a:ea typeface="Calibri" pitchFamily="34" charset="-122"/>
@@ -9301,7 +9301,7 @@
                     </a:lnT>
                     <a:lnB w="9525" cap="flat" cmpd="sng" algn="ctr">
                       <a:solidFill>
-                        <a:srgbClr val="E5E7EB"/>
+                        <a:srgbClr val="E8E4DA"/>
                       </a:solidFill>
                       <a:prstDash val="solid"/>
                       <a:round/>
@@ -9321,7 +9321,7 @@
                       <a:r>
                         <a:rPr lang="en-US" sz="1300" b="1" dirty="0">
                           <a:solidFill>
-                            <a:srgbClr val="1A1A1A"/>
+                            <a:srgbClr val="2C3639"/>
                           </a:solidFill>
                           <a:latin typeface="Calibri" pitchFamily="34" charset="0"/>
                           <a:ea typeface="Calibri" pitchFamily="34" charset="-122"/>
@@ -9348,7 +9348,7 @@
                     </a:lnT>
                     <a:lnB w="9525" cap="flat" cmpd="sng" algn="ctr">
                       <a:solidFill>
-                        <a:srgbClr val="E5E7EB"/>
+                        <a:srgbClr val="E8E4DA"/>
                       </a:solidFill>
                       <a:prstDash val="solid"/>
                       <a:round/>
@@ -9486,7 +9486,7 @@
                   <a:schemeClr val="tx2"/>
                 </a:solidFill>
               </a:rPr>
-              <a:t>Query: two required blocks</a:t>
+              <a:t>Figure 12. Query: two required blocks</a:t>
             </a:r>
             <a:endParaRPr lang="en-US" sz="1500" dirty="0"/>
           </a:p>
@@ -9511,7 +9511,7 @@
           </a:solidFill>
           <a:ln w="12700">
             <a:solidFill>
-              <a:srgbClr val="9AA3AE"/>
+              <a:srgbClr val="A9A598"/>
             </a:solidFill>
             <a:prstDash val="solid"/>
           </a:ln>
@@ -9622,7 +9622,7 @@
           </a:solidFill>
           <a:ln w="12700">
             <a:solidFill>
-              <a:srgbClr val="9AA3AE"/>
+              <a:srgbClr val="A9A598"/>
             </a:solidFill>
             <a:prstDash val="solid"/>
           </a:ln>
@@ -9733,7 +9733,7 @@
           </a:solidFill>
           <a:ln w="12700">
             <a:solidFill>
-              <a:srgbClr val="9AA3AE"/>
+              <a:srgbClr val="A9A598"/>
             </a:solidFill>
             <a:prstDash val="dash"/>
           </a:ln>
@@ -11523,7 +11523,7 @@
           <a:noFill/>
           <a:ln w="19050">
             <a:solidFill>
-              <a:srgbClr val="9AA3AE"/>
+              <a:srgbClr val="A9A598"/>
             </a:solidFill>
             <a:prstDash val="solid"/>
           </a:ln>
@@ -11546,7 +11546,7 @@
           <a:noFill/>
           <a:ln w="12700">
             <a:solidFill>
-              <a:srgbClr val="1F3A5F"/>
+              <a:srgbClr val="2C3639"/>
             </a:solidFill>
             <a:prstDash val="solid"/>
           </a:ln>
@@ -11569,7 +11569,7 @@
           <a:noFill/>
           <a:ln w="12700">
             <a:solidFill>
-              <a:srgbClr val="1F3A5F"/>
+              <a:srgbClr val="2C3639"/>
             </a:solidFill>
             <a:prstDash val="solid"/>
           </a:ln>
@@ -11592,7 +11592,7 @@
           <a:noFill/>
           <a:ln w="12700">
             <a:solidFill>
-              <a:srgbClr val="1F3A5F"/>
+              <a:srgbClr val="2C3639"/>
             </a:solidFill>
             <a:prstDash val="solid"/>
           </a:ln>
@@ -11665,7 +11665,7 @@
           <a:noFill/>
           <a:ln w="12700">
             <a:solidFill>
-              <a:srgbClr val="1F3A5F"/>
+              <a:srgbClr val="2C3639"/>
             </a:solidFill>
             <a:prstDash val="solid"/>
           </a:ln>
@@ -11688,7 +11688,7 @@
           <a:noFill/>
           <a:ln w="12700">
             <a:solidFill>
-              <a:srgbClr val="1F3A5F"/>
+              <a:srgbClr val="2C3639"/>
             </a:solidFill>
             <a:prstDash val="solid"/>
           </a:ln>
@@ -11711,7 +11711,7 @@
           <a:noFill/>
           <a:ln w="12700">
             <a:solidFill>
-              <a:srgbClr val="1F3A5F"/>
+              <a:srgbClr val="2C3639"/>
             </a:solidFill>
             <a:prstDash val="solid"/>
           </a:ln>
@@ -12526,7 +12526,7 @@
           <a:noFill/>
           <a:ln w="9525">
             <a:solidFill>
-              <a:srgbClr val="9AA3AE"/>
+              <a:srgbClr val="A9A598"/>
             </a:solidFill>
             <a:prstDash val="solid"/>
           </a:ln>
@@ -12551,7 +12551,7 @@
           </a:solidFill>
           <a:ln w="9525">
             <a:solidFill>
-              <a:srgbClr val="A23B2A"/>
+              <a:srgbClr val="A27B5C"/>
             </a:solidFill>
             <a:prstDash val="solid"/>
           </a:ln>
@@ -12576,7 +12576,7 @@
           </a:solidFill>
           <a:ln w="9525">
             <a:solidFill>
-              <a:srgbClr val="9AA3AE"/>
+              <a:srgbClr val="A9A598"/>
             </a:solidFill>
             <a:prstDash val="solid"/>
           </a:ln>
@@ -12601,7 +12601,7 @@
           </a:solidFill>
           <a:ln w="9525">
             <a:solidFill>
-              <a:srgbClr val="9AA3AE"/>
+              <a:srgbClr val="A9A598"/>
             </a:solidFill>
             <a:prstDash val="solid"/>
           </a:ln>
@@ -12626,7 +12626,7 @@
           </a:solidFill>
           <a:ln w="9525">
             <a:solidFill>
-              <a:srgbClr val="9AA3AE"/>
+              <a:srgbClr val="A9A598"/>
             </a:solidFill>
             <a:prstDash val="solid"/>
           </a:ln>
@@ -12651,7 +12651,7 @@
           </a:solidFill>
           <a:ln w="9525">
             <a:solidFill>
-              <a:srgbClr val="9AA3AE"/>
+              <a:srgbClr val="A9A598"/>
             </a:solidFill>
             <a:prstDash val="solid"/>
           </a:ln>
@@ -12676,7 +12676,7 @@
           </a:solidFill>
           <a:ln w="9525">
             <a:solidFill>
-              <a:srgbClr val="9AA3AE"/>
+              <a:srgbClr val="A9A598"/>
             </a:solidFill>
             <a:prstDash val="solid"/>
           </a:ln>
@@ -12938,7 +12938,7 @@
                   <a:schemeClr val="tx2"/>
                 </a:solidFill>
               </a:rPr>
-              <a:t>Unloading shrinks leg muscles</a:t>
+              <a:t>Figure 1. Unloading shrinks leg muscles</a:t>
             </a:r>
             <a:endParaRPr lang="en-US" sz="1400" dirty="0"/>
           </a:p>
@@ -13063,7 +13063,7 @@
           </a:solidFill>
           <a:ln w="12700">
             <a:solidFill>
-              <a:srgbClr val="A23B2A"/>
+              <a:srgbClr val="A27B5C"/>
             </a:solidFill>
             <a:prstDash val="solid"/>
           </a:ln>
@@ -13088,7 +13088,7 @@
           </a:solidFill>
           <a:ln w="12700">
             <a:solidFill>
-              <a:srgbClr val="9AA3AE"/>
+              <a:srgbClr val="A9A598"/>
             </a:solidFill>
             <a:prstDash val="solid"/>
           </a:ln>
@@ -13111,7 +13111,7 @@
           <a:noFill/>
           <a:ln w="15875">
             <a:solidFill>
-              <a:srgbClr val="1A1A1A"/>
+              <a:srgbClr val="2C3639"/>
             </a:solidFill>
             <a:prstDash val="solid"/>
             <a:tailEnd type="triangle"/>
@@ -13139,7 +13139,7 @@
           </a:solidFill>
           <a:ln w="12700">
             <a:solidFill>
-              <a:srgbClr val="A23B2A"/>
+              <a:srgbClr val="A27B5C"/>
             </a:solidFill>
             <a:prstDash val="solid"/>
           </a:ln>
@@ -13164,7 +13164,7 @@
           </a:solidFill>
           <a:ln w="12700">
             <a:solidFill>
-              <a:srgbClr val="9AA3AE"/>
+              <a:srgbClr val="A9A598"/>
             </a:solidFill>
             <a:prstDash val="solid"/>
           </a:ln>
@@ -13186,7 +13186,7 @@
           </a:prstGeom>
           <a:ln w="12700">
             <a:solidFill>
-              <a:srgbClr val="1A1A1A"/>
+              <a:srgbClr val="2C3639"/>
             </a:solidFill>
             <a:prstDash val="dash"/>
           </a:ln>
@@ -13387,7 +13387,7 @@
           <a:noFill/>
           <a:ln w="9525">
             <a:solidFill>
-              <a:srgbClr val="9AA3AE"/>
+              <a:srgbClr val="A9A598"/>
             </a:solidFill>
             <a:prstDash val="solid"/>
           </a:ln>
@@ -13412,7 +13412,7 @@
           </a:solidFill>
           <a:ln w="9525">
             <a:solidFill>
-              <a:srgbClr val="A23B2A"/>
+              <a:srgbClr val="A27B5C"/>
             </a:solidFill>
             <a:prstDash val="solid"/>
           </a:ln>
@@ -13437,7 +13437,7 @@
           </a:solidFill>
           <a:ln w="9525">
             <a:solidFill>
-              <a:srgbClr val="9AA3AE"/>
+              <a:srgbClr val="A9A598"/>
             </a:solidFill>
             <a:prstDash val="solid"/>
           </a:ln>
@@ -13462,7 +13462,7 @@
           </a:solidFill>
           <a:ln w="9525">
             <a:solidFill>
-              <a:srgbClr val="9AA3AE"/>
+              <a:srgbClr val="A9A598"/>
             </a:solidFill>
             <a:prstDash val="solid"/>
           </a:ln>
@@ -13487,7 +13487,7 @@
           </a:solidFill>
           <a:ln w="9525">
             <a:solidFill>
-              <a:srgbClr val="9AA3AE"/>
+              <a:srgbClr val="A9A598"/>
             </a:solidFill>
             <a:prstDash val="solid"/>
           </a:ln>
@@ -13512,7 +13512,7 @@
           </a:solidFill>
           <a:ln w="9525">
             <a:solidFill>
-              <a:srgbClr val="9AA3AE"/>
+              <a:srgbClr val="A9A598"/>
             </a:solidFill>
             <a:prstDash val="solid"/>
           </a:ln>
@@ -13537,7 +13537,7 @@
           </a:solidFill>
           <a:ln w="9525">
             <a:solidFill>
-              <a:srgbClr val="9AA3AE"/>
+              <a:srgbClr val="A9A598"/>
             </a:solidFill>
             <a:prstDash val="solid"/>
           </a:ln>
@@ -13783,7 +13783,7 @@
                   <a:schemeClr val="tx2"/>
                 </a:solidFill>
               </a:rPr>
-              <a:t>Moon mission vs Mars mission</a:t>
+              <a:t>Figure 2. Moon mission vs Mars mission</a:t>
             </a:r>
             <a:endParaRPr lang="en-US" sz="1400" dirty="0"/>
           </a:p>
@@ -13804,7 +13804,7 @@
             <a:avLst/>
           </a:prstGeom>
           <a:solidFill>
-            <a:srgbClr val="1F3A5F"/>
+            <a:srgbClr val="2C3639"/>
           </a:solidFill>
           <a:ln/>
         </p:spPr>
@@ -13884,7 +13884,7 @@
             <a:avLst/>
           </a:prstGeom>
           <a:solidFill>
-            <a:srgbClr val="A7AEB8"/>
+            <a:srgbClr val="C4BEB0"/>
           </a:solidFill>
           <a:ln/>
         </p:spPr>
@@ -13964,7 +13964,7 @@
             <a:avLst/>
           </a:prstGeom>
           <a:solidFill>
-            <a:srgbClr val="A23B2A"/>
+            <a:srgbClr val="A27B5C"/>
           </a:solidFill>
           <a:ln/>
         </p:spPr>
@@ -14046,7 +14046,7 @@
           <a:noFill/>
           <a:ln w="12700">
             <a:solidFill>
-              <a:srgbClr val="6B7280"/>
+              <a:srgbClr val="6F7877"/>
             </a:solidFill>
             <a:prstDash val="dash"/>
             <a:tailEnd type="triangle"/>
@@ -14106,7 +14106,7 @@
           <a:noFill/>
           <a:ln w="12700">
             <a:solidFill>
-              <a:srgbClr val="6B7280"/>
+              <a:srgbClr val="6F7877"/>
             </a:solidFill>
             <a:prstDash val="dash"/>
             <a:tailEnd type="triangle"/>
@@ -14214,7 +14214,7 @@
             <a:avLst/>
           </a:prstGeom>
           <a:solidFill>
-            <a:srgbClr val="6B7280"/>
+            <a:srgbClr val="6F7877"/>
           </a:solidFill>
           <a:ln/>
         </p:spPr>
@@ -14320,7 +14320,7 @@
             <a:avLst/>
           </a:prstGeom>
           <a:solidFill>
-            <a:srgbClr val="A23B2A"/>
+            <a:srgbClr val="A27B5C"/>
           </a:solidFill>
           <a:ln w="12700">
             <a:solidFill>
@@ -14381,7 +14381,7 @@
             <a:avLst/>
           </a:prstGeom>
           <a:solidFill>
-            <a:srgbClr val="A23B2A">
+            <a:srgbClr val="A27B5C">
               <a:alpha val="55000"/>
             </a:srgbClr>
           </a:solidFill>
@@ -14444,7 +14444,7 @@
             <a:avLst/>
           </a:prstGeom>
           <a:solidFill>
-            <a:srgbClr val="A23B2A"/>
+            <a:srgbClr val="A27B5C"/>
           </a:solidFill>
           <a:ln w="12700">
             <a:solidFill>
@@ -14507,7 +14507,7 @@
           <a:noFill/>
           <a:ln w="12700">
             <a:solidFill>
-              <a:srgbClr val="1A1A1A"/>
+              <a:srgbClr val="2C3639"/>
             </a:solidFill>
             <a:prstDash val="solid"/>
             <a:headEnd type="triangle"/>
@@ -14567,7 +14567,7 @@
           <a:noFill/>
           <a:ln w="9525">
             <a:solidFill>
-              <a:srgbClr val="6B7280"/>
+              <a:srgbClr val="6F7877"/>
             </a:solidFill>
             <a:prstDash val="solid"/>
           </a:ln>
@@ -14590,7 +14590,7 @@
           <a:noFill/>
           <a:ln w="9525">
             <a:solidFill>
-              <a:srgbClr val="6B7280"/>
+              <a:srgbClr val="6F7877"/>
             </a:solidFill>
             <a:prstDash val="solid"/>
           </a:ln>
@@ -14649,7 +14649,7 @@
           <a:noFill/>
           <a:ln w="9525">
             <a:solidFill>
-              <a:srgbClr val="6B7280"/>
+              <a:srgbClr val="6F7877"/>
             </a:solidFill>
             <a:prstDash val="solid"/>
           </a:ln>
@@ -14708,7 +14708,7 @@
           <a:noFill/>
           <a:ln w="9525">
             <a:solidFill>
-              <a:srgbClr val="6B7280"/>
+              <a:srgbClr val="6F7877"/>
             </a:solidFill>
             <a:prstDash val="solid"/>
           </a:ln>
@@ -14769,7 +14769,7 @@
           </a:solidFill>
           <a:ln w="12700">
             <a:solidFill>
-              <a:srgbClr val="9AA3AE"/>
+              <a:srgbClr val="A9A598"/>
             </a:solidFill>
             <a:prstDash val="solid"/>
           </a:ln>
@@ -14840,11 +14840,11 @@
             <a:avLst/>
           </a:prstGeom>
           <a:solidFill>
-            <a:srgbClr val="1F3A5F"/>
+            <a:srgbClr val="2C3639"/>
           </a:solidFill>
           <a:ln w="12700">
             <a:solidFill>
-              <a:srgbClr val="1F3A5F"/>
+              <a:srgbClr val="2C3639"/>
             </a:solidFill>
             <a:prstDash val="solid"/>
           </a:ln>
@@ -14919,7 +14919,7 @@
           </a:solidFill>
           <a:ln w="12700">
             <a:solidFill>
-              <a:srgbClr val="9AA3AE"/>
+              <a:srgbClr val="A9A598"/>
             </a:solidFill>
             <a:prstDash val="dash"/>
           </a:ln>
@@ -14980,7 +14980,7 @@
           </a:solidFill>
           <a:ln w="12700">
             <a:solidFill>
-              <a:srgbClr val="9AA3AE"/>
+              <a:srgbClr val="A9A598"/>
             </a:solidFill>
             <a:prstDash val="dash"/>
           </a:ln>
@@ -15039,7 +15039,7 @@
           <a:noFill/>
           <a:ln w="15875">
             <a:solidFill>
-              <a:srgbClr val="1A1A1A"/>
+              <a:srgbClr val="2C3639"/>
             </a:solidFill>
             <a:prstDash val="solid"/>
             <a:tailEnd type="triangle"/>
@@ -15099,7 +15099,7 @@
           <a:noFill/>
           <a:ln w="15875">
             <a:solidFill>
-              <a:srgbClr val="1A1A1A"/>
+              <a:srgbClr val="2C3639"/>
             </a:solidFill>
             <a:prstDash val="solid"/>
             <a:tailEnd type="triangle"/>
@@ -15109,6 +15109,42 @@
       <p:sp>
         <p:nvSpPr>
           <p:cNvPr id="57" name="Text 52"/>
+          <p:cNvSpPr txBox="1"/>
+          <p:nvPr/>
+        </p:nvSpPr>
+        <p:spPr>
+          <a:xfrm>
+            <a:off x="548640" y="5733288"/>
+            <a:ext cx="5486400" cy="228600"/>
+          </a:xfrm>
+          <a:prstGeom prst="rect">
+            <a:avLst/>
+          </a:prstGeom>
+          <a:noFill/>
+          <a:ln/>
+        </p:spPr>
+        <p:txBody>
+          <a:bodyPr wrap="square" lIns="0" tIns="0" rIns="0" bIns="0" rtlCol="0" anchor="t"/>
+          <a:lstStyle/>
+          <a:p>
+            <a:pPr indent="0" marL="0">
+              <a:buNone/>
+            </a:pPr>
+            <a:r>
+              <a:rPr lang="en-US" sz="1100" b="1" dirty="0">
+                <a:solidFill>
+                  <a:schemeClr val="tx2"/>
+                </a:solidFill>
+              </a:rPr>
+              <a:t>Figure 3. From bed-rest data to crew readiness</a:t>
+            </a:r>
+            <a:endParaRPr lang="en-US" sz="1100" dirty="0"/>
+          </a:p>
+        </p:txBody>
+      </p:sp>
+      <p:sp>
+        <p:nvSpPr>
+          <p:cNvPr id="58" name="Text 53"/>
           <p:cNvSpPr txBox="1"/>
           <p:nvPr/>
         </p:nvSpPr>
@@ -15229,7 +15265,7 @@
           <a:noFill/>
           <a:ln w="9525">
             <a:solidFill>
-              <a:srgbClr val="9AA3AE"/>
+              <a:srgbClr val="A9A598"/>
             </a:solidFill>
             <a:prstDash val="solid"/>
           </a:ln>
@@ -15254,7 +15290,7 @@
           </a:solidFill>
           <a:ln w="9525">
             <a:solidFill>
-              <a:srgbClr val="1F3A5F"/>
+              <a:srgbClr val="2C3639"/>
             </a:solidFill>
             <a:prstDash val="solid"/>
           </a:ln>
@@ -15279,7 +15315,7 @@
           </a:solidFill>
           <a:ln w="9525">
             <a:solidFill>
-              <a:srgbClr val="A23B2A"/>
+              <a:srgbClr val="A27B5C"/>
             </a:solidFill>
             <a:prstDash val="solid"/>
           </a:ln>
@@ -15304,7 +15340,7 @@
           </a:solidFill>
           <a:ln w="9525">
             <a:solidFill>
-              <a:srgbClr val="9AA3AE"/>
+              <a:srgbClr val="A9A598"/>
             </a:solidFill>
             <a:prstDash val="solid"/>
           </a:ln>
@@ -15329,7 +15365,7 @@
           </a:solidFill>
           <a:ln w="9525">
             <a:solidFill>
-              <a:srgbClr val="9AA3AE"/>
+              <a:srgbClr val="A9A598"/>
             </a:solidFill>
             <a:prstDash val="solid"/>
           </a:ln>
@@ -15354,7 +15390,7 @@
           </a:solidFill>
           <a:ln w="9525">
             <a:solidFill>
-              <a:srgbClr val="9AA3AE"/>
+              <a:srgbClr val="A9A598"/>
             </a:solidFill>
             <a:prstDash val="solid"/>
           </a:ln>
@@ -15379,7 +15415,7 @@
           </a:solidFill>
           <a:ln w="9525">
             <a:solidFill>
-              <a:srgbClr val="9AA3AE"/>
+              <a:srgbClr val="A9A598"/>
             </a:solidFill>
             <a:prstDash val="solid"/>
           </a:ln>
@@ -15470,7 +15506,43 @@
         </p:nvSpPr>
         <p:spPr>
           <a:xfrm>
-            <a:off x="548640" y="1234440"/>
+            <a:off x="548640" y="1115568"/>
+            <a:ext cx="11064240" cy="292608"/>
+          </a:xfrm>
+          <a:prstGeom prst="rect">
+            <a:avLst/>
+          </a:prstGeom>
+          <a:noFill/>
+          <a:ln/>
+        </p:spPr>
+        <p:txBody>
+          <a:bodyPr wrap="square" lIns="0" tIns="0" rIns="0" bIns="0" rtlCol="0" anchor="t"/>
+          <a:lstStyle/>
+          <a:p>
+            <a:pPr indent="0" marL="0">
+              <a:buNone/>
+            </a:pPr>
+            <a:r>
+              <a:rPr lang="en-US" sz="1400" b="1" dirty="0">
+                <a:solidFill>
+                  <a:schemeClr val="tx2"/>
+                </a:solidFill>
+              </a:rPr>
+              <a:t>Figure 4. Unloading range in the abstract and in the final dataset</a:t>
+            </a:r>
+            <a:endParaRPr lang="en-US" sz="1400" dirty="0"/>
+          </a:p>
+        </p:txBody>
+      </p:sp>
+      <p:sp>
+        <p:nvSpPr>
+          <p:cNvPr id="12" name="Text 10"/>
+          <p:cNvSpPr txBox="1"/>
+          <p:nvPr/>
+        </p:nvSpPr>
+        <p:spPr>
+          <a:xfrm>
+            <a:off x="548640" y="1481328"/>
             <a:ext cx="2651760" cy="548640"/>
           </a:xfrm>
           <a:prstGeom prst="rect">
@@ -15514,33 +15586,33 @@
       </p:sp>
       <p:sp>
         <p:nvSpPr>
-          <p:cNvPr id="12" name="Abstract 14-119"/>
+          <p:cNvPr id="13" name="Abstract 14-119"/>
           <p:cNvSpPr/>
           <p:nvPr/>
         </p:nvSpPr>
         <p:spPr>
           <a:xfrm>
-            <a:off x="3889248" y="1344168"/>
+            <a:off x="3889248" y="1591056"/>
             <a:ext cx="4480560" cy="329184"/>
           </a:xfrm>
           <a:prstGeom prst="rect">
             <a:avLst/>
           </a:prstGeom>
           <a:solidFill>
-            <a:srgbClr val="A7AEB8"/>
+            <a:srgbClr val="C4BEB0"/>
           </a:solidFill>
           <a:ln/>
         </p:spPr>
       </p:sp>
       <p:sp>
         <p:nvSpPr>
-          <p:cNvPr id="13" name="Text 11"/>
+          <p:cNvPr id="14" name="Text 12"/>
           <p:cNvSpPr txBox="1"/>
           <p:nvPr/>
         </p:nvSpPr>
         <p:spPr>
           <a:xfrm>
-            <a:off x="3477768" y="1344168"/>
+            <a:off x="3477768" y="1591056"/>
             <a:ext cx="365760" cy="329184"/>
           </a:xfrm>
           <a:prstGeom prst="rect">
@@ -15570,13 +15642,13 @@
       </p:sp>
       <p:sp>
         <p:nvSpPr>
-          <p:cNvPr id="14" name="Text 12"/>
+          <p:cNvPr id="15" name="Text 13"/>
           <p:cNvSpPr txBox="1"/>
           <p:nvPr/>
         </p:nvSpPr>
         <p:spPr>
           <a:xfrm>
-            <a:off x="8433816" y="1344168"/>
+            <a:off x="8433816" y="1591056"/>
             <a:ext cx="457200" cy="329184"/>
           </a:xfrm>
           <a:prstGeom prst="rect">
@@ -15606,13 +15678,13 @@
       </p:sp>
       <p:sp>
         <p:nvSpPr>
-          <p:cNvPr id="15" name="Text 13"/>
+          <p:cNvPr id="16" name="Text 14"/>
           <p:cNvSpPr txBox="1"/>
           <p:nvPr/>
         </p:nvSpPr>
         <p:spPr>
           <a:xfrm>
-            <a:off x="548640" y="1892808"/>
+            <a:off x="548640" y="2048256"/>
             <a:ext cx="2651760" cy="548640"/>
           </a:xfrm>
           <a:prstGeom prst="rect">
@@ -15656,53 +15728,53 @@
       </p:sp>
       <p:sp>
         <p:nvSpPr>
-          <p:cNvPr id="16" name="Final dataset 5-119"/>
+          <p:cNvPr id="17" name="Final dataset 5-119"/>
           <p:cNvSpPr/>
           <p:nvPr/>
         </p:nvSpPr>
         <p:spPr>
           <a:xfrm>
-            <a:off x="3505200" y="2002536"/>
+            <a:off x="3505200" y="2157984"/>
             <a:ext cx="4864608" cy="329184"/>
           </a:xfrm>
           <a:prstGeom prst="rect">
             <a:avLst/>
           </a:prstGeom>
           <a:solidFill>
-            <a:srgbClr val="1F3A5F"/>
+            <a:srgbClr val="2C3639"/>
           </a:solidFill>
           <a:ln/>
         </p:spPr>
       </p:sp>
       <p:sp>
         <p:nvSpPr>
-          <p:cNvPr id="17" name="Final dataset 119-180"/>
+          <p:cNvPr id="18" name="Final dataset 119-180"/>
           <p:cNvSpPr/>
           <p:nvPr/>
         </p:nvSpPr>
         <p:spPr>
           <a:xfrm>
-            <a:off x="8369808" y="2002536"/>
+            <a:off x="8369808" y="2157984"/>
             <a:ext cx="2602992" cy="329184"/>
           </a:xfrm>
           <a:prstGeom prst="rect">
             <a:avLst/>
           </a:prstGeom>
           <a:solidFill>
-            <a:srgbClr val="A23B2A"/>
+            <a:srgbClr val="A27B5C"/>
           </a:solidFill>
           <a:ln/>
         </p:spPr>
       </p:sp>
       <p:sp>
         <p:nvSpPr>
-          <p:cNvPr id="18" name="Text 16"/>
+          <p:cNvPr id="19" name="Text 17"/>
           <p:cNvSpPr txBox="1"/>
           <p:nvPr/>
         </p:nvSpPr>
         <p:spPr>
           <a:xfrm>
-            <a:off x="3093720" y="2002536"/>
+            <a:off x="3093720" y="2157984"/>
             <a:ext cx="365760" cy="329184"/>
           </a:xfrm>
           <a:prstGeom prst="rect">
@@ -15732,13 +15804,13 @@
       </p:sp>
       <p:sp>
         <p:nvSpPr>
-          <p:cNvPr id="19" name="Text 17"/>
+          <p:cNvPr id="20" name="Text 18"/>
           <p:cNvSpPr txBox="1"/>
           <p:nvPr/>
         </p:nvSpPr>
         <p:spPr>
           <a:xfrm>
-            <a:off x="11036808" y="2002536"/>
+            <a:off x="11036808" y="2157984"/>
             <a:ext cx="457200" cy="329184"/>
           </a:xfrm>
           <a:prstGeom prst="rect">
@@ -15768,13 +15840,13 @@
       </p:sp>
       <p:sp>
         <p:nvSpPr>
-          <p:cNvPr id="20" name="Text 18"/>
+          <p:cNvPr id="21" name="Text 19"/>
           <p:cNvSpPr txBox="1"/>
           <p:nvPr/>
         </p:nvSpPr>
         <p:spPr>
           <a:xfrm>
-            <a:off x="3505200" y="2002536"/>
+            <a:off x="3505200" y="2157984"/>
             <a:ext cx="4864608" cy="329184"/>
           </a:xfrm>
           <a:prstGeom prst="rect">
@@ -15804,13 +15876,13 @@
       </p:sp>
       <p:sp>
         <p:nvSpPr>
-          <p:cNvPr id="21" name="Text 19"/>
+          <p:cNvPr id="22" name="Text 20"/>
           <p:cNvSpPr txBox="1"/>
           <p:nvPr/>
         </p:nvSpPr>
         <p:spPr>
           <a:xfrm>
-            <a:off x="8369808" y="2002536"/>
+            <a:off x="8369808" y="2157984"/>
             <a:ext cx="2602992" cy="329184"/>
           </a:xfrm>
           <a:prstGeom prst="rect">
@@ -15840,7 +15912,7 @@
       </p:sp>
       <p:sp>
         <p:nvSpPr>
-          <p:cNvPr id="22" name="Day axis"/>
+          <p:cNvPr id="23" name="Day axis"/>
           <p:cNvSpPr/>
           <p:nvPr/>
         </p:nvSpPr>
@@ -15855,7 +15927,7 @@
           <a:noFill/>
           <a:ln w="9525">
             <a:solidFill>
-              <a:srgbClr val="6B7280"/>
+              <a:srgbClr val="6F7877"/>
             </a:solidFill>
             <a:prstDash val="solid"/>
           </a:ln>
@@ -15863,7 +15935,7 @@
       </p:sp>
       <p:sp>
         <p:nvSpPr>
-          <p:cNvPr id="23" name="Tick 0"/>
+          <p:cNvPr id="24" name="Tick 0"/>
           <p:cNvSpPr/>
           <p:nvPr/>
         </p:nvSpPr>
@@ -15878,7 +15950,7 @@
           <a:noFill/>
           <a:ln w="9525">
             <a:solidFill>
-              <a:srgbClr val="6B7280"/>
+              <a:srgbClr val="6F7877"/>
             </a:solidFill>
             <a:prstDash val="solid"/>
           </a:ln>
@@ -15886,7 +15958,7 @@
       </p:sp>
       <p:sp>
         <p:nvSpPr>
-          <p:cNvPr id="24" name="Text 22"/>
+          <p:cNvPr id="25" name="Text 23"/>
           <p:cNvSpPr txBox="1"/>
           <p:nvPr/>
         </p:nvSpPr>
@@ -15922,7 +15994,7 @@
       </p:sp>
       <p:sp>
         <p:nvSpPr>
-          <p:cNvPr id="25" name="Tick 30"/>
+          <p:cNvPr id="26" name="Tick 30"/>
           <p:cNvSpPr/>
           <p:nvPr/>
         </p:nvSpPr>
@@ -15937,7 +16009,7 @@
           <a:noFill/>
           <a:ln w="9525">
             <a:solidFill>
-              <a:srgbClr val="6B7280"/>
+              <a:srgbClr val="6F7877"/>
             </a:solidFill>
             <a:prstDash val="solid"/>
           </a:ln>
@@ -15945,7 +16017,7 @@
       </p:sp>
       <p:sp>
         <p:nvSpPr>
-          <p:cNvPr id="26" name="Text 24"/>
+          <p:cNvPr id="27" name="Text 25"/>
           <p:cNvSpPr txBox="1"/>
           <p:nvPr/>
         </p:nvSpPr>
@@ -15981,7 +16053,7 @@
       </p:sp>
       <p:sp>
         <p:nvSpPr>
-          <p:cNvPr id="27" name="Tick 60"/>
+          <p:cNvPr id="28" name="Tick 60"/>
           <p:cNvSpPr/>
           <p:nvPr/>
         </p:nvSpPr>
@@ -15996,7 +16068,7 @@
           <a:noFill/>
           <a:ln w="9525">
             <a:solidFill>
-              <a:srgbClr val="6B7280"/>
+              <a:srgbClr val="6F7877"/>
             </a:solidFill>
             <a:prstDash val="solid"/>
           </a:ln>
@@ -16004,7 +16076,7 @@
       </p:sp>
       <p:sp>
         <p:nvSpPr>
-          <p:cNvPr id="28" name="Text 26"/>
+          <p:cNvPr id="29" name="Text 27"/>
           <p:cNvSpPr txBox="1"/>
           <p:nvPr/>
         </p:nvSpPr>
@@ -16040,7 +16112,7 @@
       </p:sp>
       <p:sp>
         <p:nvSpPr>
-          <p:cNvPr id="29" name="Tick 90"/>
+          <p:cNvPr id="30" name="Tick 90"/>
           <p:cNvSpPr/>
           <p:nvPr/>
         </p:nvSpPr>
@@ -16055,7 +16127,7 @@
           <a:noFill/>
           <a:ln w="9525">
             <a:solidFill>
-              <a:srgbClr val="6B7280"/>
+              <a:srgbClr val="6F7877"/>
             </a:solidFill>
             <a:prstDash val="solid"/>
           </a:ln>
@@ -16063,7 +16135,7 @@
       </p:sp>
       <p:sp>
         <p:nvSpPr>
-          <p:cNvPr id="30" name="Text 28"/>
+          <p:cNvPr id="31" name="Text 29"/>
           <p:cNvSpPr txBox="1"/>
           <p:nvPr/>
         </p:nvSpPr>
@@ -16099,7 +16171,7 @@
       </p:sp>
       <p:sp>
         <p:nvSpPr>
-          <p:cNvPr id="31" name="Tick 119"/>
+          <p:cNvPr id="32" name="Tick 119"/>
           <p:cNvSpPr/>
           <p:nvPr/>
         </p:nvSpPr>
@@ -16114,7 +16186,7 @@
           <a:noFill/>
           <a:ln w="9525">
             <a:solidFill>
-              <a:srgbClr val="6B7280"/>
+              <a:srgbClr val="6F7877"/>
             </a:solidFill>
             <a:prstDash val="solid"/>
           </a:ln>
@@ -16122,7 +16194,7 @@
       </p:sp>
       <p:sp>
         <p:nvSpPr>
-          <p:cNvPr id="32" name="Text 30"/>
+          <p:cNvPr id="33" name="Text 31"/>
           <p:cNvSpPr txBox="1"/>
           <p:nvPr/>
         </p:nvSpPr>
@@ -16158,7 +16230,7 @@
       </p:sp>
       <p:sp>
         <p:nvSpPr>
-          <p:cNvPr id="33" name="Tick 150"/>
+          <p:cNvPr id="34" name="Tick 150"/>
           <p:cNvSpPr/>
           <p:nvPr/>
         </p:nvSpPr>
@@ -16173,7 +16245,7 @@
           <a:noFill/>
           <a:ln w="9525">
             <a:solidFill>
-              <a:srgbClr val="6B7280"/>
+              <a:srgbClr val="6F7877"/>
             </a:solidFill>
             <a:prstDash val="solid"/>
           </a:ln>
@@ -16181,7 +16253,7 @@
       </p:sp>
       <p:sp>
         <p:nvSpPr>
-          <p:cNvPr id="34" name="Text 32"/>
+          <p:cNvPr id="35" name="Text 33"/>
           <p:cNvSpPr txBox="1"/>
           <p:nvPr/>
         </p:nvSpPr>
@@ -16217,7 +16289,7 @@
       </p:sp>
       <p:sp>
         <p:nvSpPr>
-          <p:cNvPr id="35" name="Tick 180"/>
+          <p:cNvPr id="36" name="Tick 180"/>
           <p:cNvSpPr/>
           <p:nvPr/>
         </p:nvSpPr>
@@ -16232,7 +16304,7 @@
           <a:noFill/>
           <a:ln w="9525">
             <a:solidFill>
-              <a:srgbClr val="6B7280"/>
+              <a:srgbClr val="6F7877"/>
             </a:solidFill>
             <a:prstDash val="solid"/>
           </a:ln>
@@ -16240,7 +16312,7 @@
       </p:sp>
       <p:sp>
         <p:nvSpPr>
-          <p:cNvPr id="36" name="Text 34"/>
+          <p:cNvPr id="37" name="Text 35"/>
           <p:cNvSpPr txBox="1"/>
           <p:nvPr/>
         </p:nvSpPr>
@@ -16276,7 +16348,7 @@
       </p:sp>
       <p:sp>
         <p:nvSpPr>
-          <p:cNvPr id="37" name="Text 35"/>
+          <p:cNvPr id="38" name="Text 36"/>
           <p:cNvSpPr txBox="1"/>
           <p:nvPr/>
         </p:nvSpPr>
@@ -16312,7 +16384,7 @@
       </p:sp>
       <p:sp>
         <p:nvSpPr>
-          <p:cNvPr id="38" name="Text 36"/>
+          <p:cNvPr id="39" name="Text 37"/>
           <p:cNvSpPr txBox="1"/>
           <p:nvPr/>
         </p:nvSpPr>
@@ -16340,7 +16412,7 @@
                   <a:schemeClr val="tx2"/>
                 </a:solidFill>
               </a:rPr>
-              <a:t>Studies published per year, by length of unloading</a:t>
+              <a:t>Figure 5. Studies published per year, by length of unloading</a:t>
             </a:r>
             <a:endParaRPr lang="en-US" sz="1400" dirty="0"/>
           </a:p>
@@ -16348,7 +16420,7 @@
       </p:sp>
       <p:sp>
         <p:nvSpPr>
-          <p:cNvPr id="39" name="Text 37"/>
+          <p:cNvPr id="40" name="Text 38"/>
           <p:cNvSpPr txBox="1"/>
           <p:nvPr/>
         </p:nvSpPr>
@@ -16384,7 +16456,7 @@
       </p:sp>
       <p:sp>
         <p:nvSpPr>
-          <p:cNvPr id="40" name="Text 38"/>
+          <p:cNvPr id="41" name="Text 39"/>
           <p:cNvSpPr txBox="1"/>
           <p:nvPr/>
         </p:nvSpPr>
@@ -16420,7 +16492,7 @@
       </p:sp>
       <p:sp>
         <p:nvSpPr>
-          <p:cNvPr id="41" name="Legend 180 days (spaceflight)"/>
+          <p:cNvPr id="42" name="Legend 180 days (spaceflight)"/>
           <p:cNvSpPr/>
           <p:nvPr/>
         </p:nvSpPr>
@@ -16433,14 +16505,14 @@
             <a:avLst/>
           </a:prstGeom>
           <a:solidFill>
-            <a:srgbClr val="A23B2A"/>
+            <a:srgbClr val="A27B5C"/>
           </a:solidFill>
           <a:ln/>
         </p:spPr>
       </p:sp>
       <p:sp>
         <p:nvSpPr>
-          <p:cNvPr id="42" name="Text 40"/>
+          <p:cNvPr id="43" name="Text 41"/>
           <p:cNvSpPr txBox="1"/>
           <p:nvPr/>
         </p:nvSpPr>
@@ -16476,7 +16548,7 @@
       </p:sp>
       <p:sp>
         <p:nvSpPr>
-          <p:cNvPr id="43" name="Legend 61 to 119 days"/>
+          <p:cNvPr id="44" name="Legend 61 to 119 days"/>
           <p:cNvSpPr/>
           <p:nvPr/>
         </p:nvSpPr>
@@ -16489,14 +16561,14 @@
             <a:avLst/>
           </a:prstGeom>
           <a:solidFill>
-            <a:srgbClr val="1F3A5F"/>
+            <a:srgbClr val="3F4E4F"/>
           </a:solidFill>
           <a:ln/>
         </p:spPr>
       </p:sp>
       <p:sp>
         <p:nvSpPr>
-          <p:cNvPr id="44" name="Text 42"/>
+          <p:cNvPr id="45" name="Text 43"/>
           <p:cNvSpPr txBox="1"/>
           <p:nvPr/>
         </p:nvSpPr>
@@ -16532,7 +16604,7 @@
       </p:sp>
       <p:sp>
         <p:nvSpPr>
-          <p:cNvPr id="45" name="Legend 31 to 60 days"/>
+          <p:cNvPr id="46" name="Legend 31 to 60 days"/>
           <p:cNvSpPr/>
           <p:nvPr/>
         </p:nvSpPr>
@@ -16545,14 +16617,14 @@
             <a:avLst/>
           </a:prstGeom>
           <a:solidFill>
-            <a:srgbClr val="56739A"/>
+            <a:srgbClr val="7D8A89"/>
           </a:solidFill>
           <a:ln/>
         </p:spPr>
       </p:sp>
       <p:sp>
         <p:nvSpPr>
-          <p:cNvPr id="46" name="Text 44"/>
+          <p:cNvPr id="47" name="Text 45"/>
           <p:cNvSpPr txBox="1"/>
           <p:nvPr/>
         </p:nvSpPr>
@@ -16588,7 +16660,7 @@
       </p:sp>
       <p:sp>
         <p:nvSpPr>
-          <p:cNvPr id="47" name="Legend 15 to 30 days"/>
+          <p:cNvPr id="48" name="Legend 15 to 30 days"/>
           <p:cNvSpPr/>
           <p:nvPr/>
         </p:nvSpPr>
@@ -16601,14 +16673,14 @@
             <a:avLst/>
           </a:prstGeom>
           <a:solidFill>
-            <a:srgbClr val="8FA3BB"/>
+            <a:srgbClr val="B3AD9E"/>
           </a:solidFill>
           <a:ln/>
         </p:spPr>
       </p:sp>
       <p:sp>
         <p:nvSpPr>
-          <p:cNvPr id="48" name="Text 46"/>
+          <p:cNvPr id="49" name="Text 47"/>
           <p:cNvSpPr txBox="1"/>
           <p:nvPr/>
         </p:nvSpPr>
@@ -16644,7 +16716,7 @@
       </p:sp>
       <p:sp>
         <p:nvSpPr>
-          <p:cNvPr id="49" name="Legend 5 to 14 days"/>
+          <p:cNvPr id="50" name="Legend 5 to 14 days"/>
           <p:cNvSpPr/>
           <p:nvPr/>
         </p:nvSpPr>
@@ -16657,14 +16729,14 @@
             <a:avLst/>
           </a:prstGeom>
           <a:solidFill>
-            <a:srgbClr val="C9D2DD"/>
+            <a:srgbClr val="DCD7C9"/>
           </a:solidFill>
           <a:ln/>
         </p:spPr>
       </p:sp>
       <p:sp>
         <p:nvSpPr>
-          <p:cNvPr id="50" name="Text 48"/>
+          <p:cNvPr id="51" name="Text 49"/>
           <p:cNvSpPr txBox="1"/>
           <p:nvPr/>
         </p:nvSpPr>
@@ -16700,7 +16772,7 @@
       </p:sp>
       <p:graphicFrame>
         <p:nvGraphicFramePr>
-          <p:cNvPr id="51" name="Chart 0" descr=""/>
+          <p:cNvPr id="52" name="Chart 0" descr=""/>
           <p:cNvGraphicFramePr/>
           <p:nvPr/>
         </p:nvGraphicFramePr>
@@ -16801,7 +16873,7 @@
           <a:noFill/>
           <a:ln w="9525">
             <a:solidFill>
-              <a:srgbClr val="9AA3AE"/>
+              <a:srgbClr val="A9A598"/>
             </a:solidFill>
             <a:prstDash val="solid"/>
           </a:ln>
@@ -16826,7 +16898,7 @@
           </a:solidFill>
           <a:ln w="9525">
             <a:solidFill>
-              <a:srgbClr val="1F3A5F"/>
+              <a:srgbClr val="2C3639"/>
             </a:solidFill>
             <a:prstDash val="solid"/>
           </a:ln>
@@ -16851,7 +16923,7 @@
           </a:solidFill>
           <a:ln w="9525">
             <a:solidFill>
-              <a:srgbClr val="A23B2A"/>
+              <a:srgbClr val="A27B5C"/>
             </a:solidFill>
             <a:prstDash val="solid"/>
           </a:ln>
@@ -16876,7 +16948,7 @@
           </a:solidFill>
           <a:ln w="9525">
             <a:solidFill>
-              <a:srgbClr val="9AA3AE"/>
+              <a:srgbClr val="A9A598"/>
             </a:solidFill>
             <a:prstDash val="solid"/>
           </a:ln>
@@ -16901,7 +16973,7 @@
           </a:solidFill>
           <a:ln w="9525">
             <a:solidFill>
-              <a:srgbClr val="9AA3AE"/>
+              <a:srgbClr val="A9A598"/>
             </a:solidFill>
             <a:prstDash val="solid"/>
           </a:ln>
@@ -16926,7 +16998,7 @@
           </a:solidFill>
           <a:ln w="9525">
             <a:solidFill>
-              <a:srgbClr val="9AA3AE"/>
+              <a:srgbClr val="A9A598"/>
             </a:solidFill>
             <a:prstDash val="solid"/>
           </a:ln>
@@ -16951,7 +17023,7 @@
           </a:solidFill>
           <a:ln w="9525">
             <a:solidFill>
-              <a:srgbClr val="9AA3AE"/>
+              <a:srgbClr val="A9A598"/>
             </a:solidFill>
             <a:prstDash val="solid"/>
           </a:ln>
@@ -17089,7 +17161,7 @@
           </a:solidFill>
           <a:ln w="12700">
             <a:solidFill>
-              <a:srgbClr val="9AA3AE"/>
+              <a:srgbClr val="A9A598"/>
             </a:solidFill>
             <a:prstDash val="solid"/>
           </a:ln>
@@ -17179,7 +17251,7 @@
           <a:noFill/>
           <a:ln w="15875">
             <a:solidFill>
-              <a:srgbClr val="1A1A1A"/>
+              <a:srgbClr val="2C3639"/>
             </a:solidFill>
             <a:prstDash val="solid"/>
             <a:tailEnd type="triangle"/>
@@ -17241,7 +17313,7 @@
           </a:solidFill>
           <a:ln w="12700">
             <a:solidFill>
-              <a:srgbClr val="9AA3AE"/>
+              <a:srgbClr val="A9A598"/>
             </a:solidFill>
             <a:prstDash val="solid"/>
           </a:ln>
@@ -17317,7 +17389,7 @@
           <a:noFill/>
           <a:ln w="15875">
             <a:solidFill>
-              <a:srgbClr val="1A1A1A"/>
+              <a:srgbClr val="2C3639"/>
             </a:solidFill>
             <a:prstDash val="solid"/>
             <a:tailEnd type="triangle"/>
@@ -17379,7 +17451,7 @@
           </a:solidFill>
           <a:ln w="12700">
             <a:solidFill>
-              <a:srgbClr val="9AA3AE"/>
+              <a:srgbClr val="A9A598"/>
             </a:solidFill>
             <a:prstDash val="solid"/>
           </a:ln>
@@ -17455,7 +17527,7 @@
           <a:noFill/>
           <a:ln w="15875">
             <a:solidFill>
-              <a:srgbClr val="1A1A1A"/>
+              <a:srgbClr val="2C3639"/>
             </a:solidFill>
             <a:prstDash val="solid"/>
             <a:tailEnd type="triangle"/>
@@ -17517,7 +17589,7 @@
           </a:solidFill>
           <a:ln w="12700">
             <a:solidFill>
-              <a:srgbClr val="9AA3AE"/>
+              <a:srgbClr val="A9A598"/>
             </a:solidFill>
             <a:prstDash val="solid"/>
           </a:ln>
@@ -17593,7 +17665,7 @@
           <a:noFill/>
           <a:ln w="15875">
             <a:solidFill>
-              <a:srgbClr val="1A1A1A"/>
+              <a:srgbClr val="2C3639"/>
             </a:solidFill>
             <a:prstDash val="solid"/>
             <a:tailEnd type="triangle"/>
@@ -17651,11 +17723,11 @@
             <a:avLst/>
           </a:prstGeom>
           <a:solidFill>
-            <a:srgbClr val="1F3A5F"/>
+            <a:srgbClr val="2C3639"/>
           </a:solidFill>
           <a:ln w="12700">
             <a:solidFill>
-              <a:srgbClr val="1F3A5F"/>
+              <a:srgbClr val="2C3639"/>
             </a:solidFill>
             <a:prstDash val="solid"/>
           </a:ln>
@@ -17745,7 +17817,7 @@
           <a:noFill/>
           <a:ln w="9525">
             <a:solidFill>
-              <a:srgbClr val="9AA3AE"/>
+              <a:srgbClr val="A9A598"/>
             </a:solidFill>
             <a:prstDash val="dash"/>
             <a:tailEnd type="triangle"/>
@@ -17805,7 +17877,7 @@
           <a:noFill/>
           <a:ln w="9525">
             <a:solidFill>
-              <a:srgbClr val="9AA3AE"/>
+              <a:srgbClr val="A9A598"/>
             </a:solidFill>
             <a:prstDash val="dash"/>
             <a:tailEnd type="triangle"/>
@@ -17865,7 +17937,7 @@
           <a:noFill/>
           <a:ln w="9525">
             <a:solidFill>
-              <a:srgbClr val="9AA3AE"/>
+              <a:srgbClr val="A9A598"/>
             </a:solidFill>
             <a:prstDash val="dash"/>
             <a:tailEnd type="triangle"/>
@@ -17931,7 +18003,7 @@
         <p:spPr>
           <a:xfrm>
             <a:off x="548640" y="5806440"/>
-            <a:ext cx="6400800" cy="274320"/>
+            <a:ext cx="8229600" cy="274320"/>
           </a:xfrm>
           <a:prstGeom prst="rect">
             <a:avLst/>
@@ -17952,7 +18024,7 @@
                   <a:schemeClr val="accent3"/>
                 </a:solidFill>
               </a:rPr>
-              <a:t>Flow of records in the style of PRISMA 2020, the standard for reporting systematic reviews.</a:t>
+              <a:t>Figure 6. Flow of records, in the style of PRISMA 2020 (the standard for reporting systematic reviews).</a:t>
             </a:r>
             <a:endParaRPr lang="en-US" sz="1100" dirty="0"/>
           </a:p>
@@ -18045,7 +18117,7 @@
           <a:noFill/>
           <a:ln w="9525">
             <a:solidFill>
-              <a:srgbClr val="9AA3AE"/>
+              <a:srgbClr val="A9A598"/>
             </a:solidFill>
             <a:prstDash val="solid"/>
           </a:ln>
@@ -18070,7 +18142,7 @@
           </a:solidFill>
           <a:ln w="9525">
             <a:solidFill>
-              <a:srgbClr val="1F3A5F"/>
+              <a:srgbClr val="2C3639"/>
             </a:solidFill>
             <a:prstDash val="solid"/>
           </a:ln>
@@ -18095,7 +18167,7 @@
           </a:solidFill>
           <a:ln w="9525">
             <a:solidFill>
-              <a:srgbClr val="1F3A5F"/>
+              <a:srgbClr val="2C3639"/>
             </a:solidFill>
             <a:prstDash val="solid"/>
           </a:ln>
@@ -18120,7 +18192,7 @@
           </a:solidFill>
           <a:ln w="9525">
             <a:solidFill>
-              <a:srgbClr val="A23B2A"/>
+              <a:srgbClr val="A27B5C"/>
             </a:solidFill>
             <a:prstDash val="solid"/>
           </a:ln>
@@ -18145,7 +18217,7 @@
           </a:solidFill>
           <a:ln w="9525">
             <a:solidFill>
-              <a:srgbClr val="9AA3AE"/>
+              <a:srgbClr val="A9A598"/>
             </a:solidFill>
             <a:prstDash val="solid"/>
           </a:ln>
@@ -18170,7 +18242,7 @@
           </a:solidFill>
           <a:ln w="9525">
             <a:solidFill>
-              <a:srgbClr val="9AA3AE"/>
+              <a:srgbClr val="A9A598"/>
             </a:solidFill>
             <a:prstDash val="solid"/>
           </a:ln>
@@ -18195,7 +18267,7 @@
           </a:solidFill>
           <a:ln w="9525">
             <a:solidFill>
-              <a:srgbClr val="9AA3AE"/>
+              <a:srgbClr val="A9A598"/>
             </a:solidFill>
             <a:prstDash val="solid"/>
           </a:ln>
@@ -18308,7 +18380,7 @@
                   <a:schemeClr val="tx2"/>
                 </a:solidFill>
               </a:rPr>
-              <a:t>Final dataset at a glance</a:t>
+              <a:t>Table 1. Final dataset at a glance</a:t>
             </a:r>
             <a:endParaRPr lang="en-US" sz="1500" dirty="0"/>
           </a:p>
@@ -18379,7 +18451,7 @@
                     </a:lnT>
                     <a:lnB w="9525" cap="flat" cmpd="sng" algn="ctr">
                       <a:solidFill>
-                        <a:srgbClr val="E5E7EB"/>
+                        <a:srgbClr val="E8E4DA"/>
                       </a:solidFill>
                       <a:prstDash val="solid"/>
                       <a:round/>
@@ -18387,7 +18459,7 @@
                       <a:tailEnd type="none" w="med" len="med"/>
                     </a:lnB>
                     <a:solidFill>
-                      <a:srgbClr val="1F3A5F"/>
+                      <a:srgbClr val="2C3639"/>
                     </a:solidFill>
                   </a:tcPr>
                 </a:tc>
@@ -18429,7 +18501,7 @@
                     </a:lnT>
                     <a:lnB w="9525" cap="flat" cmpd="sng" algn="ctr">
                       <a:solidFill>
-                        <a:srgbClr val="E5E7EB"/>
+                        <a:srgbClr val="E8E4DA"/>
                       </a:solidFill>
                       <a:prstDash val="solid"/>
                       <a:round/>
@@ -18437,7 +18509,7 @@
                       <a:tailEnd type="none" w="med" len="med"/>
                     </a:lnB>
                     <a:solidFill>
-                      <a:srgbClr val="1F3A5F"/>
+                      <a:srgbClr val="2C3639"/>
                     </a:solidFill>
                   </a:tcPr>
                 </a:tc>
@@ -18454,7 +18526,7 @@
                       <a:r>
                         <a:rPr lang="en-US" sz="1300" dirty="0">
                           <a:solidFill>
-                            <a:srgbClr val="1A1A1A"/>
+                            <a:srgbClr val="2C3639"/>
                           </a:solidFill>
                           <a:latin typeface="Calibri" pitchFamily="34" charset="0"/>
                           <a:ea typeface="Calibri" pitchFamily="34" charset="-122"/>
@@ -18481,7 +18553,7 @@
                     </a:lnT>
                     <a:lnB w="9525" cap="flat" cmpd="sng" algn="ctr">
                       <a:solidFill>
-                        <a:srgbClr val="E5E7EB"/>
+                        <a:srgbClr val="E8E4DA"/>
                       </a:solidFill>
                       <a:prstDash val="solid"/>
                       <a:round/>
@@ -18501,7 +18573,7 @@
                       <a:r>
                         <a:rPr lang="en-US" sz="1300" b="1" dirty="0">
                           <a:solidFill>
-                            <a:srgbClr val="1A1A1A"/>
+                            <a:srgbClr val="2C3639"/>
                           </a:solidFill>
                           <a:latin typeface="Calibri" pitchFamily="34" charset="0"/>
                           <a:ea typeface="Calibri" pitchFamily="34" charset="-122"/>
@@ -18528,7 +18600,7 @@
                     </a:lnT>
                     <a:lnB w="9525" cap="flat" cmpd="sng" algn="ctr">
                       <a:solidFill>
-                        <a:srgbClr val="E5E7EB"/>
+                        <a:srgbClr val="E8E4DA"/>
                       </a:solidFill>
                       <a:prstDash val="solid"/>
                       <a:round/>
@@ -18550,7 +18622,7 @@
                       <a:r>
                         <a:rPr lang="en-US" sz="1300" dirty="0">
                           <a:solidFill>
-                            <a:srgbClr val="1A1A1A"/>
+                            <a:srgbClr val="2C3639"/>
                           </a:solidFill>
                           <a:latin typeface="Calibri" pitchFamily="34" charset="0"/>
                           <a:ea typeface="Calibri" pitchFamily="34" charset="-122"/>
@@ -18577,7 +18649,7 @@
                     </a:lnT>
                     <a:lnB w="9525" cap="flat" cmpd="sng" algn="ctr">
                       <a:solidFill>
-                        <a:srgbClr val="E5E7EB"/>
+                        <a:srgbClr val="E8E4DA"/>
                       </a:solidFill>
                       <a:prstDash val="solid"/>
                       <a:round/>
@@ -18597,7 +18669,7 @@
                       <a:r>
                         <a:rPr lang="en-US" sz="1300" b="1" dirty="0">
                           <a:solidFill>
-                            <a:srgbClr val="1A1A1A"/>
+                            <a:srgbClr val="2C3639"/>
                           </a:solidFill>
                           <a:latin typeface="Calibri" pitchFamily="34" charset="0"/>
                           <a:ea typeface="Calibri" pitchFamily="34" charset="-122"/>
@@ -18624,7 +18696,7 @@
                     </a:lnT>
                     <a:lnB w="9525" cap="flat" cmpd="sng" algn="ctr">
                       <a:solidFill>
-                        <a:srgbClr val="E5E7EB"/>
+                        <a:srgbClr val="E8E4DA"/>
                       </a:solidFill>
                       <a:prstDash val="solid"/>
                       <a:round/>
@@ -18646,7 +18718,7 @@
                       <a:r>
                         <a:rPr lang="en-US" sz="1300" dirty="0">
                           <a:solidFill>
-                            <a:srgbClr val="1A1A1A"/>
+                            <a:srgbClr val="2C3639"/>
                           </a:solidFill>
                           <a:latin typeface="Calibri" pitchFamily="34" charset="0"/>
                           <a:ea typeface="Calibri" pitchFamily="34" charset="-122"/>
@@ -18673,7 +18745,7 @@
                     </a:lnT>
                     <a:lnB w="9525" cap="flat" cmpd="sng" algn="ctr">
                       <a:solidFill>
-                        <a:srgbClr val="E5E7EB"/>
+                        <a:srgbClr val="E8E4DA"/>
                       </a:solidFill>
                       <a:prstDash val="solid"/>
                       <a:round/>
@@ -18693,7 +18765,7 @@
                       <a:r>
                         <a:rPr lang="en-US" sz="1300" b="1" dirty="0">
                           <a:solidFill>
-                            <a:srgbClr val="1A1A1A"/>
+                            <a:srgbClr val="2C3639"/>
                           </a:solidFill>
                           <a:latin typeface="Calibri" pitchFamily="34" charset="0"/>
                           <a:ea typeface="Calibri" pitchFamily="34" charset="-122"/>
@@ -18720,7 +18792,7 @@
                     </a:lnT>
                     <a:lnB w="9525" cap="flat" cmpd="sng" algn="ctr">
                       <a:solidFill>
-                        <a:srgbClr val="E5E7EB"/>
+                        <a:srgbClr val="E8E4DA"/>
                       </a:solidFill>
                       <a:prstDash val="solid"/>
                       <a:round/>
@@ -18811,7 +18883,7 @@
                   <a:schemeClr val="tx2"/>
                 </a:solidFill>
               </a:rPr>
-              <a:t>Imaging method and size measure</a:t>
+              <a:t>Table 2. Imaging method and size measure</a:t>
             </a:r>
             <a:endParaRPr lang="en-US" sz="1500" dirty="0"/>
           </a:p>
@@ -18884,7 +18956,7 @@
                     </a:lnT>
                     <a:lnB w="9525" cap="flat" cmpd="sng" algn="ctr">
                       <a:solidFill>
-                        <a:srgbClr val="E5E7EB"/>
+                        <a:srgbClr val="E8E4DA"/>
                       </a:solidFill>
                       <a:prstDash val="solid"/>
                       <a:round/>
@@ -18892,7 +18964,7 @@
                       <a:tailEnd type="none" w="med" len="med"/>
                     </a:lnB>
                     <a:solidFill>
-                      <a:srgbClr val="1F3A5F"/>
+                      <a:srgbClr val="2C3639"/>
                     </a:solidFill>
                   </a:tcPr>
                 </a:tc>
@@ -18934,7 +19006,7 @@
                     </a:lnT>
                     <a:lnB w="9525" cap="flat" cmpd="sng" algn="ctr">
                       <a:solidFill>
-                        <a:srgbClr val="E5E7EB"/>
+                        <a:srgbClr val="E8E4DA"/>
                       </a:solidFill>
                       <a:prstDash val="solid"/>
                       <a:round/>
@@ -18942,7 +19014,7 @@
                       <a:tailEnd type="none" w="med" len="med"/>
                     </a:lnB>
                     <a:solidFill>
-                      <a:srgbClr val="1F3A5F"/>
+                      <a:srgbClr val="2C3639"/>
                     </a:solidFill>
                   </a:tcPr>
                 </a:tc>
@@ -18984,7 +19056,7 @@
                     </a:lnT>
                     <a:lnB w="9525" cap="flat" cmpd="sng" algn="ctr">
                       <a:solidFill>
-                        <a:srgbClr val="E5E7EB"/>
+                        <a:srgbClr val="E8E4DA"/>
                       </a:solidFill>
                       <a:prstDash val="solid"/>
                       <a:round/>
@@ -18992,7 +19064,7 @@
                       <a:tailEnd type="none" w="med" len="med"/>
                     </a:lnB>
                     <a:solidFill>
-                      <a:srgbClr val="1F3A5F"/>
+                      <a:srgbClr val="2C3639"/>
                     </a:solidFill>
                   </a:tcPr>
                 </a:tc>
@@ -19034,7 +19106,7 @@
                     </a:lnT>
                     <a:lnB w="9525" cap="flat" cmpd="sng" algn="ctr">
                       <a:solidFill>
-                        <a:srgbClr val="E5E7EB"/>
+                        <a:srgbClr val="E8E4DA"/>
                       </a:solidFill>
                       <a:prstDash val="solid"/>
                       <a:round/>
@@ -19042,7 +19114,7 @@
                       <a:tailEnd type="none" w="med" len="med"/>
                     </a:lnB>
                     <a:solidFill>
-                      <a:srgbClr val="1F3A5F"/>
+                      <a:srgbClr val="2C3639"/>
                     </a:solidFill>
                   </a:tcPr>
                 </a:tc>
@@ -19059,7 +19131,7 @@
                       <a:r>
                         <a:rPr lang="en-US" sz="1300" dirty="0">
                           <a:solidFill>
-                            <a:srgbClr val="1A1A1A"/>
+                            <a:srgbClr val="2C3639"/>
                           </a:solidFill>
                           <a:latin typeface="Calibri" pitchFamily="34" charset="0"/>
                           <a:ea typeface="Calibri" pitchFamily="34" charset="-122"/>
@@ -19086,7 +19158,7 @@
                     </a:lnT>
                     <a:lnB w="9525" cap="flat" cmpd="sng" algn="ctr">
                       <a:solidFill>
-                        <a:srgbClr val="E5E7EB"/>
+                        <a:srgbClr val="E8E4DA"/>
                       </a:solidFill>
                       <a:prstDash val="solid"/>
                       <a:round/>
@@ -19106,7 +19178,7 @@
                       <a:r>
                         <a:rPr lang="en-US" sz="1300" b="1" dirty="0">
                           <a:solidFill>
-                            <a:srgbClr val="1A1A1A"/>
+                            <a:srgbClr val="2C3639"/>
                           </a:solidFill>
                           <a:latin typeface="Calibri" pitchFamily="34" charset="0"/>
                           <a:ea typeface="Calibri" pitchFamily="34" charset="-122"/>
@@ -19133,7 +19205,7 @@
                     </a:lnT>
                     <a:lnB w="9525" cap="flat" cmpd="sng" algn="ctr">
                       <a:solidFill>
-                        <a:srgbClr val="E5E7EB"/>
+                        <a:srgbClr val="E8E4DA"/>
                       </a:solidFill>
                       <a:prstDash val="solid"/>
                       <a:round/>
@@ -19153,7 +19225,7 @@
                       <a:r>
                         <a:rPr lang="en-US" sz="1300" dirty="0">
                           <a:solidFill>
-                            <a:srgbClr val="1A1A1A"/>
+                            <a:srgbClr val="2C3639"/>
                           </a:solidFill>
                           <a:latin typeface="Calibri" pitchFamily="34" charset="0"/>
                           <a:ea typeface="Calibri" pitchFamily="34" charset="-122"/>
@@ -19180,7 +19252,7 @@
                     </a:lnT>
                     <a:lnB w="9525" cap="flat" cmpd="sng" algn="ctr">
                       <a:solidFill>
-                        <a:srgbClr val="E5E7EB"/>
+                        <a:srgbClr val="E8E4DA"/>
                       </a:solidFill>
                       <a:prstDash val="solid"/>
                       <a:round/>
@@ -19200,7 +19272,7 @@
                       <a:r>
                         <a:rPr lang="en-US" sz="1300" b="1" dirty="0">
                           <a:solidFill>
-                            <a:srgbClr val="1A1A1A"/>
+                            <a:srgbClr val="2C3639"/>
                           </a:solidFill>
                           <a:latin typeface="Calibri" pitchFamily="34" charset="0"/>
                           <a:ea typeface="Calibri" pitchFamily="34" charset="-122"/>
@@ -19227,7 +19299,7 @@
                     </a:lnT>
                     <a:lnB w="9525" cap="flat" cmpd="sng" algn="ctr">
                       <a:solidFill>
-                        <a:srgbClr val="E5E7EB"/>
+                        <a:srgbClr val="E8E4DA"/>
                       </a:solidFill>
                       <a:prstDash val="solid"/>
                       <a:round/>
@@ -19249,7 +19321,7 @@
                       <a:r>
                         <a:rPr lang="en-US" sz="1300" dirty="0">
                           <a:solidFill>
-                            <a:srgbClr val="1A1A1A"/>
+                            <a:srgbClr val="2C3639"/>
                           </a:solidFill>
                           <a:latin typeface="Calibri" pitchFamily="34" charset="0"/>
                           <a:ea typeface="Calibri" pitchFamily="34" charset="-122"/>
@@ -19276,7 +19348,7 @@
                     </a:lnT>
                     <a:lnB w="9525" cap="flat" cmpd="sng" algn="ctr">
                       <a:solidFill>
-                        <a:srgbClr val="E5E7EB"/>
+                        <a:srgbClr val="E8E4DA"/>
                       </a:solidFill>
                       <a:prstDash val="solid"/>
                       <a:round/>
@@ -19296,7 +19368,7 @@
                       <a:r>
                         <a:rPr lang="en-US" sz="1300" b="1" dirty="0">
                           <a:solidFill>
-                            <a:srgbClr val="1A1A1A"/>
+                            <a:srgbClr val="2C3639"/>
                           </a:solidFill>
                           <a:latin typeface="Calibri" pitchFamily="34" charset="0"/>
                           <a:ea typeface="Calibri" pitchFamily="34" charset="-122"/>
@@ -19323,7 +19395,7 @@
                     </a:lnT>
                     <a:lnB w="9525" cap="flat" cmpd="sng" algn="ctr">
                       <a:solidFill>
-                        <a:srgbClr val="E5E7EB"/>
+                        <a:srgbClr val="E8E4DA"/>
                       </a:solidFill>
                       <a:prstDash val="solid"/>
                       <a:round/>
@@ -19343,7 +19415,7 @@
                       <a:r>
                         <a:rPr lang="en-US" sz="1300" dirty="0">
                           <a:solidFill>
-                            <a:srgbClr val="1A1A1A"/>
+                            <a:srgbClr val="2C3639"/>
                           </a:solidFill>
                           <a:latin typeface="Calibri" pitchFamily="34" charset="0"/>
                           <a:ea typeface="Calibri" pitchFamily="34" charset="-122"/>
@@ -19370,7 +19442,7 @@
                     </a:lnT>
                     <a:lnB w="9525" cap="flat" cmpd="sng" algn="ctr">
                       <a:solidFill>
-                        <a:srgbClr val="E5E7EB"/>
+                        <a:srgbClr val="E8E4DA"/>
                       </a:solidFill>
                       <a:prstDash val="solid"/>
                       <a:round/>
@@ -19390,7 +19462,7 @@
                       <a:r>
                         <a:rPr lang="en-US" sz="1300" b="1" dirty="0">
                           <a:solidFill>
-                            <a:srgbClr val="1A1A1A"/>
+                            <a:srgbClr val="2C3639"/>
                           </a:solidFill>
                           <a:latin typeface="Calibri" pitchFamily="34" charset="0"/>
                           <a:ea typeface="Calibri" pitchFamily="34" charset="-122"/>
@@ -19417,7 +19489,7 @@
                     </a:lnT>
                     <a:lnB w="9525" cap="flat" cmpd="sng" algn="ctr">
                       <a:solidFill>
-                        <a:srgbClr val="E5E7EB"/>
+                        <a:srgbClr val="E8E4DA"/>
                       </a:solidFill>
                       <a:prstDash val="solid"/>
                       <a:round/>
@@ -19439,7 +19511,7 @@
                       <a:r>
                         <a:rPr lang="en-US" sz="1300" dirty="0">
                           <a:solidFill>
-                            <a:srgbClr val="1A1A1A"/>
+                            <a:srgbClr val="2C3639"/>
                           </a:solidFill>
                           <a:latin typeface="Calibri" pitchFamily="34" charset="0"/>
                           <a:ea typeface="Calibri" pitchFamily="34" charset="-122"/>
@@ -19466,7 +19538,7 @@
                     </a:lnT>
                     <a:lnB w="9525" cap="flat" cmpd="sng" algn="ctr">
                       <a:solidFill>
-                        <a:srgbClr val="E5E7EB"/>
+                        <a:srgbClr val="E8E4DA"/>
                       </a:solidFill>
                       <a:prstDash val="solid"/>
                       <a:round/>
@@ -19486,7 +19558,7 @@
                       <a:r>
                         <a:rPr lang="en-US" sz="1300" b="1" dirty="0">
                           <a:solidFill>
-                            <a:srgbClr val="1A1A1A"/>
+                            <a:srgbClr val="2C3639"/>
                           </a:solidFill>
                           <a:latin typeface="Calibri" pitchFamily="34" charset="0"/>
                           <a:ea typeface="Calibri" pitchFamily="34" charset="-122"/>
@@ -19513,7 +19585,7 @@
                     </a:lnT>
                     <a:lnB w="9525" cap="flat" cmpd="sng" algn="ctr">
                       <a:solidFill>
-                        <a:srgbClr val="E5E7EB"/>
+                        <a:srgbClr val="E8E4DA"/>
                       </a:solidFill>
                       <a:prstDash val="solid"/>
                       <a:round/>
@@ -19533,7 +19605,7 @@
                       <a:r>
                         <a:rPr lang="en-US" sz="1300" dirty="0">
                           <a:solidFill>
-                            <a:srgbClr val="1A1A1A"/>
+                            <a:srgbClr val="2C3639"/>
                           </a:solidFill>
                           <a:latin typeface="Calibri" pitchFamily="34" charset="0"/>
                           <a:ea typeface="Calibri" pitchFamily="34" charset="-122"/>
@@ -19560,7 +19632,7 @@
                     </a:lnT>
                     <a:lnB w="9525" cap="flat" cmpd="sng" algn="ctr">
                       <a:solidFill>
-                        <a:srgbClr val="E5E7EB"/>
+                        <a:srgbClr val="E8E4DA"/>
                       </a:solidFill>
                       <a:prstDash val="solid"/>
                       <a:round/>
@@ -19580,7 +19652,7 @@
                       <a:r>
                         <a:rPr lang="en-US" sz="1300" b="1" dirty="0">
                           <a:solidFill>
-                            <a:srgbClr val="1A1A1A"/>
+                            <a:srgbClr val="2C3639"/>
                           </a:solidFill>
                           <a:latin typeface="Calibri" pitchFamily="34" charset="0"/>
                           <a:ea typeface="Calibri" pitchFamily="34" charset="-122"/>
@@ -19607,7 +19679,7 @@
                     </a:lnT>
                     <a:lnB w="9525" cap="flat" cmpd="sng" algn="ctr">
                       <a:solidFill>
-                        <a:srgbClr val="E5E7EB"/>
+                        <a:srgbClr val="E8E4DA"/>
                       </a:solidFill>
                       <a:prstDash val="solid"/>
                       <a:round/>
@@ -19629,7 +19701,7 @@
                       <a:r>
                         <a:rPr lang="en-US" sz="1300" dirty="0">
                           <a:solidFill>
-                            <a:srgbClr val="1A1A1A"/>
+                            <a:srgbClr val="2C3639"/>
                           </a:solidFill>
                           <a:latin typeface="Calibri" pitchFamily="34" charset="0"/>
                           <a:ea typeface="Calibri" pitchFamily="34" charset="-122"/>
@@ -19656,7 +19728,7 @@
                     </a:lnT>
                     <a:lnB w="9525" cap="flat" cmpd="sng" algn="ctr">
                       <a:solidFill>
-                        <a:srgbClr val="E5E7EB"/>
+                        <a:srgbClr val="E8E4DA"/>
                       </a:solidFill>
                       <a:prstDash val="solid"/>
                       <a:round/>
@@ -19676,7 +19748,7 @@
                       <a:r>
                         <a:rPr lang="en-US" sz="1300" b="1" dirty="0">
                           <a:solidFill>
-                            <a:srgbClr val="1A1A1A"/>
+                            <a:srgbClr val="2C3639"/>
                           </a:solidFill>
                           <a:latin typeface="Calibri" pitchFamily="34" charset="0"/>
                           <a:ea typeface="Calibri" pitchFamily="34" charset="-122"/>
@@ -19703,7 +19775,7 @@
                     </a:lnT>
                     <a:lnB w="9525" cap="flat" cmpd="sng" algn="ctr">
                       <a:solidFill>
-                        <a:srgbClr val="E5E7EB"/>
+                        <a:srgbClr val="E8E4DA"/>
                       </a:solidFill>
                       <a:prstDash val="solid"/>
                       <a:round/>
@@ -19723,7 +19795,7 @@
                       <a:r>
                         <a:rPr lang="en-US" sz="1300" dirty="0">
                           <a:solidFill>
-                            <a:srgbClr val="1A1A1A"/>
+                            <a:srgbClr val="2C3639"/>
                           </a:solidFill>
                           <a:latin typeface="Calibri" pitchFamily="34" charset="0"/>
                           <a:ea typeface="Calibri" pitchFamily="34" charset="-122"/>
@@ -19750,7 +19822,7 @@
                     </a:lnT>
                     <a:lnB w="9525" cap="flat" cmpd="sng" algn="ctr">
                       <a:solidFill>
-                        <a:srgbClr val="E5E7EB"/>
+                        <a:srgbClr val="E8E4DA"/>
                       </a:solidFill>
                       <a:prstDash val="solid"/>
                       <a:round/>
@@ -19770,7 +19842,7 @@
                       <a:r>
                         <a:rPr lang="en-US" sz="1300" b="1" dirty="0">
                           <a:solidFill>
-                            <a:srgbClr val="1A1A1A"/>
+                            <a:srgbClr val="2C3639"/>
                           </a:solidFill>
                           <a:latin typeface="Calibri" pitchFamily="34" charset="0"/>
                           <a:ea typeface="Calibri" pitchFamily="34" charset="-122"/>
@@ -19797,7 +19869,7 @@
                     </a:lnT>
                     <a:lnB w="9525" cap="flat" cmpd="sng" algn="ctr">
                       <a:solidFill>
-                        <a:srgbClr val="E5E7EB"/>
+                        <a:srgbClr val="E8E4DA"/>
                       </a:solidFill>
                       <a:prstDash val="solid"/>
                       <a:round/>
@@ -19819,7 +19891,7 @@
                       <a:r>
                         <a:rPr lang="en-US" sz="1300" b="1" dirty="0">
                           <a:solidFill>
-                            <a:srgbClr val="1A1A1A"/>
+                            <a:srgbClr val="2C3639"/>
                           </a:solidFill>
                           <a:latin typeface="Calibri" pitchFamily="34" charset="0"/>
                           <a:ea typeface="Calibri" pitchFamily="34" charset="-122"/>
@@ -19846,7 +19918,7 @@
                     </a:lnT>
                     <a:lnB w="9525" cap="flat" cmpd="sng" algn="ctr">
                       <a:solidFill>
-                        <a:srgbClr val="E5E7EB"/>
+                        <a:srgbClr val="E8E4DA"/>
                       </a:solidFill>
                       <a:prstDash val="solid"/>
                       <a:round/>
@@ -19866,7 +19938,7 @@
                       <a:r>
                         <a:rPr lang="en-US" sz="1300" b="1" dirty="0">
                           <a:solidFill>
-                            <a:srgbClr val="1A1A1A"/>
+                            <a:srgbClr val="2C3639"/>
                           </a:solidFill>
                           <a:latin typeface="Calibri" pitchFamily="34" charset="0"/>
                           <a:ea typeface="Calibri" pitchFamily="34" charset="-122"/>
@@ -19893,7 +19965,7 @@
                     </a:lnT>
                     <a:lnB w="9525" cap="flat" cmpd="sng" algn="ctr">
                       <a:solidFill>
-                        <a:srgbClr val="E5E7EB"/>
+                        <a:srgbClr val="E8E4DA"/>
                       </a:solidFill>
                       <a:prstDash val="solid"/>
                       <a:round/>
@@ -19913,7 +19985,7 @@
                       <a:r>
                         <a:rPr lang="en-US" sz="1300" b="1" dirty="0">
                           <a:solidFill>
-                            <a:srgbClr val="1A1A1A"/>
+                            <a:srgbClr val="2C3639"/>
                           </a:solidFill>
                           <a:latin typeface="Calibri" pitchFamily="34" charset="0"/>
                           <a:ea typeface="Calibri" pitchFamily="34" charset="-122"/>
@@ -19940,7 +20012,7 @@
                     </a:lnT>
                     <a:lnB w="9525" cap="flat" cmpd="sng" algn="ctr">
                       <a:solidFill>
-                        <a:srgbClr val="E5E7EB"/>
+                        <a:srgbClr val="E8E4DA"/>
                       </a:solidFill>
                       <a:prstDash val="solid"/>
                       <a:round/>
@@ -19960,7 +20032,7 @@
                       <a:r>
                         <a:rPr lang="en-US" sz="1300" b="1" dirty="0">
                           <a:solidFill>
-                            <a:srgbClr val="1A1A1A"/>
+                            <a:srgbClr val="2C3639"/>
                           </a:solidFill>
                           <a:latin typeface="Calibri" pitchFamily="34" charset="0"/>
                           <a:ea typeface="Calibri" pitchFamily="34" charset="-122"/>
@@ -19987,7 +20059,7 @@
                     </a:lnT>
                     <a:lnB w="9525" cap="flat" cmpd="sng" algn="ctr">
                       <a:solidFill>
-                        <a:srgbClr val="E5E7EB"/>
+                        <a:srgbClr val="E8E4DA"/>
                       </a:solidFill>
                       <a:prstDash val="solid"/>
                       <a:round/>
@@ -20088,7 +20160,7 @@
           <a:noFill/>
           <a:ln w="9525">
             <a:solidFill>
-              <a:srgbClr val="9AA3AE"/>
+              <a:srgbClr val="A9A598"/>
             </a:solidFill>
             <a:prstDash val="solid"/>
           </a:ln>
@@ -20113,7 +20185,7 @@
           </a:solidFill>
           <a:ln w="9525">
             <a:solidFill>
-              <a:srgbClr val="1F3A5F"/>
+              <a:srgbClr val="2C3639"/>
             </a:solidFill>
             <a:prstDash val="solid"/>
           </a:ln>
@@ -20138,7 +20210,7 @@
           </a:solidFill>
           <a:ln w="9525">
             <a:solidFill>
-              <a:srgbClr val="1F3A5F"/>
+              <a:srgbClr val="2C3639"/>
             </a:solidFill>
             <a:prstDash val="solid"/>
           </a:ln>
@@ -20163,7 +20235,7 @@
           </a:solidFill>
           <a:ln w="9525">
             <a:solidFill>
-              <a:srgbClr val="A23B2A"/>
+              <a:srgbClr val="A27B5C"/>
             </a:solidFill>
             <a:prstDash val="solid"/>
           </a:ln>
@@ -20188,7 +20260,7 @@
           </a:solidFill>
           <a:ln w="9525">
             <a:solidFill>
-              <a:srgbClr val="9AA3AE"/>
+              <a:srgbClr val="A9A598"/>
             </a:solidFill>
             <a:prstDash val="solid"/>
           </a:ln>
@@ -20213,7 +20285,7 @@
           </a:solidFill>
           <a:ln w="9525">
             <a:solidFill>
-              <a:srgbClr val="9AA3AE"/>
+              <a:srgbClr val="A9A598"/>
             </a:solidFill>
             <a:prstDash val="solid"/>
           </a:ln>
@@ -20238,7 +20310,7 @@
           </a:solidFill>
           <a:ln w="9525">
             <a:solidFill>
-              <a:srgbClr val="9AA3AE"/>
+              <a:srgbClr val="A9A598"/>
             </a:solidFill>
             <a:prstDash val="solid"/>
           </a:ln>
@@ -20338,7 +20410,7 @@
           <a:noFill/>
           <a:ln w="9525">
             <a:solidFill>
-              <a:srgbClr val="6B7280"/>
+              <a:srgbClr val="6F7877"/>
             </a:solidFill>
             <a:prstDash val="solid"/>
           </a:ln>
@@ -20397,7 +20469,7 @@
           <a:noFill/>
           <a:ln w="9525">
             <a:solidFill>
-              <a:srgbClr val="E5E7EB"/>
+              <a:srgbClr val="E8E4DA"/>
             </a:solidFill>
             <a:prstDash val="solid"/>
           </a:ln>
@@ -20456,7 +20528,7 @@
           <a:noFill/>
           <a:ln w="9525">
             <a:solidFill>
-              <a:srgbClr val="E5E7EB"/>
+              <a:srgbClr val="E8E4DA"/>
             </a:solidFill>
             <a:prstDash val="solid"/>
           </a:ln>
@@ -20515,7 +20587,7 @@
           <a:noFill/>
           <a:ln w="9525">
             <a:solidFill>
-              <a:srgbClr val="E5E7EB"/>
+              <a:srgbClr val="E8E4DA"/>
             </a:solidFill>
             <a:prstDash val="solid"/>
           </a:ln>
@@ -20574,7 +20646,7 @@
           <a:noFill/>
           <a:ln w="9525">
             <a:solidFill>
-              <a:srgbClr val="E5E7EB"/>
+              <a:srgbClr val="E8E4DA"/>
             </a:solidFill>
             <a:prstDash val="solid"/>
           </a:ln>
@@ -20633,7 +20705,7 @@
           <a:noFill/>
           <a:ln w="9525">
             <a:solidFill>
-              <a:srgbClr val="E5E7EB"/>
+              <a:srgbClr val="E8E4DA"/>
             </a:solidFill>
             <a:prstDash val="solid"/>
           </a:ln>
@@ -20692,7 +20764,7 @@
           <a:noFill/>
           <a:ln w="9525">
             <a:solidFill>
-              <a:srgbClr val="E5E7EB"/>
+              <a:srgbClr val="E8E4DA"/>
             </a:solidFill>
             <a:prstDash val="solid"/>
           </a:ln>
@@ -21003,7 +21075,7 @@
           <a:noFill/>
           <a:ln w="12700">
             <a:solidFill>
-              <a:srgbClr val="1A1A1A"/>
+              <a:srgbClr val="2C3639"/>
             </a:solidFill>
             <a:prstDash val="dash"/>
           </a:ln>
@@ -21246,7 +21318,7 @@
           </a:custGeom>
           <a:ln w="25400">
             <a:solidFill>
-              <a:srgbClr val="6B7280"/>
+              <a:srgbClr val="A9A598"/>
             </a:solidFill>
             <a:prstDash val="solid"/>
           </a:ln>
@@ -21267,7 +21339,7 @@
             <a:avLst/>
           </a:prstGeom>
           <a:solidFill>
-            <a:srgbClr val="6B7280"/>
+            <a:srgbClr val="A9A598"/>
           </a:solidFill>
           <a:ln w="6350">
             <a:solidFill>
@@ -21478,7 +21550,7 @@
           </a:custGeom>
           <a:ln w="25400">
             <a:solidFill>
-              <a:srgbClr val="17A2B8"/>
+              <a:srgbClr val="6E9C9A"/>
             </a:solidFill>
             <a:prstDash val="solid"/>
           </a:ln>
@@ -21499,7 +21571,7 @@
             <a:avLst/>
           </a:prstGeom>
           <a:solidFill>
-            <a:srgbClr val="17A2B8"/>
+            <a:srgbClr val="6E9C9A"/>
           </a:solidFill>
           <a:ln w="6350">
             <a:solidFill>
@@ -21710,7 +21782,7 @@
           </a:custGeom>
           <a:ln w="25400">
             <a:solidFill>
-              <a:srgbClr val="8C564B"/>
+              <a:srgbClr val="B47F7B"/>
             </a:solidFill>
             <a:prstDash val="solid"/>
           </a:ln>
@@ -21731,7 +21803,7 @@
             <a:avLst/>
           </a:prstGeom>
           <a:solidFill>
-            <a:srgbClr val="8C564B"/>
+            <a:srgbClr val="B47F7B"/>
           </a:solidFill>
           <a:ln w="6350">
             <a:solidFill>
@@ -21942,7 +22014,7 @@
           </a:custGeom>
           <a:ln w="25400">
             <a:solidFill>
-              <a:srgbClr val="2E8B57"/>
+              <a:srgbClr val="7F9160"/>
             </a:solidFill>
             <a:prstDash val="solid"/>
           </a:ln>
@@ -21963,7 +22035,7 @@
             <a:avLst/>
           </a:prstGeom>
           <a:solidFill>
-            <a:srgbClr val="2E8B57"/>
+            <a:srgbClr val="7F9160"/>
           </a:solidFill>
           <a:ln w="6350">
             <a:solidFill>
@@ -22174,7 +22246,7 @@
           </a:custGeom>
           <a:ln w="25400">
             <a:solidFill>
-              <a:srgbClr val="7B6BA8"/>
+              <a:srgbClr val="8D7CA0"/>
             </a:solidFill>
             <a:prstDash val="solid"/>
           </a:ln>
@@ -22195,7 +22267,7 @@
             <a:avLst/>
           </a:prstGeom>
           <a:solidFill>
-            <a:srgbClr val="7B6BA8"/>
+            <a:srgbClr val="8D7CA0"/>
           </a:solidFill>
           <a:ln w="6350">
             <a:solidFill>
@@ -22406,7 +22478,7 @@
           </a:custGeom>
           <a:ln w="25400">
             <a:solidFill>
-              <a:srgbClr val="4C78A8"/>
+              <a:srgbClr val="5A7A8C"/>
             </a:solidFill>
             <a:prstDash val="solid"/>
           </a:ln>
@@ -22427,7 +22499,7 @@
             <a:avLst/>
           </a:prstGeom>
           <a:solidFill>
-            <a:srgbClr val="4C78A8"/>
+            <a:srgbClr val="5A7A8C"/>
           </a:solidFill>
           <a:ln w="6350">
             <a:solidFill>
@@ -22638,7 +22710,7 @@
           </a:custGeom>
           <a:ln w="25400">
             <a:solidFill>
-              <a:srgbClr val="1F3A5F"/>
+              <a:srgbClr val="2C3639"/>
             </a:solidFill>
             <a:prstDash val="solid"/>
           </a:ln>
@@ -22659,7 +22731,7 @@
             <a:avLst/>
           </a:prstGeom>
           <a:solidFill>
-            <a:srgbClr val="1F3A5F"/>
+            <a:srgbClr val="2C3639"/>
           </a:solidFill>
           <a:ln w="6350">
             <a:solidFill>
@@ -22870,7 +22942,7 @@
           </a:custGeom>
           <a:ln w="25400">
             <a:solidFill>
-              <a:srgbClr val="D08C34"/>
+              <a:srgbClr val="C9A040"/>
             </a:solidFill>
             <a:prstDash val="solid"/>
           </a:ln>
@@ -22891,7 +22963,7 @@
             <a:avLst/>
           </a:prstGeom>
           <a:solidFill>
-            <a:srgbClr val="D08C34"/>
+            <a:srgbClr val="C9A040"/>
           </a:solidFill>
           <a:ln w="6350">
             <a:solidFill>
@@ -23102,7 +23174,7 @@
           </a:custGeom>
           <a:ln w="38100">
             <a:solidFill>
-              <a:srgbClr val="A23B2A"/>
+              <a:srgbClr val="A27B5C"/>
             </a:solidFill>
             <a:prstDash val="solid"/>
           </a:ln>
@@ -23123,7 +23195,7 @@
             <a:avLst/>
           </a:prstGeom>
           <a:solidFill>
-            <a:srgbClr val="A23B2A"/>
+            <a:srgbClr val="A27B5C"/>
           </a:solidFill>
           <a:ln w="6350">
             <a:solidFill>
@@ -23186,7 +23258,7 @@
           <a:noFill/>
           <a:ln w="9525">
             <a:solidFill>
-              <a:srgbClr val="6B7280"/>
+              <a:srgbClr val="A9A598"/>
             </a:solidFill>
             <a:prstDash val="solid"/>
           </a:ln>
@@ -23279,7 +23351,7 @@
             <a:r>
               <a:rPr lang="en-US" sz="1300" b="1" dirty="0">
                 <a:solidFill>
-                  <a:srgbClr val="6B7280"/>
+                  <a:srgbClr val="A9A598"/>
                 </a:solidFill>
               </a:rPr>
               <a:t>−1.9%</a:t>
@@ -23305,7 +23377,7 @@
           <a:noFill/>
           <a:ln w="9525">
             <a:solidFill>
-              <a:srgbClr val="17A2B8"/>
+              <a:srgbClr val="6E9C9A"/>
             </a:solidFill>
             <a:prstDash val="solid"/>
           </a:ln>
@@ -23398,7 +23470,7 @@
             <a:r>
               <a:rPr lang="en-US" sz="1300" b="1" dirty="0">
                 <a:solidFill>
-                  <a:srgbClr val="17A2B8"/>
+                  <a:srgbClr val="6E9C9A"/>
                 </a:solidFill>
               </a:rPr>
               <a:t>−5.4%</a:t>
@@ -23424,7 +23496,7 @@
           <a:noFill/>
           <a:ln w="9525">
             <a:solidFill>
-              <a:srgbClr val="8C564B"/>
+              <a:srgbClr val="B47F7B"/>
             </a:solidFill>
             <a:prstDash val="solid"/>
           </a:ln>
@@ -23517,7 +23589,7 @@
             <a:r>
               <a:rPr lang="en-US" sz="1300" b="1" dirty="0">
                 <a:solidFill>
-                  <a:srgbClr val="8C564B"/>
+                  <a:srgbClr val="B47F7B"/>
                 </a:solidFill>
               </a:rPr>
               <a:t>−6.1%</a:t>
@@ -23543,7 +23615,7 @@
           <a:noFill/>
           <a:ln w="9525">
             <a:solidFill>
-              <a:srgbClr val="2E8B57"/>
+              <a:srgbClr val="7F9160"/>
             </a:solidFill>
             <a:prstDash val="solid"/>
           </a:ln>
@@ -23636,7 +23708,7 @@
             <a:r>
               <a:rPr lang="en-US" sz="1300" b="1" dirty="0">
                 <a:solidFill>
-                  <a:srgbClr val="2E8B57"/>
+                  <a:srgbClr val="7F9160"/>
                 </a:solidFill>
               </a:rPr>
               <a:t>−6.8%</a:t>
@@ -23662,7 +23734,7 @@
           <a:noFill/>
           <a:ln w="9525">
             <a:solidFill>
-              <a:srgbClr val="7B6BA8"/>
+              <a:srgbClr val="8D7CA0"/>
             </a:solidFill>
             <a:prstDash val="solid"/>
           </a:ln>
@@ -23755,7 +23827,7 @@
             <a:r>
               <a:rPr lang="en-US" sz="1300" b="1" dirty="0">
                 <a:solidFill>
-                  <a:srgbClr val="7B6BA8"/>
+                  <a:srgbClr val="8D7CA0"/>
                 </a:solidFill>
               </a:rPr>
               <a:t>−9.1%</a:t>
@@ -23781,7 +23853,7 @@
           <a:noFill/>
           <a:ln w="9525">
             <a:solidFill>
-              <a:srgbClr val="4C78A8"/>
+              <a:srgbClr val="5A7A8C"/>
             </a:solidFill>
             <a:prstDash val="solid"/>
           </a:ln>
@@ -23874,7 +23946,7 @@
             <a:r>
               <a:rPr lang="en-US" sz="1300" b="1" dirty="0">
                 <a:solidFill>
-                  <a:srgbClr val="4C78A8"/>
+                  <a:srgbClr val="5A7A8C"/>
                 </a:solidFill>
               </a:rPr>
               <a:t>−9.8%</a:t>
@@ -23900,7 +23972,7 @@
           <a:noFill/>
           <a:ln w="9525">
             <a:solidFill>
-              <a:srgbClr val="1F3A5F"/>
+              <a:srgbClr val="2C3639"/>
             </a:solidFill>
             <a:prstDash val="solid"/>
           </a:ln>
@@ -23993,7 +24065,7 @@
             <a:r>
               <a:rPr lang="en-US" sz="1300" b="1" dirty="0">
                 <a:solidFill>
-                  <a:srgbClr val="1F3A5F"/>
+                  <a:srgbClr val="2C3639"/>
                 </a:solidFill>
               </a:rPr>
               <a:t>−10.1%</a:t>
@@ -24019,7 +24091,7 @@
           <a:noFill/>
           <a:ln w="9525">
             <a:solidFill>
-              <a:srgbClr val="D08C34"/>
+              <a:srgbClr val="C9A040"/>
             </a:solidFill>
             <a:prstDash val="solid"/>
           </a:ln>
@@ -24112,7 +24184,7 @@
             <a:r>
               <a:rPr lang="en-US" sz="1300" b="1" dirty="0">
                 <a:solidFill>
-                  <a:srgbClr val="D08C34"/>
+                  <a:srgbClr val="C9A040"/>
                 </a:solidFill>
               </a:rPr>
               <a:t>−10.2%</a:t>
@@ -24138,7 +24210,7 @@
           <a:noFill/>
           <a:ln w="9525">
             <a:solidFill>
-              <a:srgbClr val="A23B2A"/>
+              <a:srgbClr val="A27B5C"/>
             </a:solidFill>
             <a:prstDash val="solid"/>
           </a:ln>
@@ -24231,7 +24303,7 @@
             <a:r>
               <a:rPr lang="en-US" sz="1300" b="1" dirty="0">
                 <a:solidFill>
-                  <a:srgbClr val="A23B2A"/>
+                  <a:srgbClr val="A27B5C"/>
                 </a:solidFill>
               </a:rPr>
               <a:t>−15.8%</a:t>
@@ -24270,7 +24342,7 @@
                   <a:schemeClr val="accent3"/>
                 </a:solidFill>
               </a:rPr>
-              <a:t>Lines: one shared time course (saturating, τ = 60 days) scaled to each group's estimate at day 60. Control groups, days 5 to 119.</a:t>
+              <a:t>Figure 7. Change in muscle size by muscle group: one shared time course (τ = 60 days) scaled to each group's day-60 estimate; control groups, days 5 to 119.</a:t>
             </a:r>
             <a:endParaRPr lang="en-US" sz="1050" dirty="0"/>
           </a:p>
@@ -24363,7 +24435,7 @@
           <a:noFill/>
           <a:ln w="9525">
             <a:solidFill>
-              <a:srgbClr val="9AA3AE"/>
+              <a:srgbClr val="A9A598"/>
             </a:solidFill>
             <a:prstDash val="solid"/>
           </a:ln>
@@ -24388,7 +24460,7 @@
           </a:solidFill>
           <a:ln w="9525">
             <a:solidFill>
-              <a:srgbClr val="1F3A5F"/>
+              <a:srgbClr val="2C3639"/>
             </a:solidFill>
             <a:prstDash val="solid"/>
           </a:ln>
@@ -24413,7 +24485,7 @@
           </a:solidFill>
           <a:ln w="9525">
             <a:solidFill>
-              <a:srgbClr val="1F3A5F"/>
+              <a:srgbClr val="2C3639"/>
             </a:solidFill>
             <a:prstDash val="solid"/>
           </a:ln>
@@ -24438,7 +24510,7 @@
           </a:solidFill>
           <a:ln w="9525">
             <a:solidFill>
-              <a:srgbClr val="1F3A5F"/>
+              <a:srgbClr val="2C3639"/>
             </a:solidFill>
             <a:prstDash val="solid"/>
           </a:ln>
@@ -24463,7 +24535,7 @@
           </a:solidFill>
           <a:ln w="9525">
             <a:solidFill>
-              <a:srgbClr val="A23B2A"/>
+              <a:srgbClr val="A27B5C"/>
             </a:solidFill>
             <a:prstDash val="solid"/>
           </a:ln>
@@ -24488,7 +24560,7 @@
           </a:solidFill>
           <a:ln w="9525">
             <a:solidFill>
-              <a:srgbClr val="9AA3AE"/>
+              <a:srgbClr val="A9A598"/>
             </a:solidFill>
             <a:prstDash val="solid"/>
           </a:ln>
@@ -24513,7 +24585,7 @@
           </a:solidFill>
           <a:ln w="9525">
             <a:solidFill>
-              <a:srgbClr val="9AA3AE"/>
+              <a:srgbClr val="A9A598"/>
             </a:solidFill>
             <a:prstDash val="solid"/>
           </a:ln>
@@ -24615,7 +24687,7 @@
           </a:solidFill>
           <a:ln w="12700">
             <a:solidFill>
-              <a:srgbClr val="9AA3AE"/>
+              <a:srgbClr val="A9A598"/>
             </a:solidFill>
             <a:prstDash val="solid"/>
           </a:ln>
@@ -24764,7 +24836,7 @@
           <a:noFill/>
           <a:ln w="15875">
             <a:solidFill>
-              <a:srgbClr val="1A1A1A"/>
+              <a:srgbClr val="2C3639"/>
             </a:solidFill>
             <a:prstDash val="solid"/>
             <a:tailEnd type="triangle"/>
@@ -24790,7 +24862,7 @@
           </a:solidFill>
           <a:ln w="12700">
             <a:solidFill>
-              <a:srgbClr val="9AA3AE"/>
+              <a:srgbClr val="A9A598"/>
             </a:solidFill>
             <a:prstDash val="solid"/>
           </a:ln>
@@ -24921,7 +24993,7 @@
           <a:noFill/>
           <a:ln w="15875">
             <a:solidFill>
-              <a:srgbClr val="1A1A1A"/>
+              <a:srgbClr val="2C3639"/>
             </a:solidFill>
             <a:prstDash val="solid"/>
             <a:tailEnd type="triangle"/>
@@ -24947,7 +25019,7 @@
           </a:solidFill>
           <a:ln w="12700">
             <a:solidFill>
-              <a:srgbClr val="9AA3AE"/>
+              <a:srgbClr val="A9A598"/>
             </a:solidFill>
             <a:prstDash val="solid"/>
           </a:ln>
@@ -25026,7 +25098,7 @@
         <p:spPr>
           <a:xfrm>
             <a:off x="548640" y="4023360"/>
-            <a:ext cx="7315200" cy="274320"/>
+            <a:ext cx="9144000" cy="274320"/>
           </a:xfrm>
           <a:prstGeom prst="rect">
             <a:avLst/>
@@ -25047,7 +25119,7 @@
                   <a:schemeClr val="tx2"/>
                 </a:solidFill>
               </a:rPr>
-              <a:t>Testing: hold out one campaign, train on the rest, repeat 32 times</a:t>
+              <a:t>Figure 8. Testing: hold out one campaign, train on the rest, repeat 32 times</a:t>
             </a:r>
             <a:endParaRPr lang="en-US" sz="1500" dirty="0"/>
           </a:p>
@@ -25072,7 +25144,7 @@
           </a:solidFill>
           <a:ln w="6350">
             <a:solidFill>
-              <a:srgbClr val="9AA3AE"/>
+              <a:srgbClr val="A9A598"/>
             </a:solidFill>
             <a:prstDash val="solid"/>
           </a:ln>
@@ -25097,7 +25169,7 @@
           </a:solidFill>
           <a:ln w="6350">
             <a:solidFill>
-              <a:srgbClr val="9AA3AE"/>
+              <a:srgbClr val="A9A598"/>
             </a:solidFill>
             <a:prstDash val="solid"/>
           </a:ln>
@@ -25122,7 +25194,7 @@
           </a:solidFill>
           <a:ln w="6350">
             <a:solidFill>
-              <a:srgbClr val="9AA3AE"/>
+              <a:srgbClr val="A9A598"/>
             </a:solidFill>
             <a:prstDash val="solid"/>
           </a:ln>
@@ -25147,7 +25219,7 @@
           </a:solidFill>
           <a:ln w="6350">
             <a:solidFill>
-              <a:srgbClr val="9AA3AE"/>
+              <a:srgbClr val="A9A598"/>
             </a:solidFill>
             <a:prstDash val="solid"/>
           </a:ln>
@@ -25172,7 +25244,7 @@
           </a:solidFill>
           <a:ln w="6350">
             <a:solidFill>
-              <a:srgbClr val="9AA3AE"/>
+              <a:srgbClr val="A9A598"/>
             </a:solidFill>
             <a:prstDash val="solid"/>
           </a:ln>
@@ -25197,7 +25269,7 @@
           </a:solidFill>
           <a:ln w="6350">
             <a:solidFill>
-              <a:srgbClr val="9AA3AE"/>
+              <a:srgbClr val="A9A598"/>
             </a:solidFill>
             <a:prstDash val="solid"/>
           </a:ln>
@@ -25222,7 +25294,7 @@
           </a:solidFill>
           <a:ln w="6350">
             <a:solidFill>
-              <a:srgbClr val="9AA3AE"/>
+              <a:srgbClr val="A9A598"/>
             </a:solidFill>
             <a:prstDash val="solid"/>
           </a:ln>
@@ -25247,7 +25319,7 @@
           </a:solidFill>
           <a:ln w="6350">
             <a:solidFill>
-              <a:srgbClr val="9AA3AE"/>
+              <a:srgbClr val="A9A598"/>
             </a:solidFill>
             <a:prstDash val="solid"/>
           </a:ln>
@@ -25272,7 +25344,7 @@
           </a:solidFill>
           <a:ln w="6350">
             <a:solidFill>
-              <a:srgbClr val="9AA3AE"/>
+              <a:srgbClr val="A9A598"/>
             </a:solidFill>
             <a:prstDash val="solid"/>
           </a:ln>
@@ -25297,7 +25369,7 @@
           </a:solidFill>
           <a:ln w="6350">
             <a:solidFill>
-              <a:srgbClr val="9AA3AE"/>
+              <a:srgbClr val="A9A598"/>
             </a:solidFill>
             <a:prstDash val="solid"/>
           </a:ln>
@@ -25322,7 +25394,7 @@
           </a:solidFill>
           <a:ln w="6350">
             <a:solidFill>
-              <a:srgbClr val="9AA3AE"/>
+              <a:srgbClr val="A9A598"/>
             </a:solidFill>
             <a:prstDash val="solid"/>
           </a:ln>
@@ -25347,7 +25419,7 @@
           </a:solidFill>
           <a:ln w="6350">
             <a:solidFill>
-              <a:srgbClr val="9AA3AE"/>
+              <a:srgbClr val="A9A598"/>
             </a:solidFill>
             <a:prstDash val="solid"/>
           </a:ln>
@@ -25372,7 +25444,7 @@
           </a:solidFill>
           <a:ln w="6350">
             <a:solidFill>
-              <a:srgbClr val="9AA3AE"/>
+              <a:srgbClr val="A9A598"/>
             </a:solidFill>
             <a:prstDash val="solid"/>
           </a:ln>
@@ -25397,7 +25469,7 @@
           </a:solidFill>
           <a:ln w="6350">
             <a:solidFill>
-              <a:srgbClr val="A23B2A"/>
+              <a:srgbClr val="A27B5C"/>
             </a:solidFill>
             <a:prstDash val="solid"/>
           </a:ln>
@@ -25422,7 +25494,7 @@
           </a:solidFill>
           <a:ln w="6350">
             <a:solidFill>
-              <a:srgbClr val="9AA3AE"/>
+              <a:srgbClr val="A9A598"/>
             </a:solidFill>
             <a:prstDash val="solid"/>
           </a:ln>
@@ -25447,7 +25519,7 @@
           </a:solidFill>
           <a:ln w="6350">
             <a:solidFill>
-              <a:srgbClr val="9AA3AE"/>
+              <a:srgbClr val="A9A598"/>
             </a:solidFill>
             <a:prstDash val="solid"/>
           </a:ln>
@@ -25472,7 +25544,7 @@
           </a:solidFill>
           <a:ln w="6350">
             <a:solidFill>
-              <a:srgbClr val="9AA3AE"/>
+              <a:srgbClr val="A9A598"/>
             </a:solidFill>
             <a:prstDash val="solid"/>
           </a:ln>
@@ -25497,7 +25569,7 @@
           </a:solidFill>
           <a:ln w="6350">
             <a:solidFill>
-              <a:srgbClr val="9AA3AE"/>
+              <a:srgbClr val="A9A598"/>
             </a:solidFill>
             <a:prstDash val="solid"/>
           </a:ln>
@@ -25522,7 +25594,7 @@
           </a:solidFill>
           <a:ln w="6350">
             <a:solidFill>
-              <a:srgbClr val="9AA3AE"/>
+              <a:srgbClr val="A9A598"/>
             </a:solidFill>
             <a:prstDash val="solid"/>
           </a:ln>
@@ -25547,7 +25619,7 @@
           </a:solidFill>
           <a:ln w="6350">
             <a:solidFill>
-              <a:srgbClr val="9AA3AE"/>
+              <a:srgbClr val="A9A598"/>
             </a:solidFill>
             <a:prstDash val="solid"/>
           </a:ln>
@@ -25572,7 +25644,7 @@
           </a:solidFill>
           <a:ln w="6350">
             <a:solidFill>
-              <a:srgbClr val="9AA3AE"/>
+              <a:srgbClr val="A9A598"/>
             </a:solidFill>
             <a:prstDash val="solid"/>
           </a:ln>
@@ -25597,7 +25669,7 @@
           </a:solidFill>
           <a:ln w="6350">
             <a:solidFill>
-              <a:srgbClr val="9AA3AE"/>
+              <a:srgbClr val="A9A598"/>
             </a:solidFill>
             <a:prstDash val="solid"/>
           </a:ln>
@@ -25622,7 +25694,7 @@
           </a:solidFill>
           <a:ln w="6350">
             <a:solidFill>
-              <a:srgbClr val="9AA3AE"/>
+              <a:srgbClr val="A9A598"/>
             </a:solidFill>
             <a:prstDash val="solid"/>
           </a:ln>
@@ -25647,7 +25719,7 @@
           </a:solidFill>
           <a:ln w="6350">
             <a:solidFill>
-              <a:srgbClr val="9AA3AE"/>
+              <a:srgbClr val="A9A598"/>
             </a:solidFill>
             <a:prstDash val="solid"/>
           </a:ln>
@@ -25672,7 +25744,7 @@
           </a:solidFill>
           <a:ln w="6350">
             <a:solidFill>
-              <a:srgbClr val="9AA3AE"/>
+              <a:srgbClr val="A9A598"/>
             </a:solidFill>
             <a:prstDash val="solid"/>
           </a:ln>
@@ -25697,7 +25769,7 @@
           </a:solidFill>
           <a:ln w="6350">
             <a:solidFill>
-              <a:srgbClr val="9AA3AE"/>
+              <a:srgbClr val="A9A598"/>
             </a:solidFill>
             <a:prstDash val="solid"/>
           </a:ln>
@@ -25722,7 +25794,7 @@
           </a:solidFill>
           <a:ln w="6350">
             <a:solidFill>
-              <a:srgbClr val="9AA3AE"/>
+              <a:srgbClr val="A9A598"/>
             </a:solidFill>
             <a:prstDash val="solid"/>
           </a:ln>
@@ -25747,7 +25819,7 @@
           </a:solidFill>
           <a:ln w="6350">
             <a:solidFill>
-              <a:srgbClr val="9AA3AE"/>
+              <a:srgbClr val="A9A598"/>
             </a:solidFill>
             <a:prstDash val="solid"/>
           </a:ln>
@@ -25772,7 +25844,7 @@
           </a:solidFill>
           <a:ln w="6350">
             <a:solidFill>
-              <a:srgbClr val="9AA3AE"/>
+              <a:srgbClr val="A9A598"/>
             </a:solidFill>
             <a:prstDash val="solid"/>
           </a:ln>
@@ -25797,7 +25869,7 @@
           </a:solidFill>
           <a:ln w="6350">
             <a:solidFill>
-              <a:srgbClr val="9AA3AE"/>
+              <a:srgbClr val="A9A598"/>
             </a:solidFill>
             <a:prstDash val="solid"/>
           </a:ln>
@@ -25822,7 +25894,7 @@
           </a:solidFill>
           <a:ln w="6350">
             <a:solidFill>
-              <a:srgbClr val="9AA3AE"/>
+              <a:srgbClr val="A9A598"/>
             </a:solidFill>
             <a:prstDash val="solid"/>
           </a:ln>
@@ -25847,7 +25919,7 @@
           </a:solidFill>
           <a:ln w="6350">
             <a:solidFill>
-              <a:srgbClr val="9AA3AE"/>
+              <a:srgbClr val="A9A598"/>
             </a:solidFill>
             <a:prstDash val="solid"/>
           </a:ln>
@@ -25894,7 +25966,7 @@
                   <a:schemeClr val="accent1"/>
                 </a:solidFill>
               </a:rPr>
-              <a:t>Red: the held-out test campaign.</a:t>
+              <a:t>Brown: the held-out test campaign.</a:t>
             </a:r>
             <a:pPr indent="0" marL="0">
               <a:buNone/>
@@ -26027,40 +26099,40 @@
   <a:themeElements>
     <a:clrScheme name="Bed Rest to Mars academic">
       <a:dk1>
-        <a:srgbClr val="1A1A1A"/>
+        <a:srgbClr val="2C3639"/>
       </a:dk1>
       <a:lt1>
         <a:srgbClr val="FFFFFF"/>
       </a:lt1>
       <a:dk2>
-        <a:srgbClr val="1F3A5F"/>
+        <a:srgbClr val="2C3639"/>
       </a:dk2>
       <a:lt2>
-        <a:srgbClr val="F4F5F7"/>
+        <a:srgbClr val="F3F0E9"/>
       </a:lt2>
       <a:accent1>
-        <a:srgbClr val="A23B2A"/>
+        <a:srgbClr val="A27B5C"/>
       </a:accent1>
       <a:accent2>
-        <a:srgbClr val="1F3A5F"/>
+        <a:srgbClr val="3F4E4F"/>
       </a:accent2>
       <a:accent3>
-        <a:srgbClr val="6B7280"/>
+        <a:srgbClr val="6F7877"/>
       </a:accent3>
       <a:accent4>
-        <a:srgbClr val="A7AEB8"/>
+        <a:srgbClr val="C4BEB0"/>
       </a:accent4>
       <a:accent5>
-        <a:srgbClr val="9AA3AE"/>
+        <a:srgbClr val="A9A598"/>
       </a:accent5>
       <a:accent6>
-        <a:srgbClr val="E5E7EB"/>
+        <a:srgbClr val="E8E4DA"/>
       </a:accent6>
       <a:hlink>
-        <a:srgbClr val="1F3A5F"/>
+        <a:srgbClr val="3F4E4F"/>
       </a:hlink>
       <a:folHlink>
-        <a:srgbClr val="6B7280"/>
+        <a:srgbClr val="6F7877"/>
       </a:folHlink>
     </a:clrScheme>
     <a:fontScheme name="Bed Rest to Mars academic">

</xml_diff>

<commit_message>
Condense conclusions slide: two columns on top, further work below
Co-Authored-By: Claude Opus 5.5 (1M context) <noreply@anthropic.com>
Claude-Session: https://claude.ai/code/session_01JZtuYERhuCe7nB9VYHwcfv
</commit_message>
<xml_diff>
--- a/presentation/bed-rest-to-mars-talk.pptx
+++ b/presentation/bed-rest-to-mars-talk.pptx
@@ -124,13 +124,13 @@
   <p:extLst>
     <p:ext uri="{521415D9-36F7-43E2-AB2F-B90AF26B5E84}">
       <p14:sectionLst xmlns:p14="http://schemas.microsoft.com/office/powerpoint/2010/main">
-        <p14:section name="Opening" id="{155af95b-af42-929f-ad95-5c5b6b343bf7}">
+        <p14:section name="Opening" id="{bcb4df12-54f4-6163-6938-ae8afbb68747}">
           <p14:sldIdLst>
             <p14:sldId id="256"/>
             <p14:sldId id="257"/>
           </p14:sldIdLst>
         </p14:section>
-        <p14:section name="Part 1" id="{3bcafe2d-b464-76d2-84b2-86e0ada3aa2c}">
+        <p14:section name="Part 1" id="{56b65289-ec66-48b3-241d-2eaa60551133}">
           <p14:sldIdLst>
             <p14:sldId id="258"/>
             <p14:sldId id="259"/>
@@ -140,7 +140,7 @@
             <p14:sldId id="263"/>
           </p14:sldIdLst>
         </p14:section>
-        <p14:section name="Part 2" id="{e6a289ef-bcf1-5acd-6b91-70a2d7def056}">
+        <p14:section name="Part 2" id="{d859bc3c-9ad6-bfc5-e282-28378d9d1817}">
           <p14:sldIdLst>
             <p14:sldId id="264"/>
             <p14:sldId id="265"/>
@@ -149,7 +149,7 @@
             <p14:sldId id="268"/>
           </p14:sldIdLst>
         </p14:section>
-        <p14:section name="Backup" id="{725ad00d-eb6e-39b6-af67-d3ddae28cceb}">
+        <p14:section name="Backup" id="{acf4fa32-ab51-effa-ddef-e4262894e651}">
           <p14:sldIdLst>
             <p14:sldId id="269"/>
             <p14:sldId id="270"/>
@@ -158,16 +158,16 @@
             <p14:sldId id="273"/>
           </p14:sldIdLst>
         </p14:section>
-        <p14:section name="Backup" id="{e90acfed-5f95-1f6a-9d34-214730e3a323}">
+        <p14:section name="Backup" id="{a93da623-e2be-9fdc-369d-bdd599129203}">
           <p14:sldIdLst/>
         </p14:section>
-        <p14:section name="Backup" id="{941f4a64-99f9-3bcc-7aab-6095f5c103b5}">
+        <p14:section name="Backup" id="{18434d35-172b-10cc-f71a-005cbd1ba07b}">
           <p14:sldIdLst/>
         </p14:section>
-        <p14:section name="Backup" id="{d384def7-c818-61d1-5b98-2b0fac56c7a9}">
+        <p14:section name="Backup" id="{323cfc83-c2de-14cb-1fcd-9f739ab12fed}">
           <p14:sldIdLst/>
         </p14:section>
-        <p14:section name="Backup" id="{48716a63-e2fe-94d1-facb-0163cd72abcb}">
+        <p14:section name="Backup" id="{97606cd9-4e4f-4211-eb31-b3b0f44811dc}">
           <p14:sldIdLst/>
         </p14:section>
       </p14:sectionLst>
@@ -3285,7 +3285,8 @@
             <a:r>
               <a:rPr lang="en-US" dirty="0"/>
               <a:t>About thirty seconds.
-With 32 independent campaigns, standard ML models and TabPFN do not beat a curve that only knows the number of days. An LLM-based probabilistic classifier that reads each campaign's description and the other campaigns' data reduces the error from 3.13 to 2.71 points. The limitations and next steps are on the slide; the main one is that 32 campaigns is a small sample.
+With 32 independent campaigns, standard ML models and TabPFN do not beat a curve that only knows the number of days. An LLM-based probabilistic classifier that reads each campaign's description and the other campaigns' data reduces the error from 3.13 to 2.71 points. The main limitation is the small sample of 32 campaigns, mostly young men, with no bed-rest data beyond day 119.
+Next, we want to link the muscles, so that one muscle's loss predicts another's and a weighted sum estimates strength loss, and to build a risk-assessment system based on a person's characteristics.
 Thank you.</a:t>
             </a:r>
             <a:endParaRPr lang="en-US" dirty="0"/>
@@ -7717,8 +7718,8 @@
         </p:nvSpPr>
         <p:spPr>
           <a:xfrm>
-            <a:off x="548640" y="1325880"/>
-            <a:ext cx="3474720" cy="4754880"/>
+            <a:off x="548640" y="1280160"/>
+            <a:ext cx="5303520" cy="2377440"/>
           </a:xfrm>
           <a:prstGeom prst="rect">
             <a:avLst/>
@@ -7760,7 +7761,7 @@
                   <a:schemeClr val="tx1"/>
                 </a:solidFill>
               </a:rPr>
-              <a:t>With 32 independent campaigns, no ML model predicts better than a curve based on days alone (best 3.18 vs 3.16 pp error).</a:t>
+              <a:t>ML models do not beat a duration-only curve (3.18 vs 3.16 pp)</a:t>
             </a:r>
             <a:endParaRPr lang="en-US" sz="2000" dirty="0"/>
           </a:p>
@@ -7778,7 +7779,7 @@
                   <a:schemeClr val="tx1"/>
                 </a:solidFill>
               </a:rPr>
-              <a:t>An LLM that reads each campaign's description and the other campaigns' data cuts the error to 2.71 pp (curve 3.13 pp); the gain remains when everything identifying a campaign is hidden.</a:t>
+              <a:t>The LLM classifier lowers the error to 2.71 pp (curve 3.13 pp)</a:t>
             </a:r>
             <a:endParaRPr lang="en-US" sz="2000" dirty="0"/>
           </a:p>
@@ -7792,8 +7793,8 @@
         </p:nvSpPr>
         <p:spPr>
           <a:xfrm>
-            <a:off x="4343400" y="1325880"/>
-            <a:ext cx="3474720" cy="4754880"/>
+            <a:off x="6309360" y="1280160"/>
+            <a:ext cx="5303520" cy="2377440"/>
           </a:xfrm>
           <a:prstGeom prst="rect">
             <a:avLst/>
@@ -7835,7 +7836,7 @@
                   <a:schemeClr val="tx1"/>
                 </a:solidFill>
               </a:rPr>
-              <a:t>Only 32 independent campaigns</a:t>
+              <a:t>32 independent campaigns, mostly young men</a:t>
             </a:r>
             <a:endParaRPr lang="en-US" sz="2000" dirty="0"/>
           </a:p>
@@ -7853,7 +7854,7 @@
                   <a:schemeClr val="tx1"/>
                 </a:solidFill>
               </a:rPr>
-              <a:t>No data beyond day 119</a:t>
+              <a:t>No bed-rest data beyond day 119</a:t>
             </a:r>
             <a:endParaRPr lang="en-US" sz="2000" dirty="0"/>
           </a:p>
@@ -7871,7 +7872,69 @@
                   <a:schemeClr val="tx1"/>
                 </a:solidFill>
               </a:rPr>
-              <a:t>Mostly young men (347 of 425 measurements)</a:t>
+              <a:t>Group averages; bed rest is not spaceflight</a:t>
+            </a:r>
+            <a:endParaRPr lang="en-US" sz="2000" dirty="0"/>
+          </a:p>
+        </p:txBody>
+      </p:sp>
+      <p:sp>
+        <p:nvSpPr>
+          <p:cNvPr id="13" name="Divider"/>
+          <p:cNvSpPr/>
+          <p:nvPr/>
+        </p:nvSpPr>
+        <p:spPr>
+          <a:xfrm>
+            <a:off x="548640" y="3840480"/>
+            <a:ext cx="11064240" cy="0"/>
+          </a:xfrm>
+          <a:prstGeom prst="line">
+            <a:avLst/>
+          </a:prstGeom>
+          <a:noFill/>
+          <a:ln w="9525">
+            <a:solidFill>
+              <a:srgbClr val="A9A598"/>
+            </a:solidFill>
+            <a:prstDash val="solid"/>
+          </a:ln>
+        </p:spPr>
+      </p:sp>
+      <p:sp>
+        <p:nvSpPr>
+          <p:cNvPr id="14" name="Text 12"/>
+          <p:cNvSpPr txBox="1"/>
+          <p:nvPr/>
+        </p:nvSpPr>
+        <p:spPr>
+          <a:xfrm>
+            <a:off x="548640" y="4023360"/>
+            <a:ext cx="11064240" cy="2011680"/>
+          </a:xfrm>
+          <a:prstGeom prst="rect">
+            <a:avLst/>
+          </a:prstGeom>
+          <a:noFill/>
+          <a:ln/>
+        </p:spPr>
+        <p:txBody>
+          <a:bodyPr wrap="square" lIns="0" tIns="0" rIns="0" bIns="0" rtlCol="0" anchor="t"/>
+          <a:lstStyle/>
+          <a:p>
+            <a:pPr indent="0" marL="0">
+              <a:spcAft>
+                <a:spcPts val="800"/>
+              </a:spcAft>
+              <a:buNone/>
+            </a:pPr>
+            <a:r>
+              <a:rPr lang="en-US" sz="2000" b="1" dirty="0">
+                <a:solidFill>
+                  <a:schemeClr val="tx2"/>
+                </a:solidFill>
+              </a:rPr>
+              <a:t>Further work</a:t>
             </a:r>
             <a:endParaRPr lang="en-US" sz="2000" dirty="0"/>
           </a:p>
@@ -7889,7 +7952,7 @@
                   <a:schemeClr val="tx1"/>
                 </a:solidFill>
               </a:rPr>
-              <a:t>Group averages, not individual people</a:t>
+              <a:t>Link the muscles: predict one muscle's loss from another's, and weight them into an estimate of strength loss</a:t>
             </a:r>
             <a:endParaRPr lang="en-US" sz="2000" dirty="0"/>
           </a:p>
@@ -7907,118 +7970,7 @@
                   <a:schemeClr val="tx1"/>
                 </a:solidFill>
               </a:rPr>
-              <a:t>Bed rest imitates spaceflight but is not the same</a:t>
-            </a:r>
-            <a:endParaRPr lang="en-US" sz="2000" dirty="0"/>
-          </a:p>
-        </p:txBody>
-      </p:sp>
-      <p:sp>
-        <p:nvSpPr>
-          <p:cNvPr id="13" name="Text 11"/>
-          <p:cNvSpPr txBox="1"/>
-          <p:nvPr/>
-        </p:nvSpPr>
-        <p:spPr>
-          <a:xfrm>
-            <a:off x="8138160" y="1325880"/>
-            <a:ext cx="3474720" cy="4754880"/>
-          </a:xfrm>
-          <a:prstGeom prst="rect">
-            <a:avLst/>
-          </a:prstGeom>
-          <a:noFill/>
-          <a:ln/>
-        </p:spPr>
-        <p:txBody>
-          <a:bodyPr wrap="square" lIns="0" tIns="0" rIns="0" bIns="0" rtlCol="0" anchor="t"/>
-          <a:lstStyle/>
-          <a:p>
-            <a:pPr indent="0" marL="0">
-              <a:spcAft>
-                <a:spcPts val="800"/>
-              </a:spcAft>
-              <a:buNone/>
-            </a:pPr>
-            <a:r>
-              <a:rPr lang="en-US" sz="2000" b="1" dirty="0">
-                <a:solidFill>
-                  <a:schemeClr val="tx2"/>
-                </a:solidFill>
-              </a:rPr>
-              <a:t>Further work</a:t>
-            </a:r>
-            <a:endParaRPr lang="en-US" sz="2000" dirty="0"/>
-          </a:p>
-          <a:p>
-            <a:pPr marL="342900" indent="-342900">
-              <a:spcAft>
-                <a:spcPts val="400"/>
-              </a:spcAft>
-              <a:buSzPct val="100000"/>
-              <a:buChar char="•"/>
-            </a:pPr>
-            <a:r>
-              <a:rPr lang="en-US" sz="1800" dirty="0">
-                <a:solidFill>
-                  <a:schemeClr val="tx1"/>
-                </a:solidFill>
-              </a:rPr>
-              <a:t>Fix the LLM's overconfident ranges</a:t>
-            </a:r>
-            <a:endParaRPr lang="en-US" sz="2000" dirty="0"/>
-          </a:p>
-          <a:p>
-            <a:pPr marL="342900" indent="-342900">
-              <a:spcAft>
-                <a:spcPts val="400"/>
-              </a:spcAft>
-              <a:buSzPct val="100000"/>
-              <a:buChar char="•"/>
-            </a:pPr>
-            <a:r>
-              <a:rPr lang="en-US" sz="1800" dirty="0">
-                <a:solidFill>
-                  <a:schemeClr val="tx1"/>
-                </a:solidFill>
-              </a:rPr>
-              <a:t>Check results without the largest campaign, and with MRI scans only</a:t>
-            </a:r>
-            <a:endParaRPr lang="en-US" sz="2000" dirty="0"/>
-          </a:p>
-          <a:p>
-            <a:pPr marL="342900" indent="-342900">
-              <a:spcAft>
-                <a:spcPts val="400"/>
-              </a:spcAft>
-              <a:buSzPct val="100000"/>
-              <a:buChar char="•"/>
-            </a:pPr>
-            <a:r>
-              <a:rPr lang="en-US" sz="1800" dirty="0">
-                <a:solidFill>
-                  <a:schemeClr val="tx1"/>
-                </a:solidFill>
-              </a:rPr>
-              <a:t>Extend the prediction to a 180-day mission, with an uncertainty range</a:t>
-            </a:r>
-            <a:endParaRPr lang="en-US" sz="2000" dirty="0"/>
-          </a:p>
-          <a:p>
-            <a:pPr marL="342900" indent="-342900">
-              <a:spcAft>
-                <a:spcPts val="400"/>
-              </a:spcAft>
-              <a:buSzPct val="100000"/>
-              <a:buChar char="•"/>
-            </a:pPr>
-            <a:r>
-              <a:rPr lang="en-US" sz="1800" dirty="0">
-                <a:solidFill>
-                  <a:schemeClr val="tx1"/>
-                </a:solidFill>
-              </a:rPr>
-              <a:t>Link the muscles: predict one muscle's loss from another's, and weight them into an estimate of strength loss</a:t>
+              <a:t>A risk-assessment system based on a person's characteristics, such as age, sex and fitness</a:t>
             </a:r>
             <a:endParaRPr lang="en-US" sz="2000" dirty="0"/>
           </a:p>

</xml_diff>

<commit_message>
Title slide: large Earth, small Mars
Co-Authored-By: Claude Opus 5.5 (1M context) <noreply@anthropic.com>
Claude-Session: https://claude.ai/code/session_01JZtuYERhuCe7nB9VYHwcfv
</commit_message>
<xml_diff>
--- a/presentation/bed-rest-to-mars-talk.pptx
+++ b/presentation/bed-rest-to-mars-talk.pptx
@@ -124,13 +124,13 @@
   <p:extLst>
     <p:ext uri="{521415D9-36F7-43E2-AB2F-B90AF26B5E84}">
       <p14:sectionLst xmlns:p14="http://schemas.microsoft.com/office/powerpoint/2010/main">
-        <p14:section name="Opening" id="{8d21bf98-29d6-497b-02fc-89cf0cea36ff}">
+        <p14:section name="Opening" id="{f0d1b39f-a281-798b-b061-6b06405d76a2}">
           <p14:sldIdLst>
             <p14:sldId id="256"/>
             <p14:sldId id="257"/>
           </p14:sldIdLst>
         </p14:section>
-        <p14:section name="Part 1" id="{a1bedddd-1c0f-e864-0c43-7ad5b88f8bf6}">
+        <p14:section name="Part 1" id="{f21d3dc7-572d-b271-e242-1c3ebc6ce3c3}">
           <p14:sldIdLst>
             <p14:sldId id="258"/>
             <p14:sldId id="259"/>
@@ -140,7 +140,7 @@
             <p14:sldId id="263"/>
           </p14:sldIdLst>
         </p14:section>
-        <p14:section name="Part 2" id="{bb744a5d-0be8-e184-1fbf-4b0f3c6ad334}">
+        <p14:section name="Part 2" id="{156ebab2-848b-8cc3-02f4-68e17b80210e}">
           <p14:sldIdLst>
             <p14:sldId id="264"/>
             <p14:sldId id="265"/>
@@ -149,7 +149,7 @@
             <p14:sldId id="268"/>
           </p14:sldIdLst>
         </p14:section>
-        <p14:section name="Backup" id="{9f6f70a9-77b1-6fea-4d94-91cff1f9aae4}">
+        <p14:section name="Backup" id="{23e60b6b-7d94-ffba-61c5-072e50069360}">
           <p14:sldIdLst>
             <p14:sldId id="269"/>
             <p14:sldId id="270"/>
@@ -158,16 +158,16 @@
             <p14:sldId id="273"/>
           </p14:sldIdLst>
         </p14:section>
-        <p14:section name="Backup" id="{3f51455a-6f5c-1224-6df7-4d51a3e8c1ce}">
+        <p14:section name="Backup" id="{0b40e947-200f-3d3a-b3fc-fc5a9c37d2e1}">
           <p14:sldIdLst/>
         </p14:section>
-        <p14:section name="Backup" id="{47d30702-ed73-6bf3-224e-515bbb3d4b49}">
+        <p14:section name="Backup" id="{71c216e6-ebfa-f7b3-89d9-ef912a163bd6}">
           <p14:sldIdLst/>
         </p14:section>
-        <p14:section name="Backup" id="{91357859-b4e9-1f46-088a-5c462f59e8f8}">
+        <p14:section name="Backup" id="{89f666fb-dee3-3249-f9c7-60f1c6a88d96}">
           <p14:sldIdLst/>
         </p14:section>
-        <p14:section name="Backup" id="{5bdc692e-7fb3-c0ff-1abf-4b1fed4522e3}">
+        <p14:section name="Backup" id="{763930a7-370a-164d-201b-7934f587e11f}">
           <p14:sldIdLst/>
         </p14:section>
       </p14:sectionLst>

</xml_diff>

<commit_message>
Add three backup slides answering referee questions on part 1
Co-Authored-By: Claude Opus 5.5 (1M context) <noreply@anthropic.com>
Claude-Session: https://claude.ai/code/session_01JZtuYERhuCe7nB9VYHwcfv
</commit_message>
<xml_diff>
--- a/presentation/bed-rest-to-mars-talk.pptx
+++ b/presentation/bed-rest-to-mars-talk.pptx
@@ -23,9 +23,12 @@
     <p:sldId id="271" r:id="rId17"/>
     <p:sldId id="272" r:id="rId18"/>
     <p:sldId id="273" r:id="rId19"/>
+    <p:sldId id="274" r:id="rId20"/>
+    <p:sldId id="275" r:id="rId21"/>
+    <p:sldId id="276" r:id="rId22"/>
   </p:sldIdLst>
   <p:notesMasterIdLst>
-    <p:notesMasterId r:id="rId20"/>
+    <p:notesMasterId r:id="rId23"/>
   </p:notesMasterIdLst>
   <p:sldSz cx="12192000" cy="6858000"/>
   <p:notesSz cx="6858000" cy="12192000"/>
@@ -124,13 +127,13 @@
   <p:extLst>
     <p:ext uri="{521415D9-36F7-43E2-AB2F-B90AF26B5E84}">
       <p14:sectionLst xmlns:p14="http://schemas.microsoft.com/office/powerpoint/2010/main">
-        <p14:section name="Opening" id="{f0d1b39f-a281-798b-b061-6b06405d76a2}">
+        <p14:section name="Opening" id="{fa5d2aab-e98c-611c-30f0-53565645d2f5}">
           <p14:sldIdLst>
             <p14:sldId id="256"/>
             <p14:sldId id="257"/>
           </p14:sldIdLst>
         </p14:section>
-        <p14:section name="Part 1" id="{f21d3dc7-572d-b271-e242-1c3ebc6ce3c3}">
+        <p14:section name="Part 1" id="{888bdb5b-3380-679e-e544-875ff8723e21}">
           <p14:sldIdLst>
             <p14:sldId id="258"/>
             <p14:sldId id="259"/>
@@ -140,7 +143,7 @@
             <p14:sldId id="263"/>
           </p14:sldIdLst>
         </p14:section>
-        <p14:section name="Part 2" id="{156ebab2-848b-8cc3-02f4-68e17b80210e}">
+        <p14:section name="Part 2" id="{08fc8cbf-6caa-5a69-6a47-b2919281447d}">
           <p14:sldIdLst>
             <p14:sldId id="264"/>
             <p14:sldId id="265"/>
@@ -149,25 +152,37 @@
             <p14:sldId id="268"/>
           </p14:sldIdLst>
         </p14:section>
-        <p14:section name="Backup" id="{23e60b6b-7d94-ffba-61c5-072e50069360}">
+        <p14:section name="Backup" id="{18857b80-308b-260d-41e1-140975dec969}">
           <p14:sldIdLst>
             <p14:sldId id="269"/>
             <p14:sldId id="270"/>
             <p14:sldId id="271"/>
             <p14:sldId id="272"/>
             <p14:sldId id="273"/>
+            <p14:sldId id="274"/>
+            <p14:sldId id="275"/>
+            <p14:sldId id="276"/>
           </p14:sldIdLst>
         </p14:section>
-        <p14:section name="Backup" id="{0b40e947-200f-3d3a-b3fc-fc5a9c37d2e1}">
+        <p14:section name="Backup" id="{3ae0dc77-496f-0be9-fd47-cd53ba665640}">
           <p14:sldIdLst/>
         </p14:section>
-        <p14:section name="Backup" id="{71c216e6-ebfa-f7b3-89d9-ef912a163bd6}">
+        <p14:section name="Backup" id="{a7428151-474f-33a6-9ce0-ca15520a4062}">
           <p14:sldIdLst/>
         </p14:section>
-        <p14:section name="Backup" id="{89f666fb-dee3-3249-f9c7-60f1c6a88d96}">
+        <p14:section name="Backup" id="{61e93eef-ea04-d9c5-7cda-095ec5e2f536}">
           <p14:sldIdLst/>
         </p14:section>
-        <p14:section name="Backup" id="{763930a7-370a-164d-201b-7934f587e11f}">
+        <p14:section name="Backup" id="{375f218f-21ad-da33-85fa-3ff52fd5762a}">
+          <p14:sldIdLst/>
+        </p14:section>
+        <p14:section name="Backup" id="{dfc9741a-1d02-b5c9-509e-58e69988a25d}">
+          <p14:sldIdLst/>
+        </p14:section>
+        <p14:section name="Backup" id="{354ec35d-7a38-fd0d-53c2-b3d6d376266e}">
+          <p14:sldIdLst/>
+        </p14:section>
+        <p14:section name="Backup" id="{9b9b9385-26bf-10eb-0e4c-5388611efd9f}">
           <p14:sldIdLst/>
         </p14:section>
       </p14:sectionLst>
@@ -3551,7 +3566,7 @@
           <a:p>
             <a:r>
               <a:rPr lang="en-US" dirty="0"/>
-              <a:t>Backup. The two starred numbers are our own calculation from results/forecast_predictions.csv, not in the report. Without the three campaigns that carry most of the gain, the interval touches zero; say so if asked.</a:t>
+              <a:t>Backup, part 1 (Niloufar). The arithmetic question is the most likely one: 3,600 minus 2,493 is 1,107, of which 84 reached full text and 1,023 were not screened in time. Say so plainly: they are open work, not exclusions. If pressed on the full-text stage: the report's own full-text counts are still being reconciled with the final extraction (it says so in a draft note), so do not claim the full-text numbers add up exactly. Known-item test: of the ten modelling papers we knew before the search, only two were published after 2013, and every journal database returned both. The test without the date limit was not run.</a:t>
             </a:r>
             <a:endParaRPr lang="en-US" dirty="0"/>
           </a:p>
@@ -3639,7 +3654,7 @@
           <a:p>
             <a:r>
               <a:rPr lang="en-US" dirty="0"/>
-              <a:t>Backup. The honest gap here is the nearest-neighbour control: we cannot yet say whether a simple similarity method would match the LLM.</a:t>
+              <a:t>Backup, part 1 (Niloufar). Expansion: the eligibility criteria in the report's Table 2 were written before screening; dataset version 1.0 was frozen on 14 September and 1.1 on 19 September, and every result is fitted on 1.1. The rule for the curve: the saturating form is the headline unless another form beats it by at least 4 AIC points. Spaceflight: the dataset keeps the spaceflight rows, flagged, but they are post-flight measurements, so the during-unloading filter removes them. Weighting: inverse-variance weighting would need the spread of the change, which most papers do not print; the check that compares both weightings moved the duration effect by under 1 pp.</a:t>
             </a:r>
             <a:endParaRPr lang="en-US" dirty="0"/>
           </a:p>
@@ -3727,7 +3742,7 @@
           <a:p>
             <a:r>
               <a:rPr lang="en-US" dirty="0"/>
-              <a:t>Backup. The supported planning statements, within 5 to 119 days and for groups: most loss happens in the first weeks, calf muscles need protecting first, and countermeasure groups lose less.</a:t>
+              <a:t>Backup, part 1 (Niloufar). Be precise about slide 8: the coloured dots at day 60 are the model's estimates for each muscle group, with the intervals shown here. The lines are drawn with one shared time course scaled to those values, so they show the shape the model assumes, not a separate fit per muscle. The intervals are 95% cluster-robust, which means they account for several rows coming from the same campaign. The calf-versus-shin contrast is reported on its own because it does not depend on which muscle is the reference.</a:t>
             </a:r>
             <a:endParaRPr lang="en-US" dirty="0"/>
           </a:p>
@@ -3751,6 +3766,94 @@
             <a:fld id="{F7021451-1387-4CA6-816F-3879F97B5CBC}" type="slidenum">
               <a:rPr lang="en-US"/>
               <a:t>18</a:t>
+            </a:fld>
+            <a:endParaRPr lang="en-US"/>
+          </a:p>
+        </p:txBody>
+      </p:sp>
+    </p:spTree>
+    <p:extLst>
+      <p:ext uri="{BB962C8B-B14F-4D97-AF65-F5344CB8AC3E}">
+        <p14:creationId xmlns:p14="http://schemas.microsoft.com/office/powerpoint/2010/main" val="1024086991"/>
+      </p:ext>
+    </p:extLst>
+  </p:cSld>
+  <p:clrMapOvr>
+    <a:masterClrMapping/>
+  </p:clrMapOvr>
+</p:notes>
+</file>
+
+<file path=ppt/notesSlides/notesSlide19.xml><?xml version="1.0" encoding="utf-8"?>
+<p:notes xmlns:a="http://schemas.openxmlformats.org/drawingml/2006/main" xmlns:r="http://schemas.openxmlformats.org/officeDocument/2006/relationships" xmlns:p="http://schemas.openxmlformats.org/presentationml/2006/main">
+  <p:cSld>
+    <p:spTree>
+      <p:nvGrpSpPr>
+        <p:cNvPr id="1" name=""/>
+        <p:cNvGrpSpPr/>
+        <p:nvPr/>
+      </p:nvGrpSpPr>
+      <p:grpSpPr>
+        <a:xfrm>
+          <a:off x="0" y="0"/>
+          <a:ext cx="0" cy="0"/>
+          <a:chOff x="0" y="0"/>
+          <a:chExt cx="0" cy="0"/>
+        </a:xfrm>
+      </p:grpSpPr>
+      <p:sp>
+        <p:nvSpPr>
+          <p:cNvPr id="2" name="Slide Image Placeholder 1"/>
+          <p:cNvSpPr>
+            <a:spLocks noGrp="1" noRot="1" noChangeAspect="1"/>
+          </p:cNvSpPr>
+          <p:nvPr>
+            <p:ph type="sldImg"/>
+          </p:nvPr>
+        </p:nvSpPr>
+        <p:spPr/>
+      </p:sp>
+      <p:sp>
+        <p:nvSpPr>
+          <p:cNvPr id="3" name="Notes Placeholder 2"/>
+          <p:cNvSpPr>
+            <a:spLocks noGrp="1"/>
+          </p:cNvSpPr>
+          <p:nvPr>
+            <p:ph type="body" idx="1"/>
+          </p:nvPr>
+        </p:nvSpPr>
+        <p:spPr/>
+        <p:txBody>
+          <a:bodyPr/>
+          <a:lstStyle/>
+          <a:p>
+            <a:r>
+              <a:rPr lang="en-US" dirty="0"/>
+              <a:t>Backup. The two starred numbers are our own calculation from results/forecast_predictions.csv, not in the report. Without the three campaigns that carry most of the gain, the interval touches zero; say so if asked.</a:t>
+            </a:r>
+            <a:endParaRPr lang="en-US" dirty="0"/>
+          </a:p>
+        </p:txBody>
+      </p:sp>
+      <p:sp>
+        <p:nvSpPr>
+          <p:cNvPr id="4" name="Slide Number Placeholder 3"/>
+          <p:cNvSpPr>
+            <a:spLocks noGrp="1"/>
+          </p:cNvSpPr>
+          <p:nvPr>
+            <p:ph type="sldNum" sz="quarter" idx="10"/>
+          </p:nvPr>
+        </p:nvSpPr>
+        <p:spPr/>
+        <p:txBody>
+          <a:bodyPr/>
+          <a:lstStyle/>
+          <a:p>
+            <a:fld id="{F7021451-1387-4CA6-816F-3879F97B5CBC}" type="slidenum">
+              <a:rPr lang="en-US"/>
+              <a:t>19</a:t>
             </a:fld>
             <a:endParaRPr lang="en-US"/>
           </a:p>
@@ -3839,6 +3942,182 @@
             <a:fld id="{F7021451-1387-4CA6-816F-3879F97B5CBC}" type="slidenum">
               <a:rPr lang="en-US"/>
               <a:t>2</a:t>
+            </a:fld>
+            <a:endParaRPr lang="en-US"/>
+          </a:p>
+        </p:txBody>
+      </p:sp>
+    </p:spTree>
+    <p:extLst>
+      <p:ext uri="{BB962C8B-B14F-4D97-AF65-F5344CB8AC3E}">
+        <p14:creationId xmlns:p14="http://schemas.microsoft.com/office/powerpoint/2010/main" val="1024086991"/>
+      </p:ext>
+    </p:extLst>
+  </p:cSld>
+  <p:clrMapOvr>
+    <a:masterClrMapping/>
+  </p:clrMapOvr>
+</p:notes>
+</file>
+
+<file path=ppt/notesSlides/notesSlide20.xml><?xml version="1.0" encoding="utf-8"?>
+<p:notes xmlns:a="http://schemas.openxmlformats.org/drawingml/2006/main" xmlns:r="http://schemas.openxmlformats.org/officeDocument/2006/relationships" xmlns:p="http://schemas.openxmlformats.org/presentationml/2006/main">
+  <p:cSld>
+    <p:spTree>
+      <p:nvGrpSpPr>
+        <p:cNvPr id="1" name=""/>
+        <p:cNvGrpSpPr/>
+        <p:nvPr/>
+      </p:nvGrpSpPr>
+      <p:grpSpPr>
+        <a:xfrm>
+          <a:off x="0" y="0"/>
+          <a:ext cx="0" cy="0"/>
+          <a:chOff x="0" y="0"/>
+          <a:chExt cx="0" cy="0"/>
+        </a:xfrm>
+      </p:grpSpPr>
+      <p:sp>
+        <p:nvSpPr>
+          <p:cNvPr id="2" name="Slide Image Placeholder 1"/>
+          <p:cNvSpPr>
+            <a:spLocks noGrp="1" noRot="1" noChangeAspect="1"/>
+          </p:cNvSpPr>
+          <p:nvPr>
+            <p:ph type="sldImg"/>
+          </p:nvPr>
+        </p:nvSpPr>
+        <p:spPr/>
+      </p:sp>
+      <p:sp>
+        <p:nvSpPr>
+          <p:cNvPr id="3" name="Notes Placeholder 2"/>
+          <p:cNvSpPr>
+            <a:spLocks noGrp="1"/>
+          </p:cNvSpPr>
+          <p:nvPr>
+            <p:ph type="body" idx="1"/>
+          </p:nvPr>
+        </p:nvSpPr>
+        <p:spPr/>
+        <p:txBody>
+          <a:bodyPr/>
+          <a:lstStyle/>
+          <a:p>
+            <a:r>
+              <a:rPr lang="en-US" dirty="0"/>
+              <a:t>Backup. The honest gap here is the nearest-neighbour control: we cannot yet say whether a simple similarity method would match the LLM.</a:t>
+            </a:r>
+            <a:endParaRPr lang="en-US" dirty="0"/>
+          </a:p>
+        </p:txBody>
+      </p:sp>
+      <p:sp>
+        <p:nvSpPr>
+          <p:cNvPr id="4" name="Slide Number Placeholder 3"/>
+          <p:cNvSpPr>
+            <a:spLocks noGrp="1"/>
+          </p:cNvSpPr>
+          <p:nvPr>
+            <p:ph type="sldNum" sz="quarter" idx="10"/>
+          </p:nvPr>
+        </p:nvSpPr>
+        <p:spPr/>
+        <p:txBody>
+          <a:bodyPr/>
+          <a:lstStyle/>
+          <a:p>
+            <a:fld id="{F7021451-1387-4CA6-816F-3879F97B5CBC}" type="slidenum">
+              <a:rPr lang="en-US"/>
+              <a:t>20</a:t>
+            </a:fld>
+            <a:endParaRPr lang="en-US"/>
+          </a:p>
+        </p:txBody>
+      </p:sp>
+    </p:spTree>
+    <p:extLst>
+      <p:ext uri="{BB962C8B-B14F-4D97-AF65-F5344CB8AC3E}">
+        <p14:creationId xmlns:p14="http://schemas.microsoft.com/office/powerpoint/2010/main" val="1024086991"/>
+      </p:ext>
+    </p:extLst>
+  </p:cSld>
+  <p:clrMapOvr>
+    <a:masterClrMapping/>
+  </p:clrMapOvr>
+</p:notes>
+</file>
+
+<file path=ppt/notesSlides/notesSlide21.xml><?xml version="1.0" encoding="utf-8"?>
+<p:notes xmlns:a="http://schemas.openxmlformats.org/drawingml/2006/main" xmlns:r="http://schemas.openxmlformats.org/officeDocument/2006/relationships" xmlns:p="http://schemas.openxmlformats.org/presentationml/2006/main">
+  <p:cSld>
+    <p:spTree>
+      <p:nvGrpSpPr>
+        <p:cNvPr id="1" name=""/>
+        <p:cNvGrpSpPr/>
+        <p:nvPr/>
+      </p:nvGrpSpPr>
+      <p:grpSpPr>
+        <a:xfrm>
+          <a:off x="0" y="0"/>
+          <a:ext cx="0" cy="0"/>
+          <a:chOff x="0" y="0"/>
+          <a:chExt cx="0" cy="0"/>
+        </a:xfrm>
+      </p:grpSpPr>
+      <p:sp>
+        <p:nvSpPr>
+          <p:cNvPr id="2" name="Slide Image Placeholder 1"/>
+          <p:cNvSpPr>
+            <a:spLocks noGrp="1" noRot="1" noChangeAspect="1"/>
+          </p:cNvSpPr>
+          <p:nvPr>
+            <p:ph type="sldImg"/>
+          </p:nvPr>
+        </p:nvSpPr>
+        <p:spPr/>
+      </p:sp>
+      <p:sp>
+        <p:nvSpPr>
+          <p:cNvPr id="3" name="Notes Placeholder 2"/>
+          <p:cNvSpPr>
+            <a:spLocks noGrp="1"/>
+          </p:cNvSpPr>
+          <p:nvPr>
+            <p:ph type="body" idx="1"/>
+          </p:nvPr>
+        </p:nvSpPr>
+        <p:spPr/>
+        <p:txBody>
+          <a:bodyPr/>
+          <a:lstStyle/>
+          <a:p>
+            <a:r>
+              <a:rPr lang="en-US" dirty="0"/>
+              <a:t>Backup. The supported planning statements, within 5 to 119 days and for groups: most loss happens in the first weeks, calf muscles need protecting first, and countermeasure groups lose less.</a:t>
+            </a:r>
+            <a:endParaRPr lang="en-US" dirty="0"/>
+          </a:p>
+        </p:txBody>
+      </p:sp>
+      <p:sp>
+        <p:nvSpPr>
+          <p:cNvPr id="4" name="Slide Number Placeholder 3"/>
+          <p:cNvSpPr>
+            <a:spLocks noGrp="1"/>
+          </p:cNvSpPr>
+          <p:nvPr>
+            <p:ph type="sldNum" sz="quarter" idx="10"/>
+          </p:nvPr>
+        </p:nvSpPr>
+        <p:spPr/>
+        <p:txBody>
+          <a:bodyPr/>
+          <a:lstStyle/>
+          <a:p>
+            <a:fld id="{F7021451-1387-4CA6-816F-3879F97B5CBC}" type="slidenum">
+              <a:rPr lang="en-US"/>
+              <a:t>21</a:t>
             </a:fld>
             <a:endParaRPr lang="en-US"/>
           </a:p>
@@ -8415,7 +8694,7 @@
                   <a:schemeClr val="tx1"/>
                 </a:solidFill>
               </a:rPr>
-              <a:t>Not covered: Embase (no access) and 1,023 records not screened in time</a:t>
+              <a:t>Not covered: Embase (no access); 1,023 records not yet screened (screening backup)</a:t>
             </a:r>
             <a:endParaRPr lang="en-US" sz="1500" dirty="0"/>
           </a:p>
@@ -10334,7 +10613,7 @@
                 <a:ea typeface="Cambria" pitchFamily="34" charset="-122"/>
                 <a:cs typeface="Cambria" pitchFamily="34" charset="-120"/>
               </a:rPr>
-              <a:t>Backup: significance and relevance of the LLM gain</a:t>
+              <a:t>Backup: screening and study selection</a:t>
             </a:r>
             <a:endParaRPr lang="en-US" sz="2800" dirty="0"/>
           </a:p>
@@ -10409,7 +10688,7 @@
                   <a:schemeClr val="tx2"/>
                 </a:solidFill>
               </a:rPr>
-              <a:t>Is 0.42 pp worth anything?</a:t>
+              <a:t>3,600 screened, 2,493 excluded: where are the other 1,107?</a:t>
             </a:r>
             <a:endParaRPr lang="en-US" sz="1500" dirty="0"/>
           </a:p>
@@ -10427,7 +10706,7 @@
                   <a:schemeClr val="tx1"/>
                 </a:solidFill>
               </a:rPr>
-              <a:t>It is 13% lower error than the curve (3.13 to 2.71 pp)</a:t>
+              <a:t>84 went on to full text: 74 from the search and 10 from other sources</a:t>
             </a:r>
             <a:endParaRPr lang="en-US" sz="1500" dirty="0"/>
           </a:p>
@@ -10445,46 +10724,7 @@
                   <a:schemeClr val="tx1"/>
                 </a:solidFill>
               </a:rPr>
-              <a:t>Small; we present it as a secondary finding</a:t>
-            </a:r>
-            <a:endParaRPr lang="en-US" sz="1500" dirty="0"/>
-          </a:p>
-        </p:txBody>
-      </p:sp>
-      <p:sp>
-        <p:nvSpPr>
-          <p:cNvPr id="5" name="Text 3"/>
-          <p:cNvSpPr txBox="1"/>
-          <p:nvPr/>
-        </p:nvSpPr>
-        <p:spPr>
-          <a:xfrm>
-            <a:off x="6217920" y="1188720"/>
-            <a:ext cx="5394960" cy="2377440"/>
-          </a:xfrm>
-          <a:prstGeom prst="rect">
-            <a:avLst/>
-          </a:prstGeom>
-          <a:noFill/>
-          <a:ln/>
-        </p:spPr>
-        <p:txBody>
-          <a:bodyPr wrap="square" lIns="0" tIns="0" rIns="0" bIns="0" rtlCol="0" anchor="t"/>
-          <a:lstStyle/>
-          <a:p>
-            <a:pPr indent="0" marL="0">
-              <a:spcAft>
-                <a:spcPts val="400"/>
-              </a:spcAft>
-              <a:buNone/>
-            </a:pPr>
-            <a:r>
-              <a:rPr lang="en-US" sz="1500" b="1" dirty="0">
-                <a:solidFill>
-                  <a:schemeClr val="tx2"/>
-                </a:solidFill>
-              </a:rPr>
-              <a:t>20 of 32 campaigns is close to a coin flip</a:t>
+              <a:t>1,023 were not screened in the time available: the rest of the "maybe" set and 80 records waiting for a full text</a:t>
             </a:r>
             <a:endParaRPr lang="en-US" sz="1500" dirty="0"/>
           </a:p>
@@ -10502,7 +10742,46 @@
                   <a:schemeClr val="tx1"/>
                 </a:solidFill>
               </a:rPr>
-              <a:t>Counting wins only: p = 0.22 (sign test)*</a:t>
+              <a:t>They are reported as unscreened, not as excluded</a:t>
+            </a:r>
+            <a:endParaRPr lang="en-US" sz="1500" dirty="0"/>
+          </a:p>
+        </p:txBody>
+      </p:sp>
+      <p:sp>
+        <p:nvSpPr>
+          <p:cNvPr id="5" name="Text 3"/>
+          <p:cNvSpPr txBox="1"/>
+          <p:nvPr/>
+        </p:nvSpPr>
+        <p:spPr>
+          <a:xfrm>
+            <a:off x="6217920" y="1188720"/>
+            <a:ext cx="5394960" cy="2377440"/>
+          </a:xfrm>
+          <a:prstGeom prst="rect">
+            <a:avLst/>
+          </a:prstGeom>
+          <a:noFill/>
+          <a:ln/>
+        </p:spPr>
+        <p:txBody>
+          <a:bodyPr wrap="square" lIns="0" tIns="0" rIns="0" bIns="0" rtlCol="0" anchor="t"/>
+          <a:lstStyle/>
+          <a:p>
+            <a:pPr indent="0" marL="0">
+              <a:spcAft>
+                <a:spcPts val="400"/>
+              </a:spcAft>
+              <a:buNone/>
+            </a:pPr>
+            <a:r>
+              <a:rPr lang="en-US" sz="1500" b="1" dirty="0">
+                <a:solidFill>
+                  <a:schemeClr val="tx2"/>
+                </a:solidFill>
+              </a:rPr>
+              <a:t>Who screened, and was it done twice?</a:t>
             </a:r>
             <a:endParaRPr lang="en-US" sz="1500" dirty="0"/>
           </a:p>
@@ -10520,46 +10799,7 @@
                   <a:schemeClr val="tx1"/>
                 </a:solidFill>
               </a:rPr>
-              <a:t>Using the size of each win: mean gain 0.42 pp, 95% CI 0.13 to 0.73</a:t>
-            </a:r>
-            <a:endParaRPr lang="en-US" sz="1500" dirty="0"/>
-          </a:p>
-        </p:txBody>
-      </p:sp>
-      <p:sp>
-        <p:nvSpPr>
-          <p:cNvPr id="6" name="Text 4"/>
-          <p:cNvSpPr txBox="1"/>
-          <p:nvPr/>
-        </p:nvSpPr>
-        <p:spPr>
-          <a:xfrm>
-            <a:off x="548640" y="3703320"/>
-            <a:ext cx="5394960" cy="2377440"/>
-          </a:xfrm>
-          <a:prstGeom prst="rect">
-            <a:avLst/>
-          </a:prstGeom>
-          <a:noFill/>
-          <a:ln/>
-        </p:spPr>
-        <p:txBody>
-          <a:bodyPr wrap="square" lIns="0" tIns="0" rIns="0" bIns="0" rtlCol="0" anchor="t"/>
-          <a:lstStyle/>
-          <a:p>
-            <a:pPr indent="0" marL="0">
-              <a:spcAft>
-                <a:spcPts val="400"/>
-              </a:spcAft>
-              <a:buNone/>
-            </a:pPr>
-            <a:r>
-              <a:rPr lang="en-US" sz="1500" b="1" dirty="0">
-                <a:solidFill>
-                  <a:schemeClr val="tx2"/>
-                </a:solidFill>
-              </a:rPr>
-              <a:t>Does it rest on a few campaigns?</a:t>
+              <a:t>Eligibility criteria were written before screening began</a:t>
             </a:r>
             <a:endParaRPr lang="en-US" sz="1500" dirty="0"/>
           </a:p>
@@ -10577,7 +10817,7 @@
                   <a:schemeClr val="tx1"/>
                 </a:solidFill>
               </a:rPr>
-              <a:t>3 long MRI campaigns (NASA SPRINT, Berlin BBR2-2, MEDES LTBR) give 56% of the gain; without them 0.20 pp, CI −0.01 to 0.43*</a:t>
+              <a:t>A rule-based triage sorted the records; one person then read the priority set and the top of the "maybe" set</a:t>
             </a:r>
             <a:endParaRPr lang="en-US" sz="1500" dirty="0"/>
           </a:p>
@@ -10595,7 +10835,7 @@
                   <a:schemeClr val="tx1"/>
                 </a:solidFill>
               </a:rPr>
-              <a:t>Only SPRINT is recognised, and with campaign details removed the LLM still wins there (3.79 vs 5.92 pp)</a:t>
+              <a:t>No second screener</a:t>
             </a:r>
             <a:endParaRPr lang="en-US" sz="1500" dirty="0"/>
           </a:p>
@@ -10603,13 +10843,13 @@
       </p:sp>
       <p:sp>
         <p:nvSpPr>
-          <p:cNvPr id="7" name="Text 5"/>
+          <p:cNvPr id="6" name="Text 4"/>
           <p:cNvSpPr txBox="1"/>
           <p:nvPr/>
         </p:nvSpPr>
         <p:spPr>
           <a:xfrm>
-            <a:off x="6217920" y="3703320"/>
+            <a:off x="548640" y="3703320"/>
             <a:ext cx="5394960" cy="2377440"/>
           </a:xfrm>
           <a:prstGeom prst="rect">
@@ -10634,7 +10874,7 @@
                   <a:schemeClr val="tx2"/>
                 </a:solidFill>
               </a:rPr>
-              <a:t>Did it read these papers in training? Was it added after the fact?</a:t>
+              <a:t>84 full texts but 52 studies: why so few?</a:t>
             </a:r>
             <a:endParaRPr lang="en-US" sz="1500" dirty="0"/>
           </a:p>
@@ -10652,7 +10892,7 @@
                   <a:schemeClr val="tx1"/>
                 </a:solidFill>
               </a:rPr>
-              <a:t>Training exposure cannot be ruled out by any test; hiding campaign details and the naming test are the strongest checks available</a:t>
+              <a:t>19 give muscle results only as charts, without a baseline value</a:t>
             </a:r>
             <a:endParaRPr lang="en-US" sz="1500" dirty="0"/>
           </a:p>
@@ -10670,7 +10910,7 @@
                   <a:schemeClr val="tx1"/>
                 </a:solidFill>
               </a:rPr>
-              <a:t>Added after the ML result, but every check and target was committed before the first answer</a:t>
+              <a:t>4 full texts not available (one conference abstract still used); 11 excluded at full text</a:t>
             </a:r>
             <a:endParaRPr lang="en-US" sz="1500" dirty="0"/>
           </a:p>
@@ -10678,14 +10918,14 @@
       </p:sp>
       <p:sp>
         <p:nvSpPr>
-          <p:cNvPr id="8" name="Text 6"/>
+          <p:cNvPr id="7" name="Text 5"/>
           <p:cNvSpPr txBox="1"/>
           <p:nvPr/>
         </p:nvSpPr>
         <p:spPr>
           <a:xfrm>
-            <a:off x="548640" y="6035040"/>
-            <a:ext cx="9144000" cy="274320"/>
+            <a:off x="6217920" y="3703320"/>
+            <a:ext cx="5394960" cy="2377440"/>
           </a:xfrm>
           <a:prstGeom prst="rect">
             <a:avLst/>
@@ -10698,17 +10938,74 @@
           <a:lstStyle/>
           <a:p>
             <a:pPr indent="0" marL="0">
-              <a:buNone/>
-            </a:pPr>
-            <a:r>
-              <a:rPr lang="en-US" sz="1100" i="1" dirty="0">
-                <a:solidFill>
-                  <a:schemeClr val="accent3"/>
-                </a:solidFill>
-              </a:rPr>
-              <a:t>* Our calculation from the saved LLM predictions; not in the report.</a:t>
-            </a:r>
-            <a:endParaRPr lang="en-US" sz="1100" dirty="0"/>
+              <a:spcAft>
+                <a:spcPts val="400"/>
+              </a:spcAft>
+              <a:buNone/>
+            </a:pPr>
+            <a:r>
+              <a:rPr lang="en-US" sz="1500" b="1" dirty="0">
+                <a:solidFill>
+                  <a:schemeClr val="tx2"/>
+                </a:solidFill>
+              </a:rPr>
+              <a:t>Why search only from 2013?</a:t>
+            </a:r>
+            <a:endParaRPr lang="en-US" sz="1500" dirty="0"/>
+          </a:p>
+          <a:p>
+            <a:pPr marL="342900" indent="-342900">
+              <a:spcAft>
+                <a:spcPts val="400"/>
+              </a:spcAft>
+              <a:buSzPct val="100000"/>
+              <a:buChar char="•"/>
+            </a:pPr>
+            <a:r>
+              <a:rPr lang="en-US" sz="1400" dirty="0">
+                <a:solidFill>
+                  <a:schemeClr val="tx1"/>
+                </a:solidFill>
+              </a:rPr>
+              <a:t>The search was time-boxed to one week</a:t>
+            </a:r>
+            <a:endParaRPr lang="en-US" sz="1500" dirty="0"/>
+          </a:p>
+          <a:p>
+            <a:pPr marL="342900" indent="-342900">
+              <a:spcAft>
+                <a:spcPts val="400"/>
+              </a:spcAft>
+              <a:buSzPct val="100000"/>
+              <a:buChar char="•"/>
+            </a:pPr>
+            <a:r>
+              <a:rPr lang="en-US" sz="1400" dirty="0">
+                <a:solidFill>
+                  <a:schemeClr val="tx1"/>
+                </a:solidFill>
+              </a:rPr>
+              <a:t>Older work enters through 9 studies we held before the search; 6 of their campaigns would otherwise be missing</a:t>
+            </a:r>
+            <a:endParaRPr lang="en-US" sz="1500" dirty="0"/>
+          </a:p>
+          <a:p>
+            <a:pPr marL="342900" indent="-342900">
+              <a:spcAft>
+                <a:spcPts val="400"/>
+              </a:spcAft>
+              <a:buSzPct val="100000"/>
+              <a:buChar char="•"/>
+            </a:pPr>
+            <a:r>
+              <a:rPr lang="en-US" sz="1400" dirty="0">
+                <a:solidFill>
+                  <a:schemeClr val="tx1"/>
+                </a:solidFill>
+              </a:rPr>
+              <a:t>Both known modelling papers from after 2013 were found by all three journal databases</a:t>
+            </a:r>
+            <a:endParaRPr lang="en-US" sz="1500" dirty="0"/>
           </a:p>
         </p:txBody>
       </p:sp>
@@ -10817,7 +11114,7 @@
                 <a:ea typeface="Cambria" pitchFamily="34" charset="-122"/>
                 <a:cs typeface="Cambria" pitchFamily="34" charset="-120"/>
               </a:rPr>
-              <a:t>Backup: ML results and fairness of the comparison</a:t>
+              <a:t>Backup: dataset expansion and composition</a:t>
             </a:r>
             <a:endParaRPr lang="en-US" sz="2800" dirty="0"/>
           </a:p>
@@ -10892,7 +11189,7 @@
                   <a:schemeClr val="tx2"/>
                 </a:solidFill>
               </a:rPr>
-              <a:t>Did the ML models get a fair chance?</a:t>
+              <a:t>The abstract had 15 studies. Did adding 37 change the analysis after seeing data?</a:t>
             </a:r>
             <a:endParaRPr lang="en-US" sz="1500" dirty="0"/>
           </a:p>
@@ -10910,7 +11207,7 @@
                   <a:schemeClr val="tx1"/>
                 </a:solidFill>
               </a:rPr>
-              <a:t>Tuned inside each training fold, grouped by campaign; TabPFN needs no tuning</a:t>
+              <a:t>Eligibility criteria were fixed before screening; the dataset was frozen (14 and 19 September) before the final models</a:t>
             </a:r>
             <a:endParaRPr lang="en-US" sz="1500" dirty="0"/>
           </a:p>
@@ -10928,7 +11225,7 @@
                   <a:schemeClr val="tx1"/>
                 </a:solidFill>
               </a:rPr>
-              <a:t>All models saw the same inputs, folds and scoring</a:t>
+              <a:t>The curve shape was chosen by a rule declared before fitting</a:t>
             </a:r>
             <a:endParaRPr lang="en-US" sz="1500" dirty="0"/>
           </a:p>
@@ -10967,7 +11264,7 @@
                   <a:schemeClr val="tx2"/>
                 </a:solidFill>
               </a:rPr>
-              <a:t>Why not add age, sex or countermeasure type?</a:t>
+              <a:t>Slide 5 shows 180 days, but the model stops at day 119. Why?</a:t>
             </a:r>
             <a:endParaRPr lang="en-US" sz="1500" dirty="0"/>
           </a:p>
@@ -10985,7 +11282,7 @@
                   <a:schemeClr val="tx1"/>
                 </a:solidFill>
               </a:rPr>
-              <a:t>32 campaigns leave room for about 3 campaign-level inputs (about 10 campaigns per input)</a:t>
+              <a:t>The 14 spaceflight rows were measured after landing, so they leave the model with the 264 recovery rows</a:t>
             </a:r>
             <a:endParaRPr lang="en-US" sz="1500" dirty="0"/>
           </a:p>
@@ -11003,7 +11300,7 @@
                   <a:schemeClr val="tx1"/>
                 </a:solidFill>
               </a:rPr>
-              <a:t>Age and sex are fixed within a campaign (347 of 425 rows men-only), so they act as a campaign label; 126 countermeasure rows spread over 9 types</a:t>
+              <a:t>8 of the 14 are one back muscle (lumbar multifidus)</a:t>
             </a:r>
             <a:endParaRPr lang="en-US" sz="1500" dirty="0"/>
           </a:p>
@@ -11042,7 +11339,7 @@
                   <a:schemeClr val="tx2"/>
                 </a:solidFill>
               </a:rPr>
-              <a:t>Is the duration curve a straw man?</a:t>
+              <a:t>Mostly young men: does this apply to women and older crews?</a:t>
             </a:r>
             <a:endParaRPr lang="en-US" sz="1500" dirty="0"/>
           </a:p>
@@ -11060,7 +11357,7 @@
                   <a:schemeClr val="tx1"/>
                 </a:solidFill>
               </a:rPr>
-              <a:t>Ridge regression uses days, muscle and every other input: 3.28 vs 3.16 pp</a:t>
+              <a:t>Rows: men only 567, mixed 113, women only 40 (one campaign, WISE-2005)</a:t>
             </a:r>
             <a:endParaRPr lang="en-US" sz="1500" dirty="0"/>
           </a:p>
@@ -11078,7 +11375,7 @@
                   <a:schemeClr val="tx1"/>
                 </a:solidFill>
               </a:rPr>
-              <a:t>Knowing the muscle raises R² but not the error on a new campaign</a:t>
+              <a:t>Healthy young 692, older 42: the results describe young men</a:t>
             </a:r>
             <a:endParaRPr lang="en-US" sz="1500" dirty="0"/>
           </a:p>
@@ -11117,7 +11414,7 @@
                   <a:schemeClr val="tx2"/>
                 </a:solidFill>
               </a:rPr>
-              <a:t>Would a nearest-neighbour method match the LLM?</a:t>
+              <a:t>What exactly is a row's percentage change?</a:t>
             </a:r>
             <a:endParaRPr lang="en-US" sz="1500" dirty="0"/>
           </a:p>
@@ -11135,7 +11432,43 @@
                   <a:schemeClr val="tx1"/>
                 </a:solidFill>
               </a:rPr>
-              <a:t>Not tested. If the gain comes from picking similar rows, this is the next control to run</a:t>
+              <a:t>Follow-up vs the same group's own baseline; negative means loss</a:t>
+            </a:r>
+            <a:endParaRPr lang="en-US" sz="1500" dirty="0"/>
+          </a:p>
+          <a:p>
+            <a:pPr marL="342900" indent="-342900">
+              <a:spcAft>
+                <a:spcPts val="400"/>
+              </a:spcAft>
+              <a:buSzPct val="100000"/>
+              <a:buChar char="•"/>
+            </a:pPr>
+            <a:r>
+              <a:rPr lang="en-US" sz="1400" dirty="0">
+                <a:solidFill>
+                  <a:schemeClr val="tx1"/>
+                </a:solidFill>
+              </a:rPr>
+              <a:t>Recomputed from the printed values; where a paper prints the mean of individual changes, that value is kept and labelled</a:t>
+            </a:r>
+            <a:endParaRPr lang="en-US" sz="1500" dirty="0"/>
+          </a:p>
+          <a:p>
+            <a:pPr marL="342900" indent="-342900">
+              <a:spcAft>
+                <a:spcPts val="400"/>
+              </a:spcAft>
+              <a:buSzPct val="100000"/>
+              <a:buChar char="•"/>
+            </a:pPr>
+            <a:r>
+              <a:rPr lang="en-US" sz="1400" dirty="0">
+                <a:solidFill>
+                  <a:schemeClr val="tx1"/>
+                </a:solidFill>
+              </a:rPr>
+              <a:t>Rows weighted by number of participants: only 8 of 32 campaigns report the spread of the change</a:t>
             </a:r>
             <a:endParaRPr lang="en-US" sz="1500" dirty="0"/>
           </a:p>
@@ -11246,7 +11579,7 @@
                 <a:ea typeface="Cambria" pitchFamily="34" charset="-122"/>
                 <a:cs typeface="Cambria" pitchFamily="34" charset="-120"/>
               </a:rPr>
-              <a:t>Backup: applicability to Mars mission planning</a:t>
+              <a:t>Backup: certainty of the muscle-group curves</a:t>
             </a:r>
             <a:endParaRPr lang="en-US" sz="2800" dirty="0"/>
           </a:p>
@@ -11321,7 +11654,7 @@
                   <a:schemeClr val="tx2"/>
                 </a:solidFill>
               </a:rPr>
-              <a:t>A Mars transit is about 180 days; the data stop at 119</a:t>
+              <a:t>Is each line fitted to its own muscle?</a:t>
             </a:r>
             <a:endParaRPr lang="en-US" sz="1500" dirty="0"/>
           </a:p>
@@ -11339,7 +11672,7 @@
                   <a:schemeClr val="tx1"/>
                 </a:solidFill>
               </a:rPr>
-              <a:t>Only one campaign reaches 119 days</a:t>
+              <a:t>No. The day-60 values are fitted per muscle group (named muscles, 25 campaigns); the lines share one time course (τ = 60 days)</a:t>
             </a:r>
             <a:endParaRPr lang="en-US" sz="1500" dirty="0"/>
           </a:p>
@@ -11357,7 +11690,7 @@
                   <a:schemeClr val="tx1"/>
                 </a:solidFill>
               </a:rPr>
-              <a:t>A 180-day estimate is planned from the duration curve only, with an uncertainty range, labelled as an assumption</a:t>
+              <a:t>Separate shapes cannot be estimated: six of nine groups rest on four campaigns or fewer</a:t>
             </a:r>
             <a:endParaRPr lang="en-US" sz="1500" dirty="0"/>
           </a:p>
@@ -11396,7 +11729,7 @@
                   <a:schemeClr val="tx2"/>
                 </a:solidFill>
               </a:rPr>
-              <a:t>Bed rest is not spaceflight</a:t>
+              <a:t>Why a saturating curve?</a:t>
             </a:r>
             <a:endParaRPr lang="en-US" sz="1500" dirty="0"/>
           </a:p>
@@ -11414,46 +11747,7 @@
                   <a:schemeClr val="tx1"/>
                 </a:solidFill>
               </a:rPr>
-              <a:t>Only 14 spaceflight rows, 8 of them one back muscle: too few to test transfer</a:t>
-            </a:r>
-            <a:endParaRPr lang="en-US" sz="1500" dirty="0"/>
-          </a:p>
-        </p:txBody>
-      </p:sp>
-      <p:sp>
-        <p:nvSpPr>
-          <p:cNvPr id="6" name="Text 4"/>
-          <p:cNvSpPr txBox="1"/>
-          <p:nvPr/>
-        </p:nvSpPr>
-        <p:spPr>
-          <a:xfrm>
-            <a:off x="548640" y="3703320"/>
-            <a:ext cx="5394960" cy="2377440"/>
-          </a:xfrm>
-          <a:prstGeom prst="rect">
-            <a:avLst/>
-          </a:prstGeom>
-          <a:noFill/>
-          <a:ln/>
-        </p:spPr>
-        <p:txBody>
-          <a:bodyPr wrap="square" lIns="0" tIns="0" rIns="0" bIns="0" rtlCol="0" anchor="t"/>
-          <a:lstStyle/>
-          <a:p>
-            <a:pPr indent="0" marL="0">
-              <a:spcAft>
-                <a:spcPts val="400"/>
-              </a:spcAft>
-              <a:buNone/>
-            </a:pPr>
-            <a:r>
-              <a:rPr lang="en-US" sz="1500" b="1" dirty="0">
-                <a:solidFill>
-                  <a:schemeClr val="tx2"/>
-                </a:solidFill>
-              </a:rPr>
-              <a:t>Which countermeasure works? What about individuals?</a:t>
+              <a:t>Logarithmic, saturating and spline curves fit equally well (within 1.3 AIC points): the loss slows, but the data cannot say along which curve</a:t>
             </a:r>
             <a:endParaRPr lang="en-US" sz="1500" dirty="0"/>
           </a:p>
@@ -11471,7 +11765,46 @@
                   <a:schemeClr val="tx1"/>
                 </a:solidFill>
               </a:rPr>
-              <a:t>Countermeasure groups lose 3.7 pp less (95% CI 1.5 to 5.9), all types pooled</a:t>
+              <a:t>By day 119 the curve reaches 86% of its plateau, −17.3% (95% CI −20.9 to −13.7)</a:t>
+            </a:r>
+            <a:endParaRPr lang="en-US" sz="1500" dirty="0"/>
+          </a:p>
+        </p:txBody>
+      </p:sp>
+      <p:sp>
+        <p:nvSpPr>
+          <p:cNvPr id="6" name="Text 4"/>
+          <p:cNvSpPr txBox="1"/>
+          <p:nvPr/>
+        </p:nvSpPr>
+        <p:spPr>
+          <a:xfrm>
+            <a:off x="548640" y="3703320"/>
+            <a:ext cx="5394960" cy="2377440"/>
+          </a:xfrm>
+          <a:prstGeom prst="rect">
+            <a:avLst/>
+          </a:prstGeom>
+          <a:noFill/>
+          <a:ln/>
+        </p:spPr>
+        <p:txBody>
+          <a:bodyPr wrap="square" lIns="0" tIns="0" rIns="0" bIns="0" rtlCol="0" anchor="t"/>
+          <a:lstStyle/>
+          <a:p>
+            <a:pPr indent="0" marL="0">
+              <a:spcAft>
+                <a:spcPts val="400"/>
+              </a:spcAft>
+              <a:buNone/>
+            </a:pPr>
+            <a:r>
+              <a:rPr lang="en-US" sz="1500" b="1" dirty="0">
+                <a:solidFill>
+                  <a:schemeClr val="tx2"/>
+                </a:solidFill>
+              </a:rPr>
+              <a:t>How certain are the day-60 values?</a:t>
             </a:r>
             <a:endParaRPr lang="en-US" sz="1500" dirty="0"/>
           </a:p>
@@ -11489,46 +11822,7 @@
                   <a:schemeClr val="tx1"/>
                 </a:solidFill>
               </a:rPr>
-              <a:t>Every row is a group average; nothing about individual risk</a:t>
-            </a:r>
-            <a:endParaRPr lang="en-US" sz="1500" dirty="0"/>
-          </a:p>
-        </p:txBody>
-      </p:sp>
-      <p:sp>
-        <p:nvSpPr>
-          <p:cNvPr id="7" name="Text 5"/>
-          <p:cNvSpPr txBox="1"/>
-          <p:nvPr/>
-        </p:nvSpPr>
-        <p:spPr>
-          <a:xfrm>
-            <a:off x="6217920" y="3703320"/>
-            <a:ext cx="5394960" cy="2377440"/>
-          </a:xfrm>
-          <a:prstGeom prst="rect">
-            <a:avLst/>
-          </a:prstGeom>
-          <a:noFill/>
-          <a:ln/>
-        </p:spPr>
-        <p:txBody>
-          <a:bodyPr wrap="square" lIns="0" tIns="0" rIns="0" bIns="0" rtlCol="0" anchor="t"/>
-          <a:lstStyle/>
-          <a:p>
-            <a:pPr indent="0" marL="0">
-              <a:spcAft>
-                <a:spcPts val="400"/>
-              </a:spcAft>
-              <a:buNone/>
-            </a:pPr>
-            <a:r>
-              <a:rPr lang="en-US" sz="1500" b="1" dirty="0">
-                <a:solidFill>
-                  <a:schemeClr val="tx2"/>
-                </a:solidFill>
-              </a:rPr>
-              <a:t>Can anyone reproduce an LLM result?</a:t>
+              <a:t>Calf −15.8% (95% CI −18.9 to −12.7); front thigh −10.1% (−13.6 to −6.6); hip rotators −1.9% (−3.9 to 0.2)</a:t>
             </a:r>
             <a:endParaRPr lang="en-US" sz="1500" dirty="0"/>
           </a:p>
@@ -11546,7 +11840,7 @@
                   <a:schemeClr val="tx1"/>
                 </a:solidFill>
               </a:rPr>
-              <a:t>Fixed model version; all 430 answers saved, so every number rebuilds without the model</a:t>
+              <a:t>Calf vs shin, the ankle's opposing pair: 5.6 pp more loss (2.1 to 9.1), p = 0.003</a:t>
             </a:r>
             <a:endParaRPr lang="en-US" sz="1500" dirty="0"/>
           </a:p>
@@ -11564,7 +11858,82 @@
                   <a:schemeClr val="tx1"/>
                 </a:solidFill>
               </a:rPr>
-              <a:t>Identical requests differ by 0.17 pp on average</a:t>
+              <a:t>Hip rotators and outer hip: one campaign each</a:t>
+            </a:r>
+            <a:endParaRPr lang="en-US" sz="1500" dirty="0"/>
+          </a:p>
+        </p:txBody>
+      </p:sp>
+      <p:sp>
+        <p:nvSpPr>
+          <p:cNvPr id="7" name="Text 5"/>
+          <p:cNvSpPr txBox="1"/>
+          <p:nvPr/>
+        </p:nvSpPr>
+        <p:spPr>
+          <a:xfrm>
+            <a:off x="6217920" y="3703320"/>
+            <a:ext cx="5394960" cy="2377440"/>
+          </a:xfrm>
+          <a:prstGeom prst="rect">
+            <a:avLst/>
+          </a:prstGeom>
+          <a:noFill/>
+          <a:ln/>
+        </p:spPr>
+        <p:txBody>
+          <a:bodyPr wrap="square" lIns="0" tIns="0" rIns="0" bIns="0" rtlCol="0" anchor="t"/>
+          <a:lstStyle/>
+          <a:p>
+            <a:pPr indent="0" marL="0">
+              <a:spcAft>
+                <a:spcPts val="400"/>
+              </a:spcAft>
+              <a:buNone/>
+            </a:pPr>
+            <a:r>
+              <a:rPr lang="en-US" sz="1500" b="1" dirty="0">
+                <a:solidFill>
+                  <a:schemeClr val="tx2"/>
+                </a:solidFill>
+              </a:rPr>
+              <a:t>Is the calf result an artefact of how often it is scanned?</a:t>
+            </a:r>
+            <a:endParaRPr lang="en-US" sz="1500" dirty="0"/>
+          </a:p>
+          <a:p>
+            <a:pPr marL="342900" indent="-342900">
+              <a:spcAft>
+                <a:spcPts val="400"/>
+              </a:spcAft>
+              <a:buSzPct val="100000"/>
+              <a:buChar char="•"/>
+            </a:pPr>
+            <a:r>
+              <a:rPr lang="en-US" sz="1400" dirty="0">
+                <a:solidFill>
+                  <a:schemeClr val="tx1"/>
+                </a:solidFill>
+              </a:rPr>
+              <a:t>The order holds after adjusting for duration, countermeasure group and imaging method</a:t>
+            </a:r>
+            <a:endParaRPr lang="en-US" sz="1500" dirty="0"/>
+          </a:p>
+          <a:p>
+            <a:pPr marL="342900" indent="-342900">
+              <a:spcAft>
+                <a:spcPts val="400"/>
+              </a:spcAft>
+              <a:buSzPct val="100000"/>
+              <a:buChar char="•"/>
+            </a:pPr>
+            <a:r>
+              <a:rPr lang="en-US" sz="1400" dirty="0">
+                <a:solidFill>
+                  <a:schemeClr val="tx1"/>
+                </a:solidFill>
+              </a:rPr>
+              <a:t>Calf: 78 rows from 13 campaigns, the second best-covered group after the front thigh (86 rows, 22 campaigns)</a:t>
             </a:r>
             <a:endParaRPr lang="en-US" sz="1500" dirty="0"/>
           </a:p>
@@ -11610,6 +11979,489 @@
             <a:fld id="{F7021451-1387-4CA6-816F-3879F97B5CBC}" type="slidenum">
               <a:rPr b="0" lang="en-US"/>
               <a:t>18</a:t>
+            </a:fld>
+            <a:endParaRPr lang="en-US"/>
+          </a:p>
+        </p:txBody>
+      </p:sp>
+    </p:spTree>
+  </p:cSld>
+  <p:clrMapOvr>
+    <a:masterClrMapping/>
+  </p:clrMapOvr>
+</p:sld>
+</file>
+
+<file path=ppt/slides/slide19.xml><?xml version="1.0" encoding="utf-8"?>
+<p:sld xmlns:a="http://schemas.openxmlformats.org/drawingml/2006/main" xmlns:r="http://schemas.openxmlformats.org/officeDocument/2006/relationships" xmlns:p="http://schemas.openxmlformats.org/presentationml/2006/main">
+  <p:cSld name="Slide 19">
+    <p:spTree>
+      <p:nvGrpSpPr>
+        <p:cNvPr id="1" name=""/>
+        <p:cNvGrpSpPr/>
+        <p:nvPr/>
+      </p:nvGrpSpPr>
+      <p:grpSpPr>
+        <a:xfrm>
+          <a:off x="0" y="0"/>
+          <a:ext cx="0" cy="0"/>
+          <a:chOff x="0" y="0"/>
+          <a:chExt cx="0" cy="0"/>
+        </a:xfrm>
+      </p:grpSpPr>
+      <p:sp>
+        <p:nvSpPr>
+          <p:cNvPr id="2" name="Text 0"/>
+          <p:cNvSpPr/>
+          <p:nvPr>
+            <p:ph idx="101" type="title" hasCustomPrompt="1"/>
+          </p:nvPr>
+        </p:nvSpPr>
+        <p:spPr>
+          <a:xfrm>
+            <a:off x="548640" y="320040"/>
+            <a:ext cx="11064240" cy="731520"/>
+          </a:xfrm>
+          <a:prstGeom prst="rect">
+            <a:avLst/>
+          </a:prstGeom>
+          <a:noFill/>
+          <a:ln/>
+        </p:spPr>
+        <p:txBody>
+          <a:bodyPr wrap="square" lIns="0" tIns="0" rIns="0" bIns="0" rtlCol="0" anchor="ctr"/>
+          <a:lstStyle/>
+          <a:p>
+            <a:pPr algn="l" indent="0" marL="0">
+              <a:buNone/>
+            </a:pPr>
+            <a:r>
+              <a:rPr lang="en-US" sz="2800" b="1" dirty="0">
+                <a:solidFill>
+                  <a:schemeClr val="tx2"/>
+                </a:solidFill>
+                <a:latin typeface="Cambria" pitchFamily="34" charset="0"/>
+                <a:ea typeface="Cambria" pitchFamily="34" charset="-122"/>
+                <a:cs typeface="Cambria" pitchFamily="34" charset="-120"/>
+              </a:rPr>
+              <a:t>Backup: significance and relevance of the LLM gain</a:t>
+            </a:r>
+            <a:endParaRPr lang="en-US" sz="2800" dirty="0"/>
+          </a:p>
+        </p:txBody>
+      </p:sp>
+      <p:sp>
+        <p:nvSpPr>
+          <p:cNvPr id="3" name="Text 1"/>
+          <p:cNvSpPr txBox="1"/>
+          <p:nvPr/>
+        </p:nvSpPr>
+        <p:spPr>
+          <a:xfrm>
+            <a:off x="9784080" y="6355080"/>
+            <a:ext cx="1188720" cy="274320"/>
+          </a:xfrm>
+          <a:prstGeom prst="rect">
+            <a:avLst/>
+          </a:prstGeom>
+          <a:noFill/>
+          <a:ln/>
+        </p:spPr>
+        <p:txBody>
+          <a:bodyPr wrap="square" lIns="0" tIns="0" rIns="0" bIns="0" rtlCol="0" anchor="ctr"/>
+          <a:lstStyle/>
+          <a:p>
+            <a:pPr algn="r" indent="0" marL="0">
+              <a:buNone/>
+            </a:pPr>
+            <a:r>
+              <a:rPr lang="en-US" sz="1000" b="1" dirty="0">
+                <a:solidFill>
+                  <a:schemeClr val="accent3"/>
+                </a:solidFill>
+              </a:rPr>
+              <a:t>BACKUP</a:t>
+            </a:r>
+            <a:endParaRPr lang="en-US" sz="1000" dirty="0"/>
+          </a:p>
+        </p:txBody>
+      </p:sp>
+      <p:sp>
+        <p:nvSpPr>
+          <p:cNvPr id="4" name="Text 2"/>
+          <p:cNvSpPr txBox="1"/>
+          <p:nvPr/>
+        </p:nvSpPr>
+        <p:spPr>
+          <a:xfrm>
+            <a:off x="548640" y="1188720"/>
+            <a:ext cx="5394960" cy="2377440"/>
+          </a:xfrm>
+          <a:prstGeom prst="rect">
+            <a:avLst/>
+          </a:prstGeom>
+          <a:noFill/>
+          <a:ln/>
+        </p:spPr>
+        <p:txBody>
+          <a:bodyPr wrap="square" lIns="0" tIns="0" rIns="0" bIns="0" rtlCol="0" anchor="t"/>
+          <a:lstStyle/>
+          <a:p>
+            <a:pPr indent="0" marL="0">
+              <a:spcAft>
+                <a:spcPts val="400"/>
+              </a:spcAft>
+              <a:buNone/>
+            </a:pPr>
+            <a:r>
+              <a:rPr lang="en-US" sz="1500" b="1" dirty="0">
+                <a:solidFill>
+                  <a:schemeClr val="tx2"/>
+                </a:solidFill>
+              </a:rPr>
+              <a:t>Is 0.42 pp worth anything?</a:t>
+            </a:r>
+            <a:endParaRPr lang="en-US" sz="1500" dirty="0"/>
+          </a:p>
+          <a:p>
+            <a:pPr marL="342900" indent="-342900">
+              <a:spcAft>
+                <a:spcPts val="400"/>
+              </a:spcAft>
+              <a:buSzPct val="100000"/>
+              <a:buChar char="•"/>
+            </a:pPr>
+            <a:r>
+              <a:rPr lang="en-US" sz="1400" dirty="0">
+                <a:solidFill>
+                  <a:schemeClr val="tx1"/>
+                </a:solidFill>
+              </a:rPr>
+              <a:t>It is 13% lower error than the curve (3.13 to 2.71 pp)</a:t>
+            </a:r>
+            <a:endParaRPr lang="en-US" sz="1500" dirty="0"/>
+          </a:p>
+          <a:p>
+            <a:pPr marL="342900" indent="-342900">
+              <a:spcAft>
+                <a:spcPts val="400"/>
+              </a:spcAft>
+              <a:buSzPct val="100000"/>
+              <a:buChar char="•"/>
+            </a:pPr>
+            <a:r>
+              <a:rPr lang="en-US" sz="1400" dirty="0">
+                <a:solidFill>
+                  <a:schemeClr val="tx1"/>
+                </a:solidFill>
+              </a:rPr>
+              <a:t>Small; we present it as a secondary finding</a:t>
+            </a:r>
+            <a:endParaRPr lang="en-US" sz="1500" dirty="0"/>
+          </a:p>
+        </p:txBody>
+      </p:sp>
+      <p:sp>
+        <p:nvSpPr>
+          <p:cNvPr id="5" name="Text 3"/>
+          <p:cNvSpPr txBox="1"/>
+          <p:nvPr/>
+        </p:nvSpPr>
+        <p:spPr>
+          <a:xfrm>
+            <a:off x="6217920" y="1188720"/>
+            <a:ext cx="5394960" cy="2377440"/>
+          </a:xfrm>
+          <a:prstGeom prst="rect">
+            <a:avLst/>
+          </a:prstGeom>
+          <a:noFill/>
+          <a:ln/>
+        </p:spPr>
+        <p:txBody>
+          <a:bodyPr wrap="square" lIns="0" tIns="0" rIns="0" bIns="0" rtlCol="0" anchor="t"/>
+          <a:lstStyle/>
+          <a:p>
+            <a:pPr indent="0" marL="0">
+              <a:spcAft>
+                <a:spcPts val="400"/>
+              </a:spcAft>
+              <a:buNone/>
+            </a:pPr>
+            <a:r>
+              <a:rPr lang="en-US" sz="1500" b="1" dirty="0">
+                <a:solidFill>
+                  <a:schemeClr val="tx2"/>
+                </a:solidFill>
+              </a:rPr>
+              <a:t>20 of 32 campaigns is close to a coin flip</a:t>
+            </a:r>
+            <a:endParaRPr lang="en-US" sz="1500" dirty="0"/>
+          </a:p>
+          <a:p>
+            <a:pPr marL="342900" indent="-342900">
+              <a:spcAft>
+                <a:spcPts val="400"/>
+              </a:spcAft>
+              <a:buSzPct val="100000"/>
+              <a:buChar char="•"/>
+            </a:pPr>
+            <a:r>
+              <a:rPr lang="en-US" sz="1400" dirty="0">
+                <a:solidFill>
+                  <a:schemeClr val="tx1"/>
+                </a:solidFill>
+              </a:rPr>
+              <a:t>Counting wins only: p = 0.22 (sign test)*</a:t>
+            </a:r>
+            <a:endParaRPr lang="en-US" sz="1500" dirty="0"/>
+          </a:p>
+          <a:p>
+            <a:pPr marL="342900" indent="-342900">
+              <a:spcAft>
+                <a:spcPts val="400"/>
+              </a:spcAft>
+              <a:buSzPct val="100000"/>
+              <a:buChar char="•"/>
+            </a:pPr>
+            <a:r>
+              <a:rPr lang="en-US" sz="1400" dirty="0">
+                <a:solidFill>
+                  <a:schemeClr val="tx1"/>
+                </a:solidFill>
+              </a:rPr>
+              <a:t>Using the size of each win: mean gain 0.42 pp, 95% CI 0.13 to 0.73</a:t>
+            </a:r>
+            <a:endParaRPr lang="en-US" sz="1500" dirty="0"/>
+          </a:p>
+        </p:txBody>
+      </p:sp>
+      <p:sp>
+        <p:nvSpPr>
+          <p:cNvPr id="6" name="Text 4"/>
+          <p:cNvSpPr txBox="1"/>
+          <p:nvPr/>
+        </p:nvSpPr>
+        <p:spPr>
+          <a:xfrm>
+            <a:off x="548640" y="3703320"/>
+            <a:ext cx="5394960" cy="2377440"/>
+          </a:xfrm>
+          <a:prstGeom prst="rect">
+            <a:avLst/>
+          </a:prstGeom>
+          <a:noFill/>
+          <a:ln/>
+        </p:spPr>
+        <p:txBody>
+          <a:bodyPr wrap="square" lIns="0" tIns="0" rIns="0" bIns="0" rtlCol="0" anchor="t"/>
+          <a:lstStyle/>
+          <a:p>
+            <a:pPr indent="0" marL="0">
+              <a:spcAft>
+                <a:spcPts val="400"/>
+              </a:spcAft>
+              <a:buNone/>
+            </a:pPr>
+            <a:r>
+              <a:rPr lang="en-US" sz="1500" b="1" dirty="0">
+                <a:solidFill>
+                  <a:schemeClr val="tx2"/>
+                </a:solidFill>
+              </a:rPr>
+              <a:t>Does it rest on a few campaigns?</a:t>
+            </a:r>
+            <a:endParaRPr lang="en-US" sz="1500" dirty="0"/>
+          </a:p>
+          <a:p>
+            <a:pPr marL="342900" indent="-342900">
+              <a:spcAft>
+                <a:spcPts val="400"/>
+              </a:spcAft>
+              <a:buSzPct val="100000"/>
+              <a:buChar char="•"/>
+            </a:pPr>
+            <a:r>
+              <a:rPr lang="en-US" sz="1400" dirty="0">
+                <a:solidFill>
+                  <a:schemeClr val="tx1"/>
+                </a:solidFill>
+              </a:rPr>
+              <a:t>3 long MRI campaigns (NASA SPRINT, Berlin BBR2-2, MEDES LTBR) give 56% of the gain; without them 0.20 pp, CI −0.01 to 0.43*</a:t>
+            </a:r>
+            <a:endParaRPr lang="en-US" sz="1500" dirty="0"/>
+          </a:p>
+          <a:p>
+            <a:pPr marL="342900" indent="-342900">
+              <a:spcAft>
+                <a:spcPts val="400"/>
+              </a:spcAft>
+              <a:buSzPct val="100000"/>
+              <a:buChar char="•"/>
+            </a:pPr>
+            <a:r>
+              <a:rPr lang="en-US" sz="1400" dirty="0">
+                <a:solidFill>
+                  <a:schemeClr val="tx1"/>
+                </a:solidFill>
+              </a:rPr>
+              <a:t>Only SPRINT is recognised, and with campaign details removed the LLM still wins there (3.79 vs 5.92 pp)</a:t>
+            </a:r>
+            <a:endParaRPr lang="en-US" sz="1500" dirty="0"/>
+          </a:p>
+        </p:txBody>
+      </p:sp>
+      <p:sp>
+        <p:nvSpPr>
+          <p:cNvPr id="7" name="Text 5"/>
+          <p:cNvSpPr txBox="1"/>
+          <p:nvPr/>
+        </p:nvSpPr>
+        <p:spPr>
+          <a:xfrm>
+            <a:off x="6217920" y="3703320"/>
+            <a:ext cx="5394960" cy="2377440"/>
+          </a:xfrm>
+          <a:prstGeom prst="rect">
+            <a:avLst/>
+          </a:prstGeom>
+          <a:noFill/>
+          <a:ln/>
+        </p:spPr>
+        <p:txBody>
+          <a:bodyPr wrap="square" lIns="0" tIns="0" rIns="0" bIns="0" rtlCol="0" anchor="t"/>
+          <a:lstStyle/>
+          <a:p>
+            <a:pPr indent="0" marL="0">
+              <a:spcAft>
+                <a:spcPts val="400"/>
+              </a:spcAft>
+              <a:buNone/>
+            </a:pPr>
+            <a:r>
+              <a:rPr lang="en-US" sz="1500" b="1" dirty="0">
+                <a:solidFill>
+                  <a:schemeClr val="tx2"/>
+                </a:solidFill>
+              </a:rPr>
+              <a:t>Did it read these papers in training? Was it added after the fact?</a:t>
+            </a:r>
+            <a:endParaRPr lang="en-US" sz="1500" dirty="0"/>
+          </a:p>
+          <a:p>
+            <a:pPr marL="342900" indent="-342900">
+              <a:spcAft>
+                <a:spcPts val="400"/>
+              </a:spcAft>
+              <a:buSzPct val="100000"/>
+              <a:buChar char="•"/>
+            </a:pPr>
+            <a:r>
+              <a:rPr lang="en-US" sz="1400" dirty="0">
+                <a:solidFill>
+                  <a:schemeClr val="tx1"/>
+                </a:solidFill>
+              </a:rPr>
+              <a:t>Training exposure cannot be ruled out by any test; hiding campaign details and the naming test are the strongest checks available</a:t>
+            </a:r>
+            <a:endParaRPr lang="en-US" sz="1500" dirty="0"/>
+          </a:p>
+          <a:p>
+            <a:pPr marL="342900" indent="-342900">
+              <a:spcAft>
+                <a:spcPts val="400"/>
+              </a:spcAft>
+              <a:buSzPct val="100000"/>
+              <a:buChar char="•"/>
+            </a:pPr>
+            <a:r>
+              <a:rPr lang="en-US" sz="1400" dirty="0">
+                <a:solidFill>
+                  <a:schemeClr val="tx1"/>
+                </a:solidFill>
+              </a:rPr>
+              <a:t>Added after the ML result, but every check and target was committed before the first answer</a:t>
+            </a:r>
+            <a:endParaRPr lang="en-US" sz="1500" dirty="0"/>
+          </a:p>
+        </p:txBody>
+      </p:sp>
+      <p:sp>
+        <p:nvSpPr>
+          <p:cNvPr id="8" name="Text 6"/>
+          <p:cNvSpPr txBox="1"/>
+          <p:nvPr/>
+        </p:nvSpPr>
+        <p:spPr>
+          <a:xfrm>
+            <a:off x="548640" y="6035040"/>
+            <a:ext cx="9144000" cy="274320"/>
+          </a:xfrm>
+          <a:prstGeom prst="rect">
+            <a:avLst/>
+          </a:prstGeom>
+          <a:noFill/>
+          <a:ln/>
+        </p:spPr>
+        <p:txBody>
+          <a:bodyPr wrap="square" lIns="0" tIns="0" rIns="0" bIns="0" rtlCol="0" anchor="t"/>
+          <a:lstStyle/>
+          <a:p>
+            <a:pPr indent="0" marL="0">
+              <a:buNone/>
+            </a:pPr>
+            <a:r>
+              <a:rPr lang="en-US" sz="1100" i="1" dirty="0">
+                <a:solidFill>
+                  <a:schemeClr val="accent3"/>
+                </a:solidFill>
+              </a:rPr>
+              <a:t>* Our calculation from the saved LLM predictions; not in the report.</a:t>
+            </a:r>
+            <a:endParaRPr lang="en-US" sz="1100" dirty="0"/>
+          </a:p>
+        </p:txBody>
+      </p:sp>
+      <p:sp>
+        <p:nvSpPr>
+          <p:cNvPr id="25" name="Slide Number Placeholder 0"/>
+          <p:cNvSpPr>
+            <a:spLocks noGrp="1"/>
+          </p:cNvSpPr>
+          <p:nvPr>
+            <p:ph type="sldNum" sz="quarter" idx="4294967295"/>
+          </p:nvPr>
+        </p:nvSpPr>
+        <p:spPr>
+          <a:xfrm>
+            <a:off x="11155680" y="6355080"/>
+            <a:ext cx="457200" cy="274320"/>
+          </a:xfrm>
+          <a:prstGeom prst="rect">
+            <a:avLst/>
+          </a:prstGeom>
+          <a:extLst>
+            <a:ext uri="{C572A759-6A51-4108-AA02-DFA0A04FC94B}">
+              <ma14:wrappingTextBoxFlag xmlns:ma14="http://schemas.microsoft.com/office/mac/drawingml/2011/main" val="0"/>
+            </a:ext>
+          </a:extLst>
+        </p:spPr>
+        <p:txBody>
+          <a:bodyPr/>
+          <a:lstStyle>
+            <a:lvl1pPr>
+              <a:defRPr sz="1000">
+                <a:solidFill>
+                  <a:schemeClr val="accent3"/>
+                </a:solidFill>
+              </a:defRPr>
+            </a:lvl1pPr>
+          </a:lstStyle>
+          <a:p>
+            <a:pPr algn="r"/>
+            <a:fld id="{F7021451-1387-4CA6-816F-3879F97B5CBC}" type="slidenum">
+              <a:rPr b="0" lang="en-US"/>
+              <a:t>19</a:t>
             </a:fld>
             <a:endParaRPr lang="en-US"/>
           </a:p>
@@ -12702,6 +13554,864 @@
             <a:fld id="{F7021451-1387-4CA6-816F-3879F97B5CBC}" type="slidenum">
               <a:rPr b="0" lang="en-US"/>
               <a:t>2</a:t>
+            </a:fld>
+            <a:endParaRPr lang="en-US"/>
+          </a:p>
+        </p:txBody>
+      </p:sp>
+    </p:spTree>
+  </p:cSld>
+  <p:clrMapOvr>
+    <a:masterClrMapping/>
+  </p:clrMapOvr>
+</p:sld>
+</file>
+
+<file path=ppt/slides/slide20.xml><?xml version="1.0" encoding="utf-8"?>
+<p:sld xmlns:a="http://schemas.openxmlformats.org/drawingml/2006/main" xmlns:r="http://schemas.openxmlformats.org/officeDocument/2006/relationships" xmlns:p="http://schemas.openxmlformats.org/presentationml/2006/main">
+  <p:cSld name="Slide 20">
+    <p:spTree>
+      <p:nvGrpSpPr>
+        <p:cNvPr id="1" name=""/>
+        <p:cNvGrpSpPr/>
+        <p:nvPr/>
+      </p:nvGrpSpPr>
+      <p:grpSpPr>
+        <a:xfrm>
+          <a:off x="0" y="0"/>
+          <a:ext cx="0" cy="0"/>
+          <a:chOff x="0" y="0"/>
+          <a:chExt cx="0" cy="0"/>
+        </a:xfrm>
+      </p:grpSpPr>
+      <p:sp>
+        <p:nvSpPr>
+          <p:cNvPr id="2" name="Text 0"/>
+          <p:cNvSpPr/>
+          <p:nvPr>
+            <p:ph idx="101" type="title" hasCustomPrompt="1"/>
+          </p:nvPr>
+        </p:nvSpPr>
+        <p:spPr>
+          <a:xfrm>
+            <a:off x="548640" y="320040"/>
+            <a:ext cx="11064240" cy="731520"/>
+          </a:xfrm>
+          <a:prstGeom prst="rect">
+            <a:avLst/>
+          </a:prstGeom>
+          <a:noFill/>
+          <a:ln/>
+        </p:spPr>
+        <p:txBody>
+          <a:bodyPr wrap="square" lIns="0" tIns="0" rIns="0" bIns="0" rtlCol="0" anchor="ctr"/>
+          <a:lstStyle/>
+          <a:p>
+            <a:pPr algn="l" indent="0" marL="0">
+              <a:buNone/>
+            </a:pPr>
+            <a:r>
+              <a:rPr lang="en-US" sz="2800" b="1" dirty="0">
+                <a:solidFill>
+                  <a:schemeClr val="tx2"/>
+                </a:solidFill>
+                <a:latin typeface="Cambria" pitchFamily="34" charset="0"/>
+                <a:ea typeface="Cambria" pitchFamily="34" charset="-122"/>
+                <a:cs typeface="Cambria" pitchFamily="34" charset="-120"/>
+              </a:rPr>
+              <a:t>Backup: ML results and fairness of the comparison</a:t>
+            </a:r>
+            <a:endParaRPr lang="en-US" sz="2800" dirty="0"/>
+          </a:p>
+        </p:txBody>
+      </p:sp>
+      <p:sp>
+        <p:nvSpPr>
+          <p:cNvPr id="3" name="Text 1"/>
+          <p:cNvSpPr txBox="1"/>
+          <p:nvPr/>
+        </p:nvSpPr>
+        <p:spPr>
+          <a:xfrm>
+            <a:off x="9784080" y="6355080"/>
+            <a:ext cx="1188720" cy="274320"/>
+          </a:xfrm>
+          <a:prstGeom prst="rect">
+            <a:avLst/>
+          </a:prstGeom>
+          <a:noFill/>
+          <a:ln/>
+        </p:spPr>
+        <p:txBody>
+          <a:bodyPr wrap="square" lIns="0" tIns="0" rIns="0" bIns="0" rtlCol="0" anchor="ctr"/>
+          <a:lstStyle/>
+          <a:p>
+            <a:pPr algn="r" indent="0" marL="0">
+              <a:buNone/>
+            </a:pPr>
+            <a:r>
+              <a:rPr lang="en-US" sz="1000" b="1" dirty="0">
+                <a:solidFill>
+                  <a:schemeClr val="accent3"/>
+                </a:solidFill>
+              </a:rPr>
+              <a:t>BACKUP</a:t>
+            </a:r>
+            <a:endParaRPr lang="en-US" sz="1000" dirty="0"/>
+          </a:p>
+        </p:txBody>
+      </p:sp>
+      <p:sp>
+        <p:nvSpPr>
+          <p:cNvPr id="4" name="Text 2"/>
+          <p:cNvSpPr txBox="1"/>
+          <p:nvPr/>
+        </p:nvSpPr>
+        <p:spPr>
+          <a:xfrm>
+            <a:off x="548640" y="1188720"/>
+            <a:ext cx="5394960" cy="2377440"/>
+          </a:xfrm>
+          <a:prstGeom prst="rect">
+            <a:avLst/>
+          </a:prstGeom>
+          <a:noFill/>
+          <a:ln/>
+        </p:spPr>
+        <p:txBody>
+          <a:bodyPr wrap="square" lIns="0" tIns="0" rIns="0" bIns="0" rtlCol="0" anchor="t"/>
+          <a:lstStyle/>
+          <a:p>
+            <a:pPr indent="0" marL="0">
+              <a:spcAft>
+                <a:spcPts val="400"/>
+              </a:spcAft>
+              <a:buNone/>
+            </a:pPr>
+            <a:r>
+              <a:rPr lang="en-US" sz="1500" b="1" dirty="0">
+                <a:solidFill>
+                  <a:schemeClr val="tx2"/>
+                </a:solidFill>
+              </a:rPr>
+              <a:t>Did the ML models get a fair chance?</a:t>
+            </a:r>
+            <a:endParaRPr lang="en-US" sz="1500" dirty="0"/>
+          </a:p>
+          <a:p>
+            <a:pPr marL="342900" indent="-342900">
+              <a:spcAft>
+                <a:spcPts val="400"/>
+              </a:spcAft>
+              <a:buSzPct val="100000"/>
+              <a:buChar char="•"/>
+            </a:pPr>
+            <a:r>
+              <a:rPr lang="en-US" sz="1400" dirty="0">
+                <a:solidFill>
+                  <a:schemeClr val="tx1"/>
+                </a:solidFill>
+              </a:rPr>
+              <a:t>Tuned inside each training fold, grouped by campaign; TabPFN needs no tuning</a:t>
+            </a:r>
+            <a:endParaRPr lang="en-US" sz="1500" dirty="0"/>
+          </a:p>
+          <a:p>
+            <a:pPr marL="342900" indent="-342900">
+              <a:spcAft>
+                <a:spcPts val="400"/>
+              </a:spcAft>
+              <a:buSzPct val="100000"/>
+              <a:buChar char="•"/>
+            </a:pPr>
+            <a:r>
+              <a:rPr lang="en-US" sz="1400" dirty="0">
+                <a:solidFill>
+                  <a:schemeClr val="tx1"/>
+                </a:solidFill>
+              </a:rPr>
+              <a:t>All models saw the same inputs, folds and scoring</a:t>
+            </a:r>
+            <a:endParaRPr lang="en-US" sz="1500" dirty="0"/>
+          </a:p>
+        </p:txBody>
+      </p:sp>
+      <p:sp>
+        <p:nvSpPr>
+          <p:cNvPr id="5" name="Text 3"/>
+          <p:cNvSpPr txBox="1"/>
+          <p:nvPr/>
+        </p:nvSpPr>
+        <p:spPr>
+          <a:xfrm>
+            <a:off x="6217920" y="1188720"/>
+            <a:ext cx="5394960" cy="2377440"/>
+          </a:xfrm>
+          <a:prstGeom prst="rect">
+            <a:avLst/>
+          </a:prstGeom>
+          <a:noFill/>
+          <a:ln/>
+        </p:spPr>
+        <p:txBody>
+          <a:bodyPr wrap="square" lIns="0" tIns="0" rIns="0" bIns="0" rtlCol="0" anchor="t"/>
+          <a:lstStyle/>
+          <a:p>
+            <a:pPr indent="0" marL="0">
+              <a:spcAft>
+                <a:spcPts val="400"/>
+              </a:spcAft>
+              <a:buNone/>
+            </a:pPr>
+            <a:r>
+              <a:rPr lang="en-US" sz="1500" b="1" dirty="0">
+                <a:solidFill>
+                  <a:schemeClr val="tx2"/>
+                </a:solidFill>
+              </a:rPr>
+              <a:t>Why not add age, sex or countermeasure type?</a:t>
+            </a:r>
+            <a:endParaRPr lang="en-US" sz="1500" dirty="0"/>
+          </a:p>
+          <a:p>
+            <a:pPr marL="342900" indent="-342900">
+              <a:spcAft>
+                <a:spcPts val="400"/>
+              </a:spcAft>
+              <a:buSzPct val="100000"/>
+              <a:buChar char="•"/>
+            </a:pPr>
+            <a:r>
+              <a:rPr lang="en-US" sz="1400" dirty="0">
+                <a:solidFill>
+                  <a:schemeClr val="tx1"/>
+                </a:solidFill>
+              </a:rPr>
+              <a:t>32 campaigns leave room for about 3 campaign-level inputs (about 10 campaigns per input)</a:t>
+            </a:r>
+            <a:endParaRPr lang="en-US" sz="1500" dirty="0"/>
+          </a:p>
+          <a:p>
+            <a:pPr marL="342900" indent="-342900">
+              <a:spcAft>
+                <a:spcPts val="400"/>
+              </a:spcAft>
+              <a:buSzPct val="100000"/>
+              <a:buChar char="•"/>
+            </a:pPr>
+            <a:r>
+              <a:rPr lang="en-US" sz="1400" dirty="0">
+                <a:solidFill>
+                  <a:schemeClr val="tx1"/>
+                </a:solidFill>
+              </a:rPr>
+              <a:t>Age and sex are fixed within a campaign (347 of 425 rows men-only), so they act as a campaign label; 126 countermeasure rows spread over 9 types</a:t>
+            </a:r>
+            <a:endParaRPr lang="en-US" sz="1500" dirty="0"/>
+          </a:p>
+        </p:txBody>
+      </p:sp>
+      <p:sp>
+        <p:nvSpPr>
+          <p:cNvPr id="6" name="Text 4"/>
+          <p:cNvSpPr txBox="1"/>
+          <p:nvPr/>
+        </p:nvSpPr>
+        <p:spPr>
+          <a:xfrm>
+            <a:off x="548640" y="3703320"/>
+            <a:ext cx="5394960" cy="2377440"/>
+          </a:xfrm>
+          <a:prstGeom prst="rect">
+            <a:avLst/>
+          </a:prstGeom>
+          <a:noFill/>
+          <a:ln/>
+        </p:spPr>
+        <p:txBody>
+          <a:bodyPr wrap="square" lIns="0" tIns="0" rIns="0" bIns="0" rtlCol="0" anchor="t"/>
+          <a:lstStyle/>
+          <a:p>
+            <a:pPr indent="0" marL="0">
+              <a:spcAft>
+                <a:spcPts val="400"/>
+              </a:spcAft>
+              <a:buNone/>
+            </a:pPr>
+            <a:r>
+              <a:rPr lang="en-US" sz="1500" b="1" dirty="0">
+                <a:solidFill>
+                  <a:schemeClr val="tx2"/>
+                </a:solidFill>
+              </a:rPr>
+              <a:t>Is the duration curve a straw man?</a:t>
+            </a:r>
+            <a:endParaRPr lang="en-US" sz="1500" dirty="0"/>
+          </a:p>
+          <a:p>
+            <a:pPr marL="342900" indent="-342900">
+              <a:spcAft>
+                <a:spcPts val="400"/>
+              </a:spcAft>
+              <a:buSzPct val="100000"/>
+              <a:buChar char="•"/>
+            </a:pPr>
+            <a:r>
+              <a:rPr lang="en-US" sz="1400" dirty="0">
+                <a:solidFill>
+                  <a:schemeClr val="tx1"/>
+                </a:solidFill>
+              </a:rPr>
+              <a:t>Ridge regression uses days, muscle and every other input: 3.28 vs 3.16 pp</a:t>
+            </a:r>
+            <a:endParaRPr lang="en-US" sz="1500" dirty="0"/>
+          </a:p>
+          <a:p>
+            <a:pPr marL="342900" indent="-342900">
+              <a:spcAft>
+                <a:spcPts val="400"/>
+              </a:spcAft>
+              <a:buSzPct val="100000"/>
+              <a:buChar char="•"/>
+            </a:pPr>
+            <a:r>
+              <a:rPr lang="en-US" sz="1400" dirty="0">
+                <a:solidFill>
+                  <a:schemeClr val="tx1"/>
+                </a:solidFill>
+              </a:rPr>
+              <a:t>Knowing the muscle raises R² but not the error on a new campaign</a:t>
+            </a:r>
+            <a:endParaRPr lang="en-US" sz="1500" dirty="0"/>
+          </a:p>
+        </p:txBody>
+      </p:sp>
+      <p:sp>
+        <p:nvSpPr>
+          <p:cNvPr id="7" name="Text 5"/>
+          <p:cNvSpPr txBox="1"/>
+          <p:nvPr/>
+        </p:nvSpPr>
+        <p:spPr>
+          <a:xfrm>
+            <a:off x="6217920" y="3703320"/>
+            <a:ext cx="5394960" cy="2377440"/>
+          </a:xfrm>
+          <a:prstGeom prst="rect">
+            <a:avLst/>
+          </a:prstGeom>
+          <a:noFill/>
+          <a:ln/>
+        </p:spPr>
+        <p:txBody>
+          <a:bodyPr wrap="square" lIns="0" tIns="0" rIns="0" bIns="0" rtlCol="0" anchor="t"/>
+          <a:lstStyle/>
+          <a:p>
+            <a:pPr indent="0" marL="0">
+              <a:spcAft>
+                <a:spcPts val="400"/>
+              </a:spcAft>
+              <a:buNone/>
+            </a:pPr>
+            <a:r>
+              <a:rPr lang="en-US" sz="1500" b="1" dirty="0">
+                <a:solidFill>
+                  <a:schemeClr val="tx2"/>
+                </a:solidFill>
+              </a:rPr>
+              <a:t>Would a nearest-neighbour method match the LLM?</a:t>
+            </a:r>
+            <a:endParaRPr lang="en-US" sz="1500" dirty="0"/>
+          </a:p>
+          <a:p>
+            <a:pPr marL="342900" indent="-342900">
+              <a:spcAft>
+                <a:spcPts val="400"/>
+              </a:spcAft>
+              <a:buSzPct val="100000"/>
+              <a:buChar char="•"/>
+            </a:pPr>
+            <a:r>
+              <a:rPr lang="en-US" sz="1400" dirty="0">
+                <a:solidFill>
+                  <a:schemeClr val="tx1"/>
+                </a:solidFill>
+              </a:rPr>
+              <a:t>Not tested. If the gain comes from picking similar rows, this is the next control to run</a:t>
+            </a:r>
+            <a:endParaRPr lang="en-US" sz="1500" dirty="0"/>
+          </a:p>
+        </p:txBody>
+      </p:sp>
+      <p:sp>
+        <p:nvSpPr>
+          <p:cNvPr id="25" name="Slide Number Placeholder 0"/>
+          <p:cNvSpPr>
+            <a:spLocks noGrp="1"/>
+          </p:cNvSpPr>
+          <p:nvPr>
+            <p:ph type="sldNum" sz="quarter" idx="4294967295"/>
+          </p:nvPr>
+        </p:nvSpPr>
+        <p:spPr>
+          <a:xfrm>
+            <a:off x="11155680" y="6355080"/>
+            <a:ext cx="457200" cy="274320"/>
+          </a:xfrm>
+          <a:prstGeom prst="rect">
+            <a:avLst/>
+          </a:prstGeom>
+          <a:extLst>
+            <a:ext uri="{C572A759-6A51-4108-AA02-DFA0A04FC94B}">
+              <ma14:wrappingTextBoxFlag xmlns:ma14="http://schemas.microsoft.com/office/mac/drawingml/2011/main" val="0"/>
+            </a:ext>
+          </a:extLst>
+        </p:spPr>
+        <p:txBody>
+          <a:bodyPr/>
+          <a:lstStyle>
+            <a:lvl1pPr>
+              <a:defRPr sz="1000">
+                <a:solidFill>
+                  <a:schemeClr val="accent3"/>
+                </a:solidFill>
+              </a:defRPr>
+            </a:lvl1pPr>
+          </a:lstStyle>
+          <a:p>
+            <a:pPr algn="r"/>
+            <a:fld id="{F7021451-1387-4CA6-816F-3879F97B5CBC}" type="slidenum">
+              <a:rPr b="0" lang="en-US"/>
+              <a:t>20</a:t>
+            </a:fld>
+            <a:endParaRPr lang="en-US"/>
+          </a:p>
+        </p:txBody>
+      </p:sp>
+    </p:spTree>
+  </p:cSld>
+  <p:clrMapOvr>
+    <a:masterClrMapping/>
+  </p:clrMapOvr>
+</p:sld>
+</file>
+
+<file path=ppt/slides/slide21.xml><?xml version="1.0" encoding="utf-8"?>
+<p:sld xmlns:a="http://schemas.openxmlformats.org/drawingml/2006/main" xmlns:r="http://schemas.openxmlformats.org/officeDocument/2006/relationships" xmlns:p="http://schemas.openxmlformats.org/presentationml/2006/main">
+  <p:cSld name="Slide 21">
+    <p:spTree>
+      <p:nvGrpSpPr>
+        <p:cNvPr id="1" name=""/>
+        <p:cNvGrpSpPr/>
+        <p:nvPr/>
+      </p:nvGrpSpPr>
+      <p:grpSpPr>
+        <a:xfrm>
+          <a:off x="0" y="0"/>
+          <a:ext cx="0" cy="0"/>
+          <a:chOff x="0" y="0"/>
+          <a:chExt cx="0" cy="0"/>
+        </a:xfrm>
+      </p:grpSpPr>
+      <p:sp>
+        <p:nvSpPr>
+          <p:cNvPr id="2" name="Text 0"/>
+          <p:cNvSpPr/>
+          <p:nvPr>
+            <p:ph idx="101" type="title" hasCustomPrompt="1"/>
+          </p:nvPr>
+        </p:nvSpPr>
+        <p:spPr>
+          <a:xfrm>
+            <a:off x="548640" y="320040"/>
+            <a:ext cx="11064240" cy="731520"/>
+          </a:xfrm>
+          <a:prstGeom prst="rect">
+            <a:avLst/>
+          </a:prstGeom>
+          <a:noFill/>
+          <a:ln/>
+        </p:spPr>
+        <p:txBody>
+          <a:bodyPr wrap="square" lIns="0" tIns="0" rIns="0" bIns="0" rtlCol="0" anchor="ctr"/>
+          <a:lstStyle/>
+          <a:p>
+            <a:pPr algn="l" indent="0" marL="0">
+              <a:buNone/>
+            </a:pPr>
+            <a:r>
+              <a:rPr lang="en-US" sz="2800" b="1" dirty="0">
+                <a:solidFill>
+                  <a:schemeClr val="tx2"/>
+                </a:solidFill>
+                <a:latin typeface="Cambria" pitchFamily="34" charset="0"/>
+                <a:ea typeface="Cambria" pitchFamily="34" charset="-122"/>
+                <a:cs typeface="Cambria" pitchFamily="34" charset="-120"/>
+              </a:rPr>
+              <a:t>Backup: applicability to Mars mission planning</a:t>
+            </a:r>
+            <a:endParaRPr lang="en-US" sz="2800" dirty="0"/>
+          </a:p>
+        </p:txBody>
+      </p:sp>
+      <p:sp>
+        <p:nvSpPr>
+          <p:cNvPr id="3" name="Text 1"/>
+          <p:cNvSpPr txBox="1"/>
+          <p:nvPr/>
+        </p:nvSpPr>
+        <p:spPr>
+          <a:xfrm>
+            <a:off x="9784080" y="6355080"/>
+            <a:ext cx="1188720" cy="274320"/>
+          </a:xfrm>
+          <a:prstGeom prst="rect">
+            <a:avLst/>
+          </a:prstGeom>
+          <a:noFill/>
+          <a:ln/>
+        </p:spPr>
+        <p:txBody>
+          <a:bodyPr wrap="square" lIns="0" tIns="0" rIns="0" bIns="0" rtlCol="0" anchor="ctr"/>
+          <a:lstStyle/>
+          <a:p>
+            <a:pPr algn="r" indent="0" marL="0">
+              <a:buNone/>
+            </a:pPr>
+            <a:r>
+              <a:rPr lang="en-US" sz="1000" b="1" dirty="0">
+                <a:solidFill>
+                  <a:schemeClr val="accent3"/>
+                </a:solidFill>
+              </a:rPr>
+              <a:t>BACKUP</a:t>
+            </a:r>
+            <a:endParaRPr lang="en-US" sz="1000" dirty="0"/>
+          </a:p>
+        </p:txBody>
+      </p:sp>
+      <p:sp>
+        <p:nvSpPr>
+          <p:cNvPr id="4" name="Text 2"/>
+          <p:cNvSpPr txBox="1"/>
+          <p:nvPr/>
+        </p:nvSpPr>
+        <p:spPr>
+          <a:xfrm>
+            <a:off x="548640" y="1188720"/>
+            <a:ext cx="5394960" cy="2377440"/>
+          </a:xfrm>
+          <a:prstGeom prst="rect">
+            <a:avLst/>
+          </a:prstGeom>
+          <a:noFill/>
+          <a:ln/>
+        </p:spPr>
+        <p:txBody>
+          <a:bodyPr wrap="square" lIns="0" tIns="0" rIns="0" bIns="0" rtlCol="0" anchor="t"/>
+          <a:lstStyle/>
+          <a:p>
+            <a:pPr indent="0" marL="0">
+              <a:spcAft>
+                <a:spcPts val="400"/>
+              </a:spcAft>
+              <a:buNone/>
+            </a:pPr>
+            <a:r>
+              <a:rPr lang="en-US" sz="1500" b="1" dirty="0">
+                <a:solidFill>
+                  <a:schemeClr val="tx2"/>
+                </a:solidFill>
+              </a:rPr>
+              <a:t>A Mars transit is about 180 days; the data stop at 119</a:t>
+            </a:r>
+            <a:endParaRPr lang="en-US" sz="1500" dirty="0"/>
+          </a:p>
+          <a:p>
+            <a:pPr marL="342900" indent="-342900">
+              <a:spcAft>
+                <a:spcPts val="400"/>
+              </a:spcAft>
+              <a:buSzPct val="100000"/>
+              <a:buChar char="•"/>
+            </a:pPr>
+            <a:r>
+              <a:rPr lang="en-US" sz="1400" dirty="0">
+                <a:solidFill>
+                  <a:schemeClr val="tx1"/>
+                </a:solidFill>
+              </a:rPr>
+              <a:t>Only one campaign reaches 119 days</a:t>
+            </a:r>
+            <a:endParaRPr lang="en-US" sz="1500" dirty="0"/>
+          </a:p>
+          <a:p>
+            <a:pPr marL="342900" indent="-342900">
+              <a:spcAft>
+                <a:spcPts val="400"/>
+              </a:spcAft>
+              <a:buSzPct val="100000"/>
+              <a:buChar char="•"/>
+            </a:pPr>
+            <a:r>
+              <a:rPr lang="en-US" sz="1400" dirty="0">
+                <a:solidFill>
+                  <a:schemeClr val="tx1"/>
+                </a:solidFill>
+              </a:rPr>
+              <a:t>A 180-day estimate is planned from the duration curve only, with an uncertainty range, labelled as an assumption</a:t>
+            </a:r>
+            <a:endParaRPr lang="en-US" sz="1500" dirty="0"/>
+          </a:p>
+        </p:txBody>
+      </p:sp>
+      <p:sp>
+        <p:nvSpPr>
+          <p:cNvPr id="5" name="Text 3"/>
+          <p:cNvSpPr txBox="1"/>
+          <p:nvPr/>
+        </p:nvSpPr>
+        <p:spPr>
+          <a:xfrm>
+            <a:off x="6217920" y="1188720"/>
+            <a:ext cx="5394960" cy="2377440"/>
+          </a:xfrm>
+          <a:prstGeom prst="rect">
+            <a:avLst/>
+          </a:prstGeom>
+          <a:noFill/>
+          <a:ln/>
+        </p:spPr>
+        <p:txBody>
+          <a:bodyPr wrap="square" lIns="0" tIns="0" rIns="0" bIns="0" rtlCol="0" anchor="t"/>
+          <a:lstStyle/>
+          <a:p>
+            <a:pPr indent="0" marL="0">
+              <a:spcAft>
+                <a:spcPts val="400"/>
+              </a:spcAft>
+              <a:buNone/>
+            </a:pPr>
+            <a:r>
+              <a:rPr lang="en-US" sz="1500" b="1" dirty="0">
+                <a:solidFill>
+                  <a:schemeClr val="tx2"/>
+                </a:solidFill>
+              </a:rPr>
+              <a:t>Bed rest is not spaceflight</a:t>
+            </a:r>
+            <a:endParaRPr lang="en-US" sz="1500" dirty="0"/>
+          </a:p>
+          <a:p>
+            <a:pPr marL="342900" indent="-342900">
+              <a:spcAft>
+                <a:spcPts val="400"/>
+              </a:spcAft>
+              <a:buSzPct val="100000"/>
+              <a:buChar char="•"/>
+            </a:pPr>
+            <a:r>
+              <a:rPr lang="en-US" sz="1400" dirty="0">
+                <a:solidFill>
+                  <a:schemeClr val="tx1"/>
+                </a:solidFill>
+              </a:rPr>
+              <a:t>Only 14 spaceflight rows, 8 of them one back muscle: too few to test transfer</a:t>
+            </a:r>
+            <a:endParaRPr lang="en-US" sz="1500" dirty="0"/>
+          </a:p>
+        </p:txBody>
+      </p:sp>
+      <p:sp>
+        <p:nvSpPr>
+          <p:cNvPr id="6" name="Text 4"/>
+          <p:cNvSpPr txBox="1"/>
+          <p:nvPr/>
+        </p:nvSpPr>
+        <p:spPr>
+          <a:xfrm>
+            <a:off x="548640" y="3703320"/>
+            <a:ext cx="5394960" cy="2377440"/>
+          </a:xfrm>
+          <a:prstGeom prst="rect">
+            <a:avLst/>
+          </a:prstGeom>
+          <a:noFill/>
+          <a:ln/>
+        </p:spPr>
+        <p:txBody>
+          <a:bodyPr wrap="square" lIns="0" tIns="0" rIns="0" bIns="0" rtlCol="0" anchor="t"/>
+          <a:lstStyle/>
+          <a:p>
+            <a:pPr indent="0" marL="0">
+              <a:spcAft>
+                <a:spcPts val="400"/>
+              </a:spcAft>
+              <a:buNone/>
+            </a:pPr>
+            <a:r>
+              <a:rPr lang="en-US" sz="1500" b="1" dirty="0">
+                <a:solidFill>
+                  <a:schemeClr val="tx2"/>
+                </a:solidFill>
+              </a:rPr>
+              <a:t>Which countermeasure works? What about individuals?</a:t>
+            </a:r>
+            <a:endParaRPr lang="en-US" sz="1500" dirty="0"/>
+          </a:p>
+          <a:p>
+            <a:pPr marL="342900" indent="-342900">
+              <a:spcAft>
+                <a:spcPts val="400"/>
+              </a:spcAft>
+              <a:buSzPct val="100000"/>
+              <a:buChar char="•"/>
+            </a:pPr>
+            <a:r>
+              <a:rPr lang="en-US" sz="1400" dirty="0">
+                <a:solidFill>
+                  <a:schemeClr val="tx1"/>
+                </a:solidFill>
+              </a:rPr>
+              <a:t>Countermeasure groups lose 3.7 pp less (95% CI 1.5 to 5.9), all types pooled</a:t>
+            </a:r>
+            <a:endParaRPr lang="en-US" sz="1500" dirty="0"/>
+          </a:p>
+          <a:p>
+            <a:pPr marL="342900" indent="-342900">
+              <a:spcAft>
+                <a:spcPts val="400"/>
+              </a:spcAft>
+              <a:buSzPct val="100000"/>
+              <a:buChar char="•"/>
+            </a:pPr>
+            <a:r>
+              <a:rPr lang="en-US" sz="1400" dirty="0">
+                <a:solidFill>
+                  <a:schemeClr val="tx1"/>
+                </a:solidFill>
+              </a:rPr>
+              <a:t>Every row is a group average; nothing about individual risk</a:t>
+            </a:r>
+            <a:endParaRPr lang="en-US" sz="1500" dirty="0"/>
+          </a:p>
+        </p:txBody>
+      </p:sp>
+      <p:sp>
+        <p:nvSpPr>
+          <p:cNvPr id="7" name="Text 5"/>
+          <p:cNvSpPr txBox="1"/>
+          <p:nvPr/>
+        </p:nvSpPr>
+        <p:spPr>
+          <a:xfrm>
+            <a:off x="6217920" y="3703320"/>
+            <a:ext cx="5394960" cy="2377440"/>
+          </a:xfrm>
+          <a:prstGeom prst="rect">
+            <a:avLst/>
+          </a:prstGeom>
+          <a:noFill/>
+          <a:ln/>
+        </p:spPr>
+        <p:txBody>
+          <a:bodyPr wrap="square" lIns="0" tIns="0" rIns="0" bIns="0" rtlCol="0" anchor="t"/>
+          <a:lstStyle/>
+          <a:p>
+            <a:pPr indent="0" marL="0">
+              <a:spcAft>
+                <a:spcPts val="400"/>
+              </a:spcAft>
+              <a:buNone/>
+            </a:pPr>
+            <a:r>
+              <a:rPr lang="en-US" sz="1500" b="1" dirty="0">
+                <a:solidFill>
+                  <a:schemeClr val="tx2"/>
+                </a:solidFill>
+              </a:rPr>
+              <a:t>Can anyone reproduce an LLM result?</a:t>
+            </a:r>
+            <a:endParaRPr lang="en-US" sz="1500" dirty="0"/>
+          </a:p>
+          <a:p>
+            <a:pPr marL="342900" indent="-342900">
+              <a:spcAft>
+                <a:spcPts val="400"/>
+              </a:spcAft>
+              <a:buSzPct val="100000"/>
+              <a:buChar char="•"/>
+            </a:pPr>
+            <a:r>
+              <a:rPr lang="en-US" sz="1400" dirty="0">
+                <a:solidFill>
+                  <a:schemeClr val="tx1"/>
+                </a:solidFill>
+              </a:rPr>
+              <a:t>Fixed model version; all 430 answers saved, so every number rebuilds without the model</a:t>
+            </a:r>
+            <a:endParaRPr lang="en-US" sz="1500" dirty="0"/>
+          </a:p>
+          <a:p>
+            <a:pPr marL="342900" indent="-342900">
+              <a:spcAft>
+                <a:spcPts val="400"/>
+              </a:spcAft>
+              <a:buSzPct val="100000"/>
+              <a:buChar char="•"/>
+            </a:pPr>
+            <a:r>
+              <a:rPr lang="en-US" sz="1400" dirty="0">
+                <a:solidFill>
+                  <a:schemeClr val="tx1"/>
+                </a:solidFill>
+              </a:rPr>
+              <a:t>Identical requests differ by 0.17 pp on average</a:t>
+            </a:r>
+            <a:endParaRPr lang="en-US" sz="1500" dirty="0"/>
+          </a:p>
+        </p:txBody>
+      </p:sp>
+      <p:sp>
+        <p:nvSpPr>
+          <p:cNvPr id="25" name="Slide Number Placeholder 0"/>
+          <p:cNvSpPr>
+            <a:spLocks noGrp="1"/>
+          </p:cNvSpPr>
+          <p:nvPr>
+            <p:ph type="sldNum" sz="quarter" idx="4294967295"/>
+          </p:nvPr>
+        </p:nvSpPr>
+        <p:spPr>
+          <a:xfrm>
+            <a:off x="11155680" y="6355080"/>
+            <a:ext cx="457200" cy="274320"/>
+          </a:xfrm>
+          <a:prstGeom prst="rect">
+            <a:avLst/>
+          </a:prstGeom>
+          <a:extLst>
+            <a:ext uri="{C572A759-6A51-4108-AA02-DFA0A04FC94B}">
+              <ma14:wrappingTextBoxFlag xmlns:ma14="http://schemas.microsoft.com/office/mac/drawingml/2011/main" val="0"/>
+            </a:ext>
+          </a:extLst>
+        </p:spPr>
+        <p:txBody>
+          <a:bodyPr/>
+          <a:lstStyle>
+            <a:lvl1pPr>
+              <a:defRPr sz="1000">
+                <a:solidFill>
+                  <a:schemeClr val="accent3"/>
+                </a:solidFill>
+              </a:defRPr>
+            </a:lvl1pPr>
+          </a:lstStyle>
+          <a:p>
+            <a:pPr algn="r"/>
+            <a:fld id="{F7021451-1387-4CA6-816F-3879F97B5CBC}" type="slidenum">
+              <a:rPr b="0" lang="en-US"/>
+              <a:t>21</a:t>
             </a:fld>
             <a:endParaRPr lang="en-US"/>
           </a:p>

</xml_diff>

<commit_message>
Add closing slide with arrival-at-Mars visual before the backups
Co-Authored-By: Claude Opus 5.5 (1M context) <noreply@anthropic.com>
Claude-Session: https://claude.ai/code/session_01JZtuYERhuCe7nB9VYHwcfv
</commit_message>
<xml_diff>
--- a/presentation/bed-rest-to-mars-talk.pptx
+++ b/presentation/bed-rest-to-mars-talk.pptx
@@ -26,9 +26,10 @@
     <p:sldId id="274" r:id="rId20"/>
     <p:sldId id="275" r:id="rId21"/>
     <p:sldId id="276" r:id="rId22"/>
+    <p:sldId id="277" r:id="rId23"/>
   </p:sldIdLst>
   <p:notesMasterIdLst>
-    <p:notesMasterId r:id="rId23"/>
+    <p:notesMasterId r:id="rId24"/>
   </p:notesMasterIdLst>
   <p:sldSz cx="12192000" cy="6858000"/>
   <p:notesSz cx="6858000" cy="12192000"/>
@@ -127,13 +128,14 @@
   <p:extLst>
     <p:ext uri="{521415D9-36F7-43E2-AB2F-B90AF26B5E84}">
       <p14:sectionLst xmlns:p14="http://schemas.microsoft.com/office/powerpoint/2010/main">
-        <p14:section name="Opening" id="{fa5d2aab-e98c-611c-30f0-53565645d2f5}">
+        <p14:section name="Opening" id="{a0dc7691-2bf2-2674-ef07-e19c9b65dc72}">
           <p14:sldIdLst>
             <p14:sldId id="256"/>
             <p14:sldId id="257"/>
+            <p14:sldId id="269"/>
           </p14:sldIdLst>
         </p14:section>
-        <p14:section name="Part 1" id="{888bdb5b-3380-679e-e544-875ff8723e21}">
+        <p14:section name="Part 1" id="{8cefd1f0-170c-06fe-af01-a72cec1a76fa}">
           <p14:sldIdLst>
             <p14:sldId id="258"/>
             <p14:sldId id="259"/>
@@ -143,7 +145,7 @@
             <p14:sldId id="263"/>
           </p14:sldIdLst>
         </p14:section>
-        <p14:section name="Part 2" id="{08fc8cbf-6caa-5a69-6a47-b2919281447d}">
+        <p14:section name="Part 2" id="{1d4b737a-40e3-db5f-e476-b9a0477c78a5}">
           <p14:sldIdLst>
             <p14:sldId id="264"/>
             <p14:sldId id="265"/>
@@ -152,9 +154,11 @@
             <p14:sldId id="268"/>
           </p14:sldIdLst>
         </p14:section>
-        <p14:section name="Backup" id="{18857b80-308b-260d-41e1-140975dec969}">
+        <p14:section name="Opening" id="{abc4aff3-0da7-bad6-6404-4ed8a9fbaf5c}">
+          <p14:sldIdLst/>
+        </p14:section>
+        <p14:section name="Backup" id="{df318c58-9405-80b7-fbb9-b7575de952d6}">
           <p14:sldIdLst>
-            <p14:sldId id="269"/>
             <p14:sldId id="270"/>
             <p14:sldId id="271"/>
             <p14:sldId id="272"/>
@@ -162,27 +166,28 @@
             <p14:sldId id="274"/>
             <p14:sldId id="275"/>
             <p14:sldId id="276"/>
+            <p14:sldId id="277"/>
           </p14:sldIdLst>
         </p14:section>
-        <p14:section name="Backup" id="{3ae0dc77-496f-0be9-fd47-cd53ba665640}">
+        <p14:section name="Backup" id="{9aedc952-e807-b8d2-eb8f-ec387f1f3895}">
           <p14:sldIdLst/>
         </p14:section>
-        <p14:section name="Backup" id="{a7428151-474f-33a6-9ce0-ca15520a4062}">
+        <p14:section name="Backup" id="{61a15db3-76af-d63e-8963-b10874e8a5fc}">
           <p14:sldIdLst/>
         </p14:section>
-        <p14:section name="Backup" id="{61e93eef-ea04-d9c5-7cda-095ec5e2f536}">
+        <p14:section name="Backup" id="{e1e1bebb-8e6a-0be7-f3a9-8d5cec179642}">
           <p14:sldIdLst/>
         </p14:section>
-        <p14:section name="Backup" id="{375f218f-21ad-da33-85fa-3ff52fd5762a}">
+        <p14:section name="Backup" id="{950e64a2-1c0f-b942-7426-67348643ec48}">
           <p14:sldIdLst/>
         </p14:section>
-        <p14:section name="Backup" id="{dfc9741a-1d02-b5c9-509e-58e69988a25d}">
+        <p14:section name="Backup" id="{eb1b283e-b8c8-6a0b-31a7-746cf06c868f}">
           <p14:sldIdLst/>
         </p14:section>
-        <p14:section name="Backup" id="{354ec35d-7a38-fd0d-53c2-b3d6d376266e}">
+        <p14:section name="Backup" id="{34f217ce-628d-bb2e-1e6f-22e9ab9851a0}">
           <p14:sldIdLst/>
         </p14:section>
-        <p14:section name="Backup" id="{9b9b9385-26bf-10eb-0e4c-5388611efd9f}">
+        <p14:section name="Backup" id="{0e83922b-a45f-28a1-d6ed-15bc1fa0ceda}">
           <p14:sldIdLst/>
         </p14:section>
       </p14:sectionLst>
@@ -3301,8 +3306,7 @@
               <a:rPr lang="en-US" dirty="0"/>
               <a:t>About thirty seconds.
 With 32 independent campaigns, standard ML models and TabPFN do not beat a curve that only knows the number of days. An LLM-based probabilistic classifier that reads each campaign's description and the other campaigns' data reduces the error from 3.13 to 2.71 points. The main limitation is the small sample of 32 campaigns, mostly young men, with no bed-rest data beyond day 119.
-Next, we want to link the muscles, so that one muscle's loss predicts another's and a weighted sum estimates strength loss, and to build a risk-assessment system based on a person's characteristics.
-Thank you.</a:t>
+Next, we want to link the muscles, so that one muscle's loss predicts another's and a weighted sum estimates strength loss, and to build a risk-assessment system based on a person's characteristics.</a:t>
             </a:r>
             <a:endParaRPr lang="en-US" dirty="0"/>
           </a:p>
@@ -3390,7 +3394,7 @@
           <a:p>
             <a:r>
               <a:rPr lang="en-US" dirty="0"/>
-              <a:t>Backup. Be direct that the three must-show sensitivity analyses (composite-first, without MEDES, MRI only) have not been run yet. Only the weighting check has, and it changed little.</a:t>
+              <a:t>Close (Milad). Thank the audience and invite questions. The backup slides that follow answer the questions we expect: part 1 on slides 17 to 19, data and search on 15 and 16, part 2 on 20 to 22.</a:t>
             </a:r>
             <a:endParaRPr lang="en-US" dirty="0"/>
           </a:p>
@@ -3478,7 +3482,7 @@
           <a:p>
             <a:r>
               <a:rPr lang="en-US" dirty="0"/>
-              <a:t>Backup. All four strings are in the report appendix, copied from docs/literature-review/search_log.md. PubMed uses the same two blocks with MeSH terms and the humans filter; Scopus and Web of Science exclude animal studies in the query. The 2013 limit is the main weakness: only two of ten known modelling papers fall inside the window, and the known-item test without the limit was not run. Embase was not searched for lack of access; it indexes conference abstracts the other databases miss.</a:t>
+              <a:t>Backup. Be direct that the three must-show sensitivity analyses (composite-first, without MEDES, MRI only) have not been run yet. Only the weighting check has, and it changed little.</a:t>
             </a:r>
             <a:endParaRPr lang="en-US" dirty="0"/>
           </a:p>
@@ -3566,7 +3570,7 @@
           <a:p>
             <a:r>
               <a:rPr lang="en-US" dirty="0"/>
-              <a:t>Backup, part 1 (Niloufar). The arithmetic question is the most likely one: 3,600 minus 2,493 is 1,107, of which 84 reached full text and 1,023 were not screened in time. Say so plainly: they are open work, not exclusions. If pressed on the full-text stage: the report's own full-text counts are still being reconciled with the final extraction (it says so in a draft note), so do not claim the full-text numbers add up exactly. Known-item test: of the ten modelling papers we knew before the search, only two were published after 2013, and every journal database returned both. The test without the date limit was not run.</a:t>
+              <a:t>Backup. All four strings are in the report appendix, copied from docs/literature-review/search_log.md. PubMed uses the same two blocks with MeSH terms and the humans filter; Scopus and Web of Science exclude animal studies in the query. The 2013 limit is the main weakness: only two of ten known modelling papers fall inside the window, and the known-item test without the limit was not run. Embase was not searched for lack of access; it indexes conference abstracts the other databases miss.</a:t>
             </a:r>
             <a:endParaRPr lang="en-US" dirty="0"/>
           </a:p>
@@ -3654,7 +3658,7 @@
           <a:p>
             <a:r>
               <a:rPr lang="en-US" dirty="0"/>
-              <a:t>Backup, part 1 (Niloufar). Expansion: the eligibility criteria in the report's Table 2 were written before screening; dataset version 1.0 was frozen on 14 September and 1.1 on 19 September, and every result is fitted on 1.1. The rule for the curve: the saturating form is the headline unless another form beats it by at least 4 AIC points. Spaceflight: the dataset keeps the spaceflight rows, flagged, but they are post-flight measurements, so the during-unloading filter removes them. Weighting: inverse-variance weighting would need the spread of the change, which most papers do not print; the check that compares both weightings moved the duration effect by under 1 pp.</a:t>
+              <a:t>Backup, part 1 (Niloufar). The arithmetic question is the most likely one: 3,600 minus 2,493 is 1,107, of which 84 reached full text and 1,023 were not screened in time. Say so plainly: they are open work, not exclusions. If pressed on the full-text stage: the report's own full-text counts are still being reconciled with the final extraction (it says so in a draft note), so do not claim the full-text numbers add up exactly. Known-item test: of the ten modelling papers we knew before the search, only two were published after 2013, and every journal database returned both. The test without the date limit was not run.</a:t>
             </a:r>
             <a:endParaRPr lang="en-US" dirty="0"/>
           </a:p>
@@ -3742,7 +3746,7 @@
           <a:p>
             <a:r>
               <a:rPr lang="en-US" dirty="0"/>
-              <a:t>Backup, part 1 (Niloufar). Be precise about slide 8: the coloured dots at day 60 are the model's estimates for each muscle group, with the intervals shown here. The lines are drawn with one shared time course scaled to those values, so they show the shape the model assumes, not a separate fit per muscle. The intervals are 95% cluster-robust, which means they account for several rows coming from the same campaign. The calf-versus-shin contrast is reported on its own because it does not depend on which muscle is the reference.</a:t>
+              <a:t>Backup, part 1 (Niloufar). Expansion: the eligibility criteria in the report's Table 2 were written before screening; dataset version 1.0 was frozen on 14 September and 1.1 on 19 September, and every result is fitted on 1.1. The rule for the curve: the saturating form is the headline unless another form beats it by at least 4 AIC points. Spaceflight: the dataset keeps the spaceflight rows, flagged, but they are post-flight measurements, so the during-unloading filter removes them. Weighting: inverse-variance weighting would need the spread of the change, which most papers do not print; the check that compares both weightings moved the duration effect by under 1 pp.</a:t>
             </a:r>
             <a:endParaRPr lang="en-US" dirty="0"/>
           </a:p>
@@ -3830,7 +3834,7 @@
           <a:p>
             <a:r>
               <a:rPr lang="en-US" dirty="0"/>
-              <a:t>Backup. The two starred numbers are our own calculation from results/forecast_predictions.csv, not in the report. Without the three campaigns that carry most of the gain, the interval touches zero; say so if asked.</a:t>
+              <a:t>Backup, part 1 (Niloufar). Be precise about slide 8: the coloured dots at day 60 are the model's estimates for each muscle group, with the intervals shown here. The lines are drawn with one shared time course scaled to those values, so they show the shape the model assumes, not a separate fit per muscle. The intervals are 95% cluster-robust, which means they account for several rows coming from the same campaign. The calf-versus-shin contrast is reported on its own because it does not depend on which muscle is the reference.</a:t>
             </a:r>
             <a:endParaRPr lang="en-US" dirty="0"/>
           </a:p>
@@ -4006,7 +4010,7 @@
           <a:p>
             <a:r>
               <a:rPr lang="en-US" dirty="0"/>
-              <a:t>Backup. The honest gap here is the nearest-neighbour control: we cannot yet say whether a simple similarity method would match the LLM.</a:t>
+              <a:t>Backup. The two starred numbers are our own calculation from results/forecast_predictions.csv, not in the report. Without the three campaigns that carry most of the gain, the interval touches zero; say so if asked.</a:t>
             </a:r>
             <a:endParaRPr lang="en-US" dirty="0"/>
           </a:p>
@@ -4094,7 +4098,7 @@
           <a:p>
             <a:r>
               <a:rPr lang="en-US" dirty="0"/>
-              <a:t>Backup. The supported planning statements, within 5 to 119 days and for groups: most loss happens in the first weeks, calf muscles need protecting first, and countermeasure groups lose less.</a:t>
+              <a:t>Backup. The honest gap here is the nearest-neighbour control: we cannot yet say whether a simple similarity method would match the LLM.</a:t>
             </a:r>
             <a:endParaRPr lang="en-US" dirty="0"/>
           </a:p>
@@ -4118,6 +4122,94 @@
             <a:fld id="{F7021451-1387-4CA6-816F-3879F97B5CBC}" type="slidenum">
               <a:rPr lang="en-US"/>
               <a:t>21</a:t>
+            </a:fld>
+            <a:endParaRPr lang="en-US"/>
+          </a:p>
+        </p:txBody>
+      </p:sp>
+    </p:spTree>
+    <p:extLst>
+      <p:ext uri="{BB962C8B-B14F-4D97-AF65-F5344CB8AC3E}">
+        <p14:creationId xmlns:p14="http://schemas.microsoft.com/office/powerpoint/2010/main" val="1024086991"/>
+      </p:ext>
+    </p:extLst>
+  </p:cSld>
+  <p:clrMapOvr>
+    <a:masterClrMapping/>
+  </p:clrMapOvr>
+</p:notes>
+</file>
+
+<file path=ppt/notesSlides/notesSlide22.xml><?xml version="1.0" encoding="utf-8"?>
+<p:notes xmlns:a="http://schemas.openxmlformats.org/drawingml/2006/main" xmlns:r="http://schemas.openxmlformats.org/officeDocument/2006/relationships" xmlns:p="http://schemas.openxmlformats.org/presentationml/2006/main">
+  <p:cSld>
+    <p:spTree>
+      <p:nvGrpSpPr>
+        <p:cNvPr id="1" name=""/>
+        <p:cNvGrpSpPr/>
+        <p:nvPr/>
+      </p:nvGrpSpPr>
+      <p:grpSpPr>
+        <a:xfrm>
+          <a:off x="0" y="0"/>
+          <a:ext cx="0" cy="0"/>
+          <a:chOff x="0" y="0"/>
+          <a:chExt cx="0" cy="0"/>
+        </a:xfrm>
+      </p:grpSpPr>
+      <p:sp>
+        <p:nvSpPr>
+          <p:cNvPr id="2" name="Slide Image Placeholder 1"/>
+          <p:cNvSpPr>
+            <a:spLocks noGrp="1" noRot="1" noChangeAspect="1"/>
+          </p:cNvSpPr>
+          <p:nvPr>
+            <p:ph type="sldImg"/>
+          </p:nvPr>
+        </p:nvSpPr>
+        <p:spPr/>
+      </p:sp>
+      <p:sp>
+        <p:nvSpPr>
+          <p:cNvPr id="3" name="Notes Placeholder 2"/>
+          <p:cNvSpPr>
+            <a:spLocks noGrp="1"/>
+          </p:cNvSpPr>
+          <p:nvPr>
+            <p:ph type="body" idx="1"/>
+          </p:nvPr>
+        </p:nvSpPr>
+        <p:spPr/>
+        <p:txBody>
+          <a:bodyPr/>
+          <a:lstStyle/>
+          <a:p>
+            <a:r>
+              <a:rPr lang="en-US" dirty="0"/>
+              <a:t>Backup. The supported planning statements, within 5 to 119 days and for groups: most loss happens in the first weeks, calf muscles need protecting first, and countermeasure groups lose less.</a:t>
+            </a:r>
+            <a:endParaRPr lang="en-US" dirty="0"/>
+          </a:p>
+        </p:txBody>
+      </p:sp>
+      <p:sp>
+        <p:nvSpPr>
+          <p:cNvPr id="4" name="Slide Number Placeholder 3"/>
+          <p:cNvSpPr>
+            <a:spLocks noGrp="1"/>
+          </p:cNvSpPr>
+          <p:nvPr>
+            <p:ph type="sldNum" sz="quarter" idx="10"/>
+          </p:nvPr>
+        </p:nvSpPr>
+        <p:spPr/>
+        <p:txBody>
+          <a:bodyPr/>
+          <a:lstStyle/>
+          <a:p>
+            <a:fld id="{F7021451-1387-4CA6-816F-3879F97B5CBC}" type="slidenum">
+              <a:rPr lang="en-US"/>
+              <a:t>22</a:t>
             </a:fld>
             <a:endParaRPr lang="en-US"/>
           </a:p>
@@ -8534,6 +8626,20 @@
 <file path=ppt/slides/slide14.xml><?xml version="1.0" encoding="utf-8"?>
 <p:sld xmlns:a="http://schemas.openxmlformats.org/drawingml/2006/main" xmlns:r="http://schemas.openxmlformats.org/officeDocument/2006/relationships" xmlns:p="http://schemas.openxmlformats.org/presentationml/2006/main">
   <p:cSld name="Slide 14">
+    <p:bg>
+      <p:bgPr>
+        <a:blipFill dpi="0" rotWithShape="1">
+          <a:blip r:embed="rId1">
+            <a:lum/>
+          </a:blip>
+          <a:srcRect/>
+          <a:stretch>
+            <a:fillRect/>
+          </a:stretch>
+        </a:blipFill>
+        <a:effectLst/>
+      </p:bgPr>
+    </p:bg>
     <p:spTree>
       <p:nvGrpSpPr>
         <p:cNvPr id="1" name=""/>
@@ -8548,18 +8654,40 @@
           <a:chExt cx="0" cy="0"/>
         </a:xfrm>
       </p:grpSpPr>
-      <p:sp>
-        <p:nvSpPr>
-          <p:cNvPr id="2" name="Text 0"/>
-          <p:cNvSpPr/>
-          <p:nvPr>
-            <p:ph idx="101" type="title" hasCustomPrompt="1"/>
-          </p:nvPr>
-        </p:nvSpPr>
-        <p:spPr>
-          <a:xfrm>
-            <a:off x="548640" y="320040"/>
-            <a:ext cx="11064240" cy="731520"/>
+      <p:pic>
+        <p:nvPicPr>
+          <p:cNvPr id="2" name="Image 0" descr="DGLRM logo">    </p:cNvPr>
+          <p:cNvPicPr>
+            <a:picLocks noChangeAspect="1"/>
+          </p:cNvPicPr>
+          <p:nvPr/>
+        </p:nvPicPr>
+        <p:blipFill>
+          <a:blip r:embed="rId2"/>
+          <a:stretch>
+            <a:fillRect/>
+          </a:stretch>
+        </p:blipFill>
+        <p:spPr>
+          <a:xfrm>
+            <a:off x="822960" y="548640"/>
+            <a:ext cx="2926080" cy="786581"/>
+          </a:xfrm>
+          <a:prstGeom prst="rect">
+            <a:avLst/>
+          </a:prstGeom>
+        </p:spPr>
+      </p:pic>
+      <p:sp>
+        <p:nvSpPr>
+          <p:cNvPr id="3" name="Text 0"/>
+          <p:cNvSpPr txBox="1"/>
+          <p:nvPr/>
+        </p:nvSpPr>
+        <p:spPr>
+          <a:xfrm>
+            <a:off x="822960" y="1737360"/>
+            <a:ext cx="8961120" cy="1737360"/>
           </a:xfrm>
           <a:prstGeom prst="rect">
             <a:avLst/>
@@ -8568,73 +8696,60 @@
           <a:ln/>
         </p:spPr>
         <p:txBody>
-          <a:bodyPr wrap="square" lIns="0" tIns="0" rIns="0" bIns="0" rtlCol="0" anchor="ctr"/>
+          <a:bodyPr wrap="square" lIns="0" tIns="0" rIns="0" bIns="0" rtlCol="0" anchor="b"/>
           <a:lstStyle/>
           <a:p>
-            <a:pPr algn="l" indent="0" marL="0">
-              <a:buNone/>
-            </a:pPr>
-            <a:r>
-              <a:rPr lang="en-US" sz="2800" b="1" dirty="0">
-                <a:solidFill>
-                  <a:schemeClr val="tx2"/>
+            <a:pPr indent="0" marL="0">
+              <a:spcAft>
+                <a:spcPts val="1000"/>
+              </a:spcAft>
+              <a:buNone/>
+            </a:pPr>
+            <a:r>
+              <a:rPr lang="en-US" sz="4600" b="1" dirty="0">
+                <a:solidFill>
+                  <a:srgbClr val="FFFFFF"/>
                 </a:solidFill>
                 <a:latin typeface="Cambria" pitchFamily="34" charset="0"/>
                 <a:ea typeface="Cambria" pitchFamily="34" charset="-122"/>
                 <a:cs typeface="Cambria" pitchFamily="34" charset="-120"/>
               </a:rPr>
-              <a:t>Backup: dataset coverage and limitations</a:t>
-            </a:r>
-            <a:endParaRPr lang="en-US" sz="2800" dirty="0"/>
-          </a:p>
-        </p:txBody>
-      </p:sp>
-      <p:sp>
-        <p:nvSpPr>
-          <p:cNvPr id="3" name="Text 1"/>
+              <a:t>Thank you for listening</a:t>
+            </a:r>
+            <a:endParaRPr lang="en-US" sz="4600" dirty="0"/>
+          </a:p>
+          <a:p>
+            <a:pPr indent="0" marL="0">
+              <a:spcAft>
+                <a:spcPts val="1000"/>
+              </a:spcAft>
+              <a:buNone/>
+            </a:pPr>
+            <a:r>
+              <a:rPr lang="en-US" sz="2600" b="1" dirty="0">
+                <a:solidFill>
+                  <a:srgbClr val="F2D0A9"/>
+                </a:solidFill>
+                <a:latin typeface="Cambria" pitchFamily="34" charset="0"/>
+                <a:ea typeface="Cambria" pitchFamily="34" charset="-122"/>
+                <a:cs typeface="Cambria" pitchFamily="34" charset="-120"/>
+              </a:rPr>
+              <a:t>Questions are welcome</a:t>
+            </a:r>
+            <a:endParaRPr lang="en-US" sz="4600" dirty="0"/>
+          </a:p>
+        </p:txBody>
+      </p:sp>
+      <p:sp>
+        <p:nvSpPr>
+          <p:cNvPr id="4" name="Text 1"/>
           <p:cNvSpPr txBox="1"/>
           <p:nvPr/>
         </p:nvSpPr>
         <p:spPr>
           <a:xfrm>
-            <a:off x="9784080" y="6355080"/>
-            <a:ext cx="1188720" cy="274320"/>
-          </a:xfrm>
-          <a:prstGeom prst="rect">
-            <a:avLst/>
-          </a:prstGeom>
-          <a:noFill/>
-          <a:ln/>
-        </p:spPr>
-        <p:txBody>
-          <a:bodyPr wrap="square" lIns="0" tIns="0" rIns="0" bIns="0" rtlCol="0" anchor="ctr"/>
-          <a:lstStyle/>
-          <a:p>
-            <a:pPr algn="r" indent="0" marL="0">
-              <a:buNone/>
-            </a:pPr>
-            <a:r>
-              <a:rPr lang="en-US" sz="1000" b="1" dirty="0">
-                <a:solidFill>
-                  <a:schemeClr val="accent3"/>
-                </a:solidFill>
-              </a:rPr>
-              <a:t>BACKUP</a:t>
-            </a:r>
-            <a:endParaRPr lang="en-US" sz="1000" dirty="0"/>
-          </a:p>
-        </p:txBody>
-      </p:sp>
-      <p:sp>
-        <p:nvSpPr>
-          <p:cNvPr id="4" name="Text 2"/>
-          <p:cNvSpPr txBox="1"/>
-          <p:nvPr/>
-        </p:nvSpPr>
-        <p:spPr>
-          <a:xfrm>
-            <a:off x="548640" y="1188720"/>
-            <a:ext cx="5394960" cy="2377440"/>
+            <a:off x="822960" y="3840480"/>
+            <a:ext cx="7680960" cy="365760"/>
           </a:xfrm>
           <a:prstGeom prst="rect">
             <a:avLst/>
@@ -8647,69 +8762,63 @@
           <a:lstStyle/>
           <a:p>
             <a:pPr indent="0" marL="0">
-              <a:spcAft>
-                <a:spcPts val="400"/>
-              </a:spcAft>
-              <a:buNone/>
-            </a:pPr>
-            <a:r>
-              <a:rPr lang="en-US" sz="1500" b="1" dirty="0">
-                <a:solidFill>
-                  <a:schemeClr val="tx2"/>
-                </a:solidFill>
-              </a:rPr>
-              <a:t>Did you miss studies?</a:t>
-            </a:r>
-            <a:endParaRPr lang="en-US" sz="1500" dirty="0"/>
-          </a:p>
-          <a:p>
-            <a:pPr marL="342900" indent="-342900">
-              <a:spcAft>
-                <a:spcPts val="400"/>
-              </a:spcAft>
-              <a:buSzPct val="100000"/>
-              <a:buChar char="•"/>
-            </a:pPr>
-            <a:r>
-              <a:rPr lang="en-US" sz="1400" dirty="0">
-                <a:solidFill>
-                  <a:schemeClr val="tx1"/>
-                </a:solidFill>
-              </a:rPr>
-              <a:t>Four sources searched from 2013 on, plus 10 older or open-data studies (sources and queries on the next slide)</a:t>
-            </a:r>
-            <a:endParaRPr lang="en-US" sz="1500" dirty="0"/>
-          </a:p>
-          <a:p>
-            <a:pPr marL="342900" indent="-342900">
-              <a:spcAft>
-                <a:spcPts val="400"/>
-              </a:spcAft>
-              <a:buSzPct val="100000"/>
-              <a:buChar char="•"/>
-            </a:pPr>
-            <a:r>
-              <a:rPr lang="en-US" sz="1400" dirty="0">
-                <a:solidFill>
-                  <a:schemeClr val="tx1"/>
-                </a:solidFill>
-              </a:rPr>
-              <a:t>Not covered: Embase (no access); 1,023 records not yet screened (screening backup)</a:t>
-            </a:r>
-            <a:endParaRPr lang="en-US" sz="1500" dirty="0"/>
-          </a:p>
-        </p:txBody>
-      </p:sp>
-      <p:sp>
-        <p:nvSpPr>
-          <p:cNvPr id="5" name="Text 3"/>
+              <a:buNone/>
+            </a:pPr>
+            <a:r>
+              <a:rPr lang="en-US" sz="1800" dirty="0">
+                <a:solidFill>
+                  <a:srgbClr val="FFFFFF"/>
+                </a:solidFill>
+              </a:rPr>
+              <a:t>Niloufar Ahmadymarzdashty</a:t>
+            </a:r>
+            <a:pPr indent="0" marL="0">
+              <a:buNone/>
+            </a:pPr>
+            <a:r>
+              <a:rPr lang="en-US" sz="1800" baseline="30000" dirty="0">
+                <a:solidFill>
+                  <a:srgbClr val="FFFFFF"/>
+                </a:solidFill>
+              </a:rPr>
+              <a:t>1</a:t>
+            </a:r>
+            <a:pPr indent="0" marL="0">
+              <a:buNone/>
+            </a:pPr>
+            <a:r>
+              <a:rPr lang="en-US" sz="1800" dirty="0">
+                <a:solidFill>
+                  <a:srgbClr val="FFFFFF"/>
+                </a:solidFill>
+              </a:rPr>
+              <a:t>,  Milad Bahari Qaragoz</a:t>
+            </a:r>
+            <a:pPr indent="0" marL="0">
+              <a:buNone/>
+            </a:pPr>
+            <a:r>
+              <a:rPr lang="en-US" sz="1800" baseline="30000" dirty="0">
+                <a:solidFill>
+                  <a:srgbClr val="FFFFFF"/>
+                </a:solidFill>
+              </a:rPr>
+              <a:t>2</a:t>
+            </a:r>
+            <a:endParaRPr lang="en-US" sz="1800" dirty="0"/>
+          </a:p>
+        </p:txBody>
+      </p:sp>
+      <p:sp>
+        <p:nvSpPr>
+          <p:cNvPr id="5" name="Text 2"/>
           <p:cNvSpPr txBox="1"/>
           <p:nvPr/>
         </p:nvSpPr>
         <p:spPr>
           <a:xfrm>
-            <a:off x="6217920" y="1188720"/>
-            <a:ext cx="5394960" cy="2377440"/>
+            <a:off x="822960" y="4251960"/>
+            <a:ext cx="7680960" cy="548640"/>
           </a:xfrm>
           <a:prstGeom prst="rect">
             <a:avLst/>
@@ -8722,69 +8831,66 @@
           <a:lstStyle/>
           <a:p>
             <a:pPr indent="0" marL="0">
-              <a:spcAft>
-                <a:spcPts val="400"/>
-              </a:spcAft>
-              <a:buNone/>
-            </a:pPr>
-            <a:r>
-              <a:rPr lang="en-US" sz="1500" b="1" dirty="0">
-                <a:solidFill>
-                  <a:schemeClr val="tx2"/>
-                </a:solidFill>
-              </a:rPr>
-              <a:t>One campaign dominates the data</a:t>
-            </a:r>
-            <a:endParaRPr lang="en-US" sz="1500" dirty="0"/>
-          </a:p>
-          <a:p>
-            <a:pPr marL="342900" indent="-342900">
-              <a:spcAft>
-                <a:spcPts val="400"/>
-              </a:spcAft>
-              <a:buSzPct val="100000"/>
-              <a:buChar char="•"/>
+              <a:buNone/>
+            </a:pPr>
+            <a:r>
+              <a:rPr lang="en-US" sz="1400" baseline="30000" dirty="0">
+                <a:solidFill>
+                  <a:srgbClr val="B7C3D3"/>
+                </a:solidFill>
+              </a:rPr>
+              <a:t>1</a:t>
+            </a:r>
+            <a:pPr indent="0" marL="0">
+              <a:buNone/>
             </a:pPr>
             <a:r>
               <a:rPr lang="en-US" sz="1400" dirty="0">
                 <a:solidFill>
-                  <a:schemeClr val="tx1"/>
-                </a:solidFill>
-              </a:rPr>
-              <a:t>MEDES 90-day: 40% of all rows, a quarter of the modelling data</a:t>
-            </a:r>
-            <a:endParaRPr lang="en-US" sz="1500" dirty="0"/>
-          </a:p>
-          <a:p>
-            <a:pPr marL="342900" indent="-342900">
-              <a:spcAft>
-                <a:spcPts val="400"/>
-              </a:spcAft>
-              <a:buSzPct val="100000"/>
-              <a:buChar char="•"/>
+                  <a:srgbClr val="B7C3D3"/>
+                </a:solidFill>
+              </a:rPr>
+              <a:t> Independent researcher</a:t>
+            </a:r>
+            <a:endParaRPr lang="en-US" sz="1400" dirty="0"/>
+          </a:p>
+          <a:p>
+            <a:pPr indent="0" marL="0">
+              <a:buNone/>
+            </a:pPr>
+            <a:r>
+              <a:rPr lang="en-US" sz="1400" baseline="30000" dirty="0">
+                <a:solidFill>
+                  <a:srgbClr val="B7C3D3"/>
+                </a:solidFill>
+              </a:rPr>
+              <a:t>2</a:t>
+            </a:r>
+            <a:pPr indent="0" marL="0">
+              <a:buNone/>
             </a:pPr>
             <a:r>
               <a:rPr lang="en-US" sz="1400" dirty="0">
                 <a:solidFill>
-                  <a:schemeClr val="tx1"/>
-                </a:solidFill>
-              </a:rPr>
-              <a:t>Scoring gives each campaign one vote; the re-run without it is still to do</a:t>
-            </a:r>
-            <a:endParaRPr lang="en-US" sz="1500" dirty="0"/>
-          </a:p>
-        </p:txBody>
-      </p:sp>
-      <p:sp>
-        <p:nvSpPr>
-          <p:cNvPr id="6" name="Text 4"/>
+                  <a:srgbClr val="B7C3D3"/>
+                </a:solidFill>
+              </a:rPr>
+              <a:t> Master's candidate, Friedrich-Alexander-Universität Erlangen-Nürnberg (FAU)</a:t>
+            </a:r>
+            <a:endParaRPr lang="en-US" sz="1400" dirty="0"/>
+          </a:p>
+        </p:txBody>
+      </p:sp>
+      <p:sp>
+        <p:nvSpPr>
+          <p:cNvPr id="6" name="Text 3"/>
           <p:cNvSpPr txBox="1"/>
           <p:nvPr/>
         </p:nvSpPr>
         <p:spPr>
           <a:xfrm>
-            <a:off x="548640" y="3703320"/>
-            <a:ext cx="5394960" cy="2377440"/>
+            <a:off x="822960" y="4983480"/>
+            <a:ext cx="7680960" cy="365760"/>
           </a:xfrm>
           <a:prstGeom prst="rect">
             <a:avLst/>
@@ -8797,176 +8903,17 @@
           <a:lstStyle/>
           <a:p>
             <a:pPr indent="0" marL="0">
-              <a:spcAft>
-                <a:spcPts val="400"/>
-              </a:spcAft>
-              <a:buNone/>
-            </a:pPr>
-            <a:r>
-              <a:rPr lang="en-US" sz="1500" b="1" dirty="0">
-                <a:solidFill>
-                  <a:schemeClr val="tx2"/>
-                </a:solidFill>
-              </a:rPr>
-              <a:t>Can MRI, CT, DXA and ultrasound be mixed?</a:t>
-            </a:r>
-            <a:endParaRPr lang="en-US" sz="1500" dirty="0"/>
-          </a:p>
-          <a:p>
-            <a:pPr marL="342900" indent="-342900">
-              <a:spcAft>
-                <a:spcPts val="400"/>
-              </a:spcAft>
-              <a:buSzPct val="100000"/>
-              <a:buChar char="•"/>
-            </a:pPr>
-            <a:r>
-              <a:rPr lang="en-US" sz="1400" dirty="0">
-                <a:solidFill>
-                  <a:schemeClr val="tx1"/>
-                </a:solidFill>
-              </a:rPr>
-              <a:t>Each method gets its own term: DXA and ultrasound thickness show 5 to 6 pp less loss than CT; MRI volume is within 0.5 pp</a:t>
-            </a:r>
-            <a:endParaRPr lang="en-US" sz="1500" dirty="0"/>
-          </a:p>
-          <a:p>
-            <a:pPr marL="342900" indent="-342900">
-              <a:spcAft>
-                <a:spcPts val="400"/>
-              </a:spcAft>
-              <a:buSzPct val="100000"/>
-              <a:buChar char="•"/>
-            </a:pPr>
-            <a:r>
-              <a:rPr lang="en-US" sz="1400" dirty="0">
-                <a:solidFill>
-                  <a:schemeClr val="tx1"/>
-                </a:solidFill>
-              </a:rPr>
-              <a:t>The MRI-only re-run is still to do</a:t>
-            </a:r>
-            <a:endParaRPr lang="en-US" sz="1500" dirty="0"/>
-          </a:p>
-        </p:txBody>
-      </p:sp>
-      <p:sp>
-        <p:nvSpPr>
-          <p:cNvPr id="7" name="Text 5"/>
-          <p:cNvSpPr txBox="1"/>
-          <p:nvPr/>
-        </p:nvSpPr>
-        <p:spPr>
-          <a:xfrm>
-            <a:off x="6217920" y="3703320"/>
-            <a:ext cx="5394960" cy="2377440"/>
-          </a:xfrm>
-          <a:prstGeom prst="rect">
-            <a:avLst/>
-          </a:prstGeom>
-          <a:noFill/>
-          <a:ln/>
-        </p:spPr>
-        <p:txBody>
-          <a:bodyPr wrap="square" lIns="0" tIns="0" rIns="0" bIns="0" rtlCol="0" anchor="t"/>
-          <a:lstStyle/>
-          <a:p>
-            <a:pPr indent="0" marL="0">
-              <a:spcAft>
-                <a:spcPts val="400"/>
-              </a:spcAft>
-              <a:buNone/>
-            </a:pPr>
-            <a:r>
-              <a:rPr lang="en-US" sz="1500" b="1" dirty="0">
-                <a:solidFill>
-                  <a:schemeClr val="tx2"/>
-                </a:solidFill>
-              </a:rPr>
-              <a:t>How reliable is the extraction?</a:t>
-            </a:r>
-            <a:endParaRPr lang="en-US" sz="1500" dirty="0"/>
-          </a:p>
-          <a:p>
-            <a:pPr marL="342900" indent="-342900">
-              <a:spcAft>
-                <a:spcPts val="400"/>
-              </a:spcAft>
-              <a:buSzPct val="100000"/>
-              <a:buChar char="•"/>
-            </a:pPr>
-            <a:r>
-              <a:rPr lang="en-US" sz="1400" dirty="0">
-                <a:solidFill>
-                  <a:schemeClr val="tx1"/>
-                </a:solidFill>
-              </a:rPr>
-              <a:t>Every value is traced to its paper and page, table or figure</a:t>
-            </a:r>
-            <a:endParaRPr lang="en-US" sz="1500" dirty="0"/>
-          </a:p>
-          <a:p>
-            <a:pPr marL="342900" indent="-342900">
-              <a:spcAft>
-                <a:spcPts val="400"/>
-              </a:spcAft>
-              <a:buSzPct val="100000"/>
-              <a:buChar char="•"/>
-            </a:pPr>
-            <a:r>
-              <a:rPr lang="en-US" sz="1400" dirty="0">
-                <a:solidFill>
-                  <a:schemeClr val="tx1"/>
-                </a:solidFill>
-              </a:rPr>
-              <a:t>674 of 742 rows high confidence; 19 read off figures; no independent second extraction</a:t>
-            </a:r>
-            <a:endParaRPr lang="en-US" sz="1500" dirty="0"/>
-          </a:p>
-        </p:txBody>
-      </p:sp>
-      <p:sp>
-        <p:nvSpPr>
-          <p:cNvPr id="25" name="Slide Number Placeholder 0"/>
-          <p:cNvSpPr>
-            <a:spLocks noGrp="1"/>
-          </p:cNvSpPr>
-          <p:nvPr>
-            <p:ph type="sldNum" sz="quarter" idx="4294967295"/>
-          </p:nvPr>
-        </p:nvSpPr>
-        <p:spPr>
-          <a:xfrm>
-            <a:off x="11155680" y="6355080"/>
-            <a:ext cx="457200" cy="274320"/>
-          </a:xfrm>
-          <a:prstGeom prst="rect">
-            <a:avLst/>
-          </a:prstGeom>
-          <a:extLst>
-            <a:ext uri="{C572A759-6A51-4108-AA02-DFA0A04FC94B}">
-              <ma14:wrappingTextBoxFlag xmlns:ma14="http://schemas.microsoft.com/office/mac/drawingml/2011/main" val="0"/>
-            </a:ext>
-          </a:extLst>
-        </p:spPr>
-        <p:txBody>
-          <a:bodyPr/>
-          <a:lstStyle>
-            <a:lvl1pPr>
-              <a:defRPr sz="1000">
-                <a:solidFill>
-                  <a:schemeClr val="accent3"/>
-                </a:solidFill>
-              </a:defRPr>
-            </a:lvl1pPr>
-          </a:lstStyle>
-          <a:p>
-            <a:pPr algn="r"/>
-            <a:fld id="{F7021451-1387-4CA6-816F-3879F97B5CBC}" type="slidenum">
-              <a:rPr b="0" lang="en-US"/>
-              <a:t>14</a:t>
-            </a:fld>
-            <a:endParaRPr lang="en-US"/>
+              <a:buNone/>
+            </a:pPr>
+            <a:r>
+              <a:rPr lang="en-US" sz="1600" b="1" dirty="0">
+                <a:solidFill>
+                  <a:srgbClr val="F2D0A9"/>
+                </a:solidFill>
+              </a:rPr>
+              <a:t>From Bed Rest to Mars  |  64. Jahrestagung der DGLRM</a:t>
+            </a:r>
+            <a:endParaRPr lang="en-US" sz="1600" dirty="0"/>
           </a:p>
         </p:txBody>
       </p:sp>
@@ -9030,7 +8977,7 @@
                 <a:ea typeface="Cambria" pitchFamily="34" charset="-122"/>
                 <a:cs typeface="Cambria" pitchFamily="34" charset="-120"/>
               </a:rPr>
-              <a:t>Backup: literature search sources and query</a:t>
+              <a:t>Backup: dataset coverage and limitations</a:t>
             </a:r>
             <a:endParaRPr lang="en-US" sz="2800" dirty="0"/>
           </a:p>
@@ -9081,7 +9028,7 @@
         <p:spPr>
           <a:xfrm>
             <a:off x="548640" y="1188720"/>
-            <a:ext cx="5120640" cy="292608"/>
+            <a:ext cx="5394960" cy="2377440"/>
           </a:xfrm>
           <a:prstGeom prst="rect">
             <a:avLst/>
@@ -9094,6 +9041,453 @@
           <a:lstStyle/>
           <a:p>
             <a:pPr indent="0" marL="0">
+              <a:spcAft>
+                <a:spcPts val="400"/>
+              </a:spcAft>
+              <a:buNone/>
+            </a:pPr>
+            <a:r>
+              <a:rPr lang="en-US" sz="1500" b="1" dirty="0">
+                <a:solidFill>
+                  <a:schemeClr val="tx2"/>
+                </a:solidFill>
+              </a:rPr>
+              <a:t>Did you miss studies?</a:t>
+            </a:r>
+            <a:endParaRPr lang="en-US" sz="1500" dirty="0"/>
+          </a:p>
+          <a:p>
+            <a:pPr marL="342900" indent="-342900">
+              <a:spcAft>
+                <a:spcPts val="400"/>
+              </a:spcAft>
+              <a:buSzPct val="100000"/>
+              <a:buChar char="•"/>
+            </a:pPr>
+            <a:r>
+              <a:rPr lang="en-US" sz="1400" dirty="0">
+                <a:solidFill>
+                  <a:schemeClr val="tx1"/>
+                </a:solidFill>
+              </a:rPr>
+              <a:t>Four sources searched from 2013 on, plus 10 older or open-data studies (sources and queries on the next slide)</a:t>
+            </a:r>
+            <a:endParaRPr lang="en-US" sz="1500" dirty="0"/>
+          </a:p>
+          <a:p>
+            <a:pPr marL="342900" indent="-342900">
+              <a:spcAft>
+                <a:spcPts val="400"/>
+              </a:spcAft>
+              <a:buSzPct val="100000"/>
+              <a:buChar char="•"/>
+            </a:pPr>
+            <a:r>
+              <a:rPr lang="en-US" sz="1400" dirty="0">
+                <a:solidFill>
+                  <a:schemeClr val="tx1"/>
+                </a:solidFill>
+              </a:rPr>
+              <a:t>Not covered: Embase (no access); 1,023 records not yet screened (screening backup)</a:t>
+            </a:r>
+            <a:endParaRPr lang="en-US" sz="1500" dirty="0"/>
+          </a:p>
+        </p:txBody>
+      </p:sp>
+      <p:sp>
+        <p:nvSpPr>
+          <p:cNvPr id="5" name="Text 3"/>
+          <p:cNvSpPr txBox="1"/>
+          <p:nvPr/>
+        </p:nvSpPr>
+        <p:spPr>
+          <a:xfrm>
+            <a:off x="6217920" y="1188720"/>
+            <a:ext cx="5394960" cy="2377440"/>
+          </a:xfrm>
+          <a:prstGeom prst="rect">
+            <a:avLst/>
+          </a:prstGeom>
+          <a:noFill/>
+          <a:ln/>
+        </p:spPr>
+        <p:txBody>
+          <a:bodyPr wrap="square" lIns="0" tIns="0" rIns="0" bIns="0" rtlCol="0" anchor="t"/>
+          <a:lstStyle/>
+          <a:p>
+            <a:pPr indent="0" marL="0">
+              <a:spcAft>
+                <a:spcPts val="400"/>
+              </a:spcAft>
+              <a:buNone/>
+            </a:pPr>
+            <a:r>
+              <a:rPr lang="en-US" sz="1500" b="1" dirty="0">
+                <a:solidFill>
+                  <a:schemeClr val="tx2"/>
+                </a:solidFill>
+              </a:rPr>
+              <a:t>One campaign dominates the data</a:t>
+            </a:r>
+            <a:endParaRPr lang="en-US" sz="1500" dirty="0"/>
+          </a:p>
+          <a:p>
+            <a:pPr marL="342900" indent="-342900">
+              <a:spcAft>
+                <a:spcPts val="400"/>
+              </a:spcAft>
+              <a:buSzPct val="100000"/>
+              <a:buChar char="•"/>
+            </a:pPr>
+            <a:r>
+              <a:rPr lang="en-US" sz="1400" dirty="0">
+                <a:solidFill>
+                  <a:schemeClr val="tx1"/>
+                </a:solidFill>
+              </a:rPr>
+              <a:t>MEDES 90-day: 40% of all rows, a quarter of the modelling data</a:t>
+            </a:r>
+            <a:endParaRPr lang="en-US" sz="1500" dirty="0"/>
+          </a:p>
+          <a:p>
+            <a:pPr marL="342900" indent="-342900">
+              <a:spcAft>
+                <a:spcPts val="400"/>
+              </a:spcAft>
+              <a:buSzPct val="100000"/>
+              <a:buChar char="•"/>
+            </a:pPr>
+            <a:r>
+              <a:rPr lang="en-US" sz="1400" dirty="0">
+                <a:solidFill>
+                  <a:schemeClr val="tx1"/>
+                </a:solidFill>
+              </a:rPr>
+              <a:t>Scoring gives each campaign one vote; the re-run without it is still to do</a:t>
+            </a:r>
+            <a:endParaRPr lang="en-US" sz="1500" dirty="0"/>
+          </a:p>
+        </p:txBody>
+      </p:sp>
+      <p:sp>
+        <p:nvSpPr>
+          <p:cNvPr id="6" name="Text 4"/>
+          <p:cNvSpPr txBox="1"/>
+          <p:nvPr/>
+        </p:nvSpPr>
+        <p:spPr>
+          <a:xfrm>
+            <a:off x="548640" y="3703320"/>
+            <a:ext cx="5394960" cy="2377440"/>
+          </a:xfrm>
+          <a:prstGeom prst="rect">
+            <a:avLst/>
+          </a:prstGeom>
+          <a:noFill/>
+          <a:ln/>
+        </p:spPr>
+        <p:txBody>
+          <a:bodyPr wrap="square" lIns="0" tIns="0" rIns="0" bIns="0" rtlCol="0" anchor="t"/>
+          <a:lstStyle/>
+          <a:p>
+            <a:pPr indent="0" marL="0">
+              <a:spcAft>
+                <a:spcPts val="400"/>
+              </a:spcAft>
+              <a:buNone/>
+            </a:pPr>
+            <a:r>
+              <a:rPr lang="en-US" sz="1500" b="1" dirty="0">
+                <a:solidFill>
+                  <a:schemeClr val="tx2"/>
+                </a:solidFill>
+              </a:rPr>
+              <a:t>Can MRI, CT, DXA and ultrasound be mixed?</a:t>
+            </a:r>
+            <a:endParaRPr lang="en-US" sz="1500" dirty="0"/>
+          </a:p>
+          <a:p>
+            <a:pPr marL="342900" indent="-342900">
+              <a:spcAft>
+                <a:spcPts val="400"/>
+              </a:spcAft>
+              <a:buSzPct val="100000"/>
+              <a:buChar char="•"/>
+            </a:pPr>
+            <a:r>
+              <a:rPr lang="en-US" sz="1400" dirty="0">
+                <a:solidFill>
+                  <a:schemeClr val="tx1"/>
+                </a:solidFill>
+              </a:rPr>
+              <a:t>Each method gets its own term: DXA and ultrasound thickness show 5 to 6 pp less loss than CT; MRI volume is within 0.5 pp</a:t>
+            </a:r>
+            <a:endParaRPr lang="en-US" sz="1500" dirty="0"/>
+          </a:p>
+          <a:p>
+            <a:pPr marL="342900" indent="-342900">
+              <a:spcAft>
+                <a:spcPts val="400"/>
+              </a:spcAft>
+              <a:buSzPct val="100000"/>
+              <a:buChar char="•"/>
+            </a:pPr>
+            <a:r>
+              <a:rPr lang="en-US" sz="1400" dirty="0">
+                <a:solidFill>
+                  <a:schemeClr val="tx1"/>
+                </a:solidFill>
+              </a:rPr>
+              <a:t>The MRI-only re-run is still to do</a:t>
+            </a:r>
+            <a:endParaRPr lang="en-US" sz="1500" dirty="0"/>
+          </a:p>
+        </p:txBody>
+      </p:sp>
+      <p:sp>
+        <p:nvSpPr>
+          <p:cNvPr id="7" name="Text 5"/>
+          <p:cNvSpPr txBox="1"/>
+          <p:nvPr/>
+        </p:nvSpPr>
+        <p:spPr>
+          <a:xfrm>
+            <a:off x="6217920" y="3703320"/>
+            <a:ext cx="5394960" cy="2377440"/>
+          </a:xfrm>
+          <a:prstGeom prst="rect">
+            <a:avLst/>
+          </a:prstGeom>
+          <a:noFill/>
+          <a:ln/>
+        </p:spPr>
+        <p:txBody>
+          <a:bodyPr wrap="square" lIns="0" tIns="0" rIns="0" bIns="0" rtlCol="0" anchor="t"/>
+          <a:lstStyle/>
+          <a:p>
+            <a:pPr indent="0" marL="0">
+              <a:spcAft>
+                <a:spcPts val="400"/>
+              </a:spcAft>
+              <a:buNone/>
+            </a:pPr>
+            <a:r>
+              <a:rPr lang="en-US" sz="1500" b="1" dirty="0">
+                <a:solidFill>
+                  <a:schemeClr val="tx2"/>
+                </a:solidFill>
+              </a:rPr>
+              <a:t>How reliable is the extraction?</a:t>
+            </a:r>
+            <a:endParaRPr lang="en-US" sz="1500" dirty="0"/>
+          </a:p>
+          <a:p>
+            <a:pPr marL="342900" indent="-342900">
+              <a:spcAft>
+                <a:spcPts val="400"/>
+              </a:spcAft>
+              <a:buSzPct val="100000"/>
+              <a:buChar char="•"/>
+            </a:pPr>
+            <a:r>
+              <a:rPr lang="en-US" sz="1400" dirty="0">
+                <a:solidFill>
+                  <a:schemeClr val="tx1"/>
+                </a:solidFill>
+              </a:rPr>
+              <a:t>Every value is traced to its paper and page, table or figure</a:t>
+            </a:r>
+            <a:endParaRPr lang="en-US" sz="1500" dirty="0"/>
+          </a:p>
+          <a:p>
+            <a:pPr marL="342900" indent="-342900">
+              <a:spcAft>
+                <a:spcPts val="400"/>
+              </a:spcAft>
+              <a:buSzPct val="100000"/>
+              <a:buChar char="•"/>
+            </a:pPr>
+            <a:r>
+              <a:rPr lang="en-US" sz="1400" dirty="0">
+                <a:solidFill>
+                  <a:schemeClr val="tx1"/>
+                </a:solidFill>
+              </a:rPr>
+              <a:t>674 of 742 rows high confidence; 19 read off figures; no independent second extraction</a:t>
+            </a:r>
+            <a:endParaRPr lang="en-US" sz="1500" dirty="0"/>
+          </a:p>
+        </p:txBody>
+      </p:sp>
+      <p:sp>
+        <p:nvSpPr>
+          <p:cNvPr id="25" name="Slide Number Placeholder 0"/>
+          <p:cNvSpPr>
+            <a:spLocks noGrp="1"/>
+          </p:cNvSpPr>
+          <p:nvPr>
+            <p:ph type="sldNum" sz="quarter" idx="4294967295"/>
+          </p:nvPr>
+        </p:nvSpPr>
+        <p:spPr>
+          <a:xfrm>
+            <a:off x="11155680" y="6355080"/>
+            <a:ext cx="457200" cy="274320"/>
+          </a:xfrm>
+          <a:prstGeom prst="rect">
+            <a:avLst/>
+          </a:prstGeom>
+          <a:extLst>
+            <a:ext uri="{C572A759-6A51-4108-AA02-DFA0A04FC94B}">
+              <ma14:wrappingTextBoxFlag xmlns:ma14="http://schemas.microsoft.com/office/mac/drawingml/2011/main" val="0"/>
+            </a:ext>
+          </a:extLst>
+        </p:spPr>
+        <p:txBody>
+          <a:bodyPr/>
+          <a:lstStyle>
+            <a:lvl1pPr>
+              <a:defRPr sz="1000">
+                <a:solidFill>
+                  <a:schemeClr val="accent3"/>
+                </a:solidFill>
+              </a:defRPr>
+            </a:lvl1pPr>
+          </a:lstStyle>
+          <a:p>
+            <a:pPr algn="r"/>
+            <a:fld id="{F7021451-1387-4CA6-816F-3879F97B5CBC}" type="slidenum">
+              <a:rPr b="0" lang="en-US"/>
+              <a:t>15</a:t>
+            </a:fld>
+            <a:endParaRPr lang="en-US"/>
+          </a:p>
+        </p:txBody>
+      </p:sp>
+    </p:spTree>
+  </p:cSld>
+  <p:clrMapOvr>
+    <a:masterClrMapping/>
+  </p:clrMapOvr>
+</p:sld>
+</file>
+
+<file path=ppt/slides/slide16.xml><?xml version="1.0" encoding="utf-8"?>
+<p:sld xmlns:a="http://schemas.openxmlformats.org/drawingml/2006/main" xmlns:r="http://schemas.openxmlformats.org/officeDocument/2006/relationships" xmlns:p="http://schemas.openxmlformats.org/presentationml/2006/main">
+  <p:cSld name="Slide 16">
+    <p:spTree>
+      <p:nvGrpSpPr>
+        <p:cNvPr id="1" name=""/>
+        <p:cNvGrpSpPr/>
+        <p:nvPr/>
+      </p:nvGrpSpPr>
+      <p:grpSpPr>
+        <a:xfrm>
+          <a:off x="0" y="0"/>
+          <a:ext cx="0" cy="0"/>
+          <a:chOff x="0" y="0"/>
+          <a:chExt cx="0" cy="0"/>
+        </a:xfrm>
+      </p:grpSpPr>
+      <p:sp>
+        <p:nvSpPr>
+          <p:cNvPr id="2" name="Text 0"/>
+          <p:cNvSpPr/>
+          <p:nvPr>
+            <p:ph idx="101" type="title" hasCustomPrompt="1"/>
+          </p:nvPr>
+        </p:nvSpPr>
+        <p:spPr>
+          <a:xfrm>
+            <a:off x="548640" y="320040"/>
+            <a:ext cx="11064240" cy="731520"/>
+          </a:xfrm>
+          <a:prstGeom prst="rect">
+            <a:avLst/>
+          </a:prstGeom>
+          <a:noFill/>
+          <a:ln/>
+        </p:spPr>
+        <p:txBody>
+          <a:bodyPr wrap="square" lIns="0" tIns="0" rIns="0" bIns="0" rtlCol="0" anchor="ctr"/>
+          <a:lstStyle/>
+          <a:p>
+            <a:pPr algn="l" indent="0" marL="0">
+              <a:buNone/>
+            </a:pPr>
+            <a:r>
+              <a:rPr lang="en-US" sz="2800" b="1" dirty="0">
+                <a:solidFill>
+                  <a:schemeClr val="tx2"/>
+                </a:solidFill>
+                <a:latin typeface="Cambria" pitchFamily="34" charset="0"/>
+                <a:ea typeface="Cambria" pitchFamily="34" charset="-122"/>
+                <a:cs typeface="Cambria" pitchFamily="34" charset="-120"/>
+              </a:rPr>
+              <a:t>Backup: literature search sources and query</a:t>
+            </a:r>
+            <a:endParaRPr lang="en-US" sz="2800" dirty="0"/>
+          </a:p>
+        </p:txBody>
+      </p:sp>
+      <p:sp>
+        <p:nvSpPr>
+          <p:cNvPr id="3" name="Text 1"/>
+          <p:cNvSpPr txBox="1"/>
+          <p:nvPr/>
+        </p:nvSpPr>
+        <p:spPr>
+          <a:xfrm>
+            <a:off x="9784080" y="6355080"/>
+            <a:ext cx="1188720" cy="274320"/>
+          </a:xfrm>
+          <a:prstGeom prst="rect">
+            <a:avLst/>
+          </a:prstGeom>
+          <a:noFill/>
+          <a:ln/>
+        </p:spPr>
+        <p:txBody>
+          <a:bodyPr wrap="square" lIns="0" tIns="0" rIns="0" bIns="0" rtlCol="0" anchor="ctr"/>
+          <a:lstStyle/>
+          <a:p>
+            <a:pPr algn="r" indent="0" marL="0">
+              <a:buNone/>
+            </a:pPr>
+            <a:r>
+              <a:rPr lang="en-US" sz="1000" b="1" dirty="0">
+                <a:solidFill>
+                  <a:schemeClr val="accent3"/>
+                </a:solidFill>
+              </a:rPr>
+              <a:t>BACKUP</a:t>
+            </a:r>
+            <a:endParaRPr lang="en-US" sz="1000" dirty="0"/>
+          </a:p>
+        </p:txBody>
+      </p:sp>
+      <p:sp>
+        <p:nvSpPr>
+          <p:cNvPr id="4" name="Text 2"/>
+          <p:cNvSpPr txBox="1"/>
+          <p:nvPr/>
+        </p:nvSpPr>
+        <p:spPr>
+          <a:xfrm>
+            <a:off x="548640" y="1188720"/>
+            <a:ext cx="5120640" cy="292608"/>
+          </a:xfrm>
+          <a:prstGeom prst="rect">
+            <a:avLst/>
+          </a:prstGeom>
+          <a:noFill/>
+          <a:ln/>
+        </p:spPr>
+        <p:txBody>
+          <a:bodyPr wrap="square" lIns="0" tIns="0" rIns="0" bIns="0" rtlCol="0" anchor="t"/>
+          <a:lstStyle/>
+          <a:p>
+            <a:pPr indent="0" marL="0">
               <a:buNone/>
             </a:pPr>
             <a:r>
@@ -9110,7 +9504,7 @@
       </p:sp>
       <p:graphicFrame>
         <p:nvGraphicFramePr>
-          <p:cNvPr id="16" name="Table 0"/>
+          <p:cNvPr id="17" name="Table 0"/>
           <p:cNvGraphicFramePr>
             <a:graphicFrameLocks noGrp="1"/>
           </p:cNvGraphicFramePr>
@@ -10547,507 +10941,6 @@
             <a:pPr algn="r"/>
             <a:fld id="{F7021451-1387-4CA6-816F-3879F97B5CBC}" type="slidenum">
               <a:rPr b="0" lang="en-US"/>
-              <a:t>15</a:t>
-            </a:fld>
-            <a:endParaRPr lang="en-US"/>
-          </a:p>
-        </p:txBody>
-      </p:sp>
-    </p:spTree>
-  </p:cSld>
-  <p:clrMapOvr>
-    <a:masterClrMapping/>
-  </p:clrMapOvr>
-</p:sld>
-</file>
-
-<file path=ppt/slides/slide16.xml><?xml version="1.0" encoding="utf-8"?>
-<p:sld xmlns:a="http://schemas.openxmlformats.org/drawingml/2006/main" xmlns:r="http://schemas.openxmlformats.org/officeDocument/2006/relationships" xmlns:p="http://schemas.openxmlformats.org/presentationml/2006/main">
-  <p:cSld name="Slide 16">
-    <p:spTree>
-      <p:nvGrpSpPr>
-        <p:cNvPr id="1" name=""/>
-        <p:cNvGrpSpPr/>
-        <p:nvPr/>
-      </p:nvGrpSpPr>
-      <p:grpSpPr>
-        <a:xfrm>
-          <a:off x="0" y="0"/>
-          <a:ext cx="0" cy="0"/>
-          <a:chOff x="0" y="0"/>
-          <a:chExt cx="0" cy="0"/>
-        </a:xfrm>
-      </p:grpSpPr>
-      <p:sp>
-        <p:nvSpPr>
-          <p:cNvPr id="2" name="Text 0"/>
-          <p:cNvSpPr/>
-          <p:nvPr>
-            <p:ph idx="101" type="title" hasCustomPrompt="1"/>
-          </p:nvPr>
-        </p:nvSpPr>
-        <p:spPr>
-          <a:xfrm>
-            <a:off x="548640" y="320040"/>
-            <a:ext cx="11064240" cy="731520"/>
-          </a:xfrm>
-          <a:prstGeom prst="rect">
-            <a:avLst/>
-          </a:prstGeom>
-          <a:noFill/>
-          <a:ln/>
-        </p:spPr>
-        <p:txBody>
-          <a:bodyPr wrap="square" lIns="0" tIns="0" rIns="0" bIns="0" rtlCol="0" anchor="ctr"/>
-          <a:lstStyle/>
-          <a:p>
-            <a:pPr algn="l" indent="0" marL="0">
-              <a:buNone/>
-            </a:pPr>
-            <a:r>
-              <a:rPr lang="en-US" sz="2800" b="1" dirty="0">
-                <a:solidFill>
-                  <a:schemeClr val="tx2"/>
-                </a:solidFill>
-                <a:latin typeface="Cambria" pitchFamily="34" charset="0"/>
-                <a:ea typeface="Cambria" pitchFamily="34" charset="-122"/>
-                <a:cs typeface="Cambria" pitchFamily="34" charset="-120"/>
-              </a:rPr>
-              <a:t>Backup: screening and study selection</a:t>
-            </a:r>
-            <a:endParaRPr lang="en-US" sz="2800" dirty="0"/>
-          </a:p>
-        </p:txBody>
-      </p:sp>
-      <p:sp>
-        <p:nvSpPr>
-          <p:cNvPr id="3" name="Text 1"/>
-          <p:cNvSpPr txBox="1"/>
-          <p:nvPr/>
-        </p:nvSpPr>
-        <p:spPr>
-          <a:xfrm>
-            <a:off x="9784080" y="6355080"/>
-            <a:ext cx="1188720" cy="274320"/>
-          </a:xfrm>
-          <a:prstGeom prst="rect">
-            <a:avLst/>
-          </a:prstGeom>
-          <a:noFill/>
-          <a:ln/>
-        </p:spPr>
-        <p:txBody>
-          <a:bodyPr wrap="square" lIns="0" tIns="0" rIns="0" bIns="0" rtlCol="0" anchor="ctr"/>
-          <a:lstStyle/>
-          <a:p>
-            <a:pPr algn="r" indent="0" marL="0">
-              <a:buNone/>
-            </a:pPr>
-            <a:r>
-              <a:rPr lang="en-US" sz="1000" b="1" dirty="0">
-                <a:solidFill>
-                  <a:schemeClr val="accent3"/>
-                </a:solidFill>
-              </a:rPr>
-              <a:t>BACKUP</a:t>
-            </a:r>
-            <a:endParaRPr lang="en-US" sz="1000" dirty="0"/>
-          </a:p>
-        </p:txBody>
-      </p:sp>
-      <p:sp>
-        <p:nvSpPr>
-          <p:cNvPr id="4" name="Text 2"/>
-          <p:cNvSpPr txBox="1"/>
-          <p:nvPr/>
-        </p:nvSpPr>
-        <p:spPr>
-          <a:xfrm>
-            <a:off x="548640" y="1188720"/>
-            <a:ext cx="5394960" cy="2377440"/>
-          </a:xfrm>
-          <a:prstGeom prst="rect">
-            <a:avLst/>
-          </a:prstGeom>
-          <a:noFill/>
-          <a:ln/>
-        </p:spPr>
-        <p:txBody>
-          <a:bodyPr wrap="square" lIns="0" tIns="0" rIns="0" bIns="0" rtlCol="0" anchor="t"/>
-          <a:lstStyle/>
-          <a:p>
-            <a:pPr indent="0" marL="0">
-              <a:spcAft>
-                <a:spcPts val="400"/>
-              </a:spcAft>
-              <a:buNone/>
-            </a:pPr>
-            <a:r>
-              <a:rPr lang="en-US" sz="1500" b="1" dirty="0">
-                <a:solidFill>
-                  <a:schemeClr val="tx2"/>
-                </a:solidFill>
-              </a:rPr>
-              <a:t>3,600 screened, 2,493 excluded: where are the other 1,107?</a:t>
-            </a:r>
-            <a:endParaRPr lang="en-US" sz="1500" dirty="0"/>
-          </a:p>
-          <a:p>
-            <a:pPr marL="342900" indent="-342900">
-              <a:spcAft>
-                <a:spcPts val="400"/>
-              </a:spcAft>
-              <a:buSzPct val="100000"/>
-              <a:buChar char="•"/>
-            </a:pPr>
-            <a:r>
-              <a:rPr lang="en-US" sz="1400" dirty="0">
-                <a:solidFill>
-                  <a:schemeClr val="tx1"/>
-                </a:solidFill>
-              </a:rPr>
-              <a:t>84 went on to full text: 74 from the search and 10 from other sources</a:t>
-            </a:r>
-            <a:endParaRPr lang="en-US" sz="1500" dirty="0"/>
-          </a:p>
-          <a:p>
-            <a:pPr marL="342900" indent="-342900">
-              <a:spcAft>
-                <a:spcPts val="400"/>
-              </a:spcAft>
-              <a:buSzPct val="100000"/>
-              <a:buChar char="•"/>
-            </a:pPr>
-            <a:r>
-              <a:rPr lang="en-US" sz="1400" dirty="0">
-                <a:solidFill>
-                  <a:schemeClr val="tx1"/>
-                </a:solidFill>
-              </a:rPr>
-              <a:t>1,023 were not screened in the time available: the rest of the "maybe" set and 80 records waiting for a full text</a:t>
-            </a:r>
-            <a:endParaRPr lang="en-US" sz="1500" dirty="0"/>
-          </a:p>
-          <a:p>
-            <a:pPr marL="342900" indent="-342900">
-              <a:spcAft>
-                <a:spcPts val="400"/>
-              </a:spcAft>
-              <a:buSzPct val="100000"/>
-              <a:buChar char="•"/>
-            </a:pPr>
-            <a:r>
-              <a:rPr lang="en-US" sz="1400" dirty="0">
-                <a:solidFill>
-                  <a:schemeClr val="tx1"/>
-                </a:solidFill>
-              </a:rPr>
-              <a:t>They are reported as unscreened, not as excluded</a:t>
-            </a:r>
-            <a:endParaRPr lang="en-US" sz="1500" dirty="0"/>
-          </a:p>
-        </p:txBody>
-      </p:sp>
-      <p:sp>
-        <p:nvSpPr>
-          <p:cNvPr id="5" name="Text 3"/>
-          <p:cNvSpPr txBox="1"/>
-          <p:nvPr/>
-        </p:nvSpPr>
-        <p:spPr>
-          <a:xfrm>
-            <a:off x="6217920" y="1188720"/>
-            <a:ext cx="5394960" cy="2377440"/>
-          </a:xfrm>
-          <a:prstGeom prst="rect">
-            <a:avLst/>
-          </a:prstGeom>
-          <a:noFill/>
-          <a:ln/>
-        </p:spPr>
-        <p:txBody>
-          <a:bodyPr wrap="square" lIns="0" tIns="0" rIns="0" bIns="0" rtlCol="0" anchor="t"/>
-          <a:lstStyle/>
-          <a:p>
-            <a:pPr indent="0" marL="0">
-              <a:spcAft>
-                <a:spcPts val="400"/>
-              </a:spcAft>
-              <a:buNone/>
-            </a:pPr>
-            <a:r>
-              <a:rPr lang="en-US" sz="1500" b="1" dirty="0">
-                <a:solidFill>
-                  <a:schemeClr val="tx2"/>
-                </a:solidFill>
-              </a:rPr>
-              <a:t>Who screened, and was it done twice?</a:t>
-            </a:r>
-            <a:endParaRPr lang="en-US" sz="1500" dirty="0"/>
-          </a:p>
-          <a:p>
-            <a:pPr marL="342900" indent="-342900">
-              <a:spcAft>
-                <a:spcPts val="400"/>
-              </a:spcAft>
-              <a:buSzPct val="100000"/>
-              <a:buChar char="•"/>
-            </a:pPr>
-            <a:r>
-              <a:rPr lang="en-US" sz="1400" dirty="0">
-                <a:solidFill>
-                  <a:schemeClr val="tx1"/>
-                </a:solidFill>
-              </a:rPr>
-              <a:t>Eligibility criteria were written before screening began</a:t>
-            </a:r>
-            <a:endParaRPr lang="en-US" sz="1500" dirty="0"/>
-          </a:p>
-          <a:p>
-            <a:pPr marL="342900" indent="-342900">
-              <a:spcAft>
-                <a:spcPts val="400"/>
-              </a:spcAft>
-              <a:buSzPct val="100000"/>
-              <a:buChar char="•"/>
-            </a:pPr>
-            <a:r>
-              <a:rPr lang="en-US" sz="1400" dirty="0">
-                <a:solidFill>
-                  <a:schemeClr val="tx1"/>
-                </a:solidFill>
-              </a:rPr>
-              <a:t>A rule-based triage sorted the records; one person then read the priority set and the top of the "maybe" set</a:t>
-            </a:r>
-            <a:endParaRPr lang="en-US" sz="1500" dirty="0"/>
-          </a:p>
-          <a:p>
-            <a:pPr marL="342900" indent="-342900">
-              <a:spcAft>
-                <a:spcPts val="400"/>
-              </a:spcAft>
-              <a:buSzPct val="100000"/>
-              <a:buChar char="•"/>
-            </a:pPr>
-            <a:r>
-              <a:rPr lang="en-US" sz="1400" dirty="0">
-                <a:solidFill>
-                  <a:schemeClr val="tx1"/>
-                </a:solidFill>
-              </a:rPr>
-              <a:t>No second screener</a:t>
-            </a:r>
-            <a:endParaRPr lang="en-US" sz="1500" dirty="0"/>
-          </a:p>
-        </p:txBody>
-      </p:sp>
-      <p:sp>
-        <p:nvSpPr>
-          <p:cNvPr id="6" name="Text 4"/>
-          <p:cNvSpPr txBox="1"/>
-          <p:nvPr/>
-        </p:nvSpPr>
-        <p:spPr>
-          <a:xfrm>
-            <a:off x="548640" y="3703320"/>
-            <a:ext cx="5394960" cy="2377440"/>
-          </a:xfrm>
-          <a:prstGeom prst="rect">
-            <a:avLst/>
-          </a:prstGeom>
-          <a:noFill/>
-          <a:ln/>
-        </p:spPr>
-        <p:txBody>
-          <a:bodyPr wrap="square" lIns="0" tIns="0" rIns="0" bIns="0" rtlCol="0" anchor="t"/>
-          <a:lstStyle/>
-          <a:p>
-            <a:pPr indent="0" marL="0">
-              <a:spcAft>
-                <a:spcPts val="400"/>
-              </a:spcAft>
-              <a:buNone/>
-            </a:pPr>
-            <a:r>
-              <a:rPr lang="en-US" sz="1500" b="1" dirty="0">
-                <a:solidFill>
-                  <a:schemeClr val="tx2"/>
-                </a:solidFill>
-              </a:rPr>
-              <a:t>84 full texts but 52 studies: why so few?</a:t>
-            </a:r>
-            <a:endParaRPr lang="en-US" sz="1500" dirty="0"/>
-          </a:p>
-          <a:p>
-            <a:pPr marL="342900" indent="-342900">
-              <a:spcAft>
-                <a:spcPts val="400"/>
-              </a:spcAft>
-              <a:buSzPct val="100000"/>
-              <a:buChar char="•"/>
-            </a:pPr>
-            <a:r>
-              <a:rPr lang="en-US" sz="1400" dirty="0">
-                <a:solidFill>
-                  <a:schemeClr val="tx1"/>
-                </a:solidFill>
-              </a:rPr>
-              <a:t>19 give muscle results only as charts, without a baseline value</a:t>
-            </a:r>
-            <a:endParaRPr lang="en-US" sz="1500" dirty="0"/>
-          </a:p>
-          <a:p>
-            <a:pPr marL="342900" indent="-342900">
-              <a:spcAft>
-                <a:spcPts val="400"/>
-              </a:spcAft>
-              <a:buSzPct val="100000"/>
-              <a:buChar char="•"/>
-            </a:pPr>
-            <a:r>
-              <a:rPr lang="en-US" sz="1400" dirty="0">
-                <a:solidFill>
-                  <a:schemeClr val="tx1"/>
-                </a:solidFill>
-              </a:rPr>
-              <a:t>4 full texts not available (one conference abstract still used); 11 excluded at full text</a:t>
-            </a:r>
-            <a:endParaRPr lang="en-US" sz="1500" dirty="0"/>
-          </a:p>
-        </p:txBody>
-      </p:sp>
-      <p:sp>
-        <p:nvSpPr>
-          <p:cNvPr id="7" name="Text 5"/>
-          <p:cNvSpPr txBox="1"/>
-          <p:nvPr/>
-        </p:nvSpPr>
-        <p:spPr>
-          <a:xfrm>
-            <a:off x="6217920" y="3703320"/>
-            <a:ext cx="5394960" cy="2377440"/>
-          </a:xfrm>
-          <a:prstGeom prst="rect">
-            <a:avLst/>
-          </a:prstGeom>
-          <a:noFill/>
-          <a:ln/>
-        </p:spPr>
-        <p:txBody>
-          <a:bodyPr wrap="square" lIns="0" tIns="0" rIns="0" bIns="0" rtlCol="0" anchor="t"/>
-          <a:lstStyle/>
-          <a:p>
-            <a:pPr indent="0" marL="0">
-              <a:spcAft>
-                <a:spcPts val="400"/>
-              </a:spcAft>
-              <a:buNone/>
-            </a:pPr>
-            <a:r>
-              <a:rPr lang="en-US" sz="1500" b="1" dirty="0">
-                <a:solidFill>
-                  <a:schemeClr val="tx2"/>
-                </a:solidFill>
-              </a:rPr>
-              <a:t>Why search only from 2013?</a:t>
-            </a:r>
-            <a:endParaRPr lang="en-US" sz="1500" dirty="0"/>
-          </a:p>
-          <a:p>
-            <a:pPr marL="342900" indent="-342900">
-              <a:spcAft>
-                <a:spcPts val="400"/>
-              </a:spcAft>
-              <a:buSzPct val="100000"/>
-              <a:buChar char="•"/>
-            </a:pPr>
-            <a:r>
-              <a:rPr lang="en-US" sz="1400" dirty="0">
-                <a:solidFill>
-                  <a:schemeClr val="tx1"/>
-                </a:solidFill>
-              </a:rPr>
-              <a:t>The search was time-boxed to one week</a:t>
-            </a:r>
-            <a:endParaRPr lang="en-US" sz="1500" dirty="0"/>
-          </a:p>
-          <a:p>
-            <a:pPr marL="342900" indent="-342900">
-              <a:spcAft>
-                <a:spcPts val="400"/>
-              </a:spcAft>
-              <a:buSzPct val="100000"/>
-              <a:buChar char="•"/>
-            </a:pPr>
-            <a:r>
-              <a:rPr lang="en-US" sz="1400" dirty="0">
-                <a:solidFill>
-                  <a:schemeClr val="tx1"/>
-                </a:solidFill>
-              </a:rPr>
-              <a:t>Older work enters through 9 studies we held before the search; 6 of their campaigns would otherwise be missing</a:t>
-            </a:r>
-            <a:endParaRPr lang="en-US" sz="1500" dirty="0"/>
-          </a:p>
-          <a:p>
-            <a:pPr marL="342900" indent="-342900">
-              <a:spcAft>
-                <a:spcPts val="400"/>
-              </a:spcAft>
-              <a:buSzPct val="100000"/>
-              <a:buChar char="•"/>
-            </a:pPr>
-            <a:r>
-              <a:rPr lang="en-US" sz="1400" dirty="0">
-                <a:solidFill>
-                  <a:schemeClr val="tx1"/>
-                </a:solidFill>
-              </a:rPr>
-              <a:t>Both known modelling papers from after 2013 were found by all three journal databases</a:t>
-            </a:r>
-            <a:endParaRPr lang="en-US" sz="1500" dirty="0"/>
-          </a:p>
-        </p:txBody>
-      </p:sp>
-      <p:sp>
-        <p:nvSpPr>
-          <p:cNvPr id="25" name="Slide Number Placeholder 0"/>
-          <p:cNvSpPr>
-            <a:spLocks noGrp="1"/>
-          </p:cNvSpPr>
-          <p:nvPr>
-            <p:ph type="sldNum" sz="quarter" idx="4294967295"/>
-          </p:nvPr>
-        </p:nvSpPr>
-        <p:spPr>
-          <a:xfrm>
-            <a:off x="11155680" y="6355080"/>
-            <a:ext cx="457200" cy="274320"/>
-          </a:xfrm>
-          <a:prstGeom prst="rect">
-            <a:avLst/>
-          </a:prstGeom>
-          <a:extLst>
-            <a:ext uri="{C572A759-6A51-4108-AA02-DFA0A04FC94B}">
-              <ma14:wrappingTextBoxFlag xmlns:ma14="http://schemas.microsoft.com/office/mac/drawingml/2011/main" val="0"/>
-            </a:ext>
-          </a:extLst>
-        </p:spPr>
-        <p:txBody>
-          <a:bodyPr/>
-          <a:lstStyle>
-            <a:lvl1pPr>
-              <a:defRPr sz="1000">
-                <a:solidFill>
-                  <a:schemeClr val="accent3"/>
-                </a:solidFill>
-              </a:defRPr>
-            </a:lvl1pPr>
-          </a:lstStyle>
-          <a:p>
-            <a:pPr algn="r"/>
-            <a:fld id="{F7021451-1387-4CA6-816F-3879F97B5CBC}" type="slidenum">
-              <a:rPr b="0" lang="en-US"/>
               <a:t>16</a:t>
             </a:fld>
             <a:endParaRPr lang="en-US"/>
@@ -11114,7 +11007,7 @@
                 <a:ea typeface="Cambria" pitchFamily="34" charset="-122"/>
                 <a:cs typeface="Cambria" pitchFamily="34" charset="-120"/>
               </a:rPr>
-              <a:t>Backup: dataset expansion and composition</a:t>
+              <a:t>Backup: screening and study selection</a:t>
             </a:r>
             <a:endParaRPr lang="en-US" sz="2800" dirty="0"/>
           </a:p>
@@ -11189,7 +11082,7 @@
                   <a:schemeClr val="tx2"/>
                 </a:solidFill>
               </a:rPr>
-              <a:t>The abstract had 15 studies. Did adding 37 change the analysis after seeing data?</a:t>
+              <a:t>3,600 screened, 2,493 excluded: where are the other 1,107?</a:t>
             </a:r>
             <a:endParaRPr lang="en-US" sz="1500" dirty="0"/>
           </a:p>
@@ -11207,7 +11100,7 @@
                   <a:schemeClr val="tx1"/>
                 </a:solidFill>
               </a:rPr>
-              <a:t>Eligibility criteria were fixed before screening; the dataset was frozen (14 and 19 September) before the final models</a:t>
+              <a:t>84 went on to full text: 74 from the search and 10 from other sources</a:t>
             </a:r>
             <a:endParaRPr lang="en-US" sz="1500" dirty="0"/>
           </a:p>
@@ -11225,46 +11118,7 @@
                   <a:schemeClr val="tx1"/>
                 </a:solidFill>
               </a:rPr>
-              <a:t>The curve shape was chosen by a rule declared before fitting</a:t>
-            </a:r>
-            <a:endParaRPr lang="en-US" sz="1500" dirty="0"/>
-          </a:p>
-        </p:txBody>
-      </p:sp>
-      <p:sp>
-        <p:nvSpPr>
-          <p:cNvPr id="5" name="Text 3"/>
-          <p:cNvSpPr txBox="1"/>
-          <p:nvPr/>
-        </p:nvSpPr>
-        <p:spPr>
-          <a:xfrm>
-            <a:off x="6217920" y="1188720"/>
-            <a:ext cx="5394960" cy="2377440"/>
-          </a:xfrm>
-          <a:prstGeom prst="rect">
-            <a:avLst/>
-          </a:prstGeom>
-          <a:noFill/>
-          <a:ln/>
-        </p:spPr>
-        <p:txBody>
-          <a:bodyPr wrap="square" lIns="0" tIns="0" rIns="0" bIns="0" rtlCol="0" anchor="t"/>
-          <a:lstStyle/>
-          <a:p>
-            <a:pPr indent="0" marL="0">
-              <a:spcAft>
-                <a:spcPts val="400"/>
-              </a:spcAft>
-              <a:buNone/>
-            </a:pPr>
-            <a:r>
-              <a:rPr lang="en-US" sz="1500" b="1" dirty="0">
-                <a:solidFill>
-                  <a:schemeClr val="tx2"/>
-                </a:solidFill>
-              </a:rPr>
-              <a:t>Slide 5 shows 180 days, but the model stops at day 119. Why?</a:t>
+              <a:t>1,023 were not screened in the time available: the rest of the "maybe" set and 80 records waiting for a full text</a:t>
             </a:r>
             <a:endParaRPr lang="en-US" sz="1500" dirty="0"/>
           </a:p>
@@ -11282,7 +11136,46 @@
                   <a:schemeClr val="tx1"/>
                 </a:solidFill>
               </a:rPr>
-              <a:t>The 14 spaceflight rows were measured after landing, so they leave the model with the 264 recovery rows</a:t>
+              <a:t>They are reported as unscreened, not as excluded</a:t>
+            </a:r>
+            <a:endParaRPr lang="en-US" sz="1500" dirty="0"/>
+          </a:p>
+        </p:txBody>
+      </p:sp>
+      <p:sp>
+        <p:nvSpPr>
+          <p:cNvPr id="5" name="Text 3"/>
+          <p:cNvSpPr txBox="1"/>
+          <p:nvPr/>
+        </p:nvSpPr>
+        <p:spPr>
+          <a:xfrm>
+            <a:off x="6217920" y="1188720"/>
+            <a:ext cx="5394960" cy="2377440"/>
+          </a:xfrm>
+          <a:prstGeom prst="rect">
+            <a:avLst/>
+          </a:prstGeom>
+          <a:noFill/>
+          <a:ln/>
+        </p:spPr>
+        <p:txBody>
+          <a:bodyPr wrap="square" lIns="0" tIns="0" rIns="0" bIns="0" rtlCol="0" anchor="t"/>
+          <a:lstStyle/>
+          <a:p>
+            <a:pPr indent="0" marL="0">
+              <a:spcAft>
+                <a:spcPts val="400"/>
+              </a:spcAft>
+              <a:buNone/>
+            </a:pPr>
+            <a:r>
+              <a:rPr lang="en-US" sz="1500" b="1" dirty="0">
+                <a:solidFill>
+                  <a:schemeClr val="tx2"/>
+                </a:solidFill>
+              </a:rPr>
+              <a:t>Who screened, and was it done twice?</a:t>
             </a:r>
             <a:endParaRPr lang="en-US" sz="1500" dirty="0"/>
           </a:p>
@@ -11300,46 +11193,7 @@
                   <a:schemeClr val="tx1"/>
                 </a:solidFill>
               </a:rPr>
-              <a:t>8 of the 14 are one back muscle (lumbar multifidus)</a:t>
-            </a:r>
-            <a:endParaRPr lang="en-US" sz="1500" dirty="0"/>
-          </a:p>
-        </p:txBody>
-      </p:sp>
-      <p:sp>
-        <p:nvSpPr>
-          <p:cNvPr id="6" name="Text 4"/>
-          <p:cNvSpPr txBox="1"/>
-          <p:nvPr/>
-        </p:nvSpPr>
-        <p:spPr>
-          <a:xfrm>
-            <a:off x="548640" y="3703320"/>
-            <a:ext cx="5394960" cy="2377440"/>
-          </a:xfrm>
-          <a:prstGeom prst="rect">
-            <a:avLst/>
-          </a:prstGeom>
-          <a:noFill/>
-          <a:ln/>
-        </p:spPr>
-        <p:txBody>
-          <a:bodyPr wrap="square" lIns="0" tIns="0" rIns="0" bIns="0" rtlCol="0" anchor="t"/>
-          <a:lstStyle/>
-          <a:p>
-            <a:pPr indent="0" marL="0">
-              <a:spcAft>
-                <a:spcPts val="400"/>
-              </a:spcAft>
-              <a:buNone/>
-            </a:pPr>
-            <a:r>
-              <a:rPr lang="en-US" sz="1500" b="1" dirty="0">
-                <a:solidFill>
-                  <a:schemeClr val="tx2"/>
-                </a:solidFill>
-              </a:rPr>
-              <a:t>Mostly young men: does this apply to women and older crews?</a:t>
+              <a:t>Eligibility criteria were written before screening began</a:t>
             </a:r>
             <a:endParaRPr lang="en-US" sz="1500" dirty="0"/>
           </a:p>
@@ -11357,7 +11211,7 @@
                   <a:schemeClr val="tx1"/>
                 </a:solidFill>
               </a:rPr>
-              <a:t>Rows: men only 567, mixed 113, women only 40 (one campaign, WISE-2005)</a:t>
+              <a:t>A rule-based triage sorted the records; one person then read the priority set and the top of the "maybe" set</a:t>
             </a:r>
             <a:endParaRPr lang="en-US" sz="1500" dirty="0"/>
           </a:p>
@@ -11375,7 +11229,7 @@
                   <a:schemeClr val="tx1"/>
                 </a:solidFill>
               </a:rPr>
-              <a:t>Healthy young 692, older 42: the results describe young men</a:t>
+              <a:t>No second screener</a:t>
             </a:r>
             <a:endParaRPr lang="en-US" sz="1500" dirty="0"/>
           </a:p>
@@ -11383,13 +11237,13 @@
       </p:sp>
       <p:sp>
         <p:nvSpPr>
-          <p:cNvPr id="7" name="Text 5"/>
+          <p:cNvPr id="6" name="Text 4"/>
           <p:cNvSpPr txBox="1"/>
           <p:nvPr/>
         </p:nvSpPr>
         <p:spPr>
           <a:xfrm>
-            <a:off x="6217920" y="3703320"/>
+            <a:off x="548640" y="3703320"/>
             <a:ext cx="5394960" cy="2377440"/>
           </a:xfrm>
           <a:prstGeom prst="rect">
@@ -11414,7 +11268,7 @@
                   <a:schemeClr val="tx2"/>
                 </a:solidFill>
               </a:rPr>
-              <a:t>What exactly is a row's percentage change?</a:t>
+              <a:t>84 full texts but 52 studies: why so few?</a:t>
             </a:r>
             <a:endParaRPr lang="en-US" sz="1500" dirty="0"/>
           </a:p>
@@ -11432,7 +11286,7 @@
                   <a:schemeClr val="tx1"/>
                 </a:solidFill>
               </a:rPr>
-              <a:t>Follow-up vs the same group's own baseline; negative means loss</a:t>
+              <a:t>19 give muscle results only as charts, without a baseline value</a:t>
             </a:r>
             <a:endParaRPr lang="en-US" sz="1500" dirty="0"/>
           </a:p>
@@ -11450,7 +11304,46 @@
                   <a:schemeClr val="tx1"/>
                 </a:solidFill>
               </a:rPr>
-              <a:t>Recomputed from the printed values; where a paper prints the mean of individual changes, that value is kept and labelled</a:t>
+              <a:t>4 full texts not available (one conference abstract still used); 11 excluded at full text</a:t>
+            </a:r>
+            <a:endParaRPr lang="en-US" sz="1500" dirty="0"/>
+          </a:p>
+        </p:txBody>
+      </p:sp>
+      <p:sp>
+        <p:nvSpPr>
+          <p:cNvPr id="7" name="Text 5"/>
+          <p:cNvSpPr txBox="1"/>
+          <p:nvPr/>
+        </p:nvSpPr>
+        <p:spPr>
+          <a:xfrm>
+            <a:off x="6217920" y="3703320"/>
+            <a:ext cx="5394960" cy="2377440"/>
+          </a:xfrm>
+          <a:prstGeom prst="rect">
+            <a:avLst/>
+          </a:prstGeom>
+          <a:noFill/>
+          <a:ln/>
+        </p:spPr>
+        <p:txBody>
+          <a:bodyPr wrap="square" lIns="0" tIns="0" rIns="0" bIns="0" rtlCol="0" anchor="t"/>
+          <a:lstStyle/>
+          <a:p>
+            <a:pPr indent="0" marL="0">
+              <a:spcAft>
+                <a:spcPts val="400"/>
+              </a:spcAft>
+              <a:buNone/>
+            </a:pPr>
+            <a:r>
+              <a:rPr lang="en-US" sz="1500" b="1" dirty="0">
+                <a:solidFill>
+                  <a:schemeClr val="tx2"/>
+                </a:solidFill>
+              </a:rPr>
+              <a:t>Why search only from 2013?</a:t>
             </a:r>
             <a:endParaRPr lang="en-US" sz="1500" dirty="0"/>
           </a:p>
@@ -11468,7 +11361,43 @@
                   <a:schemeClr val="tx1"/>
                 </a:solidFill>
               </a:rPr>
-              <a:t>Rows weighted by number of participants: only 8 of 32 campaigns report the spread of the change</a:t>
+              <a:t>The search was time-boxed to one week</a:t>
+            </a:r>
+            <a:endParaRPr lang="en-US" sz="1500" dirty="0"/>
+          </a:p>
+          <a:p>
+            <a:pPr marL="342900" indent="-342900">
+              <a:spcAft>
+                <a:spcPts val="400"/>
+              </a:spcAft>
+              <a:buSzPct val="100000"/>
+              <a:buChar char="•"/>
+            </a:pPr>
+            <a:r>
+              <a:rPr lang="en-US" sz="1400" dirty="0">
+                <a:solidFill>
+                  <a:schemeClr val="tx1"/>
+                </a:solidFill>
+              </a:rPr>
+              <a:t>Older work enters through 9 studies we held before the search; 6 of their campaigns would otherwise be missing</a:t>
+            </a:r>
+            <a:endParaRPr lang="en-US" sz="1500" dirty="0"/>
+          </a:p>
+          <a:p>
+            <a:pPr marL="342900" indent="-342900">
+              <a:spcAft>
+                <a:spcPts val="400"/>
+              </a:spcAft>
+              <a:buSzPct val="100000"/>
+              <a:buChar char="•"/>
+            </a:pPr>
+            <a:r>
+              <a:rPr lang="en-US" sz="1400" dirty="0">
+                <a:solidFill>
+                  <a:schemeClr val="tx1"/>
+                </a:solidFill>
+              </a:rPr>
+              <a:t>Both known modelling papers from after 2013 were found by all three journal databases</a:t>
             </a:r>
             <a:endParaRPr lang="en-US" sz="1500" dirty="0"/>
           </a:p>
@@ -11579,7 +11508,7 @@
                 <a:ea typeface="Cambria" pitchFamily="34" charset="-122"/>
                 <a:cs typeface="Cambria" pitchFamily="34" charset="-120"/>
               </a:rPr>
-              <a:t>Backup: certainty of the muscle-group curves</a:t>
+              <a:t>Backup: dataset expansion and composition</a:t>
             </a:r>
             <a:endParaRPr lang="en-US" sz="2800" dirty="0"/>
           </a:p>
@@ -11654,7 +11583,7 @@
                   <a:schemeClr val="tx2"/>
                 </a:solidFill>
               </a:rPr>
-              <a:t>Is each line fitted to its own muscle?</a:t>
+              <a:t>The abstract had 15 studies. Did adding 37 change the analysis after seeing data?</a:t>
             </a:r>
             <a:endParaRPr lang="en-US" sz="1500" dirty="0"/>
           </a:p>
@@ -11672,7 +11601,7 @@
                   <a:schemeClr val="tx1"/>
                 </a:solidFill>
               </a:rPr>
-              <a:t>No. The day-60 values are fitted per muscle group (named muscles, 25 campaigns); the lines share one time course (τ = 60 days)</a:t>
+              <a:t>Eligibility criteria were fixed before screening; the dataset was frozen (14 and 19 September) before the final models</a:t>
             </a:r>
             <a:endParaRPr lang="en-US" sz="1500" dirty="0"/>
           </a:p>
@@ -11690,7 +11619,7 @@
                   <a:schemeClr val="tx1"/>
                 </a:solidFill>
               </a:rPr>
-              <a:t>Separate shapes cannot be estimated: six of nine groups rest on four campaigns or fewer</a:t>
+              <a:t>The curve shape was chosen by a rule declared before fitting</a:t>
             </a:r>
             <a:endParaRPr lang="en-US" sz="1500" dirty="0"/>
           </a:p>
@@ -11729,7 +11658,7 @@
                   <a:schemeClr val="tx2"/>
                 </a:solidFill>
               </a:rPr>
-              <a:t>Why a saturating curve?</a:t>
+              <a:t>Slide 5 shows 180 days, but the model stops at day 119. Why?</a:t>
             </a:r>
             <a:endParaRPr lang="en-US" sz="1500" dirty="0"/>
           </a:p>
@@ -11747,7 +11676,7 @@
                   <a:schemeClr val="tx1"/>
                 </a:solidFill>
               </a:rPr>
-              <a:t>Logarithmic, saturating and spline curves fit equally well (within 1.3 AIC points): the loss slows, but the data cannot say along which curve</a:t>
+              <a:t>The 14 spaceflight rows were measured after landing, so they leave the model with the 264 recovery rows</a:t>
             </a:r>
             <a:endParaRPr lang="en-US" sz="1500" dirty="0"/>
           </a:p>
@@ -11765,7 +11694,7 @@
                   <a:schemeClr val="tx1"/>
                 </a:solidFill>
               </a:rPr>
-              <a:t>By day 119 the curve reaches 86% of its plateau, −17.3% (95% CI −20.9 to −13.7)</a:t>
+              <a:t>8 of the 14 are one back muscle (lumbar multifidus)</a:t>
             </a:r>
             <a:endParaRPr lang="en-US" sz="1500" dirty="0"/>
           </a:p>
@@ -11804,7 +11733,7 @@
                   <a:schemeClr val="tx2"/>
                 </a:solidFill>
               </a:rPr>
-              <a:t>How certain are the day-60 values?</a:t>
+              <a:t>Mostly young men: does this apply to women and older crews?</a:t>
             </a:r>
             <a:endParaRPr lang="en-US" sz="1500" dirty="0"/>
           </a:p>
@@ -11822,7 +11751,7 @@
                   <a:schemeClr val="tx1"/>
                 </a:solidFill>
               </a:rPr>
-              <a:t>Calf −15.8% (95% CI −18.9 to −12.7); front thigh −10.1% (−13.6 to −6.6); hip rotators −1.9% (−3.9 to 0.2)</a:t>
+              <a:t>Rows: men only 567, mixed 113, women only 40 (one campaign, WISE-2005)</a:t>
             </a:r>
             <a:endParaRPr lang="en-US" sz="1500" dirty="0"/>
           </a:p>
@@ -11840,7 +11769,46 @@
                   <a:schemeClr val="tx1"/>
                 </a:solidFill>
               </a:rPr>
-              <a:t>Calf vs shin, the ankle's opposing pair: 5.6 pp more loss (2.1 to 9.1), p = 0.003</a:t>
+              <a:t>Healthy young 692, older 42: the results describe young men</a:t>
+            </a:r>
+            <a:endParaRPr lang="en-US" sz="1500" dirty="0"/>
+          </a:p>
+        </p:txBody>
+      </p:sp>
+      <p:sp>
+        <p:nvSpPr>
+          <p:cNvPr id="7" name="Text 5"/>
+          <p:cNvSpPr txBox="1"/>
+          <p:nvPr/>
+        </p:nvSpPr>
+        <p:spPr>
+          <a:xfrm>
+            <a:off x="6217920" y="3703320"/>
+            <a:ext cx="5394960" cy="2377440"/>
+          </a:xfrm>
+          <a:prstGeom prst="rect">
+            <a:avLst/>
+          </a:prstGeom>
+          <a:noFill/>
+          <a:ln/>
+        </p:spPr>
+        <p:txBody>
+          <a:bodyPr wrap="square" lIns="0" tIns="0" rIns="0" bIns="0" rtlCol="0" anchor="t"/>
+          <a:lstStyle/>
+          <a:p>
+            <a:pPr indent="0" marL="0">
+              <a:spcAft>
+                <a:spcPts val="400"/>
+              </a:spcAft>
+              <a:buNone/>
+            </a:pPr>
+            <a:r>
+              <a:rPr lang="en-US" sz="1500" b="1" dirty="0">
+                <a:solidFill>
+                  <a:schemeClr val="tx2"/>
+                </a:solidFill>
+              </a:rPr>
+              <a:t>What exactly is a row's percentage change?</a:t>
             </a:r>
             <a:endParaRPr lang="en-US" sz="1500" dirty="0"/>
           </a:p>
@@ -11858,46 +11826,7 @@
                   <a:schemeClr val="tx1"/>
                 </a:solidFill>
               </a:rPr>
-              <a:t>Hip rotators and outer hip: one campaign each</a:t>
-            </a:r>
-            <a:endParaRPr lang="en-US" sz="1500" dirty="0"/>
-          </a:p>
-        </p:txBody>
-      </p:sp>
-      <p:sp>
-        <p:nvSpPr>
-          <p:cNvPr id="7" name="Text 5"/>
-          <p:cNvSpPr txBox="1"/>
-          <p:nvPr/>
-        </p:nvSpPr>
-        <p:spPr>
-          <a:xfrm>
-            <a:off x="6217920" y="3703320"/>
-            <a:ext cx="5394960" cy="2377440"/>
-          </a:xfrm>
-          <a:prstGeom prst="rect">
-            <a:avLst/>
-          </a:prstGeom>
-          <a:noFill/>
-          <a:ln/>
-        </p:spPr>
-        <p:txBody>
-          <a:bodyPr wrap="square" lIns="0" tIns="0" rIns="0" bIns="0" rtlCol="0" anchor="t"/>
-          <a:lstStyle/>
-          <a:p>
-            <a:pPr indent="0" marL="0">
-              <a:spcAft>
-                <a:spcPts val="400"/>
-              </a:spcAft>
-              <a:buNone/>
-            </a:pPr>
-            <a:r>
-              <a:rPr lang="en-US" sz="1500" b="1" dirty="0">
-                <a:solidFill>
-                  <a:schemeClr val="tx2"/>
-                </a:solidFill>
-              </a:rPr>
-              <a:t>Is the calf result an artefact of how often it is scanned?</a:t>
+              <a:t>Follow-up vs the same group's own baseline; negative means loss</a:t>
             </a:r>
             <a:endParaRPr lang="en-US" sz="1500" dirty="0"/>
           </a:p>
@@ -11915,7 +11844,7 @@
                   <a:schemeClr val="tx1"/>
                 </a:solidFill>
               </a:rPr>
-              <a:t>The order holds after adjusting for duration, countermeasure group and imaging method</a:t>
+              <a:t>Recomputed from the printed values; where a paper prints the mean of individual changes, that value is kept and labelled</a:t>
             </a:r>
             <a:endParaRPr lang="en-US" sz="1500" dirty="0"/>
           </a:p>
@@ -11933,7 +11862,7 @@
                   <a:schemeClr val="tx1"/>
                 </a:solidFill>
               </a:rPr>
-              <a:t>Calf: 78 rows from 13 campaigns, the second best-covered group after the front thigh (86 rows, 22 campaigns)</a:t>
+              <a:t>Rows weighted by number of participants: only 8 of 32 campaigns report the spread of the change</a:t>
             </a:r>
             <a:endParaRPr lang="en-US" sz="1500" dirty="0"/>
           </a:p>
@@ -12044,7 +11973,7 @@
                 <a:ea typeface="Cambria" pitchFamily="34" charset="-122"/>
                 <a:cs typeface="Cambria" pitchFamily="34" charset="-120"/>
               </a:rPr>
-              <a:t>Backup: significance and relevance of the LLM gain</a:t>
+              <a:t>Backup: certainty of the muscle-group curves</a:t>
             </a:r>
             <a:endParaRPr lang="en-US" sz="2800" dirty="0"/>
           </a:p>
@@ -12119,7 +12048,7 @@
                   <a:schemeClr val="tx2"/>
                 </a:solidFill>
               </a:rPr>
-              <a:t>Is 0.42 pp worth anything?</a:t>
+              <a:t>Is each line fitted to its own muscle?</a:t>
             </a:r>
             <a:endParaRPr lang="en-US" sz="1500" dirty="0"/>
           </a:p>
@@ -12137,7 +12066,7 @@
                   <a:schemeClr val="tx1"/>
                 </a:solidFill>
               </a:rPr>
-              <a:t>It is 13% lower error than the curve (3.13 to 2.71 pp)</a:t>
+              <a:t>No. The day-60 values are fitted per muscle group (named muscles, 25 campaigns); the lines share one time course (τ = 60 days)</a:t>
             </a:r>
             <a:endParaRPr lang="en-US" sz="1500" dirty="0"/>
           </a:p>
@@ -12155,7 +12084,7 @@
                   <a:schemeClr val="tx1"/>
                 </a:solidFill>
               </a:rPr>
-              <a:t>Small; we present it as a secondary finding</a:t>
+              <a:t>Separate shapes cannot be estimated: six of nine groups rest on four campaigns or fewer</a:t>
             </a:r>
             <a:endParaRPr lang="en-US" sz="1500" dirty="0"/>
           </a:p>
@@ -12194,7 +12123,7 @@
                   <a:schemeClr val="tx2"/>
                 </a:solidFill>
               </a:rPr>
-              <a:t>20 of 32 campaigns is close to a coin flip</a:t>
+              <a:t>Why a saturating curve?</a:t>
             </a:r>
             <a:endParaRPr lang="en-US" sz="1500" dirty="0"/>
           </a:p>
@@ -12212,7 +12141,7 @@
                   <a:schemeClr val="tx1"/>
                 </a:solidFill>
               </a:rPr>
-              <a:t>Counting wins only: p = 0.22 (sign test)*</a:t>
+              <a:t>Logarithmic, saturating and spline curves fit equally well (within 1.3 AIC points): the loss slows, but the data cannot say along which curve</a:t>
             </a:r>
             <a:endParaRPr lang="en-US" sz="1500" dirty="0"/>
           </a:p>
@@ -12230,7 +12159,7 @@
                   <a:schemeClr val="tx1"/>
                 </a:solidFill>
               </a:rPr>
-              <a:t>Using the size of each win: mean gain 0.42 pp, 95% CI 0.13 to 0.73</a:t>
+              <a:t>By day 119 the curve reaches 86% of its plateau, −17.3% (95% CI −20.9 to −13.7)</a:t>
             </a:r>
             <a:endParaRPr lang="en-US" sz="1500" dirty="0"/>
           </a:p>
@@ -12269,7 +12198,7 @@
                   <a:schemeClr val="tx2"/>
                 </a:solidFill>
               </a:rPr>
-              <a:t>Does it rest on a few campaigns?</a:t>
+              <a:t>How certain are the day-60 values?</a:t>
             </a:r>
             <a:endParaRPr lang="en-US" sz="1500" dirty="0"/>
           </a:p>
@@ -12287,7 +12216,7 @@
                   <a:schemeClr val="tx1"/>
                 </a:solidFill>
               </a:rPr>
-              <a:t>3 long MRI campaigns (NASA SPRINT, Berlin BBR2-2, MEDES LTBR) give 56% of the gain; without them 0.20 pp, CI −0.01 to 0.43*</a:t>
+              <a:t>Calf −15.8% (95% CI −18.9 to −12.7); front thigh −10.1% (−13.6 to −6.6); hip rotators −1.9% (−3.9 to 0.2)</a:t>
             </a:r>
             <a:endParaRPr lang="en-US" sz="1500" dirty="0"/>
           </a:p>
@@ -12305,46 +12234,7 @@
                   <a:schemeClr val="tx1"/>
                 </a:solidFill>
               </a:rPr>
-              <a:t>Only SPRINT is recognised, and with campaign details removed the LLM still wins there (3.79 vs 5.92 pp)</a:t>
-            </a:r>
-            <a:endParaRPr lang="en-US" sz="1500" dirty="0"/>
-          </a:p>
-        </p:txBody>
-      </p:sp>
-      <p:sp>
-        <p:nvSpPr>
-          <p:cNvPr id="7" name="Text 5"/>
-          <p:cNvSpPr txBox="1"/>
-          <p:nvPr/>
-        </p:nvSpPr>
-        <p:spPr>
-          <a:xfrm>
-            <a:off x="6217920" y="3703320"/>
-            <a:ext cx="5394960" cy="2377440"/>
-          </a:xfrm>
-          <a:prstGeom prst="rect">
-            <a:avLst/>
-          </a:prstGeom>
-          <a:noFill/>
-          <a:ln/>
-        </p:spPr>
-        <p:txBody>
-          <a:bodyPr wrap="square" lIns="0" tIns="0" rIns="0" bIns="0" rtlCol="0" anchor="t"/>
-          <a:lstStyle/>
-          <a:p>
-            <a:pPr indent="0" marL="0">
-              <a:spcAft>
-                <a:spcPts val="400"/>
-              </a:spcAft>
-              <a:buNone/>
-            </a:pPr>
-            <a:r>
-              <a:rPr lang="en-US" sz="1500" b="1" dirty="0">
-                <a:solidFill>
-                  <a:schemeClr val="tx2"/>
-                </a:solidFill>
-              </a:rPr>
-              <a:t>Did it read these papers in training? Was it added after the fact?</a:t>
+              <a:t>Calf vs shin, the ankle's opposing pair: 5.6 pp more loss (2.1 to 9.1), p = 0.003</a:t>
             </a:r>
             <a:endParaRPr lang="en-US" sz="1500" dirty="0"/>
           </a:p>
@@ -12362,7 +12252,46 @@
                   <a:schemeClr val="tx1"/>
                 </a:solidFill>
               </a:rPr>
-              <a:t>Training exposure cannot be ruled out by any test; hiding campaign details and the naming test are the strongest checks available</a:t>
+              <a:t>Hip rotators and outer hip: one campaign each</a:t>
+            </a:r>
+            <a:endParaRPr lang="en-US" sz="1500" dirty="0"/>
+          </a:p>
+        </p:txBody>
+      </p:sp>
+      <p:sp>
+        <p:nvSpPr>
+          <p:cNvPr id="7" name="Text 5"/>
+          <p:cNvSpPr txBox="1"/>
+          <p:nvPr/>
+        </p:nvSpPr>
+        <p:spPr>
+          <a:xfrm>
+            <a:off x="6217920" y="3703320"/>
+            <a:ext cx="5394960" cy="2377440"/>
+          </a:xfrm>
+          <a:prstGeom prst="rect">
+            <a:avLst/>
+          </a:prstGeom>
+          <a:noFill/>
+          <a:ln/>
+        </p:spPr>
+        <p:txBody>
+          <a:bodyPr wrap="square" lIns="0" tIns="0" rIns="0" bIns="0" rtlCol="0" anchor="t"/>
+          <a:lstStyle/>
+          <a:p>
+            <a:pPr indent="0" marL="0">
+              <a:spcAft>
+                <a:spcPts val="400"/>
+              </a:spcAft>
+              <a:buNone/>
+            </a:pPr>
+            <a:r>
+              <a:rPr lang="en-US" sz="1500" b="1" dirty="0">
+                <a:solidFill>
+                  <a:schemeClr val="tx2"/>
+                </a:solidFill>
+              </a:rPr>
+              <a:t>Is the calf result an artefact of how often it is scanned?</a:t>
             </a:r>
             <a:endParaRPr lang="en-US" sz="1500" dirty="0"/>
           </a:p>
@@ -12380,45 +12309,27 @@
                   <a:schemeClr val="tx1"/>
                 </a:solidFill>
               </a:rPr>
-              <a:t>Added after the ML result, but every check and target was committed before the first answer</a:t>
+              <a:t>The order holds after adjusting for duration, countermeasure group and imaging method</a:t>
             </a:r>
             <a:endParaRPr lang="en-US" sz="1500" dirty="0"/>
           </a:p>
-        </p:txBody>
-      </p:sp>
-      <p:sp>
-        <p:nvSpPr>
-          <p:cNvPr id="8" name="Text 6"/>
-          <p:cNvSpPr txBox="1"/>
-          <p:nvPr/>
-        </p:nvSpPr>
-        <p:spPr>
-          <a:xfrm>
-            <a:off x="548640" y="6035040"/>
-            <a:ext cx="9144000" cy="274320"/>
-          </a:xfrm>
-          <a:prstGeom prst="rect">
-            <a:avLst/>
-          </a:prstGeom>
-          <a:noFill/>
-          <a:ln/>
-        </p:spPr>
-        <p:txBody>
-          <a:bodyPr wrap="square" lIns="0" tIns="0" rIns="0" bIns="0" rtlCol="0" anchor="t"/>
-          <a:lstStyle/>
-          <a:p>
-            <a:pPr indent="0" marL="0">
-              <a:buNone/>
-            </a:pPr>
-            <a:r>
-              <a:rPr lang="en-US" sz="1100" i="1" dirty="0">
-                <a:solidFill>
-                  <a:schemeClr val="accent3"/>
-                </a:solidFill>
-              </a:rPr>
-              <a:t>* Our calculation from the saved LLM predictions; not in the report.</a:t>
-            </a:r>
-            <a:endParaRPr lang="en-US" sz="1100" dirty="0"/>
+          <a:p>
+            <a:pPr marL="342900" indent="-342900">
+              <a:spcAft>
+                <a:spcPts val="400"/>
+              </a:spcAft>
+              <a:buSzPct val="100000"/>
+              <a:buChar char="•"/>
+            </a:pPr>
+            <a:r>
+              <a:rPr lang="en-US" sz="1400" dirty="0">
+                <a:solidFill>
+                  <a:schemeClr val="tx1"/>
+                </a:solidFill>
+              </a:rPr>
+              <a:t>Calf: 78 rows from 13 campaigns, the second best-covered group after the front thigh (86 rows, 22 campaigns)</a:t>
+            </a:r>
+            <a:endParaRPr lang="en-US" sz="1500" dirty="0"/>
           </a:p>
         </p:txBody>
       </p:sp>
@@ -13619,7 +13530,7 @@
                 <a:ea typeface="Cambria" pitchFamily="34" charset="-122"/>
                 <a:cs typeface="Cambria" pitchFamily="34" charset="-120"/>
               </a:rPr>
-              <a:t>Backup: ML results and fairness of the comparison</a:t>
+              <a:t>Backup: significance and relevance of the LLM gain</a:t>
             </a:r>
             <a:endParaRPr lang="en-US" sz="2800" dirty="0"/>
           </a:p>
@@ -13694,7 +13605,7 @@
                   <a:schemeClr val="tx2"/>
                 </a:solidFill>
               </a:rPr>
-              <a:t>Did the ML models get a fair chance?</a:t>
+              <a:t>Is 0.42 pp worth anything?</a:t>
             </a:r>
             <a:endParaRPr lang="en-US" sz="1500" dirty="0"/>
           </a:p>
@@ -13712,7 +13623,7 @@
                   <a:schemeClr val="tx1"/>
                 </a:solidFill>
               </a:rPr>
-              <a:t>Tuned inside each training fold, grouped by campaign; TabPFN needs no tuning</a:t>
+              <a:t>It is 13% lower error than the curve (3.13 to 2.71 pp)</a:t>
             </a:r>
             <a:endParaRPr lang="en-US" sz="1500" dirty="0"/>
           </a:p>
@@ -13730,7 +13641,7 @@
                   <a:schemeClr val="tx1"/>
                 </a:solidFill>
               </a:rPr>
-              <a:t>All models saw the same inputs, folds and scoring</a:t>
+              <a:t>Small; we present it as a secondary finding</a:t>
             </a:r>
             <a:endParaRPr lang="en-US" sz="1500" dirty="0"/>
           </a:p>
@@ -13769,7 +13680,7 @@
                   <a:schemeClr val="tx2"/>
                 </a:solidFill>
               </a:rPr>
-              <a:t>Why not add age, sex or countermeasure type?</a:t>
+              <a:t>20 of 32 campaigns is close to a coin flip</a:t>
             </a:r>
             <a:endParaRPr lang="en-US" sz="1500" dirty="0"/>
           </a:p>
@@ -13787,7 +13698,7 @@
                   <a:schemeClr val="tx1"/>
                 </a:solidFill>
               </a:rPr>
-              <a:t>32 campaigns leave room for about 3 campaign-level inputs (about 10 campaigns per input)</a:t>
+              <a:t>Counting wins only: p = 0.22 (sign test)*</a:t>
             </a:r>
             <a:endParaRPr lang="en-US" sz="1500" dirty="0"/>
           </a:p>
@@ -13805,7 +13716,7 @@
                   <a:schemeClr val="tx1"/>
                 </a:solidFill>
               </a:rPr>
-              <a:t>Age and sex are fixed within a campaign (347 of 425 rows men-only), so they act as a campaign label; 126 countermeasure rows spread over 9 types</a:t>
+              <a:t>Using the size of each win: mean gain 0.42 pp, 95% CI 0.13 to 0.73</a:t>
             </a:r>
             <a:endParaRPr lang="en-US" sz="1500" dirty="0"/>
           </a:p>
@@ -13844,7 +13755,7 @@
                   <a:schemeClr val="tx2"/>
                 </a:solidFill>
               </a:rPr>
-              <a:t>Is the duration curve a straw man?</a:t>
+              <a:t>Does it rest on a few campaigns?</a:t>
             </a:r>
             <a:endParaRPr lang="en-US" sz="1500" dirty="0"/>
           </a:p>
@@ -13862,7 +13773,7 @@
                   <a:schemeClr val="tx1"/>
                 </a:solidFill>
               </a:rPr>
-              <a:t>Ridge regression uses days, muscle and every other input: 3.28 vs 3.16 pp</a:t>
+              <a:t>3 long MRI campaigns (NASA SPRINT, Berlin BBR2-2, MEDES LTBR) give 56% of the gain; without them 0.20 pp, CI −0.01 to 0.43*</a:t>
             </a:r>
             <a:endParaRPr lang="en-US" sz="1500" dirty="0"/>
           </a:p>
@@ -13880,7 +13791,7 @@
                   <a:schemeClr val="tx1"/>
                 </a:solidFill>
               </a:rPr>
-              <a:t>Knowing the muscle raises R² but not the error on a new campaign</a:t>
+              <a:t>Only SPRINT is recognised, and with campaign details removed the LLM still wins there (3.79 vs 5.92 pp)</a:t>
             </a:r>
             <a:endParaRPr lang="en-US" sz="1500" dirty="0"/>
           </a:p>
@@ -13919,7 +13830,7 @@
                   <a:schemeClr val="tx2"/>
                 </a:solidFill>
               </a:rPr>
-              <a:t>Would a nearest-neighbour method match the LLM?</a:t>
+              <a:t>Did it read these papers in training? Was it added after the fact?</a:t>
             </a:r>
             <a:endParaRPr lang="en-US" sz="1500" dirty="0"/>
           </a:p>
@@ -13937,9 +13848,63 @@
                   <a:schemeClr val="tx1"/>
                 </a:solidFill>
               </a:rPr>
-              <a:t>Not tested. If the gain comes from picking similar rows, this is the next control to run</a:t>
+              <a:t>Training exposure cannot be ruled out by any test; hiding campaign details and the naming test are the strongest checks available</a:t>
             </a:r>
             <a:endParaRPr lang="en-US" sz="1500" dirty="0"/>
+          </a:p>
+          <a:p>
+            <a:pPr marL="342900" indent="-342900">
+              <a:spcAft>
+                <a:spcPts val="400"/>
+              </a:spcAft>
+              <a:buSzPct val="100000"/>
+              <a:buChar char="•"/>
+            </a:pPr>
+            <a:r>
+              <a:rPr lang="en-US" sz="1400" dirty="0">
+                <a:solidFill>
+                  <a:schemeClr val="tx1"/>
+                </a:solidFill>
+              </a:rPr>
+              <a:t>Added after the ML result, but every check and target was committed before the first answer</a:t>
+            </a:r>
+            <a:endParaRPr lang="en-US" sz="1500" dirty="0"/>
+          </a:p>
+        </p:txBody>
+      </p:sp>
+      <p:sp>
+        <p:nvSpPr>
+          <p:cNvPr id="8" name="Text 6"/>
+          <p:cNvSpPr txBox="1"/>
+          <p:nvPr/>
+        </p:nvSpPr>
+        <p:spPr>
+          <a:xfrm>
+            <a:off x="548640" y="6035040"/>
+            <a:ext cx="9144000" cy="274320"/>
+          </a:xfrm>
+          <a:prstGeom prst="rect">
+            <a:avLst/>
+          </a:prstGeom>
+          <a:noFill/>
+          <a:ln/>
+        </p:spPr>
+        <p:txBody>
+          <a:bodyPr wrap="square" lIns="0" tIns="0" rIns="0" bIns="0" rtlCol="0" anchor="t"/>
+          <a:lstStyle/>
+          <a:p>
+            <a:pPr indent="0" marL="0">
+              <a:buNone/>
+            </a:pPr>
+            <a:r>
+              <a:rPr lang="en-US" sz="1100" i="1" dirty="0">
+                <a:solidFill>
+                  <a:schemeClr val="accent3"/>
+                </a:solidFill>
+              </a:rPr>
+              <a:t>* Our calculation from the saved LLM predictions; not in the report.</a:t>
+            </a:r>
+            <a:endParaRPr lang="en-US" sz="1100" dirty="0"/>
           </a:p>
         </p:txBody>
       </p:sp>
@@ -14048,7 +14013,7 @@
                 <a:ea typeface="Cambria" pitchFamily="34" charset="-122"/>
                 <a:cs typeface="Cambria" pitchFamily="34" charset="-120"/>
               </a:rPr>
-              <a:t>Backup: applicability to Mars mission planning</a:t>
+              <a:t>Backup: ML results and fairness of the comparison</a:t>
             </a:r>
             <a:endParaRPr lang="en-US" sz="2800" dirty="0"/>
           </a:p>
@@ -14123,7 +14088,7 @@
                   <a:schemeClr val="tx2"/>
                 </a:solidFill>
               </a:rPr>
-              <a:t>A Mars transit is about 180 days; the data stop at 119</a:t>
+              <a:t>Did the ML models get a fair chance?</a:t>
             </a:r>
             <a:endParaRPr lang="en-US" sz="1500" dirty="0"/>
           </a:p>
@@ -14141,7 +14106,7 @@
                   <a:schemeClr val="tx1"/>
                 </a:solidFill>
               </a:rPr>
-              <a:t>Only one campaign reaches 119 days</a:t>
+              <a:t>Tuned inside each training fold, grouped by campaign; TabPFN needs no tuning</a:t>
             </a:r>
             <a:endParaRPr lang="en-US" sz="1500" dirty="0"/>
           </a:p>
@@ -14159,7 +14124,7 @@
                   <a:schemeClr val="tx1"/>
                 </a:solidFill>
               </a:rPr>
-              <a:t>A 180-day estimate is planned from the duration curve only, with an uncertainty range, labelled as an assumption</a:t>
+              <a:t>All models saw the same inputs, folds and scoring</a:t>
             </a:r>
             <a:endParaRPr lang="en-US" sz="1500" dirty="0"/>
           </a:p>
@@ -14198,7 +14163,7 @@
                   <a:schemeClr val="tx2"/>
                 </a:solidFill>
               </a:rPr>
-              <a:t>Bed rest is not spaceflight</a:t>
+              <a:t>Why not add age, sex or countermeasure type?</a:t>
             </a:r>
             <a:endParaRPr lang="en-US" sz="1500" dirty="0"/>
           </a:p>
@@ -14216,46 +14181,7 @@
                   <a:schemeClr val="tx1"/>
                 </a:solidFill>
               </a:rPr>
-              <a:t>Only 14 spaceflight rows, 8 of them one back muscle: too few to test transfer</a:t>
-            </a:r>
-            <a:endParaRPr lang="en-US" sz="1500" dirty="0"/>
-          </a:p>
-        </p:txBody>
-      </p:sp>
-      <p:sp>
-        <p:nvSpPr>
-          <p:cNvPr id="6" name="Text 4"/>
-          <p:cNvSpPr txBox="1"/>
-          <p:nvPr/>
-        </p:nvSpPr>
-        <p:spPr>
-          <a:xfrm>
-            <a:off x="548640" y="3703320"/>
-            <a:ext cx="5394960" cy="2377440"/>
-          </a:xfrm>
-          <a:prstGeom prst="rect">
-            <a:avLst/>
-          </a:prstGeom>
-          <a:noFill/>
-          <a:ln/>
-        </p:spPr>
-        <p:txBody>
-          <a:bodyPr wrap="square" lIns="0" tIns="0" rIns="0" bIns="0" rtlCol="0" anchor="t"/>
-          <a:lstStyle/>
-          <a:p>
-            <a:pPr indent="0" marL="0">
-              <a:spcAft>
-                <a:spcPts val="400"/>
-              </a:spcAft>
-              <a:buNone/>
-            </a:pPr>
-            <a:r>
-              <a:rPr lang="en-US" sz="1500" b="1" dirty="0">
-                <a:solidFill>
-                  <a:schemeClr val="tx2"/>
-                </a:solidFill>
-              </a:rPr>
-              <a:t>Which countermeasure works? What about individuals?</a:t>
+              <a:t>32 campaigns leave room for about 3 campaign-level inputs (about 10 campaigns per input)</a:t>
             </a:r>
             <a:endParaRPr lang="en-US" sz="1500" dirty="0"/>
           </a:p>
@@ -14273,7 +14199,46 @@
                   <a:schemeClr val="tx1"/>
                 </a:solidFill>
               </a:rPr>
-              <a:t>Countermeasure groups lose 3.7 pp less (95% CI 1.5 to 5.9), all types pooled</a:t>
+              <a:t>Age and sex are fixed within a campaign (347 of 425 rows men-only), so they act as a campaign label; 126 countermeasure rows spread over 9 types</a:t>
+            </a:r>
+            <a:endParaRPr lang="en-US" sz="1500" dirty="0"/>
+          </a:p>
+        </p:txBody>
+      </p:sp>
+      <p:sp>
+        <p:nvSpPr>
+          <p:cNvPr id="6" name="Text 4"/>
+          <p:cNvSpPr txBox="1"/>
+          <p:nvPr/>
+        </p:nvSpPr>
+        <p:spPr>
+          <a:xfrm>
+            <a:off x="548640" y="3703320"/>
+            <a:ext cx="5394960" cy="2377440"/>
+          </a:xfrm>
+          <a:prstGeom prst="rect">
+            <a:avLst/>
+          </a:prstGeom>
+          <a:noFill/>
+          <a:ln/>
+        </p:spPr>
+        <p:txBody>
+          <a:bodyPr wrap="square" lIns="0" tIns="0" rIns="0" bIns="0" rtlCol="0" anchor="t"/>
+          <a:lstStyle/>
+          <a:p>
+            <a:pPr indent="0" marL="0">
+              <a:spcAft>
+                <a:spcPts val="400"/>
+              </a:spcAft>
+              <a:buNone/>
+            </a:pPr>
+            <a:r>
+              <a:rPr lang="en-US" sz="1500" b="1" dirty="0">
+                <a:solidFill>
+                  <a:schemeClr val="tx2"/>
+                </a:solidFill>
+              </a:rPr>
+              <a:t>Is the duration curve a straw man?</a:t>
             </a:r>
             <a:endParaRPr lang="en-US" sz="1500" dirty="0"/>
           </a:p>
@@ -14291,46 +14256,7 @@
                   <a:schemeClr val="tx1"/>
                 </a:solidFill>
               </a:rPr>
-              <a:t>Every row is a group average; nothing about individual risk</a:t>
-            </a:r>
-            <a:endParaRPr lang="en-US" sz="1500" dirty="0"/>
-          </a:p>
-        </p:txBody>
-      </p:sp>
-      <p:sp>
-        <p:nvSpPr>
-          <p:cNvPr id="7" name="Text 5"/>
-          <p:cNvSpPr txBox="1"/>
-          <p:nvPr/>
-        </p:nvSpPr>
-        <p:spPr>
-          <a:xfrm>
-            <a:off x="6217920" y="3703320"/>
-            <a:ext cx="5394960" cy="2377440"/>
-          </a:xfrm>
-          <a:prstGeom prst="rect">
-            <a:avLst/>
-          </a:prstGeom>
-          <a:noFill/>
-          <a:ln/>
-        </p:spPr>
-        <p:txBody>
-          <a:bodyPr wrap="square" lIns="0" tIns="0" rIns="0" bIns="0" rtlCol="0" anchor="t"/>
-          <a:lstStyle/>
-          <a:p>
-            <a:pPr indent="0" marL="0">
-              <a:spcAft>
-                <a:spcPts val="400"/>
-              </a:spcAft>
-              <a:buNone/>
-            </a:pPr>
-            <a:r>
-              <a:rPr lang="en-US" sz="1500" b="1" dirty="0">
-                <a:solidFill>
-                  <a:schemeClr val="tx2"/>
-                </a:solidFill>
-              </a:rPr>
-              <a:t>Can anyone reproduce an LLM result?</a:t>
+              <a:t>Ridge regression uses days, muscle and every other input: 3.28 vs 3.16 pp</a:t>
             </a:r>
             <a:endParaRPr lang="en-US" sz="1500" dirty="0"/>
           </a:p>
@@ -14348,7 +14274,46 @@
                   <a:schemeClr val="tx1"/>
                 </a:solidFill>
               </a:rPr>
-              <a:t>Fixed model version; all 430 answers saved, so every number rebuilds without the model</a:t>
+              <a:t>Knowing the muscle raises R² but not the error on a new campaign</a:t>
+            </a:r>
+            <a:endParaRPr lang="en-US" sz="1500" dirty="0"/>
+          </a:p>
+        </p:txBody>
+      </p:sp>
+      <p:sp>
+        <p:nvSpPr>
+          <p:cNvPr id="7" name="Text 5"/>
+          <p:cNvSpPr txBox="1"/>
+          <p:nvPr/>
+        </p:nvSpPr>
+        <p:spPr>
+          <a:xfrm>
+            <a:off x="6217920" y="3703320"/>
+            <a:ext cx="5394960" cy="2377440"/>
+          </a:xfrm>
+          <a:prstGeom prst="rect">
+            <a:avLst/>
+          </a:prstGeom>
+          <a:noFill/>
+          <a:ln/>
+        </p:spPr>
+        <p:txBody>
+          <a:bodyPr wrap="square" lIns="0" tIns="0" rIns="0" bIns="0" rtlCol="0" anchor="t"/>
+          <a:lstStyle/>
+          <a:p>
+            <a:pPr indent="0" marL="0">
+              <a:spcAft>
+                <a:spcPts val="400"/>
+              </a:spcAft>
+              <a:buNone/>
+            </a:pPr>
+            <a:r>
+              <a:rPr lang="en-US" sz="1500" b="1" dirty="0">
+                <a:solidFill>
+                  <a:schemeClr val="tx2"/>
+                </a:solidFill>
+              </a:rPr>
+              <a:t>Would a nearest-neighbour method match the LLM?</a:t>
             </a:r>
             <a:endParaRPr lang="en-US" sz="1500" dirty="0"/>
           </a:p>
@@ -14366,7 +14331,7 @@
                   <a:schemeClr val="tx1"/>
                 </a:solidFill>
               </a:rPr>
-              <a:t>Identical requests differ by 0.17 pp on average</a:t>
+              <a:t>Not tested. If the gain comes from picking similar rows, this is the next control to run</a:t>
             </a:r>
             <a:endParaRPr lang="en-US" sz="1500" dirty="0"/>
           </a:p>
@@ -14412,6 +14377,435 @@
             <a:fld id="{F7021451-1387-4CA6-816F-3879F97B5CBC}" type="slidenum">
               <a:rPr b="0" lang="en-US"/>
               <a:t>21</a:t>
+            </a:fld>
+            <a:endParaRPr lang="en-US"/>
+          </a:p>
+        </p:txBody>
+      </p:sp>
+    </p:spTree>
+  </p:cSld>
+  <p:clrMapOvr>
+    <a:masterClrMapping/>
+  </p:clrMapOvr>
+</p:sld>
+</file>
+
+<file path=ppt/slides/slide22.xml><?xml version="1.0" encoding="utf-8"?>
+<p:sld xmlns:a="http://schemas.openxmlformats.org/drawingml/2006/main" xmlns:r="http://schemas.openxmlformats.org/officeDocument/2006/relationships" xmlns:p="http://schemas.openxmlformats.org/presentationml/2006/main">
+  <p:cSld name="Slide 22">
+    <p:spTree>
+      <p:nvGrpSpPr>
+        <p:cNvPr id="1" name=""/>
+        <p:cNvGrpSpPr/>
+        <p:nvPr/>
+      </p:nvGrpSpPr>
+      <p:grpSpPr>
+        <a:xfrm>
+          <a:off x="0" y="0"/>
+          <a:ext cx="0" cy="0"/>
+          <a:chOff x="0" y="0"/>
+          <a:chExt cx="0" cy="0"/>
+        </a:xfrm>
+      </p:grpSpPr>
+      <p:sp>
+        <p:nvSpPr>
+          <p:cNvPr id="2" name="Text 0"/>
+          <p:cNvSpPr/>
+          <p:nvPr>
+            <p:ph idx="101" type="title" hasCustomPrompt="1"/>
+          </p:nvPr>
+        </p:nvSpPr>
+        <p:spPr>
+          <a:xfrm>
+            <a:off x="548640" y="320040"/>
+            <a:ext cx="11064240" cy="731520"/>
+          </a:xfrm>
+          <a:prstGeom prst="rect">
+            <a:avLst/>
+          </a:prstGeom>
+          <a:noFill/>
+          <a:ln/>
+        </p:spPr>
+        <p:txBody>
+          <a:bodyPr wrap="square" lIns="0" tIns="0" rIns="0" bIns="0" rtlCol="0" anchor="ctr"/>
+          <a:lstStyle/>
+          <a:p>
+            <a:pPr algn="l" indent="0" marL="0">
+              <a:buNone/>
+            </a:pPr>
+            <a:r>
+              <a:rPr lang="en-US" sz="2800" b="1" dirty="0">
+                <a:solidFill>
+                  <a:schemeClr val="tx2"/>
+                </a:solidFill>
+                <a:latin typeface="Cambria" pitchFamily="34" charset="0"/>
+                <a:ea typeface="Cambria" pitchFamily="34" charset="-122"/>
+                <a:cs typeface="Cambria" pitchFamily="34" charset="-120"/>
+              </a:rPr>
+              <a:t>Backup: applicability to Mars mission planning</a:t>
+            </a:r>
+            <a:endParaRPr lang="en-US" sz="2800" dirty="0"/>
+          </a:p>
+        </p:txBody>
+      </p:sp>
+      <p:sp>
+        <p:nvSpPr>
+          <p:cNvPr id="3" name="Text 1"/>
+          <p:cNvSpPr txBox="1"/>
+          <p:nvPr/>
+        </p:nvSpPr>
+        <p:spPr>
+          <a:xfrm>
+            <a:off x="9784080" y="6355080"/>
+            <a:ext cx="1188720" cy="274320"/>
+          </a:xfrm>
+          <a:prstGeom prst="rect">
+            <a:avLst/>
+          </a:prstGeom>
+          <a:noFill/>
+          <a:ln/>
+        </p:spPr>
+        <p:txBody>
+          <a:bodyPr wrap="square" lIns="0" tIns="0" rIns="0" bIns="0" rtlCol="0" anchor="ctr"/>
+          <a:lstStyle/>
+          <a:p>
+            <a:pPr algn="r" indent="0" marL="0">
+              <a:buNone/>
+            </a:pPr>
+            <a:r>
+              <a:rPr lang="en-US" sz="1000" b="1" dirty="0">
+                <a:solidFill>
+                  <a:schemeClr val="accent3"/>
+                </a:solidFill>
+              </a:rPr>
+              <a:t>BACKUP</a:t>
+            </a:r>
+            <a:endParaRPr lang="en-US" sz="1000" dirty="0"/>
+          </a:p>
+        </p:txBody>
+      </p:sp>
+      <p:sp>
+        <p:nvSpPr>
+          <p:cNvPr id="4" name="Text 2"/>
+          <p:cNvSpPr txBox="1"/>
+          <p:nvPr/>
+        </p:nvSpPr>
+        <p:spPr>
+          <a:xfrm>
+            <a:off x="548640" y="1188720"/>
+            <a:ext cx="5394960" cy="2377440"/>
+          </a:xfrm>
+          <a:prstGeom prst="rect">
+            <a:avLst/>
+          </a:prstGeom>
+          <a:noFill/>
+          <a:ln/>
+        </p:spPr>
+        <p:txBody>
+          <a:bodyPr wrap="square" lIns="0" tIns="0" rIns="0" bIns="0" rtlCol="0" anchor="t"/>
+          <a:lstStyle/>
+          <a:p>
+            <a:pPr indent="0" marL="0">
+              <a:spcAft>
+                <a:spcPts val="400"/>
+              </a:spcAft>
+              <a:buNone/>
+            </a:pPr>
+            <a:r>
+              <a:rPr lang="en-US" sz="1500" b="1" dirty="0">
+                <a:solidFill>
+                  <a:schemeClr val="tx2"/>
+                </a:solidFill>
+              </a:rPr>
+              <a:t>A Mars transit is about 180 days; the data stop at 119</a:t>
+            </a:r>
+            <a:endParaRPr lang="en-US" sz="1500" dirty="0"/>
+          </a:p>
+          <a:p>
+            <a:pPr marL="342900" indent="-342900">
+              <a:spcAft>
+                <a:spcPts val="400"/>
+              </a:spcAft>
+              <a:buSzPct val="100000"/>
+              <a:buChar char="•"/>
+            </a:pPr>
+            <a:r>
+              <a:rPr lang="en-US" sz="1400" dirty="0">
+                <a:solidFill>
+                  <a:schemeClr val="tx1"/>
+                </a:solidFill>
+              </a:rPr>
+              <a:t>Only one campaign reaches 119 days</a:t>
+            </a:r>
+            <a:endParaRPr lang="en-US" sz="1500" dirty="0"/>
+          </a:p>
+          <a:p>
+            <a:pPr marL="342900" indent="-342900">
+              <a:spcAft>
+                <a:spcPts val="400"/>
+              </a:spcAft>
+              <a:buSzPct val="100000"/>
+              <a:buChar char="•"/>
+            </a:pPr>
+            <a:r>
+              <a:rPr lang="en-US" sz="1400" dirty="0">
+                <a:solidFill>
+                  <a:schemeClr val="tx1"/>
+                </a:solidFill>
+              </a:rPr>
+              <a:t>A 180-day estimate is planned from the duration curve only, with an uncertainty range, labelled as an assumption</a:t>
+            </a:r>
+            <a:endParaRPr lang="en-US" sz="1500" dirty="0"/>
+          </a:p>
+        </p:txBody>
+      </p:sp>
+      <p:sp>
+        <p:nvSpPr>
+          <p:cNvPr id="5" name="Text 3"/>
+          <p:cNvSpPr txBox="1"/>
+          <p:nvPr/>
+        </p:nvSpPr>
+        <p:spPr>
+          <a:xfrm>
+            <a:off x="6217920" y="1188720"/>
+            <a:ext cx="5394960" cy="2377440"/>
+          </a:xfrm>
+          <a:prstGeom prst="rect">
+            <a:avLst/>
+          </a:prstGeom>
+          <a:noFill/>
+          <a:ln/>
+        </p:spPr>
+        <p:txBody>
+          <a:bodyPr wrap="square" lIns="0" tIns="0" rIns="0" bIns="0" rtlCol="0" anchor="t"/>
+          <a:lstStyle/>
+          <a:p>
+            <a:pPr indent="0" marL="0">
+              <a:spcAft>
+                <a:spcPts val="400"/>
+              </a:spcAft>
+              <a:buNone/>
+            </a:pPr>
+            <a:r>
+              <a:rPr lang="en-US" sz="1500" b="1" dirty="0">
+                <a:solidFill>
+                  <a:schemeClr val="tx2"/>
+                </a:solidFill>
+              </a:rPr>
+              <a:t>Bed rest is not spaceflight</a:t>
+            </a:r>
+            <a:endParaRPr lang="en-US" sz="1500" dirty="0"/>
+          </a:p>
+          <a:p>
+            <a:pPr marL="342900" indent="-342900">
+              <a:spcAft>
+                <a:spcPts val="400"/>
+              </a:spcAft>
+              <a:buSzPct val="100000"/>
+              <a:buChar char="•"/>
+            </a:pPr>
+            <a:r>
+              <a:rPr lang="en-US" sz="1400" dirty="0">
+                <a:solidFill>
+                  <a:schemeClr val="tx1"/>
+                </a:solidFill>
+              </a:rPr>
+              <a:t>Only 14 spaceflight rows, 8 of them one back muscle: too few to test transfer</a:t>
+            </a:r>
+            <a:endParaRPr lang="en-US" sz="1500" dirty="0"/>
+          </a:p>
+        </p:txBody>
+      </p:sp>
+      <p:sp>
+        <p:nvSpPr>
+          <p:cNvPr id="6" name="Text 4"/>
+          <p:cNvSpPr txBox="1"/>
+          <p:nvPr/>
+        </p:nvSpPr>
+        <p:spPr>
+          <a:xfrm>
+            <a:off x="548640" y="3703320"/>
+            <a:ext cx="5394960" cy="2377440"/>
+          </a:xfrm>
+          <a:prstGeom prst="rect">
+            <a:avLst/>
+          </a:prstGeom>
+          <a:noFill/>
+          <a:ln/>
+        </p:spPr>
+        <p:txBody>
+          <a:bodyPr wrap="square" lIns="0" tIns="0" rIns="0" bIns="0" rtlCol="0" anchor="t"/>
+          <a:lstStyle/>
+          <a:p>
+            <a:pPr indent="0" marL="0">
+              <a:spcAft>
+                <a:spcPts val="400"/>
+              </a:spcAft>
+              <a:buNone/>
+            </a:pPr>
+            <a:r>
+              <a:rPr lang="en-US" sz="1500" b="1" dirty="0">
+                <a:solidFill>
+                  <a:schemeClr val="tx2"/>
+                </a:solidFill>
+              </a:rPr>
+              <a:t>Which countermeasure works? What about individuals?</a:t>
+            </a:r>
+            <a:endParaRPr lang="en-US" sz="1500" dirty="0"/>
+          </a:p>
+          <a:p>
+            <a:pPr marL="342900" indent="-342900">
+              <a:spcAft>
+                <a:spcPts val="400"/>
+              </a:spcAft>
+              <a:buSzPct val="100000"/>
+              <a:buChar char="•"/>
+            </a:pPr>
+            <a:r>
+              <a:rPr lang="en-US" sz="1400" dirty="0">
+                <a:solidFill>
+                  <a:schemeClr val="tx1"/>
+                </a:solidFill>
+              </a:rPr>
+              <a:t>Countermeasure groups lose 3.7 pp less (95% CI 1.5 to 5.9), all types pooled</a:t>
+            </a:r>
+            <a:endParaRPr lang="en-US" sz="1500" dirty="0"/>
+          </a:p>
+          <a:p>
+            <a:pPr marL="342900" indent="-342900">
+              <a:spcAft>
+                <a:spcPts val="400"/>
+              </a:spcAft>
+              <a:buSzPct val="100000"/>
+              <a:buChar char="•"/>
+            </a:pPr>
+            <a:r>
+              <a:rPr lang="en-US" sz="1400" dirty="0">
+                <a:solidFill>
+                  <a:schemeClr val="tx1"/>
+                </a:solidFill>
+              </a:rPr>
+              <a:t>Every row is a group average; nothing about individual risk</a:t>
+            </a:r>
+            <a:endParaRPr lang="en-US" sz="1500" dirty="0"/>
+          </a:p>
+        </p:txBody>
+      </p:sp>
+      <p:sp>
+        <p:nvSpPr>
+          <p:cNvPr id="7" name="Text 5"/>
+          <p:cNvSpPr txBox="1"/>
+          <p:nvPr/>
+        </p:nvSpPr>
+        <p:spPr>
+          <a:xfrm>
+            <a:off x="6217920" y="3703320"/>
+            <a:ext cx="5394960" cy="2377440"/>
+          </a:xfrm>
+          <a:prstGeom prst="rect">
+            <a:avLst/>
+          </a:prstGeom>
+          <a:noFill/>
+          <a:ln/>
+        </p:spPr>
+        <p:txBody>
+          <a:bodyPr wrap="square" lIns="0" tIns="0" rIns="0" bIns="0" rtlCol="0" anchor="t"/>
+          <a:lstStyle/>
+          <a:p>
+            <a:pPr indent="0" marL="0">
+              <a:spcAft>
+                <a:spcPts val="400"/>
+              </a:spcAft>
+              <a:buNone/>
+            </a:pPr>
+            <a:r>
+              <a:rPr lang="en-US" sz="1500" b="1" dirty="0">
+                <a:solidFill>
+                  <a:schemeClr val="tx2"/>
+                </a:solidFill>
+              </a:rPr>
+              <a:t>Can anyone reproduce an LLM result?</a:t>
+            </a:r>
+            <a:endParaRPr lang="en-US" sz="1500" dirty="0"/>
+          </a:p>
+          <a:p>
+            <a:pPr marL="342900" indent="-342900">
+              <a:spcAft>
+                <a:spcPts val="400"/>
+              </a:spcAft>
+              <a:buSzPct val="100000"/>
+              <a:buChar char="•"/>
+            </a:pPr>
+            <a:r>
+              <a:rPr lang="en-US" sz="1400" dirty="0">
+                <a:solidFill>
+                  <a:schemeClr val="tx1"/>
+                </a:solidFill>
+              </a:rPr>
+              <a:t>Fixed model version; all 430 answers saved, so every number rebuilds without the model</a:t>
+            </a:r>
+            <a:endParaRPr lang="en-US" sz="1500" dirty="0"/>
+          </a:p>
+          <a:p>
+            <a:pPr marL="342900" indent="-342900">
+              <a:spcAft>
+                <a:spcPts val="400"/>
+              </a:spcAft>
+              <a:buSzPct val="100000"/>
+              <a:buChar char="•"/>
+            </a:pPr>
+            <a:r>
+              <a:rPr lang="en-US" sz="1400" dirty="0">
+                <a:solidFill>
+                  <a:schemeClr val="tx1"/>
+                </a:solidFill>
+              </a:rPr>
+              <a:t>Identical requests differ by 0.17 pp on average</a:t>
+            </a:r>
+            <a:endParaRPr lang="en-US" sz="1500" dirty="0"/>
+          </a:p>
+        </p:txBody>
+      </p:sp>
+      <p:sp>
+        <p:nvSpPr>
+          <p:cNvPr id="25" name="Slide Number Placeholder 0"/>
+          <p:cNvSpPr>
+            <a:spLocks noGrp="1"/>
+          </p:cNvSpPr>
+          <p:nvPr>
+            <p:ph type="sldNum" sz="quarter" idx="4294967295"/>
+          </p:nvPr>
+        </p:nvSpPr>
+        <p:spPr>
+          <a:xfrm>
+            <a:off x="11155680" y="6355080"/>
+            <a:ext cx="457200" cy="274320"/>
+          </a:xfrm>
+          <a:prstGeom prst="rect">
+            <a:avLst/>
+          </a:prstGeom>
+          <a:extLst>
+            <a:ext uri="{C572A759-6A51-4108-AA02-DFA0A04FC94B}">
+              <ma14:wrappingTextBoxFlag xmlns:ma14="http://schemas.microsoft.com/office/mac/drawingml/2011/main" val="0"/>
+            </a:ext>
+          </a:extLst>
+        </p:spPr>
+        <p:txBody>
+          <a:bodyPr/>
+          <a:lstStyle>
+            <a:lvl1pPr>
+              <a:defRPr sz="1000">
+                <a:solidFill>
+                  <a:schemeClr val="accent3"/>
+                </a:solidFill>
+              </a:defRPr>
+            </a:lvl1pPr>
+          </a:lstStyle>
+          <a:p>
+            <a:pPr algn="r"/>
+            <a:fld id="{F7021451-1387-4CA6-816F-3879F97B5CBC}" type="slidenum">
+              <a:rPr b="0" lang="en-US"/>
+              <a:t>22</a:t>
             </a:fld>
             <a:endParaRPr lang="en-US"/>
           </a:p>

</xml_diff>

<commit_message>
Closing slide: drop names and affiliations
Co-Authored-By: Claude Opus 5.5 (1M context) <noreply@anthropic.com>
Claude-Session: https://claude.ai/code/session_01JZtuYERhuCe7nB9VYHwcfv
</commit_message>
<xml_diff>
--- a/presentation/bed-rest-to-mars-talk.pptx
+++ b/presentation/bed-rest-to-mars-talk.pptx
@@ -128,14 +128,14 @@
   <p:extLst>
     <p:ext uri="{521415D9-36F7-43E2-AB2F-B90AF26B5E84}">
       <p14:sectionLst xmlns:p14="http://schemas.microsoft.com/office/powerpoint/2010/main">
-        <p14:section name="Opening" id="{a0dc7691-2bf2-2674-ef07-e19c9b65dc72}">
+        <p14:section name="Opening" id="{bd0d8ac7-087d-9d72-fc33-b9fc1bea7bc2}">
           <p14:sldIdLst>
             <p14:sldId id="256"/>
             <p14:sldId id="257"/>
             <p14:sldId id="269"/>
           </p14:sldIdLst>
         </p14:section>
-        <p14:section name="Part 1" id="{8cefd1f0-170c-06fe-af01-a72cec1a76fa}">
+        <p14:section name="Part 1" id="{022c844c-2615-0571-eb1a-489593743407}">
           <p14:sldIdLst>
             <p14:sldId id="258"/>
             <p14:sldId id="259"/>
@@ -145,7 +145,7 @@
             <p14:sldId id="263"/>
           </p14:sldIdLst>
         </p14:section>
-        <p14:section name="Part 2" id="{1d4b737a-40e3-db5f-e476-b9a0477c78a5}">
+        <p14:section name="Part 2" id="{fcff2c66-65e2-f4ff-61ab-7b99cc8661e4}">
           <p14:sldIdLst>
             <p14:sldId id="264"/>
             <p14:sldId id="265"/>
@@ -154,10 +154,10 @@
             <p14:sldId id="268"/>
           </p14:sldIdLst>
         </p14:section>
-        <p14:section name="Opening" id="{abc4aff3-0da7-bad6-6404-4ed8a9fbaf5c}">
+        <p14:section name="Opening" id="{f7ef3c27-ad9e-efbb-8952-7d5d98bebb66}">
           <p14:sldIdLst/>
         </p14:section>
-        <p14:section name="Backup" id="{df318c58-9405-80b7-fbb9-b7575de952d6}">
+        <p14:section name="Backup" id="{4105db39-c31b-7c93-ad84-be013cf0e9e6}">
           <p14:sldIdLst>
             <p14:sldId id="270"/>
             <p14:sldId id="271"/>
@@ -169,25 +169,25 @@
             <p14:sldId id="277"/>
           </p14:sldIdLst>
         </p14:section>
-        <p14:section name="Backup" id="{9aedc952-e807-b8d2-eb8f-ec387f1f3895}">
+        <p14:section name="Backup" id="{e3fd860f-0f16-7570-1d88-d6d68928e29f}">
           <p14:sldIdLst/>
         </p14:section>
-        <p14:section name="Backup" id="{61a15db3-76af-d63e-8963-b10874e8a5fc}">
+        <p14:section name="Backup" id="{4d16a653-dee3-5fe2-8d6b-3b6889299544}">
           <p14:sldIdLst/>
         </p14:section>
-        <p14:section name="Backup" id="{e1e1bebb-8e6a-0be7-f3a9-8d5cec179642}">
+        <p14:section name="Backup" id="{e707f2e8-d809-855f-2477-7e864c18ff3b}">
           <p14:sldIdLst/>
         </p14:section>
-        <p14:section name="Backup" id="{950e64a2-1c0f-b942-7426-67348643ec48}">
+        <p14:section name="Backup" id="{679561d3-e0fb-0756-590b-bc10285cc9d1}">
           <p14:sldIdLst/>
         </p14:section>
-        <p14:section name="Backup" id="{eb1b283e-b8c8-6a0b-31a7-746cf06c868f}">
+        <p14:section name="Backup" id="{a906f4a9-bb4c-06b8-55a9-bbedf9b2ca4e}">
           <p14:sldIdLst/>
         </p14:section>
-        <p14:section name="Backup" id="{34f217ce-628d-bb2e-1e6f-22e9ab9851a0}">
+        <p14:section name="Backup" id="{376792cc-3014-87a1-f780-9492a123eb2f}">
           <p14:sldIdLst/>
         </p14:section>
-        <p14:section name="Backup" id="{0e83922b-a45f-28a1-d6ed-15bc1fa0ceda}">
+        <p14:section name="Backup" id="{b6431136-e220-e592-b664-dea504471f8a}">
           <p14:sldIdLst/>
         </p14:section>
       </p14:sectionLst>
@@ -8686,7 +8686,7 @@
         </p:nvSpPr>
         <p:spPr>
           <a:xfrm>
-            <a:off x="822960" y="1737360"/>
+            <a:off x="822960" y="1920240"/>
             <a:ext cx="8961120" cy="1737360"/>
           </a:xfrm>
           <a:prstGeom prst="rect">
@@ -8748,148 +8748,7 @@
         </p:nvSpPr>
         <p:spPr>
           <a:xfrm>
-            <a:off x="822960" y="3840480"/>
-            <a:ext cx="7680960" cy="365760"/>
-          </a:xfrm>
-          <a:prstGeom prst="rect">
-            <a:avLst/>
-          </a:prstGeom>
-          <a:noFill/>
-          <a:ln/>
-        </p:spPr>
-        <p:txBody>
-          <a:bodyPr wrap="square" lIns="0" tIns="0" rIns="0" bIns="0" rtlCol="0" anchor="t"/>
-          <a:lstStyle/>
-          <a:p>
-            <a:pPr indent="0" marL="0">
-              <a:buNone/>
-            </a:pPr>
-            <a:r>
-              <a:rPr lang="en-US" sz="1800" dirty="0">
-                <a:solidFill>
-                  <a:srgbClr val="FFFFFF"/>
-                </a:solidFill>
-              </a:rPr>
-              <a:t>Niloufar Ahmadymarzdashty</a:t>
-            </a:r>
-            <a:pPr indent="0" marL="0">
-              <a:buNone/>
-            </a:pPr>
-            <a:r>
-              <a:rPr lang="en-US" sz="1800" baseline="30000" dirty="0">
-                <a:solidFill>
-                  <a:srgbClr val="FFFFFF"/>
-                </a:solidFill>
-              </a:rPr>
-              <a:t>1</a:t>
-            </a:r>
-            <a:pPr indent="0" marL="0">
-              <a:buNone/>
-            </a:pPr>
-            <a:r>
-              <a:rPr lang="en-US" sz="1800" dirty="0">
-                <a:solidFill>
-                  <a:srgbClr val="FFFFFF"/>
-                </a:solidFill>
-              </a:rPr>
-              <a:t>,  Milad Bahari Qaragoz</a:t>
-            </a:r>
-            <a:pPr indent="0" marL="0">
-              <a:buNone/>
-            </a:pPr>
-            <a:r>
-              <a:rPr lang="en-US" sz="1800" baseline="30000" dirty="0">
-                <a:solidFill>
-                  <a:srgbClr val="FFFFFF"/>
-                </a:solidFill>
-              </a:rPr>
-              <a:t>2</a:t>
-            </a:r>
-            <a:endParaRPr lang="en-US" sz="1800" dirty="0"/>
-          </a:p>
-        </p:txBody>
-      </p:sp>
-      <p:sp>
-        <p:nvSpPr>
-          <p:cNvPr id="5" name="Text 2"/>
-          <p:cNvSpPr txBox="1"/>
-          <p:nvPr/>
-        </p:nvSpPr>
-        <p:spPr>
-          <a:xfrm>
-            <a:off x="822960" y="4251960"/>
-            <a:ext cx="7680960" cy="548640"/>
-          </a:xfrm>
-          <a:prstGeom prst="rect">
-            <a:avLst/>
-          </a:prstGeom>
-          <a:noFill/>
-          <a:ln/>
-        </p:spPr>
-        <p:txBody>
-          <a:bodyPr wrap="square" lIns="0" tIns="0" rIns="0" bIns="0" rtlCol="0" anchor="t"/>
-          <a:lstStyle/>
-          <a:p>
-            <a:pPr indent="0" marL="0">
-              <a:buNone/>
-            </a:pPr>
-            <a:r>
-              <a:rPr lang="en-US" sz="1400" baseline="30000" dirty="0">
-                <a:solidFill>
-                  <a:srgbClr val="B7C3D3"/>
-                </a:solidFill>
-              </a:rPr>
-              <a:t>1</a:t>
-            </a:r>
-            <a:pPr indent="0" marL="0">
-              <a:buNone/>
-            </a:pPr>
-            <a:r>
-              <a:rPr lang="en-US" sz="1400" dirty="0">
-                <a:solidFill>
-                  <a:srgbClr val="B7C3D3"/>
-                </a:solidFill>
-              </a:rPr>
-              <a:t> Independent researcher</a:t>
-            </a:r>
-            <a:endParaRPr lang="en-US" sz="1400" dirty="0"/>
-          </a:p>
-          <a:p>
-            <a:pPr indent="0" marL="0">
-              <a:buNone/>
-            </a:pPr>
-            <a:r>
-              <a:rPr lang="en-US" sz="1400" baseline="30000" dirty="0">
-                <a:solidFill>
-                  <a:srgbClr val="B7C3D3"/>
-                </a:solidFill>
-              </a:rPr>
-              <a:t>2</a:t>
-            </a:r>
-            <a:pPr indent="0" marL="0">
-              <a:buNone/>
-            </a:pPr>
-            <a:r>
-              <a:rPr lang="en-US" sz="1400" dirty="0">
-                <a:solidFill>
-                  <a:srgbClr val="B7C3D3"/>
-                </a:solidFill>
-              </a:rPr>
-              <a:t> Master's candidate, Friedrich-Alexander-Universität Erlangen-Nürnberg (FAU)</a:t>
-            </a:r>
-            <a:endParaRPr lang="en-US" sz="1400" dirty="0"/>
-          </a:p>
-        </p:txBody>
-      </p:sp>
-      <p:sp>
-        <p:nvSpPr>
-          <p:cNvPr id="6" name="Text 3"/>
-          <p:cNvSpPr txBox="1"/>
-          <p:nvPr/>
-        </p:nvSpPr>
-        <p:spPr>
-          <a:xfrm>
-            <a:off x="822960" y="4983480"/>
+            <a:off x="822960" y="3931920"/>
             <a:ext cx="7680960" cy="365760"/>
           </a:xfrm>
           <a:prstGeom prst="rect">

</xml_diff>

<commit_message>
Apply co-author review: honest screening flow, row counts, LLM point rule, further work
Co-Authored-By: Claude Opus 5.5 (1M context) <noreply@anthropic.com>
Claude-Session: https://claude.ai/code/session_01JZtuYERhuCe7nB9VYHwcfv
</commit_message>
<xml_diff>
--- a/presentation/bed-rest-to-mars-talk.pptx
+++ b/presentation/bed-rest-to-mars-talk.pptx
@@ -128,14 +128,14 @@
   <p:extLst>
     <p:ext uri="{521415D9-36F7-43E2-AB2F-B90AF26B5E84}">
       <p14:sectionLst xmlns:p14="http://schemas.microsoft.com/office/powerpoint/2010/main">
-        <p14:section name="Opening" id="{bd0d8ac7-087d-9d72-fc33-b9fc1bea7bc2}">
+        <p14:section name="Opening" id="{e7f9e6d6-ec35-8329-e602-d42d1c7980f2}">
           <p14:sldIdLst>
             <p14:sldId id="256"/>
             <p14:sldId id="257"/>
             <p14:sldId id="269"/>
           </p14:sldIdLst>
         </p14:section>
-        <p14:section name="Part 1" id="{022c844c-2615-0571-eb1a-489593743407}">
+        <p14:section name="Part 1" id="{ffdbd091-954c-5bab-c4f8-5f9912286b87}">
           <p14:sldIdLst>
             <p14:sldId id="258"/>
             <p14:sldId id="259"/>
@@ -145,7 +145,7 @@
             <p14:sldId id="263"/>
           </p14:sldIdLst>
         </p14:section>
-        <p14:section name="Part 2" id="{fcff2c66-65e2-f4ff-61ab-7b99cc8661e4}">
+        <p14:section name="Part 2" id="{1b3d932f-8d7a-56de-5afa-51e3f76f4722}">
           <p14:sldIdLst>
             <p14:sldId id="264"/>
             <p14:sldId id="265"/>
@@ -154,10 +154,10 @@
             <p14:sldId id="268"/>
           </p14:sldIdLst>
         </p14:section>
-        <p14:section name="Opening" id="{f7ef3c27-ad9e-efbb-8952-7d5d98bebb66}">
+        <p14:section name="Opening" id="{7633a513-5e70-eb47-aafa-5f28879be1ca}">
           <p14:sldIdLst/>
         </p14:section>
-        <p14:section name="Backup" id="{4105db39-c31b-7c93-ad84-be013cf0e9e6}">
+        <p14:section name="Backup" id="{c39d386c-8554-9712-71b3-045662f108fb}">
           <p14:sldIdLst>
             <p14:sldId id="270"/>
             <p14:sldId id="271"/>
@@ -169,25 +169,25 @@
             <p14:sldId id="277"/>
           </p14:sldIdLst>
         </p14:section>
-        <p14:section name="Backup" id="{e3fd860f-0f16-7570-1d88-d6d68928e29f}">
+        <p14:section name="Backup" id="{34331cb9-94da-b569-2bcb-10f5fde570fb}">
           <p14:sldIdLst/>
         </p14:section>
-        <p14:section name="Backup" id="{4d16a653-dee3-5fe2-8d6b-3b6889299544}">
+        <p14:section name="Backup" id="{81fe95de-732f-d158-60d8-10616e233bdd}">
           <p14:sldIdLst/>
         </p14:section>
-        <p14:section name="Backup" id="{e707f2e8-d809-855f-2477-7e864c18ff3b}">
+        <p14:section name="Backup" id="{a18b6090-d638-4fd0-36f2-5dddca561e3d}">
           <p14:sldIdLst/>
         </p14:section>
-        <p14:section name="Backup" id="{679561d3-e0fb-0756-590b-bc10285cc9d1}">
+        <p14:section name="Backup" id="{ec14e7f3-a51e-f98f-99f4-6e259a5642d2}">
           <p14:sldIdLst/>
         </p14:section>
-        <p14:section name="Backup" id="{a906f4a9-bb4c-06b8-55a9-bbedf9b2ca4e}">
+        <p14:section name="Backup" id="{8dbd50f2-63af-e1a9-b379-fc8047408602}">
           <p14:sldIdLst/>
         </p14:section>
-        <p14:section name="Backup" id="{376792cc-3014-87a1-f780-9492a123eb2f}">
+        <p14:section name="Backup" id="{95106aca-5e59-22bf-2fec-37960b186603}">
           <p14:sldIdLst/>
         </p14:section>
-        <p14:section name="Backup" id="{b6431136-e220-e592-b664-dea504471f8a}">
+        <p14:section name="Backup" id="{8cca890b-4189-30ca-2220-92c28563e643}">
           <p14:sldIdLst/>
         </p14:section>
       </p14:sectionLst>
@@ -3305,8 +3305,8 @@
             <a:r>
               <a:rPr lang="en-US" dirty="0"/>
               <a:t>About thirty seconds.
-With 32 independent campaigns, standard ML models and TabPFN do not beat a curve that only knows the number of days. An LLM-based probabilistic classifier that reads each campaign's description and the other campaigns' data reduces the error from 3.13 to 2.71 points. The main limitation is the small sample of 32 campaigns, mostly young men, with no bed-rest data beyond day 119.
-Next, we want to link the muscles, so that one muscle's loss predicts another's and a weighted sum estimates strength loss, and to build a risk-assessment system based on a person's characteristics.</a:t>
+With 32 independent campaigns, standard ML models and TabPFN do not beat a curve that only knows the number of days. An LLM-based probabilistic classifier that reads each campaign's description and the other campaigns' data reduces the error from 3.13 to 2.71 points. The main limitation is the small sample of 32 campaigns, mostly young men, with no bed-rest data beyond day 119. Stress this: every row is a group average, so the model predicts the average loss of a group of volunteers. It cannot yet predict the risk for an individual astronaut.
+Further work has three steps. First, estimate how susceptible each muscle is relative to a reference muscle, and combine those coefficients with baseline muscle volumes to estimate total lower-limb volume loss; the dataset has 30 group time points where three or more muscles were scanned together, across 14 campaigns, so this can be tested. Second, move from group averages to individuals with participant-level data over time, and link muscle loss to strength and function. Third, validate on independent campaigns and on spaceflight data before building any personal risk-assessment tool. These are plans, not results.</a:t>
             </a:r>
             <a:endParaRPr lang="en-US" dirty="0"/>
           </a:p>
@@ -3658,7 +3658,7 @@
           <a:p>
             <a:r>
               <a:rPr lang="en-US" dirty="0"/>
-              <a:t>Backup, part 1 (Niloufar). The arithmetic question is the most likely one: 3,600 minus 2,493 is 1,107, of which 84 reached full text and 1,023 were not screened in time. Say so plainly: they are open work, not exclusions. If pressed on the full-text stage: the report's own full-text counts are still being reconciled with the final extraction (it says so in a draft note), so do not claim the full-text numbers add up exactly. Known-item test: of the ten modelling papers we knew before the search, only two were published after 2013, and every journal database returned both. The test without the date limit was not run.</a:t>
+              <a:t>Backup, part 1 (Niloufar). The 1,023 unscreened records are shown leaving the flow at screening, next to the 2,493 exclusions. If asked, say plainly that they were not screened in time; they were not read and rejected. If pressed on the full-text stage: the report's own full-text counts are still being reconciled with the final extraction (it says so in a draft note), so do not claim the full-text numbers add up exactly. Known-item test: of the ten modelling papers we knew before the search, only two were published after 2013, and every journal database returned both. The test without the date limit was not run.</a:t>
             </a:r>
             <a:endParaRPr lang="en-US" dirty="0"/>
           </a:p>
@@ -4098,7 +4098,7 @@
           <a:p>
             <a:r>
               <a:rPr lang="en-US" dirty="0"/>
-              <a:t>Backup. The honest gap here is the nearest-neighbour control: we cannot yet say whether a simple similarity method would match the LLM.</a:t>
+              <a:t>Backup. The honest gap here is the nearest-neighbour control: we cannot yet say whether a simple similarity method would match the LLM. The 271 men-only rows and 100 countermeasure rows are our count on the 346 modelling rows; the report gives the same point on the 425 lower-limb rows before duplicate composites were removed (347 men-only, 126 countermeasure).</a:t>
             </a:r>
             <a:endParaRPr lang="en-US" dirty="0"/>
           </a:p>
@@ -4547,8 +4547,8 @@
             <a:r>
               <a:rPr lang="en-US" dirty="0"/>
               <a:t>Part 1 (Niloufar), about one minute.
-We searched four databases, PubMed, Scopus, Web of Science and NASA's technical reports, and added older work we had collected before the search, nine studies from before 2013 and one campaign from NASA's open bed-rest data. In total, 5,741 records. After removing duplicates, we screened 3,600 titles and abstracts. Most were excluded because they did not use an unloading model or did not measure muscle.
-We read 84 full texts. The main loss at this step: 19 studies show their muscle results only as charts, without a baseline value, so we could not extract them. 52 studies were included.
+We searched four databases, PubMed, Scopus, Web of Science and NASA's technical reports, and added older work we had collected before the search, nine studies from before 2013 and one campaign from NASA's open bed-rest data. In total, 5,741 records. After removing duplicates, 3,600 records remained. 2,493 were excluded, mostly because they did not use an unloading model or did not measure muscle, and 1,023 could not be screened in the time we had, so they did not go further.
+We sought 84 full texts. The main loss at this step: 19 studies show their muscle results only as charts, without a baseline value, so we could not extract them; 4 full texts were not available and 11 were excluded. These full-text counts are as recorded in our screening log and are still being reconciled with the dataset, so do not claim they add up exactly. 52 studies were included.
 Several papers often report the same bed-rest campaign, so we merged papers on the same cohort. The final dataset has 36 independent campaigns and 742 rows.</a:t>
             </a:r>
             <a:endParaRPr lang="en-US" dirty="0"/>
@@ -6627,7 +6627,7 @@
                   <a:schemeClr val="tx1"/>
                 </a:solidFill>
               </a:rPr>
-              <a:t>Our code turns the probabilities into one prediction, their weighted average: −6.6%</a:t>
+              <a:t>Our code averages the range midpoints, weighted by probability (open ends count as −31% and +5%): −6.6%</a:t>
             </a:r>
             <a:endParaRPr lang="en-US" sz="1300" dirty="0"/>
           </a:p>
@@ -6645,7 +6645,7 @@
                   <a:schemeClr val="tx1"/>
                 </a:solidFill>
               </a:rPr>
-              <a:t>Measured: −9.4%, an error of 2.8 pp. This is a typical row: half of the LLM's errors are smaller.</a:t>
+              <a:t>Measured: −9.4%, an error of 2.8 pp, a typical row</a:t>
             </a:r>
             <a:endParaRPr lang="en-US" sz="1300" dirty="0"/>
           </a:p>
@@ -7572,7 +7572,7 @@
                 <a:ea typeface="Cambria" pitchFamily="34" charset="-122"/>
                 <a:cs typeface="Cambria" pitchFamily="34" charset="-120"/>
               </a:rPr>
-              <a:t>Validity checks of the LLM prediction</a:t>
+              <a:t>Robustness and validity checks of the LLM prediction</a:t>
             </a:r>
             <a:endParaRPr lang="en-US" sz="2800" dirty="0"/>
           </a:p>
@@ -8466,7 +8466,25 @@
                   <a:schemeClr val="tx1"/>
                 </a:solidFill>
               </a:rPr>
-              <a:t>Group averages; bed rest is not spaceflight</a:t>
+              <a:t>Group averages, not individual astronauts</a:t>
+            </a:r>
+            <a:endParaRPr lang="en-US" sz="2000" dirty="0"/>
+          </a:p>
+          <a:p>
+            <a:pPr marL="342900" indent="-342900">
+              <a:spcAft>
+                <a:spcPts val="400"/>
+              </a:spcAft>
+              <a:buSzPct val="100000"/>
+              <a:buChar char="•"/>
+            </a:pPr>
+            <a:r>
+              <a:rPr lang="en-US" sz="1800" dirty="0">
+                <a:solidFill>
+                  <a:schemeClr val="tx1"/>
+                </a:solidFill>
+              </a:rPr>
+              <a:t>Bed rest is not spaceflight</a:t>
             </a:r>
             <a:endParaRPr lang="en-US" sz="2000" dirty="0"/>
           </a:p>
@@ -8504,7 +8522,7 @@
         <p:spPr>
           <a:xfrm>
             <a:off x="548640" y="4023360"/>
-            <a:ext cx="11064240" cy="2011680"/>
+            <a:ext cx="11064240" cy="2103120"/>
           </a:xfrm>
           <a:prstGeom prst="rect">
             <a:avLst/>
@@ -8541,12 +8559,12 @@
               <a:buChar char="•"/>
             </a:pPr>
             <a:r>
-              <a:rPr lang="en-US" sz="1800" dirty="0">
+              <a:rPr lang="en-US" sz="1600" dirty="0">
                 <a:solidFill>
                   <a:schemeClr val="tx1"/>
                 </a:solidFill>
               </a:rPr>
-              <a:t>Link the muscles: predict one muscle's loss from another's, and weight them into an estimate of strength loss</a:t>
+              <a:t>Muscle-specific modelling: estimate each muscle's susceptibility and combine it with baseline volumes into total lower-limb volume loss</a:t>
             </a:r>
             <a:endParaRPr lang="en-US" sz="2000" dirty="0"/>
           </a:p>
@@ -8559,12 +8577,30 @@
               <a:buChar char="•"/>
             </a:pPr>
             <a:r>
-              <a:rPr lang="en-US" sz="1800" dirty="0">
+              <a:rPr lang="en-US" sz="1600" dirty="0">
                 <a:solidFill>
                   <a:schemeClr val="tx1"/>
                 </a:solidFill>
               </a:rPr>
-              <a:t>A risk-assessment system based on a person's characteristics, such as age, sex and fitness</a:t>
+              <a:t>Individual and functional prediction: participant-level data over time, linked to strength and function</a:t>
+            </a:r>
+            <a:endParaRPr lang="en-US" sz="2000" dirty="0"/>
+          </a:p>
+          <a:p>
+            <a:pPr marL="342900" indent="-342900">
+              <a:spcAft>
+                <a:spcPts val="400"/>
+              </a:spcAft>
+              <a:buSzPct val="100000"/>
+              <a:buChar char="•"/>
+            </a:pPr>
+            <a:r>
+              <a:rPr lang="en-US" sz="1600" dirty="0">
+                <a:solidFill>
+                  <a:schemeClr val="tx1"/>
+                </a:solidFill>
+              </a:rPr>
+              <a:t>Validation on independent campaigns and spaceflight data before any personal risk-assessment tool</a:t>
             </a:r>
             <a:endParaRPr lang="en-US" sz="2000" dirty="0"/>
           </a:p>
@@ -10941,7 +10977,7 @@
                   <a:schemeClr val="tx2"/>
                 </a:solidFill>
               </a:rPr>
-              <a:t>3,600 screened, 2,493 excluded: where are the other 1,107?</a:t>
+              <a:t>Why were 1,023 records not screened?</a:t>
             </a:r>
             <a:endParaRPr lang="en-US" sz="1500" dirty="0"/>
           </a:p>
@@ -10959,7 +10995,7 @@
                   <a:schemeClr val="tx1"/>
                 </a:solidFill>
               </a:rPr>
-              <a:t>84 went on to full text: 74 from the search and 10 from other sources</a:t>
+              <a:t>Search and screening were time-boxed to one week</a:t>
             </a:r>
             <a:endParaRPr lang="en-US" sz="1500" dirty="0"/>
           </a:p>
@@ -10977,7 +11013,7 @@
                   <a:schemeClr val="tx1"/>
                 </a:solidFill>
               </a:rPr>
-              <a:t>1,023 were not screened in the time available: the rest of the "maybe" set and 80 records waiting for a full text</a:t>
+              <a:t>They are the rest of the "maybe" set and 80 records waiting for a full text</a:t>
             </a:r>
             <a:endParaRPr lang="en-US" sz="1500" dirty="0"/>
           </a:p>
@@ -10995,7 +11031,7 @@
                   <a:schemeClr val="tx1"/>
                 </a:solidFill>
               </a:rPr>
-              <a:t>They are reported as unscreened, not as excluded</a:t>
+              <a:t>They leave the flow at screening but are not counted as excluded</a:t>
             </a:r>
             <a:endParaRPr lang="en-US" sz="1500" dirty="0"/>
           </a:p>
@@ -11164,6 +11200,24 @@
                 </a:solidFill>
               </a:rPr>
               <a:t>4 full texts not available (one conference abstract still used); 11 excluded at full text</a:t>
+            </a:r>
+            <a:endParaRPr lang="en-US" sz="1500" dirty="0"/>
+          </a:p>
+          <a:p>
+            <a:pPr marL="342900" indent="-342900">
+              <a:spcAft>
+                <a:spcPts val="400"/>
+              </a:spcAft>
+              <a:buSzPct val="100000"/>
+              <a:buChar char="•"/>
+            </a:pPr>
+            <a:r>
+              <a:rPr lang="en-US" sz="1400" dirty="0">
+                <a:solidFill>
+                  <a:schemeClr val="tx1"/>
+                </a:solidFill>
+              </a:rPr>
+              <a:t>These counts are as recorded and still being reconciled with the dataset</a:t>
             </a:r>
             <a:endParaRPr lang="en-US" sz="1500" dirty="0"/>
           </a:p>
@@ -11610,7 +11664,7 @@
                   <a:schemeClr val="tx1"/>
                 </a:solidFill>
               </a:rPr>
-              <a:t>Rows: men only 567, mixed 113, women only 40 (one campaign, WISE-2005)</a:t>
+              <a:t>Rows, not people: men only 567, mixed 113, women only 40 (35 of them WISE-2005), not reported 22</a:t>
             </a:r>
             <a:endParaRPr lang="en-US" sz="1500" dirty="0"/>
           </a:p>
@@ -11628,7 +11682,7 @@
                   <a:schemeClr val="tx1"/>
                 </a:solidFill>
               </a:rPr>
-              <a:t>Healthy young 692, older 42: the results describe young men</a:t>
+              <a:t>Healthy young 692, middle-aged 8, older 42: the results describe young men</a:t>
             </a:r>
             <a:endParaRPr lang="en-US" sz="1500" dirty="0"/>
           </a:p>
@@ -13136,7 +13190,7 @@
                   <a:schemeClr val="tx1"/>
                 </a:solidFill>
               </a:rPr>
-              <a:t>Models used, results, LLM validity checks</a:t>
+              <a:t>Models, results, LLM robustness and validity checks</a:t>
             </a:r>
             <a:endParaRPr lang="en-US" sz="1600" dirty="0"/>
           </a:p>
@@ -14058,7 +14112,7 @@
                   <a:schemeClr val="tx1"/>
                 </a:solidFill>
               </a:rPr>
-              <a:t>Age and sex are fixed within a campaign (347 of 425 rows men-only), so they act as a campaign label; 126 countermeasure rows spread over 9 types</a:t>
+              <a:t>Age and sex are fixed within a campaign (271 of the 346 modelling rows men-only), so they act as a campaign label; 100 countermeasure rows spread over 9 types</a:t>
             </a:r>
             <a:endParaRPr lang="en-US" sz="1500" dirty="0"/>
           </a:p>
@@ -16510,7 +16564,7 @@
         <p:spPr>
           <a:xfrm>
             <a:off x="8327136" y="2880360"/>
-            <a:ext cx="1828800" cy="292608"/>
+            <a:ext cx="2377440" cy="292608"/>
           </a:xfrm>
           <a:prstGeom prst="rect">
             <a:avLst/>
@@ -16531,7 +16585,7 @@
                   <a:schemeClr val="accent3"/>
                 </a:solidFill>
               </a:rPr>
-              <a:t>◄ the whole mission</a:t>
+              <a:t>◄ the whole mission (Apollo 17)</a:t>
             </a:r>
             <a:endParaRPr lang="en-US" sz="1050" dirty="0"/>
           </a:p>
@@ -19606,7 +19660,7 @@
                   <a:schemeClr val="accent3"/>
                 </a:solidFill>
               </a:rPr>
-              <a:t>PubMed, Scopus, Web of Science, NASA reports</a:t>
+              <a:t>PubMed, Scopus, Web of Science, NASA reports; 10 from other sources</a:t>
             </a:r>
             <a:endParaRPr lang="en-US" sz="2600" dirty="0"/>
           </a:p>
@@ -19744,7 +19798,7 @@
                   <a:schemeClr val="tx1"/>
                 </a:solidFill>
               </a:rPr>
-              <a:t>titles and abstracts screened</a:t>
+              <a:t>records after removing duplicates</a:t>
             </a:r>
             <a:endParaRPr lang="en-US" sz="2600" dirty="0"/>
           </a:p>
@@ -19882,7 +19936,7 @@
                   <a:schemeClr val="tx1"/>
                 </a:solidFill>
               </a:rPr>
-              <a:t>full texts read</a:t>
+              <a:t>full texts sought</a:t>
             </a:r>
             <a:endParaRPr lang="en-US" sz="2600" dirty="0"/>
           </a:p>
@@ -20211,7 +20265,7 @@
         <p:spPr>
           <a:xfrm>
             <a:off x="1623060" y="4000500"/>
-            <a:ext cx="2011680" cy="1005840"/>
+            <a:ext cx="2011680" cy="1371600"/>
           </a:xfrm>
           <a:prstGeom prst="rect">
             <a:avLst/>
@@ -20271,7 +20325,7 @@
         <p:spPr>
           <a:xfrm>
             <a:off x="3863340" y="4000500"/>
-            <a:ext cx="2011680" cy="1005840"/>
+            <a:ext cx="2011680" cy="1371600"/>
           </a:xfrm>
           <a:prstGeom prst="rect">
             <a:avLst/>
@@ -20293,6 +20347,20 @@
                 </a:solidFill>
               </a:rPr>
               <a:t>2,493 excluded, mostly no unloading model or no muscle outcome</a:t>
+            </a:r>
+            <a:endParaRPr lang="en-US" sz="1100" dirty="0"/>
+          </a:p>
+          <a:p>
+            <a:pPr algn="ctr" indent="0" marL="0">
+              <a:buNone/>
+            </a:pPr>
+            <a:r>
+              <a:rPr lang="en-US" sz="1100" dirty="0">
+                <a:solidFill>
+                  <a:schemeClr val="accent3"/>
+                </a:solidFill>
+              </a:rPr>
+              <a:t>1,023 not screened in time</a:t>
             </a:r>
             <a:endParaRPr lang="en-US" sz="1100" dirty="0"/>
           </a:p>
@@ -20331,7 +20399,7 @@
         <p:spPr>
           <a:xfrm>
             <a:off x="6103620" y="4000500"/>
-            <a:ext cx="2011680" cy="1005840"/>
+            <a:ext cx="2011680" cy="1371600"/>
           </a:xfrm>
           <a:prstGeom prst="rect">
             <a:avLst/>
@@ -20370,6 +20438,20 @@
             </a:r>
             <a:endParaRPr lang="en-US" sz="1100" dirty="0"/>
           </a:p>
+          <a:p>
+            <a:pPr algn="ctr" indent="0" marL="0">
+              <a:buNone/>
+            </a:pPr>
+            <a:r>
+              <a:rPr lang="en-US" sz="1100" dirty="0">
+                <a:solidFill>
+                  <a:schemeClr val="accent3"/>
+                </a:solidFill>
+              </a:rPr>
+              <a:t>11 excluded at full text</a:t>
+            </a:r>
+            <a:endParaRPr lang="en-US" sz="1100" dirty="0"/>
+          </a:p>
         </p:txBody>
       </p:sp>
       <p:sp>
@@ -20381,7 +20463,7 @@
         <p:spPr>
           <a:xfrm>
             <a:off x="548640" y="5806440"/>
-            <a:ext cx="8229600" cy="274320"/>
+            <a:ext cx="11064240" cy="274320"/>
           </a:xfrm>
           <a:prstGeom prst="rect">
             <a:avLst/>
@@ -20402,7 +20484,7 @@
                   <a:schemeClr val="accent3"/>
                 </a:solidFill>
               </a:rPr>
-              <a:t>Figure 6. Flow of records, in the style of PRISMA 2020 (the standard for reporting systematic reviews).</a:t>
+              <a:t>Figure 6. Flow of records, in the style of PRISMA 2020. Full-text counts as recorded; they are still being reconciled with the dataset.</a:t>
             </a:r>
             <a:endParaRPr lang="en-US" sz="1100" dirty="0"/>
           </a:p>

</xml_diff>

<commit_message>
Drop the screening backup slide
Co-Authored-By: Claude Opus 5.5 (1M context) <noreply@anthropic.com>
Claude-Session: https://claude.ai/code/session_01JZtuYERhuCe7nB9VYHwcfv
</commit_message>
<xml_diff>
--- a/presentation/bed-rest-to-mars-talk.pptx
+++ b/presentation/bed-rest-to-mars-talk.pptx
@@ -26,10 +26,9 @@
     <p:sldId id="274" r:id="rId20"/>
     <p:sldId id="275" r:id="rId21"/>
     <p:sldId id="276" r:id="rId22"/>
-    <p:sldId id="277" r:id="rId23"/>
   </p:sldIdLst>
   <p:notesMasterIdLst>
-    <p:notesMasterId r:id="rId24"/>
+    <p:notesMasterId r:id="rId23"/>
   </p:notesMasterIdLst>
   <p:sldSz cx="12192000" cy="6858000"/>
   <p:notesSz cx="6858000" cy="12192000"/>
@@ -128,14 +127,14 @@
   <p:extLst>
     <p:ext uri="{521415D9-36F7-43E2-AB2F-B90AF26B5E84}">
       <p14:sectionLst xmlns:p14="http://schemas.microsoft.com/office/powerpoint/2010/main">
-        <p14:section name="Opening" id="{e7f9e6d6-ec35-8329-e602-d42d1c7980f2}">
+        <p14:section name="Opening" id="{5b2e7efd-b591-4e93-6056-2e08e54cbaba}">
           <p14:sldIdLst>
             <p14:sldId id="256"/>
             <p14:sldId id="257"/>
             <p14:sldId id="269"/>
           </p14:sldIdLst>
         </p14:section>
-        <p14:section name="Part 1" id="{ffdbd091-954c-5bab-c4f8-5f9912286b87}">
+        <p14:section name="Part 1" id="{318e3589-0fb6-613a-fe48-43be1782e14d}">
           <p14:sldIdLst>
             <p14:sldId id="258"/>
             <p14:sldId id="259"/>
@@ -145,7 +144,7 @@
             <p14:sldId id="263"/>
           </p14:sldIdLst>
         </p14:section>
-        <p14:section name="Part 2" id="{1b3d932f-8d7a-56de-5afa-51e3f76f4722}">
+        <p14:section name="Part 2" id="{11f8fe13-e838-8bb1-82a6-603fbcf7080e}">
           <p14:sldIdLst>
             <p14:sldId id="264"/>
             <p14:sldId id="265"/>
@@ -154,10 +153,10 @@
             <p14:sldId id="268"/>
           </p14:sldIdLst>
         </p14:section>
-        <p14:section name="Opening" id="{7633a513-5e70-eb47-aafa-5f28879be1ca}">
+        <p14:section name="Opening" id="{6e1a713f-666e-06db-7fbe-12358afc1726}">
           <p14:sldIdLst/>
         </p14:section>
-        <p14:section name="Backup" id="{c39d386c-8554-9712-71b3-045662f108fb}">
+        <p14:section name="Backup" id="{0e3c7913-d825-b7ef-edcc-daf4454785cd}">
           <p14:sldIdLst>
             <p14:sldId id="270"/>
             <p14:sldId id="271"/>
@@ -166,28 +165,24 @@
             <p14:sldId id="274"/>
             <p14:sldId id="275"/>
             <p14:sldId id="276"/>
-            <p14:sldId id="277"/>
           </p14:sldIdLst>
         </p14:section>
-        <p14:section name="Backup" id="{34331cb9-94da-b569-2bcb-10f5fde570fb}">
+        <p14:section name="Backup" id="{8fb47547-3ec1-deb7-13d4-2c814546d454}">
           <p14:sldIdLst/>
         </p14:section>
-        <p14:section name="Backup" id="{81fe95de-732f-d158-60d8-10616e233bdd}">
+        <p14:section name="Backup" id="{071c6169-074b-613f-66ca-d0b3231fe3b1}">
           <p14:sldIdLst/>
         </p14:section>
-        <p14:section name="Backup" id="{a18b6090-d638-4fd0-36f2-5dddca561e3d}">
+        <p14:section name="Backup" id="{9efe4c1d-47a7-ff20-7340-c9b3116da5b2}">
           <p14:sldIdLst/>
         </p14:section>
-        <p14:section name="Backup" id="{ec14e7f3-a51e-f98f-99f4-6e259a5642d2}">
+        <p14:section name="Backup" id="{59787599-f5be-45c0-cfa3-97f0adafc154}">
           <p14:sldIdLst/>
         </p14:section>
-        <p14:section name="Backup" id="{8dbd50f2-63af-e1a9-b379-fc8047408602}">
+        <p14:section name="Backup" id="{b549ca3d-5aa2-9626-2fdc-f4d6ade563d9}">
           <p14:sldIdLst/>
         </p14:section>
-        <p14:section name="Backup" id="{95106aca-5e59-22bf-2fec-37960b186603}">
-          <p14:sldIdLst/>
-        </p14:section>
-        <p14:section name="Backup" id="{8cca890b-4189-30ca-2220-92c28563e643}">
+        <p14:section name="Backup" id="{5f27dd35-ab38-6611-0d13-7d58b3d9ee28}">
           <p14:sldIdLst/>
         </p14:section>
       </p14:sectionLst>
@@ -3394,7 +3389,7 @@
           <a:p>
             <a:r>
               <a:rPr lang="en-US" dirty="0"/>
-              <a:t>Close (Milad). Thank the audience and invite questions. The backup slides that follow answer the questions we expect: part 1 on slides 17 to 19, data and search on 15 and 16, part 2 on 20 to 22.</a:t>
+              <a:t>Close (Milad). Thank the audience and invite questions. The backup slides that follow answer the questions we expect: part 1 on slides 17 and 18, data and search on 15 and 16, part 2 on 19 to 21.</a:t>
             </a:r>
             <a:endParaRPr lang="en-US" dirty="0"/>
           </a:p>
@@ -3658,7 +3653,7 @@
           <a:p>
             <a:r>
               <a:rPr lang="en-US" dirty="0"/>
-              <a:t>Backup, part 1 (Niloufar). The 1,023 unscreened records are shown leaving the flow at screening, next to the 2,493 exclusions. If asked, say plainly that they were not screened in time; they were not read and rejected. If pressed on the full-text stage: the report's own full-text counts are still being reconciled with the final extraction (it says so in a draft note), so do not claim the full-text numbers add up exactly. Known-item test: of the ten modelling papers we knew before the search, only two were published after 2013, and every journal database returned both. The test without the date limit was not run.</a:t>
+              <a:t>Backup, part 1 (Niloufar). Expansion: the eligibility criteria in the report's Table 2 were written before screening; dataset version 1.0 was frozen on 14 September and 1.1 on 19 September, and every result is fitted on 1.1. The rule for the curve: the saturating form is the headline unless another form beats it by at least 4 AIC points. Spaceflight: the dataset keeps the spaceflight rows, flagged, but they are post-flight measurements, so the during-unloading filter removes them. Weighting: inverse-variance weighting would need the spread of the change, which most papers do not print; the check that compares both weightings moved the duration effect by under 1 pp.</a:t>
             </a:r>
             <a:endParaRPr lang="en-US" dirty="0"/>
           </a:p>
@@ -3746,7 +3741,7 @@
           <a:p>
             <a:r>
               <a:rPr lang="en-US" dirty="0"/>
-              <a:t>Backup, part 1 (Niloufar). Expansion: the eligibility criteria in the report's Table 2 were written before screening; dataset version 1.0 was frozen on 14 September and 1.1 on 19 September, and every result is fitted on 1.1. The rule for the curve: the saturating form is the headline unless another form beats it by at least 4 AIC points. Spaceflight: the dataset keeps the spaceflight rows, flagged, but they are post-flight measurements, so the during-unloading filter removes them. Weighting: inverse-variance weighting would need the spread of the change, which most papers do not print; the check that compares both weightings moved the duration effect by under 1 pp.</a:t>
+              <a:t>Backup, part 1 (Niloufar). Be precise about slide 8: the coloured dots at day 60 are the model's estimates for each muscle group, with the intervals shown here. The lines are drawn with one shared time course scaled to those values, so they show the shape the model assumes, not a separate fit per muscle. The intervals are 95% cluster-robust, which means they account for several rows coming from the same campaign. The calf-versus-shin contrast is reported on its own because it does not depend on which muscle is the reference.</a:t>
             </a:r>
             <a:endParaRPr lang="en-US" dirty="0"/>
           </a:p>
@@ -3834,7 +3829,7 @@
           <a:p>
             <a:r>
               <a:rPr lang="en-US" dirty="0"/>
-              <a:t>Backup, part 1 (Niloufar). Be precise about slide 8: the coloured dots at day 60 are the model's estimates for each muscle group, with the intervals shown here. The lines are drawn with one shared time course scaled to those values, so they show the shape the model assumes, not a separate fit per muscle. The intervals are 95% cluster-robust, which means they account for several rows coming from the same campaign. The calf-versus-shin contrast is reported on its own because it does not depend on which muscle is the reference.</a:t>
+              <a:t>Backup. The two starred numbers are our own calculation from results/forecast_predictions.csv, not in the report. Without the three campaigns that carry most of the gain, the interval touches zero; say so if asked.</a:t>
             </a:r>
             <a:endParaRPr lang="en-US" dirty="0"/>
           </a:p>
@@ -4010,7 +4005,7 @@
           <a:p>
             <a:r>
               <a:rPr lang="en-US" dirty="0"/>
-              <a:t>Backup. The two starred numbers are our own calculation from results/forecast_predictions.csv, not in the report. Without the three campaigns that carry most of the gain, the interval touches zero; say so if asked.</a:t>
+              <a:t>Backup. The honest gap here is the nearest-neighbour control: we cannot yet say whether a simple similarity method would match the LLM. The 271 men-only rows and 100 countermeasure rows are our count on the 346 modelling rows; the report gives the same point on the 425 lower-limb rows before duplicate composites were removed (347 men-only, 126 countermeasure).</a:t>
             </a:r>
             <a:endParaRPr lang="en-US" dirty="0"/>
           </a:p>
@@ -4098,7 +4093,7 @@
           <a:p>
             <a:r>
               <a:rPr lang="en-US" dirty="0"/>
-              <a:t>Backup. The honest gap here is the nearest-neighbour control: we cannot yet say whether a simple similarity method would match the LLM. The 271 men-only rows and 100 countermeasure rows are our count on the 346 modelling rows; the report gives the same point on the 425 lower-limb rows before duplicate composites were removed (347 men-only, 126 countermeasure).</a:t>
+              <a:t>Backup. The supported planning statements, within 5 to 119 days and for groups: most loss happens in the first weeks, calf muscles need protecting first, and countermeasure groups lose less.</a:t>
             </a:r>
             <a:endParaRPr lang="en-US" dirty="0"/>
           </a:p>
@@ -4122,94 +4117,6 @@
             <a:fld id="{F7021451-1387-4CA6-816F-3879F97B5CBC}" type="slidenum">
               <a:rPr lang="en-US"/>
               <a:t>21</a:t>
-            </a:fld>
-            <a:endParaRPr lang="en-US"/>
-          </a:p>
-        </p:txBody>
-      </p:sp>
-    </p:spTree>
-    <p:extLst>
-      <p:ext uri="{BB962C8B-B14F-4D97-AF65-F5344CB8AC3E}">
-        <p14:creationId xmlns:p14="http://schemas.microsoft.com/office/powerpoint/2010/main" val="1024086991"/>
-      </p:ext>
-    </p:extLst>
-  </p:cSld>
-  <p:clrMapOvr>
-    <a:masterClrMapping/>
-  </p:clrMapOvr>
-</p:notes>
-</file>
-
-<file path=ppt/notesSlides/notesSlide22.xml><?xml version="1.0" encoding="utf-8"?>
-<p:notes xmlns:a="http://schemas.openxmlformats.org/drawingml/2006/main" xmlns:r="http://schemas.openxmlformats.org/officeDocument/2006/relationships" xmlns:p="http://schemas.openxmlformats.org/presentationml/2006/main">
-  <p:cSld>
-    <p:spTree>
-      <p:nvGrpSpPr>
-        <p:cNvPr id="1" name=""/>
-        <p:cNvGrpSpPr/>
-        <p:nvPr/>
-      </p:nvGrpSpPr>
-      <p:grpSpPr>
-        <a:xfrm>
-          <a:off x="0" y="0"/>
-          <a:ext cx="0" cy="0"/>
-          <a:chOff x="0" y="0"/>
-          <a:chExt cx="0" cy="0"/>
-        </a:xfrm>
-      </p:grpSpPr>
-      <p:sp>
-        <p:nvSpPr>
-          <p:cNvPr id="2" name="Slide Image Placeholder 1"/>
-          <p:cNvSpPr>
-            <a:spLocks noGrp="1" noRot="1" noChangeAspect="1"/>
-          </p:cNvSpPr>
-          <p:nvPr>
-            <p:ph type="sldImg"/>
-          </p:nvPr>
-        </p:nvSpPr>
-        <p:spPr/>
-      </p:sp>
-      <p:sp>
-        <p:nvSpPr>
-          <p:cNvPr id="3" name="Notes Placeholder 2"/>
-          <p:cNvSpPr>
-            <a:spLocks noGrp="1"/>
-          </p:cNvSpPr>
-          <p:nvPr>
-            <p:ph type="body" idx="1"/>
-          </p:nvPr>
-        </p:nvSpPr>
-        <p:spPr/>
-        <p:txBody>
-          <a:bodyPr/>
-          <a:lstStyle/>
-          <a:p>
-            <a:r>
-              <a:rPr lang="en-US" dirty="0"/>
-              <a:t>Backup. The supported planning statements, within 5 to 119 days and for groups: most loss happens in the first weeks, calf muscles need protecting first, and countermeasure groups lose less.</a:t>
-            </a:r>
-            <a:endParaRPr lang="en-US" dirty="0"/>
-          </a:p>
-        </p:txBody>
-      </p:sp>
-      <p:sp>
-        <p:nvSpPr>
-          <p:cNvPr id="4" name="Slide Number Placeholder 3"/>
-          <p:cNvSpPr>
-            <a:spLocks noGrp="1"/>
-          </p:cNvSpPr>
-          <p:nvPr>
-            <p:ph type="sldNum" sz="quarter" idx="10"/>
-          </p:nvPr>
-        </p:nvSpPr>
-        <p:spPr/>
-        <p:txBody>
-          <a:bodyPr/>
-          <a:lstStyle/>
-          <a:p>
-            <a:fld id="{F7021451-1387-4CA6-816F-3879F97B5CBC}" type="slidenum">
-              <a:rPr lang="en-US"/>
-              <a:t>22</a:t>
             </a:fld>
             <a:endParaRPr lang="en-US"/>
           </a:p>
@@ -8983,7 +8890,7 @@
                   <a:schemeClr val="tx1"/>
                 </a:solidFill>
               </a:rPr>
-              <a:t>Not covered: Embase (no access); 1,023 records not yet screened (screening backup)</a:t>
+              <a:t>Not covered: Embase (no access); 1,023 records not screened in time (slide 6)</a:t>
             </a:r>
             <a:endParaRPr lang="en-US" sz="1500" dirty="0"/>
           </a:p>
@@ -10902,7 +10809,7 @@
                 <a:ea typeface="Cambria" pitchFamily="34" charset="-122"/>
                 <a:cs typeface="Cambria" pitchFamily="34" charset="-120"/>
               </a:rPr>
-              <a:t>Backup: screening and study selection</a:t>
+              <a:t>Backup: dataset expansion and composition</a:t>
             </a:r>
             <a:endParaRPr lang="en-US" sz="2800" dirty="0"/>
           </a:p>
@@ -10977,7 +10884,7 @@
                   <a:schemeClr val="tx2"/>
                 </a:solidFill>
               </a:rPr>
-              <a:t>Why were 1,023 records not screened?</a:t>
+              <a:t>The abstract had 15 studies. Did adding 37 change the analysis after seeing data?</a:t>
             </a:r>
             <a:endParaRPr lang="en-US" sz="1500" dirty="0"/>
           </a:p>
@@ -10995,7 +10902,7 @@
                   <a:schemeClr val="tx1"/>
                 </a:solidFill>
               </a:rPr>
-              <a:t>Search and screening were time-boxed to one week</a:t>
+              <a:t>Eligibility criteria were fixed before screening; the dataset was frozen (14 and 19 September) before the final models</a:t>
             </a:r>
             <a:endParaRPr lang="en-US" sz="1500" dirty="0"/>
           </a:p>
@@ -11013,7 +10920,46 @@
                   <a:schemeClr val="tx1"/>
                 </a:solidFill>
               </a:rPr>
-              <a:t>They are the rest of the "maybe" set and 80 records waiting for a full text</a:t>
+              <a:t>The curve shape was chosen by a rule declared before fitting</a:t>
+            </a:r>
+            <a:endParaRPr lang="en-US" sz="1500" dirty="0"/>
+          </a:p>
+        </p:txBody>
+      </p:sp>
+      <p:sp>
+        <p:nvSpPr>
+          <p:cNvPr id="5" name="Text 3"/>
+          <p:cNvSpPr txBox="1"/>
+          <p:nvPr/>
+        </p:nvSpPr>
+        <p:spPr>
+          <a:xfrm>
+            <a:off x="6217920" y="1188720"/>
+            <a:ext cx="5394960" cy="2377440"/>
+          </a:xfrm>
+          <a:prstGeom prst="rect">
+            <a:avLst/>
+          </a:prstGeom>
+          <a:noFill/>
+          <a:ln/>
+        </p:spPr>
+        <p:txBody>
+          <a:bodyPr wrap="square" lIns="0" tIns="0" rIns="0" bIns="0" rtlCol="0" anchor="t"/>
+          <a:lstStyle/>
+          <a:p>
+            <a:pPr indent="0" marL="0">
+              <a:spcAft>
+                <a:spcPts val="400"/>
+              </a:spcAft>
+              <a:buNone/>
+            </a:pPr>
+            <a:r>
+              <a:rPr lang="en-US" sz="1500" b="1" dirty="0">
+                <a:solidFill>
+                  <a:schemeClr val="tx2"/>
+                </a:solidFill>
+              </a:rPr>
+              <a:t>Slide 5 shows 180 days, but the model stops at day 119. Why?</a:t>
             </a:r>
             <a:endParaRPr lang="en-US" sz="1500" dirty="0"/>
           </a:p>
@@ -11031,46 +10977,7 @@
                   <a:schemeClr val="tx1"/>
                 </a:solidFill>
               </a:rPr>
-              <a:t>They leave the flow at screening but are not counted as excluded</a:t>
-            </a:r>
-            <a:endParaRPr lang="en-US" sz="1500" dirty="0"/>
-          </a:p>
-        </p:txBody>
-      </p:sp>
-      <p:sp>
-        <p:nvSpPr>
-          <p:cNvPr id="5" name="Text 3"/>
-          <p:cNvSpPr txBox="1"/>
-          <p:nvPr/>
-        </p:nvSpPr>
-        <p:spPr>
-          <a:xfrm>
-            <a:off x="6217920" y="1188720"/>
-            <a:ext cx="5394960" cy="2377440"/>
-          </a:xfrm>
-          <a:prstGeom prst="rect">
-            <a:avLst/>
-          </a:prstGeom>
-          <a:noFill/>
-          <a:ln/>
-        </p:spPr>
-        <p:txBody>
-          <a:bodyPr wrap="square" lIns="0" tIns="0" rIns="0" bIns="0" rtlCol="0" anchor="t"/>
-          <a:lstStyle/>
-          <a:p>
-            <a:pPr indent="0" marL="0">
-              <a:spcAft>
-                <a:spcPts val="400"/>
-              </a:spcAft>
-              <a:buNone/>
-            </a:pPr>
-            <a:r>
-              <a:rPr lang="en-US" sz="1500" b="1" dirty="0">
-                <a:solidFill>
-                  <a:schemeClr val="tx2"/>
-                </a:solidFill>
-              </a:rPr>
-              <a:t>Who screened, and was it done twice?</a:t>
+              <a:t>The 14 spaceflight rows were measured after landing, so they leave the model with the 264 recovery rows</a:t>
             </a:r>
             <a:endParaRPr lang="en-US" sz="1500" dirty="0"/>
           </a:p>
@@ -11088,7 +10995,46 @@
                   <a:schemeClr val="tx1"/>
                 </a:solidFill>
               </a:rPr>
-              <a:t>Eligibility criteria were written before screening began</a:t>
+              <a:t>8 of the 14 are one back muscle (lumbar multifidus)</a:t>
+            </a:r>
+            <a:endParaRPr lang="en-US" sz="1500" dirty="0"/>
+          </a:p>
+        </p:txBody>
+      </p:sp>
+      <p:sp>
+        <p:nvSpPr>
+          <p:cNvPr id="6" name="Text 4"/>
+          <p:cNvSpPr txBox="1"/>
+          <p:nvPr/>
+        </p:nvSpPr>
+        <p:spPr>
+          <a:xfrm>
+            <a:off x="548640" y="3703320"/>
+            <a:ext cx="5394960" cy="2377440"/>
+          </a:xfrm>
+          <a:prstGeom prst="rect">
+            <a:avLst/>
+          </a:prstGeom>
+          <a:noFill/>
+          <a:ln/>
+        </p:spPr>
+        <p:txBody>
+          <a:bodyPr wrap="square" lIns="0" tIns="0" rIns="0" bIns="0" rtlCol="0" anchor="t"/>
+          <a:lstStyle/>
+          <a:p>
+            <a:pPr indent="0" marL="0">
+              <a:spcAft>
+                <a:spcPts val="400"/>
+              </a:spcAft>
+              <a:buNone/>
+            </a:pPr>
+            <a:r>
+              <a:rPr lang="en-US" sz="1500" b="1" dirty="0">
+                <a:solidFill>
+                  <a:schemeClr val="tx2"/>
+                </a:solidFill>
+              </a:rPr>
+              <a:t>Mostly young men: does this apply to women and older crews?</a:t>
             </a:r>
             <a:endParaRPr lang="en-US" sz="1500" dirty="0"/>
           </a:p>
@@ -11106,7 +11052,7 @@
                   <a:schemeClr val="tx1"/>
                 </a:solidFill>
               </a:rPr>
-              <a:t>A rule-based triage sorted the records; one person then read the priority set and the top of the "maybe" set</a:t>
+              <a:t>Rows, not people: men only 567, mixed 113, women only 40 (35 of them WISE-2005), not reported 22</a:t>
             </a:r>
             <a:endParaRPr lang="en-US" sz="1500" dirty="0"/>
           </a:p>
@@ -11124,7 +11070,7 @@
                   <a:schemeClr val="tx1"/>
                 </a:solidFill>
               </a:rPr>
-              <a:t>No second screener</a:t>
+              <a:t>Healthy young 692, middle-aged 8, older 42: the results describe young men</a:t>
             </a:r>
             <a:endParaRPr lang="en-US" sz="1500" dirty="0"/>
           </a:p>
@@ -11132,13 +11078,13 @@
       </p:sp>
       <p:sp>
         <p:nvSpPr>
-          <p:cNvPr id="6" name="Text 4"/>
+          <p:cNvPr id="7" name="Text 5"/>
           <p:cNvSpPr txBox="1"/>
           <p:nvPr/>
         </p:nvSpPr>
         <p:spPr>
           <a:xfrm>
-            <a:off x="548640" y="3703320"/>
+            <a:off x="6217920" y="3703320"/>
             <a:ext cx="5394960" cy="2377440"/>
           </a:xfrm>
           <a:prstGeom prst="rect">
@@ -11163,7 +11109,7 @@
                   <a:schemeClr val="tx2"/>
                 </a:solidFill>
               </a:rPr>
-              <a:t>84 full texts but 52 studies: why so few?</a:t>
+              <a:t>What exactly is a row's percentage change?</a:t>
             </a:r>
             <a:endParaRPr lang="en-US" sz="1500" dirty="0"/>
           </a:p>
@@ -11181,7 +11127,7 @@
                   <a:schemeClr val="tx1"/>
                 </a:solidFill>
               </a:rPr>
-              <a:t>19 give muscle results only as charts, without a baseline value</a:t>
+              <a:t>Follow-up vs the same group's own baseline; negative means loss</a:t>
             </a:r>
             <a:endParaRPr lang="en-US" sz="1500" dirty="0"/>
           </a:p>
@@ -11199,7 +11145,7 @@
                   <a:schemeClr val="tx1"/>
                 </a:solidFill>
               </a:rPr>
-              <a:t>4 full texts not available (one conference abstract still used); 11 excluded at full text</a:t>
+              <a:t>Recomputed from the printed values; where a paper prints the mean of individual changes, that value is kept and labelled</a:t>
             </a:r>
             <a:endParaRPr lang="en-US" sz="1500" dirty="0"/>
           </a:p>
@@ -11217,100 +11163,7 @@
                   <a:schemeClr val="tx1"/>
                 </a:solidFill>
               </a:rPr>
-              <a:t>These counts are as recorded and still being reconciled with the dataset</a:t>
-            </a:r>
-            <a:endParaRPr lang="en-US" sz="1500" dirty="0"/>
-          </a:p>
-        </p:txBody>
-      </p:sp>
-      <p:sp>
-        <p:nvSpPr>
-          <p:cNvPr id="7" name="Text 5"/>
-          <p:cNvSpPr txBox="1"/>
-          <p:nvPr/>
-        </p:nvSpPr>
-        <p:spPr>
-          <a:xfrm>
-            <a:off x="6217920" y="3703320"/>
-            <a:ext cx="5394960" cy="2377440"/>
-          </a:xfrm>
-          <a:prstGeom prst="rect">
-            <a:avLst/>
-          </a:prstGeom>
-          <a:noFill/>
-          <a:ln/>
-        </p:spPr>
-        <p:txBody>
-          <a:bodyPr wrap="square" lIns="0" tIns="0" rIns="0" bIns="0" rtlCol="0" anchor="t"/>
-          <a:lstStyle/>
-          <a:p>
-            <a:pPr indent="0" marL="0">
-              <a:spcAft>
-                <a:spcPts val="400"/>
-              </a:spcAft>
-              <a:buNone/>
-            </a:pPr>
-            <a:r>
-              <a:rPr lang="en-US" sz="1500" b="1" dirty="0">
-                <a:solidFill>
-                  <a:schemeClr val="tx2"/>
-                </a:solidFill>
-              </a:rPr>
-              <a:t>Why search only from 2013?</a:t>
-            </a:r>
-            <a:endParaRPr lang="en-US" sz="1500" dirty="0"/>
-          </a:p>
-          <a:p>
-            <a:pPr marL="342900" indent="-342900">
-              <a:spcAft>
-                <a:spcPts val="400"/>
-              </a:spcAft>
-              <a:buSzPct val="100000"/>
-              <a:buChar char="•"/>
-            </a:pPr>
-            <a:r>
-              <a:rPr lang="en-US" sz="1400" dirty="0">
-                <a:solidFill>
-                  <a:schemeClr val="tx1"/>
-                </a:solidFill>
-              </a:rPr>
-              <a:t>The search was time-boxed to one week</a:t>
-            </a:r>
-            <a:endParaRPr lang="en-US" sz="1500" dirty="0"/>
-          </a:p>
-          <a:p>
-            <a:pPr marL="342900" indent="-342900">
-              <a:spcAft>
-                <a:spcPts val="400"/>
-              </a:spcAft>
-              <a:buSzPct val="100000"/>
-              <a:buChar char="•"/>
-            </a:pPr>
-            <a:r>
-              <a:rPr lang="en-US" sz="1400" dirty="0">
-                <a:solidFill>
-                  <a:schemeClr val="tx1"/>
-                </a:solidFill>
-              </a:rPr>
-              <a:t>Older work enters through 9 studies we held before the search; 6 of their campaigns would otherwise be missing</a:t>
-            </a:r>
-            <a:endParaRPr lang="en-US" sz="1500" dirty="0"/>
-          </a:p>
-          <a:p>
-            <a:pPr marL="342900" indent="-342900">
-              <a:spcAft>
-                <a:spcPts val="400"/>
-              </a:spcAft>
-              <a:buSzPct val="100000"/>
-              <a:buChar char="•"/>
-            </a:pPr>
-            <a:r>
-              <a:rPr lang="en-US" sz="1400" dirty="0">
-                <a:solidFill>
-                  <a:schemeClr val="tx1"/>
-                </a:solidFill>
-              </a:rPr>
-              <a:t>Both known modelling papers from after 2013 were found by all three journal databases</a:t>
+              <a:t>Rows weighted by number of participants: only 8 of 32 campaigns report the spread of the change</a:t>
             </a:r>
             <a:endParaRPr lang="en-US" sz="1500" dirty="0"/>
           </a:p>
@@ -11421,7 +11274,7 @@
                 <a:ea typeface="Cambria" pitchFamily="34" charset="-122"/>
                 <a:cs typeface="Cambria" pitchFamily="34" charset="-120"/>
               </a:rPr>
-              <a:t>Backup: dataset expansion and composition</a:t>
+              <a:t>Backup: certainty of the muscle-group curves</a:t>
             </a:r>
             <a:endParaRPr lang="en-US" sz="2800" dirty="0"/>
           </a:p>
@@ -11496,7 +11349,7 @@
                   <a:schemeClr val="tx2"/>
                 </a:solidFill>
               </a:rPr>
-              <a:t>The abstract had 15 studies. Did adding 37 change the analysis after seeing data?</a:t>
+              <a:t>Is each line fitted to its own muscle?</a:t>
             </a:r>
             <a:endParaRPr lang="en-US" sz="1500" dirty="0"/>
           </a:p>
@@ -11514,7 +11367,7 @@
                   <a:schemeClr val="tx1"/>
                 </a:solidFill>
               </a:rPr>
-              <a:t>Eligibility criteria were fixed before screening; the dataset was frozen (14 and 19 September) before the final models</a:t>
+              <a:t>No. The day-60 values are fitted per muscle group (named muscles, 25 campaigns); the lines share one time course (τ = 60 days)</a:t>
             </a:r>
             <a:endParaRPr lang="en-US" sz="1500" dirty="0"/>
           </a:p>
@@ -11532,7 +11385,7 @@
                   <a:schemeClr val="tx1"/>
                 </a:solidFill>
               </a:rPr>
-              <a:t>The curve shape was chosen by a rule declared before fitting</a:t>
+              <a:t>Separate shapes cannot be estimated: six of nine groups rest on four campaigns or fewer</a:t>
             </a:r>
             <a:endParaRPr lang="en-US" sz="1500" dirty="0"/>
           </a:p>
@@ -11571,7 +11424,7 @@
                   <a:schemeClr val="tx2"/>
                 </a:solidFill>
               </a:rPr>
-              <a:t>Slide 5 shows 180 days, but the model stops at day 119. Why?</a:t>
+              <a:t>Why a saturating curve?</a:t>
             </a:r>
             <a:endParaRPr lang="en-US" sz="1500" dirty="0"/>
           </a:p>
@@ -11589,7 +11442,7 @@
                   <a:schemeClr val="tx1"/>
                 </a:solidFill>
               </a:rPr>
-              <a:t>The 14 spaceflight rows were measured after landing, so they leave the model with the 264 recovery rows</a:t>
+              <a:t>Logarithmic, saturating and spline curves fit equally well (within 1.3 AIC points): the loss slows, but the data cannot say along which curve</a:t>
             </a:r>
             <a:endParaRPr lang="en-US" sz="1500" dirty="0"/>
           </a:p>
@@ -11607,7 +11460,7 @@
                   <a:schemeClr val="tx1"/>
                 </a:solidFill>
               </a:rPr>
-              <a:t>8 of the 14 are one back muscle (lumbar multifidus)</a:t>
+              <a:t>By day 119 the curve reaches 86% of its plateau, −17.3% (95% CI −20.9 to −13.7)</a:t>
             </a:r>
             <a:endParaRPr lang="en-US" sz="1500" dirty="0"/>
           </a:p>
@@ -11646,7 +11499,7 @@
                   <a:schemeClr val="tx2"/>
                 </a:solidFill>
               </a:rPr>
-              <a:t>Mostly young men: does this apply to women and older crews?</a:t>
+              <a:t>How certain are the day-60 values?</a:t>
             </a:r>
             <a:endParaRPr lang="en-US" sz="1500" dirty="0"/>
           </a:p>
@@ -11664,7 +11517,7 @@
                   <a:schemeClr val="tx1"/>
                 </a:solidFill>
               </a:rPr>
-              <a:t>Rows, not people: men only 567, mixed 113, women only 40 (35 of them WISE-2005), not reported 22</a:t>
+              <a:t>Calf −15.8% (95% CI −18.9 to −12.7); front thigh −10.1% (−13.6 to −6.6); hip rotators −1.9% (−3.9 to 0.2)</a:t>
             </a:r>
             <a:endParaRPr lang="en-US" sz="1500" dirty="0"/>
           </a:p>
@@ -11682,46 +11535,7 @@
                   <a:schemeClr val="tx1"/>
                 </a:solidFill>
               </a:rPr>
-              <a:t>Healthy young 692, middle-aged 8, older 42: the results describe young men</a:t>
-            </a:r>
-            <a:endParaRPr lang="en-US" sz="1500" dirty="0"/>
-          </a:p>
-        </p:txBody>
-      </p:sp>
-      <p:sp>
-        <p:nvSpPr>
-          <p:cNvPr id="7" name="Text 5"/>
-          <p:cNvSpPr txBox="1"/>
-          <p:nvPr/>
-        </p:nvSpPr>
-        <p:spPr>
-          <a:xfrm>
-            <a:off x="6217920" y="3703320"/>
-            <a:ext cx="5394960" cy="2377440"/>
-          </a:xfrm>
-          <a:prstGeom prst="rect">
-            <a:avLst/>
-          </a:prstGeom>
-          <a:noFill/>
-          <a:ln/>
-        </p:spPr>
-        <p:txBody>
-          <a:bodyPr wrap="square" lIns="0" tIns="0" rIns="0" bIns="0" rtlCol="0" anchor="t"/>
-          <a:lstStyle/>
-          <a:p>
-            <a:pPr indent="0" marL="0">
-              <a:spcAft>
-                <a:spcPts val="400"/>
-              </a:spcAft>
-              <a:buNone/>
-            </a:pPr>
-            <a:r>
-              <a:rPr lang="en-US" sz="1500" b="1" dirty="0">
-                <a:solidFill>
-                  <a:schemeClr val="tx2"/>
-                </a:solidFill>
-              </a:rPr>
-              <a:t>What exactly is a row's percentage change?</a:t>
+              <a:t>Calf vs shin, the ankle's opposing pair: 5.6 pp more loss (2.1 to 9.1), p = 0.003</a:t>
             </a:r>
             <a:endParaRPr lang="en-US" sz="1500" dirty="0"/>
           </a:p>
@@ -11739,7 +11553,46 @@
                   <a:schemeClr val="tx1"/>
                 </a:solidFill>
               </a:rPr>
-              <a:t>Follow-up vs the same group's own baseline; negative means loss</a:t>
+              <a:t>Hip rotators and outer hip: one campaign each</a:t>
+            </a:r>
+            <a:endParaRPr lang="en-US" sz="1500" dirty="0"/>
+          </a:p>
+        </p:txBody>
+      </p:sp>
+      <p:sp>
+        <p:nvSpPr>
+          <p:cNvPr id="7" name="Text 5"/>
+          <p:cNvSpPr txBox="1"/>
+          <p:nvPr/>
+        </p:nvSpPr>
+        <p:spPr>
+          <a:xfrm>
+            <a:off x="6217920" y="3703320"/>
+            <a:ext cx="5394960" cy="2377440"/>
+          </a:xfrm>
+          <a:prstGeom prst="rect">
+            <a:avLst/>
+          </a:prstGeom>
+          <a:noFill/>
+          <a:ln/>
+        </p:spPr>
+        <p:txBody>
+          <a:bodyPr wrap="square" lIns="0" tIns="0" rIns="0" bIns="0" rtlCol="0" anchor="t"/>
+          <a:lstStyle/>
+          <a:p>
+            <a:pPr indent="0" marL="0">
+              <a:spcAft>
+                <a:spcPts val="400"/>
+              </a:spcAft>
+              <a:buNone/>
+            </a:pPr>
+            <a:r>
+              <a:rPr lang="en-US" sz="1500" b="1" dirty="0">
+                <a:solidFill>
+                  <a:schemeClr val="tx2"/>
+                </a:solidFill>
+              </a:rPr>
+              <a:t>Is the calf result an artefact of how often it is scanned?</a:t>
             </a:r>
             <a:endParaRPr lang="en-US" sz="1500" dirty="0"/>
           </a:p>
@@ -11757,7 +11610,7 @@
                   <a:schemeClr val="tx1"/>
                 </a:solidFill>
               </a:rPr>
-              <a:t>Recomputed from the printed values; where a paper prints the mean of individual changes, that value is kept and labelled</a:t>
+              <a:t>The order holds after adjusting for duration, countermeasure group and imaging method</a:t>
             </a:r>
             <a:endParaRPr lang="en-US" sz="1500" dirty="0"/>
           </a:p>
@@ -11775,7 +11628,7 @@
                   <a:schemeClr val="tx1"/>
                 </a:solidFill>
               </a:rPr>
-              <a:t>Rows weighted by number of participants: only 8 of 32 campaigns report the spread of the change</a:t>
+              <a:t>Calf: 78 rows from 13 campaigns, the second best-covered group after the front thigh (86 rows, 22 campaigns)</a:t>
             </a:r>
             <a:endParaRPr lang="en-US" sz="1500" dirty="0"/>
           </a:p>
@@ -11886,7 +11739,7 @@
                 <a:ea typeface="Cambria" pitchFamily="34" charset="-122"/>
                 <a:cs typeface="Cambria" pitchFamily="34" charset="-120"/>
               </a:rPr>
-              <a:t>Backup: certainty of the muscle-group curves</a:t>
+              <a:t>Backup: significance and relevance of the LLM gain</a:t>
             </a:r>
             <a:endParaRPr lang="en-US" sz="2800" dirty="0"/>
           </a:p>
@@ -11961,7 +11814,7 @@
                   <a:schemeClr val="tx2"/>
                 </a:solidFill>
               </a:rPr>
-              <a:t>Is each line fitted to its own muscle?</a:t>
+              <a:t>Is 0.42 pp worth anything?</a:t>
             </a:r>
             <a:endParaRPr lang="en-US" sz="1500" dirty="0"/>
           </a:p>
@@ -11979,7 +11832,7 @@
                   <a:schemeClr val="tx1"/>
                 </a:solidFill>
               </a:rPr>
-              <a:t>No. The day-60 values are fitted per muscle group (named muscles, 25 campaigns); the lines share one time course (τ = 60 days)</a:t>
+              <a:t>It is 13% lower error than the curve (3.13 to 2.71 pp)</a:t>
             </a:r>
             <a:endParaRPr lang="en-US" sz="1500" dirty="0"/>
           </a:p>
@@ -11997,7 +11850,7 @@
                   <a:schemeClr val="tx1"/>
                 </a:solidFill>
               </a:rPr>
-              <a:t>Separate shapes cannot be estimated: six of nine groups rest on four campaigns or fewer</a:t>
+              <a:t>Small; we present it as a secondary finding</a:t>
             </a:r>
             <a:endParaRPr lang="en-US" sz="1500" dirty="0"/>
           </a:p>
@@ -12036,7 +11889,7 @@
                   <a:schemeClr val="tx2"/>
                 </a:solidFill>
               </a:rPr>
-              <a:t>Why a saturating curve?</a:t>
+              <a:t>20 of 32 campaigns is close to a coin flip</a:t>
             </a:r>
             <a:endParaRPr lang="en-US" sz="1500" dirty="0"/>
           </a:p>
@@ -12054,7 +11907,7 @@
                   <a:schemeClr val="tx1"/>
                 </a:solidFill>
               </a:rPr>
-              <a:t>Logarithmic, saturating and spline curves fit equally well (within 1.3 AIC points): the loss slows, but the data cannot say along which curve</a:t>
+              <a:t>Counting wins only: p = 0.22 (sign test)*</a:t>
             </a:r>
             <a:endParaRPr lang="en-US" sz="1500" dirty="0"/>
           </a:p>
@@ -12072,7 +11925,7 @@
                   <a:schemeClr val="tx1"/>
                 </a:solidFill>
               </a:rPr>
-              <a:t>By day 119 the curve reaches 86% of its plateau, −17.3% (95% CI −20.9 to −13.7)</a:t>
+              <a:t>Using the size of each win: mean gain 0.42 pp, 95% CI 0.13 to 0.73</a:t>
             </a:r>
             <a:endParaRPr lang="en-US" sz="1500" dirty="0"/>
           </a:p>
@@ -12111,7 +11964,7 @@
                   <a:schemeClr val="tx2"/>
                 </a:solidFill>
               </a:rPr>
-              <a:t>How certain are the day-60 values?</a:t>
+              <a:t>Does it rest on a few campaigns?</a:t>
             </a:r>
             <a:endParaRPr lang="en-US" sz="1500" dirty="0"/>
           </a:p>
@@ -12129,7 +11982,7 @@
                   <a:schemeClr val="tx1"/>
                 </a:solidFill>
               </a:rPr>
-              <a:t>Calf −15.8% (95% CI −18.9 to −12.7); front thigh −10.1% (−13.6 to −6.6); hip rotators −1.9% (−3.9 to 0.2)</a:t>
+              <a:t>3 long MRI campaigns (NASA SPRINT, Berlin BBR2-2, MEDES LTBR) give 56% of the gain; without them 0.20 pp, CI −0.01 to 0.43*</a:t>
             </a:r>
             <a:endParaRPr lang="en-US" sz="1500" dirty="0"/>
           </a:p>
@@ -12147,7 +12000,46 @@
                   <a:schemeClr val="tx1"/>
                 </a:solidFill>
               </a:rPr>
-              <a:t>Calf vs shin, the ankle's opposing pair: 5.6 pp more loss (2.1 to 9.1), p = 0.003</a:t>
+              <a:t>Only SPRINT is recognised, and with campaign details removed the LLM still wins there (3.79 vs 5.92 pp)</a:t>
+            </a:r>
+            <a:endParaRPr lang="en-US" sz="1500" dirty="0"/>
+          </a:p>
+        </p:txBody>
+      </p:sp>
+      <p:sp>
+        <p:nvSpPr>
+          <p:cNvPr id="7" name="Text 5"/>
+          <p:cNvSpPr txBox="1"/>
+          <p:nvPr/>
+        </p:nvSpPr>
+        <p:spPr>
+          <a:xfrm>
+            <a:off x="6217920" y="3703320"/>
+            <a:ext cx="5394960" cy="2377440"/>
+          </a:xfrm>
+          <a:prstGeom prst="rect">
+            <a:avLst/>
+          </a:prstGeom>
+          <a:noFill/>
+          <a:ln/>
+        </p:spPr>
+        <p:txBody>
+          <a:bodyPr wrap="square" lIns="0" tIns="0" rIns="0" bIns="0" rtlCol="0" anchor="t"/>
+          <a:lstStyle/>
+          <a:p>
+            <a:pPr indent="0" marL="0">
+              <a:spcAft>
+                <a:spcPts val="400"/>
+              </a:spcAft>
+              <a:buNone/>
+            </a:pPr>
+            <a:r>
+              <a:rPr lang="en-US" sz="1500" b="1" dirty="0">
+                <a:solidFill>
+                  <a:schemeClr val="tx2"/>
+                </a:solidFill>
+              </a:rPr>
+              <a:t>Did it read these papers in training? Was it added after the fact?</a:t>
             </a:r>
             <a:endParaRPr lang="en-US" sz="1500" dirty="0"/>
           </a:p>
@@ -12165,46 +12057,7 @@
                   <a:schemeClr val="tx1"/>
                 </a:solidFill>
               </a:rPr>
-              <a:t>Hip rotators and outer hip: one campaign each</a:t>
-            </a:r>
-            <a:endParaRPr lang="en-US" sz="1500" dirty="0"/>
-          </a:p>
-        </p:txBody>
-      </p:sp>
-      <p:sp>
-        <p:nvSpPr>
-          <p:cNvPr id="7" name="Text 5"/>
-          <p:cNvSpPr txBox="1"/>
-          <p:nvPr/>
-        </p:nvSpPr>
-        <p:spPr>
-          <a:xfrm>
-            <a:off x="6217920" y="3703320"/>
-            <a:ext cx="5394960" cy="2377440"/>
-          </a:xfrm>
-          <a:prstGeom prst="rect">
-            <a:avLst/>
-          </a:prstGeom>
-          <a:noFill/>
-          <a:ln/>
-        </p:spPr>
-        <p:txBody>
-          <a:bodyPr wrap="square" lIns="0" tIns="0" rIns="0" bIns="0" rtlCol="0" anchor="t"/>
-          <a:lstStyle/>
-          <a:p>
-            <a:pPr indent="0" marL="0">
-              <a:spcAft>
-                <a:spcPts val="400"/>
-              </a:spcAft>
-              <a:buNone/>
-            </a:pPr>
-            <a:r>
-              <a:rPr lang="en-US" sz="1500" b="1" dirty="0">
-                <a:solidFill>
-                  <a:schemeClr val="tx2"/>
-                </a:solidFill>
-              </a:rPr>
-              <a:t>Is the calf result an artefact of how often it is scanned?</a:t>
+              <a:t>Training exposure cannot be ruled out by any test; hiding campaign details and the naming test are the strongest checks available</a:t>
             </a:r>
             <a:endParaRPr lang="en-US" sz="1500" dirty="0"/>
           </a:p>
@@ -12222,27 +12075,45 @@
                   <a:schemeClr val="tx1"/>
                 </a:solidFill>
               </a:rPr>
-              <a:t>The order holds after adjusting for duration, countermeasure group and imaging method</a:t>
+              <a:t>Added after the ML result, but every check and target was committed before the first answer</a:t>
             </a:r>
             <a:endParaRPr lang="en-US" sz="1500" dirty="0"/>
           </a:p>
-          <a:p>
-            <a:pPr marL="342900" indent="-342900">
-              <a:spcAft>
-                <a:spcPts val="400"/>
-              </a:spcAft>
-              <a:buSzPct val="100000"/>
-              <a:buChar char="•"/>
-            </a:pPr>
-            <a:r>
-              <a:rPr lang="en-US" sz="1400" dirty="0">
-                <a:solidFill>
-                  <a:schemeClr val="tx1"/>
-                </a:solidFill>
-              </a:rPr>
-              <a:t>Calf: 78 rows from 13 campaigns, the second best-covered group after the front thigh (86 rows, 22 campaigns)</a:t>
-            </a:r>
-            <a:endParaRPr lang="en-US" sz="1500" dirty="0"/>
+        </p:txBody>
+      </p:sp>
+      <p:sp>
+        <p:nvSpPr>
+          <p:cNvPr id="8" name="Text 6"/>
+          <p:cNvSpPr txBox="1"/>
+          <p:nvPr/>
+        </p:nvSpPr>
+        <p:spPr>
+          <a:xfrm>
+            <a:off x="548640" y="6035040"/>
+            <a:ext cx="9144000" cy="274320"/>
+          </a:xfrm>
+          <a:prstGeom prst="rect">
+            <a:avLst/>
+          </a:prstGeom>
+          <a:noFill/>
+          <a:ln/>
+        </p:spPr>
+        <p:txBody>
+          <a:bodyPr wrap="square" lIns="0" tIns="0" rIns="0" bIns="0" rtlCol="0" anchor="t"/>
+          <a:lstStyle/>
+          <a:p>
+            <a:pPr indent="0" marL="0">
+              <a:buNone/>
+            </a:pPr>
+            <a:r>
+              <a:rPr lang="en-US" sz="1100" i="1" dirty="0">
+                <a:solidFill>
+                  <a:schemeClr val="accent3"/>
+                </a:solidFill>
+              </a:rPr>
+              <a:t>* Our calculation from the saved LLM predictions; not in the report.</a:t>
+            </a:r>
+            <a:endParaRPr lang="en-US" sz="1100" dirty="0"/>
           </a:p>
         </p:txBody>
       </p:sp>
@@ -13443,7 +13314,7 @@
                 <a:ea typeface="Cambria" pitchFamily="34" charset="-122"/>
                 <a:cs typeface="Cambria" pitchFamily="34" charset="-120"/>
               </a:rPr>
-              <a:t>Backup: significance and relevance of the LLM gain</a:t>
+              <a:t>Backup: ML results and fairness of the comparison</a:t>
             </a:r>
             <a:endParaRPr lang="en-US" sz="2800" dirty="0"/>
           </a:p>
@@ -13518,7 +13389,7 @@
                   <a:schemeClr val="tx2"/>
                 </a:solidFill>
               </a:rPr>
-              <a:t>Is 0.42 pp worth anything?</a:t>
+              <a:t>Did the ML models get a fair chance?</a:t>
             </a:r>
             <a:endParaRPr lang="en-US" sz="1500" dirty="0"/>
           </a:p>
@@ -13536,7 +13407,7 @@
                   <a:schemeClr val="tx1"/>
                 </a:solidFill>
               </a:rPr>
-              <a:t>It is 13% lower error than the curve (3.13 to 2.71 pp)</a:t>
+              <a:t>Tuned inside each training fold, grouped by campaign; TabPFN needs no tuning</a:t>
             </a:r>
             <a:endParaRPr lang="en-US" sz="1500" dirty="0"/>
           </a:p>
@@ -13554,7 +13425,7 @@
                   <a:schemeClr val="tx1"/>
                 </a:solidFill>
               </a:rPr>
-              <a:t>Small; we present it as a secondary finding</a:t>
+              <a:t>All models saw the same inputs, folds and scoring</a:t>
             </a:r>
             <a:endParaRPr lang="en-US" sz="1500" dirty="0"/>
           </a:p>
@@ -13593,7 +13464,7 @@
                   <a:schemeClr val="tx2"/>
                 </a:solidFill>
               </a:rPr>
-              <a:t>20 of 32 campaigns is close to a coin flip</a:t>
+              <a:t>Why not add age, sex or countermeasure type?</a:t>
             </a:r>
             <a:endParaRPr lang="en-US" sz="1500" dirty="0"/>
           </a:p>
@@ -13611,7 +13482,7 @@
                   <a:schemeClr val="tx1"/>
                 </a:solidFill>
               </a:rPr>
-              <a:t>Counting wins only: p = 0.22 (sign test)*</a:t>
+              <a:t>32 campaigns leave room for about 3 campaign-level inputs (about 10 campaigns per input)</a:t>
             </a:r>
             <a:endParaRPr lang="en-US" sz="1500" dirty="0"/>
           </a:p>
@@ -13629,7 +13500,7 @@
                   <a:schemeClr val="tx1"/>
                 </a:solidFill>
               </a:rPr>
-              <a:t>Using the size of each win: mean gain 0.42 pp, 95% CI 0.13 to 0.73</a:t>
+              <a:t>Age and sex are fixed within a campaign (271 of the 346 modelling rows men-only), so they act as a campaign label; 100 countermeasure rows spread over 9 types</a:t>
             </a:r>
             <a:endParaRPr lang="en-US" sz="1500" dirty="0"/>
           </a:p>
@@ -13668,7 +13539,7 @@
                   <a:schemeClr val="tx2"/>
                 </a:solidFill>
               </a:rPr>
-              <a:t>Does it rest on a few campaigns?</a:t>
+              <a:t>Is the duration curve a straw man?</a:t>
             </a:r>
             <a:endParaRPr lang="en-US" sz="1500" dirty="0"/>
           </a:p>
@@ -13686,7 +13557,7 @@
                   <a:schemeClr val="tx1"/>
                 </a:solidFill>
               </a:rPr>
-              <a:t>3 long MRI campaigns (NASA SPRINT, Berlin BBR2-2, MEDES LTBR) give 56% of the gain; without them 0.20 pp, CI −0.01 to 0.43*</a:t>
+              <a:t>Ridge regression uses days, muscle and every other input: 3.28 vs 3.16 pp</a:t>
             </a:r>
             <a:endParaRPr lang="en-US" sz="1500" dirty="0"/>
           </a:p>
@@ -13704,7 +13575,7 @@
                   <a:schemeClr val="tx1"/>
                 </a:solidFill>
               </a:rPr>
-              <a:t>Only SPRINT is recognised, and with campaign details removed the LLM still wins there (3.79 vs 5.92 pp)</a:t>
+              <a:t>Knowing the muscle raises R² but not the error on a new campaign</a:t>
             </a:r>
             <a:endParaRPr lang="en-US" sz="1500" dirty="0"/>
           </a:p>
@@ -13743,7 +13614,7 @@
                   <a:schemeClr val="tx2"/>
                 </a:solidFill>
               </a:rPr>
-              <a:t>Did it read these papers in training? Was it added after the fact?</a:t>
+              <a:t>Would a nearest-neighbour method match the LLM?</a:t>
             </a:r>
             <a:endParaRPr lang="en-US" sz="1500" dirty="0"/>
           </a:p>
@@ -13761,63 +13632,9 @@
                   <a:schemeClr val="tx1"/>
                 </a:solidFill>
               </a:rPr>
-              <a:t>Training exposure cannot be ruled out by any test; hiding campaign details and the naming test are the strongest checks available</a:t>
+              <a:t>Not tested. If the gain comes from picking similar rows, this is the next control to run</a:t>
             </a:r>
             <a:endParaRPr lang="en-US" sz="1500" dirty="0"/>
-          </a:p>
-          <a:p>
-            <a:pPr marL="342900" indent="-342900">
-              <a:spcAft>
-                <a:spcPts val="400"/>
-              </a:spcAft>
-              <a:buSzPct val="100000"/>
-              <a:buChar char="•"/>
-            </a:pPr>
-            <a:r>
-              <a:rPr lang="en-US" sz="1400" dirty="0">
-                <a:solidFill>
-                  <a:schemeClr val="tx1"/>
-                </a:solidFill>
-              </a:rPr>
-              <a:t>Added after the ML result, but every check and target was committed before the first answer</a:t>
-            </a:r>
-            <a:endParaRPr lang="en-US" sz="1500" dirty="0"/>
-          </a:p>
-        </p:txBody>
-      </p:sp>
-      <p:sp>
-        <p:nvSpPr>
-          <p:cNvPr id="8" name="Text 6"/>
-          <p:cNvSpPr txBox="1"/>
-          <p:nvPr/>
-        </p:nvSpPr>
-        <p:spPr>
-          <a:xfrm>
-            <a:off x="548640" y="6035040"/>
-            <a:ext cx="9144000" cy="274320"/>
-          </a:xfrm>
-          <a:prstGeom prst="rect">
-            <a:avLst/>
-          </a:prstGeom>
-          <a:noFill/>
-          <a:ln/>
-        </p:spPr>
-        <p:txBody>
-          <a:bodyPr wrap="square" lIns="0" tIns="0" rIns="0" bIns="0" rtlCol="0" anchor="t"/>
-          <a:lstStyle/>
-          <a:p>
-            <a:pPr indent="0" marL="0">
-              <a:buNone/>
-            </a:pPr>
-            <a:r>
-              <a:rPr lang="en-US" sz="1100" i="1" dirty="0">
-                <a:solidFill>
-                  <a:schemeClr val="accent3"/>
-                </a:solidFill>
-              </a:rPr>
-              <a:t>* Our calculation from the saved LLM predictions; not in the report.</a:t>
-            </a:r>
-            <a:endParaRPr lang="en-US" sz="1100" dirty="0"/>
           </a:p>
         </p:txBody>
       </p:sp>
@@ -13926,7 +13743,7 @@
                 <a:ea typeface="Cambria" pitchFamily="34" charset="-122"/>
                 <a:cs typeface="Cambria" pitchFamily="34" charset="-120"/>
               </a:rPr>
-              <a:t>Backup: ML results and fairness of the comparison</a:t>
+              <a:t>Backup: applicability to Mars mission planning</a:t>
             </a:r>
             <a:endParaRPr lang="en-US" sz="2800" dirty="0"/>
           </a:p>
@@ -14001,7 +13818,7 @@
                   <a:schemeClr val="tx2"/>
                 </a:solidFill>
               </a:rPr>
-              <a:t>Did the ML models get a fair chance?</a:t>
+              <a:t>A Mars transit is about 180 days; the data stop at 119</a:t>
             </a:r>
             <a:endParaRPr lang="en-US" sz="1500" dirty="0"/>
           </a:p>
@@ -14019,7 +13836,7 @@
                   <a:schemeClr val="tx1"/>
                 </a:solidFill>
               </a:rPr>
-              <a:t>Tuned inside each training fold, grouped by campaign; TabPFN needs no tuning</a:t>
+              <a:t>Only one campaign reaches 119 days</a:t>
             </a:r>
             <a:endParaRPr lang="en-US" sz="1500" dirty="0"/>
           </a:p>
@@ -14037,7 +13854,7 @@
                   <a:schemeClr val="tx1"/>
                 </a:solidFill>
               </a:rPr>
-              <a:t>All models saw the same inputs, folds and scoring</a:t>
+              <a:t>A 180-day estimate is planned from the duration curve only, with an uncertainty range, labelled as an assumption</a:t>
             </a:r>
             <a:endParaRPr lang="en-US" sz="1500" dirty="0"/>
           </a:p>
@@ -14076,7 +13893,7 @@
                   <a:schemeClr val="tx2"/>
                 </a:solidFill>
               </a:rPr>
-              <a:t>Why not add age, sex or countermeasure type?</a:t>
+              <a:t>Bed rest is not spaceflight</a:t>
             </a:r>
             <a:endParaRPr lang="en-US" sz="1500" dirty="0"/>
           </a:p>
@@ -14094,7 +13911,46 @@
                   <a:schemeClr val="tx1"/>
                 </a:solidFill>
               </a:rPr>
-              <a:t>32 campaigns leave room for about 3 campaign-level inputs (about 10 campaigns per input)</a:t>
+              <a:t>Only 14 spaceflight rows, 8 of them one back muscle: too few to test transfer</a:t>
+            </a:r>
+            <a:endParaRPr lang="en-US" sz="1500" dirty="0"/>
+          </a:p>
+        </p:txBody>
+      </p:sp>
+      <p:sp>
+        <p:nvSpPr>
+          <p:cNvPr id="6" name="Text 4"/>
+          <p:cNvSpPr txBox="1"/>
+          <p:nvPr/>
+        </p:nvSpPr>
+        <p:spPr>
+          <a:xfrm>
+            <a:off x="548640" y="3703320"/>
+            <a:ext cx="5394960" cy="2377440"/>
+          </a:xfrm>
+          <a:prstGeom prst="rect">
+            <a:avLst/>
+          </a:prstGeom>
+          <a:noFill/>
+          <a:ln/>
+        </p:spPr>
+        <p:txBody>
+          <a:bodyPr wrap="square" lIns="0" tIns="0" rIns="0" bIns="0" rtlCol="0" anchor="t"/>
+          <a:lstStyle/>
+          <a:p>
+            <a:pPr indent="0" marL="0">
+              <a:spcAft>
+                <a:spcPts val="400"/>
+              </a:spcAft>
+              <a:buNone/>
+            </a:pPr>
+            <a:r>
+              <a:rPr lang="en-US" sz="1500" b="1" dirty="0">
+                <a:solidFill>
+                  <a:schemeClr val="tx2"/>
+                </a:solidFill>
+              </a:rPr>
+              <a:t>Which countermeasure works? What about individuals?</a:t>
             </a:r>
             <a:endParaRPr lang="en-US" sz="1500" dirty="0"/>
           </a:p>
@@ -14112,46 +13968,7 @@
                   <a:schemeClr val="tx1"/>
                 </a:solidFill>
               </a:rPr>
-              <a:t>Age and sex are fixed within a campaign (271 of the 346 modelling rows men-only), so they act as a campaign label; 100 countermeasure rows spread over 9 types</a:t>
-            </a:r>
-            <a:endParaRPr lang="en-US" sz="1500" dirty="0"/>
-          </a:p>
-        </p:txBody>
-      </p:sp>
-      <p:sp>
-        <p:nvSpPr>
-          <p:cNvPr id="6" name="Text 4"/>
-          <p:cNvSpPr txBox="1"/>
-          <p:nvPr/>
-        </p:nvSpPr>
-        <p:spPr>
-          <a:xfrm>
-            <a:off x="548640" y="3703320"/>
-            <a:ext cx="5394960" cy="2377440"/>
-          </a:xfrm>
-          <a:prstGeom prst="rect">
-            <a:avLst/>
-          </a:prstGeom>
-          <a:noFill/>
-          <a:ln/>
-        </p:spPr>
-        <p:txBody>
-          <a:bodyPr wrap="square" lIns="0" tIns="0" rIns="0" bIns="0" rtlCol="0" anchor="t"/>
-          <a:lstStyle/>
-          <a:p>
-            <a:pPr indent="0" marL="0">
-              <a:spcAft>
-                <a:spcPts val="400"/>
-              </a:spcAft>
-              <a:buNone/>
-            </a:pPr>
-            <a:r>
-              <a:rPr lang="en-US" sz="1500" b="1" dirty="0">
-                <a:solidFill>
-                  <a:schemeClr val="tx2"/>
-                </a:solidFill>
-              </a:rPr>
-              <a:t>Is the duration curve a straw man?</a:t>
+              <a:t>Countermeasure groups lose 3.7 pp less (95% CI 1.5 to 5.9), all types pooled</a:t>
             </a:r>
             <a:endParaRPr lang="en-US" sz="1500" dirty="0"/>
           </a:p>
@@ -14169,7 +13986,46 @@
                   <a:schemeClr val="tx1"/>
                 </a:solidFill>
               </a:rPr>
-              <a:t>Ridge regression uses days, muscle and every other input: 3.28 vs 3.16 pp</a:t>
+              <a:t>Every row is a group average; nothing about individual risk</a:t>
+            </a:r>
+            <a:endParaRPr lang="en-US" sz="1500" dirty="0"/>
+          </a:p>
+        </p:txBody>
+      </p:sp>
+      <p:sp>
+        <p:nvSpPr>
+          <p:cNvPr id="7" name="Text 5"/>
+          <p:cNvSpPr txBox="1"/>
+          <p:nvPr/>
+        </p:nvSpPr>
+        <p:spPr>
+          <a:xfrm>
+            <a:off x="6217920" y="3703320"/>
+            <a:ext cx="5394960" cy="2377440"/>
+          </a:xfrm>
+          <a:prstGeom prst="rect">
+            <a:avLst/>
+          </a:prstGeom>
+          <a:noFill/>
+          <a:ln/>
+        </p:spPr>
+        <p:txBody>
+          <a:bodyPr wrap="square" lIns="0" tIns="0" rIns="0" bIns="0" rtlCol="0" anchor="t"/>
+          <a:lstStyle/>
+          <a:p>
+            <a:pPr indent="0" marL="0">
+              <a:spcAft>
+                <a:spcPts val="400"/>
+              </a:spcAft>
+              <a:buNone/>
+            </a:pPr>
+            <a:r>
+              <a:rPr lang="en-US" sz="1500" b="1" dirty="0">
+                <a:solidFill>
+                  <a:schemeClr val="tx2"/>
+                </a:solidFill>
+              </a:rPr>
+              <a:t>Can anyone reproduce an LLM result?</a:t>
             </a:r>
             <a:endParaRPr lang="en-US" sz="1500" dirty="0"/>
           </a:p>
@@ -14187,46 +14043,7 @@
                   <a:schemeClr val="tx1"/>
                 </a:solidFill>
               </a:rPr>
-              <a:t>Knowing the muscle raises R² but not the error on a new campaign</a:t>
-            </a:r>
-            <a:endParaRPr lang="en-US" sz="1500" dirty="0"/>
-          </a:p>
-        </p:txBody>
-      </p:sp>
-      <p:sp>
-        <p:nvSpPr>
-          <p:cNvPr id="7" name="Text 5"/>
-          <p:cNvSpPr txBox="1"/>
-          <p:nvPr/>
-        </p:nvSpPr>
-        <p:spPr>
-          <a:xfrm>
-            <a:off x="6217920" y="3703320"/>
-            <a:ext cx="5394960" cy="2377440"/>
-          </a:xfrm>
-          <a:prstGeom prst="rect">
-            <a:avLst/>
-          </a:prstGeom>
-          <a:noFill/>
-          <a:ln/>
-        </p:spPr>
-        <p:txBody>
-          <a:bodyPr wrap="square" lIns="0" tIns="0" rIns="0" bIns="0" rtlCol="0" anchor="t"/>
-          <a:lstStyle/>
-          <a:p>
-            <a:pPr indent="0" marL="0">
-              <a:spcAft>
-                <a:spcPts val="400"/>
-              </a:spcAft>
-              <a:buNone/>
-            </a:pPr>
-            <a:r>
-              <a:rPr lang="en-US" sz="1500" b="1" dirty="0">
-                <a:solidFill>
-                  <a:schemeClr val="tx2"/>
-                </a:solidFill>
-              </a:rPr>
-              <a:t>Would a nearest-neighbour method match the LLM?</a:t>
+              <a:t>Fixed model version; all 430 answers saved, so every number rebuilds without the model</a:t>
             </a:r>
             <a:endParaRPr lang="en-US" sz="1500" dirty="0"/>
           </a:p>
@@ -14244,7 +14061,7 @@
                   <a:schemeClr val="tx1"/>
                 </a:solidFill>
               </a:rPr>
-              <a:t>Not tested. If the gain comes from picking similar rows, this is the next control to run</a:t>
+              <a:t>Identical requests differ by 0.17 pp on average</a:t>
             </a:r>
             <a:endParaRPr lang="en-US" sz="1500" dirty="0"/>
           </a:p>
@@ -14290,435 +14107,6 @@
             <a:fld id="{F7021451-1387-4CA6-816F-3879F97B5CBC}" type="slidenum">
               <a:rPr b="0" lang="en-US"/>
               <a:t>21</a:t>
-            </a:fld>
-            <a:endParaRPr lang="en-US"/>
-          </a:p>
-        </p:txBody>
-      </p:sp>
-    </p:spTree>
-  </p:cSld>
-  <p:clrMapOvr>
-    <a:masterClrMapping/>
-  </p:clrMapOvr>
-</p:sld>
-</file>
-
-<file path=ppt/slides/slide22.xml><?xml version="1.0" encoding="utf-8"?>
-<p:sld xmlns:a="http://schemas.openxmlformats.org/drawingml/2006/main" xmlns:r="http://schemas.openxmlformats.org/officeDocument/2006/relationships" xmlns:p="http://schemas.openxmlformats.org/presentationml/2006/main">
-  <p:cSld name="Slide 22">
-    <p:spTree>
-      <p:nvGrpSpPr>
-        <p:cNvPr id="1" name=""/>
-        <p:cNvGrpSpPr/>
-        <p:nvPr/>
-      </p:nvGrpSpPr>
-      <p:grpSpPr>
-        <a:xfrm>
-          <a:off x="0" y="0"/>
-          <a:ext cx="0" cy="0"/>
-          <a:chOff x="0" y="0"/>
-          <a:chExt cx="0" cy="0"/>
-        </a:xfrm>
-      </p:grpSpPr>
-      <p:sp>
-        <p:nvSpPr>
-          <p:cNvPr id="2" name="Text 0"/>
-          <p:cNvSpPr/>
-          <p:nvPr>
-            <p:ph idx="101" type="title" hasCustomPrompt="1"/>
-          </p:nvPr>
-        </p:nvSpPr>
-        <p:spPr>
-          <a:xfrm>
-            <a:off x="548640" y="320040"/>
-            <a:ext cx="11064240" cy="731520"/>
-          </a:xfrm>
-          <a:prstGeom prst="rect">
-            <a:avLst/>
-          </a:prstGeom>
-          <a:noFill/>
-          <a:ln/>
-        </p:spPr>
-        <p:txBody>
-          <a:bodyPr wrap="square" lIns="0" tIns="0" rIns="0" bIns="0" rtlCol="0" anchor="ctr"/>
-          <a:lstStyle/>
-          <a:p>
-            <a:pPr algn="l" indent="0" marL="0">
-              <a:buNone/>
-            </a:pPr>
-            <a:r>
-              <a:rPr lang="en-US" sz="2800" b="1" dirty="0">
-                <a:solidFill>
-                  <a:schemeClr val="tx2"/>
-                </a:solidFill>
-                <a:latin typeface="Cambria" pitchFamily="34" charset="0"/>
-                <a:ea typeface="Cambria" pitchFamily="34" charset="-122"/>
-                <a:cs typeface="Cambria" pitchFamily="34" charset="-120"/>
-              </a:rPr>
-              <a:t>Backup: applicability to Mars mission planning</a:t>
-            </a:r>
-            <a:endParaRPr lang="en-US" sz="2800" dirty="0"/>
-          </a:p>
-        </p:txBody>
-      </p:sp>
-      <p:sp>
-        <p:nvSpPr>
-          <p:cNvPr id="3" name="Text 1"/>
-          <p:cNvSpPr txBox="1"/>
-          <p:nvPr/>
-        </p:nvSpPr>
-        <p:spPr>
-          <a:xfrm>
-            <a:off x="9784080" y="6355080"/>
-            <a:ext cx="1188720" cy="274320"/>
-          </a:xfrm>
-          <a:prstGeom prst="rect">
-            <a:avLst/>
-          </a:prstGeom>
-          <a:noFill/>
-          <a:ln/>
-        </p:spPr>
-        <p:txBody>
-          <a:bodyPr wrap="square" lIns="0" tIns="0" rIns="0" bIns="0" rtlCol="0" anchor="ctr"/>
-          <a:lstStyle/>
-          <a:p>
-            <a:pPr algn="r" indent="0" marL="0">
-              <a:buNone/>
-            </a:pPr>
-            <a:r>
-              <a:rPr lang="en-US" sz="1000" b="1" dirty="0">
-                <a:solidFill>
-                  <a:schemeClr val="accent3"/>
-                </a:solidFill>
-              </a:rPr>
-              <a:t>BACKUP</a:t>
-            </a:r>
-            <a:endParaRPr lang="en-US" sz="1000" dirty="0"/>
-          </a:p>
-        </p:txBody>
-      </p:sp>
-      <p:sp>
-        <p:nvSpPr>
-          <p:cNvPr id="4" name="Text 2"/>
-          <p:cNvSpPr txBox="1"/>
-          <p:nvPr/>
-        </p:nvSpPr>
-        <p:spPr>
-          <a:xfrm>
-            <a:off x="548640" y="1188720"/>
-            <a:ext cx="5394960" cy="2377440"/>
-          </a:xfrm>
-          <a:prstGeom prst="rect">
-            <a:avLst/>
-          </a:prstGeom>
-          <a:noFill/>
-          <a:ln/>
-        </p:spPr>
-        <p:txBody>
-          <a:bodyPr wrap="square" lIns="0" tIns="0" rIns="0" bIns="0" rtlCol="0" anchor="t"/>
-          <a:lstStyle/>
-          <a:p>
-            <a:pPr indent="0" marL="0">
-              <a:spcAft>
-                <a:spcPts val="400"/>
-              </a:spcAft>
-              <a:buNone/>
-            </a:pPr>
-            <a:r>
-              <a:rPr lang="en-US" sz="1500" b="1" dirty="0">
-                <a:solidFill>
-                  <a:schemeClr val="tx2"/>
-                </a:solidFill>
-              </a:rPr>
-              <a:t>A Mars transit is about 180 days; the data stop at 119</a:t>
-            </a:r>
-            <a:endParaRPr lang="en-US" sz="1500" dirty="0"/>
-          </a:p>
-          <a:p>
-            <a:pPr marL="342900" indent="-342900">
-              <a:spcAft>
-                <a:spcPts val="400"/>
-              </a:spcAft>
-              <a:buSzPct val="100000"/>
-              <a:buChar char="•"/>
-            </a:pPr>
-            <a:r>
-              <a:rPr lang="en-US" sz="1400" dirty="0">
-                <a:solidFill>
-                  <a:schemeClr val="tx1"/>
-                </a:solidFill>
-              </a:rPr>
-              <a:t>Only one campaign reaches 119 days</a:t>
-            </a:r>
-            <a:endParaRPr lang="en-US" sz="1500" dirty="0"/>
-          </a:p>
-          <a:p>
-            <a:pPr marL="342900" indent="-342900">
-              <a:spcAft>
-                <a:spcPts val="400"/>
-              </a:spcAft>
-              <a:buSzPct val="100000"/>
-              <a:buChar char="•"/>
-            </a:pPr>
-            <a:r>
-              <a:rPr lang="en-US" sz="1400" dirty="0">
-                <a:solidFill>
-                  <a:schemeClr val="tx1"/>
-                </a:solidFill>
-              </a:rPr>
-              <a:t>A 180-day estimate is planned from the duration curve only, with an uncertainty range, labelled as an assumption</a:t>
-            </a:r>
-            <a:endParaRPr lang="en-US" sz="1500" dirty="0"/>
-          </a:p>
-        </p:txBody>
-      </p:sp>
-      <p:sp>
-        <p:nvSpPr>
-          <p:cNvPr id="5" name="Text 3"/>
-          <p:cNvSpPr txBox="1"/>
-          <p:nvPr/>
-        </p:nvSpPr>
-        <p:spPr>
-          <a:xfrm>
-            <a:off x="6217920" y="1188720"/>
-            <a:ext cx="5394960" cy="2377440"/>
-          </a:xfrm>
-          <a:prstGeom prst="rect">
-            <a:avLst/>
-          </a:prstGeom>
-          <a:noFill/>
-          <a:ln/>
-        </p:spPr>
-        <p:txBody>
-          <a:bodyPr wrap="square" lIns="0" tIns="0" rIns="0" bIns="0" rtlCol="0" anchor="t"/>
-          <a:lstStyle/>
-          <a:p>
-            <a:pPr indent="0" marL="0">
-              <a:spcAft>
-                <a:spcPts val="400"/>
-              </a:spcAft>
-              <a:buNone/>
-            </a:pPr>
-            <a:r>
-              <a:rPr lang="en-US" sz="1500" b="1" dirty="0">
-                <a:solidFill>
-                  <a:schemeClr val="tx2"/>
-                </a:solidFill>
-              </a:rPr>
-              <a:t>Bed rest is not spaceflight</a:t>
-            </a:r>
-            <a:endParaRPr lang="en-US" sz="1500" dirty="0"/>
-          </a:p>
-          <a:p>
-            <a:pPr marL="342900" indent="-342900">
-              <a:spcAft>
-                <a:spcPts val="400"/>
-              </a:spcAft>
-              <a:buSzPct val="100000"/>
-              <a:buChar char="•"/>
-            </a:pPr>
-            <a:r>
-              <a:rPr lang="en-US" sz="1400" dirty="0">
-                <a:solidFill>
-                  <a:schemeClr val="tx1"/>
-                </a:solidFill>
-              </a:rPr>
-              <a:t>Only 14 spaceflight rows, 8 of them one back muscle: too few to test transfer</a:t>
-            </a:r>
-            <a:endParaRPr lang="en-US" sz="1500" dirty="0"/>
-          </a:p>
-        </p:txBody>
-      </p:sp>
-      <p:sp>
-        <p:nvSpPr>
-          <p:cNvPr id="6" name="Text 4"/>
-          <p:cNvSpPr txBox="1"/>
-          <p:nvPr/>
-        </p:nvSpPr>
-        <p:spPr>
-          <a:xfrm>
-            <a:off x="548640" y="3703320"/>
-            <a:ext cx="5394960" cy="2377440"/>
-          </a:xfrm>
-          <a:prstGeom prst="rect">
-            <a:avLst/>
-          </a:prstGeom>
-          <a:noFill/>
-          <a:ln/>
-        </p:spPr>
-        <p:txBody>
-          <a:bodyPr wrap="square" lIns="0" tIns="0" rIns="0" bIns="0" rtlCol="0" anchor="t"/>
-          <a:lstStyle/>
-          <a:p>
-            <a:pPr indent="0" marL="0">
-              <a:spcAft>
-                <a:spcPts val="400"/>
-              </a:spcAft>
-              <a:buNone/>
-            </a:pPr>
-            <a:r>
-              <a:rPr lang="en-US" sz="1500" b="1" dirty="0">
-                <a:solidFill>
-                  <a:schemeClr val="tx2"/>
-                </a:solidFill>
-              </a:rPr>
-              <a:t>Which countermeasure works? What about individuals?</a:t>
-            </a:r>
-            <a:endParaRPr lang="en-US" sz="1500" dirty="0"/>
-          </a:p>
-          <a:p>
-            <a:pPr marL="342900" indent="-342900">
-              <a:spcAft>
-                <a:spcPts val="400"/>
-              </a:spcAft>
-              <a:buSzPct val="100000"/>
-              <a:buChar char="•"/>
-            </a:pPr>
-            <a:r>
-              <a:rPr lang="en-US" sz="1400" dirty="0">
-                <a:solidFill>
-                  <a:schemeClr val="tx1"/>
-                </a:solidFill>
-              </a:rPr>
-              <a:t>Countermeasure groups lose 3.7 pp less (95% CI 1.5 to 5.9), all types pooled</a:t>
-            </a:r>
-            <a:endParaRPr lang="en-US" sz="1500" dirty="0"/>
-          </a:p>
-          <a:p>
-            <a:pPr marL="342900" indent="-342900">
-              <a:spcAft>
-                <a:spcPts val="400"/>
-              </a:spcAft>
-              <a:buSzPct val="100000"/>
-              <a:buChar char="•"/>
-            </a:pPr>
-            <a:r>
-              <a:rPr lang="en-US" sz="1400" dirty="0">
-                <a:solidFill>
-                  <a:schemeClr val="tx1"/>
-                </a:solidFill>
-              </a:rPr>
-              <a:t>Every row is a group average; nothing about individual risk</a:t>
-            </a:r>
-            <a:endParaRPr lang="en-US" sz="1500" dirty="0"/>
-          </a:p>
-        </p:txBody>
-      </p:sp>
-      <p:sp>
-        <p:nvSpPr>
-          <p:cNvPr id="7" name="Text 5"/>
-          <p:cNvSpPr txBox="1"/>
-          <p:nvPr/>
-        </p:nvSpPr>
-        <p:spPr>
-          <a:xfrm>
-            <a:off x="6217920" y="3703320"/>
-            <a:ext cx="5394960" cy="2377440"/>
-          </a:xfrm>
-          <a:prstGeom prst="rect">
-            <a:avLst/>
-          </a:prstGeom>
-          <a:noFill/>
-          <a:ln/>
-        </p:spPr>
-        <p:txBody>
-          <a:bodyPr wrap="square" lIns="0" tIns="0" rIns="0" bIns="0" rtlCol="0" anchor="t"/>
-          <a:lstStyle/>
-          <a:p>
-            <a:pPr indent="0" marL="0">
-              <a:spcAft>
-                <a:spcPts val="400"/>
-              </a:spcAft>
-              <a:buNone/>
-            </a:pPr>
-            <a:r>
-              <a:rPr lang="en-US" sz="1500" b="1" dirty="0">
-                <a:solidFill>
-                  <a:schemeClr val="tx2"/>
-                </a:solidFill>
-              </a:rPr>
-              <a:t>Can anyone reproduce an LLM result?</a:t>
-            </a:r>
-            <a:endParaRPr lang="en-US" sz="1500" dirty="0"/>
-          </a:p>
-          <a:p>
-            <a:pPr marL="342900" indent="-342900">
-              <a:spcAft>
-                <a:spcPts val="400"/>
-              </a:spcAft>
-              <a:buSzPct val="100000"/>
-              <a:buChar char="•"/>
-            </a:pPr>
-            <a:r>
-              <a:rPr lang="en-US" sz="1400" dirty="0">
-                <a:solidFill>
-                  <a:schemeClr val="tx1"/>
-                </a:solidFill>
-              </a:rPr>
-              <a:t>Fixed model version; all 430 answers saved, so every number rebuilds without the model</a:t>
-            </a:r>
-            <a:endParaRPr lang="en-US" sz="1500" dirty="0"/>
-          </a:p>
-          <a:p>
-            <a:pPr marL="342900" indent="-342900">
-              <a:spcAft>
-                <a:spcPts val="400"/>
-              </a:spcAft>
-              <a:buSzPct val="100000"/>
-              <a:buChar char="•"/>
-            </a:pPr>
-            <a:r>
-              <a:rPr lang="en-US" sz="1400" dirty="0">
-                <a:solidFill>
-                  <a:schemeClr val="tx1"/>
-                </a:solidFill>
-              </a:rPr>
-              <a:t>Identical requests differ by 0.17 pp on average</a:t>
-            </a:r>
-            <a:endParaRPr lang="en-US" sz="1500" dirty="0"/>
-          </a:p>
-        </p:txBody>
-      </p:sp>
-      <p:sp>
-        <p:nvSpPr>
-          <p:cNvPr id="25" name="Slide Number Placeholder 0"/>
-          <p:cNvSpPr>
-            <a:spLocks noGrp="1"/>
-          </p:cNvSpPr>
-          <p:nvPr>
-            <p:ph type="sldNum" sz="quarter" idx="4294967295"/>
-          </p:nvPr>
-        </p:nvSpPr>
-        <p:spPr>
-          <a:xfrm>
-            <a:off x="11155680" y="6355080"/>
-            <a:ext cx="457200" cy="274320"/>
-          </a:xfrm>
-          <a:prstGeom prst="rect">
-            <a:avLst/>
-          </a:prstGeom>
-          <a:extLst>
-            <a:ext uri="{C572A759-6A51-4108-AA02-DFA0A04FC94B}">
-              <ma14:wrappingTextBoxFlag xmlns:ma14="http://schemas.microsoft.com/office/mac/drawingml/2011/main" val="0"/>
-            </a:ext>
-          </a:extLst>
-        </p:spPr>
-        <p:txBody>
-          <a:bodyPr/>
-          <a:lstStyle>
-            <a:lvl1pPr>
-              <a:defRPr sz="1000">
-                <a:solidFill>
-                  <a:schemeClr val="accent3"/>
-                </a:solidFill>
-              </a:defRPr>
-            </a:lvl1pPr>
-          </a:lstStyle>
-          <a:p>
-            <a:pPr algn="r"/>
-            <a:fld id="{F7021451-1387-4CA6-816F-3879F97B5CBC}" type="slidenum">
-              <a:rPr b="0" lang="en-US"/>
-              <a:t>22</a:t>
             </a:fld>
             <a:endParaRPr lang="en-US"/>
           </a:p>

</xml_diff>

<commit_message>
Slide 6: count the 1,023 unscreened records with the exclusions
Co-Authored-By: Claude Opus 5.5 (1M context) <noreply@anthropic.com>
Claude-Session: https://claude.ai/code/session_01JZtuYERhuCe7nB9VYHwcfv
</commit_message>
<xml_diff>
--- a/presentation/bed-rest-to-mars-talk.pptx
+++ b/presentation/bed-rest-to-mars-talk.pptx
@@ -127,14 +127,14 @@
   <p:extLst>
     <p:ext uri="{521415D9-36F7-43E2-AB2F-B90AF26B5E84}">
       <p14:sectionLst xmlns:p14="http://schemas.microsoft.com/office/powerpoint/2010/main">
-        <p14:section name="Opening" id="{5b2e7efd-b591-4e93-6056-2e08e54cbaba}">
+        <p14:section name="Opening" id="{73e27190-7d75-5ae6-4fc8-671c63efa8cf}">
           <p14:sldIdLst>
             <p14:sldId id="256"/>
             <p14:sldId id="257"/>
             <p14:sldId id="269"/>
           </p14:sldIdLst>
         </p14:section>
-        <p14:section name="Part 1" id="{318e3589-0fb6-613a-fe48-43be1782e14d}">
+        <p14:section name="Part 1" id="{4ae507ea-faa7-3cc8-4e9a-80fa99e52fae}">
           <p14:sldIdLst>
             <p14:sldId id="258"/>
             <p14:sldId id="259"/>
@@ -144,7 +144,7 @@
             <p14:sldId id="263"/>
           </p14:sldIdLst>
         </p14:section>
-        <p14:section name="Part 2" id="{11f8fe13-e838-8bb1-82a6-603fbcf7080e}">
+        <p14:section name="Part 2" id="{4a5a8499-9bb3-c2c4-5d7c-9c7b3139de41}">
           <p14:sldIdLst>
             <p14:sldId id="264"/>
             <p14:sldId id="265"/>
@@ -153,10 +153,10 @@
             <p14:sldId id="268"/>
           </p14:sldIdLst>
         </p14:section>
-        <p14:section name="Opening" id="{6e1a713f-666e-06db-7fbe-12358afc1726}">
+        <p14:section name="Opening" id="{7cb78df6-81d7-112c-a8ec-b1d21830bc72}">
           <p14:sldIdLst/>
         </p14:section>
-        <p14:section name="Backup" id="{0e3c7913-d825-b7ef-edcc-daf4454785cd}">
+        <p14:section name="Backup" id="{b5ca61b4-2f4b-3932-a09a-9d5634aee94a}">
           <p14:sldIdLst>
             <p14:sldId id="270"/>
             <p14:sldId id="271"/>
@@ -167,22 +167,22 @@
             <p14:sldId id="276"/>
           </p14:sldIdLst>
         </p14:section>
-        <p14:section name="Backup" id="{8fb47547-3ec1-deb7-13d4-2c814546d454}">
+        <p14:section name="Backup" id="{6fb8db39-badc-bf63-fd2e-ae6424000f3e}">
           <p14:sldIdLst/>
         </p14:section>
-        <p14:section name="Backup" id="{071c6169-074b-613f-66ca-d0b3231fe3b1}">
+        <p14:section name="Backup" id="{cc79a993-a745-164c-f23c-52e9cb70a7ad}">
           <p14:sldIdLst/>
         </p14:section>
-        <p14:section name="Backup" id="{9efe4c1d-47a7-ff20-7340-c9b3116da5b2}">
+        <p14:section name="Backup" id="{cb87b11a-1408-ce61-8aa7-75bb61e0a084}">
           <p14:sldIdLst/>
         </p14:section>
-        <p14:section name="Backup" id="{59787599-f5be-45c0-cfa3-97f0adafc154}">
+        <p14:section name="Backup" id="{aab8d5a4-2aba-b7f9-0a66-584a6ee78edb}">
           <p14:sldIdLst/>
         </p14:section>
-        <p14:section name="Backup" id="{b549ca3d-5aa2-9626-2fdc-f4d6ade563d9}">
+        <p14:section name="Backup" id="{67f1d8d0-e89a-e540-5591-3d8529d63472}">
           <p14:sldIdLst/>
         </p14:section>
-        <p14:section name="Backup" id="{5f27dd35-ab38-6611-0d13-7d58b3d9ee28}">
+        <p14:section name="Backup" id="{f01d780d-881c-859d-d804-7e66c5c6fbfd}">
           <p14:sldIdLst/>
         </p14:section>
       </p14:sectionLst>
@@ -4454,7 +4454,7 @@
             <a:r>
               <a:rPr lang="en-US" dirty="0"/>
               <a:t>Part 1 (Niloufar), about one minute.
-We searched four databases, PubMed, Scopus, Web of Science and NASA's technical reports, and added older work we had collected before the search, nine studies from before 2013 and one campaign from NASA's open bed-rest data. In total, 5,741 records. After removing duplicates, 3,600 records remained. 2,493 were excluded, mostly because they did not use an unloading model or did not measure muscle, and 1,023 could not be screened in the time we had, so they did not go further.
+We searched four databases, PubMed, Scopus, Web of Science and NASA's technical reports, and added older work we had collected before the search, nine studies from before 2013 and one campaign from NASA's open bed-rest data. In total, 5,741 records. After removing duplicates, 3,600 records remained, and 3,516 were excluded at this stage. If asked: 2,493 were excluded on title and abstract, mostly for no unloading model or no muscle outcome; the other 1,023 were not screened in the time available and did not go further.
 We sought 84 full texts. The main loss at this step: 19 studies show their muscle results only as charts, without a baseline value, so we could not extract them; 4 full texts were not available and 11 were excluded. These full-text counts are as recorded in our screening log and are still being reconciled with the dataset, so do not claim they add up exactly. 52 studies were included.
 Several papers often report the same bed-rest campaign, so we merged papers on the same cohort. The final dataset has 36 independent campaigns and 742 rows.</a:t>
             </a:r>
@@ -8890,7 +8890,7 @@
                   <a:schemeClr val="tx1"/>
                 </a:solidFill>
               </a:rPr>
-              <a:t>Not covered: Embase (no access); 1,023 records not screened in time (slide 6)</a:t>
+              <a:t>Not covered: Embase (no access)</a:t>
             </a:r>
             <a:endParaRPr lang="en-US" sz="1500" dirty="0"/>
           </a:p>
@@ -19734,21 +19734,7 @@
                   <a:schemeClr val="accent3"/>
                 </a:solidFill>
               </a:rPr>
-              <a:t>2,493 excluded, mostly no unloading model or no muscle outcome</a:t>
-            </a:r>
-            <a:endParaRPr lang="en-US" sz="1100" dirty="0"/>
-          </a:p>
-          <a:p>
-            <a:pPr algn="ctr" indent="0" marL="0">
-              <a:buNone/>
-            </a:pPr>
-            <a:r>
-              <a:rPr lang="en-US" sz="1100" dirty="0">
-                <a:solidFill>
-                  <a:schemeClr val="accent3"/>
-                </a:solidFill>
-              </a:rPr>
-              <a:t>1,023 not screened in time</a:t>
+              <a:t>3,516 excluded</a:t>
             </a:r>
             <a:endParaRPr lang="en-US" sz="1100" dirty="0"/>
           </a:p>

</xml_diff>

<commit_message>
Deck: plain-language pass on slide text from a listener's view
Co-Authored-By: Claude Opus 5.5 (1M context) <noreply@anthropic.com>
Claude-Session: https://claude.ai/code/session_01JZtuYERhuCe7nB9VYHwcfv
</commit_message>
<xml_diff>
--- a/presentation/bed-rest-to-mars-talk.pptx
+++ b/presentation/bed-rest-to-mars-talk.pptx
@@ -127,14 +127,14 @@
   <p:extLst>
     <p:ext uri="{521415D9-36F7-43E2-AB2F-B90AF26B5E84}">
       <p14:sectionLst xmlns:p14="http://schemas.microsoft.com/office/powerpoint/2010/main">
-        <p14:section name="Opening" id="{73e27190-7d75-5ae6-4fc8-671c63efa8cf}">
+        <p14:section name="Opening" id="{c6039182-a584-9b83-9d52-95677517c382}">
           <p14:sldIdLst>
             <p14:sldId id="256"/>
             <p14:sldId id="257"/>
             <p14:sldId id="269"/>
           </p14:sldIdLst>
         </p14:section>
-        <p14:section name="Part 1" id="{4ae507ea-faa7-3cc8-4e9a-80fa99e52fae}">
+        <p14:section name="Part 1" id="{20de4196-23af-ee4f-3080-1758558fc264}">
           <p14:sldIdLst>
             <p14:sldId id="258"/>
             <p14:sldId id="259"/>
@@ -144,7 +144,7 @@
             <p14:sldId id="263"/>
           </p14:sldIdLst>
         </p14:section>
-        <p14:section name="Part 2" id="{4a5a8499-9bb3-c2c4-5d7c-9c7b3139de41}">
+        <p14:section name="Part 2" id="{a998b75a-0434-82c2-9c76-556f0f9b9732}">
           <p14:sldIdLst>
             <p14:sldId id="264"/>
             <p14:sldId id="265"/>
@@ -153,10 +153,10 @@
             <p14:sldId id="268"/>
           </p14:sldIdLst>
         </p14:section>
-        <p14:section name="Opening" id="{7cb78df6-81d7-112c-a8ec-b1d21830bc72}">
+        <p14:section name="Opening" id="{32c02aab-ac61-1308-df37-aa986ff4a26b}">
           <p14:sldIdLst/>
         </p14:section>
-        <p14:section name="Backup" id="{b5ca61b4-2f4b-3932-a09a-9d5634aee94a}">
+        <p14:section name="Backup" id="{5cd04eb8-87f7-abd8-7e71-d139912d95fc}">
           <p14:sldIdLst>
             <p14:sldId id="270"/>
             <p14:sldId id="271"/>
@@ -167,22 +167,22 @@
             <p14:sldId id="276"/>
           </p14:sldIdLst>
         </p14:section>
-        <p14:section name="Backup" id="{6fb8db39-badc-bf63-fd2e-ae6424000f3e}">
+        <p14:section name="Backup" id="{4a61b26b-85d1-c1b8-5768-5467916a4bb6}">
           <p14:sldIdLst/>
         </p14:section>
-        <p14:section name="Backup" id="{cc79a993-a745-164c-f23c-52e9cb70a7ad}">
+        <p14:section name="Backup" id="{bf2706ef-0d94-e94e-6274-502c5d7feea7}">
           <p14:sldIdLst/>
         </p14:section>
-        <p14:section name="Backup" id="{cb87b11a-1408-ce61-8aa7-75bb61e0a084}">
+        <p14:section name="Backup" id="{b3f1d89b-cae6-db19-b719-4d90dae6da08}">
           <p14:sldIdLst/>
         </p14:section>
-        <p14:section name="Backup" id="{aab8d5a4-2aba-b7f9-0a66-584a6ee78edb}">
+        <p14:section name="Backup" id="{67918eca-7e20-7dad-93a0-9a667cad40dc}">
           <p14:sldIdLst/>
         </p14:section>
-        <p14:section name="Backup" id="{67f1d8d0-e89a-e540-5591-3d8529d63472}">
+        <p14:section name="Backup" id="{45516639-b8df-f207-f4b3-e3b952a41f7d}">
           <p14:sldIdLst/>
         </p14:section>
-        <p14:section name="Backup" id="{f01d780d-881c-859d-d804-7e66c5c6fbfd}">
+        <p14:section name="Backup" id="{c1b1da5d-60a2-9e50-cd61-f3f96a370b1c}">
           <p14:sldIdLst/>
         </p14:section>
       </p14:sectionLst>
@@ -3300,8 +3300,8 @@
             <a:r>
               <a:rPr lang="en-US" dirty="0"/>
               <a:t>About thirty seconds.
-With 32 independent campaigns, standard ML models and TabPFN do not beat a curve that only knows the number of days. An LLM-based probabilistic classifier that reads each campaign's description and the other campaigns' data reduces the error from 3.13 to 2.71 points. The main limitation is the small sample of 32 campaigns, mostly young men, with no bed-rest data beyond day 119. Stress this: every row is a group average, so the model predicts the average loss of a group of volunteers. It cannot yet predict the risk for an individual astronaut.
-Further work has three steps. First, estimate how susceptible each muscle is relative to a reference muscle, and combine those coefficients with baseline muscle volumes to estimate total lower-limb volume loss; the dataset has 30 group time points where three or more muscles were scanned together, across 14 campaigns, so this can be tested. Second, move from group averages to individuals with participant-level data over time, and link muscle loss to strength and function. Third, validate on independent campaigns and on spaceflight data before building any personal risk-assessment tool. These are plans, not results.</a:t>
+With 32 independent campaigns, standard ML models and TabPFN do not beat a curve that only knows the number of days. An LLM-based probabilistic classifier that reads each campaign's description and the other campaigns' data reduces the error from 3.13 to 2.71 points. The main limitation is the small sample of 32 campaigns, mostly young men, with no bed-rest data beyond day 119. Every row is a group average, so the model predicts the average loss of a group of volunteers. It cannot yet predict the risk for an individual astronaut.
+Further work has three steps. First, estimate how susceptible each muscle is relative to a reference muscle, and combine those coefficients with baseline muscle volumes to estimate total lower-limb volume loss; the dataset has 30 group time points where three or more muscles were scanned together, across 14 campaigns, so this can be tested. Second, move from group averages to individuals with participant-level data over time, and link muscle loss to strength and function. Third, validate on independent campaigns and on spaceflight data before building any personal risk-assessment tool.</a:t>
             </a:r>
             <a:endParaRPr lang="en-US" dirty="0"/>
           </a:p>
@@ -4275,7 +4275,7 @@
               <a:t>Part 1 (Niloufar), about forty-five seconds.
 Direct spaceflight data on muscle are scarce, so we use head-down bed rest, the standard ground analogue: volunteers lie tilted six degrees head-down and their legs carry no weight, under controlled conditions. Bed rest is not the same as spaceflight, but it is a sound starting point to build and test prediction models.
 Mars in our title stands for the long-term application. The panel compares the two missions on one time scale. A Moon mission lasted about twelve days, and the crew could be home in three. A Mars mission takes about two and a half years: six months to get there, about five hundred days on the surface, six months back. There is no early return in an emergency, and after six months in weightlessness the crew must leave the spacecraft and work on the surface. Mission figures: Apollo 17, and NASA's Mars Design Reference Architecture 5.0.
-The bottom row is the idea: atrophy prediction, together with strength and power testing, could one day help keep the crew ready for work on arrival. The dashed steps are future use, and applying the model on a real mission needs validation with spaceflight data first.</a:t>
+In the bottom row, atrophy prediction, together with strength and power testing, could one day help keep the crew ready for work on arrival. The dashed steps are future use, and applying the model on a real mission needs validation with spaceflight data first.</a:t>
             </a:r>
             <a:endParaRPr lang="en-US" dirty="0"/>
           </a:p>
@@ -4455,7 +4455,7 @@
               <a:rPr lang="en-US" dirty="0"/>
               <a:t>Part 1 (Niloufar), about one minute.
 We searched four databases, PubMed, Scopus, Web of Science and NASA's technical reports, and added older work we had collected before the search, nine studies from before 2013 and one campaign from NASA's open bed-rest data. In total, 5,741 records. After removing duplicates, 3,600 records remained, and 3,516 were excluded at this stage. If asked: 2,493 were excluded on title and abstract, mostly for no unloading model or no muscle outcome; the other 1,023 were not screened in the time available and did not go further.
-We sought 84 full texts. The main loss at this step: 19 studies show their muscle results only as charts, without a baseline value, so we could not extract them; 4 full texts were not available and 11 were excluded. These full-text counts are as recorded in our screening log and are still being reconciled with the dataset, so do not claim they add up exactly. 52 studies were included.
+We sought 84 full texts. Most were lost because 19 studies show their muscle results only as charts, without a baseline value, so we could not extract them; 4 full texts were not available and 11 were excluded. These full-text counts are as recorded in our screening log and are still being reconciled with the dataset, so do not claim they add up exactly. 52 studies were included.
 Several papers often report the same bed-rest campaign, so we merged papers on the same cohort. The final dataset has 36 independent campaigns and 742 rows.</a:t>
             </a:r>
             <a:endParaRPr lang="en-US" dirty="0"/>
@@ -4637,7 +4637,7 @@
             <a:r>
               <a:rPr lang="en-US" dirty="0"/>
               <a:t>Part 1 (Niloufar), about one minute.
-No, muscles are not affected equally. Each line shows how much a muscle group shrinks over the days of bed rest, for groups without a countermeasure. The dashed line reads the values at day 60.
+Muscles do not lose size equally. Each line shows how much a muscle group shrinks over the days of bed rest, for groups without a countermeasure. The dashed line reads the values at day 60.
 The calf, the plantar flexors, loses most: about 16 percent at day 60, almost 6 percentage points more than the front thigh. The shin, the front thigh and the back thigh lose about 10 percent. Hip muscles lose least.
 How the lines are drawn: the day-60 values are the estimates of our meta-regression for each muscle group. The shape over time is the one curve the model fits to all muscles, rising fast in the first weeks and levelling off; time constant 60 days. Hip rotators and outer hip rest on a single campaign each, so treat those two with care.</a:t>
             </a:r>
@@ -6478,7 +6478,7 @@
                   <a:schemeClr val="accent3"/>
                 </a:solidFill>
               </a:rPr>
-              <a:t>Not a chat model: it is built for classification and returns only a probability for each listed option, never free text.</a:t>
+              <a:t>A classifier: it returns one probability per listed option and never writes text.</a:t>
             </a:r>
             <a:endParaRPr lang="en-US" sz="1100" dirty="0"/>
           </a:p>
@@ -6534,7 +6534,7 @@
                   <a:schemeClr val="tx1"/>
                 </a:solidFill>
               </a:rPr>
-              <a:t>Our code averages the range midpoints, weighted by probability (open ends count as −31% and +5%): −6.6%</a:t>
+              <a:t>Prediction −6.6%: range midpoints weighted by probability (open ends −31% and +5%)</a:t>
             </a:r>
             <a:endParaRPr lang="en-US" sz="1300" dirty="0"/>
           </a:p>
@@ -6552,7 +6552,7 @@
                   <a:schemeClr val="tx1"/>
                 </a:solidFill>
               </a:rPr>
-              <a:t>Measured: −9.4%, an error of 2.8 pp, a typical row</a:t>
+              <a:t>Measured −9.4%: error 2.8 pp, the median error</a:t>
             </a:r>
             <a:endParaRPr lang="en-US" sz="1300" dirty="0"/>
           </a:p>
@@ -6588,7 +6588,7 @@
                   <a:schemeClr val="tx1"/>
                 </a:solidFill>
               </a:rPr>
-              <a:t>Never sent (checked on every request): </a:t>
+              <a:t>Never sent, checked on every request: </a:t>
             </a:r>
             <a:pPr indent="0" marL="0">
               <a:buNone/>
@@ -6599,7 +6599,7 @@
                   <a:schemeClr val="tx1"/>
                 </a:solidFill>
               </a:rPr>
-              <a:t>the held-out campaign's measurements, and any paper, author or campaign name. All 430 answers are saved, so every result can be rebuilt without calling the model again.</a:t>
+              <a:t>the held-out campaign's measurements, and any paper, author or campaign name. All 430 answers are saved, and every result rebuilds from them.</a:t>
             </a:r>
             <a:endParaRPr lang="en-US" sz="1300" dirty="0"/>
           </a:p>
@@ -7039,7 +7039,7 @@
                   <a:schemeClr val="tx1"/>
                 </a:solidFill>
               </a:rPr>
-              <a:t>ML models explain more of the differences (R² 0.27 to 0.39), but none has lower error than the curve.</a:t>
+              <a:t>ML models explain more variance (R² 0.27 to 0.39), but none has lower error than the curve.</a:t>
             </a:r>
             <a:endParaRPr lang="en-US" sz="1400" dirty="0"/>
           </a:p>
@@ -7075,7 +7075,7 @@
                   <a:schemeClr val="tx1"/>
                 </a:solidFill>
               </a:rPr>
-              <a:t>95% confidence interval of that difference: 0.13 to 0.73 pp. The whole range is above zero, so it is unlikely to be luck.</a:t>
+              <a:t>95% confidence interval of that difference: 0.13 to 0.73 pp, entirely above zero.</a:t>
             </a:r>
             <a:endParaRPr lang="en-US" sz="1400" dirty="0"/>
           </a:p>
@@ -7111,7 +7111,7 @@
                   <a:schemeClr val="accent3"/>
                 </a:solidFill>
               </a:rPr>
-              <a:t>The curve shows 3.13 pp here, not 3.16, because the comparison scores it exactly as it scores the LLM.</a:t>
+              <a:t>In the paired comparison the curve is scored exactly as the LLM is, which gives 3.13 pp instead of 3.16.</a:t>
             </a:r>
             <a:endParaRPr lang="en-US" sz="1100" dirty="0"/>
           </a:p>
@@ -7515,7 +7515,7 @@
                   <a:schemeClr val="accent3"/>
                 </a:solidFill>
               </a:rPr>
-              <a:t>Gain = how much smaller the LLM's error is than the curve's, in pp (full result: 0.42). Each check and its pass rule were fixed before running it.</a:t>
+              <a:t>Gain: reduction in error against the curve, in pp (full result 0.42). Each check and its pass rule were fixed before it was run.</a:t>
             </a:r>
             <a:endParaRPr lang="en-US" sz="1300" dirty="0"/>
           </a:p>
@@ -7551,7 +7551,7 @@
                   <a:schemeClr val="tx2"/>
                 </a:solidFill>
               </a:rPr>
-              <a:t>Does it recognise a known campaign?</a:t>
+              <a:t>Recognition of a known campaign</a:t>
             </a:r>
             <a:endParaRPr lang="en-US" sz="1600" dirty="0"/>
           </a:p>
@@ -7604,7 +7604,7 @@
                   <a:schemeClr val="tx2"/>
                 </a:solidFill>
               </a:rPr>
-              <a:t>Does it use the other campaigns' data?</a:t>
+              <a:t>Use of the other campaigns' data</a:t>
             </a:r>
             <a:endParaRPr lang="en-US" sz="1600" dirty="0"/>
           </a:p>
@@ -7676,7 +7676,7 @@
                   <a:schemeClr val="tx2"/>
                 </a:solidFill>
               </a:rPr>
-              <a:t>Is it sensitive to presentation?</a:t>
+              <a:t>Sensitivity to presentation</a:t>
             </a:r>
             <a:endParaRPr lang="en-US" sz="1600" dirty="0"/>
           </a:p>
@@ -7729,7 +7729,7 @@
                   <a:schemeClr val="tx2"/>
                 </a:solidFill>
               </a:rPr>
-              <a:t>Is it reproducible?</a:t>
+              <a:t>Reproducibility</a:t>
             </a:r>
             <a:endParaRPr lang="en-US" sz="1600" dirty="0"/>
           </a:p>
@@ -7747,7 +7747,7 @@
                   <a:schemeClr val="tx1"/>
                 </a:solidFill>
               </a:rPr>
-              <a:t>20 identical requests resent: predictions differ by 0.17 pp on average, well below the 0.42 pp gain</a:t>
+              <a:t>20 identical requests resent: predictions differ by 0.17 pp on average, below the 0.42 pp gain</a:t>
             </a:r>
             <a:endParaRPr lang="en-US" sz="1600" dirty="0"/>
           </a:p>
@@ -7801,7 +7801,7 @@
                   <a:schemeClr val="tx1"/>
                 </a:solidFill>
               </a:rPr>
-              <a:t>Added after the ML result was known; not in the original plan</a:t>
+              <a:t>Added after the ML result was known</a:t>
             </a:r>
             <a:endParaRPr lang="en-US" sz="1600" dirty="0"/>
           </a:p>
@@ -12057,7 +12057,7 @@
                   <a:schemeClr val="tx1"/>
                 </a:solidFill>
               </a:rPr>
-              <a:t>Training exposure cannot be ruled out by any test; hiding campaign details and the naming test are the strongest checks available</a:t>
+              <a:t>No test can rule out training exposure; hiding campaign details and the naming test are the strongest checks available</a:t>
             </a:r>
             <a:endParaRPr lang="en-US" sz="1500" dirty="0"/>
           </a:p>
@@ -13061,7 +13061,7 @@
                   <a:schemeClr val="tx1"/>
                 </a:solidFill>
               </a:rPr>
-              <a:t>Models, results, LLM robustness and validity checks</a:t>
+              <a:t>Model comparison; LLM validity checks</a:t>
             </a:r>
             <a:endParaRPr lang="en-US" sz="1600" dirty="0"/>
           </a:p>
@@ -13170,42 +13170,6 @@
               <a:t>Findings, limitations, further work</a:t>
             </a:r>
             <a:endParaRPr lang="en-US" sz="1600" dirty="0"/>
-          </a:p>
-        </p:txBody>
-      </p:sp>
-      <p:sp>
-        <p:nvSpPr>
-          <p:cNvPr id="32" name="Text 28"/>
-          <p:cNvSpPr txBox="1"/>
-          <p:nvPr/>
-        </p:nvSpPr>
-        <p:spPr>
-          <a:xfrm>
-            <a:off x="548640" y="5760720"/>
-            <a:ext cx="11064240" cy="320040"/>
-          </a:xfrm>
-          <a:prstGeom prst="rect">
-            <a:avLst/>
-          </a:prstGeom>
-          <a:noFill/>
-          <a:ln/>
-        </p:spPr>
-        <p:txBody>
-          <a:bodyPr wrap="square" lIns="0" tIns="0" rIns="0" bIns="0" rtlCol="0" anchor="t"/>
-          <a:lstStyle/>
-          <a:p>
-            <a:pPr indent="0" marL="0">
-              <a:buNone/>
-            </a:pPr>
-            <a:r>
-              <a:rPr lang="en-US" sz="1300" i="1" dirty="0">
-                <a:solidFill>
-                  <a:schemeClr val="accent3"/>
-                </a:solidFill>
-              </a:rPr>
-              <a:t>The marker in the bottom-right corner of each slide shows where we are.</a:t>
-            </a:r>
-            <a:endParaRPr lang="en-US" sz="1300" dirty="0"/>
           </a:p>
         </p:txBody>
       </p:sp>
@@ -14468,7 +14432,7 @@
                   <a:schemeClr val="tx2"/>
                 </a:solidFill>
               </a:rPr>
-              <a:t>Why is this important?</a:t>
+              <a:t>Why prediction matters</a:t>
             </a:r>
             <a:endParaRPr lang="en-US" sz="2000" dirty="0"/>
           </a:p>
@@ -15451,7 +15415,7 @@
                   <a:schemeClr val="tx1"/>
                 </a:solidFill>
               </a:rPr>
-              <a:t>No early return in an emergency: the crew depends on its own fitness</a:t>
+              <a:t>No early return in an emergency</a:t>
             </a:r>
             <a:endParaRPr lang="en-US" sz="1900" dirty="0"/>
           </a:p>
@@ -19858,7 +19822,7 @@
                   <a:schemeClr val="accent3"/>
                 </a:solidFill>
               </a:rPr>
-              <a:t>Figure 6. Flow of records, in the style of PRISMA 2020. Full-text counts as recorded; they are still being reconciled with the dataset.</a:t>
+              <a:t>Figure 6. Flow of records, in the style of PRISMA 2020. Full-text counts are not yet reconciled with the dataset.</a:t>
             </a:r>
             <a:endParaRPr lang="en-US" sz="1100" dirty="0"/>
           </a:p>
@@ -20718,7 +20682,7 @@
                   <a:schemeClr val="tx1"/>
                 </a:solidFill>
               </a:rPr>
-              <a:t>742 observations are not 742 independent participants: </a:t>
+              <a:t>742 rows come from 36 campaigns: </a:t>
             </a:r>
             <a:pPr indent="0" marL="0">
               <a:buNone/>
@@ -27946,17 +27910,6 @@
               </a:rPr>
               <a:t>Orange: the held-out test campaign.</a:t>
             </a:r>
-            <a:pPr indent="0" marL="0">
-              <a:buNone/>
-            </a:pPr>
-            <a:r>
-              <a:rPr lang="en-US" sz="1400" dirty="0">
-                <a:solidFill>
-                  <a:schemeClr val="tx1"/>
-                </a:solidFill>
-              </a:rPr>
-              <a:t>  Each campaign is held out once.</a:t>
-            </a:r>
             <a:endParaRPr lang="en-US" sz="1400" dirty="0"/>
           </a:p>
         </p:txBody>
@@ -27995,7 +27948,7 @@
                   <a:schemeClr val="tx1"/>
                 </a:solidFill>
               </a:rPr>
-              <a:t>Why campaigns, not measurements: the 346 rows used for modelling come from 32 of the 36 campaigns, and rows of one campaign share volunteers.</a:t>
+              <a:t>Rows of one campaign share volunteers, so whole campaigns are held out. The 346 modelling rows come from 32 of the 36 campaigns.</a:t>
             </a:r>
             <a:endParaRPr lang="en-US" sz="1400" dirty="0"/>
           </a:p>

</xml_diff>

<commit_message>
Rewrite part 2 and backup speaker notes in plain academic sentences
Co-Authored-By: Claude Opus 5.5 (1M context) <noreply@anthropic.com>
Claude-Session: https://claude.ai/code/session_01JZtuYERhuCe7nB9VYHwcfv
</commit_message>
<xml_diff>
--- a/presentation/bed-rest-to-mars-talk.pptx
+++ b/presentation/bed-rest-to-mars-talk.pptx
@@ -127,14 +127,14 @@
   <p:extLst>
     <p:ext uri="{521415D9-36F7-43E2-AB2F-B90AF26B5E84}">
       <p14:sectionLst xmlns:p14="http://schemas.microsoft.com/office/powerpoint/2010/main">
-        <p14:section name="Opening" id="{c6039182-a584-9b83-9d52-95677517c382}">
+        <p14:section name="Opening" id="{1205b08f-4ad4-94d9-a8af-69e1d76c73a4}">
           <p14:sldIdLst>
             <p14:sldId id="256"/>
             <p14:sldId id="257"/>
             <p14:sldId id="269"/>
           </p14:sldIdLst>
         </p14:section>
-        <p14:section name="Part 1" id="{20de4196-23af-ee4f-3080-1758558fc264}">
+        <p14:section name="Part 1" id="{ad4ffea1-6501-465b-31c4-863d29f17a3d}">
           <p14:sldIdLst>
             <p14:sldId id="258"/>
             <p14:sldId id="259"/>
@@ -144,7 +144,7 @@
             <p14:sldId id="263"/>
           </p14:sldIdLst>
         </p14:section>
-        <p14:section name="Part 2" id="{a998b75a-0434-82c2-9c76-556f0f9b9732}">
+        <p14:section name="Part 2" id="{7940ae97-8207-d7a5-651d-461feaa577ef}">
           <p14:sldIdLst>
             <p14:sldId id="264"/>
             <p14:sldId id="265"/>
@@ -153,10 +153,10 @@
             <p14:sldId id="268"/>
           </p14:sldIdLst>
         </p14:section>
-        <p14:section name="Opening" id="{32c02aab-ac61-1308-df37-aa986ff4a26b}">
+        <p14:section name="Opening" id="{11aa2f7b-e2ab-bb97-6314-5702067d0878}">
           <p14:sldIdLst/>
         </p14:section>
-        <p14:section name="Backup" id="{5cd04eb8-87f7-abd8-7e71-d139912d95fc}">
+        <p14:section name="Backup" id="{27889b14-fde7-e57f-9d61-b87db006cab9}">
           <p14:sldIdLst>
             <p14:sldId id="270"/>
             <p14:sldId id="271"/>
@@ -167,22 +167,22 @@
             <p14:sldId id="276"/>
           </p14:sldIdLst>
         </p14:section>
-        <p14:section name="Backup" id="{4a61b26b-85d1-c1b8-5768-5467916a4bb6}">
+        <p14:section name="Backup" id="{107e6259-972c-05b7-8b09-a018452c7e73}">
           <p14:sldIdLst/>
         </p14:section>
-        <p14:section name="Backup" id="{bf2706ef-0d94-e94e-6274-502c5d7feea7}">
+        <p14:section name="Backup" id="{1d0e1d56-69a4-70a8-992d-3986b97ce3bb}">
           <p14:sldIdLst/>
         </p14:section>
-        <p14:section name="Backup" id="{b3f1d89b-cae6-db19-b719-4d90dae6da08}">
+        <p14:section name="Backup" id="{12d1af59-5442-8806-8d61-ad98929b6aa2}">
           <p14:sldIdLst/>
         </p14:section>
-        <p14:section name="Backup" id="{67918eca-7e20-7dad-93a0-9a667cad40dc}">
+        <p14:section name="Backup" id="{f4250f32-de82-f639-1ff4-4f3fd3f44ee7}">
           <p14:sldIdLst/>
         </p14:section>
-        <p14:section name="Backup" id="{45516639-b8df-f207-f4b3-e3b952a41f7d}">
+        <p14:section name="Backup" id="{fb631ca6-2d3d-c600-3dfa-6d8220401e0f}">
           <p14:sldIdLst/>
         </p14:section>
-        <p14:section name="Backup" id="{c1b1da5d-60a2-9e50-cd61-f3f96a370b1c}">
+        <p14:section name="Backup" id="{0795748e-97fb-a6b4-518d-624058b4198f}">
           <p14:sldIdLst/>
         </p14:section>
       </p14:sectionLst>
@@ -3023,10 +3023,10 @@
             <a:r>
               <a:rPr lang="en-US" dirty="0"/>
               <a:t>About a minute and a half.
-The ML models only saw coded columns. Here we gave each measurement, written out in words, to a newly released language model built for probabilistic classification. It is not a chat model that writes text: you give it a described situation and a fixed list of options, and it returns a probability for each option, nothing else.
-On the left is a real request from our cache. It describes the volunteers, the protocol, the muscle and how it was scanned, and the day. It also contains the duration curve fitted on the other 31 campaigns and as many rows from those campaigns as fit, most similar first. The question asks which of 19 ranges the change will fall in.
-On the right is what came back for this row: a probability for each range. We never ask the model for a number. Our code turns the probabilities into a prediction, here minus 6.6 percent against an observed minus 9.4. We chose this row because its error is the model's median error.
-The request never contains the held-out campaign's own data or any name that could identify a paper, and the code checks that on every request. Every answer is cached, so all our numbers can be rebuilt without calling the model again.</a:t>
+The standard models receive coded columns. For the LLM, we described each measurement in text and passed it to an LLM-based probabilistic classifier. This model does not generate text. It receives a description and a fixed list of options and returns a probability for each option.
+The left panel shows an actual request. It contains the participants, the protocol, the muscle, the imaging method and the target day. It also contains the duration curve fitted on the other 31 campaigns and the most similar rows from those campaigns. The model is asked in which of 19 ranges the change will fall.
+The right panel shows the returned probabilities. We do not ask the model for a number. The prediction is the probability-weighted mean of the range midpoints, here −6.6 percent. The measured value was −9.4 percent. The error of this example equals the median error of the model.
+The request never contains data from the held-out campaign or any paper, author or campaign name. This is checked automatically for every request. All 430 responses are stored, so every result can be reproduced without querying the model again.</a:t>
             </a:r>
             <a:endParaRPr lang="en-US" dirty="0"/>
           </a:p>
@@ -3115,10 +3115,10 @@
             <a:r>
               <a:rPr lang="en-US" dirty="0"/>
               <a:t>About a minute and a half.
-We compared four standard models, ridge regression, random forest, support vector regression and gradient boosting, tuned inside each training fold, and later TabPFN, a neural network pretrained for small tables. On the left is the error on the held-out campaign. The duration curve scores 3.16 percentage points and the best ML model, the random forest, 3.18: none of them is lower than the curve. On the right, the ML models explain two to three times more variance, because they learn that the calf loses more than the hip. Most of the error left is a shift that applies to a whole campaign, from its scanner, its volunteers or its protocol, and none of our columns describes it. We had committed in advance to report this result whichever way it came out.
-The language model is at the bottom. Its error is 2.71 percentage points, the lowest of all models, and it explains the most variance, 0.43.
-Compared with the curve on the same rows and scored the same way, the error falls from 3.13 to 2.71, a gain of 0.42 points. The 95 percent confidence interval runs from 0.13 to 0.73, so even the most pessimistic estimate is an improvement. It is closer than the curve in 20 of the 32 campaigns. No other method has a gain whose interval stays above zero.
-If asked about a target: we had set a 15 percent improvement target. The error improvement is 13.3 percent and the probabilistic score improvement 17.7 percent.</a:t>
+We compared four standard models, ridge regression, random forest, support vector regression and gradient boosting, each tuned within the training folds. We also tested TabPFN, a network pretrained for small tabular data.
+The left figure shows the error on the held-out campaigns. The duration curve has an error of 3.16 percentage points. The best machine learning model, the random forest, has 3.18. No machine learning model has a lower error than the curve. The right figure shows that these models explain two to three times more variance, because they learn the differences between muscles. Most of the remaining error is a shift that affects a whole campaign, for example through the scanner, the volunteers or the protocol. None of our inputs describes this shift. We had committed in advance to report this result regardless of the outcome.
+The LLM has an error of 2.71 percentage points and the highest R², 0.43. In a paired comparison on the same rows, the error decreases from 3.13 to 2.71, a reduction of 0.42 percentage points. The 95 percent confidence interval is 0.13 to 0.73, so it excludes zero. The LLM is closer than the curve in 20 of 32 campaigns. No other model has an improvement with a confidence interval that excludes zero.
+If asked about the target: we had set a 15 percent improvement in advance. The error improved by 13.3 percent and the probabilistic score by 17.7 percent.</a:t>
             </a:r>
             <a:endParaRPr lang="en-US" dirty="0"/>
           </a:p>
@@ -3207,11 +3207,12 @@
             <a:r>
               <a:rPr lang="en-US" dirty="0"/>
               <a:t>About a minute and a quarter.
-We wrote down each check and its pass rule, and committed them to the repository, before running it.
-Language models have read many papers, so the model might recognise a published campaign and recall its result. With every identifying detail removed, the gain is 0.30 points and its interval stays above zero. When we asked the model to choose the campaign's name from a list of options, it was right 19 percent of the time, where guessing gives 8 percent. If asked: of the three campaigns behind most of the gain, it named only one.
-When we shuffle the other campaigns' values, the gain turns into a loss of 1.25 points, and with no reference data the error rises to 5.85. The gain comes from reading those data.
-Reordering the rows or shifting the range edges changes the error by 1 to 3 percent. Repeating 20 requests moves the predictions by 0.17 points on average, well under the 0.42 gain.
-Three limitations: we added this model after the ML result; its 80 percent ranges contain the truth only 62 percent of the time, so we quote only point predictions; and when given a campaign's own earlier scans, it does not use them.</a:t>
+Each check and its pass criterion were defined and committed to the repository before the check was run.
+First, recognition. The model may have seen the published studies during training. With all identifying details removed, the improvement is 0.30 percentage points, and the confidence interval still excludes zero. When asked to select the campaign name from a list, the model was correct in 19 percent of cases, against 8 percent by chance.
+If asked about recognition: of the three campaigns that contribute most of the improvement, the model identified only one.
+Second, use of the reference data. When the values of the other campaigns are shuffled, the model is 1.25 percentage points worse than the curve. Without reference data, the error rises to 5.85. The improvement therefore depends on these data.
+Third, presentation. Changing the row order or shifting the range boundaries changes the error by 1 to 3 percent. Fourth, reproducibility. Repeating 20 requests changes the predictions by 0.17 percentage points on average, less than the 0.42 improvement.
+There are three limitations. The model was added after the machine learning results were known. Its 80 percent ranges contain the measured value in only 62 percent of cases, so we report only point predictions. It also ignores a campaign's own earlier measurements.</a:t>
             </a:r>
             <a:endParaRPr lang="en-US" dirty="0"/>
           </a:p>
@@ -3299,9 +3300,11 @@
           <a:p>
             <a:r>
               <a:rPr lang="en-US" dirty="0"/>
-              <a:t>About thirty seconds.
-With 32 independent campaigns, standard ML models and TabPFN do not beat a curve that only knows the number of days. An LLM-based probabilistic classifier that reads each campaign's description and the other campaigns' data reduces the error from 3.13 to 2.71 points. The main limitation is the small sample of 32 campaigns, mostly young men, with no bed-rest data beyond day 119. Every row is a group average, so the model predicts the average loss of a group of volunteers. It cannot yet predict the risk for an individual astronaut.
-Further work has three steps. First, estimate how susceptible each muscle is relative to a reference muscle, and combine those coefficients with baseline muscle volumes to estimate total lower-limb volume loss; the dataset has 30 group time points where three or more muscles were scanned together, across 14 campaigns, so this can be tested. Second, move from group averages to individuals with participant-level data over time, and link muscle loss to strength and function. Third, validate on independent campaigns and on spaceflight data before building any personal risk-assessment tool.</a:t>
+              <a:t>About forty-five seconds.
+With 32 independent campaigns, standard machine learning models and TabPFN do not outperform a curve based on duration alone. The LLM-based classifier uses the description of each campaign and the data of the other campaigns, and it reduces the error from 3.13 to 2.71 percentage points.
+The main limitations are the small number of campaigns, mostly with young men, and the lack of bed-rest data beyond day 119. Each row is a group mean. The model therefore predicts the average loss of a group, not the risk of an individual astronaut.
+Further work has three steps. First, we will estimate the relative susceptibility of each muscle and combine it with baseline volumes to estimate the total volume loss of the lower limb. Second, we will use individual participant data over time and relate muscle loss to strength and function. Third, we will validate the model on independent campaigns and spaceflight data before developing an individual risk assessment.
+If asked about the first step: the dataset contains 30 group time points with three or more muscles measured together, across 14 campaigns.</a:t>
             </a:r>
             <a:endParaRPr lang="en-US" dirty="0"/>
           </a:p>
@@ -3389,7 +3392,9 @@
           <a:p>
             <a:r>
               <a:rPr lang="en-US" dirty="0"/>
-              <a:t>Close (Milad). Thank the audience and invite questions. The backup slides that follow answer the questions we expect: part 1 on slides 17 and 18, data and search on 15 and 16, part 2 on 19 to 21.</a:t>
+              <a:t>Closing.
+Thank you for your attention. We are happy to take your questions.
+Backup slides: 15 and 16 on the data and the search, 17 and 18 on part 1, 19 to 21 on part 2.</a:t>
             </a:r>
             <a:endParaRPr lang="en-US" dirty="0"/>
           </a:p>
@@ -3477,7 +3482,7 @@
           <a:p>
             <a:r>
               <a:rPr lang="en-US" dirty="0"/>
-              <a:t>Backup. Be direct that the three must-show sensitivity analyses (composite-first, without MEDES, MRI only) have not been run yet. Only the weighting check has, and it changed little.</a:t>
+              <a:t>If asked about sensitivity analyses: three planned analyses have not been run yet. These are the composite-first analysis, the analysis without the MEDES campaign, and the MRI-only analysis. Only the weighting check has been run, and it changed the results little.</a:t>
             </a:r>
             <a:endParaRPr lang="en-US" dirty="0"/>
           </a:p>
@@ -3565,7 +3570,8 @@
           <a:p>
             <a:r>
               <a:rPr lang="en-US" dirty="0"/>
-              <a:t>Backup. All four strings are in the report appendix, copied from docs/literature-review/search_log.md. PubMed uses the same two blocks with MeSH terms and the humans filter; Scopus and Web of Science exclude animal studies in the query. The 2013 limit is the main weakness: only two of ten known modelling papers fall inside the window, and the known-item test without the limit was not run. Embase was not searched for lack of access; it indexes conference abstracts the other databases miss.</a:t>
+              <a:t>All four search strings are in the appendix of the report and in docs/literature-review/search_log.md. PubMed uses the same two blocks with MeSH terms and a humans filter. Scopus and Web of Science exclude animal studies in the query.
+The main weakness is the limit to publications from 2013 onwards. Only two of ten known modelling papers fall inside this window, and the search without the limit was not tested. Embase was not searched because we had no access. It indexes conference abstracts that the other databases miss.</a:t>
             </a:r>
             <a:endParaRPr lang="en-US" dirty="0"/>
           </a:p>
@@ -3653,7 +3659,11 @@
           <a:p>
             <a:r>
               <a:rPr lang="en-US" dirty="0"/>
-              <a:t>Backup, part 1 (Niloufar). Expansion: the eligibility criteria in the report's Table 2 were written before screening; dataset version 1.0 was frozen on 14 September and 1.1 on 19 September, and every result is fitted on 1.1. The rule for the curve: the saturating form is the headline unless another form beats it by at least 4 AIC points. Spaceflight: the dataset keeps the spaceflight rows, flagged, but they are post-flight measurements, so the during-unloading filter removes them. Weighting: inverse-variance weighting would need the spread of the change, which most papers do not print; the check that compares both weightings moved the duration effect by under 1 pp.</a:t>
+              <a:t>Part 1 (Niloufar).
+The eligibility criteria in Table 2 of the report were defined before screening. Dataset version 1.0 was frozen on 14 September and version 1.1 on 19 September. All results use version 1.1.
+The saturating curve is used unless another form is better by at least 4 AIC points.
+The spaceflight rows remain in the dataset and are flagged. They were measured after landing, so the filter for measurements during unloading removes them.
+Inverse-variance weighting would need the variance of the change, which most papers do not report. Comparing both weightings changed the duration effect by less than 1 percentage point.</a:t>
             </a:r>
             <a:endParaRPr lang="en-US" dirty="0"/>
           </a:p>
@@ -3741,7 +3751,9 @@
           <a:p>
             <a:r>
               <a:rPr lang="en-US" dirty="0"/>
-              <a:t>Backup, part 1 (Niloufar). Be precise about slide 8: the coloured dots at day 60 are the model's estimates for each muscle group, with the intervals shown here. The lines are drawn with one shared time course scaled to those values, so they show the shape the model assumes, not a separate fit per muscle. The intervals are 95% cluster-robust, which means they account for several rows coming from the same campaign. The calf-versus-shin contrast is reported on its own because it does not depend on which muscle is the reference.</a:t>
+              <a:t>Part 1 (Niloufar).
+The dots at day 60 on slide 8 are the meta-regression estimates for each muscle group, with the intervals shown here. The lines use one shared time course scaled to these values. They show the assumed shape, not a separate fit for each muscle.
+The intervals are 95 percent cluster-robust intervals, which account for several rows coming from the same campaign. The calf versus shin contrast is reported separately because it does not depend on the choice of reference muscle.</a:t>
             </a:r>
             <a:endParaRPr lang="en-US" dirty="0"/>
           </a:p>
@@ -3829,7 +3841,8 @@
           <a:p>
             <a:r>
               <a:rPr lang="en-US" dirty="0"/>
-              <a:t>Backup. The two starred numbers are our own calculation from results/forecast_predictions.csv, not in the report. Without the three campaigns that carry most of the gain, the interval touches zero; say so if asked.</a:t>
+              <a:t>The two numbers marked with an asterisk are our own calculation from results/forecast_predictions.csv. They are not in the report.
+Without the three campaigns that contribute most of the improvement, the confidence interval includes zero. State this directly if asked.</a:t>
             </a:r>
             <a:endParaRPr lang="en-US" dirty="0"/>
           </a:p>
@@ -4005,7 +4018,8 @@
           <a:p>
             <a:r>
               <a:rPr lang="en-US" dirty="0"/>
-              <a:t>Backup. The honest gap here is the nearest-neighbour control: we cannot yet say whether a simple similarity method would match the LLM. The 271 men-only rows and 100 countermeasure rows are our count on the 346 modelling rows; the report gives the same point on the 425 lower-limb rows before duplicate composites were removed (347 men-only, 126 countermeasure).</a:t>
+              <a:t>The open point is the nearest-neighbour control. We cannot yet say whether a simple similarity method would perform as well as the LLM.
+The counts of 271 men-only rows and 100 countermeasure rows refer to the 346 modelling rows. The report gives the same point for the 425 lower-limb rows before duplicate composites were removed: 347 men-only and 126 countermeasure rows.</a:t>
             </a:r>
             <a:endParaRPr lang="en-US" dirty="0"/>
           </a:p>
@@ -4093,7 +4107,7 @@
           <a:p>
             <a:r>
               <a:rPr lang="en-US" dirty="0"/>
-              <a:t>Backup. The supported planning statements, within 5 to 119 days and for groups: most loss happens in the first weeks, calf muscles need protecting first, and countermeasure groups lose less.</a:t>
+              <a:t>Within 5 to 119 days and at group level, the data support three statements for mission planning. Most of the loss occurs in the first weeks. The calf muscles need protection first. Groups with a countermeasure lose less muscle.</a:t>
             </a:r>
             <a:endParaRPr lang="en-US" dirty="0"/>
           </a:p>
@@ -4728,9 +4742,9 @@
             <a:r>
               <a:rPr lang="en-US" dirty="0"/>
               <a:t>About one minute.
-Each row in our data is one measurement: a group of volunteers, one muscle, one day of bed rest. The inputs are the day of the scan, the muscle family, whether the group did a countermeasure, how the muscle was imaged, and whether the value covers a group of muscles. The output is the percentage change in muscle size from before bed rest.
-We have 346 rows, but they come from 32 independent campaigns, because several papers report the same volunteers. So we test by holding out one whole campaign, training on the other 31 and predicting the held-out one, 32 times. The code checks that no campaign appears on both sides of a split.
-The score is the mean absolute error in percentage points, averaged so that each campaign counts once. Every model is compared with a duration-only curve, which uses the number of days and nothing else.</a:t>
+Each row in the dataset is one measurement: the mean change of one muscle, in one group of volunteers, on one day of bed rest. The inputs are the day of the scan, the muscle group, whether the group received a countermeasure, the imaging method, and whether the value refers to one muscle or several combined. The output is the percentage change in muscle size from baseline.
+The 346 modelling rows come from 32 independent campaigns. Rows from the same campaign share volunteers, so they are not independent. We therefore used leave-one-campaign-out validation. We trained on 31 campaigns, predicted the held-out campaign, and repeated this 32 times. The code verifies that no campaign appears in both the training and the test set.
+The metric is the mean absolute error in percentage points, with each campaign weighted equally. The reference is a duration curve that uses only the number of days.</a:t>
             </a:r>
             <a:endParaRPr lang="en-US" dirty="0"/>
           </a:p>

</xml_diff>

<commit_message>
Speaker notes for part 2 and backups: simpler ELI18 wording
Co-Authored-By: Claude Opus 5.5 (1M context) <noreply@anthropic.com>
Claude-Session: https://claude.ai/code/session_01JZtuYERhuCe7nB9VYHwcfv
</commit_message>
<xml_diff>
--- a/presentation/bed-rest-to-mars-talk.pptx
+++ b/presentation/bed-rest-to-mars-talk.pptx
@@ -127,14 +127,14 @@
   <p:extLst>
     <p:ext uri="{521415D9-36F7-43E2-AB2F-B90AF26B5E84}">
       <p14:sectionLst xmlns:p14="http://schemas.microsoft.com/office/powerpoint/2010/main">
-        <p14:section name="Opening" id="{1205b08f-4ad4-94d9-a8af-69e1d76c73a4}">
+        <p14:section name="Opening" id="{865f01b2-a0fa-7480-ffb5-25a1d343896c}">
           <p14:sldIdLst>
             <p14:sldId id="256"/>
             <p14:sldId id="257"/>
             <p14:sldId id="269"/>
           </p14:sldIdLst>
         </p14:section>
-        <p14:section name="Part 1" id="{ad4ffea1-6501-465b-31c4-863d29f17a3d}">
+        <p14:section name="Part 1" id="{dd671e12-9e5e-fa9e-845e-eb6bd417d025}">
           <p14:sldIdLst>
             <p14:sldId id="258"/>
             <p14:sldId id="259"/>
@@ -144,7 +144,7 @@
             <p14:sldId id="263"/>
           </p14:sldIdLst>
         </p14:section>
-        <p14:section name="Part 2" id="{7940ae97-8207-d7a5-651d-461feaa577ef}">
+        <p14:section name="Part 2" id="{bce21c75-539a-41f8-fbd2-505fc054d305}">
           <p14:sldIdLst>
             <p14:sldId id="264"/>
             <p14:sldId id="265"/>
@@ -153,10 +153,10 @@
             <p14:sldId id="268"/>
           </p14:sldIdLst>
         </p14:section>
-        <p14:section name="Opening" id="{11aa2f7b-e2ab-bb97-6314-5702067d0878}">
+        <p14:section name="Opening" id="{a963ba27-4b57-0221-a8a3-4c272d75beaf}">
           <p14:sldIdLst/>
         </p14:section>
-        <p14:section name="Backup" id="{27889b14-fde7-e57f-9d61-b87db006cab9}">
+        <p14:section name="Backup" id="{6148af0b-5294-7df5-eba6-753162907679}">
           <p14:sldIdLst>
             <p14:sldId id="270"/>
             <p14:sldId id="271"/>
@@ -167,22 +167,22 @@
             <p14:sldId id="276"/>
           </p14:sldIdLst>
         </p14:section>
-        <p14:section name="Backup" id="{107e6259-972c-05b7-8b09-a018452c7e73}">
+        <p14:section name="Backup" id="{ed5dc3e5-a8d0-4340-b1ec-070b090c9b0a}">
           <p14:sldIdLst/>
         </p14:section>
-        <p14:section name="Backup" id="{1d0e1d56-69a4-70a8-992d-3986b97ce3bb}">
+        <p14:section name="Backup" id="{2e91f7a9-7299-32fd-7426-93b45de28e81}">
           <p14:sldIdLst/>
         </p14:section>
-        <p14:section name="Backup" id="{12d1af59-5442-8806-8d61-ad98929b6aa2}">
+        <p14:section name="Backup" id="{8a0a4ea2-77f4-4d29-9460-63508770e1e8}">
           <p14:sldIdLst/>
         </p14:section>
-        <p14:section name="Backup" id="{f4250f32-de82-f639-1ff4-4f3fd3f44ee7}">
+        <p14:section name="Backup" id="{b8338c61-24ca-2d56-d190-46bdda22b5d9}">
           <p14:sldIdLst/>
         </p14:section>
-        <p14:section name="Backup" id="{fb631ca6-2d3d-c600-3dfa-6d8220401e0f}">
+        <p14:section name="Backup" id="{0b69dadf-c25a-29fa-7806-fbe496af9f8f}">
           <p14:sldIdLst/>
         </p14:section>
-        <p14:section name="Backup" id="{0795748e-97fb-a6b4-518d-624058b4198f}">
+        <p14:section name="Backup" id="{8edfd0a3-002c-cdac-4da3-f597138e54c8}">
           <p14:sldIdLst/>
         </p14:section>
       </p14:sectionLst>
@@ -3023,10 +3023,10 @@
             <a:r>
               <a:rPr lang="en-US" dirty="0"/>
               <a:t>About a minute and a half.
-The standard models receive coded columns. For the LLM, we described each measurement in text and passed it to an LLM-based probabilistic classifier. This model does not generate text. It receives a description and a fixed list of options and returns a probability for each option.
-The left panel shows an actual request. It contains the participants, the protocol, the muscle, the imaging method and the target day. It also contains the duration curve fitted on the other 31 campaigns and the most similar rows from those campaigns. The model is asked in which of 19 ranges the change will fall.
-The right panel shows the returned probabilities. We do not ask the model for a number. The prediction is the probability-weighted mean of the range midpoints, here −6.6 percent. The measured value was −9.4 percent. The error of this example equals the median error of the model.
-The request never contains data from the held-out campaign or any paper, author or campaign name. This is checked automatically for every request. All 430 responses are stored, so every result can be reproduced without querying the model again.</a:t>
+The normal models only see numbers in a table. For the LLM, we wrote each measurement out in words. We used a special kind of LLM. It does not chat or write text. It gets a description and a fixed list of answers, and it gives back a probability for each answer.
+On the left is a real request. It describes the volunteers, the bed-rest study, the muscle, how it was scanned, and the day. It also includes the duration curve and the most similar rows from the other 31 campaigns. Then it asks: in which of these 19 ranges will the change fall?
+On the right is the answer: a probability for each range. We never ask the model for a number. We turn the probabilities into one number by taking a weighted average of the middle of each range. Here that gives −6.6 percent. The real value was −9.4 percent. This example has a typical error for this model.
+The request never includes any data from the hidden campaign, and never the name of a paper, author or campaign. The code checks this for every request. We saved all 430 answers, so anyone can check our results without running the model again.</a:t>
             </a:r>
             <a:endParaRPr lang="en-US" dirty="0"/>
           </a:p>
@@ -3115,10 +3115,10 @@
             <a:r>
               <a:rPr lang="en-US" dirty="0"/>
               <a:t>About a minute and a half.
-We compared four standard models, ridge regression, random forest, support vector regression and gradient boosting, each tuned within the training folds. We also tested TabPFN, a network pretrained for small tabular data.
-The left figure shows the error on the held-out campaigns. The duration curve has an error of 3.16 percentage points. The best machine learning model, the random forest, has 3.18. No machine learning model has a lower error than the curve. The right figure shows that these models explain two to three times more variance, because they learn the differences between muscles. Most of the remaining error is a shift that affects a whole campaign, for example through the scanner, the volunteers or the protocol. None of our inputs describes this shift. We had committed in advance to report this result regardless of the outcome.
-The LLM has an error of 2.71 percentage points and the highest R², 0.43. In a paired comparison on the same rows, the error decreases from 3.13 to 2.71, a reduction of 0.42 percentage points. The 95 percent confidence interval is 0.13 to 0.73, so it excludes zero. The LLM is closer than the curve in 20 of 32 campaigns. No other model has an improvement with a confidence interval that excludes zero.
-If asked about the target: we had set a 15 percent improvement in advance. The error improved by 13.3 percent and the probabilistic score by 17.7 percent.</a:t>
+We tested four standard machine learning models: ridge regression, random forest, support vector regression and gradient boosting. We also tested TabPFN, a network that was trained in advance on many small tables.
+The left chart shows the error on the hidden campaigns. Lower is better. The simple duration curve is off by 3.16 percentage points. The best machine learning model, the random forest, is off by 3.18. So none of them beats the simple curve. The right chart shows R², which is how much of the differences between rows a model explains. Here the machine learning models do better, because they learn that some muscles shrink more than others. But most of the error comes from differences between whole campaigns, such as the scanner, the people or the study design. None of our inputs captures that. We had decided in advance to report this result either way.
+The LLM is at the top. Its error is 2.71 percentage points, the lowest of all, and it also explains the most, with an R² of 0.43. When we compare it with the curve on exactly the same rows, the error drops from 3.13 to 2.71. That is 0.42 points better. The 95 percent confidence interval goes from 0.13 to 0.73. Even the low end is above zero, so the improvement is real. The LLM beats the curve in 20 of the 32 campaigns. No other model has a clear improvement like this.
+If asked about the target: we had set a goal of 15 percent improvement in advance. The error improved by 13.3 percent and the probability score by 17.7 percent.</a:t>
             </a:r>
             <a:endParaRPr lang="en-US" dirty="0"/>
           </a:p>
@@ -3207,12 +3207,11 @@
             <a:r>
               <a:rPr lang="en-US" dirty="0"/>
               <a:t>About a minute and a quarter.
-Each check and its pass criterion were defined and committed to the repository before the check was run.
-First, recognition. The model may have seen the published studies during training. With all identifying details removed, the improvement is 0.30 percentage points, and the confidence interval still excludes zero. When asked to select the campaign name from a list, the model was correct in 19 percent of cases, against 8 percent by chance.
-If asked about recognition: of the three campaigns that contribute most of the improvement, the model identified only one.
-Second, use of the reference data. When the values of the other campaigns are shuffled, the model is 1.25 percentage points worse than the curve. Without reference data, the error rises to 5.85. The improvement therefore depends on these data.
-Third, presentation. Changing the row order or shifting the range boundaries changes the error by 1 to 3 percent. Fourth, reproducibility. Repeating 20 requests changes the predictions by 0.17 percentage points on average, less than the 0.42 improvement.
-There are three limitations. The model was added after the machine learning results were known. Its 80 percent ranges contain the measured value in only 62 percent of cases, so we report only point predictions. It also ignores a campaign's own earlier measurements.</a:t>
+We wrote down every check and its pass rule before running it. First, does the model just remember the studies? It may have read these papers during training. When we remove every detail that could identify a campaign, the LLM is still clearly better, by 0.30 points. We also asked it to pick the campaign name from a list. It was right 19 percent of the time, while random guessing gives 8 percent.
+If asked about recognition: of the three campaigns behind most of the improvement, it recognised only one.
+Second, does it really use the data from the other campaigns? When we mix up those values, it becomes 1.25 points worse than the curve. With no data at all, the error jumps to 5.85. So the improvement comes from reading that data.
+Third, does the format matter? Changing the order of the rows or moving the ranges changes the error by only 1 to 3 percent. Fourth, is it stable? Sending the same 20 requests again changes the predictions by 0.17 points on average, smaller than the 0.42 improvement.
+There are three limits. We added the LLM after we had seen the machine learning results. Its 80 percent ranges contain the real value only 62 percent of the time, so it is too confident and we only use its single number. And when we give it earlier scans from the same campaign, it ignores them.</a:t>
             </a:r>
             <a:endParaRPr lang="en-US" dirty="0"/>
           </a:p>
@@ -3301,10 +3300,10 @@
             <a:r>
               <a:rPr lang="en-US" dirty="0"/>
               <a:t>About forty-five seconds.
-With 32 independent campaigns, standard machine learning models and TabPFN do not outperform a curve based on duration alone. The LLM-based classifier uses the description of each campaign and the data of the other campaigns, and it reduces the error from 3.13 to 2.71 percentage points.
-The main limitations are the small number of campaigns, mostly with young men, and the lack of bed-rest data beyond day 119. Each row is a group mean. The model therefore predicts the average loss of a group, not the risk of an individual astronaut.
-Further work has three steps. First, we will estimate the relative susceptibility of each muscle and combine it with baseline volumes to estimate the total volume loss of the lower limb. Second, we will use individual participant data over time and relate muscle loss to strength and function. Third, we will validate the model on independent campaigns and spaceflight data before developing an individual risk assessment.
-If asked about the first step: the dataset contains 30 group time points with three or more muscles measured together, across 14 campaigns.</a:t>
+To sum up: with only 32 campaigns, standard machine learning models do not beat a simple curve that only knows the number of days. The LLM classifier, which reads the description of each campaign and the data of the others, lowers the error from 3.13 to 2.71 percentage points.
+The main limits: we have only 32 campaigns, mostly young men, and no bed-rest data after day 119. Every row is a group average. So we predict how much a group loses on average, not the risk for one astronaut.
+Next steps. First, find out how strongly each muscle reacts, and use that with normal muscle sizes to estimate the total loss in the legs. Second, use data from individual people over time, and link muscle loss to strength and function. Third, test everything on new campaigns and on real spaceflight data before building any personal risk tool.
+If asked about the first step: the dataset has 30 group time points where three or more muscles were measured together, across 14 campaigns.</a:t>
             </a:r>
             <a:endParaRPr lang="en-US" dirty="0"/>
           </a:p>
@@ -3393,7 +3392,7 @@
             <a:r>
               <a:rPr lang="en-US" dirty="0"/>
               <a:t>Closing.
-Thank you for your attention. We are happy to take your questions.
+Thank you for listening. We are happy to answer your questions.
 Backup slides: 15 and 16 on the data and the search, 17 and 18 on part 1, 19 to 21 on part 2.</a:t>
             </a:r>
             <a:endParaRPr lang="en-US" dirty="0"/>
@@ -3482,7 +3481,7 @@
           <a:p>
             <a:r>
               <a:rPr lang="en-US" dirty="0"/>
-              <a:t>If asked about sensitivity analyses: three planned analyses have not been run yet. These are the composite-first analysis, the analysis without the MEDES campaign, and the MRI-only analysis. Only the weighting check has been run, and it changed the results little.</a:t>
+              <a:t>If asked about extra checks: three planned checks have not been run yet. These are the composite-first analysis, the analysis without the MEDES campaign, and the analysis with MRI only. Only the weighting check has been run, and it changed the results very little.</a:t>
             </a:r>
             <a:endParaRPr lang="en-US" dirty="0"/>
           </a:p>
@@ -3570,8 +3569,8 @@
           <a:p>
             <a:r>
               <a:rPr lang="en-US" dirty="0"/>
-              <a:t>All four search strings are in the appendix of the report and in docs/literature-review/search_log.md. PubMed uses the same two blocks with MeSH terms and a humans filter. Scopus and Web of Science exclude animal studies in the query.
-The main weakness is the limit to publications from 2013 onwards. Only two of ten known modelling papers fall inside this window, and the search without the limit was not tested. Embase was not searched because we had no access. It indexes conference abstracts that the other databases miss.</a:t>
+              <a:t>All four search strings are in the appendix of the report and in docs/literature-review/search_log.md. PubMed uses the same two blocks, with MeSH terms and a filter for human studies. Scopus and Web of Science remove animal studies in the search itself.
+The main weakness is that we only searched papers from 2013 onwards. Only two of ten known modelling papers fall in that period, and we did not test the search without this limit. We could not search Embase because we had no access. Embase includes conference abstracts that the other databases miss.</a:t>
             </a:r>
             <a:endParaRPr lang="en-US" dirty="0"/>
           </a:p>
@@ -3660,10 +3659,10 @@
             <a:r>
               <a:rPr lang="en-US" dirty="0"/>
               <a:t>Part 1 (Niloufar).
-The eligibility criteria in Table 2 of the report were defined before screening. Dataset version 1.0 was frozen on 14 September and version 1.1 on 19 September. All results use version 1.1.
-The saturating curve is used unless another form is better by at least 4 AIC points.
-The spaceflight rows remain in the dataset and are flagged. They were measured after landing, so the filter for measurements during unloading removes them.
-Inverse-variance weighting would need the variance of the change, which most papers do not report. Comparing both weightings changed the duration effect by less than 1 percentage point.</a:t>
+We set the rules for which studies to include, in Table 2 of the report, before we started screening. Version 1.0 of the dataset was frozen on 14 September and version 1.1 on 19 September. All results use version 1.1.
+We use the saturating curve unless another shape fits better by at least 4 AIC points.
+The spaceflight rows are still in the dataset, marked as spaceflight. They were measured after landing, so the filter for measurements during unloading leaves them out.
+Weighting rows by their uncertainty would need the spread of each change, and most papers do not report it. When we compared both ways of weighting, the effect of duration changed by less than 1 percentage point.</a:t>
             </a:r>
             <a:endParaRPr lang="en-US" dirty="0"/>
           </a:p>
@@ -3752,8 +3751,8 @@
             <a:r>
               <a:rPr lang="en-US" dirty="0"/>
               <a:t>Part 1 (Niloufar).
-The dots at day 60 on slide 8 are the meta-regression estimates for each muscle group, with the intervals shown here. The lines use one shared time course scaled to these values. They show the assumed shape, not a separate fit for each muscle.
-The intervals are 95 percent cluster-robust intervals, which account for several rows coming from the same campaign. The calf versus shin contrast is reported separately because it does not depend on the choice of reference muscle.</a:t>
+The dots at day 60 on slide 8 are the estimates for each muscle group, with the ranges shown here. All lines use the same curve shape, scaled to these dots. So they show the shape we assume, not a separate fit for each muscle.
+The ranges are 95 percent intervals that take into account that several rows come from the same campaign. We show the calf versus shin comparison on its own because it does not depend on which muscle we use as the reference.</a:t>
             </a:r>
             <a:endParaRPr lang="en-US" dirty="0"/>
           </a:p>
@@ -3841,8 +3840,8 @@
           <a:p>
             <a:r>
               <a:rPr lang="en-US" dirty="0"/>
-              <a:t>The two numbers marked with an asterisk are our own calculation from results/forecast_predictions.csv. They are not in the report.
-Without the three campaigns that contribute most of the improvement, the confidence interval includes zero. State this directly if asked.</a:t>
+              <a:t>The two numbers with an asterisk are our own calculation from results/forecast_predictions.csv. They are not in the report.
+If we remove the three campaigns that give most of the improvement, the interval touches zero. Say this openly if asked.</a:t>
             </a:r>
             <a:endParaRPr lang="en-US" dirty="0"/>
           </a:p>
@@ -4018,8 +4017,8 @@
           <a:p>
             <a:r>
               <a:rPr lang="en-US" dirty="0"/>
-              <a:t>The open point is the nearest-neighbour control. We cannot yet say whether a simple similarity method would perform as well as the LLM.
-The counts of 271 men-only rows and 100 countermeasure rows refer to the 346 modelling rows. The report gives the same point for the 425 lower-limb rows before duplicate composites were removed: 347 men-only and 126 countermeasure rows.</a:t>
+              <a:t>The open question is the nearest-neighbour test. We do not yet know whether a simple method that just picks similar rows would do as well as the LLM.
+The 271 men-only rows and 100 countermeasure rows are counted on the 346 modelling rows. The report makes the same point with the 425 leg rows before duplicates were removed: 347 men-only and 126 countermeasure rows.</a:t>
             </a:r>
             <a:endParaRPr lang="en-US" dirty="0"/>
           </a:p>
@@ -4107,7 +4106,7 @@
           <a:p>
             <a:r>
               <a:rPr lang="en-US" dirty="0"/>
-              <a:t>Within 5 to 119 days and at group level, the data support three statements for mission planning. Most of the loss occurs in the first weeks. The calf muscles need protection first. Groups with a countermeasure lose less muscle.</a:t>
+              <a:t>Within 5 to 119 days, and for groups, the data support three points for mission planning. Most of the loss happens in the first weeks. The calf muscles need protection first. Groups with a countermeasure, such as exercise, lose less muscle.</a:t>
             </a:r>
             <a:endParaRPr lang="en-US" dirty="0"/>
           </a:p>
@@ -4742,9 +4741,9 @@
             <a:r>
               <a:rPr lang="en-US" dirty="0"/>
               <a:t>About one minute.
-Each row in the dataset is one measurement: the mean change of one muscle, in one group of volunteers, on one day of bed rest. The inputs are the day of the scan, the muscle group, whether the group received a countermeasure, the imaging method, and whether the value refers to one muscle or several combined. The output is the percentage change in muscle size from baseline.
-The 346 modelling rows come from 32 independent campaigns. Rows from the same campaign share volunteers, so they are not independent. We therefore used leave-one-campaign-out validation. We trained on 31 campaigns, predicted the held-out campaign, and repeated this 32 times. The code verifies that no campaign appears in both the training and the test set.
-The metric is the mean absolute error in percentage points, with each campaign weighted equally. The reference is a duration curve that uses only the number of days.</a:t>
+Each row in our data is one measurement. It tells us how much one muscle shrank, on average, in one group of volunteers, on one day of bed rest. For every row, the models get five facts: the day of the scan, which muscle it is, whether the group did exercise or not, how the muscle was scanned, and whether it is one muscle or several together. The models must predict how many percent the muscle shrank compared with before bed rest.
+We have 346 rows, but they come from only 32 separate studies, which we call campaigns. Rows from the same campaign come from the same people, so they are not truly separate. If a model trains on some rows of a campaign and is tested on others, it can cheat. So we hide one whole campaign, train on the other 31, and predict the hidden one. We repeat this 32 times, once for every campaign. The code checks that no campaign is ever on both sides.
+We score each model by its average error in percentage points. Each campaign counts the same. As the simplest reference, we use a duration curve: it only knows how many days the bed rest lasted.</a:t>
             </a:r>
             <a:endParaRPr lang="en-US" dirty="0"/>
           </a:p>

</xml_diff>